<commit_message>
pwp: replace radius variable R by r
</commit_message>
<xml_diff>
--- a/projet_final/projet_final/MEC8211-Projet-final-Presentation.pptx
+++ b/projet_final/projet_final/MEC8211-Projet-final-Presentation.pptx
@@ -204,7 +204,7 @@
           <a:p>
             <a:fld id="{BB0B2023-C595-443A-8D8C-AB9DF5A28D48}" type="datetimeFigureOut">
               <a:rPr lang="fr-FR" smtClean="0"/>
-              <a:t>09/04/2026</a:t>
+              <a:t>10/04/2026</a:t>
             </a:fld>
             <a:endParaRPr lang="fr-FR"/>
           </a:p>
@@ -894,7 +894,7 @@
           <a:p>
             <a:fld id="{4E51AFDA-D128-4B68-A211-269E2451E5DE}" type="datetimeFigureOut">
               <a:rPr lang="fr-FR" smtClean="0"/>
-              <a:t>09/04/2026</a:t>
+              <a:t>10/04/2026</a:t>
             </a:fld>
             <a:endParaRPr lang="fr-FR"/>
           </a:p>
@@ -1092,7 +1092,7 @@
           <a:p>
             <a:fld id="{4E51AFDA-D128-4B68-A211-269E2451E5DE}" type="datetimeFigureOut">
               <a:rPr lang="fr-FR" smtClean="0"/>
-              <a:t>09/04/2026</a:t>
+              <a:t>10/04/2026</a:t>
             </a:fld>
             <a:endParaRPr lang="fr-FR"/>
           </a:p>
@@ -1300,7 +1300,7 @@
           <a:p>
             <a:fld id="{4E51AFDA-D128-4B68-A211-269E2451E5DE}" type="datetimeFigureOut">
               <a:rPr lang="fr-FR" smtClean="0"/>
-              <a:t>09/04/2026</a:t>
+              <a:t>10/04/2026</a:t>
             </a:fld>
             <a:endParaRPr lang="fr-FR"/>
           </a:p>
@@ -1498,7 +1498,7 @@
           <a:p>
             <a:fld id="{4E51AFDA-D128-4B68-A211-269E2451E5DE}" type="datetimeFigureOut">
               <a:rPr lang="fr-FR" smtClean="0"/>
-              <a:t>09/04/2026</a:t>
+              <a:t>10/04/2026</a:t>
             </a:fld>
             <a:endParaRPr lang="fr-FR"/>
           </a:p>
@@ -1773,7 +1773,7 @@
           <a:p>
             <a:fld id="{4E51AFDA-D128-4B68-A211-269E2451E5DE}" type="datetimeFigureOut">
               <a:rPr lang="fr-FR" smtClean="0"/>
-              <a:t>09/04/2026</a:t>
+              <a:t>10/04/2026</a:t>
             </a:fld>
             <a:endParaRPr lang="fr-FR"/>
           </a:p>
@@ -2038,7 +2038,7 @@
           <a:p>
             <a:fld id="{4E51AFDA-D128-4B68-A211-269E2451E5DE}" type="datetimeFigureOut">
               <a:rPr lang="fr-FR" smtClean="0"/>
-              <a:t>09/04/2026</a:t>
+              <a:t>10/04/2026</a:t>
             </a:fld>
             <a:endParaRPr lang="fr-FR"/>
           </a:p>
@@ -2450,7 +2450,7 @@
           <a:p>
             <a:fld id="{4E51AFDA-D128-4B68-A211-269E2451E5DE}" type="datetimeFigureOut">
               <a:rPr lang="fr-FR" smtClean="0"/>
-              <a:t>09/04/2026</a:t>
+              <a:t>10/04/2026</a:t>
             </a:fld>
             <a:endParaRPr lang="fr-FR"/>
           </a:p>
@@ -2591,7 +2591,7 @@
           <a:p>
             <a:fld id="{4E51AFDA-D128-4B68-A211-269E2451E5DE}" type="datetimeFigureOut">
               <a:rPr lang="fr-FR" smtClean="0"/>
-              <a:t>09/04/2026</a:t>
+              <a:t>10/04/2026</a:t>
             </a:fld>
             <a:endParaRPr lang="fr-FR"/>
           </a:p>
@@ -2704,7 +2704,7 @@
           <a:p>
             <a:fld id="{4E51AFDA-D128-4B68-A211-269E2451E5DE}" type="datetimeFigureOut">
               <a:rPr lang="fr-FR" smtClean="0"/>
-              <a:t>09/04/2026</a:t>
+              <a:t>10/04/2026</a:t>
             </a:fld>
             <a:endParaRPr lang="fr-FR"/>
           </a:p>
@@ -3015,7 +3015,7 @@
           <a:p>
             <a:fld id="{4E51AFDA-D128-4B68-A211-269E2451E5DE}" type="datetimeFigureOut">
               <a:rPr lang="fr-FR" smtClean="0"/>
-              <a:t>09/04/2026</a:t>
+              <a:t>10/04/2026</a:t>
             </a:fld>
             <a:endParaRPr lang="fr-FR"/>
           </a:p>
@@ -3303,7 +3303,7 @@
           <a:p>
             <a:fld id="{4E51AFDA-D128-4B68-A211-269E2451E5DE}" type="datetimeFigureOut">
               <a:rPr lang="fr-FR" smtClean="0"/>
-              <a:t>09/04/2026</a:t>
+              <a:t>10/04/2026</a:t>
             </a:fld>
             <a:endParaRPr lang="fr-FR"/>
           </a:p>
@@ -3547,7 +3547,7 @@
           <a:p>
             <a:fld id="{4E51AFDA-D128-4B68-A211-269E2451E5DE}" type="datetimeFigureOut">
               <a:rPr lang="fr-FR" smtClean="0"/>
-              <a:t>09/04/2026</a:t>
+              <a:t>10/04/2026</a:t>
             </a:fld>
             <a:endParaRPr lang="fr-FR"/>
           </a:p>
@@ -4362,8 +4362,8 @@
           </a:p>
         </p:txBody>
       </p:sp>
-      <mc:AlternateContent xmlns:mc="http://schemas.openxmlformats.org/markup-compatibility/2006" xmlns:a14="http://schemas.microsoft.com/office/drawing/2010/main">
-        <mc:Choice Requires="a14">
+      <mc:AlternateContent xmlns:mc="http://schemas.openxmlformats.org/markup-compatibility/2006">
+        <mc:Choice xmlns:a14="http://schemas.microsoft.com/office/drawing/2010/main" Requires="a14">
           <p:sp>
             <p:nvSpPr>
               <p:cNvPr id="3" name="Espace réservé du contenu 2">
@@ -4395,7 +4395,7 @@
                 <a:pPr fontAlgn="base"/>
                 <a:r>
                   <a:rPr lang="fr-FR" dirty="0"/>
-                  <a:t>Refroidissement à l'air ambient d'un lingot métallique </a:t>
+                  <a:t>Refroidissement à l'air ambient d'un lingot métallique cylindrique </a:t>
                 </a:r>
                 <a:r>
                   <a:rPr lang="en-US" dirty="0"/>
@@ -5285,7 +5285,7 @@
             </p:txBody>
           </p:sp>
         </mc:Choice>
-        <mc:Fallback xmlns="">
+        <mc:Fallback>
           <p:sp>
             <p:nvSpPr>
               <p:cNvPr id="3" name="Espace réservé du contenu 2">
@@ -5319,7 +5319,7 @@
               <a:lstStyle/>
               <a:p>
                 <a:r>
-                  <a:rPr lang="fr-FR">
+                  <a:rPr lang="fr-CA">
                     <a:noFill/>
                   </a:rPr>
                   <a:t> </a:t>
@@ -5504,7 +5504,7 @@
                 </a:pPr>
                 <a:r>
                   <a:rPr lang="fr-FR" dirty="0"/>
-                  <a:t>Hors des frontières (R-1, R+1, z-1, z+1 sont définis)</a:t>
+                  <a:t>Hors des frontières (r-1, r+1, z-1, z+1 sont définis)</a:t>
                 </a:r>
               </a:p>
               <a:p>
@@ -5621,10 +5621,10 @@
                           </m:e>
                           <m:sub>
                             <m:r>
-                              <a:rPr lang="fr-FR" b="0" i="1" smtClean="0">
-                                <a:latin typeface="Cambria Math" panose="02040503050406030204" pitchFamily="18" charset="0"/>
-                              </a:rPr>
-                              <m:t>𝑅</m:t>
+                              <a:rPr lang="fr-CA" b="0" i="1" smtClean="0">
+                                <a:latin typeface="Cambria Math" panose="02040503050406030204" pitchFamily="18" charset="0"/>
+                              </a:rPr>
+                              <m:t>𝑟</m:t>
                             </m:r>
                             <m:r>
                               <a:rPr lang="fr-FR" b="0" i="1" smtClean="0">
@@ -5687,10 +5687,10 @@
                           </m:e>
                           <m:sub>
                             <m:r>
-                              <a:rPr lang="fr-FR" b="0" i="1" smtClean="0">
-                                <a:latin typeface="Cambria Math" panose="02040503050406030204" pitchFamily="18" charset="0"/>
-                              </a:rPr>
-                              <m:t>𝑅</m:t>
+                              <a:rPr lang="fr-CA" b="0" i="1" smtClean="0">
+                                <a:latin typeface="Cambria Math" panose="02040503050406030204" pitchFamily="18" charset="0"/>
+                              </a:rPr>
+                              <m:t>𝑟</m:t>
                             </m:r>
                             <m:r>
                               <a:rPr lang="fr-FR" b="0" i="1" smtClean="0">
@@ -5771,10 +5771,10 @@
                           <m:t>𝜕</m:t>
                         </m:r>
                         <m:r>
-                          <a:rPr lang="fr-FR" b="0" i="1" smtClean="0">
-                            <a:latin typeface="Cambria Math" panose="02040503050406030204" pitchFamily="18" charset="0"/>
-                          </a:rPr>
-                          <m:t>𝑅</m:t>
+                          <a:rPr lang="fr-CA" b="0" i="1" smtClean="0">
+                            <a:latin typeface="Cambria Math" panose="02040503050406030204" pitchFamily="18" charset="0"/>
+                          </a:rPr>
+                          <m:t>𝑟</m:t>
                         </m:r>
                       </m:den>
                     </m:f>
@@ -5852,10 +5852,10 @@
                           </m:e>
                           <m:sub>
                             <m:r>
-                              <a:rPr lang="fr-FR" i="1">
-                                <a:latin typeface="Cambria Math" panose="02040503050406030204" pitchFamily="18" charset="0"/>
-                              </a:rPr>
-                              <m:t>𝑅</m:t>
+                              <a:rPr lang="fr-CA" b="0" i="1" smtClean="0">
+                                <a:latin typeface="Cambria Math" panose="02040503050406030204" pitchFamily="18" charset="0"/>
+                              </a:rPr>
+                              <m:t>𝑟</m:t>
                             </m:r>
                             <m:r>
                               <a:rPr lang="fr-FR" b="0" i="1" smtClean="0">
@@ -5909,10 +5909,10 @@
                           </m:e>
                           <m:sub>
                             <m:r>
-                              <a:rPr lang="fr-FR" i="1">
-                                <a:latin typeface="Cambria Math" panose="02040503050406030204" pitchFamily="18" charset="0"/>
-                              </a:rPr>
-                              <m:t>𝑅</m:t>
+                              <a:rPr lang="fr-CA" b="0" i="1" smtClean="0">
+                                <a:latin typeface="Cambria Math" panose="02040503050406030204" pitchFamily="18" charset="0"/>
+                              </a:rPr>
+                              <m:t>𝑟</m:t>
                             </m:r>
                             <m:r>
                               <a:rPr lang="fr-FR" b="0" i="1" smtClean="0">
@@ -5960,10 +5960,10 @@
                           <m:t>Δ</m:t>
                         </m:r>
                         <m:r>
-                          <a:rPr lang="fr-FR" b="0" i="1" smtClean="0">
-                            <a:latin typeface="Cambria Math" panose="02040503050406030204" pitchFamily="18" charset="0"/>
-                          </a:rPr>
-                          <m:t>𝑅</m:t>
+                          <a:rPr lang="fr-CA" b="0" i="1" smtClean="0">
+                            <a:latin typeface="Cambria Math" panose="02040503050406030204" pitchFamily="18" charset="0"/>
+                          </a:rPr>
+                          <m:t>𝑟</m:t>
                         </m:r>
                       </m:den>
                     </m:f>
@@ -6045,10 +6045,10 @@
                             </m:sSupPr>
                             <m:e>
                               <m:r>
-                                <a:rPr lang="fr-FR" sz="2400" i="1">
+                                <a:rPr lang="fr-CA" sz="2400" b="0" i="1" smtClean="0">
                                   <a:latin typeface="Cambria Math" panose="02040503050406030204" pitchFamily="18" charset="0"/>
                                 </a:rPr>
-                                <m:t>𝑅</m:t>
+                                <m:t>𝑟</m:t>
                               </m:r>
                             </m:e>
                             <m:sup>
@@ -6123,10 +6123,10 @@
                             <m:t>𝜕</m:t>
                           </m:r>
                           <m:r>
-                            <a:rPr lang="fr-FR" sz="2400" i="1">
+                            <a:rPr lang="fr-CA" sz="2400" b="0" i="1" smtClean="0">
                               <a:latin typeface="Cambria Math" panose="02040503050406030204" pitchFamily="18" charset="0"/>
                             </a:rPr>
-                            <m:t>𝑅</m:t>
+                            <m:t>𝑟</m:t>
                           </m:r>
                         </m:den>
                       </m:f>
@@ -6366,10 +6366,10 @@
                         </m:e>
                         <m:sub>
                           <m:r>
-                            <a:rPr lang="fr-FR" sz="2400" i="1">
+                            <a:rPr lang="fr-CA" sz="2400" b="0" i="1" smtClean="0">
                               <a:latin typeface="Cambria Math" panose="02040503050406030204" pitchFamily="18" charset="0"/>
                             </a:rPr>
-                            <m:t>𝑅</m:t>
+                            <m:t>𝑟</m:t>
                           </m:r>
                           <m:r>
                             <a:rPr lang="fr-FR" sz="2400" i="1">
@@ -6432,10 +6432,10 @@
                         </m:e>
                         <m:sub>
                           <m:r>
-                            <a:rPr lang="fr-FR" sz="2400" i="1">
+                            <a:rPr lang="fr-CA" sz="2400" b="0" i="1" smtClean="0">
                               <a:latin typeface="Cambria Math" panose="02040503050406030204" pitchFamily="18" charset="0"/>
                             </a:rPr>
-                            <m:t>𝑅</m:t>
+                            <m:t>𝑟</m:t>
                           </m:r>
                           <m:r>
                             <a:rPr lang="fr-FR" sz="2400" i="1">
@@ -6551,10 +6551,10 @@
                             </m:e>
                             <m:sub>
                               <m:r>
-                                <a:rPr lang="fr-FR" sz="2400" i="1">
+                                <a:rPr lang="fr-CA" sz="2400" b="0" i="1" smtClean="0">
                                   <a:latin typeface="Cambria Math" panose="02040503050406030204" pitchFamily="18" charset="0"/>
                                 </a:rPr>
-                                <m:t>𝑅</m:t>
+                                <m:t>𝑟</m:t>
                               </m:r>
                               <m:r>
                                 <a:rPr lang="fr-FR" sz="2400" i="1">
@@ -6608,10 +6608,10 @@
                             </m:e>
                             <m:sub>
                               <m:r>
-                                <a:rPr lang="fr-FR" sz="2400" i="1">
+                                <a:rPr lang="fr-CA" sz="2400" b="0" i="1" smtClean="0">
                                   <a:latin typeface="Cambria Math" panose="02040503050406030204" pitchFamily="18" charset="0"/>
                                 </a:rPr>
-                                <m:t>𝑅</m:t>
+                                <m:t>𝑟</m:t>
                               </m:r>
                               <m:r>
                                 <a:rPr lang="fr-FR" sz="2400" i="1">
@@ -6659,10 +6659,10 @@
                             </m:e>
                             <m:sub>
                               <m:r>
-                                <a:rPr lang="fr-FR" sz="2400" i="1">
+                                <a:rPr lang="fr-CA" sz="2400" b="0" i="1" smtClean="0">
                                   <a:latin typeface="Cambria Math" panose="02040503050406030204" pitchFamily="18" charset="0"/>
                                 </a:rPr>
-                                <m:t>𝑅</m:t>
+                                <m:t>𝑟</m:t>
                               </m:r>
                               <m:r>
                                 <a:rPr lang="fr-FR" sz="2400" i="1">
@@ -6710,10 +6710,10 @@
                                 <m:rPr>
                                   <m:sty m:val="p"/>
                                 </m:rPr>
-                                <a:rPr lang="fr-FR" sz="2400">
+                                <a:rPr lang="fr-CA" sz="2400" b="0" i="0" smtClean="0">
                                   <a:latin typeface="Cambria Math" panose="02040503050406030204" pitchFamily="18" charset="0"/>
                                 </a:rPr>
-                                <m:t>R</m:t>
+                                <m:t>r</m:t>
                               </m:r>
                             </m:e>
                             <m:sup>
@@ -6792,10 +6792,10 @@
                             </m:e>
                             <m:sub>
                               <m:r>
-                                <a:rPr lang="fr-FR" sz="2400" i="1">
+                                <a:rPr lang="fr-CA" sz="2400" b="0" i="1" smtClean="0">
                                   <a:latin typeface="Cambria Math" panose="02040503050406030204" pitchFamily="18" charset="0"/>
                                 </a:rPr>
-                                <m:t>𝑅</m:t>
+                                <m:t>𝑟</m:t>
                               </m:r>
                               <m:r>
                                 <a:rPr lang="fr-FR" sz="2400" i="1">
@@ -6843,10 +6843,10 @@
                             </m:e>
                             <m:sub>
                               <m:r>
-                                <a:rPr lang="fr-FR" sz="2400" i="1">
+                                <a:rPr lang="fr-CA" sz="2400" b="0" i="1" smtClean="0">
                                   <a:latin typeface="Cambria Math" panose="02040503050406030204" pitchFamily="18" charset="0"/>
                                 </a:rPr>
-                                <m:t>𝑅</m:t>
+                                <m:t>𝑟</m:t>
                               </m:r>
                               <m:r>
                                 <a:rPr lang="fr-FR" sz="2400" i="1">
@@ -6888,10 +6888,10 @@
                             <m:t>Δ</m:t>
                           </m:r>
                           <m:r>
-                            <a:rPr lang="fr-FR" sz="2400" i="1">
+                            <a:rPr lang="fr-CA" sz="2400" b="0" i="1" smtClean="0">
                               <a:latin typeface="Cambria Math" panose="02040503050406030204" pitchFamily="18" charset="0"/>
                             </a:rPr>
-                            <m:t>𝑅</m:t>
+                            <m:t>𝑟</m:t>
                           </m:r>
                         </m:den>
                       </m:f>
@@ -6928,10 +6928,10 @@
                             </m:e>
                             <m:sub>
                               <m:r>
-                                <a:rPr lang="fr-FR" sz="2400" i="1">
+                                <a:rPr lang="fr-CA" sz="2400" b="0" i="1" smtClean="0">
                                   <a:latin typeface="Cambria Math" panose="02040503050406030204" pitchFamily="18" charset="0"/>
                                 </a:rPr>
-                                <m:t>𝑅</m:t>
+                                <m:t>𝑟</m:t>
                               </m:r>
                               <m:r>
                                 <a:rPr lang="fr-FR" sz="2400" i="1">
@@ -6991,10 +6991,10 @@
                             </m:e>
                             <m:sub>
                               <m:r>
-                                <a:rPr lang="fr-FR" sz="2400" i="1">
+                                <a:rPr lang="fr-CA" sz="2400" b="0" i="1" smtClean="0">
                                   <a:latin typeface="Cambria Math" panose="02040503050406030204" pitchFamily="18" charset="0"/>
                                 </a:rPr>
-                                <m:t>𝑅</m:t>
+                                <m:t>𝑟</m:t>
                               </m:r>
                               <m:r>
                                 <a:rPr lang="fr-FR" sz="2400" i="1">
@@ -7042,10 +7042,10 @@
                             </m:e>
                             <m:sub>
                               <m:r>
-                                <a:rPr lang="fr-FR" sz="2400" i="1">
+                                <a:rPr lang="fr-CA" sz="2400" b="0" i="1" smtClean="0">
                                   <a:latin typeface="Cambria Math" panose="02040503050406030204" pitchFamily="18" charset="0"/>
                                 </a:rPr>
-                                <m:t>𝑅</m:t>
+                                <m:t>𝑟</m:t>
                               </m:r>
                               <m:r>
                                 <a:rPr lang="fr-FR" sz="2400" i="1">
@@ -7183,7 +7183,7 @@
               <a:lstStyle/>
               <a:p>
                 <a:r>
-                  <a:rPr lang="fr-FR">
+                  <a:rPr lang="fr-CA">
                     <a:noFill/>
                   </a:rPr>
                   <a:t> </a:t>
@@ -7341,8 +7341,8 @@
           </a:p>
         </p:txBody>
       </p:sp>
-      <mc:AlternateContent xmlns:mc="http://schemas.openxmlformats.org/markup-compatibility/2006" xmlns:a14="http://schemas.microsoft.com/office/drawing/2010/main">
-        <mc:Choice Requires="a14">
+      <mc:AlternateContent xmlns:mc="http://schemas.openxmlformats.org/markup-compatibility/2006">
+        <mc:Choice xmlns:a14="http://schemas.microsoft.com/office/drawing/2010/main" Requires="a14">
           <p:sp>
             <p:nvSpPr>
               <p:cNvPr id="5" name="ZoneTexte 4">
@@ -7445,11 +7445,11 @@
                           </m:sSupPr>
                           <m:e>
                             <m:r>
-                              <a:rPr lang="fr-FR" sz="2600" i="1">
+                              <a:rPr lang="fr-CA" sz="2600" b="0" i="1" smtClean="0">
                                 <a:latin typeface="Cambria Math" panose="02040503050406030204" pitchFamily="18" charset="0"/>
                                 <a:ea typeface="Cambria Math" panose="02040503050406030204" pitchFamily="18" charset="0"/>
                               </a:rPr>
-                              <m:t>𝑅</m:t>
+                              <m:t>𝑟</m:t>
                             </m:r>
                           </m:e>
                           <m:sup>
@@ -7546,11 +7546,11 @@
                           </m:e>
                           <m:sub>
                             <m:r>
-                              <a:rPr lang="fr-FR" sz="2600" i="1">
+                              <a:rPr lang="fr-CA" sz="2600" b="0" i="1" smtClean="0">
                                 <a:latin typeface="Cambria Math" panose="02040503050406030204" pitchFamily="18" charset="0"/>
                                 <a:ea typeface="Cambria Math" panose="02040503050406030204" pitchFamily="18" charset="0"/>
                               </a:rPr>
-                              <m:t>𝑅</m:t>
+                              <m:t>𝑟</m:t>
                             </m:r>
                             <m:r>
                               <a:rPr lang="fr-FR" sz="2600" i="1">
@@ -7611,11 +7611,11 @@
                           </m:e>
                           <m:sub>
                             <m:r>
-                              <a:rPr lang="fr-FR" sz="2600" i="1">
+                              <a:rPr lang="fr-CA" sz="2600" b="0" i="1" smtClean="0">
                                 <a:latin typeface="Cambria Math" panose="02040503050406030204" pitchFamily="18" charset="0"/>
                                 <a:ea typeface="Cambria Math" panose="02040503050406030204" pitchFamily="18" charset="0"/>
                               </a:rPr>
-                              <m:t>𝑅</m:t>
+                              <m:t>𝑟</m:t>
                             </m:r>
                             <m:r>
                               <a:rPr lang="fr-FR" sz="2600" i="1">
@@ -7669,11 +7669,11 @@
                           </m:e>
                           <m:sub>
                             <m:r>
-                              <a:rPr lang="fr-FR" sz="2600" i="1">
+                              <a:rPr lang="fr-CA" sz="2600" b="0" i="1" smtClean="0">
                                 <a:latin typeface="Cambria Math" panose="02040503050406030204" pitchFamily="18" charset="0"/>
                                 <a:ea typeface="Cambria Math" panose="02040503050406030204" pitchFamily="18" charset="0"/>
                               </a:rPr>
-                              <m:t>𝑅</m:t>
+                              <m:t>𝑟</m:t>
                             </m:r>
                             <m:r>
                               <a:rPr lang="fr-FR" sz="2600" i="1">
@@ -7726,11 +7726,11 @@
                               <m:rPr>
                                 <m:sty m:val="p"/>
                               </m:rPr>
-                              <a:rPr lang="fr-FR" sz="2600">
+                              <a:rPr lang="fr-CA" sz="2600" b="0" i="0" smtClean="0">
                                 <a:latin typeface="Cambria Math" panose="02040503050406030204" pitchFamily="18" charset="0"/>
                                 <a:ea typeface="Cambria Math" panose="02040503050406030204" pitchFamily="18" charset="0"/>
                               </a:rPr>
-                              <m:t>R</m:t>
+                              <m:t>r</m:t>
                             </m:r>
                           </m:e>
                           <m:sup>
@@ -7918,10 +7918,10 @@
                           </m:e>
                           <m:sub>
                             <m:r>
-                              <a:rPr lang="fr-FR" sz="2600" i="1">
-                                <a:latin typeface="Cambria Math" panose="02040503050406030204" pitchFamily="18" charset="0"/>
-                              </a:rPr>
-                              <m:t>𝑅</m:t>
+                              <a:rPr lang="fr-CA" sz="2600" b="0" i="1" smtClean="0">
+                                <a:latin typeface="Cambria Math" panose="02040503050406030204" pitchFamily="18" charset="0"/>
+                              </a:rPr>
+                              <m:t>𝑟</m:t>
                             </m:r>
                             <m:r>
                               <a:rPr lang="fr-FR" sz="2600" i="1">
@@ -7981,10 +7981,10 @@
                           </m:e>
                           <m:sub>
                             <m:r>
-                              <a:rPr lang="fr-FR" sz="2600" i="1">
-                                <a:latin typeface="Cambria Math" panose="02040503050406030204" pitchFamily="18" charset="0"/>
-                              </a:rPr>
-                              <m:t>𝑅</m:t>
+                              <a:rPr lang="fr-CA" sz="2600" b="0" i="1" smtClean="0">
+                                <a:latin typeface="Cambria Math" panose="02040503050406030204" pitchFamily="18" charset="0"/>
+                              </a:rPr>
+                              <m:t>𝑟</m:t>
                             </m:r>
                             <m:r>
                               <a:rPr lang="fr-FR" sz="2600" i="1">
@@ -8032,10 +8032,10 @@
                           </m:e>
                           <m:sub>
                             <m:r>
-                              <a:rPr lang="fr-FR" sz="2600" i="1">
-                                <a:latin typeface="Cambria Math" panose="02040503050406030204" pitchFamily="18" charset="0"/>
-                              </a:rPr>
-                              <m:t>𝑅</m:t>
+                              <a:rPr lang="fr-CA" sz="2600" b="0" i="1" smtClean="0">
+                                <a:latin typeface="Cambria Math" panose="02040503050406030204" pitchFamily="18" charset="0"/>
+                              </a:rPr>
+                              <m:t>𝑟</m:t>
                             </m:r>
                             <m:r>
                               <a:rPr lang="fr-FR" sz="2600" i="1">
@@ -8120,7 +8120,7 @@
             </p:txBody>
           </p:sp>
         </mc:Choice>
-        <mc:Fallback xmlns="">
+        <mc:Fallback>
           <p:sp>
             <p:nvSpPr>
               <p:cNvPr id="5" name="ZoneTexte 4">
@@ -8155,7 +8155,7 @@
               <a:lstStyle/>
               <a:p>
                 <a:r>
-                  <a:rPr lang="fr-FR">
+                  <a:rPr lang="fr-CA">
                     <a:noFill/>
                   </a:rPr>
                   <a:t> </a:t>
@@ -9924,10 +9924,10 @@
                           </m:e>
                           <m:sub>
                             <m:r>
-                              <a:rPr lang="fr-FR" i="1">
-                                <a:latin typeface="Cambria Math" panose="02040503050406030204" pitchFamily="18" charset="0"/>
-                              </a:rPr>
-                              <m:t>𝑅</m:t>
+                              <a:rPr lang="fr-CA" b="0" i="1" smtClean="0">
+                                <a:latin typeface="Cambria Math" panose="02040503050406030204" pitchFamily="18" charset="0"/>
+                              </a:rPr>
+                              <m:t>𝑟</m:t>
                             </m:r>
                             <m:r>
                               <a:rPr lang="fr-FR" i="1">
@@ -9990,10 +9990,10 @@
                           </m:e>
                           <m:sub>
                             <m:r>
-                              <a:rPr lang="fr-FR" i="1">
-                                <a:latin typeface="Cambria Math" panose="02040503050406030204" pitchFamily="18" charset="0"/>
-                              </a:rPr>
-                              <m:t>𝑅</m:t>
+                              <a:rPr lang="fr-CA" b="0" i="1" smtClean="0">
+                                <a:latin typeface="Cambria Math" panose="02040503050406030204" pitchFamily="18" charset="0"/>
+                              </a:rPr>
+                              <m:t>𝑟</m:t>
                             </m:r>
                             <m:r>
                               <a:rPr lang="fr-FR" i="1">
@@ -10172,10 +10172,10 @@
                           <m:t>,</m:t>
                         </m:r>
                         <m:r>
-                          <a:rPr lang="fr-FR" b="0" i="1" smtClean="0">
-                            <a:latin typeface="Cambria Math" panose="02040503050406030204" pitchFamily="18" charset="0"/>
-                          </a:rPr>
-                          <m:t>𝑅</m:t>
+                          <a:rPr lang="fr-CA" b="0" i="1" smtClean="0">
+                            <a:latin typeface="Cambria Math" panose="02040503050406030204" pitchFamily="18" charset="0"/>
+                          </a:rPr>
+                          <m:t>𝑟</m:t>
                         </m:r>
                         <m:r>
                           <a:rPr lang="fr-FR" b="0" i="1" smtClean="0">
@@ -10330,10 +10330,10 @@
                           <m:t>,</m:t>
                         </m:r>
                         <m:r>
-                          <a:rPr lang="fr-FR" b="0" i="1" smtClean="0">
-                            <a:latin typeface="Cambria Math" panose="02040503050406030204" pitchFamily="18" charset="0"/>
-                          </a:rPr>
-                          <m:t>𝑅</m:t>
+                          <a:rPr lang="fr-CA" b="0" i="1" smtClean="0">
+                            <a:latin typeface="Cambria Math" panose="02040503050406030204" pitchFamily="18" charset="0"/>
+                          </a:rPr>
+                          <m:t>𝑟</m:t>
                         </m:r>
                         <m:r>
                           <a:rPr lang="fr-FR" b="0" i="1" smtClean="0">
@@ -10661,10 +10661,10 @@
                           <m:t>,</m:t>
                         </m:r>
                         <m:r>
-                          <a:rPr lang="fr-FR" i="1">
-                            <a:latin typeface="Cambria Math" panose="02040503050406030204" pitchFamily="18" charset="0"/>
-                          </a:rPr>
-                          <m:t>𝑅</m:t>
+                          <a:rPr lang="fr-CA" b="0" i="1" smtClean="0">
+                            <a:latin typeface="Cambria Math" panose="02040503050406030204" pitchFamily="18" charset="0"/>
+                          </a:rPr>
+                          <m:t>𝑟</m:t>
                         </m:r>
                         <m:r>
                           <a:rPr lang="fr-FR" i="1">
@@ -10804,10 +10804,10 @@
                           <m:t>,</m:t>
                         </m:r>
                         <m:r>
-                          <a:rPr lang="fr-FR" b="0" i="1" smtClean="0">
-                            <a:latin typeface="Cambria Math" panose="02040503050406030204" pitchFamily="18" charset="0"/>
-                          </a:rPr>
-                          <m:t>𝑅</m:t>
+                          <a:rPr lang="fr-CA" b="0" i="1" smtClean="0">
+                            <a:latin typeface="Cambria Math" panose="02040503050406030204" pitchFamily="18" charset="0"/>
+                          </a:rPr>
+                          <m:t>𝑟</m:t>
                         </m:r>
                         <m:r>
                           <a:rPr lang="fr-FR" b="0" i="1" smtClean="0">
@@ -10963,7 +10963,7 @@
               <a:lstStyle/>
               <a:p>
                 <a:r>
-                  <a:rPr lang="fr-FR">
+                  <a:rPr lang="fr-CA">
                     <a:noFill/>
                   </a:rPr>
                   <a:t> </a:t>
@@ -11112,10 +11112,10 @@
                           </m:e>
                           <m:sub>
                             <m:r>
-                              <a:rPr lang="fr-FR" sz="2400" i="1">
-                                <a:latin typeface="Cambria Math" panose="02040503050406030204" pitchFamily="18" charset="0"/>
-                              </a:rPr>
-                              <m:t>𝑅</m:t>
+                              <a:rPr lang="fr-CA" sz="2400" b="0" i="1" smtClean="0">
+                                <a:latin typeface="Cambria Math" panose="02040503050406030204" pitchFamily="18" charset="0"/>
+                              </a:rPr>
+                              <m:t>𝑟</m:t>
                             </m:r>
                             <m:r>
                               <a:rPr lang="fr-FR" sz="2400" i="1">
@@ -11163,10 +11163,10 @@
                           </m:e>
                           <m:sub>
                             <m:r>
-                              <a:rPr lang="fr-FR" sz="2400" i="1">
-                                <a:latin typeface="Cambria Math" panose="02040503050406030204" pitchFamily="18" charset="0"/>
-                              </a:rPr>
-                              <m:t>𝑅</m:t>
+                              <a:rPr lang="fr-CA" sz="2400" b="0" i="1" smtClean="0">
+                                <a:latin typeface="Cambria Math" panose="02040503050406030204" pitchFamily="18" charset="0"/>
+                              </a:rPr>
+                              <m:t>𝑟</m:t>
                             </m:r>
                             <m:r>
                               <a:rPr lang="fr-FR" sz="2400" i="1">
@@ -11202,10 +11202,10 @@
                           <m:t>Δ</m:t>
                         </m:r>
                         <m:r>
-                          <a:rPr lang="fr-FR" sz="2400" i="1">
-                            <a:latin typeface="Cambria Math" panose="02040503050406030204" pitchFamily="18" charset="0"/>
-                          </a:rPr>
-                          <m:t>𝑅</m:t>
+                          <a:rPr lang="fr-CA" sz="2400" b="0" i="1" smtClean="0">
+                            <a:latin typeface="Cambria Math" panose="02040503050406030204" pitchFamily="18" charset="0"/>
+                          </a:rPr>
+                          <m:t>𝑟</m:t>
                         </m:r>
                       </m:den>
                     </m:f>
@@ -11260,10 +11260,10 @@
                               <m:t>Δ</m:t>
                             </m:r>
                             <m:r>
-                              <a:rPr lang="fr-FR" sz="2400" i="1">
-                                <a:latin typeface="Cambria Math" panose="02040503050406030204" pitchFamily="18" charset="0"/>
-                              </a:rPr>
-                              <m:t>𝑅</m:t>
+                              <a:rPr lang="fr-CA" sz="2400" b="0" i="1" smtClean="0">
+                                <a:latin typeface="Cambria Math" panose="02040503050406030204" pitchFamily="18" charset="0"/>
+                              </a:rPr>
+                              <m:t>𝑟</m:t>
                             </m:r>
                           </m:den>
                         </m:f>
@@ -11334,10 +11334,10 @@
                           <m:t>𝜕</m:t>
                         </m:r>
                         <m:r>
-                          <a:rPr lang="fr-FR" sz="2400" b="0" i="1" smtClean="0">
-                            <a:latin typeface="Cambria Math" panose="02040503050406030204" pitchFamily="18" charset="0"/>
-                          </a:rPr>
-                          <m:t>𝑅</m:t>
+                          <a:rPr lang="fr-CA" sz="2400" b="0" i="1" smtClean="0">
+                            <a:latin typeface="Cambria Math" panose="02040503050406030204" pitchFamily="18" charset="0"/>
+                          </a:rPr>
+                          <m:t>𝑟</m:t>
                         </m:r>
                       </m:den>
                     </m:f>
@@ -11384,10 +11384,10 @@
                           <m:t>,</m:t>
                         </m:r>
                         <m:r>
-                          <a:rPr lang="fr-FR" sz="2400" b="0" i="1" smtClean="0">
-                            <a:latin typeface="Cambria Math" panose="02040503050406030204" pitchFamily="18" charset="0"/>
-                          </a:rPr>
-                          <m:t>𝑅</m:t>
+                          <a:rPr lang="fr-CA" sz="2400" b="0" i="1" smtClean="0">
+                            <a:latin typeface="Cambria Math" panose="02040503050406030204" pitchFamily="18" charset="0"/>
+                          </a:rPr>
+                          <m:t>𝑟</m:t>
                         </m:r>
                         <m:r>
                           <a:rPr lang="fr-FR" sz="2400" b="0" i="1" smtClean="0">
@@ -11413,10 +11413,10 @@
                       <m:t>Δ</m:t>
                     </m:r>
                     <m:r>
-                      <a:rPr lang="fr-FR" sz="2400" b="0" i="1" smtClean="0">
+                      <a:rPr lang="fr-CA" sz="2400" b="0" i="1" smtClean="0">
                         <a:latin typeface="Cambria Math" panose="02040503050406030204" pitchFamily="18" charset="0"/>
                       </a:rPr>
-                      <m:t>𝑅</m:t>
+                      <m:t>𝑟</m:t>
                     </m:r>
                     <m:r>
                       <a:rPr lang="fr-FR" sz="2400" b="0" i="1" smtClean="0">
@@ -11506,13 +11506,13 @@
                           </m:sSupPr>
                           <m:e>
                             <m:r>
-                              <a:rPr lang="fr-FR" sz="2400" b="0" i="1" smtClean="0">
+                              <a:rPr lang="fr-CA" sz="2400" b="0" i="1" smtClean="0">
                                 <a:solidFill>
                                   <a:srgbClr val="FF0000"/>
                                 </a:solidFill>
                                 <a:latin typeface="Cambria Math" panose="02040503050406030204" pitchFamily="18" charset="0"/>
                               </a:rPr>
-                              <m:t>𝑅</m:t>
+                              <m:t>𝑟</m:t>
                             </m:r>
                           </m:e>
                           <m:sup>
@@ -11587,13 +11587,13 @@
                           <m:t>,</m:t>
                         </m:r>
                         <m:r>
-                          <a:rPr lang="fr-FR" sz="2400" i="1">
+                          <a:rPr lang="fr-CA" sz="2400" b="0" i="1" smtClean="0">
                             <a:solidFill>
                               <a:srgbClr val="FF0000"/>
                             </a:solidFill>
                             <a:latin typeface="Cambria Math" panose="02040503050406030204" pitchFamily="18" charset="0"/>
                           </a:rPr>
-                          <m:t>𝑅</m:t>
+                          <m:t>𝑟</m:t>
                         </m:r>
                         <m:r>
                           <a:rPr lang="fr-FR" sz="2400" i="1">
@@ -11652,13 +11652,13 @@
                           </m:sSupPr>
                           <m:e>
                             <m:r>
-                              <a:rPr lang="fr-FR" sz="2400" b="0" i="1" smtClean="0">
+                              <a:rPr lang="fr-CA" sz="2400" b="0" i="1" smtClean="0">
                                 <a:solidFill>
                                   <a:srgbClr val="FF0000"/>
                                 </a:solidFill>
                                 <a:latin typeface="Cambria Math" panose="02040503050406030204" pitchFamily="18" charset="0"/>
                               </a:rPr>
-                              <m:t>𝑅</m:t>
+                              <m:t>𝑟</m:t>
                             </m:r>
                           </m:e>
                           <m:sup>
@@ -11750,10 +11750,10 @@
                           </m:sSupPr>
                           <m:e>
                             <m:r>
-                              <a:rPr lang="fr-FR" sz="2400" b="0" i="1" smtClean="0">
-                                <a:latin typeface="Cambria Math" panose="02040503050406030204" pitchFamily="18" charset="0"/>
-                              </a:rPr>
-                              <m:t>𝑅</m:t>
+                              <a:rPr lang="fr-CA" sz="2400" b="0" i="1" smtClean="0">
+                                <a:latin typeface="Cambria Math" panose="02040503050406030204" pitchFamily="18" charset="0"/>
+                              </a:rPr>
+                              <m:t>𝑟</m:t>
                             </m:r>
                           </m:e>
                           <m:sup>
@@ -11810,10 +11810,10 @@
                           <m:t>,</m:t>
                         </m:r>
                         <m:r>
-                          <a:rPr lang="fr-FR" sz="2400" i="1">
-                            <a:latin typeface="Cambria Math" panose="02040503050406030204" pitchFamily="18" charset="0"/>
-                          </a:rPr>
-                          <m:t>𝑅</m:t>
+                          <a:rPr lang="fr-CA" sz="2400" b="0" i="1" smtClean="0">
+                            <a:latin typeface="Cambria Math" panose="02040503050406030204" pitchFamily="18" charset="0"/>
+                          </a:rPr>
+                          <m:t>𝑟</m:t>
                         </m:r>
                         <m:r>
                           <a:rPr lang="fr-FR" sz="2400" i="1">
@@ -11857,10 +11857,10 @@
                           </m:sSupPr>
                           <m:e>
                             <m:r>
-                              <a:rPr lang="fr-FR" sz="2400" b="0" i="1" smtClean="0">
-                                <a:latin typeface="Cambria Math" panose="02040503050406030204" pitchFamily="18" charset="0"/>
-                              </a:rPr>
-                              <m:t>𝑅</m:t>
+                              <a:rPr lang="fr-CA" sz="2400" b="0" i="1" smtClean="0">
+                                <a:latin typeface="Cambria Math" panose="02040503050406030204" pitchFamily="18" charset="0"/>
+                              </a:rPr>
+                              <m:t>𝑟</m:t>
                             </m:r>
                           </m:e>
                           <m:sup>
@@ -11922,10 +11922,10 @@
                           </m:sSupPr>
                           <m:e>
                             <m:r>
-                              <a:rPr lang="fr-FR" sz="2400" b="0" i="1" smtClean="0">
-                                <a:latin typeface="Cambria Math" panose="02040503050406030204" pitchFamily="18" charset="0"/>
-                              </a:rPr>
-                              <m:t>𝑅</m:t>
+                              <a:rPr lang="fr-CA" sz="2400" b="0" i="1" smtClean="0">
+                                <a:latin typeface="Cambria Math" panose="02040503050406030204" pitchFamily="18" charset="0"/>
+                              </a:rPr>
+                              <m:t>𝑟</m:t>
                             </m:r>
                           </m:e>
                           <m:sup>
@@ -12046,10 +12046,10 @@
                           <m:t>𝜕</m:t>
                         </m:r>
                         <m:r>
-                          <a:rPr lang="fr-FR" sz="2400" b="0" i="1" smtClean="0">
-                            <a:latin typeface="Cambria Math" panose="02040503050406030204" pitchFamily="18" charset="0"/>
-                          </a:rPr>
-                          <m:t>𝑅</m:t>
+                          <a:rPr lang="fr-CA" sz="2400" b="0" i="1" smtClean="0">
+                            <a:latin typeface="Cambria Math" panose="02040503050406030204" pitchFamily="18" charset="0"/>
+                          </a:rPr>
+                          <m:t>𝑟</m:t>
                         </m:r>
                       </m:den>
                     </m:f>
@@ -12096,10 +12096,10 @@
                           <m:t>,</m:t>
                         </m:r>
                         <m:r>
-                          <a:rPr lang="fr-FR" sz="2400" b="0" i="1" smtClean="0">
-                            <a:latin typeface="Cambria Math" panose="02040503050406030204" pitchFamily="18" charset="0"/>
-                          </a:rPr>
-                          <m:t>𝑅</m:t>
+                          <a:rPr lang="fr-CA" sz="2400" b="0" i="1" smtClean="0">
+                            <a:latin typeface="Cambria Math" panose="02040503050406030204" pitchFamily="18" charset="0"/>
+                          </a:rPr>
+                          <m:t>𝑟</m:t>
                         </m:r>
                         <m:r>
                           <a:rPr lang="fr-FR" sz="2400" b="0" i="1" smtClean="0">
@@ -12125,10 +12125,10 @@
                       <m:t>Δ</m:t>
                     </m:r>
                     <m:r>
-                      <a:rPr lang="fr-FR" sz="2400" b="0" i="1" smtClean="0">
+                      <a:rPr lang="fr-CA" sz="2400" b="0" i="1" smtClean="0">
                         <a:latin typeface="Cambria Math" panose="02040503050406030204" pitchFamily="18" charset="0"/>
                       </a:rPr>
-                      <m:t>𝑅</m:t>
+                      <m:t>𝑟</m:t>
                     </m:r>
                     <m:r>
                       <a:rPr lang="fr-FR" sz="2400" b="0" i="1" smtClean="0">
@@ -12299,13 +12299,13 @@
                           <m:t>,</m:t>
                         </m:r>
                         <m:r>
-                          <a:rPr lang="fr-FR" sz="2400" i="1">
+                          <a:rPr lang="fr-CA" sz="2400" b="0" i="1" smtClean="0">
                             <a:solidFill>
                               <a:srgbClr val="FF0000"/>
                             </a:solidFill>
                             <a:latin typeface="Cambria Math" panose="02040503050406030204" pitchFamily="18" charset="0"/>
                           </a:rPr>
-                          <m:t>𝑅</m:t>
+                          <m:t>𝑟</m:t>
                         </m:r>
                         <m:r>
                           <a:rPr lang="fr-FR" sz="2400" i="1">
@@ -12364,13 +12364,13 @@
                           </m:sSupPr>
                           <m:e>
                             <m:r>
-                              <a:rPr lang="fr-FR" sz="2400" b="0" i="1" smtClean="0">
+                              <a:rPr lang="fr-CA" sz="2400" b="0" i="1" smtClean="0">
                                 <a:solidFill>
                                   <a:srgbClr val="FF0000"/>
                                 </a:solidFill>
                                 <a:latin typeface="Cambria Math" panose="02040503050406030204" pitchFamily="18" charset="0"/>
                               </a:rPr>
-                              <m:t>𝑅</m:t>
+                              <m:t>𝑟</m:t>
                             </m:r>
                           </m:e>
                           <m:sup>
@@ -12474,10 +12474,10 @@
                           </m:sSupPr>
                           <m:e>
                             <m:r>
-                              <a:rPr lang="fr-FR" sz="2400" i="1">
-                                <a:latin typeface="Cambria Math" panose="02040503050406030204" pitchFamily="18" charset="0"/>
-                              </a:rPr>
-                              <m:t>𝑅</m:t>
+                              <a:rPr lang="fr-CA" sz="2400" b="0" i="1" smtClean="0">
+                                <a:latin typeface="Cambria Math" panose="02040503050406030204" pitchFamily="18" charset="0"/>
+                              </a:rPr>
+                              <m:t>𝑟</m:t>
                             </m:r>
                           </m:e>
                           <m:sup>
@@ -12534,10 +12534,10 @@
                           <m:t>,</m:t>
                         </m:r>
                         <m:r>
-                          <a:rPr lang="fr-FR" sz="2400" i="1">
-                            <a:latin typeface="Cambria Math" panose="02040503050406030204" pitchFamily="18" charset="0"/>
-                          </a:rPr>
-                          <m:t>𝑅</m:t>
+                          <a:rPr lang="fr-CA" sz="2400" b="0" i="1" smtClean="0">
+                            <a:latin typeface="Cambria Math" panose="02040503050406030204" pitchFamily="18" charset="0"/>
+                          </a:rPr>
+                          <m:t>𝑟</m:t>
                         </m:r>
                         <m:r>
                           <a:rPr lang="fr-FR" sz="2400" i="1">
@@ -12581,10 +12581,10 @@
                           </m:sSupPr>
                           <m:e>
                             <m:r>
-                              <a:rPr lang="fr-FR" sz="2400" i="1">
-                                <a:latin typeface="Cambria Math" panose="02040503050406030204" pitchFamily="18" charset="0"/>
-                              </a:rPr>
-                              <m:t>𝑅</m:t>
+                              <a:rPr lang="fr-CA" sz="2400" b="0" i="1" smtClean="0">
+                                <a:latin typeface="Cambria Math" panose="02040503050406030204" pitchFamily="18" charset="0"/>
+                              </a:rPr>
+                              <m:t>𝑟</m:t>
                             </m:r>
                           </m:e>
                           <m:sup>
@@ -12646,10 +12646,10 @@
                           </m:sSupPr>
                           <m:e>
                             <m:r>
-                              <a:rPr lang="fr-FR" sz="2400" i="1">
-                                <a:latin typeface="Cambria Math" panose="02040503050406030204" pitchFamily="18" charset="0"/>
-                              </a:rPr>
-                              <m:t>𝑅</m:t>
+                              <a:rPr lang="fr-CA" sz="2400" b="0" i="1" smtClean="0">
+                                <a:latin typeface="Cambria Math" panose="02040503050406030204" pitchFamily="18" charset="0"/>
+                              </a:rPr>
+                              <m:t>𝑟</m:t>
                             </m:r>
                           </m:e>
                           <m:sup>
@@ -12779,10 +12779,10 @@
                           <m:t>,</m:t>
                         </m:r>
                         <m:r>
-                          <a:rPr lang="fr-FR" sz="2400" i="1">
-                            <a:latin typeface="Cambria Math" panose="02040503050406030204" pitchFamily="18" charset="0"/>
-                          </a:rPr>
-                          <m:t>𝑅</m:t>
+                          <a:rPr lang="fr-CA" sz="2400" b="0" i="1" smtClean="0">
+                            <a:latin typeface="Cambria Math" panose="02040503050406030204" pitchFamily="18" charset="0"/>
+                          </a:rPr>
+                          <m:t>𝑟</m:t>
                         </m:r>
                         <m:r>
                           <a:rPr lang="fr-FR" sz="2400" i="1">
@@ -12862,10 +12862,10 @@
                           </m:sSupPr>
                           <m:e>
                             <m:r>
-                              <a:rPr lang="fr-FR" sz="2400" b="0" i="1" smtClean="0">
-                                <a:latin typeface="Cambria Math" panose="02040503050406030204" pitchFamily="18" charset="0"/>
-                              </a:rPr>
-                              <m:t>𝑅</m:t>
+                              <a:rPr lang="fr-CA" sz="2400" b="0" i="1" smtClean="0">
+                                <a:latin typeface="Cambria Math" panose="02040503050406030204" pitchFamily="18" charset="0"/>
+                              </a:rPr>
+                              <m:t>𝑟</m:t>
                             </m:r>
                           </m:e>
                           <m:sup>
@@ -12951,13 +12951,13 @@
                           </m:sSupPr>
                           <m:e>
                             <m:r>
-                              <a:rPr lang="fr-FR" sz="2400" b="0" i="1" smtClean="0">
+                              <a:rPr lang="fr-CA" sz="2400" b="0" i="1" smtClean="0">
                                 <a:solidFill>
                                   <a:srgbClr val="0070C0"/>
                                 </a:solidFill>
                                 <a:latin typeface="Cambria Math" panose="02040503050406030204" pitchFamily="18" charset="0"/>
                               </a:rPr>
-                              <m:t>𝑅</m:t>
+                              <m:t>𝑟</m:t>
                             </m:r>
                           </m:e>
                           <m:sup>
@@ -13031,13 +13031,13 @@
                       </m:sSupPr>
                       <m:e>
                         <m:r>
-                          <a:rPr lang="fr-FR" sz="2400" b="0" i="1" smtClean="0">
+                          <a:rPr lang="fr-CA" sz="2400" b="0" i="1" smtClean="0">
                             <a:solidFill>
                               <a:srgbClr val="0070C0"/>
                             </a:solidFill>
                             <a:latin typeface="Cambria Math" panose="02040503050406030204" pitchFamily="18" charset="0"/>
                           </a:rPr>
-                          <m:t>𝑅</m:t>
+                          <m:t>𝑟</m:t>
                         </m:r>
                       </m:e>
                       <m:sup>
@@ -13099,10 +13099,10 @@
                           </m:e>
                           <m:sub>
                             <m:r>
-                              <a:rPr lang="fr-FR" sz="2400" i="1">
-                                <a:latin typeface="Cambria Math" panose="02040503050406030204" pitchFamily="18" charset="0"/>
-                              </a:rPr>
-                              <m:t>𝑅</m:t>
+                              <a:rPr lang="fr-CA" sz="2400" b="0" i="1" smtClean="0">
+                                <a:latin typeface="Cambria Math" panose="02040503050406030204" pitchFamily="18" charset="0"/>
+                              </a:rPr>
+                              <m:t>𝑟</m:t>
                             </m:r>
                             <m:r>
                               <a:rPr lang="fr-FR" sz="2400" i="1">
@@ -13162,10 +13162,10 @@
                           </m:e>
                           <m:sub>
                             <m:r>
-                              <a:rPr lang="fr-FR" sz="2400" i="1">
-                                <a:latin typeface="Cambria Math" panose="02040503050406030204" pitchFamily="18" charset="0"/>
-                              </a:rPr>
-                              <m:t>𝑅</m:t>
+                              <a:rPr lang="fr-CA" sz="2400" b="0" i="1" smtClean="0">
+                                <a:latin typeface="Cambria Math" panose="02040503050406030204" pitchFamily="18" charset="0"/>
+                              </a:rPr>
+                              <m:t>𝑟</m:t>
                             </m:r>
                             <m:r>
                               <a:rPr lang="fr-FR" sz="2400" i="1">
@@ -13213,10 +13213,10 @@
                           </m:e>
                           <m:sub>
                             <m:r>
-                              <a:rPr lang="fr-FR" sz="2400" i="1">
-                                <a:latin typeface="Cambria Math" panose="02040503050406030204" pitchFamily="18" charset="0"/>
-                              </a:rPr>
-                              <m:t>𝑅</m:t>
+                              <a:rPr lang="fr-CA" sz="2400" b="0" i="1" smtClean="0">
+                                <a:latin typeface="Cambria Math" panose="02040503050406030204" pitchFamily="18" charset="0"/>
+                              </a:rPr>
+                              <m:t>𝑟</m:t>
                             </m:r>
                             <m:r>
                               <a:rPr lang="fr-FR" sz="2400" i="1">
@@ -13515,13 +13515,13 @@
                           <m:t>,</m:t>
                         </m:r>
                         <m:r>
-                          <a:rPr lang="fr-FR" sz="2400" i="1">
+                          <a:rPr lang="fr-CA" sz="2400" b="0" i="1" smtClean="0">
                             <a:solidFill>
                               <a:srgbClr val="FF0000"/>
                             </a:solidFill>
                             <a:latin typeface="Cambria Math" panose="02040503050406030204" pitchFamily="18" charset="0"/>
                           </a:rPr>
-                          <m:t>𝑅</m:t>
+                          <m:t>𝑟</m:t>
                         </m:r>
                         <m:r>
                           <a:rPr lang="fr-FR" sz="2400" i="1">
@@ -13733,13 +13733,13 @@
                           <m:t>,</m:t>
                         </m:r>
                         <m:r>
-                          <a:rPr lang="fr-FR" sz="2400" i="1">
+                          <a:rPr lang="fr-CA" sz="2400" b="0" i="1" smtClean="0">
                             <a:solidFill>
                               <a:schemeClr val="tx1"/>
                             </a:solidFill>
                             <a:latin typeface="Cambria Math" panose="02040503050406030204" pitchFamily="18" charset="0"/>
                           </a:rPr>
-                          <m:t>𝑅</m:t>
+                          <m:t>𝑟</m:t>
                         </m:r>
                         <m:r>
                           <a:rPr lang="fr-FR" sz="2400" i="1">
@@ -14001,13 +14001,13 @@
                           <m:t>,</m:t>
                         </m:r>
                         <m:r>
-                          <a:rPr lang="fr-FR" sz="2400" i="1">
+                          <a:rPr lang="fr-CA" sz="2400" b="0" i="1" smtClean="0">
                             <a:solidFill>
                               <a:srgbClr val="FF0000"/>
                             </a:solidFill>
                             <a:latin typeface="Cambria Math" panose="02040503050406030204" pitchFamily="18" charset="0"/>
                           </a:rPr>
-                          <m:t>𝑅</m:t>
+                          <m:t>𝑟</m:t>
                         </m:r>
                         <m:r>
                           <a:rPr lang="fr-FR" sz="2400" i="1">
@@ -14458,13 +14458,13 @@
                           <m:t>,</m:t>
                         </m:r>
                         <m:r>
-                          <a:rPr lang="fr-FR" sz="2400" i="1">
+                          <a:rPr lang="fr-CA" sz="2400" b="0" i="1" smtClean="0">
                             <a:solidFill>
                               <a:srgbClr val="FF0000"/>
                             </a:solidFill>
                             <a:latin typeface="Cambria Math" panose="02040503050406030204" pitchFamily="18" charset="0"/>
                           </a:rPr>
-                          <m:t>𝑅</m:t>
+                          <m:t>𝑟</m:t>
                         </m:r>
                         <m:r>
                           <a:rPr lang="fr-FR" sz="2400" i="1">
@@ -14631,10 +14631,10 @@
                           <m:t>,</m:t>
                         </m:r>
                         <m:r>
-                          <a:rPr lang="fr-FR" sz="2400" i="1">
-                            <a:latin typeface="Cambria Math" panose="02040503050406030204" pitchFamily="18" charset="0"/>
-                          </a:rPr>
-                          <m:t>𝑅</m:t>
+                          <a:rPr lang="fr-CA" sz="2400" b="0" i="1" smtClean="0">
+                            <a:latin typeface="Cambria Math" panose="02040503050406030204" pitchFamily="18" charset="0"/>
+                          </a:rPr>
+                          <m:t>𝑟</m:t>
                         </m:r>
                         <m:r>
                           <a:rPr lang="fr-FR" sz="2400" i="1">
@@ -14872,13 +14872,13 @@
                           <m:t>,</m:t>
                         </m:r>
                         <m:r>
-                          <a:rPr lang="fr-FR" sz="2400" i="1">
+                          <a:rPr lang="fr-CA" sz="2400" b="0" i="1" smtClean="0">
                             <a:solidFill>
                               <a:srgbClr val="FF0000"/>
                             </a:solidFill>
                             <a:latin typeface="Cambria Math" panose="02040503050406030204" pitchFamily="18" charset="0"/>
                           </a:rPr>
-                          <m:t>𝑅</m:t>
+                          <m:t>𝑟</m:t>
                         </m:r>
                         <m:r>
                           <a:rPr lang="fr-FR" sz="2400" i="1">
@@ -15457,10 +15457,10 @@
                           <m:t>,</m:t>
                         </m:r>
                         <m:r>
-                          <a:rPr lang="fr-FR" sz="2400" i="1">
-                            <a:latin typeface="Cambria Math" panose="02040503050406030204" pitchFamily="18" charset="0"/>
-                          </a:rPr>
-                          <m:t>𝑅</m:t>
+                          <a:rPr lang="fr-CA" sz="2400" b="0" i="1" smtClean="0">
+                            <a:latin typeface="Cambria Math" panose="02040503050406030204" pitchFamily="18" charset="0"/>
+                          </a:rPr>
+                          <m:t>𝑟</m:t>
                         </m:r>
                         <m:r>
                           <a:rPr lang="fr-FR" sz="2400" i="1">
@@ -15787,7 +15787,7 @@
               <a:lstStyle/>
               <a:p>
                 <a:r>
-                  <a:rPr lang="fr-FR">
+                  <a:rPr lang="fr-CA">
                     <a:noFill/>
                   </a:rPr>
                   <a:t> </a:t>

</xml_diff>

<commit_message>
pwp: cylindrical heat equation developpment
</commit_message>
<xml_diff>
--- a/projet_final/projet_final/MEC8211-Projet-final-Presentation.pptx
+++ b/projet_final/projet_final/MEC8211-Projet-final-Presentation.pptx
@@ -5,17 +5,18 @@
     <p:sldMasterId id="2147483648" r:id="rId1"/>
   </p:sldMasterIdLst>
   <p:notesMasterIdLst>
-    <p:notesMasterId r:id="rId10"/>
+    <p:notesMasterId r:id="rId11"/>
   </p:notesMasterIdLst>
   <p:sldIdLst>
     <p:sldId id="256" r:id="rId2"/>
     <p:sldId id="258" r:id="rId3"/>
     <p:sldId id="257" r:id="rId4"/>
-    <p:sldId id="259" r:id="rId5"/>
-    <p:sldId id="263" r:id="rId6"/>
-    <p:sldId id="260" r:id="rId7"/>
-    <p:sldId id="262" r:id="rId8"/>
-    <p:sldId id="261" r:id="rId9"/>
+    <p:sldId id="264" r:id="rId5"/>
+    <p:sldId id="259" r:id="rId6"/>
+    <p:sldId id="263" r:id="rId7"/>
+    <p:sldId id="260" r:id="rId8"/>
+    <p:sldId id="262" r:id="rId9"/>
+    <p:sldId id="261" r:id="rId10"/>
   </p:sldIdLst>
   <p:sldSz cx="12192000" cy="6858000"/>
   <p:notesSz cx="6858000" cy="9144000"/>
@@ -620,7 +621,7 @@
           <a:p>
             <a:fld id="{F6105186-0725-443C-BC59-E521425E81CD}" type="slidenum">
               <a:rPr lang="fr-FR" smtClean="0"/>
-              <a:t>6</a:t>
+              <a:t>7</a:t>
             </a:fld>
             <a:endParaRPr lang="fr-FR"/>
           </a:p>
@@ -728,7 +729,7 @@
           <a:p>
             <a:fld id="{F6105186-0725-443C-BC59-E521425E81CD}" type="slidenum">
               <a:rPr lang="fr-FR" smtClean="0"/>
-              <a:t>7</a:t>
+              <a:t>8</a:t>
             </a:fld>
             <a:endParaRPr lang="fr-FR"/>
           </a:p>
@@ -5424,6 +5425,1493 @@
   <p:cSld>
     <p:spTree>
       <p:nvGrpSpPr>
+        <p:cNvPr id="1" name="">
+          <a:extLst>
+            <a:ext uri="{FF2B5EF4-FFF2-40B4-BE49-F238E27FC236}">
+              <a16:creationId xmlns:a16="http://schemas.microsoft.com/office/drawing/2014/main" id="{030694C9-7099-3A84-9A6D-5B2A0879BE8B}"/>
+            </a:ext>
+          </a:extLst>
+        </p:cNvPr>
+        <p:cNvGrpSpPr/>
+        <p:nvPr/>
+      </p:nvGrpSpPr>
+      <p:grpSpPr>
+        <a:xfrm>
+          <a:off x="0" y="0"/>
+          <a:ext cx="0" cy="0"/>
+          <a:chOff x="0" y="0"/>
+          <a:chExt cx="0" cy="0"/>
+        </a:xfrm>
+      </p:grpSpPr>
+      <p:sp>
+        <p:nvSpPr>
+          <p:cNvPr id="2" name="Titre 1">
+            <a:extLst>
+              <a:ext uri="{FF2B5EF4-FFF2-40B4-BE49-F238E27FC236}">
+                <a16:creationId xmlns:a16="http://schemas.microsoft.com/office/drawing/2014/main" id="{0DEC12AB-5894-7E9F-0510-EB109BFCA985}"/>
+              </a:ext>
+            </a:extLst>
+          </p:cNvPr>
+          <p:cNvSpPr>
+            <a:spLocks noGrp="1"/>
+          </p:cNvSpPr>
+          <p:nvPr>
+            <p:ph type="title"/>
+          </p:nvPr>
+        </p:nvSpPr>
+        <p:spPr>
+          <a:xfrm>
+            <a:off x="838200" y="18255"/>
+            <a:ext cx="10515600" cy="1325563"/>
+          </a:xfrm>
+        </p:spPr>
+        <p:txBody>
+          <a:bodyPr/>
+          <a:lstStyle/>
+          <a:p>
+            <a:r>
+              <a:rPr lang="fr-FR" dirty="0"/>
+              <a:t>Modélisation mathématique</a:t>
+            </a:r>
+          </a:p>
+        </p:txBody>
+      </p:sp>
+      <mc:AlternateContent xmlns:mc="http://schemas.openxmlformats.org/markup-compatibility/2006">
+        <mc:Choice xmlns:a14="http://schemas.microsoft.com/office/drawing/2010/main" Requires="a14">
+          <p:sp>
+            <p:nvSpPr>
+              <p:cNvPr id="3" name="Espace réservé du contenu 2">
+                <a:extLst>
+                  <a:ext uri="{FF2B5EF4-FFF2-40B4-BE49-F238E27FC236}">
+                    <a16:creationId xmlns:a16="http://schemas.microsoft.com/office/drawing/2014/main" id="{8073797C-3545-B398-B72A-5A621002005D}"/>
+                  </a:ext>
+                </a:extLst>
+              </p:cNvPr>
+              <p:cNvSpPr>
+                <a:spLocks noGrp="1"/>
+              </p:cNvSpPr>
+              <p:nvPr>
+                <p:ph idx="1"/>
+              </p:nvPr>
+            </p:nvSpPr>
+            <p:spPr>
+              <a:xfrm>
+                <a:off x="838200" y="1155033"/>
+                <a:ext cx="8177463" cy="5358062"/>
+              </a:xfrm>
+            </p:spPr>
+            <p:txBody>
+              <a:bodyPr>
+                <a:normAutofit fontScale="92500" lnSpcReduction="10000"/>
+              </a:bodyPr>
+              <a:lstStyle/>
+              <a:p>
+                <a:pPr marL="0" indent="0" fontAlgn="base">
+                  <a:spcBef>
+                    <a:spcPts val="1800"/>
+                  </a:spcBef>
+                  <a:buNone/>
+                </a:pPr>
+                <a:r>
+                  <a:rPr lang="fr-FR" dirty="0"/>
+                  <a:t>Equation de la chaleur en 2D </a:t>
+                </a:r>
+                <a:endParaRPr lang="en-US" dirty="0"/>
+              </a:p>
+              <a:p>
+                <a:pPr marL="0" indent="0">
+                  <a:spcBef>
+                    <a:spcPts val="1800"/>
+                  </a:spcBef>
+                  <a:buNone/>
+                </a:pPr>
+                <a14:m>
+                  <m:oMathPara xmlns:m="http://schemas.openxmlformats.org/officeDocument/2006/math">
+                    <m:oMathParaPr>
+                      <m:jc m:val="centerGroup"/>
+                    </m:oMathParaPr>
+                    <m:oMath xmlns:m="http://schemas.openxmlformats.org/officeDocument/2006/math">
+                      <m:r>
+                        <m:rPr>
+                          <m:sty m:val="p"/>
+                        </m:rPr>
+                        <a:rPr lang="el-GR" i="1">
+                          <a:latin typeface="Cambria Math" panose="02040503050406030204" pitchFamily="18" charset="0"/>
+                        </a:rPr>
+                        <m:t>ρ</m:t>
+                      </m:r>
+                      <m:sSub>
+                        <m:sSubPr>
+                          <m:ctrlPr>
+                            <a:rPr lang="fr-FR" b="0" i="1" smtClean="0">
+                              <a:latin typeface="Cambria Math" panose="02040503050406030204" pitchFamily="18" charset="0"/>
+                            </a:rPr>
+                          </m:ctrlPr>
+                        </m:sSubPr>
+                        <m:e>
+                          <m:r>
+                            <a:rPr lang="fr-FR" b="0" i="1" smtClean="0">
+                              <a:latin typeface="Cambria Math" panose="02040503050406030204" pitchFamily="18" charset="0"/>
+                            </a:rPr>
+                            <m:t>𝐶</m:t>
+                          </m:r>
+                        </m:e>
+                        <m:sub>
+                          <m:r>
+                            <a:rPr lang="fr-FR" b="0" i="1" smtClean="0">
+                              <a:latin typeface="Cambria Math" panose="02040503050406030204" pitchFamily="18" charset="0"/>
+                            </a:rPr>
+                            <m:t>𝑝</m:t>
+                          </m:r>
+                        </m:sub>
+                      </m:sSub>
+                      <m:f>
+                        <m:fPr>
+                          <m:ctrlPr>
+                            <a:rPr lang="fr-FR" i="1">
+                              <a:latin typeface="Cambria Math" panose="02040503050406030204" pitchFamily="18" charset="0"/>
+                            </a:rPr>
+                          </m:ctrlPr>
+                        </m:fPr>
+                        <m:num>
+                          <m:r>
+                            <a:rPr lang="fr-FR" i="1">
+                              <a:latin typeface="Cambria Math" panose="02040503050406030204" pitchFamily="18" charset="0"/>
+                            </a:rPr>
+                            <m:t>𝜕</m:t>
+                          </m:r>
+                          <m:r>
+                            <a:rPr lang="fr-FR" b="0" i="1" smtClean="0">
+                              <a:latin typeface="Cambria Math" panose="02040503050406030204" pitchFamily="18" charset="0"/>
+                            </a:rPr>
+                            <m:t>𝑇</m:t>
+                          </m:r>
+                        </m:num>
+                        <m:den>
+                          <m:r>
+                            <a:rPr lang="fr-FR" i="1">
+                              <a:latin typeface="Cambria Math" panose="02040503050406030204" pitchFamily="18" charset="0"/>
+                            </a:rPr>
+                            <m:t>𝜕</m:t>
+                          </m:r>
+                          <m:r>
+                            <a:rPr lang="fr-FR" b="0" i="1" smtClean="0">
+                              <a:latin typeface="Cambria Math" panose="02040503050406030204" pitchFamily="18" charset="0"/>
+                            </a:rPr>
+                            <m:t>𝑡</m:t>
+                          </m:r>
+                        </m:den>
+                      </m:f>
+                      <m:r>
+                        <a:rPr lang="fr-FR" b="0" i="1" smtClean="0">
+                          <a:latin typeface="Cambria Math" panose="02040503050406030204" pitchFamily="18" charset="0"/>
+                        </a:rPr>
+                        <m:t>=</m:t>
+                      </m:r>
+                      <m:r>
+                        <a:rPr lang="fr-FR" b="0" i="1" smtClean="0">
+                          <a:latin typeface="Cambria Math" panose="02040503050406030204" pitchFamily="18" charset="0"/>
+                        </a:rPr>
+                        <m:t>𝑘</m:t>
+                      </m:r>
+                      <m:sSup>
+                        <m:sSupPr>
+                          <m:ctrlPr>
+                            <a:rPr lang="fr-FR" b="0" i="1" smtClean="0">
+                              <a:latin typeface="Cambria Math" panose="02040503050406030204" pitchFamily="18" charset="0"/>
+                            </a:rPr>
+                          </m:ctrlPr>
+                        </m:sSupPr>
+                        <m:e>
+                          <m:r>
+                            <m:rPr>
+                              <m:sty m:val="p"/>
+                            </m:rPr>
+                            <a:rPr lang="fr-FR" b="0" i="1" smtClean="0">
+                              <a:latin typeface="Cambria Math" panose="02040503050406030204" pitchFamily="18" charset="0"/>
+                            </a:rPr>
+                            <m:t>∇</m:t>
+                          </m:r>
+                        </m:e>
+                        <m:sup>
+                          <m:r>
+                            <a:rPr lang="fr-FR" b="0" i="1" smtClean="0">
+                              <a:latin typeface="Cambria Math" panose="02040503050406030204" pitchFamily="18" charset="0"/>
+                            </a:rPr>
+                            <m:t>2</m:t>
+                          </m:r>
+                        </m:sup>
+                      </m:sSup>
+                      <m:r>
+                        <a:rPr lang="fr-FR" b="0" i="1" smtClean="0">
+                          <a:latin typeface="Cambria Math" panose="02040503050406030204" pitchFamily="18" charset="0"/>
+                        </a:rPr>
+                        <m:t>𝑇</m:t>
+                      </m:r>
+                    </m:oMath>
+                  </m:oMathPara>
+                </a14:m>
+                <a:endParaRPr lang="fr-FR" b="0" dirty="0"/>
+              </a:p>
+              <a:p>
+                <a:pPr marL="0" indent="0">
+                  <a:spcBef>
+                    <a:spcPts val="1800"/>
+                  </a:spcBef>
+                  <a:buNone/>
+                </a:pPr>
+                <a:r>
+                  <a:rPr lang="fr-FR" dirty="0"/>
+                  <a:t>En cartésien, on a :</a:t>
+                </a:r>
+              </a:p>
+              <a:p>
+                <a:pPr marL="0" indent="0">
+                  <a:spcBef>
+                    <a:spcPts val="1800"/>
+                  </a:spcBef>
+                  <a:buNone/>
+                </a:pPr>
+                <a14:m>
+                  <m:oMathPara xmlns:m="http://schemas.openxmlformats.org/officeDocument/2006/math">
+                    <m:oMathParaPr>
+                      <m:jc m:val="centerGroup"/>
+                    </m:oMathParaPr>
+                    <m:oMath xmlns:m="http://schemas.openxmlformats.org/officeDocument/2006/math">
+                      <m:r>
+                        <m:rPr>
+                          <m:sty m:val="p"/>
+                        </m:rPr>
+                        <a:rPr lang="el-GR" i="1">
+                          <a:latin typeface="Cambria Math" panose="02040503050406030204" pitchFamily="18" charset="0"/>
+                        </a:rPr>
+                        <m:t>ρ</m:t>
+                      </m:r>
+                      <m:sSub>
+                        <m:sSubPr>
+                          <m:ctrlPr>
+                            <a:rPr lang="fr-FR" i="1">
+                              <a:latin typeface="Cambria Math" panose="02040503050406030204" pitchFamily="18" charset="0"/>
+                            </a:rPr>
+                          </m:ctrlPr>
+                        </m:sSubPr>
+                        <m:e>
+                          <m:r>
+                            <a:rPr lang="fr-FR" i="1">
+                              <a:latin typeface="Cambria Math" panose="02040503050406030204" pitchFamily="18" charset="0"/>
+                            </a:rPr>
+                            <m:t>𝐶</m:t>
+                          </m:r>
+                        </m:e>
+                        <m:sub>
+                          <m:r>
+                            <a:rPr lang="fr-FR" i="1">
+                              <a:latin typeface="Cambria Math" panose="02040503050406030204" pitchFamily="18" charset="0"/>
+                            </a:rPr>
+                            <m:t>𝑝</m:t>
+                          </m:r>
+                        </m:sub>
+                      </m:sSub>
+                      <m:r>
+                        <a:rPr lang="fr-FR" i="1">
+                          <a:latin typeface="Cambria Math" panose="02040503050406030204" pitchFamily="18" charset="0"/>
+                        </a:rPr>
+                        <m:t> </m:t>
+                      </m:r>
+                      <m:f>
+                        <m:fPr>
+                          <m:ctrlPr>
+                            <a:rPr lang="fr-FR" i="1">
+                              <a:latin typeface="Cambria Math" panose="02040503050406030204" pitchFamily="18" charset="0"/>
+                            </a:rPr>
+                          </m:ctrlPr>
+                        </m:fPr>
+                        <m:num>
+                          <m:r>
+                            <a:rPr lang="fr-FR" i="1">
+                              <a:latin typeface="Cambria Math" panose="02040503050406030204" pitchFamily="18" charset="0"/>
+                            </a:rPr>
+                            <m:t>𝜕</m:t>
+                          </m:r>
+                          <m:r>
+                            <a:rPr lang="fr-FR" i="1">
+                              <a:latin typeface="Cambria Math" panose="02040503050406030204" pitchFamily="18" charset="0"/>
+                            </a:rPr>
+                            <m:t>𝑇</m:t>
+                          </m:r>
+                        </m:num>
+                        <m:den>
+                          <m:r>
+                            <a:rPr lang="fr-FR" i="1">
+                              <a:latin typeface="Cambria Math" panose="02040503050406030204" pitchFamily="18" charset="0"/>
+                            </a:rPr>
+                            <m:t>𝜕</m:t>
+                          </m:r>
+                          <m:r>
+                            <a:rPr lang="fr-FR" i="1">
+                              <a:latin typeface="Cambria Math" panose="02040503050406030204" pitchFamily="18" charset="0"/>
+                            </a:rPr>
+                            <m:t>𝑡</m:t>
+                          </m:r>
+                        </m:den>
+                      </m:f>
+                      <m:r>
+                        <a:rPr lang="fr-CA" b="0" i="1" smtClean="0">
+                          <a:latin typeface="Cambria Math" panose="02040503050406030204" pitchFamily="18" charset="0"/>
+                        </a:rPr>
+                        <m:t>=</m:t>
+                      </m:r>
+                      <m:r>
+                        <a:rPr lang="fr-CA" b="0" i="1" smtClean="0">
+                          <a:latin typeface="Cambria Math" panose="02040503050406030204" pitchFamily="18" charset="0"/>
+                        </a:rPr>
+                        <m:t>𝑘</m:t>
+                      </m:r>
+                      <m:r>
+                        <a:rPr lang="fr-CA" b="0" i="1" smtClean="0">
+                          <a:latin typeface="Cambria Math" panose="02040503050406030204" pitchFamily="18" charset="0"/>
+                        </a:rPr>
+                        <m:t>(</m:t>
+                      </m:r>
+                      <m:f>
+                        <m:fPr>
+                          <m:ctrlPr>
+                            <a:rPr lang="fr-FR" i="1">
+                              <a:latin typeface="Cambria Math" panose="02040503050406030204" pitchFamily="18" charset="0"/>
+                            </a:rPr>
+                          </m:ctrlPr>
+                        </m:fPr>
+                        <m:num>
+                          <m:sSup>
+                            <m:sSupPr>
+                              <m:ctrlPr>
+                                <a:rPr lang="fr-FR" i="1">
+                                  <a:latin typeface="Cambria Math" panose="02040503050406030204" pitchFamily="18" charset="0"/>
+                                </a:rPr>
+                              </m:ctrlPr>
+                            </m:sSupPr>
+                            <m:e>
+                              <m:r>
+                                <a:rPr lang="fr-FR" i="1">
+                                  <a:latin typeface="Cambria Math" panose="02040503050406030204" pitchFamily="18" charset="0"/>
+                                </a:rPr>
+                                <m:t>𝜕</m:t>
+                              </m:r>
+                            </m:e>
+                            <m:sup>
+                              <m:r>
+                                <a:rPr lang="fr-FR" i="1">
+                                  <a:latin typeface="Cambria Math" panose="02040503050406030204" pitchFamily="18" charset="0"/>
+                                </a:rPr>
+                                <m:t>2</m:t>
+                              </m:r>
+                            </m:sup>
+                          </m:sSup>
+                          <m:r>
+                            <a:rPr lang="fr-FR" i="1">
+                              <a:latin typeface="Cambria Math" panose="02040503050406030204" pitchFamily="18" charset="0"/>
+                            </a:rPr>
+                            <m:t>𝑇</m:t>
+                          </m:r>
+                        </m:num>
+                        <m:den>
+                          <m:r>
+                            <a:rPr lang="fr-FR" i="1">
+                              <a:latin typeface="Cambria Math" panose="02040503050406030204" pitchFamily="18" charset="0"/>
+                            </a:rPr>
+                            <m:t>𝜕</m:t>
+                          </m:r>
+                          <m:sSup>
+                            <m:sSupPr>
+                              <m:ctrlPr>
+                                <a:rPr lang="fr-FR" i="1">
+                                  <a:latin typeface="Cambria Math" panose="02040503050406030204" pitchFamily="18" charset="0"/>
+                                </a:rPr>
+                              </m:ctrlPr>
+                            </m:sSupPr>
+                            <m:e>
+                              <m:r>
+                                <a:rPr lang="fr-CA" b="0" i="1" smtClean="0">
+                                  <a:latin typeface="Cambria Math" panose="02040503050406030204" pitchFamily="18" charset="0"/>
+                                </a:rPr>
+                                <m:t>𝑥</m:t>
+                              </m:r>
+                            </m:e>
+                            <m:sup>
+                              <m:r>
+                                <a:rPr lang="fr-FR" i="1">
+                                  <a:latin typeface="Cambria Math" panose="02040503050406030204" pitchFamily="18" charset="0"/>
+                                </a:rPr>
+                                <m:t>2</m:t>
+                              </m:r>
+                            </m:sup>
+                          </m:sSup>
+                        </m:den>
+                      </m:f>
+                      <m:r>
+                        <a:rPr lang="fr-FR" i="1">
+                          <a:latin typeface="Cambria Math" panose="02040503050406030204" pitchFamily="18" charset="0"/>
+                        </a:rPr>
+                        <m:t>+</m:t>
+                      </m:r>
+                      <m:f>
+                        <m:fPr>
+                          <m:ctrlPr>
+                            <a:rPr lang="fr-FR" i="1">
+                              <a:latin typeface="Cambria Math" panose="02040503050406030204" pitchFamily="18" charset="0"/>
+                            </a:rPr>
+                          </m:ctrlPr>
+                        </m:fPr>
+                        <m:num>
+                          <m:sSup>
+                            <m:sSupPr>
+                              <m:ctrlPr>
+                                <a:rPr lang="fr-FR" i="1">
+                                  <a:latin typeface="Cambria Math" panose="02040503050406030204" pitchFamily="18" charset="0"/>
+                                </a:rPr>
+                              </m:ctrlPr>
+                            </m:sSupPr>
+                            <m:e>
+                              <m:r>
+                                <a:rPr lang="fr-FR" i="1">
+                                  <a:latin typeface="Cambria Math" panose="02040503050406030204" pitchFamily="18" charset="0"/>
+                                </a:rPr>
+                                <m:t>𝜕</m:t>
+                              </m:r>
+                            </m:e>
+                            <m:sup>
+                              <m:r>
+                                <a:rPr lang="fr-FR" i="1">
+                                  <a:latin typeface="Cambria Math" panose="02040503050406030204" pitchFamily="18" charset="0"/>
+                                </a:rPr>
+                                <m:t>2</m:t>
+                              </m:r>
+                            </m:sup>
+                          </m:sSup>
+                          <m:r>
+                            <a:rPr lang="fr-FR" i="1">
+                              <a:latin typeface="Cambria Math" panose="02040503050406030204" pitchFamily="18" charset="0"/>
+                            </a:rPr>
+                            <m:t>𝑇</m:t>
+                          </m:r>
+                        </m:num>
+                        <m:den>
+                          <m:r>
+                            <a:rPr lang="fr-FR" i="1">
+                              <a:latin typeface="Cambria Math" panose="02040503050406030204" pitchFamily="18" charset="0"/>
+                            </a:rPr>
+                            <m:t>𝜕</m:t>
+                          </m:r>
+                          <m:sSup>
+                            <m:sSupPr>
+                              <m:ctrlPr>
+                                <a:rPr lang="fr-FR" i="1">
+                                  <a:latin typeface="Cambria Math" panose="02040503050406030204" pitchFamily="18" charset="0"/>
+                                </a:rPr>
+                              </m:ctrlPr>
+                            </m:sSupPr>
+                            <m:e>
+                              <m:r>
+                                <a:rPr lang="fr-CA" b="0" i="1" smtClean="0">
+                                  <a:latin typeface="Cambria Math" panose="02040503050406030204" pitchFamily="18" charset="0"/>
+                                </a:rPr>
+                                <m:t>𝑦</m:t>
+                              </m:r>
+                            </m:e>
+                            <m:sup>
+                              <m:r>
+                                <a:rPr lang="fr-FR" i="1">
+                                  <a:latin typeface="Cambria Math" panose="02040503050406030204" pitchFamily="18" charset="0"/>
+                                </a:rPr>
+                                <m:t>2</m:t>
+                              </m:r>
+                            </m:sup>
+                          </m:sSup>
+                        </m:den>
+                      </m:f>
+                      <m:r>
+                        <a:rPr lang="fr-CA" b="0" i="1" smtClean="0">
+                          <a:latin typeface="Cambria Math" panose="02040503050406030204" pitchFamily="18" charset="0"/>
+                        </a:rPr>
+                        <m:t>)</m:t>
+                      </m:r>
+                    </m:oMath>
+                  </m:oMathPara>
+                </a14:m>
+                <a:endParaRPr lang="fr-FR" b="0" dirty="0"/>
+              </a:p>
+              <a:p>
+                <a:pPr marL="0" indent="0">
+                  <a:spcBef>
+                    <a:spcPts val="1800"/>
+                  </a:spcBef>
+                  <a:buNone/>
+                </a:pPr>
+                <a:r>
+                  <a:rPr lang="fr-FR" dirty="0"/>
+                  <a:t>En cylindrique, on retrouve :</a:t>
+                </a:r>
+              </a:p>
+              <a:p>
+                <a:pPr marL="0" indent="0">
+                  <a:spcBef>
+                    <a:spcPts val="1800"/>
+                  </a:spcBef>
+                  <a:buNone/>
+                </a:pPr>
+                <a14:m>
+                  <m:oMathPara xmlns:m="http://schemas.openxmlformats.org/officeDocument/2006/math">
+                    <m:oMathParaPr>
+                      <m:jc m:val="centerGroup"/>
+                    </m:oMathParaPr>
+                    <m:oMath xmlns:m="http://schemas.openxmlformats.org/officeDocument/2006/math">
+                      <m:r>
+                        <a:rPr lang="fr-CA" b="0" i="1" smtClean="0">
+                          <a:latin typeface="Cambria Math" panose="02040503050406030204" pitchFamily="18" charset="0"/>
+                        </a:rPr>
+                        <m:t>𝑥</m:t>
+                      </m:r>
+                      <m:r>
+                        <a:rPr lang="fr-CA" i="1">
+                          <a:latin typeface="Cambria Math" panose="02040503050406030204" pitchFamily="18" charset="0"/>
+                        </a:rPr>
+                        <m:t>=</m:t>
+                      </m:r>
+                      <m:r>
+                        <m:rPr>
+                          <m:sty m:val="p"/>
+                        </m:rPr>
+                        <a:rPr lang="fr-CA">
+                          <a:latin typeface="Cambria Math" panose="02040503050406030204" pitchFamily="18" charset="0"/>
+                        </a:rPr>
+                        <m:t>r</m:t>
+                      </m:r>
+                      <m:func>
+                        <m:funcPr>
+                          <m:ctrlPr>
+                            <a:rPr lang="fr-CA" i="1">
+                              <a:latin typeface="Cambria Math" panose="02040503050406030204" pitchFamily="18" charset="0"/>
+                            </a:rPr>
+                          </m:ctrlPr>
+                        </m:funcPr>
+                        <m:fName>
+                          <m:r>
+                            <m:rPr>
+                              <m:sty m:val="p"/>
+                            </m:rPr>
+                            <a:rPr lang="fr-CA">
+                              <a:latin typeface="Cambria Math" panose="02040503050406030204" pitchFamily="18" charset="0"/>
+                            </a:rPr>
+                            <m:t>cos</m:t>
+                          </m:r>
+                        </m:fName>
+                        <m:e>
+                          <m:d>
+                            <m:dPr>
+                              <m:ctrlPr>
+                                <a:rPr lang="fr-CA" i="1">
+                                  <a:latin typeface="Cambria Math" panose="02040503050406030204" pitchFamily="18" charset="0"/>
+                                </a:rPr>
+                              </m:ctrlPr>
+                            </m:dPr>
+                            <m:e>
+                              <m:r>
+                                <a:rPr lang="fr-CA" i="1">
+                                  <a:latin typeface="Cambria Math" panose="02040503050406030204" pitchFamily="18" charset="0"/>
+                                </a:rPr>
+                                <m:t>𝜃</m:t>
+                              </m:r>
+                            </m:e>
+                          </m:d>
+                        </m:e>
+                      </m:func>
+                      <m:r>
+                        <a:rPr lang="fr-CA" i="1">
+                          <a:latin typeface="Cambria Math" panose="02040503050406030204" pitchFamily="18" charset="0"/>
+                        </a:rPr>
+                        <m:t>𝑒𝑡</m:t>
+                      </m:r>
+                      <m:r>
+                        <a:rPr lang="fr-CA" i="1">
+                          <a:latin typeface="Cambria Math" panose="02040503050406030204" pitchFamily="18" charset="0"/>
+                        </a:rPr>
+                        <m:t> </m:t>
+                      </m:r>
+                      <m:r>
+                        <a:rPr lang="fr-CA" i="1">
+                          <a:latin typeface="Cambria Math" panose="02040503050406030204" pitchFamily="18" charset="0"/>
+                        </a:rPr>
+                        <m:t>𝑦</m:t>
+                      </m:r>
+                      <m:r>
+                        <a:rPr lang="fr-CA" i="1">
+                          <a:latin typeface="Cambria Math" panose="02040503050406030204" pitchFamily="18" charset="0"/>
+                        </a:rPr>
+                        <m:t>=</m:t>
+                      </m:r>
+                      <m:r>
+                        <a:rPr lang="fr-CA" b="0" i="1" smtClean="0">
+                          <a:latin typeface="Cambria Math" panose="02040503050406030204" pitchFamily="18" charset="0"/>
+                        </a:rPr>
+                        <m:t>𝑧</m:t>
+                      </m:r>
+                      <m:r>
+                        <a:rPr lang="fr-CA" b="0" i="1" smtClean="0">
+                          <a:latin typeface="Cambria Math" panose="02040503050406030204" pitchFamily="18" charset="0"/>
+                        </a:rPr>
+                        <m:t>, </m:t>
+                      </m:r>
+                      <m:r>
+                        <a:rPr lang="fr-CA" b="0" i="1" smtClean="0">
+                          <a:latin typeface="Cambria Math" panose="02040503050406030204" pitchFamily="18" charset="0"/>
+                        </a:rPr>
+                        <m:t>𝜃</m:t>
+                      </m:r>
+                      <m:r>
+                        <a:rPr lang="fr-CA" b="0" i="1" smtClean="0">
+                          <a:latin typeface="Cambria Math" panose="02040503050406030204" pitchFamily="18" charset="0"/>
+                        </a:rPr>
+                        <m:t>=0</m:t>
+                      </m:r>
+                    </m:oMath>
+                  </m:oMathPara>
+                </a14:m>
+                <a:endParaRPr lang="fr-FR" dirty="0"/>
+              </a:p>
+              <a:p>
+                <a:pPr marL="0" indent="0" algn="ctr">
+                  <a:spcBef>
+                    <a:spcPts val="1800"/>
+                  </a:spcBef>
+                  <a:buNone/>
+                </a:pPr>
+                <a14:m>
+                  <m:oMath xmlns:m="http://schemas.openxmlformats.org/officeDocument/2006/math">
+                    <m:sSup>
+                      <m:sSupPr>
+                        <m:ctrlPr>
+                          <a:rPr lang="fr-FR" i="1">
+                            <a:latin typeface="Cambria Math" panose="02040503050406030204" pitchFamily="18" charset="0"/>
+                          </a:rPr>
+                        </m:ctrlPr>
+                      </m:sSupPr>
+                      <m:e>
+                        <m:r>
+                          <m:rPr>
+                            <m:sty m:val="p"/>
+                          </m:rPr>
+                          <a:rPr lang="fr-FR" i="1">
+                            <a:latin typeface="Cambria Math" panose="02040503050406030204" pitchFamily="18" charset="0"/>
+                          </a:rPr>
+                          <m:t>∇</m:t>
+                        </m:r>
+                      </m:e>
+                      <m:sup>
+                        <m:r>
+                          <a:rPr lang="fr-FR" i="1">
+                            <a:latin typeface="Cambria Math" panose="02040503050406030204" pitchFamily="18" charset="0"/>
+                          </a:rPr>
+                          <m:t>2</m:t>
+                        </m:r>
+                      </m:sup>
+                    </m:sSup>
+                    <m:r>
+                      <a:rPr lang="fr-FR" i="1">
+                        <a:latin typeface="Cambria Math" panose="02040503050406030204" pitchFamily="18" charset="0"/>
+                      </a:rPr>
+                      <m:t>𝑇</m:t>
+                    </m:r>
+                  </m:oMath>
+                </a14:m>
+                <a:r>
+                  <a:rPr lang="fr-FR" dirty="0"/>
+                  <a:t> = </a:t>
+                </a:r>
+                <a14:m>
+                  <m:oMath xmlns:m="http://schemas.openxmlformats.org/officeDocument/2006/math">
+                    <m:f>
+                      <m:fPr>
+                        <m:ctrlPr>
+                          <a:rPr lang="fr-FR" i="1">
+                            <a:latin typeface="Cambria Math" panose="02040503050406030204" pitchFamily="18" charset="0"/>
+                          </a:rPr>
+                        </m:ctrlPr>
+                      </m:fPr>
+                      <m:num>
+                        <m:sSup>
+                          <m:sSupPr>
+                            <m:ctrlPr>
+                              <a:rPr lang="fr-FR" i="1">
+                                <a:latin typeface="Cambria Math" panose="02040503050406030204" pitchFamily="18" charset="0"/>
+                              </a:rPr>
+                            </m:ctrlPr>
+                          </m:sSupPr>
+                          <m:e>
+                            <m:r>
+                              <a:rPr lang="fr-FR" i="1">
+                                <a:latin typeface="Cambria Math" panose="02040503050406030204" pitchFamily="18" charset="0"/>
+                              </a:rPr>
+                              <m:t>𝜕</m:t>
+                            </m:r>
+                          </m:e>
+                          <m:sup>
+                            <m:r>
+                              <a:rPr lang="fr-FR" i="1">
+                                <a:latin typeface="Cambria Math" panose="02040503050406030204" pitchFamily="18" charset="0"/>
+                              </a:rPr>
+                              <m:t>2</m:t>
+                            </m:r>
+                          </m:sup>
+                        </m:sSup>
+                        <m:r>
+                          <a:rPr lang="fr-FR" i="1">
+                            <a:latin typeface="Cambria Math" panose="02040503050406030204" pitchFamily="18" charset="0"/>
+                          </a:rPr>
+                          <m:t>𝑇</m:t>
+                        </m:r>
+                      </m:num>
+                      <m:den>
+                        <m:r>
+                          <a:rPr lang="fr-FR" i="1">
+                            <a:latin typeface="Cambria Math" panose="02040503050406030204" pitchFamily="18" charset="0"/>
+                          </a:rPr>
+                          <m:t>𝜕</m:t>
+                        </m:r>
+                        <m:sSup>
+                          <m:sSupPr>
+                            <m:ctrlPr>
+                              <a:rPr lang="fr-FR" i="1">
+                                <a:latin typeface="Cambria Math" panose="02040503050406030204" pitchFamily="18" charset="0"/>
+                              </a:rPr>
+                            </m:ctrlPr>
+                          </m:sSupPr>
+                          <m:e>
+                            <m:r>
+                              <a:rPr lang="fr-CA" i="1">
+                                <a:latin typeface="Cambria Math" panose="02040503050406030204" pitchFamily="18" charset="0"/>
+                              </a:rPr>
+                              <m:t>𝑟</m:t>
+                            </m:r>
+                          </m:e>
+                          <m:sup>
+                            <m:r>
+                              <a:rPr lang="fr-FR" i="1">
+                                <a:latin typeface="Cambria Math" panose="02040503050406030204" pitchFamily="18" charset="0"/>
+                              </a:rPr>
+                              <m:t>2</m:t>
+                            </m:r>
+                          </m:sup>
+                        </m:sSup>
+                      </m:den>
+                    </m:f>
+                    <m:r>
+                      <a:rPr lang="fr-FR" i="1">
+                        <a:latin typeface="Cambria Math" panose="02040503050406030204" pitchFamily="18" charset="0"/>
+                      </a:rPr>
+                      <m:t>+</m:t>
+                    </m:r>
+                    <m:f>
+                      <m:fPr>
+                        <m:ctrlPr>
+                          <a:rPr lang="fr-FR" i="1">
+                            <a:latin typeface="Cambria Math" panose="02040503050406030204" pitchFamily="18" charset="0"/>
+                          </a:rPr>
+                        </m:ctrlPr>
+                      </m:fPr>
+                      <m:num>
+                        <m:r>
+                          <a:rPr lang="fr-FR" i="1">
+                            <a:latin typeface="Cambria Math" panose="02040503050406030204" pitchFamily="18" charset="0"/>
+                          </a:rPr>
+                          <m:t>1</m:t>
+                        </m:r>
+                      </m:num>
+                      <m:den>
+                        <m:r>
+                          <a:rPr lang="fr-CA" b="0" i="1" smtClean="0">
+                            <a:latin typeface="Cambria Math" panose="02040503050406030204" pitchFamily="18" charset="0"/>
+                          </a:rPr>
+                          <m:t>𝑟</m:t>
+                        </m:r>
+                      </m:den>
+                    </m:f>
+                    <m:f>
+                      <m:fPr>
+                        <m:ctrlPr>
+                          <a:rPr lang="fr-FR" i="1">
+                            <a:latin typeface="Cambria Math" panose="02040503050406030204" pitchFamily="18" charset="0"/>
+                          </a:rPr>
+                        </m:ctrlPr>
+                      </m:fPr>
+                      <m:num>
+                        <m:r>
+                          <a:rPr lang="fr-FR" i="1">
+                            <a:latin typeface="Cambria Math" panose="02040503050406030204" pitchFamily="18" charset="0"/>
+                          </a:rPr>
+                          <m:t>𝜕</m:t>
+                        </m:r>
+                        <m:r>
+                          <a:rPr lang="fr-FR" i="1">
+                            <a:latin typeface="Cambria Math" panose="02040503050406030204" pitchFamily="18" charset="0"/>
+                          </a:rPr>
+                          <m:t>𝑇</m:t>
+                        </m:r>
+                      </m:num>
+                      <m:den>
+                        <m:r>
+                          <a:rPr lang="fr-FR" i="1">
+                            <a:latin typeface="Cambria Math" panose="02040503050406030204" pitchFamily="18" charset="0"/>
+                          </a:rPr>
+                          <m:t>𝜕</m:t>
+                        </m:r>
+                        <m:r>
+                          <a:rPr lang="fr-CA" i="1">
+                            <a:latin typeface="Cambria Math" panose="02040503050406030204" pitchFamily="18" charset="0"/>
+                          </a:rPr>
+                          <m:t>𝑟</m:t>
+                        </m:r>
+                      </m:den>
+                    </m:f>
+                    <m:r>
+                      <a:rPr lang="fr-FR" i="1">
+                        <a:latin typeface="Cambria Math" panose="02040503050406030204" pitchFamily="18" charset="0"/>
+                      </a:rPr>
+                      <m:t>+</m:t>
+                    </m:r>
+                    <m:f>
+                      <m:fPr>
+                        <m:ctrlPr>
+                          <a:rPr lang="fr-FR" i="1">
+                            <a:latin typeface="Cambria Math" panose="02040503050406030204" pitchFamily="18" charset="0"/>
+                          </a:rPr>
+                        </m:ctrlPr>
+                      </m:fPr>
+                      <m:num>
+                        <m:sSup>
+                          <m:sSupPr>
+                            <m:ctrlPr>
+                              <a:rPr lang="fr-FR" i="1">
+                                <a:latin typeface="Cambria Math" panose="02040503050406030204" pitchFamily="18" charset="0"/>
+                              </a:rPr>
+                            </m:ctrlPr>
+                          </m:sSupPr>
+                          <m:e>
+                            <m:r>
+                              <a:rPr lang="fr-FR" i="1">
+                                <a:latin typeface="Cambria Math" panose="02040503050406030204" pitchFamily="18" charset="0"/>
+                              </a:rPr>
+                              <m:t>𝜕</m:t>
+                            </m:r>
+                          </m:e>
+                          <m:sup>
+                            <m:r>
+                              <a:rPr lang="fr-FR" i="1">
+                                <a:latin typeface="Cambria Math" panose="02040503050406030204" pitchFamily="18" charset="0"/>
+                              </a:rPr>
+                              <m:t>2</m:t>
+                            </m:r>
+                          </m:sup>
+                        </m:sSup>
+                        <m:r>
+                          <a:rPr lang="fr-FR" i="1">
+                            <a:latin typeface="Cambria Math" panose="02040503050406030204" pitchFamily="18" charset="0"/>
+                          </a:rPr>
+                          <m:t>𝑇</m:t>
+                        </m:r>
+                      </m:num>
+                      <m:den>
+                        <m:r>
+                          <a:rPr lang="fr-FR" i="1">
+                            <a:latin typeface="Cambria Math" panose="02040503050406030204" pitchFamily="18" charset="0"/>
+                          </a:rPr>
+                          <m:t>𝜕</m:t>
+                        </m:r>
+                        <m:sSup>
+                          <m:sSupPr>
+                            <m:ctrlPr>
+                              <a:rPr lang="fr-FR" i="1">
+                                <a:latin typeface="Cambria Math" panose="02040503050406030204" pitchFamily="18" charset="0"/>
+                              </a:rPr>
+                            </m:ctrlPr>
+                          </m:sSupPr>
+                          <m:e>
+                            <m:r>
+                              <a:rPr lang="fr-FR" i="1">
+                                <a:latin typeface="Cambria Math" panose="02040503050406030204" pitchFamily="18" charset="0"/>
+                              </a:rPr>
+                              <m:t>𝑧</m:t>
+                            </m:r>
+                          </m:e>
+                          <m:sup>
+                            <m:r>
+                              <a:rPr lang="fr-FR" i="1">
+                                <a:latin typeface="Cambria Math" panose="02040503050406030204" pitchFamily="18" charset="0"/>
+                              </a:rPr>
+                              <m:t>2</m:t>
+                            </m:r>
+                          </m:sup>
+                        </m:sSup>
+                      </m:den>
+                    </m:f>
+                  </m:oMath>
+                </a14:m>
+                <a:endParaRPr lang="fr-FR" dirty="0"/>
+              </a:p>
+              <a:p>
+                <a:pPr marL="0" indent="0" algn="ctr">
+                  <a:spcBef>
+                    <a:spcPts val="1800"/>
+                  </a:spcBef>
+                  <a:buNone/>
+                </a:pPr>
+                <a:endParaRPr lang="fr-FR" dirty="0"/>
+              </a:p>
+              <a:p>
+                <a:pPr marL="0" indent="0">
+                  <a:spcBef>
+                    <a:spcPts val="1800"/>
+                  </a:spcBef>
+                  <a:buNone/>
+                </a:pPr>
+                <a14:m>
+                  <m:oMathPara xmlns:m="http://schemas.openxmlformats.org/officeDocument/2006/math">
+                    <m:oMathParaPr>
+                      <m:jc m:val="centerGroup"/>
+                    </m:oMathParaPr>
+                    <m:oMath xmlns:m="http://schemas.openxmlformats.org/officeDocument/2006/math">
+                      <m:r>
+                        <m:rPr>
+                          <m:sty m:val="p"/>
+                        </m:rPr>
+                        <a:rPr lang="el-GR" i="1">
+                          <a:latin typeface="Cambria Math" panose="02040503050406030204" pitchFamily="18" charset="0"/>
+                        </a:rPr>
+                        <m:t>ρ</m:t>
+                      </m:r>
+                      <m:sSub>
+                        <m:sSubPr>
+                          <m:ctrlPr>
+                            <a:rPr lang="fr-FR" i="1">
+                              <a:latin typeface="Cambria Math" panose="02040503050406030204" pitchFamily="18" charset="0"/>
+                            </a:rPr>
+                          </m:ctrlPr>
+                        </m:sSubPr>
+                        <m:e>
+                          <m:r>
+                            <a:rPr lang="fr-FR" i="1">
+                              <a:latin typeface="Cambria Math" panose="02040503050406030204" pitchFamily="18" charset="0"/>
+                            </a:rPr>
+                            <m:t>𝐶</m:t>
+                          </m:r>
+                        </m:e>
+                        <m:sub>
+                          <m:r>
+                            <a:rPr lang="fr-FR" i="1">
+                              <a:latin typeface="Cambria Math" panose="02040503050406030204" pitchFamily="18" charset="0"/>
+                            </a:rPr>
+                            <m:t>𝑝</m:t>
+                          </m:r>
+                        </m:sub>
+                      </m:sSub>
+                      <m:r>
+                        <a:rPr lang="fr-FR" i="1">
+                          <a:latin typeface="Cambria Math" panose="02040503050406030204" pitchFamily="18" charset="0"/>
+                        </a:rPr>
+                        <m:t> </m:t>
+                      </m:r>
+                      <m:f>
+                        <m:fPr>
+                          <m:ctrlPr>
+                            <a:rPr lang="fr-FR" i="1">
+                              <a:latin typeface="Cambria Math" panose="02040503050406030204" pitchFamily="18" charset="0"/>
+                            </a:rPr>
+                          </m:ctrlPr>
+                        </m:fPr>
+                        <m:num>
+                          <m:r>
+                            <a:rPr lang="fr-FR" i="1">
+                              <a:latin typeface="Cambria Math" panose="02040503050406030204" pitchFamily="18" charset="0"/>
+                            </a:rPr>
+                            <m:t>𝜕</m:t>
+                          </m:r>
+                          <m:r>
+                            <a:rPr lang="fr-FR" i="1">
+                              <a:latin typeface="Cambria Math" panose="02040503050406030204" pitchFamily="18" charset="0"/>
+                            </a:rPr>
+                            <m:t>𝑇</m:t>
+                          </m:r>
+                        </m:num>
+                        <m:den>
+                          <m:r>
+                            <a:rPr lang="fr-FR" i="1">
+                              <a:latin typeface="Cambria Math" panose="02040503050406030204" pitchFamily="18" charset="0"/>
+                            </a:rPr>
+                            <m:t>𝜕</m:t>
+                          </m:r>
+                          <m:r>
+                            <a:rPr lang="fr-FR" i="1">
+                              <a:latin typeface="Cambria Math" panose="02040503050406030204" pitchFamily="18" charset="0"/>
+                            </a:rPr>
+                            <m:t>𝑡</m:t>
+                          </m:r>
+                        </m:den>
+                      </m:f>
+                      <m:r>
+                        <a:rPr lang="fr-FR" i="1">
+                          <a:latin typeface="Cambria Math" panose="02040503050406030204" pitchFamily="18" charset="0"/>
+                        </a:rPr>
+                        <m:t> </m:t>
+                      </m:r>
+                      <m:r>
+                        <a:rPr lang="fr-CA" b="0" i="1" smtClean="0">
+                          <a:latin typeface="Cambria Math" panose="02040503050406030204" pitchFamily="18" charset="0"/>
+                        </a:rPr>
+                        <m:t>=</m:t>
+                      </m:r>
+                      <m:r>
+                        <a:rPr lang="fr-CA" b="0" i="1" smtClean="0">
+                          <a:latin typeface="Cambria Math" panose="02040503050406030204" pitchFamily="18" charset="0"/>
+                        </a:rPr>
+                        <m:t>𝑘</m:t>
+                      </m:r>
+                      <m:r>
+                        <a:rPr lang="fr-CA" b="0" i="1" smtClean="0">
+                          <a:latin typeface="Cambria Math" panose="02040503050406030204" pitchFamily="18" charset="0"/>
+                        </a:rPr>
+                        <m:t>(</m:t>
+                      </m:r>
+                      <m:f>
+                        <m:fPr>
+                          <m:ctrlPr>
+                            <a:rPr lang="fr-FR" i="1">
+                              <a:latin typeface="Cambria Math" panose="02040503050406030204" pitchFamily="18" charset="0"/>
+                            </a:rPr>
+                          </m:ctrlPr>
+                        </m:fPr>
+                        <m:num>
+                          <m:sSup>
+                            <m:sSupPr>
+                              <m:ctrlPr>
+                                <a:rPr lang="fr-FR" i="1">
+                                  <a:latin typeface="Cambria Math" panose="02040503050406030204" pitchFamily="18" charset="0"/>
+                                </a:rPr>
+                              </m:ctrlPr>
+                            </m:sSupPr>
+                            <m:e>
+                              <m:r>
+                                <a:rPr lang="fr-FR" i="1">
+                                  <a:latin typeface="Cambria Math" panose="02040503050406030204" pitchFamily="18" charset="0"/>
+                                </a:rPr>
+                                <m:t>𝜕</m:t>
+                              </m:r>
+                            </m:e>
+                            <m:sup>
+                              <m:r>
+                                <a:rPr lang="fr-FR" i="1">
+                                  <a:latin typeface="Cambria Math" panose="02040503050406030204" pitchFamily="18" charset="0"/>
+                                </a:rPr>
+                                <m:t>2</m:t>
+                              </m:r>
+                            </m:sup>
+                          </m:sSup>
+                          <m:r>
+                            <a:rPr lang="fr-FR" i="1">
+                              <a:latin typeface="Cambria Math" panose="02040503050406030204" pitchFamily="18" charset="0"/>
+                            </a:rPr>
+                            <m:t>𝑇</m:t>
+                          </m:r>
+                        </m:num>
+                        <m:den>
+                          <m:r>
+                            <a:rPr lang="fr-FR" i="1">
+                              <a:latin typeface="Cambria Math" panose="02040503050406030204" pitchFamily="18" charset="0"/>
+                            </a:rPr>
+                            <m:t>𝜕</m:t>
+                          </m:r>
+                          <m:sSup>
+                            <m:sSupPr>
+                              <m:ctrlPr>
+                                <a:rPr lang="fr-FR" i="1">
+                                  <a:latin typeface="Cambria Math" panose="02040503050406030204" pitchFamily="18" charset="0"/>
+                                </a:rPr>
+                              </m:ctrlPr>
+                            </m:sSupPr>
+                            <m:e>
+                              <m:r>
+                                <a:rPr lang="fr-CA" i="1">
+                                  <a:latin typeface="Cambria Math" panose="02040503050406030204" pitchFamily="18" charset="0"/>
+                                </a:rPr>
+                                <m:t>𝑟</m:t>
+                              </m:r>
+                            </m:e>
+                            <m:sup>
+                              <m:r>
+                                <a:rPr lang="fr-FR" i="1">
+                                  <a:latin typeface="Cambria Math" panose="02040503050406030204" pitchFamily="18" charset="0"/>
+                                </a:rPr>
+                                <m:t>2</m:t>
+                              </m:r>
+                            </m:sup>
+                          </m:sSup>
+                        </m:den>
+                      </m:f>
+                      <m:r>
+                        <a:rPr lang="fr-FR" i="1">
+                          <a:latin typeface="Cambria Math" panose="02040503050406030204" pitchFamily="18" charset="0"/>
+                        </a:rPr>
+                        <m:t>+</m:t>
+                      </m:r>
+                      <m:f>
+                        <m:fPr>
+                          <m:ctrlPr>
+                            <a:rPr lang="fr-FR" i="1">
+                              <a:latin typeface="Cambria Math" panose="02040503050406030204" pitchFamily="18" charset="0"/>
+                            </a:rPr>
+                          </m:ctrlPr>
+                        </m:fPr>
+                        <m:num>
+                          <m:r>
+                            <a:rPr lang="fr-FR" i="1">
+                              <a:latin typeface="Cambria Math" panose="02040503050406030204" pitchFamily="18" charset="0"/>
+                            </a:rPr>
+                            <m:t>1</m:t>
+                          </m:r>
+                        </m:num>
+                        <m:den>
+                          <m:r>
+                            <a:rPr lang="fr-CA" b="0" i="1" smtClean="0">
+                              <a:latin typeface="Cambria Math" panose="02040503050406030204" pitchFamily="18" charset="0"/>
+                            </a:rPr>
+                            <m:t>𝑟</m:t>
+                          </m:r>
+                        </m:den>
+                      </m:f>
+                      <m:f>
+                        <m:fPr>
+                          <m:ctrlPr>
+                            <a:rPr lang="fr-FR" i="1">
+                              <a:latin typeface="Cambria Math" panose="02040503050406030204" pitchFamily="18" charset="0"/>
+                            </a:rPr>
+                          </m:ctrlPr>
+                        </m:fPr>
+                        <m:num>
+                          <m:r>
+                            <a:rPr lang="fr-FR" i="1">
+                              <a:latin typeface="Cambria Math" panose="02040503050406030204" pitchFamily="18" charset="0"/>
+                            </a:rPr>
+                            <m:t>𝜕</m:t>
+                          </m:r>
+                          <m:r>
+                            <a:rPr lang="fr-FR" i="1">
+                              <a:latin typeface="Cambria Math" panose="02040503050406030204" pitchFamily="18" charset="0"/>
+                            </a:rPr>
+                            <m:t>𝑇</m:t>
+                          </m:r>
+                        </m:num>
+                        <m:den>
+                          <m:r>
+                            <a:rPr lang="fr-FR" i="1">
+                              <a:latin typeface="Cambria Math" panose="02040503050406030204" pitchFamily="18" charset="0"/>
+                            </a:rPr>
+                            <m:t>𝜕</m:t>
+                          </m:r>
+                          <m:r>
+                            <a:rPr lang="fr-CA" i="1">
+                              <a:latin typeface="Cambria Math" panose="02040503050406030204" pitchFamily="18" charset="0"/>
+                            </a:rPr>
+                            <m:t>𝑟</m:t>
+                          </m:r>
+                        </m:den>
+                      </m:f>
+                      <m:r>
+                        <a:rPr lang="fr-FR" i="1">
+                          <a:latin typeface="Cambria Math" panose="02040503050406030204" pitchFamily="18" charset="0"/>
+                        </a:rPr>
+                        <m:t>+</m:t>
+                      </m:r>
+                      <m:f>
+                        <m:fPr>
+                          <m:ctrlPr>
+                            <a:rPr lang="fr-FR" i="1">
+                              <a:latin typeface="Cambria Math" panose="02040503050406030204" pitchFamily="18" charset="0"/>
+                            </a:rPr>
+                          </m:ctrlPr>
+                        </m:fPr>
+                        <m:num>
+                          <m:sSup>
+                            <m:sSupPr>
+                              <m:ctrlPr>
+                                <a:rPr lang="fr-FR" i="1">
+                                  <a:latin typeface="Cambria Math" panose="02040503050406030204" pitchFamily="18" charset="0"/>
+                                </a:rPr>
+                              </m:ctrlPr>
+                            </m:sSupPr>
+                            <m:e>
+                              <m:r>
+                                <a:rPr lang="fr-FR" i="1">
+                                  <a:latin typeface="Cambria Math" panose="02040503050406030204" pitchFamily="18" charset="0"/>
+                                </a:rPr>
+                                <m:t>𝜕</m:t>
+                              </m:r>
+                            </m:e>
+                            <m:sup>
+                              <m:r>
+                                <a:rPr lang="fr-FR" i="1">
+                                  <a:latin typeface="Cambria Math" panose="02040503050406030204" pitchFamily="18" charset="0"/>
+                                </a:rPr>
+                                <m:t>2</m:t>
+                              </m:r>
+                            </m:sup>
+                          </m:sSup>
+                          <m:r>
+                            <a:rPr lang="fr-FR" i="1">
+                              <a:latin typeface="Cambria Math" panose="02040503050406030204" pitchFamily="18" charset="0"/>
+                            </a:rPr>
+                            <m:t>𝑇</m:t>
+                          </m:r>
+                        </m:num>
+                        <m:den>
+                          <m:r>
+                            <a:rPr lang="fr-FR" i="1">
+                              <a:latin typeface="Cambria Math" panose="02040503050406030204" pitchFamily="18" charset="0"/>
+                            </a:rPr>
+                            <m:t>𝜕</m:t>
+                          </m:r>
+                          <m:sSup>
+                            <m:sSupPr>
+                              <m:ctrlPr>
+                                <a:rPr lang="fr-FR" i="1">
+                                  <a:latin typeface="Cambria Math" panose="02040503050406030204" pitchFamily="18" charset="0"/>
+                                </a:rPr>
+                              </m:ctrlPr>
+                            </m:sSupPr>
+                            <m:e>
+                              <m:r>
+                                <a:rPr lang="fr-FR" i="1">
+                                  <a:latin typeface="Cambria Math" panose="02040503050406030204" pitchFamily="18" charset="0"/>
+                                </a:rPr>
+                                <m:t>𝑧</m:t>
+                              </m:r>
+                            </m:e>
+                            <m:sup>
+                              <m:r>
+                                <a:rPr lang="fr-FR" i="1">
+                                  <a:latin typeface="Cambria Math" panose="02040503050406030204" pitchFamily="18" charset="0"/>
+                                </a:rPr>
+                                <m:t>2</m:t>
+                              </m:r>
+                            </m:sup>
+                          </m:sSup>
+                        </m:den>
+                      </m:f>
+                      <m:r>
+                        <a:rPr lang="fr-CA" b="0" i="1" smtClean="0">
+                          <a:latin typeface="Cambria Math" panose="02040503050406030204" pitchFamily="18" charset="0"/>
+                        </a:rPr>
+                        <m:t>)</m:t>
+                      </m:r>
+                    </m:oMath>
+                  </m:oMathPara>
+                </a14:m>
+                <a:endParaRPr lang="fr-FR" i="1" dirty="0">
+                  <a:latin typeface="Cambria Math" panose="02040503050406030204" pitchFamily="18" charset="0"/>
+                </a:endParaRPr>
+              </a:p>
+              <a:p>
+                <a:pPr marL="0" indent="0">
+                  <a:spcBef>
+                    <a:spcPts val="1800"/>
+                  </a:spcBef>
+                  <a:buNone/>
+                </a:pPr>
+                <a:endParaRPr lang="fr-FR" b="0" dirty="0"/>
+              </a:p>
+              <a:p>
+                <a:pPr marL="0" indent="0" algn="ctr">
+                  <a:buNone/>
+                </a:pPr>
+                <a:endParaRPr lang="fr-FR" b="0" dirty="0"/>
+              </a:p>
+              <a:p>
+                <a:pPr marL="0" indent="0" algn="ctr">
+                  <a:buNone/>
+                </a:pPr>
+                <a:endParaRPr lang="fr-FR" b="0" dirty="0"/>
+              </a:p>
+              <a:p>
+                <a:pPr marL="0" indent="0" algn="ctr">
+                  <a:buNone/>
+                </a:pPr>
+                <a:endParaRPr lang="fr-FR" b="0" dirty="0"/>
+              </a:p>
+              <a:p>
+                <a:pPr marL="0" indent="0" algn="ctr">
+                  <a:buNone/>
+                </a:pPr>
+                <a:endParaRPr lang="fr-FR" b="0" dirty="0"/>
+              </a:p>
+              <a:p>
+                <a:pPr marL="0" indent="0" algn="ctr">
+                  <a:buNone/>
+                </a:pPr>
+                <a:endParaRPr lang="fr-FR" b="0" dirty="0"/>
+              </a:p>
+              <a:p>
+                <a:pPr marL="0" indent="0">
+                  <a:buNone/>
+                </a:pPr>
+                <a:endParaRPr lang="fr-FR" b="0" dirty="0"/>
+              </a:p>
+              <a:p>
+                <a:pPr marL="0" indent="0">
+                  <a:buNone/>
+                </a:pPr>
+                <a:endParaRPr lang="fr-FR" b="0" dirty="0"/>
+              </a:p>
+              <a:p>
+                <a:pPr marL="0" indent="0">
+                  <a:buNone/>
+                </a:pPr>
+                <a:endParaRPr lang="fr-FR" b="0" dirty="0"/>
+              </a:p>
+              <a:p>
+                <a:pPr marL="0" indent="0">
+                  <a:buNone/>
+                </a:pPr>
+                <a:endParaRPr lang="fr-FR" b="0" dirty="0"/>
+              </a:p>
+              <a:p>
+                <a:pPr marL="0" indent="0">
+                  <a:buNone/>
+                </a:pPr>
+                <a:endParaRPr lang="fr-FR" b="0" dirty="0"/>
+              </a:p>
+              <a:p>
+                <a:pPr marL="0" indent="0">
+                  <a:buNone/>
+                </a:pPr>
+                <a:endParaRPr lang="fr-FR" dirty="0"/>
+              </a:p>
+            </p:txBody>
+          </p:sp>
+        </mc:Choice>
+        <mc:Fallback>
+          <p:sp>
+            <p:nvSpPr>
+              <p:cNvPr id="3" name="Espace réservé du contenu 2">
+                <a:extLst>
+                  <a:ext uri="{FF2B5EF4-FFF2-40B4-BE49-F238E27FC236}">
+                    <a16:creationId xmlns:a16="http://schemas.microsoft.com/office/drawing/2014/main" id="{8073797C-3545-B398-B72A-5A621002005D}"/>
+                  </a:ext>
+                </a:extLst>
+              </p:cNvPr>
+              <p:cNvSpPr>
+                <a:spLocks noGrp="1" noRot="1" noChangeAspect="1" noMove="1" noResize="1" noEditPoints="1" noAdjustHandles="1" noChangeArrowheads="1" noChangeShapeType="1" noTextEdit="1"/>
+              </p:cNvSpPr>
+              <p:nvPr>
+                <p:ph idx="1"/>
+              </p:nvPr>
+            </p:nvSpPr>
+            <p:spPr>
+              <a:xfrm>
+                <a:off x="838200" y="1155033"/>
+                <a:ext cx="8177463" cy="5358062"/>
+              </a:xfrm>
+              <a:blipFill>
+                <a:blip r:embed="rId2"/>
+                <a:stretch>
+                  <a:fillRect l="-1342" t="-2275"/>
+                </a:stretch>
+              </a:blipFill>
+            </p:spPr>
+            <p:txBody>
+              <a:bodyPr/>
+              <a:lstStyle/>
+              <a:p>
+                <a:r>
+                  <a:rPr lang="fr-CA">
+                    <a:noFill/>
+                  </a:rPr>
+                  <a:t> </a:t>
+                </a:r>
+              </a:p>
+            </p:txBody>
+          </p:sp>
+        </mc:Fallback>
+      </mc:AlternateContent>
+      <p:sp>
+        <p:nvSpPr>
+          <p:cNvPr id="4" name="Rectangle 3">
+            <a:extLst>
+              <a:ext uri="{FF2B5EF4-FFF2-40B4-BE49-F238E27FC236}">
+                <a16:creationId xmlns:a16="http://schemas.microsoft.com/office/drawing/2014/main" id="{D8880BBA-A9C5-15DA-64A8-34FD76C6B27D}"/>
+              </a:ext>
+            </a:extLst>
+          </p:cNvPr>
+          <p:cNvSpPr/>
+          <p:nvPr/>
+        </p:nvSpPr>
+        <p:spPr>
+          <a:xfrm>
+            <a:off x="2606040" y="5321808"/>
+            <a:ext cx="4828032" cy="1325563"/>
+          </a:xfrm>
+          <a:prstGeom prst="rect">
+            <a:avLst/>
+          </a:prstGeom>
+          <a:noFill/>
+          <a:ln>
+            <a:solidFill>
+              <a:schemeClr val="accent6">
+                <a:lumMod val="60000"/>
+                <a:lumOff val="40000"/>
+              </a:schemeClr>
+            </a:solidFill>
+          </a:ln>
+        </p:spPr>
+        <p:style>
+          <a:lnRef idx="2">
+            <a:schemeClr val="accent6">
+              <a:shade val="15000"/>
+            </a:schemeClr>
+          </a:lnRef>
+          <a:fillRef idx="1">
+            <a:schemeClr val="accent6"/>
+          </a:fillRef>
+          <a:effectRef idx="0">
+            <a:schemeClr val="accent6"/>
+          </a:effectRef>
+          <a:fontRef idx="minor">
+            <a:schemeClr val="lt1"/>
+          </a:fontRef>
+        </p:style>
+        <p:txBody>
+          <a:bodyPr rtlCol="0" anchor="ctr"/>
+          <a:lstStyle/>
+          <a:p>
+            <a:pPr algn="ctr"/>
+            <a:endParaRPr lang="fr-CA"/>
+          </a:p>
+        </p:txBody>
+      </p:sp>
+    </p:spTree>
+    <p:extLst>
+      <p:ext uri="{BB962C8B-B14F-4D97-AF65-F5344CB8AC3E}">
+        <p14:creationId xmlns:p14="http://schemas.microsoft.com/office/powerpoint/2010/main" val="980743001"/>
+      </p:ext>
+    </p:extLst>
+  </p:cSld>
+  <p:clrMapOvr>
+    <a:masterClrMapping/>
+  </p:clrMapOvr>
+</p:sld>
+</file>
+
+<file path=ppt/slides/slide5.xml><?xml version="1.0" encoding="utf-8"?>
+<p:sld xmlns:a="http://schemas.openxmlformats.org/drawingml/2006/main" xmlns:r="http://schemas.openxmlformats.org/officeDocument/2006/relationships" xmlns:p="http://schemas.openxmlformats.org/presentationml/2006/main">
+  <p:cSld>
+    <p:spTree>
+      <p:nvGrpSpPr>
         <p:cNvPr id="1" name=""/>
         <p:cNvGrpSpPr/>
         <p:nvPr/>
@@ -5736,7 +7224,21 @@
                     </m:f>
                   </m:oMath>
                 </a14:m>
-                <a:endParaRPr lang="fr-FR" dirty="0"/>
+                <a:r>
+                  <a:rPr lang="fr-FR" dirty="0"/>
+                  <a:t> , </a:t>
+                </a:r>
+                <a:r>
+                  <a:rPr lang="fr-FR" sz="2400" dirty="0">
+                    <a:latin typeface="Cambria" panose="02040503050406030204" pitchFamily="18" charset="0"/>
+                    <a:ea typeface="Cambria" panose="02040503050406030204" pitchFamily="18" charset="0"/>
+                  </a:rPr>
+                  <a:t>ordre 1 </a:t>
+                </a:r>
+                <a:endParaRPr lang="fr-FR" dirty="0">
+                  <a:latin typeface="Cambria" panose="02040503050406030204" pitchFamily="18" charset="0"/>
+                  <a:ea typeface="Cambria" panose="02040503050406030204" pitchFamily="18" charset="0"/>
+                </a:endParaRPr>
               </a:p>
               <a:p>
                 <a14:m>
@@ -5969,9 +7471,17 @@
                     </m:f>
                   </m:oMath>
                 </a14:m>
-                <a:endParaRPr lang="fr-FR" dirty="0"/>
-              </a:p>
-              <a:p>
+                <a:r>
+                  <a:rPr lang="fr-FR" dirty="0"/>
+                  <a:t>, </a:t>
+                </a:r>
+                <a:r>
+                  <a:rPr lang="fr-FR" sz="2400" dirty="0">
+                    <a:latin typeface="Cambria" panose="02040503050406030204" pitchFamily="18" charset="0"/>
+                    <a:ea typeface="Cambria" panose="02040503050406030204" pitchFamily="18" charset="0"/>
+                  </a:rPr>
+                  <a:t>ordre 2</a:t>
+                </a:r>
                 <a:endParaRPr lang="fr-FR" dirty="0"/>
               </a:p>
               <a:p>
@@ -5979,6 +7489,9 @@
               </a:p>
               <a:p>
                 <a:pPr marL="0" indent="0">
+                  <a:spcBef>
+                    <a:spcPts val="1800"/>
+                  </a:spcBef>
                   <a:buNone/>
                 </a:pPr>
                 <a14:m>
@@ -5987,6 +7500,107 @@
                       <m:jc m:val="centerGroup"/>
                     </m:oMathParaPr>
                     <m:oMath xmlns:m="http://schemas.openxmlformats.org/officeDocument/2006/math">
+                      <m:r>
+                        <m:rPr>
+                          <m:sty m:val="p"/>
+                        </m:rPr>
+                        <a:rPr lang="el-GR" sz="2400" i="1">
+                          <a:latin typeface="Cambria Math" panose="02040503050406030204" pitchFamily="18" charset="0"/>
+                        </a:rPr>
+                        <m:t>ρ</m:t>
+                      </m:r>
+                      <m:sSub>
+                        <m:sSubPr>
+                          <m:ctrlPr>
+                            <a:rPr lang="fr-FR" sz="2400" i="1">
+                              <a:latin typeface="Cambria Math" panose="02040503050406030204" pitchFamily="18" charset="0"/>
+                            </a:rPr>
+                          </m:ctrlPr>
+                        </m:sSubPr>
+                        <m:e>
+                          <m:r>
+                            <a:rPr lang="fr-FR" sz="2400" i="1">
+                              <a:latin typeface="Cambria Math" panose="02040503050406030204" pitchFamily="18" charset="0"/>
+                            </a:rPr>
+                            <m:t>𝐶</m:t>
+                          </m:r>
+                        </m:e>
+                        <m:sub>
+                          <m:r>
+                            <a:rPr lang="fr-FR" sz="2400" i="1">
+                              <a:latin typeface="Cambria Math" panose="02040503050406030204" pitchFamily="18" charset="0"/>
+                            </a:rPr>
+                            <m:t>𝑝</m:t>
+                          </m:r>
+                        </m:sub>
+                      </m:sSub>
+                      <m:r>
+                        <a:rPr lang="fr-FR" sz="2400" i="1">
+                          <a:latin typeface="Cambria Math" panose="02040503050406030204" pitchFamily="18" charset="0"/>
+                        </a:rPr>
+                        <m:t> </m:t>
+                      </m:r>
+                      <m:f>
+                        <m:fPr>
+                          <m:ctrlPr>
+                            <a:rPr lang="fr-FR" sz="2400" i="1">
+                              <a:latin typeface="Cambria Math" panose="02040503050406030204" pitchFamily="18" charset="0"/>
+                            </a:rPr>
+                          </m:ctrlPr>
+                        </m:fPr>
+                        <m:num>
+                          <m:r>
+                            <a:rPr lang="fr-FR" sz="2400" i="1">
+                              <a:latin typeface="Cambria Math" panose="02040503050406030204" pitchFamily="18" charset="0"/>
+                            </a:rPr>
+                            <m:t>𝜕</m:t>
+                          </m:r>
+                          <m:r>
+                            <a:rPr lang="fr-FR" sz="2400" i="1">
+                              <a:latin typeface="Cambria Math" panose="02040503050406030204" pitchFamily="18" charset="0"/>
+                            </a:rPr>
+                            <m:t>𝑇</m:t>
+                          </m:r>
+                        </m:num>
+                        <m:den>
+                          <m:r>
+                            <a:rPr lang="fr-FR" sz="2400" i="1">
+                              <a:latin typeface="Cambria Math" panose="02040503050406030204" pitchFamily="18" charset="0"/>
+                            </a:rPr>
+                            <m:t>𝜕</m:t>
+                          </m:r>
+                          <m:r>
+                            <a:rPr lang="fr-FR" sz="2400" i="1">
+                              <a:latin typeface="Cambria Math" panose="02040503050406030204" pitchFamily="18" charset="0"/>
+                            </a:rPr>
+                            <m:t>𝑡</m:t>
+                          </m:r>
+                        </m:den>
+                      </m:f>
+                      <m:r>
+                        <a:rPr lang="fr-FR" sz="2400" i="1">
+                          <a:latin typeface="Cambria Math" panose="02040503050406030204" pitchFamily="18" charset="0"/>
+                        </a:rPr>
+                        <m:t> </m:t>
+                      </m:r>
+                      <m:r>
+                        <a:rPr lang="fr-CA" sz="2400" i="1">
+                          <a:latin typeface="Cambria Math" panose="02040503050406030204" pitchFamily="18" charset="0"/>
+                        </a:rPr>
+                        <m:t>=</m:t>
+                      </m:r>
+                      <m:r>
+                        <a:rPr lang="fr-CA" sz="2400" b="0" i="1" smtClean="0">
+                          <a:latin typeface="Cambria Math" panose="02040503050406030204" pitchFamily="18" charset="0"/>
+                        </a:rPr>
+                        <m:t>𝑘</m:t>
+                      </m:r>
+                      <m:r>
+                        <a:rPr lang="fr-CA" sz="2400" b="0" i="1" smtClean="0">
+                          <a:latin typeface="Cambria Math" panose="02040503050406030204" pitchFamily="18" charset="0"/>
+                        </a:rPr>
+                        <m:t>(</m:t>
+                      </m:r>
                       <m:f>
                         <m:fPr>
                           <m:ctrlPr>
@@ -6045,7 +7659,7 @@
                             </m:sSupPr>
                             <m:e>
                               <m:r>
-                                <a:rPr lang="fr-CA" sz="2400" b="0" i="1" smtClean="0">
+                                <a:rPr lang="fr-CA" sz="2400" i="1">
                                   <a:latin typeface="Cambria Math" panose="02040503050406030204" pitchFamily="18" charset="0"/>
                                 </a:rPr>
                                 <m:t>𝑟</m:t>
@@ -6063,7 +7677,7 @@
                         </m:den>
                       </m:f>
                       <m:r>
-                        <a:rPr lang="fr-FR" sz="2400" b="0" i="1" smtClean="0">
+                        <a:rPr lang="fr-FR" sz="2400" i="1">
                           <a:latin typeface="Cambria Math" panose="02040503050406030204" pitchFamily="18" charset="0"/>
                         </a:rPr>
                         <m:t>+</m:t>
@@ -6078,7 +7692,7 @@
                         </m:fPr>
                         <m:num>
                           <m:r>
-                            <a:rPr lang="fr-FR" sz="2400" b="0" i="1" smtClean="0">
+                            <a:rPr lang="fr-FR" sz="2400" i="1">
                               <a:latin typeface="Cambria Math" panose="02040503050406030204" pitchFamily="18" charset="0"/>
                             </a:rPr>
                             <m:t>1</m:t>
@@ -6086,10 +7700,10 @@
                         </m:num>
                         <m:den>
                           <m:r>
-                            <a:rPr lang="fr-FR" sz="2400" b="0" i="1" smtClean="0">
+                            <a:rPr lang="fr-CA" sz="2400" b="0" i="1" smtClean="0">
                               <a:latin typeface="Cambria Math" panose="02040503050406030204" pitchFamily="18" charset="0"/>
                             </a:rPr>
-                            <m:t>𝑅</m:t>
+                            <m:t>𝑟</m:t>
                           </m:r>
                         </m:den>
                       </m:f>
@@ -6123,7 +7737,7 @@
                             <m:t>𝜕</m:t>
                           </m:r>
                           <m:r>
-                            <a:rPr lang="fr-CA" sz="2400" b="0" i="1" smtClean="0">
+                            <a:rPr lang="fr-CA" sz="2400" i="1">
                               <a:latin typeface="Cambria Math" panose="02040503050406030204" pitchFamily="18" charset="0"/>
                             </a:rPr>
                             <m:t>𝑟</m:t>
@@ -6131,7 +7745,7 @@
                         </m:den>
                       </m:f>
                       <m:r>
-                        <a:rPr lang="fr-FR" sz="2400" b="0" i="1" smtClean="0">
+                        <a:rPr lang="fr-FR" sz="2400" i="1">
                           <a:latin typeface="Cambria Math" panose="02040503050406030204" pitchFamily="18" charset="0"/>
                         </a:rPr>
                         <m:t>+</m:t>
@@ -6212,116 +7826,10 @@
                         </m:den>
                       </m:f>
                       <m:r>
-                        <a:rPr lang="fr-FR" sz="2400" b="0" i="1" smtClean="0">
+                        <a:rPr lang="fr-CA" sz="2400" b="0" i="1" smtClean="0">
                           <a:latin typeface="Cambria Math" panose="02040503050406030204" pitchFamily="18" charset="0"/>
                         </a:rPr>
-                        <m:t>−</m:t>
-                      </m:r>
-                      <m:f>
-                        <m:fPr>
-                          <m:ctrlPr>
-                            <a:rPr lang="fr-FR" sz="2400" i="1">
-                              <a:latin typeface="Cambria Math" panose="02040503050406030204" pitchFamily="18" charset="0"/>
-                            </a:rPr>
-                          </m:ctrlPr>
-                        </m:fPr>
-                        <m:num>
-                          <m:r>
-                            <m:rPr>
-                              <m:sty m:val="p"/>
-                            </m:rPr>
-                            <a:rPr lang="el-GR" sz="2400" i="1">
-                              <a:latin typeface="Cambria Math" panose="02040503050406030204" pitchFamily="18" charset="0"/>
-                            </a:rPr>
-                            <m:t>ρ</m:t>
-                          </m:r>
-                          <m:sSub>
-                            <m:sSubPr>
-                              <m:ctrlPr>
-                                <a:rPr lang="fr-FR" sz="2400" i="1">
-                                  <a:latin typeface="Cambria Math" panose="02040503050406030204" pitchFamily="18" charset="0"/>
-                                </a:rPr>
-                              </m:ctrlPr>
-                            </m:sSubPr>
-                            <m:e>
-                              <m:r>
-                                <a:rPr lang="fr-FR" sz="2400" i="1">
-                                  <a:latin typeface="Cambria Math" panose="02040503050406030204" pitchFamily="18" charset="0"/>
-                                </a:rPr>
-                                <m:t>𝐶</m:t>
-                              </m:r>
-                            </m:e>
-                            <m:sub>
-                              <m:r>
-                                <a:rPr lang="fr-FR" sz="2400" i="1">
-                                  <a:latin typeface="Cambria Math" panose="02040503050406030204" pitchFamily="18" charset="0"/>
-                                </a:rPr>
-                                <m:t>𝑝</m:t>
-                              </m:r>
-                            </m:sub>
-                          </m:sSub>
-                        </m:num>
-                        <m:den>
-                          <m:r>
-                            <m:rPr>
-                              <m:sty m:val="p"/>
-                            </m:rPr>
-                            <a:rPr lang="fr-FR" sz="2400" b="0" i="0" smtClean="0">
-                              <a:latin typeface="Cambria Math" panose="02040503050406030204" pitchFamily="18" charset="0"/>
-                            </a:rPr>
-                            <m:t>k</m:t>
-                          </m:r>
-                          <m:r>
-                            <m:rPr>
-                              <m:nor/>
-                            </m:rPr>
-                            <a:rPr lang="fr-FR" sz="2400"/>
-                            <m:t> </m:t>
-                          </m:r>
-                        </m:den>
-                      </m:f>
-                      <m:f>
-                        <m:fPr>
-                          <m:ctrlPr>
-                            <a:rPr lang="fr-FR" sz="2400" i="1">
-                              <a:latin typeface="Cambria Math" panose="02040503050406030204" pitchFamily="18" charset="0"/>
-                            </a:rPr>
-                          </m:ctrlPr>
-                        </m:fPr>
-                        <m:num>
-                          <m:r>
-                            <a:rPr lang="fr-FR" sz="2400" i="1">
-                              <a:latin typeface="Cambria Math" panose="02040503050406030204" pitchFamily="18" charset="0"/>
-                            </a:rPr>
-                            <m:t>𝜕</m:t>
-                          </m:r>
-                          <m:r>
-                            <a:rPr lang="fr-FR" sz="2400" i="1">
-                              <a:latin typeface="Cambria Math" panose="02040503050406030204" pitchFamily="18" charset="0"/>
-                            </a:rPr>
-                            <m:t>𝑇</m:t>
-                          </m:r>
-                        </m:num>
-                        <m:den>
-                          <m:r>
-                            <a:rPr lang="fr-FR" sz="2400" i="1">
-                              <a:latin typeface="Cambria Math" panose="02040503050406030204" pitchFamily="18" charset="0"/>
-                            </a:rPr>
-                            <m:t>𝜕</m:t>
-                          </m:r>
-                          <m:r>
-                            <a:rPr lang="fr-FR" sz="2400" i="1">
-                              <a:latin typeface="Cambria Math" panose="02040503050406030204" pitchFamily="18" charset="0"/>
-                            </a:rPr>
-                            <m:t>𝑡</m:t>
-                          </m:r>
-                        </m:den>
-                      </m:f>
-                      <m:r>
-                        <a:rPr lang="fr-FR" sz="2400" b="0" i="1" smtClean="0">
-                          <a:latin typeface="Cambria Math" panose="02040503050406030204" pitchFamily="18" charset="0"/>
-                        </a:rPr>
-                        <m:t>=0</m:t>
+                        <m:t>)</m:t>
                       </m:r>
                     </m:oMath>
                   </m:oMathPara>
@@ -6758,10 +8266,10 @@
                         </m:num>
                         <m:den>
                           <m:r>
-                            <a:rPr lang="fr-FR" sz="2400" i="1">
+                            <a:rPr lang="fr-CA" sz="2400" b="0" i="1" smtClean="0">
                               <a:latin typeface="Cambria Math" panose="02040503050406030204" pitchFamily="18" charset="0"/>
                             </a:rPr>
-                            <m:t>𝑅</m:t>
+                            <m:t>𝑟</m:t>
                           </m:r>
                         </m:den>
                       </m:f>
@@ -7193,154 +8701,6 @@
           </p:sp>
         </mc:Fallback>
       </mc:AlternateContent>
-      <p:sp>
-        <p:nvSpPr>
-          <p:cNvPr id="4" name="Flèche : courbe vers la droite 3">
-            <a:extLst>
-              <a:ext uri="{FF2B5EF4-FFF2-40B4-BE49-F238E27FC236}">
-                <a16:creationId xmlns:a16="http://schemas.microsoft.com/office/drawing/2014/main" id="{1AFB7D79-82CC-3BF4-26BE-A0D023326082}"/>
-              </a:ext>
-            </a:extLst>
-          </p:cNvPr>
-          <p:cNvSpPr/>
-          <p:nvPr/>
-        </p:nvSpPr>
-        <p:spPr>
-          <a:xfrm rot="4263975">
-            <a:off x="1775824" y="2807560"/>
-            <a:ext cx="607576" cy="3713718"/>
-          </a:xfrm>
-          <a:prstGeom prst="curvedRightArrow">
-            <a:avLst>
-              <a:gd name="adj1" fmla="val 25000"/>
-              <a:gd name="adj2" fmla="val 50000"/>
-              <a:gd name="adj3" fmla="val 36727"/>
-            </a:avLst>
-          </a:prstGeom>
-        </p:spPr>
-        <p:style>
-          <a:lnRef idx="2">
-            <a:schemeClr val="accent1">
-              <a:shade val="15000"/>
-            </a:schemeClr>
-          </a:lnRef>
-          <a:fillRef idx="1">
-            <a:schemeClr val="accent1"/>
-          </a:fillRef>
-          <a:effectRef idx="0">
-            <a:schemeClr val="accent1"/>
-          </a:effectRef>
-          <a:fontRef idx="minor">
-            <a:schemeClr val="lt1"/>
-          </a:fontRef>
-        </p:style>
-        <p:txBody>
-          <a:bodyPr rtlCol="0" anchor="ctr"/>
-          <a:lstStyle>
-            <a:defPPr>
-              <a:defRPr lang="fr-FR"/>
-            </a:defPPr>
-            <a:lvl1pPr marL="0" algn="l" defTabSz="914400" rtl="0" eaLnBrk="1" latinLnBrk="0" hangingPunct="1">
-              <a:defRPr sz="1800" kern="1200">
-                <a:solidFill>
-                  <a:schemeClr val="lt1"/>
-                </a:solidFill>
-                <a:latin typeface="+mn-lt"/>
-                <a:ea typeface="+mn-ea"/>
-                <a:cs typeface="+mn-cs"/>
-              </a:defRPr>
-            </a:lvl1pPr>
-            <a:lvl2pPr marL="457200" algn="l" defTabSz="914400" rtl="0" eaLnBrk="1" latinLnBrk="0" hangingPunct="1">
-              <a:defRPr sz="1800" kern="1200">
-                <a:solidFill>
-                  <a:schemeClr val="lt1"/>
-                </a:solidFill>
-                <a:latin typeface="+mn-lt"/>
-                <a:ea typeface="+mn-ea"/>
-                <a:cs typeface="+mn-cs"/>
-              </a:defRPr>
-            </a:lvl2pPr>
-            <a:lvl3pPr marL="914400" algn="l" defTabSz="914400" rtl="0" eaLnBrk="1" latinLnBrk="0" hangingPunct="1">
-              <a:defRPr sz="1800" kern="1200">
-                <a:solidFill>
-                  <a:schemeClr val="lt1"/>
-                </a:solidFill>
-                <a:latin typeface="+mn-lt"/>
-                <a:ea typeface="+mn-ea"/>
-                <a:cs typeface="+mn-cs"/>
-              </a:defRPr>
-            </a:lvl3pPr>
-            <a:lvl4pPr marL="1371600" algn="l" defTabSz="914400" rtl="0" eaLnBrk="1" latinLnBrk="0" hangingPunct="1">
-              <a:defRPr sz="1800" kern="1200">
-                <a:solidFill>
-                  <a:schemeClr val="lt1"/>
-                </a:solidFill>
-                <a:latin typeface="+mn-lt"/>
-                <a:ea typeface="+mn-ea"/>
-                <a:cs typeface="+mn-cs"/>
-              </a:defRPr>
-            </a:lvl4pPr>
-            <a:lvl5pPr marL="1828800" algn="l" defTabSz="914400" rtl="0" eaLnBrk="1" latinLnBrk="0" hangingPunct="1">
-              <a:defRPr sz="1800" kern="1200">
-                <a:solidFill>
-                  <a:schemeClr val="lt1"/>
-                </a:solidFill>
-                <a:latin typeface="+mn-lt"/>
-                <a:ea typeface="+mn-ea"/>
-                <a:cs typeface="+mn-cs"/>
-              </a:defRPr>
-            </a:lvl5pPr>
-            <a:lvl6pPr marL="2286000" algn="l" defTabSz="914400" rtl="0" eaLnBrk="1" latinLnBrk="0" hangingPunct="1">
-              <a:defRPr sz="1800" kern="1200">
-                <a:solidFill>
-                  <a:schemeClr val="lt1"/>
-                </a:solidFill>
-                <a:latin typeface="+mn-lt"/>
-                <a:ea typeface="+mn-ea"/>
-                <a:cs typeface="+mn-cs"/>
-              </a:defRPr>
-            </a:lvl6pPr>
-            <a:lvl7pPr marL="2743200" algn="l" defTabSz="914400" rtl="0" eaLnBrk="1" latinLnBrk="0" hangingPunct="1">
-              <a:defRPr sz="1800" kern="1200">
-                <a:solidFill>
-                  <a:schemeClr val="lt1"/>
-                </a:solidFill>
-                <a:latin typeface="+mn-lt"/>
-                <a:ea typeface="+mn-ea"/>
-                <a:cs typeface="+mn-cs"/>
-              </a:defRPr>
-            </a:lvl7pPr>
-            <a:lvl8pPr marL="3200400" algn="l" defTabSz="914400" rtl="0" eaLnBrk="1" latinLnBrk="0" hangingPunct="1">
-              <a:defRPr sz="1800" kern="1200">
-                <a:solidFill>
-                  <a:schemeClr val="lt1"/>
-                </a:solidFill>
-                <a:latin typeface="+mn-lt"/>
-                <a:ea typeface="+mn-ea"/>
-                <a:cs typeface="+mn-cs"/>
-              </a:defRPr>
-            </a:lvl8pPr>
-            <a:lvl9pPr marL="3657600" algn="l" defTabSz="914400" rtl="0" eaLnBrk="1" latinLnBrk="0" hangingPunct="1">
-              <a:defRPr sz="1800" kern="1200">
-                <a:solidFill>
-                  <a:schemeClr val="lt1"/>
-                </a:solidFill>
-                <a:latin typeface="+mn-lt"/>
-                <a:ea typeface="+mn-ea"/>
-                <a:cs typeface="+mn-cs"/>
-              </a:defRPr>
-            </a:lvl9pPr>
-          </a:lstStyle>
-          <a:p>
-            <a:pPr algn="ctr"/>
-            <a:endParaRPr lang="fr-FR">
-              <a:solidFill>
-                <a:schemeClr val="tx1"/>
-              </a:solidFill>
-            </a:endParaRPr>
-          </a:p>
-        </p:txBody>
-      </p:sp>
       <mc:AlternateContent xmlns:mc="http://schemas.openxmlformats.org/markup-compatibility/2006">
         <mc:Choice xmlns:a14="http://schemas.microsoft.com/office/drawing/2010/main" Requires="a14">
           <p:sp>
@@ -7357,8 +8717,8 @@
             </p:nvSpPr>
             <p:spPr>
               <a:xfrm>
-                <a:off x="4860473" y="1439866"/>
-                <a:ext cx="5167085" cy="1759200"/>
+                <a:off x="4869617" y="1595314"/>
+                <a:ext cx="5362519" cy="1732654"/>
               </a:xfrm>
               <a:prstGeom prst="rect">
                 <a:avLst/>
@@ -7757,10 +9117,20 @@
                     </m:f>
                   </m:oMath>
                 </a14:m>
-                <a:endParaRPr lang="fr-FR" sz="2600" dirty="0">
-                  <a:latin typeface="Cambria" panose="02040503050406030204" pitchFamily="18" charset="0"/>
-                  <a:ea typeface="Cambria" panose="02040503050406030204" pitchFamily="18" charset="0"/>
-                </a:endParaRPr>
+                <a:r>
+                  <a:rPr lang="fr-FR" sz="2600" dirty="0">
+                    <a:latin typeface="Cambria" panose="02040503050406030204" pitchFamily="18" charset="0"/>
+                    <a:ea typeface="Cambria" panose="02040503050406030204" pitchFamily="18" charset="0"/>
+                  </a:rPr>
+                  <a:t>, </a:t>
+                </a:r>
+                <a:r>
+                  <a:rPr lang="fr-FR" sz="2000" dirty="0">
+                    <a:latin typeface="Cambria" panose="02040503050406030204" pitchFamily="18" charset="0"/>
+                    <a:ea typeface="Cambria" panose="02040503050406030204" pitchFamily="18" charset="0"/>
+                  </a:rPr>
+                  <a:t>ordre 2</a:t>
+                </a:r>
               </a:p>
               <a:p>
                 <a:pPr marL="457200" indent="-457200">
@@ -8115,7 +9485,17 @@
                     </m:f>
                   </m:oMath>
                 </a14:m>
-                <a:endParaRPr lang="fr-FR" sz="2600" dirty="0"/>
+                <a:r>
+                  <a:rPr lang="fr-FR" sz="2600" dirty="0"/>
+                  <a:t>, </a:t>
+                </a:r>
+                <a:r>
+                  <a:rPr lang="fr-FR" sz="2000" dirty="0">
+                    <a:latin typeface="Cambria" panose="02040503050406030204" pitchFamily="18" charset="0"/>
+                    <a:ea typeface="Cambria" panose="02040503050406030204" pitchFamily="18" charset="0"/>
+                  </a:rPr>
+                  <a:t>ordre 2</a:t>
+                </a:r>
               </a:p>
             </p:txBody>
           </p:sp>
@@ -8137,8 +9517,8 @@
             </p:nvSpPr>
             <p:spPr>
               <a:xfrm>
-                <a:off x="4860473" y="1439866"/>
-                <a:ext cx="5167085" cy="1759200"/>
+                <a:off x="4869617" y="1595314"/>
+                <a:ext cx="5362519" cy="1732654"/>
               </a:xfrm>
               <a:prstGeom prst="rect">
                 <a:avLst/>
@@ -8146,7 +9526,7 @@
               <a:blipFill>
                 <a:blip r:embed="rId3"/>
                 <a:stretch>
-                  <a:fillRect/>
+                  <a:fillRect b="-2113"/>
                 </a:stretch>
               </a:blipFill>
             </p:spPr>
@@ -8165,6 +9545,54 @@
           </p:sp>
         </mc:Fallback>
       </mc:AlternateContent>
+      <p:sp>
+        <p:nvSpPr>
+          <p:cNvPr id="6" name="Arc 5">
+            <a:extLst>
+              <a:ext uri="{FF2B5EF4-FFF2-40B4-BE49-F238E27FC236}">
+                <a16:creationId xmlns:a16="http://schemas.microsoft.com/office/drawing/2014/main" id="{669E06E8-CC02-FA18-F417-BCEB210B1102}"/>
+              </a:ext>
+            </a:extLst>
+          </p:cNvPr>
+          <p:cNvSpPr/>
+          <p:nvPr/>
+        </p:nvSpPr>
+        <p:spPr>
+          <a:xfrm rot="241833" flipH="1">
+            <a:off x="2857585" y="4094814"/>
+            <a:ext cx="2152095" cy="1509192"/>
+          </a:xfrm>
+          <a:prstGeom prst="arc">
+            <a:avLst/>
+          </a:prstGeom>
+          <a:ln>
+            <a:headEnd type="none" w="med" len="med"/>
+            <a:tailEnd type="triangle" w="med" len="med"/>
+          </a:ln>
+        </p:spPr>
+        <p:style>
+          <a:lnRef idx="2">
+            <a:schemeClr val="accent1"/>
+          </a:lnRef>
+          <a:fillRef idx="0">
+            <a:schemeClr val="accent1"/>
+          </a:fillRef>
+          <a:effectRef idx="1">
+            <a:schemeClr val="accent1"/>
+          </a:effectRef>
+          <a:fontRef idx="minor">
+            <a:schemeClr val="tx1"/>
+          </a:fontRef>
+        </p:style>
+        <p:txBody>
+          <a:bodyPr rtlCol="0" anchor="ctr"/>
+          <a:lstStyle/>
+          <a:p>
+            <a:pPr algn="ctr"/>
+            <a:endParaRPr lang="fr-CA"/>
+          </a:p>
+        </p:txBody>
+      </p:sp>
     </p:spTree>
     <p:extLst>
       <p:ext uri="{BB962C8B-B14F-4D97-AF65-F5344CB8AC3E}">
@@ -8178,7 +9606,7 @@
 </p:sld>
 </file>
 
-<file path=ppt/slides/slide5.xml><?xml version="1.0" encoding="utf-8"?>
+<file path=ppt/slides/slide6.xml><?xml version="1.0" encoding="utf-8"?>
 <p:sld xmlns:a="http://schemas.openxmlformats.org/drawingml/2006/main" xmlns:r="http://schemas.openxmlformats.org/officeDocument/2006/relationships" xmlns:p="http://schemas.openxmlformats.org/presentationml/2006/main">
   <p:cSld>
     <p:spTree>
@@ -8266,7 +9694,7 @@
 </p:sld>
 </file>
 
-<file path=ppt/slides/slide6.xml><?xml version="1.0" encoding="utf-8"?>
+<file path=ppt/slides/slide7.xml><?xml version="1.0" encoding="utf-8"?>
 <p:sld xmlns:a="http://schemas.openxmlformats.org/drawingml/2006/main" xmlns:r="http://schemas.openxmlformats.org/officeDocument/2006/relationships" xmlns:p="http://schemas.openxmlformats.org/presentationml/2006/main">
   <p:cSld>
     <p:spTree>
@@ -10986,7 +12414,7 @@
 </p:sld>
 </file>
 
-<file path=ppt/slides/slide7.xml><?xml version="1.0" encoding="utf-8"?>
+<file path=ppt/slides/slide8.xml><?xml version="1.0" encoding="utf-8"?>
 <p:sld xmlns:a="http://schemas.openxmlformats.org/drawingml/2006/main" xmlns:r="http://schemas.openxmlformats.org/officeDocument/2006/relationships" xmlns:p="http://schemas.openxmlformats.org/presentationml/2006/main">
   <p:cSld>
     <p:spTree>
@@ -15810,7 +17238,7 @@
 </p:sld>
 </file>
 
-<file path=ppt/slides/slide8.xml><?xml version="1.0" encoding="utf-8"?>
+<file path=ppt/slides/slide9.xml><?xml version="1.0" encoding="utf-8"?>
 <p:sld xmlns:a="http://schemas.openxmlformats.org/drawingml/2006/main" xmlns:r="http://schemas.openxmlformats.org/officeDocument/2006/relationships" xmlns:p="http://schemas.openxmlformats.org/presentationml/2006/main">
   <p:cSld>
     <p:spTree>

</xml_diff>

<commit_message>
pwp: ajout de la discrétisation des frontières
</commit_message>
<xml_diff>
--- a/projet_final/projet_final/MEC8211-Projet-final-Presentation.pptx
+++ b/projet_final/projet_final/MEC8211-Projet-final-Presentation.pptx
@@ -9656,31 +9656,3469 @@
           </a:p>
         </p:txBody>
       </p:sp>
-      <p:sp>
-        <p:nvSpPr>
-          <p:cNvPr id="3" name="Espace réservé du contenu 2">
+      <p:pic>
+        <p:nvPicPr>
+          <p:cNvPr id="5" name="Espace réservé du contenu 4">
             <a:extLst>
               <a:ext uri="{FF2B5EF4-FFF2-40B4-BE49-F238E27FC236}">
-                <a16:creationId xmlns:a16="http://schemas.microsoft.com/office/drawing/2014/main" id="{492A9C98-CDF3-02FE-6E21-30036838C3DB}"/>
+                <a16:creationId xmlns:a16="http://schemas.microsoft.com/office/drawing/2014/main" id="{4595270A-CFC5-DE88-BDE0-18625C38E140}"/>
               </a:ext>
             </a:extLst>
           </p:cNvPr>
-          <p:cNvSpPr>
-            <a:spLocks noGrp="1"/>
-          </p:cNvSpPr>
+          <p:cNvPicPr>
+            <a:picLocks noGrp="1" noChangeAspect="1"/>
+          </p:cNvPicPr>
           <p:nvPr>
             <p:ph idx="1"/>
           </p:nvPr>
+        </p:nvPicPr>
+        <p:blipFill>
+          <a:blip r:embed="rId2"/>
+          <a:stretch>
+            <a:fillRect/>
+          </a:stretch>
+        </p:blipFill>
+        <p:spPr>
+          <a:xfrm>
+            <a:off x="1016619" y="4270193"/>
+            <a:ext cx="4204606" cy="2487977"/>
+          </a:xfrm>
+          <a:prstGeom prst="rect">
+            <a:avLst/>
+          </a:prstGeom>
+        </p:spPr>
+      </p:pic>
+      <mc:AlternateContent xmlns:mc="http://schemas.openxmlformats.org/markup-compatibility/2006">
+        <mc:Choice xmlns:a14="http://schemas.microsoft.com/office/drawing/2010/main" Requires="a14">
+          <p:sp>
+            <p:nvSpPr>
+              <p:cNvPr id="6" name="ZoneTexte 5">
+                <a:extLst>
+                  <a:ext uri="{FF2B5EF4-FFF2-40B4-BE49-F238E27FC236}">
+                    <a16:creationId xmlns:a16="http://schemas.microsoft.com/office/drawing/2014/main" id="{F5871682-0B46-824A-AEFF-E8E2BCE778AB}"/>
+                  </a:ext>
+                </a:extLst>
+              </p:cNvPr>
+              <p:cNvSpPr txBox="1"/>
+              <p:nvPr/>
+            </p:nvSpPr>
+            <p:spPr>
+              <a:xfrm>
+                <a:off x="667512" y="1343818"/>
+                <a:ext cx="5897880" cy="1288686"/>
+              </a:xfrm>
+              <a:prstGeom prst="rect">
+                <a:avLst/>
+              </a:prstGeom>
+              <a:noFill/>
+            </p:spPr>
+            <p:txBody>
+              <a:bodyPr wrap="square" rtlCol="0">
+                <a:spAutoFit/>
+              </a:bodyPr>
+              <a:lstStyle/>
+              <a:p>
+                <a:r>
+                  <a:rPr lang="fr-CA" dirty="0">
+                    <a:solidFill>
+                      <a:schemeClr val="accent2"/>
+                    </a:solidFill>
+                  </a:rPr>
+                  <a:t>Condition de symétrie (Neumann) :</a:t>
+                </a:r>
+              </a:p>
+              <a:p>
+                <a:pPr algn="ctr"/>
+                <a:r>
+                  <a:rPr lang="fr-CA" dirty="0">
+                    <a:solidFill>
+                      <a:schemeClr val="accent2"/>
+                    </a:solidFill>
+                  </a:rPr>
+                  <a:t>	</a:t>
+                </a:r>
+                <a14:m>
+                  <m:oMath xmlns:m="http://schemas.openxmlformats.org/officeDocument/2006/math">
+                    <m:f>
+                      <m:fPr>
+                        <m:ctrlPr>
+                          <a:rPr lang="fr-CA" b="0" i="1" smtClean="0">
+                            <a:solidFill>
+                              <a:schemeClr val="accent2"/>
+                            </a:solidFill>
+                            <a:latin typeface="Cambria Math" panose="02040503050406030204" pitchFamily="18" charset="0"/>
+                          </a:rPr>
+                        </m:ctrlPr>
+                      </m:fPr>
+                      <m:num>
+                        <m:r>
+                          <a:rPr lang="fr-CA" b="0" i="1" smtClean="0">
+                            <a:solidFill>
+                              <a:schemeClr val="accent2"/>
+                            </a:solidFill>
+                            <a:latin typeface="Cambria Math" panose="02040503050406030204" pitchFamily="18" charset="0"/>
+                          </a:rPr>
+                          <m:t>𝑑𝑇</m:t>
+                        </m:r>
+                      </m:num>
+                      <m:den>
+                        <m:r>
+                          <a:rPr lang="fr-CA" b="0" i="1" smtClean="0">
+                            <a:solidFill>
+                              <a:schemeClr val="accent2"/>
+                            </a:solidFill>
+                            <a:latin typeface="Cambria Math" panose="02040503050406030204" pitchFamily="18" charset="0"/>
+                          </a:rPr>
+                          <m:t>𝑑𝑧</m:t>
+                        </m:r>
+                      </m:den>
+                    </m:f>
+                    <m:r>
+                      <a:rPr lang="fr-CA" b="0" i="1" smtClean="0">
+                        <a:solidFill>
+                          <a:schemeClr val="accent2"/>
+                        </a:solidFill>
+                        <a:latin typeface="Cambria Math" panose="02040503050406030204" pitchFamily="18" charset="0"/>
+                      </a:rPr>
+                      <m:t>=0</m:t>
+                    </m:r>
+                  </m:oMath>
+                </a14:m>
+                <a:endParaRPr lang="fr-CA" b="0" i="1" dirty="0">
+                  <a:solidFill>
+                    <a:schemeClr val="accent2"/>
+                  </a:solidFill>
+                  <a:latin typeface="Cambria Math" panose="02040503050406030204" pitchFamily="18" charset="0"/>
+                </a:endParaRPr>
+              </a:p>
+              <a:p>
+                <a:pPr algn="ctr"/>
+                <a14:m>
+                  <m:oMathPara xmlns:m="http://schemas.openxmlformats.org/officeDocument/2006/math">
+                    <m:oMathParaPr>
+                      <m:jc m:val="centerGroup"/>
+                    </m:oMathParaPr>
+                    <m:oMath xmlns:m="http://schemas.openxmlformats.org/officeDocument/2006/math">
+                      <m:sSubSup>
+                        <m:sSubSupPr>
+                          <m:ctrlPr>
+                            <a:rPr lang="fr-CA" b="0" i="1" smtClean="0">
+                              <a:solidFill>
+                                <a:schemeClr val="accent2"/>
+                              </a:solidFill>
+                              <a:latin typeface="Cambria Math" panose="02040503050406030204" pitchFamily="18" charset="0"/>
+                            </a:rPr>
+                          </m:ctrlPr>
+                        </m:sSubSupPr>
+                        <m:e>
+                          <m:r>
+                            <a:rPr lang="fr-CA" b="0" i="1" smtClean="0">
+                              <a:solidFill>
+                                <a:schemeClr val="accent2"/>
+                              </a:solidFill>
+                              <a:latin typeface="Cambria Math" panose="02040503050406030204" pitchFamily="18" charset="0"/>
+                            </a:rPr>
+                            <m:t>𝑇</m:t>
+                          </m:r>
+                        </m:e>
+                        <m:sub>
+                          <m:r>
+                            <a:rPr lang="fr-CA" b="0" i="1" smtClean="0">
+                              <a:solidFill>
+                                <a:schemeClr val="accent2"/>
+                              </a:solidFill>
+                              <a:latin typeface="Cambria Math" panose="02040503050406030204" pitchFamily="18" charset="0"/>
+                            </a:rPr>
+                            <m:t>𝑟</m:t>
+                          </m:r>
+                          <m:r>
+                            <a:rPr lang="fr-CA" b="0" i="1" smtClean="0">
+                              <a:solidFill>
+                                <a:schemeClr val="accent2"/>
+                              </a:solidFill>
+                              <a:latin typeface="Cambria Math" panose="02040503050406030204" pitchFamily="18" charset="0"/>
+                            </a:rPr>
+                            <m:t>,</m:t>
+                          </m:r>
+                          <m:r>
+                            <a:rPr lang="fr-CA" b="0" i="1" smtClean="0">
+                              <a:solidFill>
+                                <a:schemeClr val="accent2"/>
+                              </a:solidFill>
+                              <a:latin typeface="Cambria Math" panose="02040503050406030204" pitchFamily="18" charset="0"/>
+                            </a:rPr>
+                            <m:t>𝑧</m:t>
+                          </m:r>
+                        </m:sub>
+                        <m:sup>
+                          <m:r>
+                            <a:rPr lang="fr-CA" b="0" i="1" smtClean="0">
+                              <a:solidFill>
+                                <a:schemeClr val="accent2"/>
+                              </a:solidFill>
+                              <a:latin typeface="Cambria Math" panose="02040503050406030204" pitchFamily="18" charset="0"/>
+                            </a:rPr>
+                            <m:t>𝑡</m:t>
+                          </m:r>
+                          <m:r>
+                            <a:rPr lang="fr-CA" b="0" i="1" smtClean="0">
+                              <a:solidFill>
+                                <a:schemeClr val="accent2"/>
+                              </a:solidFill>
+                              <a:latin typeface="Cambria Math" panose="02040503050406030204" pitchFamily="18" charset="0"/>
+                            </a:rPr>
+                            <m:t>+∆</m:t>
+                          </m:r>
+                          <m:r>
+                            <a:rPr lang="fr-CA" b="0" i="1" smtClean="0">
+                              <a:solidFill>
+                                <a:schemeClr val="accent2"/>
+                              </a:solidFill>
+                              <a:latin typeface="Cambria Math" panose="02040503050406030204" pitchFamily="18" charset="0"/>
+                              <a:ea typeface="Cambria Math" panose="02040503050406030204" pitchFamily="18" charset="0"/>
+                            </a:rPr>
+                            <m:t>𝑡</m:t>
+                          </m:r>
+                        </m:sup>
+                      </m:sSubSup>
+                      <m:r>
+                        <a:rPr lang="fr-CA" b="0" i="0" smtClean="0">
+                          <a:solidFill>
+                            <a:schemeClr val="accent2"/>
+                          </a:solidFill>
+                          <a:latin typeface="Cambria Math" panose="02040503050406030204" pitchFamily="18" charset="0"/>
+                        </a:rPr>
+                        <m:t>=</m:t>
+                      </m:r>
+                      <m:f>
+                        <m:fPr>
+                          <m:ctrlPr>
+                            <a:rPr lang="fr-CA" b="0" i="0" smtClean="0">
+                              <a:solidFill>
+                                <a:schemeClr val="accent2"/>
+                              </a:solidFill>
+                              <a:latin typeface="Cambria Math" panose="02040503050406030204" pitchFamily="18" charset="0"/>
+                            </a:rPr>
+                          </m:ctrlPr>
+                        </m:fPr>
+                        <m:num>
+                          <m:r>
+                            <a:rPr lang="fr-CA" b="0" i="0" smtClean="0">
+                              <a:solidFill>
+                                <a:schemeClr val="accent2"/>
+                              </a:solidFill>
+                              <a:latin typeface="Cambria Math" panose="02040503050406030204" pitchFamily="18" charset="0"/>
+                            </a:rPr>
+                            <m:t>−</m:t>
+                          </m:r>
+                          <m:r>
+                            <a:rPr lang="fr-CA" b="0" i="0" smtClean="0">
+                              <a:solidFill>
+                                <a:schemeClr val="accent2"/>
+                              </a:solidFill>
+                              <a:latin typeface="Cambria Math" panose="02040503050406030204" pitchFamily="18" charset="0"/>
+                            </a:rPr>
+                            <m:t>1</m:t>
+                          </m:r>
+                        </m:num>
+                        <m:den>
+                          <m:r>
+                            <a:rPr lang="fr-CA" b="0" i="0" smtClean="0">
+                              <a:solidFill>
+                                <a:schemeClr val="accent2"/>
+                              </a:solidFill>
+                              <a:latin typeface="Cambria Math" panose="02040503050406030204" pitchFamily="18" charset="0"/>
+                            </a:rPr>
+                            <m:t>3</m:t>
+                          </m:r>
+                        </m:den>
+                      </m:f>
+                      <m:sSubSup>
+                        <m:sSubSupPr>
+                          <m:ctrlPr>
+                            <a:rPr lang="fr-CA" i="1">
+                              <a:solidFill>
+                                <a:schemeClr val="accent2"/>
+                              </a:solidFill>
+                              <a:latin typeface="Cambria Math" panose="02040503050406030204" pitchFamily="18" charset="0"/>
+                            </a:rPr>
+                          </m:ctrlPr>
+                        </m:sSubSupPr>
+                        <m:e>
+                          <m:r>
+                            <a:rPr lang="fr-CA" i="1">
+                              <a:solidFill>
+                                <a:schemeClr val="accent2"/>
+                              </a:solidFill>
+                              <a:latin typeface="Cambria Math" panose="02040503050406030204" pitchFamily="18" charset="0"/>
+                            </a:rPr>
+                            <m:t>𝑇</m:t>
+                          </m:r>
+                        </m:e>
+                        <m:sub>
+                          <m:r>
+                            <a:rPr lang="fr-CA" i="1">
+                              <a:solidFill>
+                                <a:schemeClr val="accent2"/>
+                              </a:solidFill>
+                              <a:latin typeface="Cambria Math" panose="02040503050406030204" pitchFamily="18" charset="0"/>
+                            </a:rPr>
+                            <m:t>𝑟</m:t>
+                          </m:r>
+                          <m:r>
+                            <a:rPr lang="fr-CA" i="1">
+                              <a:solidFill>
+                                <a:schemeClr val="accent2"/>
+                              </a:solidFill>
+                              <a:latin typeface="Cambria Math" panose="02040503050406030204" pitchFamily="18" charset="0"/>
+                            </a:rPr>
+                            <m:t>,</m:t>
+                          </m:r>
+                          <m:r>
+                            <a:rPr lang="fr-CA" i="1">
+                              <a:solidFill>
+                                <a:schemeClr val="accent2"/>
+                              </a:solidFill>
+                              <a:latin typeface="Cambria Math" panose="02040503050406030204" pitchFamily="18" charset="0"/>
+                            </a:rPr>
+                            <m:t>𝑧</m:t>
+                          </m:r>
+                          <m:r>
+                            <a:rPr lang="fr-CA" b="0" i="1" smtClean="0">
+                              <a:solidFill>
+                                <a:schemeClr val="accent2"/>
+                              </a:solidFill>
+                              <a:latin typeface="Cambria Math" panose="02040503050406030204" pitchFamily="18" charset="0"/>
+                            </a:rPr>
+                            <m:t>+2</m:t>
+                          </m:r>
+                        </m:sub>
+                        <m:sup>
+                          <m:r>
+                            <a:rPr lang="fr-CA" i="1">
+                              <a:solidFill>
+                                <a:schemeClr val="accent2"/>
+                              </a:solidFill>
+                              <a:latin typeface="Cambria Math" panose="02040503050406030204" pitchFamily="18" charset="0"/>
+                            </a:rPr>
+                            <m:t>𝑡</m:t>
+                          </m:r>
+                        </m:sup>
+                      </m:sSubSup>
+                      <m:r>
+                        <a:rPr lang="fr-CA" b="0" i="1" smtClean="0">
+                          <a:solidFill>
+                            <a:schemeClr val="accent2"/>
+                          </a:solidFill>
+                          <a:latin typeface="Cambria Math" panose="02040503050406030204" pitchFamily="18" charset="0"/>
+                          <a:ea typeface="Cambria Math" panose="02040503050406030204" pitchFamily="18" charset="0"/>
+                        </a:rPr>
+                        <m:t>+</m:t>
+                      </m:r>
+                      <m:f>
+                        <m:fPr>
+                          <m:ctrlPr>
+                            <a:rPr lang="fr-CA" b="0" i="1" smtClean="0">
+                              <a:solidFill>
+                                <a:schemeClr val="accent2"/>
+                              </a:solidFill>
+                              <a:latin typeface="Cambria Math" panose="02040503050406030204" pitchFamily="18" charset="0"/>
+                              <a:ea typeface="Cambria Math" panose="02040503050406030204" pitchFamily="18" charset="0"/>
+                            </a:rPr>
+                          </m:ctrlPr>
+                        </m:fPr>
+                        <m:num>
+                          <m:r>
+                            <a:rPr lang="fr-CA" b="0" i="1" smtClean="0">
+                              <a:solidFill>
+                                <a:schemeClr val="accent2"/>
+                              </a:solidFill>
+                              <a:latin typeface="Cambria Math" panose="02040503050406030204" pitchFamily="18" charset="0"/>
+                              <a:ea typeface="Cambria Math" panose="02040503050406030204" pitchFamily="18" charset="0"/>
+                            </a:rPr>
+                            <m:t>4</m:t>
+                          </m:r>
+                        </m:num>
+                        <m:den>
+                          <m:r>
+                            <a:rPr lang="fr-CA" b="0" i="1" smtClean="0">
+                              <a:solidFill>
+                                <a:schemeClr val="accent2"/>
+                              </a:solidFill>
+                              <a:latin typeface="Cambria Math" panose="02040503050406030204" pitchFamily="18" charset="0"/>
+                              <a:ea typeface="Cambria Math" panose="02040503050406030204" pitchFamily="18" charset="0"/>
+                            </a:rPr>
+                            <m:t>3</m:t>
+                          </m:r>
+                        </m:den>
+                      </m:f>
+                      <m:sSubSup>
+                        <m:sSubSupPr>
+                          <m:ctrlPr>
+                            <a:rPr lang="fr-CA" i="1">
+                              <a:solidFill>
+                                <a:schemeClr val="accent2"/>
+                              </a:solidFill>
+                              <a:latin typeface="Cambria Math" panose="02040503050406030204" pitchFamily="18" charset="0"/>
+                            </a:rPr>
+                          </m:ctrlPr>
+                        </m:sSubSupPr>
+                        <m:e>
+                          <m:r>
+                            <a:rPr lang="fr-CA" i="1">
+                              <a:solidFill>
+                                <a:schemeClr val="accent2"/>
+                              </a:solidFill>
+                              <a:latin typeface="Cambria Math" panose="02040503050406030204" pitchFamily="18" charset="0"/>
+                            </a:rPr>
+                            <m:t>𝑇</m:t>
+                          </m:r>
+                        </m:e>
+                        <m:sub>
+                          <m:r>
+                            <a:rPr lang="fr-CA" i="1">
+                              <a:solidFill>
+                                <a:schemeClr val="accent2"/>
+                              </a:solidFill>
+                              <a:latin typeface="Cambria Math" panose="02040503050406030204" pitchFamily="18" charset="0"/>
+                            </a:rPr>
+                            <m:t>𝑟</m:t>
+                          </m:r>
+                          <m:r>
+                            <a:rPr lang="fr-CA" i="1">
+                              <a:solidFill>
+                                <a:schemeClr val="accent2"/>
+                              </a:solidFill>
+                              <a:latin typeface="Cambria Math" panose="02040503050406030204" pitchFamily="18" charset="0"/>
+                            </a:rPr>
+                            <m:t>,</m:t>
+                          </m:r>
+                          <m:r>
+                            <a:rPr lang="fr-CA" i="1">
+                              <a:solidFill>
+                                <a:schemeClr val="accent2"/>
+                              </a:solidFill>
+                              <a:latin typeface="Cambria Math" panose="02040503050406030204" pitchFamily="18" charset="0"/>
+                            </a:rPr>
+                            <m:t>𝑧</m:t>
+                          </m:r>
+                          <m:r>
+                            <a:rPr lang="fr-CA" b="0" i="1" smtClean="0">
+                              <a:solidFill>
+                                <a:schemeClr val="accent2"/>
+                              </a:solidFill>
+                              <a:latin typeface="Cambria Math" panose="02040503050406030204" pitchFamily="18" charset="0"/>
+                            </a:rPr>
+                            <m:t>+1</m:t>
+                          </m:r>
+                        </m:sub>
+                        <m:sup>
+                          <m:r>
+                            <a:rPr lang="fr-CA" i="1">
+                              <a:solidFill>
+                                <a:schemeClr val="accent2"/>
+                              </a:solidFill>
+                              <a:latin typeface="Cambria Math" panose="02040503050406030204" pitchFamily="18" charset="0"/>
+                            </a:rPr>
+                            <m:t>𝑡</m:t>
+                          </m:r>
+                        </m:sup>
+                      </m:sSubSup>
+                    </m:oMath>
+                  </m:oMathPara>
+                </a14:m>
+                <a:endParaRPr lang="fr-CA" dirty="0">
+                  <a:solidFill>
+                    <a:schemeClr val="accent2"/>
+                  </a:solidFill>
+                </a:endParaRPr>
+              </a:p>
+            </p:txBody>
+          </p:sp>
+        </mc:Choice>
+        <mc:Fallback>
+          <p:sp>
+            <p:nvSpPr>
+              <p:cNvPr id="6" name="ZoneTexte 5">
+                <a:extLst>
+                  <a:ext uri="{FF2B5EF4-FFF2-40B4-BE49-F238E27FC236}">
+                    <a16:creationId xmlns:a16="http://schemas.microsoft.com/office/drawing/2014/main" id="{F5871682-0B46-824A-AEFF-E8E2BCE778AB}"/>
+                  </a:ext>
+                </a:extLst>
+              </p:cNvPr>
+              <p:cNvSpPr txBox="1">
+                <a:spLocks noRot="1" noChangeAspect="1" noMove="1" noResize="1" noEditPoints="1" noAdjustHandles="1" noChangeArrowheads="1" noChangeShapeType="1" noTextEdit="1"/>
+              </p:cNvSpPr>
+              <p:nvPr/>
+            </p:nvSpPr>
+            <p:spPr>
+              <a:xfrm>
+                <a:off x="667512" y="1343818"/>
+                <a:ext cx="5897880" cy="1288686"/>
+              </a:xfrm>
+              <a:prstGeom prst="rect">
+                <a:avLst/>
+              </a:prstGeom>
+              <a:blipFill>
+                <a:blip r:embed="rId3"/>
+                <a:stretch>
+                  <a:fillRect l="-931" t="-1887"/>
+                </a:stretch>
+              </a:blipFill>
+            </p:spPr>
+            <p:txBody>
+              <a:bodyPr/>
+              <a:lstStyle/>
+              <a:p>
+                <a:r>
+                  <a:rPr lang="fr-CA">
+                    <a:noFill/>
+                  </a:rPr>
+                  <a:t> </a:t>
+                </a:r>
+              </a:p>
+            </p:txBody>
+          </p:sp>
+        </mc:Fallback>
+      </mc:AlternateContent>
+      <mc:AlternateContent xmlns:mc="http://schemas.openxmlformats.org/markup-compatibility/2006">
+        <mc:Choice xmlns:a14="http://schemas.microsoft.com/office/drawing/2010/main" Requires="a14">
+          <p:sp>
+            <p:nvSpPr>
+              <p:cNvPr id="7" name="ZoneTexte 6">
+                <a:extLst>
+                  <a:ext uri="{FF2B5EF4-FFF2-40B4-BE49-F238E27FC236}">
+                    <a16:creationId xmlns:a16="http://schemas.microsoft.com/office/drawing/2014/main" id="{35B26447-C369-915B-101D-E4FC7C5D7482}"/>
+                  </a:ext>
+                </a:extLst>
+              </p:cNvPr>
+              <p:cNvSpPr txBox="1"/>
+              <p:nvPr/>
+            </p:nvSpPr>
+            <p:spPr>
+              <a:xfrm>
+                <a:off x="582168" y="2784657"/>
+                <a:ext cx="5897880" cy="1288686"/>
+              </a:xfrm>
+              <a:prstGeom prst="rect">
+                <a:avLst/>
+              </a:prstGeom>
+              <a:noFill/>
+            </p:spPr>
+            <p:txBody>
+              <a:bodyPr wrap="square" rtlCol="0">
+                <a:spAutoFit/>
+              </a:bodyPr>
+              <a:lstStyle/>
+              <a:p>
+                <a:r>
+                  <a:rPr lang="fr-CA" dirty="0">
+                    <a:solidFill>
+                      <a:srgbClr val="FFBF00"/>
+                    </a:solidFill>
+                  </a:rPr>
+                  <a:t>Condition de symétrie (Neumann) :</a:t>
+                </a:r>
+              </a:p>
+              <a:p>
+                <a:pPr algn="ctr"/>
+                <a:r>
+                  <a:rPr lang="fr-CA" dirty="0">
+                    <a:solidFill>
+                      <a:srgbClr val="FFBF00"/>
+                    </a:solidFill>
+                  </a:rPr>
+                  <a:t>	</a:t>
+                </a:r>
+                <a14:m>
+                  <m:oMath xmlns:m="http://schemas.openxmlformats.org/officeDocument/2006/math">
+                    <m:f>
+                      <m:fPr>
+                        <m:ctrlPr>
+                          <a:rPr lang="fr-CA" b="0" i="1" smtClean="0">
+                            <a:solidFill>
+                              <a:srgbClr val="FFBF00"/>
+                            </a:solidFill>
+                            <a:latin typeface="Cambria Math" panose="02040503050406030204" pitchFamily="18" charset="0"/>
+                          </a:rPr>
+                        </m:ctrlPr>
+                      </m:fPr>
+                      <m:num>
+                        <m:r>
+                          <a:rPr lang="fr-CA" b="0" i="1" smtClean="0">
+                            <a:solidFill>
+                              <a:srgbClr val="FFBF00"/>
+                            </a:solidFill>
+                            <a:latin typeface="Cambria Math" panose="02040503050406030204" pitchFamily="18" charset="0"/>
+                          </a:rPr>
+                          <m:t>𝑑𝑇</m:t>
+                        </m:r>
+                      </m:num>
+                      <m:den>
+                        <m:r>
+                          <a:rPr lang="fr-CA" b="0" i="1" smtClean="0">
+                            <a:solidFill>
+                              <a:srgbClr val="FFBF00"/>
+                            </a:solidFill>
+                            <a:latin typeface="Cambria Math" panose="02040503050406030204" pitchFamily="18" charset="0"/>
+                          </a:rPr>
+                          <m:t>𝑑𝑧</m:t>
+                        </m:r>
+                      </m:den>
+                    </m:f>
+                    <m:r>
+                      <a:rPr lang="fr-CA" b="0" i="1" smtClean="0">
+                        <a:solidFill>
+                          <a:srgbClr val="FFBF00"/>
+                        </a:solidFill>
+                        <a:latin typeface="Cambria Math" panose="02040503050406030204" pitchFamily="18" charset="0"/>
+                      </a:rPr>
+                      <m:t>=0</m:t>
+                    </m:r>
+                  </m:oMath>
+                </a14:m>
+                <a:endParaRPr lang="fr-CA" b="0" i="1" dirty="0">
+                  <a:solidFill>
+                    <a:srgbClr val="FFBF00"/>
+                  </a:solidFill>
+                  <a:latin typeface="Cambria Math" panose="02040503050406030204" pitchFamily="18" charset="0"/>
+                </a:endParaRPr>
+              </a:p>
+              <a:p>
+                <a:pPr algn="ctr"/>
+                <a14:m>
+                  <m:oMathPara xmlns:m="http://schemas.openxmlformats.org/officeDocument/2006/math">
+                    <m:oMathParaPr>
+                      <m:jc m:val="centerGroup"/>
+                    </m:oMathParaPr>
+                    <m:oMath xmlns:m="http://schemas.openxmlformats.org/officeDocument/2006/math">
+                      <m:sSubSup>
+                        <m:sSubSupPr>
+                          <m:ctrlPr>
+                            <a:rPr lang="fr-CA" b="0" i="1" smtClean="0">
+                              <a:solidFill>
+                                <a:srgbClr val="FFBF00"/>
+                              </a:solidFill>
+                              <a:latin typeface="Cambria Math" panose="02040503050406030204" pitchFamily="18" charset="0"/>
+                            </a:rPr>
+                          </m:ctrlPr>
+                        </m:sSubSupPr>
+                        <m:e>
+                          <m:r>
+                            <a:rPr lang="fr-CA" b="0" i="1" smtClean="0">
+                              <a:solidFill>
+                                <a:srgbClr val="FFBF00"/>
+                              </a:solidFill>
+                              <a:latin typeface="Cambria Math" panose="02040503050406030204" pitchFamily="18" charset="0"/>
+                            </a:rPr>
+                            <m:t>𝑇</m:t>
+                          </m:r>
+                        </m:e>
+                        <m:sub>
+                          <m:r>
+                            <a:rPr lang="fr-CA" b="0" i="1" smtClean="0">
+                              <a:solidFill>
+                                <a:srgbClr val="FFBF00"/>
+                              </a:solidFill>
+                              <a:latin typeface="Cambria Math" panose="02040503050406030204" pitchFamily="18" charset="0"/>
+                            </a:rPr>
+                            <m:t>𝑟</m:t>
+                          </m:r>
+                          <m:r>
+                            <a:rPr lang="fr-CA" b="0" i="1" smtClean="0">
+                              <a:solidFill>
+                                <a:srgbClr val="FFBF00"/>
+                              </a:solidFill>
+                              <a:latin typeface="Cambria Math" panose="02040503050406030204" pitchFamily="18" charset="0"/>
+                            </a:rPr>
+                            <m:t>,</m:t>
+                          </m:r>
+                          <m:r>
+                            <a:rPr lang="fr-CA" b="0" i="1" smtClean="0">
+                              <a:solidFill>
+                                <a:srgbClr val="FFBF00"/>
+                              </a:solidFill>
+                              <a:latin typeface="Cambria Math" panose="02040503050406030204" pitchFamily="18" charset="0"/>
+                            </a:rPr>
+                            <m:t>𝑧</m:t>
+                          </m:r>
+                        </m:sub>
+                        <m:sup>
+                          <m:r>
+                            <a:rPr lang="fr-CA" b="0" i="1" smtClean="0">
+                              <a:solidFill>
+                                <a:srgbClr val="FFBF00"/>
+                              </a:solidFill>
+                              <a:latin typeface="Cambria Math" panose="02040503050406030204" pitchFamily="18" charset="0"/>
+                            </a:rPr>
+                            <m:t>𝑡</m:t>
+                          </m:r>
+                          <m:r>
+                            <a:rPr lang="fr-CA" b="0" i="1" smtClean="0">
+                              <a:solidFill>
+                                <a:srgbClr val="FFBF00"/>
+                              </a:solidFill>
+                              <a:latin typeface="Cambria Math" panose="02040503050406030204" pitchFamily="18" charset="0"/>
+                            </a:rPr>
+                            <m:t>+∆</m:t>
+                          </m:r>
+                          <m:r>
+                            <a:rPr lang="fr-CA" b="0" i="1" smtClean="0">
+                              <a:solidFill>
+                                <a:srgbClr val="FFBF00"/>
+                              </a:solidFill>
+                              <a:latin typeface="Cambria Math" panose="02040503050406030204" pitchFamily="18" charset="0"/>
+                              <a:ea typeface="Cambria Math" panose="02040503050406030204" pitchFamily="18" charset="0"/>
+                            </a:rPr>
+                            <m:t>𝑡</m:t>
+                          </m:r>
+                        </m:sup>
+                      </m:sSubSup>
+                      <m:r>
+                        <a:rPr lang="fr-CA" b="0" i="0" smtClean="0">
+                          <a:solidFill>
+                            <a:srgbClr val="FFBF00"/>
+                          </a:solidFill>
+                          <a:latin typeface="Cambria Math" panose="02040503050406030204" pitchFamily="18" charset="0"/>
+                        </a:rPr>
+                        <m:t>=</m:t>
+                      </m:r>
+                      <m:f>
+                        <m:fPr>
+                          <m:ctrlPr>
+                            <a:rPr lang="fr-CA" b="0" i="1" smtClean="0">
+                              <a:solidFill>
+                                <a:srgbClr val="FFBF00"/>
+                              </a:solidFill>
+                              <a:latin typeface="Cambria Math" panose="02040503050406030204" pitchFamily="18" charset="0"/>
+                            </a:rPr>
+                          </m:ctrlPr>
+                        </m:fPr>
+                        <m:num>
+                          <m:r>
+                            <a:rPr lang="fr-CA" b="0" i="0" smtClean="0">
+                              <a:solidFill>
+                                <a:srgbClr val="FFBF00"/>
+                              </a:solidFill>
+                              <a:latin typeface="Cambria Math" panose="02040503050406030204" pitchFamily="18" charset="0"/>
+                            </a:rPr>
+                            <m:t>−1</m:t>
+                          </m:r>
+                        </m:num>
+                        <m:den>
+                          <m:r>
+                            <a:rPr lang="fr-CA" b="0" i="0" smtClean="0">
+                              <a:solidFill>
+                                <a:srgbClr val="FFBF00"/>
+                              </a:solidFill>
+                              <a:latin typeface="Cambria Math" panose="02040503050406030204" pitchFamily="18" charset="0"/>
+                            </a:rPr>
+                            <m:t>3</m:t>
+                          </m:r>
+                        </m:den>
+                      </m:f>
+                      <m:sSubSup>
+                        <m:sSubSupPr>
+                          <m:ctrlPr>
+                            <a:rPr lang="fr-CA" i="1">
+                              <a:solidFill>
+                                <a:srgbClr val="FFBF00"/>
+                              </a:solidFill>
+                              <a:latin typeface="Cambria Math" panose="02040503050406030204" pitchFamily="18" charset="0"/>
+                            </a:rPr>
+                          </m:ctrlPr>
+                        </m:sSubSupPr>
+                        <m:e>
+                          <m:r>
+                            <a:rPr lang="fr-CA" i="1">
+                              <a:solidFill>
+                                <a:srgbClr val="FFBF00"/>
+                              </a:solidFill>
+                              <a:latin typeface="Cambria Math" panose="02040503050406030204" pitchFamily="18" charset="0"/>
+                            </a:rPr>
+                            <m:t>𝑇</m:t>
+                          </m:r>
+                        </m:e>
+                        <m:sub>
+                          <m:r>
+                            <a:rPr lang="fr-CA" i="1">
+                              <a:solidFill>
+                                <a:srgbClr val="FFBF00"/>
+                              </a:solidFill>
+                              <a:latin typeface="Cambria Math" panose="02040503050406030204" pitchFamily="18" charset="0"/>
+                            </a:rPr>
+                            <m:t>𝑟</m:t>
+                          </m:r>
+                          <m:r>
+                            <a:rPr lang="fr-CA" i="1">
+                              <a:solidFill>
+                                <a:srgbClr val="FFBF00"/>
+                              </a:solidFill>
+                              <a:latin typeface="Cambria Math" panose="02040503050406030204" pitchFamily="18" charset="0"/>
+                            </a:rPr>
+                            <m:t>,</m:t>
+                          </m:r>
+                          <m:r>
+                            <a:rPr lang="fr-CA" i="1">
+                              <a:solidFill>
+                                <a:srgbClr val="FFBF00"/>
+                              </a:solidFill>
+                              <a:latin typeface="Cambria Math" panose="02040503050406030204" pitchFamily="18" charset="0"/>
+                            </a:rPr>
+                            <m:t>𝑧</m:t>
+                          </m:r>
+                          <m:r>
+                            <a:rPr lang="fr-CA" b="0" i="1" smtClean="0">
+                              <a:solidFill>
+                                <a:srgbClr val="FFBF00"/>
+                              </a:solidFill>
+                              <a:latin typeface="Cambria Math" panose="02040503050406030204" pitchFamily="18" charset="0"/>
+                            </a:rPr>
+                            <m:t>+2</m:t>
+                          </m:r>
+                        </m:sub>
+                        <m:sup>
+                          <m:r>
+                            <a:rPr lang="fr-CA" i="1">
+                              <a:solidFill>
+                                <a:srgbClr val="FFBF00"/>
+                              </a:solidFill>
+                              <a:latin typeface="Cambria Math" panose="02040503050406030204" pitchFamily="18" charset="0"/>
+                            </a:rPr>
+                            <m:t>𝑡</m:t>
+                          </m:r>
+                        </m:sup>
+                      </m:sSubSup>
+                      <m:r>
+                        <a:rPr lang="fr-CA" b="0" i="1" smtClean="0">
+                          <a:solidFill>
+                            <a:srgbClr val="FFBF00"/>
+                          </a:solidFill>
+                          <a:latin typeface="Cambria Math" panose="02040503050406030204" pitchFamily="18" charset="0"/>
+                          <a:ea typeface="Cambria Math" panose="02040503050406030204" pitchFamily="18" charset="0"/>
+                        </a:rPr>
+                        <m:t>+</m:t>
+                      </m:r>
+                      <m:f>
+                        <m:fPr>
+                          <m:ctrlPr>
+                            <a:rPr lang="fr-CA" b="0" i="1" smtClean="0">
+                              <a:solidFill>
+                                <a:srgbClr val="FFBF00"/>
+                              </a:solidFill>
+                              <a:latin typeface="Cambria Math" panose="02040503050406030204" pitchFamily="18" charset="0"/>
+                              <a:ea typeface="Cambria Math" panose="02040503050406030204" pitchFamily="18" charset="0"/>
+                            </a:rPr>
+                          </m:ctrlPr>
+                        </m:fPr>
+                        <m:num>
+                          <m:r>
+                            <a:rPr lang="fr-CA" b="0" i="1" smtClean="0">
+                              <a:solidFill>
+                                <a:srgbClr val="FFBF00"/>
+                              </a:solidFill>
+                              <a:latin typeface="Cambria Math" panose="02040503050406030204" pitchFamily="18" charset="0"/>
+                              <a:ea typeface="Cambria Math" panose="02040503050406030204" pitchFamily="18" charset="0"/>
+                            </a:rPr>
+                            <m:t>4</m:t>
+                          </m:r>
+                        </m:num>
+                        <m:den>
+                          <m:r>
+                            <a:rPr lang="fr-CA" b="0" i="1" smtClean="0">
+                              <a:solidFill>
+                                <a:srgbClr val="FFBF00"/>
+                              </a:solidFill>
+                              <a:latin typeface="Cambria Math" panose="02040503050406030204" pitchFamily="18" charset="0"/>
+                              <a:ea typeface="Cambria Math" panose="02040503050406030204" pitchFamily="18" charset="0"/>
+                            </a:rPr>
+                            <m:t>3</m:t>
+                          </m:r>
+                        </m:den>
+                      </m:f>
+                      <m:sSubSup>
+                        <m:sSubSupPr>
+                          <m:ctrlPr>
+                            <a:rPr lang="fr-CA" i="1">
+                              <a:solidFill>
+                                <a:srgbClr val="FFBF00"/>
+                              </a:solidFill>
+                              <a:latin typeface="Cambria Math" panose="02040503050406030204" pitchFamily="18" charset="0"/>
+                            </a:rPr>
+                          </m:ctrlPr>
+                        </m:sSubSupPr>
+                        <m:e>
+                          <m:r>
+                            <a:rPr lang="fr-CA" i="1">
+                              <a:solidFill>
+                                <a:srgbClr val="FFBF00"/>
+                              </a:solidFill>
+                              <a:latin typeface="Cambria Math" panose="02040503050406030204" pitchFamily="18" charset="0"/>
+                            </a:rPr>
+                            <m:t>𝑇</m:t>
+                          </m:r>
+                        </m:e>
+                        <m:sub>
+                          <m:r>
+                            <a:rPr lang="fr-CA" i="1">
+                              <a:solidFill>
+                                <a:srgbClr val="FFBF00"/>
+                              </a:solidFill>
+                              <a:latin typeface="Cambria Math" panose="02040503050406030204" pitchFamily="18" charset="0"/>
+                            </a:rPr>
+                            <m:t>𝑟</m:t>
+                          </m:r>
+                          <m:r>
+                            <a:rPr lang="fr-CA" i="1">
+                              <a:solidFill>
+                                <a:srgbClr val="FFBF00"/>
+                              </a:solidFill>
+                              <a:latin typeface="Cambria Math" panose="02040503050406030204" pitchFamily="18" charset="0"/>
+                            </a:rPr>
+                            <m:t>,</m:t>
+                          </m:r>
+                          <m:r>
+                            <a:rPr lang="fr-CA" i="1">
+                              <a:solidFill>
+                                <a:srgbClr val="FFBF00"/>
+                              </a:solidFill>
+                              <a:latin typeface="Cambria Math" panose="02040503050406030204" pitchFamily="18" charset="0"/>
+                            </a:rPr>
+                            <m:t>𝑧</m:t>
+                          </m:r>
+                          <m:r>
+                            <a:rPr lang="fr-CA" b="0" i="1" smtClean="0">
+                              <a:solidFill>
+                                <a:srgbClr val="FFBF00"/>
+                              </a:solidFill>
+                              <a:latin typeface="Cambria Math" panose="02040503050406030204" pitchFamily="18" charset="0"/>
+                            </a:rPr>
+                            <m:t>+1</m:t>
+                          </m:r>
+                        </m:sub>
+                        <m:sup>
+                          <m:r>
+                            <a:rPr lang="fr-CA" i="1">
+                              <a:solidFill>
+                                <a:srgbClr val="FFBF00"/>
+                              </a:solidFill>
+                              <a:latin typeface="Cambria Math" panose="02040503050406030204" pitchFamily="18" charset="0"/>
+                            </a:rPr>
+                            <m:t>𝑡</m:t>
+                          </m:r>
+                        </m:sup>
+                      </m:sSubSup>
+                    </m:oMath>
+                  </m:oMathPara>
+                </a14:m>
+                <a:endParaRPr lang="fr-CA" dirty="0">
+                  <a:solidFill>
+                    <a:srgbClr val="FFBF00"/>
+                  </a:solidFill>
+                </a:endParaRPr>
+              </a:p>
+            </p:txBody>
+          </p:sp>
+        </mc:Choice>
+        <mc:Fallback>
+          <p:sp>
+            <p:nvSpPr>
+              <p:cNvPr id="7" name="ZoneTexte 6">
+                <a:extLst>
+                  <a:ext uri="{FF2B5EF4-FFF2-40B4-BE49-F238E27FC236}">
+                    <a16:creationId xmlns:a16="http://schemas.microsoft.com/office/drawing/2014/main" id="{35B26447-C369-915B-101D-E4FC7C5D7482}"/>
+                  </a:ext>
+                </a:extLst>
+              </p:cNvPr>
+              <p:cNvSpPr txBox="1">
+                <a:spLocks noRot="1" noChangeAspect="1" noMove="1" noResize="1" noEditPoints="1" noAdjustHandles="1" noChangeArrowheads="1" noChangeShapeType="1" noTextEdit="1"/>
+              </p:cNvSpPr>
+              <p:nvPr/>
+            </p:nvSpPr>
+            <p:spPr>
+              <a:xfrm>
+                <a:off x="582168" y="2784657"/>
+                <a:ext cx="5897880" cy="1288686"/>
+              </a:xfrm>
+              <a:prstGeom prst="rect">
+                <a:avLst/>
+              </a:prstGeom>
+              <a:blipFill>
+                <a:blip r:embed="rId4"/>
+                <a:stretch>
+                  <a:fillRect l="-931" t="-2370"/>
+                </a:stretch>
+              </a:blipFill>
+            </p:spPr>
+            <p:txBody>
+              <a:bodyPr/>
+              <a:lstStyle/>
+              <a:p>
+                <a:r>
+                  <a:rPr lang="fr-CA">
+                    <a:noFill/>
+                  </a:rPr>
+                  <a:t> </a:t>
+                </a:r>
+              </a:p>
+            </p:txBody>
+          </p:sp>
+        </mc:Fallback>
+      </mc:AlternateContent>
+      <mc:AlternateContent xmlns:mc="http://schemas.openxmlformats.org/markup-compatibility/2006">
+        <mc:Choice xmlns:a14="http://schemas.microsoft.com/office/drawing/2010/main" Requires="a14">
+          <p:sp>
+            <p:nvSpPr>
+              <p:cNvPr id="8" name="ZoneTexte 7">
+                <a:extLst>
+                  <a:ext uri="{FF2B5EF4-FFF2-40B4-BE49-F238E27FC236}">
+                    <a16:creationId xmlns:a16="http://schemas.microsoft.com/office/drawing/2014/main" id="{B81FF01E-407B-CE8F-80F4-CFC728E6CA10}"/>
+                  </a:ext>
+                </a:extLst>
+              </p:cNvPr>
+              <p:cNvSpPr txBox="1"/>
+              <p:nvPr/>
+            </p:nvSpPr>
+            <p:spPr>
+              <a:xfrm>
+                <a:off x="5803392" y="1268922"/>
+                <a:ext cx="6141720" cy="1869614"/>
+              </a:xfrm>
+              <a:prstGeom prst="rect">
+                <a:avLst/>
+              </a:prstGeom>
+              <a:noFill/>
+            </p:spPr>
+            <p:txBody>
+              <a:bodyPr wrap="square" rtlCol="0">
+                <a:spAutoFit/>
+              </a:bodyPr>
+              <a:lstStyle/>
+              <a:p>
+                <a:r>
+                  <a:rPr lang="fr-CA" dirty="0">
+                    <a:solidFill>
+                      <a:srgbClr val="5B9BD5"/>
+                    </a:solidFill>
+                  </a:rPr>
+                  <a:t>Condition de robin, convection-radiation :</a:t>
+                </a:r>
+              </a:p>
+              <a:p>
+                <a:pPr algn="ctr">
+                  <a:spcBef>
+                    <a:spcPts val="1800"/>
+                  </a:spcBef>
+                </a:pPr>
+                <a:r>
+                  <a:rPr lang="fr-CA" dirty="0">
+                    <a:solidFill>
+                      <a:srgbClr val="5B9BD5"/>
+                    </a:solidFill>
+                  </a:rPr>
+                  <a:t>	</a:t>
+                </a:r>
+                <a14:m>
+                  <m:oMath xmlns:m="http://schemas.openxmlformats.org/officeDocument/2006/math">
+                    <m:r>
+                      <a:rPr lang="fr-FR" i="1" smtClean="0">
+                        <a:solidFill>
+                          <a:srgbClr val="5B9BD5"/>
+                        </a:solidFill>
+                        <a:latin typeface="Cambria Math" panose="02040503050406030204" pitchFamily="18" charset="0"/>
+                      </a:rPr>
+                      <m:t>−</m:t>
+                    </m:r>
+                    <m:r>
+                      <a:rPr lang="fr-FR" i="1" smtClean="0">
+                        <a:solidFill>
+                          <a:srgbClr val="5B9BD5"/>
+                        </a:solidFill>
+                        <a:latin typeface="Cambria Math" panose="02040503050406030204" pitchFamily="18" charset="0"/>
+                      </a:rPr>
+                      <m:t>𝑘</m:t>
+                    </m:r>
+                    <m:r>
+                      <m:rPr>
+                        <m:sty m:val="p"/>
+                      </m:rPr>
+                      <a:rPr lang="fr-FR" i="1" smtClean="0">
+                        <a:solidFill>
+                          <a:srgbClr val="5B9BD5"/>
+                        </a:solidFill>
+                        <a:latin typeface="Cambria Math" panose="02040503050406030204" pitchFamily="18" charset="0"/>
+                      </a:rPr>
+                      <m:t>∇</m:t>
+                    </m:r>
+                    <m:r>
+                      <a:rPr lang="fr-FR" i="1" smtClean="0">
+                        <a:solidFill>
+                          <a:srgbClr val="5B9BD5"/>
+                        </a:solidFill>
+                        <a:latin typeface="Cambria Math" panose="02040503050406030204" pitchFamily="18" charset="0"/>
+                      </a:rPr>
+                      <m:t>𝑇</m:t>
+                    </m:r>
+                    <m:r>
+                      <a:rPr lang="fr-FR" i="1" smtClean="0">
+                        <a:solidFill>
+                          <a:srgbClr val="5B9BD5"/>
+                        </a:solidFill>
+                        <a:latin typeface="Cambria Math" panose="02040503050406030204" pitchFamily="18" charset="0"/>
+                      </a:rPr>
+                      <m:t>.</m:t>
+                    </m:r>
+                    <m:acc>
+                      <m:accPr>
+                        <m:chr m:val="⃗"/>
+                        <m:ctrlPr>
+                          <a:rPr lang="fr-FR" i="1" smtClean="0">
+                            <a:solidFill>
+                              <a:srgbClr val="5B9BD5"/>
+                            </a:solidFill>
+                            <a:latin typeface="Cambria Math" panose="02040503050406030204" pitchFamily="18" charset="0"/>
+                          </a:rPr>
+                        </m:ctrlPr>
+                      </m:accPr>
+                      <m:e>
+                        <m:r>
+                          <a:rPr lang="fr-CA" b="0" i="1" smtClean="0">
+                            <a:solidFill>
+                              <a:srgbClr val="5B9BD5"/>
+                            </a:solidFill>
+                            <a:latin typeface="Cambria Math" panose="02040503050406030204" pitchFamily="18" charset="0"/>
+                          </a:rPr>
+                          <m:t>𝑛</m:t>
+                        </m:r>
+                      </m:e>
+                    </m:acc>
+                    <m:r>
+                      <a:rPr lang="fr-FR" i="1" smtClean="0">
+                        <a:solidFill>
+                          <a:srgbClr val="5B9BD5"/>
+                        </a:solidFill>
+                        <a:latin typeface="Cambria Math" panose="02040503050406030204" pitchFamily="18" charset="0"/>
+                      </a:rPr>
+                      <m:t>=</m:t>
+                    </m:r>
+                    <m:r>
+                      <a:rPr lang="fr-FR" i="1" smtClean="0">
+                        <a:solidFill>
+                          <a:srgbClr val="5B9BD5"/>
+                        </a:solidFill>
+                        <a:latin typeface="Cambria Math" panose="02040503050406030204" pitchFamily="18" charset="0"/>
+                      </a:rPr>
+                      <m:t>h</m:t>
+                    </m:r>
+                    <m:d>
+                      <m:dPr>
+                        <m:ctrlPr>
+                          <a:rPr lang="fr-FR" i="1">
+                            <a:solidFill>
+                              <a:srgbClr val="5B9BD5"/>
+                            </a:solidFill>
+                            <a:latin typeface="Cambria Math" panose="02040503050406030204" pitchFamily="18" charset="0"/>
+                          </a:rPr>
+                        </m:ctrlPr>
+                      </m:dPr>
+                      <m:e>
+                        <m:r>
+                          <a:rPr lang="fr-FR" i="1">
+                            <a:solidFill>
+                              <a:srgbClr val="5B9BD5"/>
+                            </a:solidFill>
+                            <a:latin typeface="Cambria Math" panose="02040503050406030204" pitchFamily="18" charset="0"/>
+                          </a:rPr>
+                          <m:t>𝑇</m:t>
+                        </m:r>
+                        <m:r>
+                          <a:rPr lang="fr-FR" i="1">
+                            <a:solidFill>
+                              <a:srgbClr val="5B9BD5"/>
+                            </a:solidFill>
+                            <a:latin typeface="Cambria Math" panose="02040503050406030204" pitchFamily="18" charset="0"/>
+                          </a:rPr>
+                          <m:t>−</m:t>
+                        </m:r>
+                        <m:sSub>
+                          <m:sSubPr>
+                            <m:ctrlPr>
+                              <a:rPr lang="fr-FR" i="1">
+                                <a:solidFill>
+                                  <a:srgbClr val="5B9BD5"/>
+                                </a:solidFill>
+                                <a:latin typeface="Cambria Math" panose="02040503050406030204" pitchFamily="18" charset="0"/>
+                              </a:rPr>
+                            </m:ctrlPr>
+                          </m:sSubPr>
+                          <m:e>
+                            <m:r>
+                              <a:rPr lang="fr-FR" i="1">
+                                <a:solidFill>
+                                  <a:srgbClr val="5B9BD5"/>
+                                </a:solidFill>
+                                <a:latin typeface="Cambria Math" panose="02040503050406030204" pitchFamily="18" charset="0"/>
+                              </a:rPr>
+                              <m:t>𝑇</m:t>
+                            </m:r>
+                          </m:e>
+                          <m:sub>
+                            <m:r>
+                              <a:rPr lang="fr-FR" i="1">
+                                <a:solidFill>
+                                  <a:srgbClr val="5B9BD5"/>
+                                </a:solidFill>
+                                <a:latin typeface="Cambria Math" panose="02040503050406030204" pitchFamily="18" charset="0"/>
+                              </a:rPr>
+                              <m:t>∞</m:t>
+                            </m:r>
+                            <m:r>
+                              <m:rPr>
+                                <m:nor/>
+                              </m:rPr>
+                              <a:rPr lang="fr-FR" dirty="0">
+                                <a:solidFill>
+                                  <a:srgbClr val="5B9BD5"/>
+                                </a:solidFill>
+                              </a:rPr>
+                              <m:t> </m:t>
+                            </m:r>
+                          </m:sub>
+                        </m:sSub>
+                      </m:e>
+                    </m:d>
+                    <m:r>
+                      <a:rPr lang="fr-FR" i="1">
+                        <a:solidFill>
+                          <a:srgbClr val="5B9BD5"/>
+                        </a:solidFill>
+                        <a:latin typeface="Cambria Math" panose="02040503050406030204" pitchFamily="18" charset="0"/>
+                      </a:rPr>
+                      <m:t>+</m:t>
+                    </m:r>
+                    <m:r>
+                      <m:rPr>
+                        <m:sty m:val="p"/>
+                      </m:rPr>
+                      <a:rPr lang="fr-FR" i="1">
+                        <a:solidFill>
+                          <a:srgbClr val="5B9BD5"/>
+                        </a:solidFill>
+                        <a:latin typeface="Cambria Math" panose="02040503050406030204" pitchFamily="18" charset="0"/>
+                      </a:rPr>
+                      <m:t>ϵσ</m:t>
+                    </m:r>
+                    <m:r>
+                      <a:rPr lang="fr-FR" i="1">
+                        <a:solidFill>
+                          <a:srgbClr val="5B9BD5"/>
+                        </a:solidFill>
+                        <a:latin typeface="Cambria Math" panose="02040503050406030204" pitchFamily="18" charset="0"/>
+                      </a:rPr>
+                      <m:t>(</m:t>
+                    </m:r>
+                    <m:sSup>
+                      <m:sSupPr>
+                        <m:ctrlPr>
+                          <a:rPr lang="fr-FR" i="1">
+                            <a:solidFill>
+                              <a:srgbClr val="5B9BD5"/>
+                            </a:solidFill>
+                            <a:latin typeface="Cambria Math" panose="02040503050406030204" pitchFamily="18" charset="0"/>
+                          </a:rPr>
+                        </m:ctrlPr>
+                      </m:sSupPr>
+                      <m:e>
+                        <m:r>
+                          <a:rPr lang="fr-FR" i="1">
+                            <a:solidFill>
+                              <a:srgbClr val="5B9BD5"/>
+                            </a:solidFill>
+                            <a:latin typeface="Cambria Math" panose="02040503050406030204" pitchFamily="18" charset="0"/>
+                          </a:rPr>
+                          <m:t>𝑇</m:t>
+                        </m:r>
+                      </m:e>
+                      <m:sup>
+                        <m:r>
+                          <a:rPr lang="fr-FR" i="1">
+                            <a:solidFill>
+                              <a:srgbClr val="5B9BD5"/>
+                            </a:solidFill>
+                            <a:latin typeface="Cambria Math" panose="02040503050406030204" pitchFamily="18" charset="0"/>
+                          </a:rPr>
+                          <m:t>4</m:t>
+                        </m:r>
+                      </m:sup>
+                    </m:sSup>
+                    <m:r>
+                      <a:rPr lang="fr-FR" i="1">
+                        <a:solidFill>
+                          <a:srgbClr val="5B9BD5"/>
+                        </a:solidFill>
+                        <a:latin typeface="Cambria Math" panose="02040503050406030204" pitchFamily="18" charset="0"/>
+                      </a:rPr>
+                      <m:t>−</m:t>
+                    </m:r>
+                    <m:sSubSup>
+                      <m:sSubSupPr>
+                        <m:ctrlPr>
+                          <a:rPr lang="fr-FR" i="1">
+                            <a:solidFill>
+                              <a:srgbClr val="5B9BD5"/>
+                            </a:solidFill>
+                            <a:latin typeface="Cambria Math" panose="02040503050406030204" pitchFamily="18" charset="0"/>
+                          </a:rPr>
+                        </m:ctrlPr>
+                      </m:sSubSupPr>
+                      <m:e>
+                        <m:r>
+                          <a:rPr lang="fr-FR" i="1">
+                            <a:solidFill>
+                              <a:srgbClr val="5B9BD5"/>
+                            </a:solidFill>
+                            <a:latin typeface="Cambria Math" panose="02040503050406030204" pitchFamily="18" charset="0"/>
+                          </a:rPr>
+                          <m:t>𝑇</m:t>
+                        </m:r>
+                      </m:e>
+                      <m:sub>
+                        <m:r>
+                          <a:rPr lang="fr-FR" i="1">
+                            <a:solidFill>
+                              <a:srgbClr val="5B9BD5"/>
+                            </a:solidFill>
+                            <a:latin typeface="Cambria Math" panose="02040503050406030204" pitchFamily="18" charset="0"/>
+                          </a:rPr>
+                          <m:t>∞</m:t>
+                        </m:r>
+                      </m:sub>
+                      <m:sup>
+                        <m:r>
+                          <a:rPr lang="fr-FR" i="1">
+                            <a:solidFill>
+                              <a:srgbClr val="5B9BD5"/>
+                            </a:solidFill>
+                            <a:latin typeface="Cambria Math" panose="02040503050406030204" pitchFamily="18" charset="0"/>
+                          </a:rPr>
+                          <m:t>4</m:t>
+                        </m:r>
+                      </m:sup>
+                    </m:sSubSup>
+                    <m:r>
+                      <a:rPr lang="fr-FR" i="1">
+                        <a:solidFill>
+                          <a:srgbClr val="5B9BD5"/>
+                        </a:solidFill>
+                        <a:latin typeface="Cambria Math" panose="02040503050406030204" pitchFamily="18" charset="0"/>
+                      </a:rPr>
+                      <m:t>)</m:t>
+                    </m:r>
+                  </m:oMath>
+                </a14:m>
+                <a:endParaRPr lang="fr-FR" dirty="0">
+                  <a:solidFill>
+                    <a:srgbClr val="5B9BD5"/>
+                  </a:solidFill>
+                </a:endParaRPr>
+              </a:p>
+              <a:p>
+                <a:pPr algn="ctr"/>
+                <a14:m>
+                  <m:oMath xmlns:m="http://schemas.openxmlformats.org/officeDocument/2006/math">
+                    <m:sSubSup>
+                      <m:sSubSupPr>
+                        <m:ctrlPr>
+                          <a:rPr lang="fr-CA" b="0" i="1" smtClean="0">
+                            <a:solidFill>
+                              <a:srgbClr val="5B9BD5"/>
+                            </a:solidFill>
+                            <a:latin typeface="Cambria Math" panose="02040503050406030204" pitchFamily="18" charset="0"/>
+                          </a:rPr>
+                        </m:ctrlPr>
+                      </m:sSubSupPr>
+                      <m:e>
+                        <m:r>
+                          <a:rPr lang="fr-CA" b="0" i="1" smtClean="0">
+                            <a:solidFill>
+                              <a:srgbClr val="5B9BD5"/>
+                            </a:solidFill>
+                            <a:latin typeface="Cambria Math" panose="02040503050406030204" pitchFamily="18" charset="0"/>
+                          </a:rPr>
+                          <m:t>𝑇</m:t>
+                        </m:r>
+                      </m:e>
+                      <m:sub>
+                        <m:r>
+                          <a:rPr lang="fr-CA" b="0" i="1" smtClean="0">
+                            <a:solidFill>
+                              <a:srgbClr val="5B9BD5"/>
+                            </a:solidFill>
+                            <a:latin typeface="Cambria Math" panose="02040503050406030204" pitchFamily="18" charset="0"/>
+                          </a:rPr>
+                          <m:t>𝑟</m:t>
+                        </m:r>
+                        <m:r>
+                          <a:rPr lang="fr-CA" b="0" i="1" smtClean="0">
+                            <a:solidFill>
+                              <a:srgbClr val="5B9BD5"/>
+                            </a:solidFill>
+                            <a:latin typeface="Cambria Math" panose="02040503050406030204" pitchFamily="18" charset="0"/>
+                          </a:rPr>
+                          <m:t>,</m:t>
+                        </m:r>
+                        <m:r>
+                          <a:rPr lang="fr-CA" b="0" i="1" smtClean="0">
+                            <a:solidFill>
+                              <a:srgbClr val="5B9BD5"/>
+                            </a:solidFill>
+                            <a:latin typeface="Cambria Math" panose="02040503050406030204" pitchFamily="18" charset="0"/>
+                          </a:rPr>
+                          <m:t>𝑧</m:t>
+                        </m:r>
+                      </m:sub>
+                      <m:sup>
+                        <m:r>
+                          <a:rPr lang="fr-CA" b="0" i="1" smtClean="0">
+                            <a:solidFill>
+                              <a:srgbClr val="5B9BD5"/>
+                            </a:solidFill>
+                            <a:latin typeface="Cambria Math" panose="02040503050406030204" pitchFamily="18" charset="0"/>
+                          </a:rPr>
+                          <m:t>𝑡</m:t>
+                        </m:r>
+                        <m:r>
+                          <a:rPr lang="fr-CA" b="0" i="1" smtClean="0">
+                            <a:solidFill>
+                              <a:srgbClr val="5B9BD5"/>
+                            </a:solidFill>
+                            <a:latin typeface="Cambria Math" panose="02040503050406030204" pitchFamily="18" charset="0"/>
+                          </a:rPr>
+                          <m:t>+∆</m:t>
+                        </m:r>
+                        <m:r>
+                          <a:rPr lang="fr-CA" b="0" i="1" smtClean="0">
+                            <a:solidFill>
+                              <a:srgbClr val="5B9BD5"/>
+                            </a:solidFill>
+                            <a:latin typeface="Cambria Math" panose="02040503050406030204" pitchFamily="18" charset="0"/>
+                            <a:ea typeface="Cambria Math" panose="02040503050406030204" pitchFamily="18" charset="0"/>
+                          </a:rPr>
+                          <m:t>𝑡</m:t>
+                        </m:r>
+                      </m:sup>
+                    </m:sSubSup>
+                    <m:r>
+                      <a:rPr lang="fr-CA" b="0" i="0" smtClean="0">
+                        <a:solidFill>
+                          <a:srgbClr val="5B9BD5"/>
+                        </a:solidFill>
+                        <a:latin typeface="Cambria Math" panose="02040503050406030204" pitchFamily="18" charset="0"/>
+                      </a:rPr>
+                      <m:t>=</m:t>
+                    </m:r>
+                    <m:r>
+                      <a:rPr lang="fr-CA" b="0" i="0" smtClean="0">
+                        <a:solidFill>
+                          <a:srgbClr val="5B9BD5"/>
+                        </a:solidFill>
+                        <a:latin typeface="Cambria Math" panose="02040503050406030204" pitchFamily="18" charset="0"/>
+                      </a:rPr>
+                      <m:t>[</m:t>
+                    </m:r>
+                    <m:d>
+                      <m:dPr>
+                        <m:ctrlPr>
+                          <a:rPr lang="fr-CA" b="0" i="0" smtClean="0">
+                            <a:solidFill>
+                              <a:srgbClr val="5B9BD5"/>
+                            </a:solidFill>
+                            <a:latin typeface="Cambria Math" panose="02040503050406030204" pitchFamily="18" charset="0"/>
+                          </a:rPr>
+                        </m:ctrlPr>
+                      </m:dPr>
+                      <m:e>
+                        <m:f>
+                          <m:fPr>
+                            <m:ctrlPr>
+                              <a:rPr lang="fr-CA" b="0" i="0" smtClean="0">
+                                <a:solidFill>
+                                  <a:srgbClr val="5B9BD5"/>
+                                </a:solidFill>
+                                <a:latin typeface="Cambria Math" panose="02040503050406030204" pitchFamily="18" charset="0"/>
+                              </a:rPr>
+                            </m:ctrlPr>
+                          </m:fPr>
+                          <m:num>
+                            <m:r>
+                              <a:rPr lang="fr-CA" b="0" i="0" smtClean="0">
+                                <a:solidFill>
+                                  <a:srgbClr val="5B9BD5"/>
+                                </a:solidFill>
+                                <a:latin typeface="Cambria Math" panose="02040503050406030204" pitchFamily="18" charset="0"/>
+                              </a:rPr>
+                              <m:t>−2</m:t>
+                            </m:r>
+                            <m:r>
+                              <a:rPr lang="fr-CA" b="0" i="1" smtClean="0">
+                                <a:solidFill>
+                                  <a:srgbClr val="5B9BD5"/>
+                                </a:solidFill>
+                                <a:latin typeface="Cambria Math" panose="02040503050406030204" pitchFamily="18" charset="0"/>
+                              </a:rPr>
+                              <m:t>∆</m:t>
+                            </m:r>
+                            <m:r>
+                              <m:rPr>
+                                <m:sty m:val="p"/>
+                              </m:rPr>
+                              <a:rPr lang="fr-CA" b="0" i="0" smtClean="0">
+                                <a:solidFill>
+                                  <a:srgbClr val="5B9BD5"/>
+                                </a:solidFill>
+                                <a:latin typeface="Cambria Math" panose="02040503050406030204" pitchFamily="18" charset="0"/>
+                              </a:rPr>
+                              <m:t>z</m:t>
+                            </m:r>
+                          </m:num>
+                          <m:den>
+                            <m:r>
+                              <m:rPr>
+                                <m:sty m:val="p"/>
+                              </m:rPr>
+                              <a:rPr lang="fr-CA" b="0" i="0" smtClean="0">
+                                <a:solidFill>
+                                  <a:srgbClr val="5B9BD5"/>
+                                </a:solidFill>
+                                <a:latin typeface="Cambria Math" panose="02040503050406030204" pitchFamily="18" charset="0"/>
+                              </a:rPr>
+                              <m:t>k</m:t>
+                            </m:r>
+                          </m:den>
+                        </m:f>
+                      </m:e>
+                    </m:d>
+                    <m:r>
+                      <a:rPr lang="fr-CA" b="0" i="0" smtClean="0">
+                        <a:solidFill>
+                          <a:srgbClr val="5B9BD5"/>
+                        </a:solidFill>
+                        <a:latin typeface="Cambria Math" panose="02040503050406030204" pitchFamily="18" charset="0"/>
+                      </a:rPr>
+                      <m:t>∗(</m:t>
+                    </m:r>
+                    <m:r>
+                      <m:rPr>
+                        <m:sty m:val="p"/>
+                      </m:rPr>
+                      <a:rPr lang="fr-CA" b="0" i="0" smtClean="0">
+                        <a:solidFill>
+                          <a:srgbClr val="5B9BD5"/>
+                        </a:solidFill>
+                        <a:latin typeface="Cambria Math" panose="02040503050406030204" pitchFamily="18" charset="0"/>
+                      </a:rPr>
+                      <m:t>h</m:t>
+                    </m:r>
+                    <m:r>
+                      <a:rPr lang="fr-CA" b="0" i="0" smtClean="0">
+                        <a:solidFill>
+                          <a:srgbClr val="5B9BD5"/>
+                        </a:solidFill>
+                        <a:latin typeface="Cambria Math" panose="02040503050406030204" pitchFamily="18" charset="0"/>
+                      </a:rPr>
+                      <m:t>(</m:t>
+                    </m:r>
+                    <m:sSubSup>
+                      <m:sSubSupPr>
+                        <m:ctrlPr>
+                          <a:rPr lang="fr-CA" i="1">
+                            <a:solidFill>
+                              <a:srgbClr val="5B9BD5"/>
+                            </a:solidFill>
+                            <a:latin typeface="Cambria Math" panose="02040503050406030204" pitchFamily="18" charset="0"/>
+                          </a:rPr>
+                        </m:ctrlPr>
+                      </m:sSubSupPr>
+                      <m:e>
+                        <m:r>
+                          <a:rPr lang="fr-CA" i="1">
+                            <a:solidFill>
+                              <a:srgbClr val="5B9BD5"/>
+                            </a:solidFill>
+                            <a:latin typeface="Cambria Math" panose="02040503050406030204" pitchFamily="18" charset="0"/>
+                          </a:rPr>
+                          <m:t>𝑇</m:t>
+                        </m:r>
+                      </m:e>
+                      <m:sub>
+                        <m:r>
+                          <a:rPr lang="fr-CA" i="1">
+                            <a:solidFill>
+                              <a:srgbClr val="5B9BD5"/>
+                            </a:solidFill>
+                            <a:latin typeface="Cambria Math" panose="02040503050406030204" pitchFamily="18" charset="0"/>
+                          </a:rPr>
+                          <m:t>𝑟</m:t>
+                        </m:r>
+                        <m:r>
+                          <a:rPr lang="fr-CA" i="1">
+                            <a:solidFill>
+                              <a:srgbClr val="5B9BD5"/>
+                            </a:solidFill>
+                            <a:latin typeface="Cambria Math" panose="02040503050406030204" pitchFamily="18" charset="0"/>
+                          </a:rPr>
+                          <m:t>,</m:t>
+                        </m:r>
+                        <m:r>
+                          <a:rPr lang="fr-CA" i="1">
+                            <a:solidFill>
+                              <a:srgbClr val="5B9BD5"/>
+                            </a:solidFill>
+                            <a:latin typeface="Cambria Math" panose="02040503050406030204" pitchFamily="18" charset="0"/>
+                          </a:rPr>
+                          <m:t>𝑧</m:t>
+                        </m:r>
+                      </m:sub>
+                      <m:sup>
+                        <m:r>
+                          <a:rPr lang="fr-CA" b="0" i="1" smtClean="0">
+                            <a:solidFill>
+                              <a:srgbClr val="5B9BD5"/>
+                            </a:solidFill>
+                            <a:latin typeface="Cambria Math" panose="02040503050406030204" pitchFamily="18" charset="0"/>
+                          </a:rPr>
+                          <m:t>𝑡</m:t>
+                        </m:r>
+                      </m:sup>
+                    </m:sSubSup>
+                  </m:oMath>
+                </a14:m>
+                <a:r>
+                  <a:rPr lang="fr-CA" dirty="0">
+                    <a:solidFill>
+                      <a:srgbClr val="5B9BD5"/>
+                    </a:solidFill>
+                  </a:rPr>
+                  <a:t>-</a:t>
+                </a:r>
+                <a:r>
+                  <a:rPr lang="fr-FR" dirty="0">
+                    <a:solidFill>
+                      <a:srgbClr val="5B9BD5"/>
+                    </a:solidFill>
+                  </a:rPr>
+                  <a:t> </a:t>
+                </a:r>
+                <a14:m>
+                  <m:oMath xmlns:m="http://schemas.openxmlformats.org/officeDocument/2006/math">
+                    <m:sSub>
+                      <m:sSubPr>
+                        <m:ctrlPr>
+                          <a:rPr lang="fr-FR" i="1">
+                            <a:solidFill>
+                              <a:srgbClr val="5B9BD5"/>
+                            </a:solidFill>
+                            <a:latin typeface="Cambria Math" panose="02040503050406030204" pitchFamily="18" charset="0"/>
+                          </a:rPr>
+                        </m:ctrlPr>
+                      </m:sSubPr>
+                      <m:e>
+                        <m:r>
+                          <a:rPr lang="fr-FR" i="1">
+                            <a:solidFill>
+                              <a:srgbClr val="5B9BD5"/>
+                            </a:solidFill>
+                            <a:latin typeface="Cambria Math" panose="02040503050406030204" pitchFamily="18" charset="0"/>
+                          </a:rPr>
+                          <m:t>𝑇</m:t>
+                        </m:r>
+                      </m:e>
+                      <m:sub>
+                        <m:r>
+                          <a:rPr lang="fr-FR" i="1">
+                            <a:solidFill>
+                              <a:srgbClr val="5B9BD5"/>
+                            </a:solidFill>
+                            <a:latin typeface="Cambria Math" panose="02040503050406030204" pitchFamily="18" charset="0"/>
+                          </a:rPr>
+                          <m:t>∞</m:t>
+                        </m:r>
+                        <m:r>
+                          <m:rPr>
+                            <m:nor/>
+                          </m:rPr>
+                          <a:rPr lang="fr-FR" dirty="0">
+                            <a:solidFill>
+                              <a:srgbClr val="5B9BD5"/>
+                            </a:solidFill>
+                          </a:rPr>
+                          <m:t> </m:t>
+                        </m:r>
+                      </m:sub>
+                    </m:sSub>
+                    <m:r>
+                      <a:rPr lang="fr-CA" b="0" i="1" dirty="0" smtClean="0">
+                        <a:solidFill>
+                          <a:srgbClr val="5B9BD5"/>
+                        </a:solidFill>
+                        <a:latin typeface="Cambria Math" panose="02040503050406030204" pitchFamily="18" charset="0"/>
+                      </a:rPr>
+                      <m:t>)</m:t>
+                    </m:r>
+                  </m:oMath>
+                </a14:m>
+                <a:r>
+                  <a:rPr lang="fr-CA" dirty="0">
+                    <a:solidFill>
+                      <a:srgbClr val="5B9BD5"/>
+                    </a:solidFill>
+                  </a:rPr>
+                  <a:t> + </a:t>
+                </a:r>
+                <a14:m>
+                  <m:oMath xmlns:m="http://schemas.openxmlformats.org/officeDocument/2006/math">
+                    <m:r>
+                      <m:rPr>
+                        <m:sty m:val="p"/>
+                      </m:rPr>
+                      <a:rPr lang="fr-FR" i="1">
+                        <a:solidFill>
+                          <a:srgbClr val="5B9BD5"/>
+                        </a:solidFill>
+                        <a:latin typeface="Cambria Math" panose="02040503050406030204" pitchFamily="18" charset="0"/>
+                      </a:rPr>
+                      <m:t>ϵσ</m:t>
+                    </m:r>
+                    <m:r>
+                      <a:rPr lang="fr-FR" i="1">
+                        <a:solidFill>
+                          <a:srgbClr val="5B9BD5"/>
+                        </a:solidFill>
+                        <a:latin typeface="Cambria Math" panose="02040503050406030204" pitchFamily="18" charset="0"/>
+                      </a:rPr>
+                      <m:t>(</m:t>
+                    </m:r>
+                    <m:sSup>
+                      <m:sSupPr>
+                        <m:ctrlPr>
+                          <a:rPr lang="fr-FR" i="1">
+                            <a:solidFill>
+                              <a:srgbClr val="5B9BD5"/>
+                            </a:solidFill>
+                            <a:latin typeface="Cambria Math" panose="02040503050406030204" pitchFamily="18" charset="0"/>
+                          </a:rPr>
+                        </m:ctrlPr>
+                      </m:sSupPr>
+                      <m:e>
+                        <m:sSubSup>
+                          <m:sSubSupPr>
+                            <m:ctrlPr>
+                              <a:rPr lang="fr-CA" i="1">
+                                <a:solidFill>
+                                  <a:srgbClr val="5B9BD5"/>
+                                </a:solidFill>
+                                <a:latin typeface="Cambria Math" panose="02040503050406030204" pitchFamily="18" charset="0"/>
+                              </a:rPr>
+                            </m:ctrlPr>
+                          </m:sSubSupPr>
+                          <m:e>
+                            <m:r>
+                              <a:rPr lang="fr-CA" i="1">
+                                <a:solidFill>
+                                  <a:srgbClr val="5B9BD5"/>
+                                </a:solidFill>
+                                <a:latin typeface="Cambria Math" panose="02040503050406030204" pitchFamily="18" charset="0"/>
+                              </a:rPr>
+                              <m:t>𝑇</m:t>
+                            </m:r>
+                          </m:e>
+                          <m:sub>
+                            <m:r>
+                              <a:rPr lang="fr-CA" i="1">
+                                <a:solidFill>
+                                  <a:srgbClr val="5B9BD5"/>
+                                </a:solidFill>
+                                <a:latin typeface="Cambria Math" panose="02040503050406030204" pitchFamily="18" charset="0"/>
+                              </a:rPr>
+                              <m:t>𝑟</m:t>
+                            </m:r>
+                            <m:r>
+                              <a:rPr lang="fr-CA" i="1">
+                                <a:solidFill>
+                                  <a:srgbClr val="5B9BD5"/>
+                                </a:solidFill>
+                                <a:latin typeface="Cambria Math" panose="02040503050406030204" pitchFamily="18" charset="0"/>
+                              </a:rPr>
+                              <m:t>,</m:t>
+                            </m:r>
+                            <m:r>
+                              <a:rPr lang="fr-CA" i="1">
+                                <a:solidFill>
+                                  <a:srgbClr val="5B9BD5"/>
+                                </a:solidFill>
+                                <a:latin typeface="Cambria Math" panose="02040503050406030204" pitchFamily="18" charset="0"/>
+                              </a:rPr>
+                              <m:t>𝑧</m:t>
+                            </m:r>
+                          </m:sub>
+                          <m:sup>
+                            <m:r>
+                              <a:rPr lang="fr-CA" i="1">
+                                <a:solidFill>
+                                  <a:srgbClr val="5B9BD5"/>
+                                </a:solidFill>
+                                <a:latin typeface="Cambria Math" panose="02040503050406030204" pitchFamily="18" charset="0"/>
+                              </a:rPr>
+                              <m:t>𝑡</m:t>
+                            </m:r>
+                          </m:sup>
+                        </m:sSubSup>
+                      </m:e>
+                      <m:sup>
+                        <m:r>
+                          <a:rPr lang="fr-FR" i="1">
+                            <a:solidFill>
+                              <a:srgbClr val="5B9BD5"/>
+                            </a:solidFill>
+                            <a:latin typeface="Cambria Math" panose="02040503050406030204" pitchFamily="18" charset="0"/>
+                          </a:rPr>
+                          <m:t>4</m:t>
+                        </m:r>
+                      </m:sup>
+                    </m:sSup>
+                    <m:r>
+                      <a:rPr lang="fr-FR" i="1">
+                        <a:solidFill>
+                          <a:srgbClr val="5B9BD5"/>
+                        </a:solidFill>
+                        <a:latin typeface="Cambria Math" panose="02040503050406030204" pitchFamily="18" charset="0"/>
+                      </a:rPr>
+                      <m:t>−</m:t>
+                    </m:r>
+                    <m:sSubSup>
+                      <m:sSubSupPr>
+                        <m:ctrlPr>
+                          <a:rPr lang="fr-FR" i="1">
+                            <a:solidFill>
+                              <a:srgbClr val="5B9BD5"/>
+                            </a:solidFill>
+                            <a:latin typeface="Cambria Math" panose="02040503050406030204" pitchFamily="18" charset="0"/>
+                          </a:rPr>
+                        </m:ctrlPr>
+                      </m:sSubSupPr>
+                      <m:e>
+                        <m:r>
+                          <a:rPr lang="fr-FR" i="1">
+                            <a:solidFill>
+                              <a:srgbClr val="5B9BD5"/>
+                            </a:solidFill>
+                            <a:latin typeface="Cambria Math" panose="02040503050406030204" pitchFamily="18" charset="0"/>
+                          </a:rPr>
+                          <m:t>𝑇</m:t>
+                        </m:r>
+                      </m:e>
+                      <m:sub>
+                        <m:r>
+                          <a:rPr lang="fr-FR" i="1">
+                            <a:solidFill>
+                              <a:srgbClr val="5B9BD5"/>
+                            </a:solidFill>
+                            <a:latin typeface="Cambria Math" panose="02040503050406030204" pitchFamily="18" charset="0"/>
+                          </a:rPr>
+                          <m:t>∞</m:t>
+                        </m:r>
+                      </m:sub>
+                      <m:sup>
+                        <m:r>
+                          <a:rPr lang="fr-FR" i="1">
+                            <a:solidFill>
+                              <a:srgbClr val="5B9BD5"/>
+                            </a:solidFill>
+                            <a:latin typeface="Cambria Math" panose="02040503050406030204" pitchFamily="18" charset="0"/>
+                          </a:rPr>
+                          <m:t>4</m:t>
+                        </m:r>
+                      </m:sup>
+                    </m:sSubSup>
+                    <m:r>
+                      <a:rPr lang="fr-FR" i="1">
+                        <a:solidFill>
+                          <a:srgbClr val="5B9BD5"/>
+                        </a:solidFill>
+                        <a:latin typeface="Cambria Math" panose="02040503050406030204" pitchFamily="18" charset="0"/>
+                      </a:rPr>
+                      <m:t>)</m:t>
+                    </m:r>
+                    <m:r>
+                      <a:rPr lang="fr-CA" b="0" i="1" smtClean="0">
+                        <a:solidFill>
+                          <a:srgbClr val="5B9BD5"/>
+                        </a:solidFill>
+                        <a:latin typeface="Cambria Math" panose="02040503050406030204" pitchFamily="18" charset="0"/>
+                      </a:rPr>
+                      <m:t>) −</m:t>
+                    </m:r>
+                    <m:sSubSup>
+                      <m:sSubSupPr>
+                        <m:ctrlPr>
+                          <a:rPr lang="fr-CA" i="1">
+                            <a:solidFill>
+                              <a:srgbClr val="5B9BD5"/>
+                            </a:solidFill>
+                            <a:latin typeface="Cambria Math" panose="02040503050406030204" pitchFamily="18" charset="0"/>
+                          </a:rPr>
+                        </m:ctrlPr>
+                      </m:sSubSupPr>
+                      <m:e>
+                        <m:r>
+                          <a:rPr lang="fr-CA" i="1">
+                            <a:solidFill>
+                              <a:srgbClr val="5B9BD5"/>
+                            </a:solidFill>
+                            <a:latin typeface="Cambria Math" panose="02040503050406030204" pitchFamily="18" charset="0"/>
+                          </a:rPr>
+                          <m:t>𝑇</m:t>
+                        </m:r>
+                      </m:e>
+                      <m:sub>
+                        <m:r>
+                          <a:rPr lang="fr-CA" i="1">
+                            <a:solidFill>
+                              <a:srgbClr val="5B9BD5"/>
+                            </a:solidFill>
+                            <a:latin typeface="Cambria Math" panose="02040503050406030204" pitchFamily="18" charset="0"/>
+                          </a:rPr>
+                          <m:t>𝑟</m:t>
+                        </m:r>
+                        <m:r>
+                          <a:rPr lang="fr-CA" i="1">
+                            <a:solidFill>
+                              <a:srgbClr val="5B9BD5"/>
+                            </a:solidFill>
+                            <a:latin typeface="Cambria Math" panose="02040503050406030204" pitchFamily="18" charset="0"/>
+                          </a:rPr>
+                          <m:t>,</m:t>
+                        </m:r>
+                        <m:r>
+                          <a:rPr lang="fr-CA" i="1">
+                            <a:solidFill>
+                              <a:srgbClr val="5B9BD5"/>
+                            </a:solidFill>
+                            <a:latin typeface="Cambria Math" panose="02040503050406030204" pitchFamily="18" charset="0"/>
+                          </a:rPr>
+                          <m:t>𝑧</m:t>
+                        </m:r>
+                        <m:r>
+                          <a:rPr lang="fr-CA" b="0" i="1" smtClean="0">
+                            <a:solidFill>
+                              <a:srgbClr val="5B9BD5"/>
+                            </a:solidFill>
+                            <a:latin typeface="Cambria Math" panose="02040503050406030204" pitchFamily="18" charset="0"/>
+                          </a:rPr>
+                          <m:t>−2</m:t>
+                        </m:r>
+                      </m:sub>
+                      <m:sup>
+                        <m:r>
+                          <a:rPr lang="fr-CA" i="1">
+                            <a:solidFill>
+                              <a:srgbClr val="5B9BD5"/>
+                            </a:solidFill>
+                            <a:latin typeface="Cambria Math" panose="02040503050406030204" pitchFamily="18" charset="0"/>
+                          </a:rPr>
+                          <m:t>𝑡</m:t>
+                        </m:r>
+                      </m:sup>
+                    </m:sSubSup>
+                    <m:r>
+                      <a:rPr lang="fr-CA" b="0" i="1" smtClean="0">
+                        <a:solidFill>
+                          <a:srgbClr val="5B9BD5"/>
+                        </a:solidFill>
+                        <a:latin typeface="Cambria Math" panose="02040503050406030204" pitchFamily="18" charset="0"/>
+                        <a:ea typeface="Cambria Math" panose="02040503050406030204" pitchFamily="18" charset="0"/>
+                      </a:rPr>
+                      <m:t>+4</m:t>
+                    </m:r>
+                    <m:sSubSup>
+                      <m:sSubSupPr>
+                        <m:ctrlPr>
+                          <a:rPr lang="fr-CA" i="1">
+                            <a:solidFill>
+                              <a:srgbClr val="5B9BD5"/>
+                            </a:solidFill>
+                            <a:latin typeface="Cambria Math" panose="02040503050406030204" pitchFamily="18" charset="0"/>
+                          </a:rPr>
+                        </m:ctrlPr>
+                      </m:sSubSupPr>
+                      <m:e>
+                        <m:r>
+                          <a:rPr lang="fr-CA" i="1">
+                            <a:solidFill>
+                              <a:srgbClr val="5B9BD5"/>
+                            </a:solidFill>
+                            <a:latin typeface="Cambria Math" panose="02040503050406030204" pitchFamily="18" charset="0"/>
+                          </a:rPr>
+                          <m:t>𝑇</m:t>
+                        </m:r>
+                      </m:e>
+                      <m:sub>
+                        <m:r>
+                          <a:rPr lang="fr-CA" i="1">
+                            <a:solidFill>
+                              <a:srgbClr val="5B9BD5"/>
+                            </a:solidFill>
+                            <a:latin typeface="Cambria Math" panose="02040503050406030204" pitchFamily="18" charset="0"/>
+                          </a:rPr>
+                          <m:t>𝑟</m:t>
+                        </m:r>
+                        <m:r>
+                          <a:rPr lang="fr-CA" i="1">
+                            <a:solidFill>
+                              <a:srgbClr val="5B9BD5"/>
+                            </a:solidFill>
+                            <a:latin typeface="Cambria Math" panose="02040503050406030204" pitchFamily="18" charset="0"/>
+                          </a:rPr>
+                          <m:t>,</m:t>
+                        </m:r>
+                        <m:r>
+                          <a:rPr lang="fr-CA" i="1">
+                            <a:solidFill>
+                              <a:srgbClr val="5B9BD5"/>
+                            </a:solidFill>
+                            <a:latin typeface="Cambria Math" panose="02040503050406030204" pitchFamily="18" charset="0"/>
+                          </a:rPr>
+                          <m:t>𝑧</m:t>
+                        </m:r>
+                        <m:r>
+                          <a:rPr lang="fr-CA" b="0" i="1" smtClean="0">
+                            <a:solidFill>
+                              <a:srgbClr val="5B9BD5"/>
+                            </a:solidFill>
+                            <a:latin typeface="Cambria Math" panose="02040503050406030204" pitchFamily="18" charset="0"/>
+                          </a:rPr>
+                          <m:t>−1</m:t>
+                        </m:r>
+                      </m:sub>
+                      <m:sup>
+                        <m:r>
+                          <a:rPr lang="fr-CA" i="1">
+                            <a:solidFill>
+                              <a:srgbClr val="5B9BD5"/>
+                            </a:solidFill>
+                            <a:latin typeface="Cambria Math" panose="02040503050406030204" pitchFamily="18" charset="0"/>
+                          </a:rPr>
+                          <m:t>𝑡</m:t>
+                        </m:r>
+                      </m:sup>
+                    </m:sSubSup>
+                    <m:r>
+                      <a:rPr lang="fr-CA" b="0" i="1" smtClean="0">
+                        <a:solidFill>
+                          <a:srgbClr val="5B9BD5"/>
+                        </a:solidFill>
+                        <a:latin typeface="Cambria Math" panose="02040503050406030204" pitchFamily="18" charset="0"/>
+                        <a:ea typeface="Cambria Math" panose="02040503050406030204" pitchFamily="18" charset="0"/>
+                      </a:rPr>
+                      <m:t>)]÷3</m:t>
+                    </m:r>
+                  </m:oMath>
+                </a14:m>
+                <a:r>
+                  <a:rPr lang="fr-CA" dirty="0">
+                    <a:solidFill>
+                      <a:srgbClr val="5B9BD5"/>
+                    </a:solidFill>
+                  </a:rPr>
+                  <a:t> </a:t>
+                </a:r>
+              </a:p>
+              <a:p>
+                <a:pPr algn="ctr"/>
+                <a14:m>
+                  <m:oMathPara xmlns:m="http://schemas.openxmlformats.org/officeDocument/2006/math">
+                    <m:oMathParaPr>
+                      <m:jc m:val="centerGroup"/>
+                    </m:oMathParaPr>
+                    <m:oMath xmlns:m="http://schemas.openxmlformats.org/officeDocument/2006/math">
+                      <m:acc>
+                        <m:accPr>
+                          <m:chr m:val="⃗"/>
+                          <m:ctrlPr>
+                            <a:rPr lang="fr-FR" i="1">
+                              <a:solidFill>
+                                <a:srgbClr val="5B9BD5"/>
+                              </a:solidFill>
+                              <a:latin typeface="Cambria Math" panose="02040503050406030204" pitchFamily="18" charset="0"/>
+                            </a:rPr>
+                          </m:ctrlPr>
+                        </m:accPr>
+                        <m:e>
+                          <m:r>
+                            <a:rPr lang="fr-CA" i="1">
+                              <a:solidFill>
+                                <a:srgbClr val="5B9BD5"/>
+                              </a:solidFill>
+                              <a:latin typeface="Cambria Math" panose="02040503050406030204" pitchFamily="18" charset="0"/>
+                            </a:rPr>
+                            <m:t>𝑛</m:t>
+                          </m:r>
+                        </m:e>
+                      </m:acc>
+                      <m:r>
+                        <a:rPr lang="fr-CA" b="0" i="1" smtClean="0">
+                          <a:solidFill>
+                            <a:srgbClr val="5B9BD5"/>
+                          </a:solidFill>
+                          <a:latin typeface="Cambria Math" panose="02040503050406030204" pitchFamily="18" charset="0"/>
+                        </a:rPr>
+                        <m:t>=(0,1)</m:t>
+                      </m:r>
+                    </m:oMath>
+                  </m:oMathPara>
+                </a14:m>
+                <a:endParaRPr lang="fr-CA" dirty="0">
+                  <a:solidFill>
+                    <a:srgbClr val="5B9BD5"/>
+                  </a:solidFill>
+                </a:endParaRPr>
+              </a:p>
+            </p:txBody>
+          </p:sp>
+        </mc:Choice>
+        <mc:Fallback>
+          <p:sp>
+            <p:nvSpPr>
+              <p:cNvPr id="8" name="ZoneTexte 7">
+                <a:extLst>
+                  <a:ext uri="{FF2B5EF4-FFF2-40B4-BE49-F238E27FC236}">
+                    <a16:creationId xmlns:a16="http://schemas.microsoft.com/office/drawing/2014/main" id="{B81FF01E-407B-CE8F-80F4-CFC728E6CA10}"/>
+                  </a:ext>
+                </a:extLst>
+              </p:cNvPr>
+              <p:cNvSpPr txBox="1">
+                <a:spLocks noRot="1" noChangeAspect="1" noMove="1" noResize="1" noEditPoints="1" noAdjustHandles="1" noChangeArrowheads="1" noChangeShapeType="1" noTextEdit="1"/>
+              </p:cNvSpPr>
+              <p:nvPr/>
+            </p:nvSpPr>
+            <p:spPr>
+              <a:xfrm>
+                <a:off x="5803392" y="1268922"/>
+                <a:ext cx="6141720" cy="1869614"/>
+              </a:xfrm>
+              <a:prstGeom prst="rect">
+                <a:avLst/>
+              </a:prstGeom>
+              <a:blipFill>
+                <a:blip r:embed="rId5"/>
+                <a:stretch>
+                  <a:fillRect l="-794" t="-1303" b="-1954"/>
+                </a:stretch>
+              </a:blipFill>
+            </p:spPr>
+            <p:txBody>
+              <a:bodyPr/>
+              <a:lstStyle/>
+              <a:p>
+                <a:r>
+                  <a:rPr lang="fr-CA">
+                    <a:noFill/>
+                  </a:rPr>
+                  <a:t> </a:t>
+                </a:r>
+              </a:p>
+            </p:txBody>
+          </p:sp>
+        </mc:Fallback>
+      </mc:AlternateContent>
+      <mc:AlternateContent xmlns:mc="http://schemas.openxmlformats.org/markup-compatibility/2006">
+        <mc:Choice xmlns:a14="http://schemas.microsoft.com/office/drawing/2010/main" Requires="a14">
+          <p:sp>
+            <p:nvSpPr>
+              <p:cNvPr id="9" name="ZoneTexte 8">
+                <a:extLst>
+                  <a:ext uri="{FF2B5EF4-FFF2-40B4-BE49-F238E27FC236}">
+                    <a16:creationId xmlns:a16="http://schemas.microsoft.com/office/drawing/2014/main" id="{A0DEE587-681A-1A82-80C1-940949F38F5B}"/>
+                  </a:ext>
+                </a:extLst>
+              </p:cNvPr>
+              <p:cNvSpPr txBox="1"/>
+              <p:nvPr/>
+            </p:nvSpPr>
+            <p:spPr>
+              <a:xfrm>
+                <a:off x="5903976" y="3023260"/>
+                <a:ext cx="6288024" cy="1869614"/>
+              </a:xfrm>
+              <a:prstGeom prst="rect">
+                <a:avLst/>
+              </a:prstGeom>
+              <a:noFill/>
+            </p:spPr>
+            <p:txBody>
+              <a:bodyPr wrap="square" rtlCol="0">
+                <a:spAutoFit/>
+              </a:bodyPr>
+              <a:lstStyle/>
+              <a:p>
+                <a:r>
+                  <a:rPr lang="fr-CA" dirty="0">
+                    <a:solidFill>
+                      <a:srgbClr val="6FAD46"/>
+                    </a:solidFill>
+                  </a:rPr>
+                  <a:t>Condition de robin, convection-radiation :</a:t>
+                </a:r>
+              </a:p>
+              <a:p>
+                <a:pPr algn="ctr">
+                  <a:spcBef>
+                    <a:spcPts val="1800"/>
+                  </a:spcBef>
+                </a:pPr>
+                <a:r>
+                  <a:rPr lang="fr-CA" dirty="0">
+                    <a:solidFill>
+                      <a:srgbClr val="6FAD46"/>
+                    </a:solidFill>
+                  </a:rPr>
+                  <a:t>	</a:t>
+                </a:r>
+                <a14:m>
+                  <m:oMath xmlns:m="http://schemas.openxmlformats.org/officeDocument/2006/math">
+                    <m:r>
+                      <a:rPr lang="fr-FR" i="1" smtClean="0">
+                        <a:solidFill>
+                          <a:srgbClr val="6FAD46"/>
+                        </a:solidFill>
+                        <a:latin typeface="Cambria Math" panose="02040503050406030204" pitchFamily="18" charset="0"/>
+                      </a:rPr>
+                      <m:t>−</m:t>
+                    </m:r>
+                    <m:r>
+                      <a:rPr lang="fr-FR" i="1" smtClean="0">
+                        <a:solidFill>
+                          <a:srgbClr val="6FAD46"/>
+                        </a:solidFill>
+                        <a:latin typeface="Cambria Math" panose="02040503050406030204" pitchFamily="18" charset="0"/>
+                      </a:rPr>
+                      <m:t>𝑘</m:t>
+                    </m:r>
+                    <m:r>
+                      <m:rPr>
+                        <m:sty m:val="p"/>
+                      </m:rPr>
+                      <a:rPr lang="fr-FR" i="1" smtClean="0">
+                        <a:solidFill>
+                          <a:srgbClr val="6FAD46"/>
+                        </a:solidFill>
+                        <a:latin typeface="Cambria Math" panose="02040503050406030204" pitchFamily="18" charset="0"/>
+                      </a:rPr>
+                      <m:t>∇</m:t>
+                    </m:r>
+                    <m:r>
+                      <a:rPr lang="fr-FR" i="1" smtClean="0">
+                        <a:solidFill>
+                          <a:srgbClr val="6FAD46"/>
+                        </a:solidFill>
+                        <a:latin typeface="Cambria Math" panose="02040503050406030204" pitchFamily="18" charset="0"/>
+                      </a:rPr>
+                      <m:t>𝑇</m:t>
+                    </m:r>
+                    <m:r>
+                      <a:rPr lang="fr-FR" i="1" smtClean="0">
+                        <a:solidFill>
+                          <a:srgbClr val="6FAD46"/>
+                        </a:solidFill>
+                        <a:latin typeface="Cambria Math" panose="02040503050406030204" pitchFamily="18" charset="0"/>
+                      </a:rPr>
+                      <m:t>.</m:t>
+                    </m:r>
+                    <m:acc>
+                      <m:accPr>
+                        <m:chr m:val="⃗"/>
+                        <m:ctrlPr>
+                          <a:rPr lang="fr-FR" i="1" smtClean="0">
+                            <a:solidFill>
+                              <a:srgbClr val="6FAD46"/>
+                            </a:solidFill>
+                            <a:latin typeface="Cambria Math" panose="02040503050406030204" pitchFamily="18" charset="0"/>
+                          </a:rPr>
+                        </m:ctrlPr>
+                      </m:accPr>
+                      <m:e>
+                        <m:r>
+                          <a:rPr lang="fr-CA" b="0" i="1" smtClean="0">
+                            <a:solidFill>
+                              <a:srgbClr val="6FAD46"/>
+                            </a:solidFill>
+                            <a:latin typeface="Cambria Math" panose="02040503050406030204" pitchFamily="18" charset="0"/>
+                          </a:rPr>
+                          <m:t>𝑛</m:t>
+                        </m:r>
+                      </m:e>
+                    </m:acc>
+                    <m:r>
+                      <a:rPr lang="fr-FR" i="1" smtClean="0">
+                        <a:solidFill>
+                          <a:srgbClr val="6FAD46"/>
+                        </a:solidFill>
+                        <a:latin typeface="Cambria Math" panose="02040503050406030204" pitchFamily="18" charset="0"/>
+                      </a:rPr>
+                      <m:t>=</m:t>
+                    </m:r>
+                    <m:r>
+                      <a:rPr lang="fr-FR" i="1" smtClean="0">
+                        <a:solidFill>
+                          <a:srgbClr val="6FAD46"/>
+                        </a:solidFill>
+                        <a:latin typeface="Cambria Math" panose="02040503050406030204" pitchFamily="18" charset="0"/>
+                      </a:rPr>
+                      <m:t>h</m:t>
+                    </m:r>
+                    <m:d>
+                      <m:dPr>
+                        <m:ctrlPr>
+                          <a:rPr lang="fr-FR" i="1">
+                            <a:solidFill>
+                              <a:srgbClr val="6FAD46"/>
+                            </a:solidFill>
+                            <a:latin typeface="Cambria Math" panose="02040503050406030204" pitchFamily="18" charset="0"/>
+                          </a:rPr>
+                        </m:ctrlPr>
+                      </m:dPr>
+                      <m:e>
+                        <m:r>
+                          <a:rPr lang="fr-FR" i="1">
+                            <a:solidFill>
+                              <a:srgbClr val="6FAD46"/>
+                            </a:solidFill>
+                            <a:latin typeface="Cambria Math" panose="02040503050406030204" pitchFamily="18" charset="0"/>
+                          </a:rPr>
+                          <m:t>𝑇</m:t>
+                        </m:r>
+                        <m:r>
+                          <a:rPr lang="fr-FR" i="1">
+                            <a:solidFill>
+                              <a:srgbClr val="6FAD46"/>
+                            </a:solidFill>
+                            <a:latin typeface="Cambria Math" panose="02040503050406030204" pitchFamily="18" charset="0"/>
+                          </a:rPr>
+                          <m:t>−</m:t>
+                        </m:r>
+                        <m:sSub>
+                          <m:sSubPr>
+                            <m:ctrlPr>
+                              <a:rPr lang="fr-FR" i="1">
+                                <a:solidFill>
+                                  <a:srgbClr val="6FAD46"/>
+                                </a:solidFill>
+                                <a:latin typeface="Cambria Math" panose="02040503050406030204" pitchFamily="18" charset="0"/>
+                              </a:rPr>
+                            </m:ctrlPr>
+                          </m:sSubPr>
+                          <m:e>
+                            <m:r>
+                              <a:rPr lang="fr-FR" i="1">
+                                <a:solidFill>
+                                  <a:srgbClr val="6FAD46"/>
+                                </a:solidFill>
+                                <a:latin typeface="Cambria Math" panose="02040503050406030204" pitchFamily="18" charset="0"/>
+                              </a:rPr>
+                              <m:t>𝑇</m:t>
+                            </m:r>
+                          </m:e>
+                          <m:sub>
+                            <m:r>
+                              <a:rPr lang="fr-FR" i="1">
+                                <a:solidFill>
+                                  <a:srgbClr val="6FAD46"/>
+                                </a:solidFill>
+                                <a:latin typeface="Cambria Math" panose="02040503050406030204" pitchFamily="18" charset="0"/>
+                              </a:rPr>
+                              <m:t>∞</m:t>
+                            </m:r>
+                            <m:r>
+                              <m:rPr>
+                                <m:nor/>
+                              </m:rPr>
+                              <a:rPr lang="fr-FR" dirty="0">
+                                <a:solidFill>
+                                  <a:srgbClr val="6FAD46"/>
+                                </a:solidFill>
+                              </a:rPr>
+                              <m:t> </m:t>
+                            </m:r>
+                          </m:sub>
+                        </m:sSub>
+                      </m:e>
+                    </m:d>
+                    <m:r>
+                      <a:rPr lang="fr-FR" i="1">
+                        <a:solidFill>
+                          <a:srgbClr val="6FAD46"/>
+                        </a:solidFill>
+                        <a:latin typeface="Cambria Math" panose="02040503050406030204" pitchFamily="18" charset="0"/>
+                      </a:rPr>
+                      <m:t>+</m:t>
+                    </m:r>
+                    <m:r>
+                      <m:rPr>
+                        <m:sty m:val="p"/>
+                      </m:rPr>
+                      <a:rPr lang="fr-FR" i="1">
+                        <a:solidFill>
+                          <a:srgbClr val="6FAD46"/>
+                        </a:solidFill>
+                        <a:latin typeface="Cambria Math" panose="02040503050406030204" pitchFamily="18" charset="0"/>
+                      </a:rPr>
+                      <m:t>ϵσ</m:t>
+                    </m:r>
+                    <m:r>
+                      <a:rPr lang="fr-FR" i="1">
+                        <a:solidFill>
+                          <a:srgbClr val="6FAD46"/>
+                        </a:solidFill>
+                        <a:latin typeface="Cambria Math" panose="02040503050406030204" pitchFamily="18" charset="0"/>
+                      </a:rPr>
+                      <m:t>(</m:t>
+                    </m:r>
+                    <m:sSup>
+                      <m:sSupPr>
+                        <m:ctrlPr>
+                          <a:rPr lang="fr-FR" i="1">
+                            <a:solidFill>
+                              <a:srgbClr val="6FAD46"/>
+                            </a:solidFill>
+                            <a:latin typeface="Cambria Math" panose="02040503050406030204" pitchFamily="18" charset="0"/>
+                          </a:rPr>
+                        </m:ctrlPr>
+                      </m:sSupPr>
+                      <m:e>
+                        <m:r>
+                          <a:rPr lang="fr-FR" i="1">
+                            <a:solidFill>
+                              <a:srgbClr val="6FAD46"/>
+                            </a:solidFill>
+                            <a:latin typeface="Cambria Math" panose="02040503050406030204" pitchFamily="18" charset="0"/>
+                          </a:rPr>
+                          <m:t>𝑇</m:t>
+                        </m:r>
+                      </m:e>
+                      <m:sup>
+                        <m:r>
+                          <a:rPr lang="fr-FR" i="1">
+                            <a:solidFill>
+                              <a:srgbClr val="6FAD46"/>
+                            </a:solidFill>
+                            <a:latin typeface="Cambria Math" panose="02040503050406030204" pitchFamily="18" charset="0"/>
+                          </a:rPr>
+                          <m:t>4</m:t>
+                        </m:r>
+                      </m:sup>
+                    </m:sSup>
+                    <m:r>
+                      <a:rPr lang="fr-FR" i="1">
+                        <a:solidFill>
+                          <a:srgbClr val="6FAD46"/>
+                        </a:solidFill>
+                        <a:latin typeface="Cambria Math" panose="02040503050406030204" pitchFamily="18" charset="0"/>
+                      </a:rPr>
+                      <m:t>−</m:t>
+                    </m:r>
+                    <m:sSubSup>
+                      <m:sSubSupPr>
+                        <m:ctrlPr>
+                          <a:rPr lang="fr-FR" i="1">
+                            <a:solidFill>
+                              <a:srgbClr val="6FAD46"/>
+                            </a:solidFill>
+                            <a:latin typeface="Cambria Math" panose="02040503050406030204" pitchFamily="18" charset="0"/>
+                          </a:rPr>
+                        </m:ctrlPr>
+                      </m:sSubSupPr>
+                      <m:e>
+                        <m:r>
+                          <a:rPr lang="fr-FR" i="1">
+                            <a:solidFill>
+                              <a:srgbClr val="6FAD46"/>
+                            </a:solidFill>
+                            <a:latin typeface="Cambria Math" panose="02040503050406030204" pitchFamily="18" charset="0"/>
+                          </a:rPr>
+                          <m:t>𝑇</m:t>
+                        </m:r>
+                      </m:e>
+                      <m:sub>
+                        <m:r>
+                          <a:rPr lang="fr-FR" i="1">
+                            <a:solidFill>
+                              <a:srgbClr val="6FAD46"/>
+                            </a:solidFill>
+                            <a:latin typeface="Cambria Math" panose="02040503050406030204" pitchFamily="18" charset="0"/>
+                          </a:rPr>
+                          <m:t>∞</m:t>
+                        </m:r>
+                      </m:sub>
+                      <m:sup>
+                        <m:r>
+                          <a:rPr lang="fr-FR" i="1">
+                            <a:solidFill>
+                              <a:srgbClr val="6FAD46"/>
+                            </a:solidFill>
+                            <a:latin typeface="Cambria Math" panose="02040503050406030204" pitchFamily="18" charset="0"/>
+                          </a:rPr>
+                          <m:t>4</m:t>
+                        </m:r>
+                      </m:sup>
+                    </m:sSubSup>
+                    <m:r>
+                      <a:rPr lang="fr-FR" i="1">
+                        <a:solidFill>
+                          <a:srgbClr val="6FAD46"/>
+                        </a:solidFill>
+                        <a:latin typeface="Cambria Math" panose="02040503050406030204" pitchFamily="18" charset="0"/>
+                      </a:rPr>
+                      <m:t>)</m:t>
+                    </m:r>
+                  </m:oMath>
+                </a14:m>
+                <a:endParaRPr lang="fr-FR" dirty="0">
+                  <a:solidFill>
+                    <a:srgbClr val="6FAD46"/>
+                  </a:solidFill>
+                </a:endParaRPr>
+              </a:p>
+              <a:p>
+                <a:pPr algn="ctr"/>
+                <a14:m>
+                  <m:oMath xmlns:m="http://schemas.openxmlformats.org/officeDocument/2006/math">
+                    <m:sSubSup>
+                      <m:sSubSupPr>
+                        <m:ctrlPr>
+                          <a:rPr lang="fr-CA" b="0" i="1" smtClean="0">
+                            <a:solidFill>
+                              <a:srgbClr val="6FAD46"/>
+                            </a:solidFill>
+                            <a:latin typeface="Cambria Math" panose="02040503050406030204" pitchFamily="18" charset="0"/>
+                          </a:rPr>
+                        </m:ctrlPr>
+                      </m:sSubSupPr>
+                      <m:e>
+                        <m:r>
+                          <a:rPr lang="fr-CA" b="0" i="1" smtClean="0">
+                            <a:solidFill>
+                              <a:srgbClr val="6FAD46"/>
+                            </a:solidFill>
+                            <a:latin typeface="Cambria Math" panose="02040503050406030204" pitchFamily="18" charset="0"/>
+                          </a:rPr>
+                          <m:t>𝑇</m:t>
+                        </m:r>
+                      </m:e>
+                      <m:sub>
+                        <m:r>
+                          <a:rPr lang="fr-CA" b="0" i="1" smtClean="0">
+                            <a:solidFill>
+                              <a:srgbClr val="6FAD46"/>
+                            </a:solidFill>
+                            <a:latin typeface="Cambria Math" panose="02040503050406030204" pitchFamily="18" charset="0"/>
+                          </a:rPr>
+                          <m:t>𝑟</m:t>
+                        </m:r>
+                        <m:r>
+                          <a:rPr lang="fr-CA" b="0" i="1" smtClean="0">
+                            <a:solidFill>
+                              <a:srgbClr val="6FAD46"/>
+                            </a:solidFill>
+                            <a:latin typeface="Cambria Math" panose="02040503050406030204" pitchFamily="18" charset="0"/>
+                          </a:rPr>
+                          <m:t>,</m:t>
+                        </m:r>
+                        <m:r>
+                          <a:rPr lang="fr-CA" b="0" i="1" smtClean="0">
+                            <a:solidFill>
+                              <a:srgbClr val="6FAD46"/>
+                            </a:solidFill>
+                            <a:latin typeface="Cambria Math" panose="02040503050406030204" pitchFamily="18" charset="0"/>
+                          </a:rPr>
+                          <m:t>𝑧</m:t>
+                        </m:r>
+                      </m:sub>
+                      <m:sup>
+                        <m:r>
+                          <a:rPr lang="fr-CA" b="0" i="1" smtClean="0">
+                            <a:solidFill>
+                              <a:srgbClr val="6FAD46"/>
+                            </a:solidFill>
+                            <a:latin typeface="Cambria Math" panose="02040503050406030204" pitchFamily="18" charset="0"/>
+                          </a:rPr>
+                          <m:t>𝑡</m:t>
+                        </m:r>
+                        <m:r>
+                          <a:rPr lang="fr-CA" b="0" i="1" smtClean="0">
+                            <a:solidFill>
+                              <a:srgbClr val="6FAD46"/>
+                            </a:solidFill>
+                            <a:latin typeface="Cambria Math" panose="02040503050406030204" pitchFamily="18" charset="0"/>
+                          </a:rPr>
+                          <m:t>+∆</m:t>
+                        </m:r>
+                        <m:r>
+                          <a:rPr lang="fr-CA" b="0" i="1" smtClean="0">
+                            <a:solidFill>
+                              <a:srgbClr val="6FAD46"/>
+                            </a:solidFill>
+                            <a:latin typeface="Cambria Math" panose="02040503050406030204" pitchFamily="18" charset="0"/>
+                            <a:ea typeface="Cambria Math" panose="02040503050406030204" pitchFamily="18" charset="0"/>
+                          </a:rPr>
+                          <m:t>𝑡</m:t>
+                        </m:r>
+                      </m:sup>
+                    </m:sSubSup>
+                    <m:r>
+                      <a:rPr lang="fr-CA" b="0" i="0" smtClean="0">
+                        <a:solidFill>
+                          <a:srgbClr val="6FAD46"/>
+                        </a:solidFill>
+                        <a:latin typeface="Cambria Math" panose="02040503050406030204" pitchFamily="18" charset="0"/>
+                      </a:rPr>
+                      <m:t>=[</m:t>
+                    </m:r>
+                    <m:d>
+                      <m:dPr>
+                        <m:ctrlPr>
+                          <a:rPr lang="fr-CA" b="0" i="1" smtClean="0">
+                            <a:solidFill>
+                              <a:srgbClr val="6FAD46"/>
+                            </a:solidFill>
+                            <a:latin typeface="Cambria Math" panose="02040503050406030204" pitchFamily="18" charset="0"/>
+                          </a:rPr>
+                        </m:ctrlPr>
+                      </m:dPr>
+                      <m:e>
+                        <m:f>
+                          <m:fPr>
+                            <m:ctrlPr>
+                              <a:rPr lang="fr-CA" b="0" i="1" smtClean="0">
+                                <a:solidFill>
+                                  <a:srgbClr val="6FAD46"/>
+                                </a:solidFill>
+                                <a:latin typeface="Cambria Math" panose="02040503050406030204" pitchFamily="18" charset="0"/>
+                              </a:rPr>
+                            </m:ctrlPr>
+                          </m:fPr>
+                          <m:num>
+                            <m:r>
+                              <a:rPr lang="fr-CA" b="0" i="0" smtClean="0">
+                                <a:solidFill>
+                                  <a:srgbClr val="6FAD46"/>
+                                </a:solidFill>
+                                <a:latin typeface="Cambria Math" panose="02040503050406030204" pitchFamily="18" charset="0"/>
+                              </a:rPr>
+                              <m:t>−2</m:t>
+                            </m:r>
+                            <m:r>
+                              <a:rPr lang="fr-CA" b="0" i="1" smtClean="0">
+                                <a:solidFill>
+                                  <a:srgbClr val="6FAD46"/>
+                                </a:solidFill>
+                                <a:latin typeface="Cambria Math" panose="02040503050406030204" pitchFamily="18" charset="0"/>
+                              </a:rPr>
+                              <m:t>∆</m:t>
+                            </m:r>
+                            <m:r>
+                              <m:rPr>
+                                <m:sty m:val="p"/>
+                              </m:rPr>
+                              <a:rPr lang="fr-CA" b="0" i="0" smtClean="0">
+                                <a:solidFill>
+                                  <a:srgbClr val="6FAD46"/>
+                                </a:solidFill>
+                                <a:latin typeface="Cambria Math" panose="02040503050406030204" pitchFamily="18" charset="0"/>
+                              </a:rPr>
+                              <m:t>r</m:t>
+                            </m:r>
+                          </m:num>
+                          <m:den>
+                            <m:r>
+                              <m:rPr>
+                                <m:sty m:val="p"/>
+                              </m:rPr>
+                              <a:rPr lang="fr-CA" b="0" i="0" smtClean="0">
+                                <a:solidFill>
+                                  <a:srgbClr val="6FAD46"/>
+                                </a:solidFill>
+                                <a:latin typeface="Cambria Math" panose="02040503050406030204" pitchFamily="18" charset="0"/>
+                              </a:rPr>
+                              <m:t>k</m:t>
+                            </m:r>
+                          </m:den>
+                        </m:f>
+                      </m:e>
+                    </m:d>
+                    <m:r>
+                      <a:rPr lang="fr-CA" b="0" i="0" smtClean="0">
+                        <a:solidFill>
+                          <a:srgbClr val="6FAD46"/>
+                        </a:solidFill>
+                        <a:latin typeface="Cambria Math" panose="02040503050406030204" pitchFamily="18" charset="0"/>
+                      </a:rPr>
+                      <m:t>∗(</m:t>
+                    </m:r>
+                    <m:r>
+                      <m:rPr>
+                        <m:sty m:val="p"/>
+                      </m:rPr>
+                      <a:rPr lang="fr-CA" b="0" i="0" smtClean="0">
+                        <a:solidFill>
+                          <a:srgbClr val="6FAD46"/>
+                        </a:solidFill>
+                        <a:latin typeface="Cambria Math" panose="02040503050406030204" pitchFamily="18" charset="0"/>
+                      </a:rPr>
+                      <m:t>h</m:t>
+                    </m:r>
+                    <m:r>
+                      <a:rPr lang="fr-CA" b="0" i="0" smtClean="0">
+                        <a:solidFill>
+                          <a:srgbClr val="6FAD46"/>
+                        </a:solidFill>
+                        <a:latin typeface="Cambria Math" panose="02040503050406030204" pitchFamily="18" charset="0"/>
+                      </a:rPr>
+                      <m:t>(</m:t>
+                    </m:r>
+                    <m:sSubSup>
+                      <m:sSubSupPr>
+                        <m:ctrlPr>
+                          <a:rPr lang="fr-CA" i="1">
+                            <a:solidFill>
+                              <a:srgbClr val="6FAD46"/>
+                            </a:solidFill>
+                            <a:latin typeface="Cambria Math" panose="02040503050406030204" pitchFamily="18" charset="0"/>
+                          </a:rPr>
+                        </m:ctrlPr>
+                      </m:sSubSupPr>
+                      <m:e>
+                        <m:r>
+                          <a:rPr lang="fr-CA" i="1">
+                            <a:solidFill>
+                              <a:srgbClr val="6FAD46"/>
+                            </a:solidFill>
+                            <a:latin typeface="Cambria Math" panose="02040503050406030204" pitchFamily="18" charset="0"/>
+                          </a:rPr>
+                          <m:t>𝑇</m:t>
+                        </m:r>
+                      </m:e>
+                      <m:sub>
+                        <m:r>
+                          <a:rPr lang="fr-CA" i="1">
+                            <a:solidFill>
+                              <a:srgbClr val="6FAD46"/>
+                            </a:solidFill>
+                            <a:latin typeface="Cambria Math" panose="02040503050406030204" pitchFamily="18" charset="0"/>
+                          </a:rPr>
+                          <m:t>𝑟</m:t>
+                        </m:r>
+                        <m:r>
+                          <a:rPr lang="fr-CA" i="1">
+                            <a:solidFill>
+                              <a:srgbClr val="6FAD46"/>
+                            </a:solidFill>
+                            <a:latin typeface="Cambria Math" panose="02040503050406030204" pitchFamily="18" charset="0"/>
+                          </a:rPr>
+                          <m:t>,</m:t>
+                        </m:r>
+                        <m:r>
+                          <a:rPr lang="fr-CA" i="1">
+                            <a:solidFill>
+                              <a:srgbClr val="6FAD46"/>
+                            </a:solidFill>
+                            <a:latin typeface="Cambria Math" panose="02040503050406030204" pitchFamily="18" charset="0"/>
+                          </a:rPr>
+                          <m:t>𝑧</m:t>
+                        </m:r>
+                      </m:sub>
+                      <m:sup>
+                        <m:r>
+                          <a:rPr lang="fr-CA" b="0" i="1" smtClean="0">
+                            <a:solidFill>
+                              <a:srgbClr val="6FAD46"/>
+                            </a:solidFill>
+                            <a:latin typeface="Cambria Math" panose="02040503050406030204" pitchFamily="18" charset="0"/>
+                          </a:rPr>
+                          <m:t>𝑡</m:t>
+                        </m:r>
+                      </m:sup>
+                    </m:sSubSup>
+                  </m:oMath>
+                </a14:m>
+                <a:r>
+                  <a:rPr lang="fr-CA" dirty="0">
+                    <a:solidFill>
+                      <a:srgbClr val="6FAD46"/>
+                    </a:solidFill>
+                  </a:rPr>
+                  <a:t>-</a:t>
+                </a:r>
+                <a:r>
+                  <a:rPr lang="fr-FR" dirty="0">
+                    <a:solidFill>
+                      <a:srgbClr val="6FAD46"/>
+                    </a:solidFill>
+                  </a:rPr>
+                  <a:t> </a:t>
+                </a:r>
+                <a14:m>
+                  <m:oMath xmlns:m="http://schemas.openxmlformats.org/officeDocument/2006/math">
+                    <m:sSub>
+                      <m:sSubPr>
+                        <m:ctrlPr>
+                          <a:rPr lang="fr-FR" i="1">
+                            <a:solidFill>
+                              <a:srgbClr val="6FAD46"/>
+                            </a:solidFill>
+                            <a:latin typeface="Cambria Math" panose="02040503050406030204" pitchFamily="18" charset="0"/>
+                          </a:rPr>
+                        </m:ctrlPr>
+                      </m:sSubPr>
+                      <m:e>
+                        <m:r>
+                          <a:rPr lang="fr-FR" i="1">
+                            <a:solidFill>
+                              <a:srgbClr val="6FAD46"/>
+                            </a:solidFill>
+                            <a:latin typeface="Cambria Math" panose="02040503050406030204" pitchFamily="18" charset="0"/>
+                          </a:rPr>
+                          <m:t>𝑇</m:t>
+                        </m:r>
+                      </m:e>
+                      <m:sub>
+                        <m:r>
+                          <a:rPr lang="fr-FR" i="1">
+                            <a:solidFill>
+                              <a:srgbClr val="6FAD46"/>
+                            </a:solidFill>
+                            <a:latin typeface="Cambria Math" panose="02040503050406030204" pitchFamily="18" charset="0"/>
+                          </a:rPr>
+                          <m:t>∞</m:t>
+                        </m:r>
+                        <m:r>
+                          <m:rPr>
+                            <m:nor/>
+                          </m:rPr>
+                          <a:rPr lang="fr-FR" dirty="0">
+                            <a:solidFill>
+                              <a:srgbClr val="6FAD46"/>
+                            </a:solidFill>
+                          </a:rPr>
+                          <m:t> </m:t>
+                        </m:r>
+                      </m:sub>
+                    </m:sSub>
+                    <m:r>
+                      <a:rPr lang="fr-CA" b="0" i="1" dirty="0" smtClean="0">
+                        <a:solidFill>
+                          <a:srgbClr val="6FAD46"/>
+                        </a:solidFill>
+                        <a:latin typeface="Cambria Math" panose="02040503050406030204" pitchFamily="18" charset="0"/>
+                      </a:rPr>
+                      <m:t>)</m:t>
+                    </m:r>
+                  </m:oMath>
+                </a14:m>
+                <a:r>
+                  <a:rPr lang="fr-CA" dirty="0">
+                    <a:solidFill>
+                      <a:srgbClr val="6FAD46"/>
+                    </a:solidFill>
+                  </a:rPr>
+                  <a:t> + </a:t>
+                </a:r>
+                <a14:m>
+                  <m:oMath xmlns:m="http://schemas.openxmlformats.org/officeDocument/2006/math">
+                    <m:r>
+                      <m:rPr>
+                        <m:sty m:val="p"/>
+                      </m:rPr>
+                      <a:rPr lang="fr-FR" i="1">
+                        <a:solidFill>
+                          <a:srgbClr val="6FAD46"/>
+                        </a:solidFill>
+                        <a:latin typeface="Cambria Math" panose="02040503050406030204" pitchFamily="18" charset="0"/>
+                      </a:rPr>
+                      <m:t>ϵσ</m:t>
+                    </m:r>
+                    <m:r>
+                      <a:rPr lang="fr-FR" i="1">
+                        <a:solidFill>
+                          <a:srgbClr val="6FAD46"/>
+                        </a:solidFill>
+                        <a:latin typeface="Cambria Math" panose="02040503050406030204" pitchFamily="18" charset="0"/>
+                      </a:rPr>
+                      <m:t>(</m:t>
+                    </m:r>
+                    <m:sSup>
+                      <m:sSupPr>
+                        <m:ctrlPr>
+                          <a:rPr lang="fr-FR" i="1">
+                            <a:solidFill>
+                              <a:srgbClr val="6FAD46"/>
+                            </a:solidFill>
+                            <a:latin typeface="Cambria Math" panose="02040503050406030204" pitchFamily="18" charset="0"/>
+                          </a:rPr>
+                        </m:ctrlPr>
+                      </m:sSupPr>
+                      <m:e>
+                        <m:sSubSup>
+                          <m:sSubSupPr>
+                            <m:ctrlPr>
+                              <a:rPr lang="fr-CA" i="1">
+                                <a:solidFill>
+                                  <a:srgbClr val="6FAD46"/>
+                                </a:solidFill>
+                                <a:latin typeface="Cambria Math" panose="02040503050406030204" pitchFamily="18" charset="0"/>
+                              </a:rPr>
+                            </m:ctrlPr>
+                          </m:sSubSupPr>
+                          <m:e>
+                            <m:r>
+                              <a:rPr lang="fr-CA" i="1">
+                                <a:solidFill>
+                                  <a:srgbClr val="6FAD46"/>
+                                </a:solidFill>
+                                <a:latin typeface="Cambria Math" panose="02040503050406030204" pitchFamily="18" charset="0"/>
+                              </a:rPr>
+                              <m:t>𝑇</m:t>
+                            </m:r>
+                          </m:e>
+                          <m:sub>
+                            <m:r>
+                              <a:rPr lang="fr-CA" i="1">
+                                <a:solidFill>
+                                  <a:srgbClr val="6FAD46"/>
+                                </a:solidFill>
+                                <a:latin typeface="Cambria Math" panose="02040503050406030204" pitchFamily="18" charset="0"/>
+                              </a:rPr>
+                              <m:t>𝑟</m:t>
+                            </m:r>
+                            <m:r>
+                              <a:rPr lang="fr-CA" i="1">
+                                <a:solidFill>
+                                  <a:srgbClr val="6FAD46"/>
+                                </a:solidFill>
+                                <a:latin typeface="Cambria Math" panose="02040503050406030204" pitchFamily="18" charset="0"/>
+                              </a:rPr>
+                              <m:t>,</m:t>
+                            </m:r>
+                            <m:r>
+                              <a:rPr lang="fr-CA" i="1">
+                                <a:solidFill>
+                                  <a:srgbClr val="6FAD46"/>
+                                </a:solidFill>
+                                <a:latin typeface="Cambria Math" panose="02040503050406030204" pitchFamily="18" charset="0"/>
+                              </a:rPr>
+                              <m:t>𝑧</m:t>
+                            </m:r>
+                          </m:sub>
+                          <m:sup>
+                            <m:r>
+                              <a:rPr lang="fr-CA" i="1">
+                                <a:solidFill>
+                                  <a:srgbClr val="6FAD46"/>
+                                </a:solidFill>
+                                <a:latin typeface="Cambria Math" panose="02040503050406030204" pitchFamily="18" charset="0"/>
+                              </a:rPr>
+                              <m:t>𝑡</m:t>
+                            </m:r>
+                          </m:sup>
+                        </m:sSubSup>
+                      </m:e>
+                      <m:sup>
+                        <m:r>
+                          <a:rPr lang="fr-FR" i="1">
+                            <a:solidFill>
+                              <a:srgbClr val="6FAD46"/>
+                            </a:solidFill>
+                            <a:latin typeface="Cambria Math" panose="02040503050406030204" pitchFamily="18" charset="0"/>
+                          </a:rPr>
+                          <m:t>4</m:t>
+                        </m:r>
+                      </m:sup>
+                    </m:sSup>
+                    <m:r>
+                      <a:rPr lang="fr-FR" i="1">
+                        <a:solidFill>
+                          <a:srgbClr val="6FAD46"/>
+                        </a:solidFill>
+                        <a:latin typeface="Cambria Math" panose="02040503050406030204" pitchFamily="18" charset="0"/>
+                      </a:rPr>
+                      <m:t>−</m:t>
+                    </m:r>
+                    <m:sSubSup>
+                      <m:sSubSupPr>
+                        <m:ctrlPr>
+                          <a:rPr lang="fr-FR" i="1">
+                            <a:solidFill>
+                              <a:srgbClr val="6FAD46"/>
+                            </a:solidFill>
+                            <a:latin typeface="Cambria Math" panose="02040503050406030204" pitchFamily="18" charset="0"/>
+                          </a:rPr>
+                        </m:ctrlPr>
+                      </m:sSubSupPr>
+                      <m:e>
+                        <m:r>
+                          <a:rPr lang="fr-FR" i="1">
+                            <a:solidFill>
+                              <a:srgbClr val="6FAD46"/>
+                            </a:solidFill>
+                            <a:latin typeface="Cambria Math" panose="02040503050406030204" pitchFamily="18" charset="0"/>
+                          </a:rPr>
+                          <m:t>𝑇</m:t>
+                        </m:r>
+                      </m:e>
+                      <m:sub>
+                        <m:r>
+                          <a:rPr lang="fr-FR" i="1">
+                            <a:solidFill>
+                              <a:srgbClr val="6FAD46"/>
+                            </a:solidFill>
+                            <a:latin typeface="Cambria Math" panose="02040503050406030204" pitchFamily="18" charset="0"/>
+                          </a:rPr>
+                          <m:t>∞</m:t>
+                        </m:r>
+                      </m:sub>
+                      <m:sup>
+                        <m:r>
+                          <a:rPr lang="fr-FR" i="1">
+                            <a:solidFill>
+                              <a:srgbClr val="6FAD46"/>
+                            </a:solidFill>
+                            <a:latin typeface="Cambria Math" panose="02040503050406030204" pitchFamily="18" charset="0"/>
+                          </a:rPr>
+                          <m:t>4</m:t>
+                        </m:r>
+                      </m:sup>
+                    </m:sSubSup>
+                    <m:r>
+                      <a:rPr lang="fr-FR" i="1">
+                        <a:solidFill>
+                          <a:srgbClr val="6FAD46"/>
+                        </a:solidFill>
+                        <a:latin typeface="Cambria Math" panose="02040503050406030204" pitchFamily="18" charset="0"/>
+                      </a:rPr>
+                      <m:t>)</m:t>
+                    </m:r>
+                    <m:r>
+                      <a:rPr lang="fr-CA" b="0" i="1" smtClean="0">
+                        <a:solidFill>
+                          <a:srgbClr val="6FAD46"/>
+                        </a:solidFill>
+                        <a:latin typeface="Cambria Math" panose="02040503050406030204" pitchFamily="18" charset="0"/>
+                      </a:rPr>
+                      <m:t>) −</m:t>
+                    </m:r>
+                    <m:sSubSup>
+                      <m:sSubSupPr>
+                        <m:ctrlPr>
+                          <a:rPr lang="fr-CA" i="1">
+                            <a:solidFill>
+                              <a:srgbClr val="6FAD46"/>
+                            </a:solidFill>
+                            <a:latin typeface="Cambria Math" panose="02040503050406030204" pitchFamily="18" charset="0"/>
+                          </a:rPr>
+                        </m:ctrlPr>
+                      </m:sSubSupPr>
+                      <m:e>
+                        <m:r>
+                          <a:rPr lang="fr-CA" i="1">
+                            <a:solidFill>
+                              <a:srgbClr val="6FAD46"/>
+                            </a:solidFill>
+                            <a:latin typeface="Cambria Math" panose="02040503050406030204" pitchFamily="18" charset="0"/>
+                          </a:rPr>
+                          <m:t>𝑇</m:t>
+                        </m:r>
+                      </m:e>
+                      <m:sub>
+                        <m:r>
+                          <a:rPr lang="fr-CA" i="1">
+                            <a:solidFill>
+                              <a:srgbClr val="6FAD46"/>
+                            </a:solidFill>
+                            <a:latin typeface="Cambria Math" panose="02040503050406030204" pitchFamily="18" charset="0"/>
+                          </a:rPr>
+                          <m:t>𝑟</m:t>
+                        </m:r>
+                        <m:r>
+                          <a:rPr lang="fr-CA" i="1">
+                            <a:solidFill>
+                              <a:srgbClr val="6FAD46"/>
+                            </a:solidFill>
+                            <a:latin typeface="Cambria Math" panose="02040503050406030204" pitchFamily="18" charset="0"/>
+                          </a:rPr>
+                          <m:t>,</m:t>
+                        </m:r>
+                        <m:r>
+                          <a:rPr lang="fr-CA" i="1">
+                            <a:solidFill>
+                              <a:srgbClr val="6FAD46"/>
+                            </a:solidFill>
+                            <a:latin typeface="Cambria Math" panose="02040503050406030204" pitchFamily="18" charset="0"/>
+                          </a:rPr>
+                          <m:t>𝑧</m:t>
+                        </m:r>
+                        <m:r>
+                          <a:rPr lang="fr-CA" b="0" i="1" smtClean="0">
+                            <a:solidFill>
+                              <a:srgbClr val="6FAD46"/>
+                            </a:solidFill>
+                            <a:latin typeface="Cambria Math" panose="02040503050406030204" pitchFamily="18" charset="0"/>
+                          </a:rPr>
+                          <m:t>+</m:t>
+                        </m:r>
+                        <m:r>
+                          <a:rPr lang="fr-CA" b="0" i="1" smtClean="0">
+                            <a:solidFill>
+                              <a:srgbClr val="6FAD46"/>
+                            </a:solidFill>
+                            <a:latin typeface="Cambria Math" panose="02040503050406030204" pitchFamily="18" charset="0"/>
+                          </a:rPr>
+                          <m:t>2</m:t>
+                        </m:r>
+                      </m:sub>
+                      <m:sup>
+                        <m:r>
+                          <a:rPr lang="fr-CA" i="1">
+                            <a:solidFill>
+                              <a:srgbClr val="6FAD46"/>
+                            </a:solidFill>
+                            <a:latin typeface="Cambria Math" panose="02040503050406030204" pitchFamily="18" charset="0"/>
+                          </a:rPr>
+                          <m:t>𝑡</m:t>
+                        </m:r>
+                      </m:sup>
+                    </m:sSubSup>
+                    <m:r>
+                      <a:rPr lang="fr-CA" b="0" i="1" smtClean="0">
+                        <a:solidFill>
+                          <a:srgbClr val="6FAD46"/>
+                        </a:solidFill>
+                        <a:latin typeface="Cambria Math" panose="02040503050406030204" pitchFamily="18" charset="0"/>
+                        <a:ea typeface="Cambria Math" panose="02040503050406030204" pitchFamily="18" charset="0"/>
+                      </a:rPr>
+                      <m:t>+4</m:t>
+                    </m:r>
+                    <m:sSubSup>
+                      <m:sSubSupPr>
+                        <m:ctrlPr>
+                          <a:rPr lang="fr-CA" i="1">
+                            <a:solidFill>
+                              <a:srgbClr val="6FAD46"/>
+                            </a:solidFill>
+                            <a:latin typeface="Cambria Math" panose="02040503050406030204" pitchFamily="18" charset="0"/>
+                          </a:rPr>
+                        </m:ctrlPr>
+                      </m:sSubSupPr>
+                      <m:e>
+                        <m:r>
+                          <a:rPr lang="fr-CA" i="1">
+                            <a:solidFill>
+                              <a:srgbClr val="6FAD46"/>
+                            </a:solidFill>
+                            <a:latin typeface="Cambria Math" panose="02040503050406030204" pitchFamily="18" charset="0"/>
+                          </a:rPr>
+                          <m:t>𝑇</m:t>
+                        </m:r>
+                      </m:e>
+                      <m:sub>
+                        <m:r>
+                          <a:rPr lang="fr-CA" i="1">
+                            <a:solidFill>
+                              <a:srgbClr val="6FAD46"/>
+                            </a:solidFill>
+                            <a:latin typeface="Cambria Math" panose="02040503050406030204" pitchFamily="18" charset="0"/>
+                          </a:rPr>
+                          <m:t>𝑟</m:t>
+                        </m:r>
+                        <m:r>
+                          <a:rPr lang="fr-CA" i="1">
+                            <a:solidFill>
+                              <a:srgbClr val="6FAD46"/>
+                            </a:solidFill>
+                            <a:latin typeface="Cambria Math" panose="02040503050406030204" pitchFamily="18" charset="0"/>
+                          </a:rPr>
+                          <m:t>,</m:t>
+                        </m:r>
+                        <m:r>
+                          <a:rPr lang="fr-CA" i="1">
+                            <a:solidFill>
+                              <a:srgbClr val="6FAD46"/>
+                            </a:solidFill>
+                            <a:latin typeface="Cambria Math" panose="02040503050406030204" pitchFamily="18" charset="0"/>
+                          </a:rPr>
+                          <m:t>𝑧</m:t>
+                        </m:r>
+                        <m:r>
+                          <a:rPr lang="fr-CA" b="0" i="1" smtClean="0">
+                            <a:solidFill>
+                              <a:srgbClr val="6FAD46"/>
+                            </a:solidFill>
+                            <a:latin typeface="Cambria Math" panose="02040503050406030204" pitchFamily="18" charset="0"/>
+                          </a:rPr>
+                          <m:t>+</m:t>
+                        </m:r>
+                        <m:r>
+                          <a:rPr lang="fr-CA" b="0" i="1" smtClean="0">
+                            <a:solidFill>
+                              <a:srgbClr val="6FAD46"/>
+                            </a:solidFill>
+                            <a:latin typeface="Cambria Math" panose="02040503050406030204" pitchFamily="18" charset="0"/>
+                          </a:rPr>
+                          <m:t>1</m:t>
+                        </m:r>
+                      </m:sub>
+                      <m:sup>
+                        <m:r>
+                          <a:rPr lang="fr-CA" i="1">
+                            <a:solidFill>
+                              <a:srgbClr val="6FAD46"/>
+                            </a:solidFill>
+                            <a:latin typeface="Cambria Math" panose="02040503050406030204" pitchFamily="18" charset="0"/>
+                          </a:rPr>
+                          <m:t>𝑡</m:t>
+                        </m:r>
+                      </m:sup>
+                    </m:sSubSup>
+                    <m:r>
+                      <a:rPr lang="fr-CA" b="0" i="1" smtClean="0">
+                        <a:solidFill>
+                          <a:srgbClr val="6FAD46"/>
+                        </a:solidFill>
+                        <a:latin typeface="Cambria Math" panose="02040503050406030204" pitchFamily="18" charset="0"/>
+                        <a:ea typeface="Cambria Math" panose="02040503050406030204" pitchFamily="18" charset="0"/>
+                      </a:rPr>
+                      <m:t>)]÷3</m:t>
+                    </m:r>
+                  </m:oMath>
+                </a14:m>
+                <a:r>
+                  <a:rPr lang="fr-CA" dirty="0">
+                    <a:solidFill>
+                      <a:srgbClr val="6FAD46"/>
+                    </a:solidFill>
+                  </a:rPr>
+                  <a:t> </a:t>
+                </a:r>
+              </a:p>
+              <a:p>
+                <a:pPr algn="ctr"/>
+                <a14:m>
+                  <m:oMathPara xmlns:m="http://schemas.openxmlformats.org/officeDocument/2006/math">
+                    <m:oMathParaPr>
+                      <m:jc m:val="centerGroup"/>
+                    </m:oMathParaPr>
+                    <m:oMath xmlns:m="http://schemas.openxmlformats.org/officeDocument/2006/math">
+                      <m:acc>
+                        <m:accPr>
+                          <m:chr m:val="⃗"/>
+                          <m:ctrlPr>
+                            <a:rPr lang="fr-FR" i="1">
+                              <a:solidFill>
+                                <a:srgbClr val="6FAD46"/>
+                              </a:solidFill>
+                              <a:latin typeface="Cambria Math" panose="02040503050406030204" pitchFamily="18" charset="0"/>
+                            </a:rPr>
+                          </m:ctrlPr>
+                        </m:accPr>
+                        <m:e>
+                          <m:r>
+                            <a:rPr lang="fr-CA" i="1">
+                              <a:solidFill>
+                                <a:srgbClr val="6FAD46"/>
+                              </a:solidFill>
+                              <a:latin typeface="Cambria Math" panose="02040503050406030204" pitchFamily="18" charset="0"/>
+                            </a:rPr>
+                            <m:t>𝑛</m:t>
+                          </m:r>
+                        </m:e>
+                      </m:acc>
+                      <m:r>
+                        <a:rPr lang="fr-CA" b="0" i="1" smtClean="0">
+                          <a:solidFill>
+                            <a:srgbClr val="6FAD46"/>
+                          </a:solidFill>
+                          <a:latin typeface="Cambria Math" panose="02040503050406030204" pitchFamily="18" charset="0"/>
+                        </a:rPr>
+                        <m:t>=(</m:t>
+                      </m:r>
+                      <m:r>
+                        <a:rPr lang="fr-CA" b="0" i="1" smtClean="0">
+                          <a:solidFill>
+                            <a:srgbClr val="6FAD46"/>
+                          </a:solidFill>
+                          <a:latin typeface="Cambria Math" panose="02040503050406030204" pitchFamily="18" charset="0"/>
+                        </a:rPr>
+                        <m:t>1</m:t>
+                      </m:r>
+                      <m:r>
+                        <a:rPr lang="fr-CA" b="0" i="1" smtClean="0">
+                          <a:solidFill>
+                            <a:srgbClr val="6FAD46"/>
+                          </a:solidFill>
+                          <a:latin typeface="Cambria Math" panose="02040503050406030204" pitchFamily="18" charset="0"/>
+                        </a:rPr>
+                        <m:t>,</m:t>
+                      </m:r>
+                      <m:r>
+                        <a:rPr lang="fr-CA" b="0" i="1" smtClean="0">
+                          <a:solidFill>
+                            <a:srgbClr val="6FAD46"/>
+                          </a:solidFill>
+                          <a:latin typeface="Cambria Math" panose="02040503050406030204" pitchFamily="18" charset="0"/>
+                        </a:rPr>
+                        <m:t>0</m:t>
+                      </m:r>
+                      <m:r>
+                        <a:rPr lang="fr-CA" b="0" i="1" smtClean="0">
+                          <a:solidFill>
+                            <a:srgbClr val="6FAD46"/>
+                          </a:solidFill>
+                          <a:latin typeface="Cambria Math" panose="02040503050406030204" pitchFamily="18" charset="0"/>
+                        </a:rPr>
+                        <m:t>)</m:t>
+                      </m:r>
+                    </m:oMath>
+                  </m:oMathPara>
+                </a14:m>
+                <a:endParaRPr lang="fr-CA" dirty="0">
+                  <a:solidFill>
+                    <a:srgbClr val="6FAD46"/>
+                  </a:solidFill>
+                </a:endParaRPr>
+              </a:p>
+            </p:txBody>
+          </p:sp>
+        </mc:Choice>
+        <mc:Fallback>
+          <p:sp>
+            <p:nvSpPr>
+              <p:cNvPr id="9" name="ZoneTexte 8">
+                <a:extLst>
+                  <a:ext uri="{FF2B5EF4-FFF2-40B4-BE49-F238E27FC236}">
+                    <a16:creationId xmlns:a16="http://schemas.microsoft.com/office/drawing/2014/main" id="{A0DEE587-681A-1A82-80C1-940949F38F5B}"/>
+                  </a:ext>
+                </a:extLst>
+              </p:cNvPr>
+              <p:cNvSpPr txBox="1">
+                <a:spLocks noRot="1" noChangeAspect="1" noMove="1" noResize="1" noEditPoints="1" noAdjustHandles="1" noChangeArrowheads="1" noChangeShapeType="1" noTextEdit="1"/>
+              </p:cNvSpPr>
+              <p:nvPr/>
+            </p:nvSpPr>
+            <p:spPr>
+              <a:xfrm>
+                <a:off x="5903976" y="3023260"/>
+                <a:ext cx="6288024" cy="1869614"/>
+              </a:xfrm>
+              <a:prstGeom prst="rect">
+                <a:avLst/>
+              </a:prstGeom>
+              <a:blipFill>
+                <a:blip r:embed="rId6"/>
+                <a:stretch>
+                  <a:fillRect l="-873" t="-1629" b="-1629"/>
+                </a:stretch>
+              </a:blipFill>
+            </p:spPr>
+            <p:txBody>
+              <a:bodyPr/>
+              <a:lstStyle/>
+              <a:p>
+                <a:r>
+                  <a:rPr lang="fr-CA">
+                    <a:noFill/>
+                  </a:rPr>
+                  <a:t> </a:t>
+                </a:r>
+              </a:p>
+            </p:txBody>
+          </p:sp>
+        </mc:Fallback>
+      </mc:AlternateContent>
+      <p:sp>
+        <p:nvSpPr>
+          <p:cNvPr id="10" name="ZoneTexte 9">
+            <a:extLst>
+              <a:ext uri="{FF2B5EF4-FFF2-40B4-BE49-F238E27FC236}">
+                <a16:creationId xmlns:a16="http://schemas.microsoft.com/office/drawing/2014/main" id="{841669E0-8634-2A94-9DF2-325DD99B02AA}"/>
+              </a:ext>
+            </a:extLst>
+          </p:cNvPr>
+          <p:cNvSpPr txBox="1"/>
+          <p:nvPr/>
         </p:nvSpPr>
-        <p:spPr/>
+        <p:spPr>
+          <a:xfrm>
+            <a:off x="5999988" y="5008150"/>
+            <a:ext cx="6096000" cy="646331"/>
+          </a:xfrm>
+          <a:prstGeom prst="rect">
+            <a:avLst/>
+          </a:prstGeom>
+          <a:noFill/>
+        </p:spPr>
         <p:txBody>
-          <a:bodyPr/>
+          <a:bodyPr wrap="square" rtlCol="0">
+            <a:spAutoFit/>
+          </a:bodyPr>
           <a:lstStyle/>
           <a:p>
-            <a:endParaRPr lang="fr-FR" dirty="0"/>
+            <a:r>
+              <a:rPr lang="fr-CA" dirty="0" err="1"/>
+              <a:t>Dicrétisations</a:t>
+            </a:r>
+            <a:r>
+              <a:rPr lang="fr-CA" dirty="0"/>
+              <a:t> réalisées à l’aide des méthodes de </a:t>
+            </a:r>
+            <a:r>
+              <a:rPr lang="fr-CA" dirty="0" err="1"/>
+              <a:t>Gear</a:t>
+            </a:r>
+            <a:r>
+              <a:rPr lang="fr-CA" dirty="0"/>
+              <a:t>, d’ordre 2 :</a:t>
+            </a:r>
           </a:p>
         </p:txBody>
       </p:sp>
+      <p:pic>
+        <p:nvPicPr>
+          <p:cNvPr id="12" name="Image 11">
+            <a:extLst>
+              <a:ext uri="{FF2B5EF4-FFF2-40B4-BE49-F238E27FC236}">
+                <a16:creationId xmlns:a16="http://schemas.microsoft.com/office/drawing/2014/main" id="{32A8A863-AC5E-8C31-7C35-11133CCD2831}"/>
+              </a:ext>
+            </a:extLst>
+          </p:cNvPr>
+          <p:cNvPicPr>
+            <a:picLocks noChangeAspect="1"/>
+          </p:cNvPicPr>
+          <p:nvPr/>
+        </p:nvPicPr>
+        <p:blipFill>
+          <a:blip r:embed="rId7"/>
+          <a:stretch>
+            <a:fillRect/>
+          </a:stretch>
+        </p:blipFill>
+        <p:spPr>
+          <a:xfrm>
+            <a:off x="5903976" y="5752785"/>
+            <a:ext cx="6096000" cy="975360"/>
+          </a:xfrm>
+          <a:prstGeom prst="rect">
+            <a:avLst/>
+          </a:prstGeom>
+        </p:spPr>
+      </p:pic>
     </p:spTree>
     <p:extLst>
       <p:ext uri="{BB962C8B-B14F-4D97-AF65-F5344CB8AC3E}">

</xml_diff>

<commit_message>
pwp: ajout des slides sur la vérification de code, manque MMS et GCI
</commit_message>
<xml_diff>
--- a/projet_final/projet_final/MEC8211-Projet-final-Presentation.pptx
+++ b/projet_final/projet_final/MEC8211-Projet-final-Presentation.pptx
@@ -5,7 +5,7 @@
     <p:sldMasterId id="2147483648" r:id="rId1"/>
   </p:sldMasterIdLst>
   <p:notesMasterIdLst>
-    <p:notesMasterId r:id="rId11"/>
+    <p:notesMasterId r:id="rId13"/>
   </p:notesMasterIdLst>
   <p:sldIdLst>
     <p:sldId id="256" r:id="rId2"/>
@@ -17,6 +17,8 @@
     <p:sldId id="260" r:id="rId8"/>
     <p:sldId id="262" r:id="rId9"/>
     <p:sldId id="261" r:id="rId10"/>
+    <p:sldId id="265" r:id="rId11"/>
+    <p:sldId id="266" r:id="rId12"/>
   </p:sldIdLst>
   <p:sldSz cx="12192000" cy="6858000"/>
   <p:notesSz cx="6858000" cy="9144000"/>
@@ -4112,6 +4114,316 @@
 </p:sld>
 </file>
 
+<file path=ppt/slides/slide10.xml><?xml version="1.0" encoding="utf-8"?>
+<p:sld xmlns:a="http://schemas.openxmlformats.org/drawingml/2006/main" xmlns:r="http://schemas.openxmlformats.org/officeDocument/2006/relationships" xmlns:p="http://schemas.openxmlformats.org/presentationml/2006/main">
+  <p:cSld>
+    <p:spTree>
+      <p:nvGrpSpPr>
+        <p:cNvPr id="1" name="">
+          <a:extLst>
+            <a:ext uri="{FF2B5EF4-FFF2-40B4-BE49-F238E27FC236}">
+              <a16:creationId xmlns:a16="http://schemas.microsoft.com/office/drawing/2014/main" id="{D728461F-0ADA-F2B0-A6E7-097DBD122703}"/>
+            </a:ext>
+          </a:extLst>
+        </p:cNvPr>
+        <p:cNvGrpSpPr/>
+        <p:nvPr/>
+      </p:nvGrpSpPr>
+      <p:grpSpPr>
+        <a:xfrm>
+          <a:off x="0" y="0"/>
+          <a:ext cx="0" cy="0"/>
+          <a:chOff x="0" y="0"/>
+          <a:chExt cx="0" cy="0"/>
+        </a:xfrm>
+      </p:grpSpPr>
+      <p:sp>
+        <p:nvSpPr>
+          <p:cNvPr id="2" name="Titre 1">
+            <a:extLst>
+              <a:ext uri="{FF2B5EF4-FFF2-40B4-BE49-F238E27FC236}">
+                <a16:creationId xmlns:a16="http://schemas.microsoft.com/office/drawing/2014/main" id="{C0CE1403-3D16-B3B5-E3F3-9368B3195007}"/>
+              </a:ext>
+            </a:extLst>
+          </p:cNvPr>
+          <p:cNvSpPr>
+            <a:spLocks noGrp="1"/>
+          </p:cNvSpPr>
+          <p:nvPr>
+            <p:ph type="title"/>
+          </p:nvPr>
+        </p:nvSpPr>
+        <p:spPr/>
+        <p:txBody>
+          <a:bodyPr/>
+          <a:lstStyle/>
+          <a:p>
+            <a:r>
+              <a:rPr lang="fr-FR" dirty="0"/>
+              <a:t>Vérification de code - Résultats :</a:t>
+            </a:r>
+          </a:p>
+        </p:txBody>
+      </p:sp>
+      <p:sp>
+        <p:nvSpPr>
+          <p:cNvPr id="3" name="Espace réservé du contenu 2">
+            <a:extLst>
+              <a:ext uri="{FF2B5EF4-FFF2-40B4-BE49-F238E27FC236}">
+                <a16:creationId xmlns:a16="http://schemas.microsoft.com/office/drawing/2014/main" id="{E699FE2D-5448-2AC8-260C-B0D0A0501122}"/>
+              </a:ext>
+            </a:extLst>
+          </p:cNvPr>
+          <p:cNvSpPr>
+            <a:spLocks noGrp="1"/>
+          </p:cNvSpPr>
+          <p:nvPr>
+            <p:ph idx="1"/>
+          </p:nvPr>
+        </p:nvSpPr>
+        <p:spPr/>
+        <p:txBody>
+          <a:bodyPr>
+            <a:normAutofit fontScale="92500" lnSpcReduction="20000"/>
+          </a:bodyPr>
+          <a:lstStyle/>
+          <a:p>
+            <a:r>
+              <a:rPr lang="fr-FR" dirty="0"/>
+              <a:t>Tests unitaires : rien de surprenant, objectif de conserver une pérennité et une stabilité du code malgré des changements.</a:t>
+            </a:r>
+          </a:p>
+          <a:p>
+            <a:r>
+              <a:rPr lang="fr-FR" dirty="0"/>
+              <a:t>Tests de vérification de code :</a:t>
+            </a:r>
+          </a:p>
+          <a:p>
+            <a:pPr lvl="1">
+              <a:buFont typeface="Courier New" panose="02070309020205020404" pitchFamily="49" charset="0"/>
+              <a:buChar char="o"/>
+            </a:pPr>
+            <a:r>
+              <a:rPr lang="fr-FR" dirty="0" err="1"/>
+              <a:t>testSymmetrie</a:t>
+            </a:r>
+            <a:r>
+              <a:rPr lang="fr-FR" dirty="0"/>
+              <a:t> :</a:t>
+            </a:r>
+          </a:p>
+          <a:p>
+            <a:pPr lvl="2">
+              <a:buFont typeface="Courier New" panose="02070309020205020404" pitchFamily="49" charset="0"/>
+              <a:buChar char="o"/>
+            </a:pPr>
+            <a:r>
+              <a:rPr lang="fr-FR" dirty="0"/>
+              <a:t> A révélé un </a:t>
+            </a:r>
+            <a:r>
+              <a:rPr lang="fr-FR" i="1" dirty="0"/>
+              <a:t>champ de mine</a:t>
+            </a:r>
+            <a:r>
+              <a:rPr lang="fr-FR" dirty="0"/>
+              <a:t> de bugs au sein du code.</a:t>
+            </a:r>
+          </a:p>
+          <a:p>
+            <a:pPr lvl="2">
+              <a:buFont typeface="Courier New" panose="02070309020205020404" pitchFamily="49" charset="0"/>
+              <a:buChar char="o"/>
+            </a:pPr>
+            <a:r>
+              <a:rPr lang="fr-FR" dirty="0"/>
+              <a:t>A permis de revisiter et de réécrire correctement les équations de discrétisation (que nous croyions déjà bonne).</a:t>
+            </a:r>
+          </a:p>
+          <a:p>
+            <a:pPr lvl="2">
+              <a:buFont typeface="Courier New" panose="02070309020205020404" pitchFamily="49" charset="0"/>
+              <a:buChar char="o"/>
+            </a:pPr>
+            <a:r>
+              <a:rPr lang="fr-FR" dirty="0"/>
+              <a:t>Problèmes d’indexation des points, notamment pour les conditions frontières aux </a:t>
+            </a:r>
+            <a:r>
+              <a:rPr lang="fr-FR" i="1" dirty="0"/>
+              <a:t>coins</a:t>
+            </a:r>
+            <a:r>
+              <a:rPr lang="fr-FR" dirty="0"/>
+              <a:t> du domaine.</a:t>
+            </a:r>
+          </a:p>
+          <a:p>
+            <a:pPr lvl="1">
+              <a:buFont typeface="Courier New" panose="02070309020205020404" pitchFamily="49" charset="0"/>
+              <a:buChar char="o"/>
+            </a:pPr>
+            <a:r>
+              <a:rPr lang="fr-FR" dirty="0" err="1"/>
+              <a:t>testInvarianceGaliléenne</a:t>
+            </a:r>
+            <a:r>
+              <a:rPr lang="fr-FR" dirty="0"/>
+              <a:t> :</a:t>
+            </a:r>
+          </a:p>
+          <a:p>
+            <a:pPr lvl="2">
+              <a:buFont typeface="Courier New" panose="02070309020205020404" pitchFamily="49" charset="0"/>
+              <a:buChar char="o"/>
+            </a:pPr>
+            <a:r>
+              <a:rPr lang="fr-FR" dirty="0"/>
+              <a:t>A révélé quelques subtilités du code qui on permis de l’améliorer, notamment la manière dont est calculé le rayon et la manière dont sont initialisés les paramètres.</a:t>
+            </a:r>
+          </a:p>
+          <a:p>
+            <a:pPr lvl="1">
+              <a:buFont typeface="Courier New" panose="02070309020205020404" pitchFamily="49" charset="0"/>
+              <a:buChar char="o"/>
+            </a:pPr>
+            <a:r>
+              <a:rPr lang="fr-FR" dirty="0" err="1"/>
+              <a:t>testConservationEnergie</a:t>
+            </a:r>
+            <a:r>
+              <a:rPr lang="fr-FR" dirty="0"/>
+              <a:t> :</a:t>
+            </a:r>
+          </a:p>
+          <a:p>
+            <a:pPr lvl="2">
+              <a:buFont typeface="Courier New" panose="02070309020205020404" pitchFamily="49" charset="0"/>
+              <a:buChar char="o"/>
+            </a:pPr>
+            <a:r>
+              <a:rPr lang="fr-FR" dirty="0"/>
+              <a:t>Un peu complexe à mettre en place. </a:t>
+            </a:r>
+          </a:p>
+          <a:p>
+            <a:pPr lvl="2">
+              <a:buFont typeface="Courier New" panose="02070309020205020404" pitchFamily="49" charset="0"/>
+              <a:buChar char="o"/>
+            </a:pPr>
+            <a:r>
+              <a:rPr lang="fr-FR" dirty="0"/>
+              <a:t>Flux de chaleur conservé de manière satisfaisante, au millième près.</a:t>
+            </a:r>
+          </a:p>
+        </p:txBody>
+      </p:sp>
+    </p:spTree>
+    <p:extLst>
+      <p:ext uri="{BB962C8B-B14F-4D97-AF65-F5344CB8AC3E}">
+        <p14:creationId xmlns:p14="http://schemas.microsoft.com/office/powerpoint/2010/main" val="845833206"/>
+      </p:ext>
+    </p:extLst>
+  </p:cSld>
+  <p:clrMapOvr>
+    <a:masterClrMapping/>
+  </p:clrMapOvr>
+</p:sld>
+</file>
+
+<file path=ppt/slides/slide11.xml><?xml version="1.0" encoding="utf-8"?>
+<p:sld xmlns:a="http://schemas.openxmlformats.org/drawingml/2006/main" xmlns:r="http://schemas.openxmlformats.org/officeDocument/2006/relationships" xmlns:p="http://schemas.openxmlformats.org/presentationml/2006/main">
+  <p:cSld>
+    <p:spTree>
+      <p:nvGrpSpPr>
+        <p:cNvPr id="1" name="">
+          <a:extLst>
+            <a:ext uri="{FF2B5EF4-FFF2-40B4-BE49-F238E27FC236}">
+              <a16:creationId xmlns:a16="http://schemas.microsoft.com/office/drawing/2014/main" id="{2D58B92D-CCAF-B970-4FDC-1318950469AF}"/>
+            </a:ext>
+          </a:extLst>
+        </p:cNvPr>
+        <p:cNvGrpSpPr/>
+        <p:nvPr/>
+      </p:nvGrpSpPr>
+      <p:grpSpPr>
+        <a:xfrm>
+          <a:off x="0" y="0"/>
+          <a:ext cx="0" cy="0"/>
+          <a:chOff x="0" y="0"/>
+          <a:chExt cx="0" cy="0"/>
+        </a:xfrm>
+      </p:grpSpPr>
+      <p:sp>
+        <p:nvSpPr>
+          <p:cNvPr id="2" name="Titre 1">
+            <a:extLst>
+              <a:ext uri="{FF2B5EF4-FFF2-40B4-BE49-F238E27FC236}">
+                <a16:creationId xmlns:a16="http://schemas.microsoft.com/office/drawing/2014/main" id="{D217134A-892B-0D3A-608A-3FB298A4622A}"/>
+              </a:ext>
+            </a:extLst>
+          </p:cNvPr>
+          <p:cNvSpPr>
+            <a:spLocks noGrp="1"/>
+          </p:cNvSpPr>
+          <p:nvPr>
+            <p:ph type="title"/>
+          </p:nvPr>
+        </p:nvSpPr>
+        <p:spPr/>
+        <p:txBody>
+          <a:bodyPr/>
+          <a:lstStyle/>
+          <a:p>
+            <a:r>
+              <a:rPr lang="fr-FR" dirty="0"/>
+              <a:t>Vérification de code - MMS :</a:t>
+            </a:r>
+          </a:p>
+        </p:txBody>
+      </p:sp>
+      <p:sp>
+        <p:nvSpPr>
+          <p:cNvPr id="3" name="Espace réservé du contenu 2">
+            <a:extLst>
+              <a:ext uri="{FF2B5EF4-FFF2-40B4-BE49-F238E27FC236}">
+                <a16:creationId xmlns:a16="http://schemas.microsoft.com/office/drawing/2014/main" id="{26B832D3-1AFE-0930-0EA6-79DF70C198F0}"/>
+              </a:ext>
+            </a:extLst>
+          </p:cNvPr>
+          <p:cNvSpPr>
+            <a:spLocks noGrp="1"/>
+          </p:cNvSpPr>
+          <p:nvPr>
+            <p:ph idx="1"/>
+          </p:nvPr>
+        </p:nvSpPr>
+        <p:spPr/>
+        <p:txBody>
+          <a:bodyPr/>
+          <a:lstStyle/>
+          <a:p>
+            <a:r>
+              <a:rPr lang="fr-FR" dirty="0"/>
+              <a:t>Implémentation de tests</a:t>
+            </a:r>
+          </a:p>
+        </p:txBody>
+      </p:sp>
+    </p:spTree>
+    <p:extLst>
+      <p:ext uri="{BB962C8B-B14F-4D97-AF65-F5344CB8AC3E}">
+        <p14:creationId xmlns:p14="http://schemas.microsoft.com/office/powerpoint/2010/main" val="3708032523"/>
+      </p:ext>
+    </p:extLst>
+  </p:cSld>
+  <p:clrMapOvr>
+    <a:masterClrMapping/>
+  </p:clrMapOvr>
+</p:sld>
+</file>
+
 <file path=ppt/slides/slide2.xml><?xml version="1.0" encoding="utf-8"?>
 <p:sld xmlns:a="http://schemas.openxmlformats.org/drawingml/2006/main" xmlns:r="http://schemas.openxmlformats.org/officeDocument/2006/relationships" xmlns:p="http://schemas.openxmlformats.org/presentationml/2006/main">
   <p:cSld>
@@ -15945,7 +16257,7 @@
                   <a:rPr lang="fr-FR" sz="2400" b="0" i="0" dirty="0">
                     <a:latin typeface="Cambria Math" panose="02040503050406030204" pitchFamily="18" charset="0"/>
                   </a:rPr>
-                  <a:t>Ordre 2 en espace (R et z) :</a:t>
+                  <a:t>Ordre 2 en espace (r et z) :</a:t>
                 </a:r>
               </a:p>
               <a:p>
@@ -20714,35 +21026,390 @@
           <a:bodyPr/>
           <a:lstStyle/>
           <a:p>
-            <a:endParaRPr lang="fr-FR"/>
+            <a:r>
+              <a:rPr lang="fr-FR" dirty="0"/>
+              <a:t>Vérification de code - Méthodologie :</a:t>
+            </a:r>
           </a:p>
         </p:txBody>
       </p:sp>
-      <p:sp>
-        <p:nvSpPr>
-          <p:cNvPr id="3" name="Espace réservé du contenu 2">
-            <a:extLst>
-              <a:ext uri="{FF2B5EF4-FFF2-40B4-BE49-F238E27FC236}">
-                <a16:creationId xmlns:a16="http://schemas.microsoft.com/office/drawing/2014/main" id="{4013CAEC-1AC4-C17B-EAFA-EC1AB7DBA279}"/>
-              </a:ext>
-            </a:extLst>
-          </p:cNvPr>
-          <p:cNvSpPr>
-            <a:spLocks noGrp="1"/>
-          </p:cNvSpPr>
-          <p:nvPr>
-            <p:ph idx="1"/>
-          </p:nvPr>
-        </p:nvSpPr>
-        <p:spPr/>
-        <p:txBody>
-          <a:bodyPr/>
-          <a:lstStyle/>
-          <a:p>
-            <a:endParaRPr lang="fr-FR"/>
-          </a:p>
-        </p:txBody>
-      </p:sp>
+      <mc:AlternateContent xmlns:mc="http://schemas.openxmlformats.org/markup-compatibility/2006">
+        <mc:Choice xmlns:a14="http://schemas.microsoft.com/office/drawing/2010/main" Requires="a14">
+          <p:sp>
+            <p:nvSpPr>
+              <p:cNvPr id="3" name="Espace réservé du contenu 2">
+                <a:extLst>
+                  <a:ext uri="{FF2B5EF4-FFF2-40B4-BE49-F238E27FC236}">
+                    <a16:creationId xmlns:a16="http://schemas.microsoft.com/office/drawing/2014/main" id="{4013CAEC-1AC4-C17B-EAFA-EC1AB7DBA279}"/>
+                  </a:ext>
+                </a:extLst>
+              </p:cNvPr>
+              <p:cNvSpPr>
+                <a:spLocks noGrp="1"/>
+              </p:cNvSpPr>
+              <p:nvPr>
+                <p:ph idx="1"/>
+              </p:nvPr>
+            </p:nvSpPr>
+            <p:spPr>
+              <a:xfrm>
+                <a:off x="838200" y="1825625"/>
+                <a:ext cx="10628376" cy="4351338"/>
+              </a:xfrm>
+            </p:spPr>
+            <p:txBody>
+              <a:bodyPr>
+                <a:normAutofit fontScale="77500" lnSpcReduction="20000"/>
+              </a:bodyPr>
+              <a:lstStyle/>
+              <a:p>
+                <a:pPr>
+                  <a:lnSpc>
+                    <a:spcPct val="124000"/>
+                  </a:lnSpc>
+                </a:pPr>
+                <a:r>
+                  <a:rPr lang="fr-FR" dirty="0"/>
+                  <a:t>Implémentation de divers tests avec le module </a:t>
+                </a:r>
+                <a:r>
+                  <a:rPr lang="fr-FR" i="1" dirty="0" err="1"/>
+                  <a:t>unittest</a:t>
+                </a:r>
+                <a:r>
+                  <a:rPr lang="fr-FR" dirty="0"/>
+                  <a:t> de python :</a:t>
+                </a:r>
+              </a:p>
+              <a:p>
+                <a:pPr lvl="1">
+                  <a:lnSpc>
+                    <a:spcPct val="124000"/>
+                  </a:lnSpc>
+                </a:pPr>
+                <a:r>
+                  <a:rPr lang="fr-FR" b="1" dirty="0"/>
+                  <a:t>Tests unitaires </a:t>
+                </a:r>
+                <a:r>
+                  <a:rPr lang="fr-FR" dirty="0"/>
+                  <a:t>pour les différentes fonctions du code implémentés :</a:t>
+                </a:r>
+              </a:p>
+              <a:p>
+                <a:pPr lvl="2">
+                  <a:lnSpc>
+                    <a:spcPct val="124000"/>
+                  </a:lnSpc>
+                  <a:buFont typeface="Courier New" panose="02070309020205020404" pitchFamily="49" charset="0"/>
+                  <a:buChar char="o"/>
+                </a:pPr>
+                <a:r>
+                  <a:rPr lang="fr-FR" b="1" dirty="0" err="1"/>
+                  <a:t>testPosition</a:t>
+                </a:r>
+                <a:r>
+                  <a:rPr lang="fr-FR" dirty="0"/>
+                  <a:t> : </a:t>
+                </a:r>
+                <a:r>
+                  <a:rPr lang="fr-CA" dirty="0"/>
+                  <a:t>Test la fonction Position avec des valeurs connues.</a:t>
+                </a:r>
+              </a:p>
+              <a:p>
+                <a:pPr lvl="2">
+                  <a:lnSpc>
+                    <a:spcPct val="124000"/>
+                  </a:lnSpc>
+                  <a:buFont typeface="Courier New" panose="02070309020205020404" pitchFamily="49" charset="0"/>
+                  <a:buChar char="o"/>
+                </a:pPr>
+                <a:r>
+                  <a:rPr lang="fr-CA" b="1" dirty="0" err="1"/>
+                  <a:t>testMilieu</a:t>
+                </a:r>
+                <a:r>
+                  <a:rPr lang="fr-CA" dirty="0"/>
+                  <a:t> : Test la fonction Milieu avec des valeurs connues.</a:t>
+                </a:r>
+              </a:p>
+              <a:p>
+                <a:pPr lvl="2">
+                  <a:lnSpc>
+                    <a:spcPct val="124000"/>
+                  </a:lnSpc>
+                  <a:buFont typeface="Courier New" panose="02070309020205020404" pitchFamily="49" charset="0"/>
+                  <a:buChar char="o"/>
+                </a:pPr>
+                <a:r>
+                  <a:rPr lang="fr-CA" b="1" dirty="0" err="1"/>
+                  <a:t>testTemperature</a:t>
+                </a:r>
+                <a:r>
+                  <a:rPr lang="fr-CA" dirty="0"/>
+                  <a:t> : Test la fonction </a:t>
+                </a:r>
+                <a:r>
+                  <a:rPr lang="fr-CA" dirty="0" err="1"/>
+                  <a:t>Temperature</a:t>
+                </a:r>
+                <a:r>
+                  <a:rPr lang="fr-CA" dirty="0"/>
+                  <a:t> avec des valeurs connues.</a:t>
+                </a:r>
+              </a:p>
+              <a:p>
+                <a:pPr lvl="1">
+                  <a:lnSpc>
+                    <a:spcPct val="124000"/>
+                  </a:lnSpc>
+                </a:pPr>
+                <a:r>
+                  <a:rPr lang="fr-CA" b="1" dirty="0"/>
+                  <a:t>Tests de vérification de code </a:t>
+                </a:r>
+                <a:r>
+                  <a:rPr lang="fr-CA" dirty="0"/>
+                  <a:t>implémentés :</a:t>
+                </a:r>
+              </a:p>
+              <a:p>
+                <a:pPr lvl="2">
+                  <a:lnSpc>
+                    <a:spcPct val="124000"/>
+                  </a:lnSpc>
+                  <a:buFont typeface="Courier New" panose="02070309020205020404" pitchFamily="49" charset="0"/>
+                  <a:buChar char="o"/>
+                </a:pPr>
+                <a:r>
+                  <a:rPr lang="fr-CA" b="1" dirty="0" err="1"/>
+                  <a:t>testSymetrie</a:t>
+                </a:r>
+                <a:r>
+                  <a:rPr lang="fr-CA" dirty="0"/>
+                  <a:t> : Test la simplification de la condition de symétrie en comparant le résultat symétrique au résultat du domaine complet.</a:t>
+                </a:r>
+              </a:p>
+              <a:p>
+                <a:pPr lvl="2">
+                  <a:lnSpc>
+                    <a:spcPct val="124000"/>
+                  </a:lnSpc>
+                  <a:buFont typeface="Courier New" panose="02070309020205020404" pitchFamily="49" charset="0"/>
+                  <a:buChar char="o"/>
+                </a:pPr>
+                <a:r>
+                  <a:rPr lang="fr-CA" b="1" dirty="0" err="1"/>
+                  <a:t>testConservationEnergie</a:t>
+                </a:r>
+                <a:r>
+                  <a:rPr lang="fr-CA" dirty="0"/>
+                  <a:t> : Test la conservation de l'énergie du solveur en effectuant un bilan </a:t>
+                </a:r>
+                <a:r>
+                  <a:rPr lang="fr-CA" dirty="0" err="1"/>
+                  <a:t>énegérique</a:t>
+                </a:r>
+                <a:r>
+                  <a:rPr lang="fr-CA" dirty="0"/>
+                  <a:t> à l'intérieur du domaine et sur la frontière. On cherche :</a:t>
+                </a:r>
+                <a:br>
+                  <a:rPr lang="fr-CA" dirty="0"/>
+                </a:br>
+                <a14:m>
+                  <m:oMath xmlns:m="http://schemas.openxmlformats.org/officeDocument/2006/math">
+                    <m:acc>
+                      <m:accPr>
+                        <m:chr m:val="̇"/>
+                        <m:ctrlPr>
+                          <a:rPr lang="fr-CA" i="1" smtClean="0">
+                            <a:latin typeface="Cambria Math" panose="02040503050406030204" pitchFamily="18" charset="0"/>
+                          </a:rPr>
+                        </m:ctrlPr>
+                      </m:accPr>
+                      <m:e>
+                        <m:sSub>
+                          <m:sSubPr>
+                            <m:ctrlPr>
+                              <a:rPr lang="fr-CA" b="0" i="1" smtClean="0">
+                                <a:latin typeface="Cambria Math" panose="02040503050406030204" pitchFamily="18" charset="0"/>
+                              </a:rPr>
+                            </m:ctrlPr>
+                          </m:sSubPr>
+                          <m:e>
+                            <m:r>
+                              <a:rPr lang="fr-CA" b="0" i="1" smtClean="0">
+                                <a:latin typeface="Cambria Math" panose="02040503050406030204" pitchFamily="18" charset="0"/>
+                              </a:rPr>
+                              <m:t>𝑞</m:t>
+                            </m:r>
+                          </m:e>
+                          <m:sub>
+                            <m:r>
+                              <a:rPr lang="fr-CA" b="0" i="1" smtClean="0">
+                                <a:latin typeface="Cambria Math" panose="02040503050406030204" pitchFamily="18" charset="0"/>
+                              </a:rPr>
+                              <m:t>𝑖𝑛𝑡</m:t>
+                            </m:r>
+                          </m:sub>
+                        </m:sSub>
+                      </m:e>
+                    </m:acc>
+                    <m:r>
+                      <a:rPr lang="fr-CA" i="1" smtClean="0">
+                        <a:latin typeface="Cambria Math" panose="02040503050406030204" pitchFamily="18" charset="0"/>
+                        <a:ea typeface="Cambria Math" panose="02040503050406030204" pitchFamily="18" charset="0"/>
+                      </a:rPr>
+                      <m:t>≈</m:t>
+                    </m:r>
+                    <m:acc>
+                      <m:accPr>
+                        <m:chr m:val="̇"/>
+                        <m:ctrlPr>
+                          <a:rPr lang="fr-CA" i="1">
+                            <a:latin typeface="Cambria Math" panose="02040503050406030204" pitchFamily="18" charset="0"/>
+                          </a:rPr>
+                        </m:ctrlPr>
+                      </m:accPr>
+                      <m:e>
+                        <m:sSub>
+                          <m:sSubPr>
+                            <m:ctrlPr>
+                              <a:rPr lang="fr-CA" i="1">
+                                <a:latin typeface="Cambria Math" panose="02040503050406030204" pitchFamily="18" charset="0"/>
+                              </a:rPr>
+                            </m:ctrlPr>
+                          </m:sSubPr>
+                          <m:e>
+                            <m:r>
+                              <a:rPr lang="fr-CA" i="1">
+                                <a:latin typeface="Cambria Math" panose="02040503050406030204" pitchFamily="18" charset="0"/>
+                              </a:rPr>
+                              <m:t>𝑞</m:t>
+                            </m:r>
+                          </m:e>
+                          <m:sub>
+                            <m:r>
+                              <a:rPr lang="fr-CA" i="1">
+                                <a:latin typeface="Cambria Math" panose="02040503050406030204" pitchFamily="18" charset="0"/>
+                              </a:rPr>
+                              <m:t>𝑓𝑟𝑜𝑛𝑡</m:t>
+                            </m:r>
+                          </m:sub>
+                        </m:sSub>
+                      </m:e>
+                    </m:acc>
+                  </m:oMath>
+                </a14:m>
+                <a:endParaRPr lang="fr-CA" dirty="0"/>
+              </a:p>
+              <a:p>
+                <a:pPr lvl="2">
+                  <a:lnSpc>
+                    <a:spcPct val="124000"/>
+                  </a:lnSpc>
+                  <a:buFont typeface="Courier New" panose="02070309020205020404" pitchFamily="49" charset="0"/>
+                  <a:buChar char="o"/>
+                </a:pPr>
+                <a:r>
+                  <a:rPr lang="fr-CA" b="1" dirty="0" err="1"/>
+                  <a:t>testInvarianceGalileenne</a:t>
+                </a:r>
+                <a:r>
+                  <a:rPr lang="fr-CA" dirty="0"/>
+                  <a:t> : Test l’invariance galiléenne du solveur par translation des coordonnées.</a:t>
+                </a:r>
+              </a:p>
+              <a:p>
+                <a:pPr lvl="1">
+                  <a:lnSpc>
+                    <a:spcPct val="124000"/>
+                  </a:lnSpc>
+                </a:pPr>
+                <a:r>
+                  <a:rPr lang="fr-CA" dirty="0"/>
+                  <a:t>Implémentation de la </a:t>
+                </a:r>
+                <a:r>
+                  <a:rPr lang="fr-CA" b="1" dirty="0"/>
+                  <a:t>MMS</a:t>
+                </a:r>
+                <a:r>
+                  <a:rPr lang="fr-CA" dirty="0"/>
+                  <a:t> pour évaluer l’ordre de convergence du solveur.</a:t>
+                </a:r>
+              </a:p>
+              <a:p>
+                <a:pPr lvl="2">
+                  <a:buFont typeface="Courier New" panose="02070309020205020404" pitchFamily="49" charset="0"/>
+                  <a:buChar char="o"/>
+                </a:pPr>
+                <a:endParaRPr lang="fr-CA" dirty="0"/>
+              </a:p>
+              <a:p>
+                <a:pPr lvl="2">
+                  <a:buFont typeface="Courier New" panose="02070309020205020404" pitchFamily="49" charset="0"/>
+                  <a:buChar char="o"/>
+                </a:pPr>
+                <a:endParaRPr lang="fr-FR" dirty="0"/>
+              </a:p>
+              <a:p>
+                <a:pPr lvl="2"/>
+                <a:endParaRPr lang="fr-FR" dirty="0"/>
+              </a:p>
+              <a:p>
+                <a:pPr lvl="2"/>
+                <a:endParaRPr lang="fr-FR" dirty="0"/>
+              </a:p>
+            </p:txBody>
+          </p:sp>
+        </mc:Choice>
+        <mc:Fallback>
+          <p:sp>
+            <p:nvSpPr>
+              <p:cNvPr id="3" name="Espace réservé du contenu 2">
+                <a:extLst>
+                  <a:ext uri="{FF2B5EF4-FFF2-40B4-BE49-F238E27FC236}">
+                    <a16:creationId xmlns:a16="http://schemas.microsoft.com/office/drawing/2014/main" id="{4013CAEC-1AC4-C17B-EAFA-EC1AB7DBA279}"/>
+                  </a:ext>
+                </a:extLst>
+              </p:cNvPr>
+              <p:cNvSpPr>
+                <a:spLocks noGrp="1" noRot="1" noChangeAspect="1" noMove="1" noResize="1" noEditPoints="1" noAdjustHandles="1" noChangeArrowheads="1" noChangeShapeType="1" noTextEdit="1"/>
+              </p:cNvSpPr>
+              <p:nvPr>
+                <p:ph idx="1"/>
+              </p:nvPr>
+            </p:nvSpPr>
+            <p:spPr>
+              <a:xfrm>
+                <a:off x="838200" y="1825625"/>
+                <a:ext cx="10628376" cy="4351338"/>
+              </a:xfrm>
+              <a:blipFill>
+                <a:blip r:embed="rId2"/>
+                <a:stretch>
+                  <a:fillRect l="-688" t="-700" r="-574"/>
+                </a:stretch>
+              </a:blipFill>
+            </p:spPr>
+            <p:txBody>
+              <a:bodyPr/>
+              <a:lstStyle/>
+              <a:p>
+                <a:r>
+                  <a:rPr lang="fr-CA">
+                    <a:noFill/>
+                  </a:rPr>
+                  <a:t> </a:t>
+                </a:r>
+              </a:p>
+            </p:txBody>
+          </p:sp>
+        </mc:Fallback>
+      </mc:AlternateContent>
     </p:spTree>
     <p:extLst>
       <p:ext uri="{BB962C8B-B14F-4D97-AF65-F5344CB8AC3E}">

</xml_diff>

<commit_message>
pwp: ajout de la MMS
</commit_message>
<xml_diff>
--- a/projet_final/projet_final/MEC8211-Projet-final-Presentation.pptx
+++ b/projet_final/projet_final/MEC8211-Projet-final-Presentation.pptx
@@ -5,7 +5,7 @@
     <p:sldMasterId id="2147483648" r:id="rId1"/>
   </p:sldMasterIdLst>
   <p:notesMasterIdLst>
-    <p:notesMasterId r:id="rId13"/>
+    <p:notesMasterId r:id="rId15"/>
   </p:notesMasterIdLst>
   <p:sldIdLst>
     <p:sldId id="256" r:id="rId2"/>
@@ -19,6 +19,8 @@
     <p:sldId id="261" r:id="rId10"/>
     <p:sldId id="265" r:id="rId11"/>
     <p:sldId id="266" r:id="rId12"/>
+    <p:sldId id="267" r:id="rId13"/>
+    <p:sldId id="268" r:id="rId14"/>
   </p:sldIdLst>
   <p:sldSz cx="12192000" cy="6858000"/>
   <p:notesSz cx="6858000" cy="9144000"/>
@@ -4383,34 +4385,558 @@
           </a:p>
         </p:txBody>
       </p:sp>
-      <p:sp>
-        <p:nvSpPr>
-          <p:cNvPr id="3" name="Espace réservé du contenu 2">
-            <a:extLst>
-              <a:ext uri="{FF2B5EF4-FFF2-40B4-BE49-F238E27FC236}">
-                <a16:creationId xmlns:a16="http://schemas.microsoft.com/office/drawing/2014/main" id="{26B832D3-1AFE-0930-0EA6-79DF70C198F0}"/>
-              </a:ext>
-            </a:extLst>
-          </p:cNvPr>
-          <p:cNvSpPr>
-            <a:spLocks noGrp="1"/>
-          </p:cNvSpPr>
-          <p:nvPr>
-            <p:ph idx="1"/>
-          </p:nvPr>
-        </p:nvSpPr>
-        <p:spPr/>
-        <p:txBody>
-          <a:bodyPr/>
-          <a:lstStyle/>
-          <a:p>
-            <a:r>
-              <a:rPr lang="fr-FR" dirty="0"/>
-              <a:t>Implémentation de tests</a:t>
-            </a:r>
-          </a:p>
-        </p:txBody>
-      </p:sp>
+      <mc:AlternateContent xmlns:mc="http://schemas.openxmlformats.org/markup-compatibility/2006">
+        <mc:Choice xmlns:a14="http://schemas.microsoft.com/office/drawing/2010/main" Requires="a14">
+          <p:sp>
+            <p:nvSpPr>
+              <p:cNvPr id="3" name="Espace réservé du contenu 2">
+                <a:extLst>
+                  <a:ext uri="{FF2B5EF4-FFF2-40B4-BE49-F238E27FC236}">
+                    <a16:creationId xmlns:a16="http://schemas.microsoft.com/office/drawing/2014/main" id="{26B832D3-1AFE-0930-0EA6-79DF70C198F0}"/>
+                  </a:ext>
+                </a:extLst>
+              </p:cNvPr>
+              <p:cNvSpPr>
+                <a:spLocks noGrp="1"/>
+              </p:cNvSpPr>
+              <p:nvPr>
+                <p:ph idx="1"/>
+              </p:nvPr>
+            </p:nvSpPr>
+            <p:spPr/>
+            <p:txBody>
+              <a:bodyPr>
+                <a:normAutofit fontScale="92500" lnSpcReduction="20000"/>
+              </a:bodyPr>
+              <a:lstStyle/>
+              <a:p>
+                <a:r>
+                  <a:rPr lang="fr-FR" dirty="0"/>
+                  <a:t>Implémentation de la méthode des solutions manufacturés. </a:t>
+                </a:r>
+              </a:p>
+              <a:p>
+                <a:r>
+                  <a:rPr lang="fr-FR" dirty="0"/>
+                  <a:t>Changements nécessaires :</a:t>
+                </a:r>
+              </a:p>
+              <a:p>
+                <a:pPr lvl="1"/>
+                <a:r>
+                  <a:rPr lang="fr-FR" dirty="0"/>
+                  <a:t>Implémentation de conditions de Dirichlet aux frontières extérieures:</a:t>
+                </a:r>
+                <a:br>
+                  <a:rPr lang="fr-FR" dirty="0"/>
+                </a:br>
+                <a14:m>
+                  <m:oMath xmlns:m="http://schemas.openxmlformats.org/officeDocument/2006/math">
+                    <m:sSubSup>
+                      <m:sSubSupPr>
+                        <m:ctrlPr>
+                          <a:rPr lang="fr-CA" b="0" i="1" smtClean="0">
+                            <a:latin typeface="Cambria Math" panose="02040503050406030204" pitchFamily="18" charset="0"/>
+                          </a:rPr>
+                        </m:ctrlPr>
+                      </m:sSubSupPr>
+                      <m:e>
+                        <m:r>
+                          <a:rPr lang="fr-CA" b="0" i="1" smtClean="0">
+                            <a:latin typeface="Cambria Math" panose="02040503050406030204" pitchFamily="18" charset="0"/>
+                          </a:rPr>
+                          <m:t>𝑇</m:t>
+                        </m:r>
+                      </m:e>
+                      <m:sub>
+                        <m:r>
+                          <a:rPr lang="fr-CA" b="0" i="1" smtClean="0">
+                            <a:latin typeface="Cambria Math" panose="02040503050406030204" pitchFamily="18" charset="0"/>
+                          </a:rPr>
+                          <m:t>𝑟</m:t>
+                        </m:r>
+                        <m:r>
+                          <a:rPr lang="fr-CA" b="0" i="1" smtClean="0">
+                            <a:latin typeface="Cambria Math" panose="02040503050406030204" pitchFamily="18" charset="0"/>
+                          </a:rPr>
+                          <m:t>,</m:t>
+                        </m:r>
+                        <m:r>
+                          <a:rPr lang="fr-CA" b="0" i="1" smtClean="0">
+                            <a:latin typeface="Cambria Math" panose="02040503050406030204" pitchFamily="18" charset="0"/>
+                          </a:rPr>
+                          <m:t>𝑧</m:t>
+                        </m:r>
+                      </m:sub>
+                      <m:sup>
+                        <m:r>
+                          <a:rPr lang="fr-CA" b="0" i="1" smtClean="0">
+                            <a:latin typeface="Cambria Math" panose="02040503050406030204" pitchFamily="18" charset="0"/>
+                          </a:rPr>
+                          <m:t>𝑡</m:t>
+                        </m:r>
+                        <m:r>
+                          <a:rPr lang="fr-CA" b="0" i="1" smtClean="0">
+                            <a:latin typeface="Cambria Math" panose="02040503050406030204" pitchFamily="18" charset="0"/>
+                          </a:rPr>
+                          <m:t>+∆</m:t>
+                        </m:r>
+                        <m:r>
+                          <a:rPr lang="fr-CA" b="0" i="1" smtClean="0">
+                            <a:latin typeface="Cambria Math" panose="02040503050406030204" pitchFamily="18" charset="0"/>
+                          </a:rPr>
+                          <m:t>𝑡</m:t>
+                        </m:r>
+                      </m:sup>
+                    </m:sSubSup>
+                    <m:r>
+                      <a:rPr lang="fr-CA" b="0" i="1" smtClean="0">
+                        <a:latin typeface="Cambria Math" panose="02040503050406030204" pitchFamily="18" charset="0"/>
+                      </a:rPr>
+                      <m:t>=</m:t>
+                    </m:r>
+                    <m:sSubSup>
+                      <m:sSubSupPr>
+                        <m:ctrlPr>
+                          <a:rPr lang="fr-CA" b="0" i="1" smtClean="0">
+                            <a:latin typeface="Cambria Math" panose="02040503050406030204" pitchFamily="18" charset="0"/>
+                          </a:rPr>
+                        </m:ctrlPr>
+                      </m:sSubSupPr>
+                      <m:e>
+                        <m:sSub>
+                          <m:sSubPr>
+                            <m:ctrlPr>
+                              <a:rPr lang="fr-CA" b="0" i="1" smtClean="0">
+                                <a:latin typeface="Cambria Math" panose="02040503050406030204" pitchFamily="18" charset="0"/>
+                              </a:rPr>
+                            </m:ctrlPr>
+                          </m:sSubPr>
+                          <m:e>
+                            <m:r>
+                              <a:rPr lang="fr-CA" b="0" i="1" smtClean="0">
+                                <a:latin typeface="Cambria Math" panose="02040503050406030204" pitchFamily="18" charset="0"/>
+                              </a:rPr>
+                              <m:t>𝑇</m:t>
+                            </m:r>
+                          </m:e>
+                          <m:sub>
+                            <m:r>
+                              <a:rPr lang="fr-CA" b="0" i="1" smtClean="0">
+                                <a:latin typeface="Cambria Math" panose="02040503050406030204" pitchFamily="18" charset="0"/>
+                              </a:rPr>
+                              <m:t>𝑀𝑀𝑆</m:t>
+                            </m:r>
+                          </m:sub>
+                        </m:sSub>
+                      </m:e>
+                      <m:sub>
+                        <m:r>
+                          <a:rPr lang="fr-CA" b="0" i="1" smtClean="0">
+                            <a:latin typeface="Cambria Math" panose="02040503050406030204" pitchFamily="18" charset="0"/>
+                          </a:rPr>
+                          <m:t>𝑟</m:t>
+                        </m:r>
+                        <m:r>
+                          <a:rPr lang="fr-CA" b="0" i="1" smtClean="0">
+                            <a:latin typeface="Cambria Math" panose="02040503050406030204" pitchFamily="18" charset="0"/>
+                          </a:rPr>
+                          <m:t>,</m:t>
+                        </m:r>
+                        <m:r>
+                          <a:rPr lang="fr-CA" b="0" i="1" smtClean="0">
+                            <a:latin typeface="Cambria Math" panose="02040503050406030204" pitchFamily="18" charset="0"/>
+                          </a:rPr>
+                          <m:t>𝑧</m:t>
+                        </m:r>
+                      </m:sub>
+                      <m:sup>
+                        <m:r>
+                          <a:rPr lang="fr-CA" b="0" i="1" smtClean="0">
+                            <a:latin typeface="Cambria Math" panose="02040503050406030204" pitchFamily="18" charset="0"/>
+                          </a:rPr>
+                          <m:t>𝑡</m:t>
+                        </m:r>
+                        <m:r>
+                          <a:rPr lang="fr-CA" b="0" i="1" smtClean="0">
+                            <a:latin typeface="Cambria Math" panose="02040503050406030204" pitchFamily="18" charset="0"/>
+                          </a:rPr>
+                          <m:t>+∆</m:t>
+                        </m:r>
+                        <m:r>
+                          <a:rPr lang="fr-CA" b="0" i="1" smtClean="0">
+                            <a:latin typeface="Cambria Math" panose="02040503050406030204" pitchFamily="18" charset="0"/>
+                          </a:rPr>
+                          <m:t>𝑡</m:t>
+                        </m:r>
+                      </m:sup>
+                    </m:sSubSup>
+                  </m:oMath>
+                </a14:m>
+                <a:endParaRPr lang="fr-FR" dirty="0"/>
+              </a:p>
+              <a:p>
+                <a:pPr lvl="1"/>
+                <a:r>
+                  <a:rPr lang="fr-FR" dirty="0"/>
+                  <a:t>Implémentation d’un terme source dans l’équation du milieu du domaine.</a:t>
+                </a:r>
+              </a:p>
+              <a:p>
+                <a:pPr lvl="1"/>
+                <a:r>
+                  <a:rPr lang="fr-FR" dirty="0"/>
+                  <a:t>Repenser la classe </a:t>
+                </a:r>
+                <a:r>
+                  <a:rPr lang="fr-FR" i="1" dirty="0"/>
+                  <a:t>Paramètres</a:t>
+                </a:r>
+                <a:r>
+                  <a:rPr lang="fr-FR" dirty="0"/>
+                  <a:t> pour intégrer le tout et permettre à un utilisateur d’imposer une </a:t>
+                </a:r>
+                <a:r>
+                  <a:rPr lang="fr-FR" i="1" dirty="0"/>
+                  <a:t>MMS</a:t>
+                </a:r>
+                <a:r>
+                  <a:rPr lang="fr-FR" dirty="0"/>
+                  <a:t>, ou non.</a:t>
+                </a:r>
+              </a:p>
+              <a:p>
+                <a:r>
+                  <a:rPr lang="fr-FR" dirty="0"/>
+                  <a:t>Équation choisie :</a:t>
+                </a:r>
+                <a:br>
+                  <a:rPr lang="fr-FR" dirty="0"/>
+                </a:br>
+                <a14:m>
+                  <m:oMath xmlns:m="http://schemas.openxmlformats.org/officeDocument/2006/math">
+                    <m:sSub>
+                      <m:sSubPr>
+                        <m:ctrlPr>
+                          <a:rPr lang="fr-CA" b="0" i="1" smtClean="0">
+                            <a:latin typeface="Cambria Math" panose="02040503050406030204" pitchFamily="18" charset="0"/>
+                          </a:rPr>
+                        </m:ctrlPr>
+                      </m:sSubPr>
+                      <m:e>
+                        <m:r>
+                          <a:rPr lang="fr-CA" b="0" i="1" smtClean="0">
+                            <a:latin typeface="Cambria Math" panose="02040503050406030204" pitchFamily="18" charset="0"/>
+                          </a:rPr>
+                          <m:t>𝑇</m:t>
+                        </m:r>
+                      </m:e>
+                      <m:sub>
+                        <m:r>
+                          <a:rPr lang="fr-CA" b="0" i="1" smtClean="0">
+                            <a:latin typeface="Cambria Math" panose="02040503050406030204" pitchFamily="18" charset="0"/>
+                          </a:rPr>
+                          <m:t>𝑀𝑀𝑆</m:t>
+                        </m:r>
+                      </m:sub>
+                    </m:sSub>
+                    <m:r>
+                      <a:rPr lang="fr-CA" b="0" i="1" smtClean="0">
+                        <a:latin typeface="Cambria Math" panose="02040503050406030204" pitchFamily="18" charset="0"/>
+                      </a:rPr>
+                      <m:t>=</m:t>
+                    </m:r>
+                    <m:sSub>
+                      <m:sSubPr>
+                        <m:ctrlPr>
+                          <a:rPr lang="fr-CA" b="0" i="1" smtClean="0">
+                            <a:latin typeface="Cambria Math" panose="02040503050406030204" pitchFamily="18" charset="0"/>
+                          </a:rPr>
+                        </m:ctrlPr>
+                      </m:sSubPr>
+                      <m:e>
+                        <m:r>
+                          <a:rPr lang="fr-CA" b="0" i="1" smtClean="0">
+                            <a:latin typeface="Cambria Math" panose="02040503050406030204" pitchFamily="18" charset="0"/>
+                          </a:rPr>
+                          <m:t>𝑇</m:t>
+                        </m:r>
+                      </m:e>
+                      <m:sub>
+                        <m:r>
+                          <a:rPr lang="fr-CA" b="0" i="1" smtClean="0">
+                            <a:latin typeface="Cambria Math" panose="02040503050406030204" pitchFamily="18" charset="0"/>
+                          </a:rPr>
+                          <m:t>𝑟𝑒𝑓</m:t>
+                        </m:r>
+                      </m:sub>
+                    </m:sSub>
+                    <m:r>
+                      <a:rPr lang="fr-CA" b="0" i="1" smtClean="0">
+                        <a:latin typeface="Cambria Math" panose="02040503050406030204" pitchFamily="18" charset="0"/>
+                      </a:rPr>
+                      <m:t>+</m:t>
+                    </m:r>
+                    <m:r>
+                      <a:rPr lang="fr-CA" b="0" i="1" smtClean="0">
+                        <a:latin typeface="Cambria Math" panose="02040503050406030204" pitchFamily="18" charset="0"/>
+                      </a:rPr>
+                      <m:t>𝐴</m:t>
+                    </m:r>
+                    <m:sSup>
+                      <m:sSupPr>
+                        <m:ctrlPr>
+                          <a:rPr lang="fr-CA" b="0" i="1" smtClean="0">
+                            <a:latin typeface="Cambria Math" panose="02040503050406030204" pitchFamily="18" charset="0"/>
+                          </a:rPr>
+                        </m:ctrlPr>
+                      </m:sSupPr>
+                      <m:e>
+                        <m:r>
+                          <a:rPr lang="fr-CA" b="0" i="1" smtClean="0">
+                            <a:latin typeface="Cambria Math" panose="02040503050406030204" pitchFamily="18" charset="0"/>
+                          </a:rPr>
+                          <m:t>𝑒</m:t>
+                        </m:r>
+                      </m:e>
+                      <m:sup>
+                        <m:r>
+                          <a:rPr lang="fr-CA" b="0" i="1" smtClean="0">
+                            <a:latin typeface="Cambria Math" panose="02040503050406030204" pitchFamily="18" charset="0"/>
+                          </a:rPr>
+                          <m:t>(−</m:t>
+                        </m:r>
+                        <m:r>
+                          <a:rPr lang="fr-CA" b="0" i="1" smtClean="0">
+                            <a:latin typeface="Cambria Math" panose="02040503050406030204" pitchFamily="18" charset="0"/>
+                          </a:rPr>
+                          <m:t>𝑡</m:t>
+                        </m:r>
+                        <m:r>
+                          <a:rPr lang="fr-CA" b="0" i="1" smtClean="0">
+                            <a:latin typeface="Cambria Math" panose="02040503050406030204" pitchFamily="18" charset="0"/>
+                          </a:rPr>
+                          <m:t>/</m:t>
+                        </m:r>
+                        <m:sSub>
+                          <m:sSubPr>
+                            <m:ctrlPr>
+                              <a:rPr lang="fr-CA" b="0" i="1" smtClean="0">
+                                <a:latin typeface="Cambria Math" panose="02040503050406030204" pitchFamily="18" charset="0"/>
+                              </a:rPr>
+                            </m:ctrlPr>
+                          </m:sSubPr>
+                          <m:e>
+                            <m:r>
+                              <a:rPr lang="fr-CA" b="0" i="1" smtClean="0">
+                                <a:latin typeface="Cambria Math" panose="02040503050406030204" pitchFamily="18" charset="0"/>
+                              </a:rPr>
+                              <m:t>𝑡</m:t>
+                            </m:r>
+                          </m:e>
+                          <m:sub>
+                            <m:r>
+                              <a:rPr lang="fr-CA" b="0" i="1" smtClean="0">
+                                <a:latin typeface="Cambria Math" panose="02040503050406030204" pitchFamily="18" charset="0"/>
+                              </a:rPr>
+                              <m:t>𝑓𝑖𝑛𝑎𝑙</m:t>
+                            </m:r>
+                          </m:sub>
+                        </m:sSub>
+                        <m:r>
+                          <a:rPr lang="fr-CA" b="0" i="1" smtClean="0">
+                            <a:latin typeface="Cambria Math" panose="02040503050406030204" pitchFamily="18" charset="0"/>
+                          </a:rPr>
+                          <m:t>)</m:t>
+                        </m:r>
+                      </m:sup>
+                    </m:sSup>
+                    <m:func>
+                      <m:funcPr>
+                        <m:ctrlPr>
+                          <a:rPr lang="fr-CA" b="0" i="1" smtClean="0">
+                            <a:latin typeface="Cambria Math" panose="02040503050406030204" pitchFamily="18" charset="0"/>
+                          </a:rPr>
+                        </m:ctrlPr>
+                      </m:funcPr>
+                      <m:fName>
+                        <m:r>
+                          <m:rPr>
+                            <m:sty m:val="p"/>
+                          </m:rPr>
+                          <a:rPr lang="fr-CA" b="0" i="0" smtClean="0">
+                            <a:latin typeface="Cambria Math" panose="02040503050406030204" pitchFamily="18" charset="0"/>
+                          </a:rPr>
+                          <m:t>cos</m:t>
+                        </m:r>
+                      </m:fName>
+                      <m:e>
+                        <m:d>
+                          <m:dPr>
+                            <m:ctrlPr>
+                              <a:rPr lang="fr-CA" b="0" i="1" smtClean="0">
+                                <a:latin typeface="Cambria Math" panose="02040503050406030204" pitchFamily="18" charset="0"/>
+                              </a:rPr>
+                            </m:ctrlPr>
+                          </m:dPr>
+                          <m:e>
+                            <m:f>
+                              <m:fPr>
+                                <m:ctrlPr>
+                                  <a:rPr lang="fr-CA" b="0" i="1" smtClean="0">
+                                    <a:latin typeface="Cambria Math" panose="02040503050406030204" pitchFamily="18" charset="0"/>
+                                  </a:rPr>
+                                </m:ctrlPr>
+                              </m:fPr>
+                              <m:num>
+                                <m:r>
+                                  <a:rPr lang="fr-CA" b="0" i="1" smtClean="0">
+                                    <a:latin typeface="Cambria Math" panose="02040503050406030204" pitchFamily="18" charset="0"/>
+                                  </a:rPr>
+                                  <m:t>𝜋</m:t>
+                                </m:r>
+                                <m:r>
+                                  <a:rPr lang="fr-CA" b="0" i="1" smtClean="0">
+                                    <a:latin typeface="Cambria Math" panose="02040503050406030204" pitchFamily="18" charset="0"/>
+                                  </a:rPr>
+                                  <m:t>𝑟</m:t>
+                                </m:r>
+                              </m:num>
+                              <m:den>
+                                <m:r>
+                                  <a:rPr lang="fr-CA" b="0" i="1" smtClean="0">
+                                    <a:latin typeface="Cambria Math" panose="02040503050406030204" pitchFamily="18" charset="0"/>
+                                  </a:rPr>
+                                  <m:t>𝑅</m:t>
+                                </m:r>
+                              </m:den>
+                            </m:f>
+                          </m:e>
+                        </m:d>
+                      </m:e>
+                    </m:func>
+                    <m:r>
+                      <m:rPr>
+                        <m:sty m:val="p"/>
+                      </m:rPr>
+                      <a:rPr lang="fr-CA" b="0" i="0" smtClean="0">
+                        <a:latin typeface="Cambria Math" panose="02040503050406030204" pitchFamily="18" charset="0"/>
+                      </a:rPr>
+                      <m:t>cos</m:t>
+                    </m:r>
+                    <m:r>
+                      <a:rPr lang="fr-CA" b="0" i="1" smtClean="0">
+                        <a:latin typeface="Cambria Math" panose="02040503050406030204" pitchFamily="18" charset="0"/>
+                      </a:rPr>
+                      <m:t>⁡(</m:t>
+                    </m:r>
+                    <m:f>
+                      <m:fPr>
+                        <m:ctrlPr>
+                          <a:rPr lang="fr-CA" b="0" i="1" smtClean="0">
+                            <a:latin typeface="Cambria Math" panose="02040503050406030204" pitchFamily="18" charset="0"/>
+                          </a:rPr>
+                        </m:ctrlPr>
+                      </m:fPr>
+                      <m:num>
+                        <m:r>
+                          <a:rPr lang="fr-CA" b="0" i="1" smtClean="0">
+                            <a:latin typeface="Cambria Math" panose="02040503050406030204" pitchFamily="18" charset="0"/>
+                          </a:rPr>
+                          <m:t>𝜋</m:t>
+                        </m:r>
+                        <m:r>
+                          <a:rPr lang="fr-CA" b="0" i="1" smtClean="0">
+                            <a:latin typeface="Cambria Math" panose="02040503050406030204" pitchFamily="18" charset="0"/>
+                          </a:rPr>
+                          <m:t>𝑧</m:t>
+                        </m:r>
+                      </m:num>
+                      <m:den>
+                        <m:r>
+                          <a:rPr lang="fr-CA" b="0" i="1" smtClean="0">
+                            <a:latin typeface="Cambria Math" panose="02040503050406030204" pitchFamily="18" charset="0"/>
+                          </a:rPr>
+                          <m:t>𝐻</m:t>
+                        </m:r>
+                      </m:den>
+                    </m:f>
+                    <m:r>
+                      <a:rPr lang="fr-CA" b="0" i="1" smtClean="0">
+                        <a:latin typeface="Cambria Math" panose="02040503050406030204" pitchFamily="18" charset="0"/>
+                      </a:rPr>
+                      <m:t>)</m:t>
+                    </m:r>
+                  </m:oMath>
+                </a14:m>
+                <a:endParaRPr lang="fr-FR" dirty="0"/>
+              </a:p>
+              <a:p>
+                <a:pPr marL="914400" lvl="2" indent="0">
+                  <a:buNone/>
+                </a:pPr>
+                <a:r>
+                  <a:rPr lang="fr-FR" dirty="0"/>
+                  <a:t>Ici, on choisit 2 cosinus de manière à forcer l’équation a être symétrique aux frontières r=0, z=0.</a:t>
+                </a:r>
+              </a:p>
+              <a:p>
+                <a:r>
+                  <a:rPr lang="fr-FR" dirty="0"/>
+                  <a:t>Le calcul du terme source est fait à l’aide de la librairie </a:t>
+                </a:r>
+                <a:r>
+                  <a:rPr lang="fr-FR" i="1" dirty="0" err="1"/>
+                  <a:t>sympy</a:t>
+                </a:r>
+                <a:r>
+                  <a:rPr lang="fr-FR" dirty="0"/>
+                  <a:t> dans Python. Les développements ne seront donc pas présentés.</a:t>
+                </a:r>
+              </a:p>
+            </p:txBody>
+          </p:sp>
+        </mc:Choice>
+        <mc:Fallback>
+          <p:sp>
+            <p:nvSpPr>
+              <p:cNvPr id="3" name="Espace réservé du contenu 2">
+                <a:extLst>
+                  <a:ext uri="{FF2B5EF4-FFF2-40B4-BE49-F238E27FC236}">
+                    <a16:creationId xmlns:a16="http://schemas.microsoft.com/office/drawing/2014/main" id="{26B832D3-1AFE-0930-0EA6-79DF70C198F0}"/>
+                  </a:ext>
+                </a:extLst>
+              </p:cNvPr>
+              <p:cNvSpPr>
+                <a:spLocks noGrp="1" noRot="1" noChangeAspect="1" noMove="1" noResize="1" noEditPoints="1" noAdjustHandles="1" noChangeArrowheads="1" noChangeShapeType="1" noTextEdit="1"/>
+              </p:cNvSpPr>
+              <p:nvPr>
+                <p:ph idx="1"/>
+              </p:nvPr>
+            </p:nvSpPr>
+            <p:spPr>
+              <a:blipFill>
+                <a:blip r:embed="rId2"/>
+                <a:stretch>
+                  <a:fillRect l="-928" t="-3501" r="-464" b="-1401"/>
+                </a:stretch>
+              </a:blipFill>
+            </p:spPr>
+            <p:txBody>
+              <a:bodyPr/>
+              <a:lstStyle/>
+              <a:p>
+                <a:r>
+                  <a:rPr lang="fr-CA">
+                    <a:noFill/>
+                  </a:rPr>
+                  <a:t> </a:t>
+                </a:r>
+              </a:p>
+            </p:txBody>
+          </p:sp>
+        </mc:Fallback>
+      </mc:AlternateContent>
     </p:spTree>
     <p:extLst>
       <p:ext uri="{BB962C8B-B14F-4D97-AF65-F5344CB8AC3E}">
@@ -4421,6 +4947,664 @@
   <p:clrMapOvr>
     <a:masterClrMapping/>
   </p:clrMapOvr>
+</p:sld>
+</file>
+
+<file path=ppt/slides/slide12.xml><?xml version="1.0" encoding="utf-8"?>
+<p:sld xmlns:a="http://schemas.openxmlformats.org/drawingml/2006/main" xmlns:r="http://schemas.openxmlformats.org/officeDocument/2006/relationships" xmlns:p="http://schemas.openxmlformats.org/presentationml/2006/main">
+  <p:cSld>
+    <p:spTree>
+      <p:nvGrpSpPr>
+        <p:cNvPr id="1" name="">
+          <a:extLst>
+            <a:ext uri="{FF2B5EF4-FFF2-40B4-BE49-F238E27FC236}">
+              <a16:creationId xmlns:a16="http://schemas.microsoft.com/office/drawing/2014/main" id="{4810F47C-EA86-426C-9E31-441BF44D6DBA}"/>
+            </a:ext>
+          </a:extLst>
+        </p:cNvPr>
+        <p:cNvGrpSpPr/>
+        <p:nvPr/>
+      </p:nvGrpSpPr>
+      <p:grpSpPr>
+        <a:xfrm>
+          <a:off x="0" y="0"/>
+          <a:ext cx="0" cy="0"/>
+          <a:chOff x="0" y="0"/>
+          <a:chExt cx="0" cy="0"/>
+        </a:xfrm>
+      </p:grpSpPr>
+      <p:sp>
+        <p:nvSpPr>
+          <p:cNvPr id="2" name="Titre 1">
+            <a:extLst>
+              <a:ext uri="{FF2B5EF4-FFF2-40B4-BE49-F238E27FC236}">
+                <a16:creationId xmlns:a16="http://schemas.microsoft.com/office/drawing/2014/main" id="{15732BA4-6A05-72B7-DA5A-7F788E2CAD71}"/>
+              </a:ext>
+            </a:extLst>
+          </p:cNvPr>
+          <p:cNvSpPr>
+            <a:spLocks noGrp="1"/>
+          </p:cNvSpPr>
+          <p:nvPr>
+            <p:ph type="title"/>
+          </p:nvPr>
+        </p:nvSpPr>
+        <p:spPr/>
+        <p:txBody>
+          <a:bodyPr/>
+          <a:lstStyle/>
+          <a:p>
+            <a:r>
+              <a:rPr lang="fr-FR" dirty="0"/>
+              <a:t>Vérification de code – MMS – Résultats :</a:t>
+            </a:r>
+          </a:p>
+        </p:txBody>
+      </p:sp>
+      <p:pic>
+        <p:nvPicPr>
+          <p:cNvPr id="5" name="Espace réservé du contenu 4">
+            <a:extLst>
+              <a:ext uri="{FF2B5EF4-FFF2-40B4-BE49-F238E27FC236}">
+                <a16:creationId xmlns:a16="http://schemas.microsoft.com/office/drawing/2014/main" id="{C16CC2A3-774C-4A0E-8885-22E49233D892}"/>
+              </a:ext>
+            </a:extLst>
+          </p:cNvPr>
+          <p:cNvPicPr>
+            <a:picLocks noGrp="1" noChangeAspect="1"/>
+          </p:cNvPicPr>
+          <p:nvPr>
+            <p:ph idx="1"/>
+          </p:nvPr>
+        </p:nvPicPr>
+        <p:blipFill>
+          <a:blip r:embed="rId2">
+            <a:extLst>
+              <a:ext uri="{28A0092B-C50C-407E-A947-70E740481C1C}">
+                <a14:useLocalDpi xmlns:a14="http://schemas.microsoft.com/office/drawing/2010/main" val="0"/>
+              </a:ext>
+            </a:extLst>
+          </a:blip>
+          <a:stretch>
+            <a:fillRect/>
+          </a:stretch>
+        </p:blipFill>
+        <p:spPr>
+          <a:xfrm>
+            <a:off x="1902354" y="1690688"/>
+            <a:ext cx="8387292" cy="5032375"/>
+          </a:xfrm>
+          <a:prstGeom prst="rect">
+            <a:avLst/>
+          </a:prstGeom>
+        </p:spPr>
+      </p:pic>
+      <p:grpSp>
+        <p:nvGrpSpPr>
+          <p:cNvPr id="10" name="Groupe 9">
+            <a:extLst>
+              <a:ext uri="{FF2B5EF4-FFF2-40B4-BE49-F238E27FC236}">
+                <a16:creationId xmlns:a16="http://schemas.microsoft.com/office/drawing/2014/main" id="{0733C7CD-F52D-5C54-C2B4-44406B95C157}"/>
+              </a:ext>
+            </a:extLst>
+          </p:cNvPr>
+          <p:cNvGrpSpPr/>
+          <p:nvPr/>
+        </p:nvGrpSpPr>
+        <p:grpSpPr>
+          <a:xfrm>
+            <a:off x="311285" y="5077838"/>
+            <a:ext cx="3385226" cy="1448624"/>
+            <a:chOff x="311285" y="5077838"/>
+            <a:chExt cx="3385226" cy="1448624"/>
+          </a:xfrm>
+        </p:grpSpPr>
+        <p:sp>
+          <p:nvSpPr>
+            <p:cNvPr id="6" name="Rectangle 5">
+              <a:extLst>
+                <a:ext uri="{FF2B5EF4-FFF2-40B4-BE49-F238E27FC236}">
+                  <a16:creationId xmlns:a16="http://schemas.microsoft.com/office/drawing/2014/main" id="{D6CB769F-2C76-74CB-5981-7343AE429DE5}"/>
+                </a:ext>
+              </a:extLst>
+            </p:cNvPr>
+            <p:cNvSpPr/>
+            <p:nvPr/>
+          </p:nvSpPr>
+          <p:spPr>
+            <a:xfrm>
+              <a:off x="2373549" y="5077838"/>
+              <a:ext cx="1322962" cy="398834"/>
+            </a:xfrm>
+            <a:prstGeom prst="rect">
+              <a:avLst/>
+            </a:prstGeom>
+            <a:noFill/>
+            <a:ln w="57150">
+              <a:solidFill>
+                <a:schemeClr val="accent6">
+                  <a:lumMod val="60000"/>
+                  <a:lumOff val="40000"/>
+                </a:schemeClr>
+              </a:solidFill>
+            </a:ln>
+          </p:spPr>
+          <p:style>
+            <a:lnRef idx="2">
+              <a:schemeClr val="accent6">
+                <a:shade val="15000"/>
+              </a:schemeClr>
+            </a:lnRef>
+            <a:fillRef idx="1">
+              <a:schemeClr val="accent6"/>
+            </a:fillRef>
+            <a:effectRef idx="0">
+              <a:schemeClr val="accent6"/>
+            </a:effectRef>
+            <a:fontRef idx="minor">
+              <a:schemeClr val="lt1"/>
+            </a:fontRef>
+          </p:style>
+          <p:txBody>
+            <a:bodyPr rtlCol="0" anchor="ctr"/>
+            <a:lstStyle/>
+            <a:p>
+              <a:pPr algn="ctr"/>
+              <a:endParaRPr lang="fr-CA"/>
+            </a:p>
+          </p:txBody>
+        </p:sp>
+        <p:cxnSp>
+          <p:nvCxnSpPr>
+            <p:cNvPr id="8" name="Connecteur droit avec flèche 7">
+              <a:extLst>
+                <a:ext uri="{FF2B5EF4-FFF2-40B4-BE49-F238E27FC236}">
+                  <a16:creationId xmlns:a16="http://schemas.microsoft.com/office/drawing/2014/main" id="{CEEDC86A-29FF-1B82-1333-62836274B581}"/>
+                </a:ext>
+              </a:extLst>
+            </p:cNvPr>
+            <p:cNvCxnSpPr>
+              <a:stCxn id="6" idx="1"/>
+            </p:cNvCxnSpPr>
+            <p:nvPr/>
+          </p:nvCxnSpPr>
+          <p:spPr>
+            <a:xfrm flipH="1">
+              <a:off x="1322962" y="5277255"/>
+              <a:ext cx="1050587" cy="325877"/>
+            </a:xfrm>
+            <a:prstGeom prst="straightConnector1">
+              <a:avLst/>
+            </a:prstGeom>
+            <a:ln>
+              <a:tailEnd type="triangle"/>
+            </a:ln>
+          </p:spPr>
+          <p:style>
+            <a:lnRef idx="2">
+              <a:schemeClr val="accent1"/>
+            </a:lnRef>
+            <a:fillRef idx="0">
+              <a:schemeClr val="accent1"/>
+            </a:fillRef>
+            <a:effectRef idx="1">
+              <a:schemeClr val="accent1"/>
+            </a:effectRef>
+            <a:fontRef idx="minor">
+              <a:schemeClr val="tx1"/>
+            </a:fontRef>
+          </p:style>
+        </p:cxnSp>
+        <p:sp>
+          <p:nvSpPr>
+            <p:cNvPr id="9" name="ZoneTexte 8">
+              <a:extLst>
+                <a:ext uri="{FF2B5EF4-FFF2-40B4-BE49-F238E27FC236}">
+                  <a16:creationId xmlns:a16="http://schemas.microsoft.com/office/drawing/2014/main" id="{3AD781C3-D9E5-9A25-B650-D4D2A98A52FC}"/>
+                </a:ext>
+              </a:extLst>
+            </p:cNvPr>
+            <p:cNvSpPr txBox="1"/>
+            <p:nvPr/>
+          </p:nvSpPr>
+          <p:spPr>
+            <a:xfrm>
+              <a:off x="311285" y="5603132"/>
+              <a:ext cx="1741251" cy="923330"/>
+            </a:xfrm>
+            <a:prstGeom prst="rect">
+              <a:avLst/>
+            </a:prstGeom>
+            <a:noFill/>
+          </p:spPr>
+          <p:txBody>
+            <a:bodyPr wrap="square" rtlCol="0">
+              <a:spAutoFit/>
+            </a:bodyPr>
+            <a:lstStyle/>
+            <a:p>
+              <a:r>
+                <a:rPr lang="fr-CA" dirty="0"/>
+                <a:t>Discrétisation spatiale prend le dessus</a:t>
+              </a:r>
+            </a:p>
+          </p:txBody>
+        </p:sp>
+      </p:grpSp>
+    </p:spTree>
+    <p:extLst>
+      <p:ext uri="{BB962C8B-B14F-4D97-AF65-F5344CB8AC3E}">
+        <p14:creationId xmlns:p14="http://schemas.microsoft.com/office/powerpoint/2010/main" val="969147623"/>
+      </p:ext>
+    </p:extLst>
+  </p:cSld>
+  <p:clrMapOvr>
+    <a:masterClrMapping/>
+  </p:clrMapOvr>
+  <p:timing>
+    <p:tnLst>
+      <p:par>
+        <p:cTn id="1" dur="indefinite" restart="never" nodeType="tmRoot">
+          <p:childTnLst>
+            <p:seq concurrent="1" nextAc="seek">
+              <p:cTn id="2" dur="indefinite" nodeType="mainSeq">
+                <p:childTnLst>
+                  <p:par>
+                    <p:cTn id="3" fill="hold">
+                      <p:stCondLst>
+                        <p:cond delay="indefinite"/>
+                      </p:stCondLst>
+                      <p:childTnLst>
+                        <p:par>
+                          <p:cTn id="4" fill="hold">
+                            <p:stCondLst>
+                              <p:cond delay="0"/>
+                            </p:stCondLst>
+                            <p:childTnLst>
+                              <p:par>
+                                <p:cTn id="5" presetID="1" presetClass="entr" presetSubtype="0" fill="hold" nodeType="clickEffect">
+                                  <p:stCondLst>
+                                    <p:cond delay="0"/>
+                                  </p:stCondLst>
+                                  <p:childTnLst>
+                                    <p:set>
+                                      <p:cBhvr>
+                                        <p:cTn id="6" dur="1" fill="hold">
+                                          <p:stCondLst>
+                                            <p:cond delay="0"/>
+                                          </p:stCondLst>
+                                        </p:cTn>
+                                        <p:tgtEl>
+                                          <p:spTgt spid="10"/>
+                                        </p:tgtEl>
+                                        <p:attrNameLst>
+                                          <p:attrName>style.visibility</p:attrName>
+                                        </p:attrNameLst>
+                                      </p:cBhvr>
+                                      <p:to>
+                                        <p:strVal val="visible"/>
+                                      </p:to>
+                                    </p:set>
+                                  </p:childTnLst>
+                                </p:cTn>
+                              </p:par>
+                            </p:childTnLst>
+                          </p:cTn>
+                        </p:par>
+                      </p:childTnLst>
+                    </p:cTn>
+                  </p:par>
+                </p:childTnLst>
+              </p:cTn>
+              <p:prevCondLst>
+                <p:cond evt="onPrev" delay="0">
+                  <p:tgtEl>
+                    <p:sldTgt/>
+                  </p:tgtEl>
+                </p:cond>
+              </p:prevCondLst>
+              <p:nextCondLst>
+                <p:cond evt="onNext" delay="0">
+                  <p:tgtEl>
+                    <p:sldTgt/>
+                  </p:tgtEl>
+                </p:cond>
+              </p:nextCondLst>
+            </p:seq>
+          </p:childTnLst>
+        </p:cTn>
+      </p:par>
+    </p:tnLst>
+  </p:timing>
+</p:sld>
+</file>
+
+<file path=ppt/slides/slide13.xml><?xml version="1.0" encoding="utf-8"?>
+<p:sld xmlns:a="http://schemas.openxmlformats.org/drawingml/2006/main" xmlns:r="http://schemas.openxmlformats.org/officeDocument/2006/relationships" xmlns:p="http://schemas.openxmlformats.org/presentationml/2006/main">
+  <p:cSld>
+    <p:spTree>
+      <p:nvGrpSpPr>
+        <p:cNvPr id="1" name="">
+          <a:extLst>
+            <a:ext uri="{FF2B5EF4-FFF2-40B4-BE49-F238E27FC236}">
+              <a16:creationId xmlns:a16="http://schemas.microsoft.com/office/drawing/2014/main" id="{0714F719-4F8B-B0BF-A652-91D4A8E1C2E6}"/>
+            </a:ext>
+          </a:extLst>
+        </p:cNvPr>
+        <p:cNvGrpSpPr/>
+        <p:nvPr/>
+      </p:nvGrpSpPr>
+      <p:grpSpPr>
+        <a:xfrm>
+          <a:off x="0" y="0"/>
+          <a:ext cx="0" cy="0"/>
+          <a:chOff x="0" y="0"/>
+          <a:chExt cx="0" cy="0"/>
+        </a:xfrm>
+      </p:grpSpPr>
+      <p:sp>
+        <p:nvSpPr>
+          <p:cNvPr id="2" name="Titre 1">
+            <a:extLst>
+              <a:ext uri="{FF2B5EF4-FFF2-40B4-BE49-F238E27FC236}">
+                <a16:creationId xmlns:a16="http://schemas.microsoft.com/office/drawing/2014/main" id="{BF6CDAA5-638A-B4E8-6AFE-7C186CA43D2B}"/>
+              </a:ext>
+            </a:extLst>
+          </p:cNvPr>
+          <p:cNvSpPr>
+            <a:spLocks noGrp="1"/>
+          </p:cNvSpPr>
+          <p:nvPr>
+            <p:ph type="title"/>
+          </p:nvPr>
+        </p:nvSpPr>
+        <p:spPr/>
+        <p:txBody>
+          <a:bodyPr/>
+          <a:lstStyle/>
+          <a:p>
+            <a:r>
+              <a:rPr lang="fr-FR" dirty="0"/>
+              <a:t>Vérification de code – MMS – Résultats :</a:t>
+            </a:r>
+          </a:p>
+        </p:txBody>
+      </p:sp>
+      <p:pic>
+        <p:nvPicPr>
+          <p:cNvPr id="7" name="Espace réservé du contenu 6">
+            <a:extLst>
+              <a:ext uri="{FF2B5EF4-FFF2-40B4-BE49-F238E27FC236}">
+                <a16:creationId xmlns:a16="http://schemas.microsoft.com/office/drawing/2014/main" id="{6B8E9D59-8E3B-8479-E1C7-62F3A39A5D2D}"/>
+              </a:ext>
+            </a:extLst>
+          </p:cNvPr>
+          <p:cNvPicPr>
+            <a:picLocks noGrp="1" noChangeAspect="1"/>
+          </p:cNvPicPr>
+          <p:nvPr>
+            <p:ph idx="1"/>
+          </p:nvPr>
+        </p:nvPicPr>
+        <p:blipFill>
+          <a:blip r:embed="rId2">
+            <a:extLst>
+              <a:ext uri="{28A0092B-C50C-407E-A947-70E740481C1C}">
+                <a14:useLocalDpi xmlns:a14="http://schemas.microsoft.com/office/drawing/2010/main" val="0"/>
+              </a:ext>
+            </a:extLst>
+          </a:blip>
+          <a:stretch>
+            <a:fillRect/>
+          </a:stretch>
+        </p:blipFill>
+        <p:spPr>
+          <a:xfrm>
+            <a:off x="1902000" y="1690688"/>
+            <a:ext cx="8388000" cy="5032800"/>
+          </a:xfrm>
+          <a:prstGeom prst="rect">
+            <a:avLst/>
+          </a:prstGeom>
+        </p:spPr>
+      </p:pic>
+      <p:grpSp>
+        <p:nvGrpSpPr>
+          <p:cNvPr id="8" name="Groupe 7">
+            <a:extLst>
+              <a:ext uri="{FF2B5EF4-FFF2-40B4-BE49-F238E27FC236}">
+                <a16:creationId xmlns:a16="http://schemas.microsoft.com/office/drawing/2014/main" id="{4C4CFFBA-3429-F2F4-7F11-D968906589E4}"/>
+              </a:ext>
+            </a:extLst>
+          </p:cNvPr>
+          <p:cNvGrpSpPr/>
+          <p:nvPr/>
+        </p:nvGrpSpPr>
+        <p:grpSpPr>
+          <a:xfrm>
+            <a:off x="209387" y="3016251"/>
+            <a:ext cx="3385226" cy="1725623"/>
+            <a:chOff x="311285" y="5077838"/>
+            <a:chExt cx="3385226" cy="1725623"/>
+          </a:xfrm>
+        </p:grpSpPr>
+        <p:sp>
+          <p:nvSpPr>
+            <p:cNvPr id="9" name="Rectangle 8">
+              <a:extLst>
+                <a:ext uri="{FF2B5EF4-FFF2-40B4-BE49-F238E27FC236}">
+                  <a16:creationId xmlns:a16="http://schemas.microsoft.com/office/drawing/2014/main" id="{B57A2EE6-1A05-1DB3-5DAA-1C28E8D82F63}"/>
+                </a:ext>
+              </a:extLst>
+            </p:cNvPr>
+            <p:cNvSpPr/>
+            <p:nvPr/>
+          </p:nvSpPr>
+          <p:spPr>
+            <a:xfrm>
+              <a:off x="2373549" y="5077838"/>
+              <a:ext cx="1322962" cy="398834"/>
+            </a:xfrm>
+            <a:prstGeom prst="rect">
+              <a:avLst/>
+            </a:prstGeom>
+            <a:noFill/>
+            <a:ln w="57150">
+              <a:solidFill>
+                <a:schemeClr val="accent6">
+                  <a:lumMod val="60000"/>
+                  <a:lumOff val="40000"/>
+                </a:schemeClr>
+              </a:solidFill>
+            </a:ln>
+          </p:spPr>
+          <p:style>
+            <a:lnRef idx="2">
+              <a:schemeClr val="accent6">
+                <a:shade val="15000"/>
+              </a:schemeClr>
+            </a:lnRef>
+            <a:fillRef idx="1">
+              <a:schemeClr val="accent6"/>
+            </a:fillRef>
+            <a:effectRef idx="0">
+              <a:schemeClr val="accent6"/>
+            </a:effectRef>
+            <a:fontRef idx="minor">
+              <a:schemeClr val="lt1"/>
+            </a:fontRef>
+          </p:style>
+          <p:txBody>
+            <a:bodyPr rtlCol="0" anchor="ctr"/>
+            <a:lstStyle/>
+            <a:p>
+              <a:pPr algn="ctr"/>
+              <a:endParaRPr lang="fr-CA"/>
+            </a:p>
+          </p:txBody>
+        </p:sp>
+        <p:cxnSp>
+          <p:nvCxnSpPr>
+            <p:cNvPr id="10" name="Connecteur droit avec flèche 9">
+              <a:extLst>
+                <a:ext uri="{FF2B5EF4-FFF2-40B4-BE49-F238E27FC236}">
+                  <a16:creationId xmlns:a16="http://schemas.microsoft.com/office/drawing/2014/main" id="{EE0D9918-4259-5FE5-2239-A38236148190}"/>
+                </a:ext>
+              </a:extLst>
+            </p:cNvPr>
+            <p:cNvCxnSpPr>
+              <a:stCxn id="9" idx="1"/>
+            </p:cNvCxnSpPr>
+            <p:nvPr/>
+          </p:nvCxnSpPr>
+          <p:spPr>
+            <a:xfrm flipH="1">
+              <a:off x="1322962" y="5277255"/>
+              <a:ext cx="1050587" cy="325877"/>
+            </a:xfrm>
+            <a:prstGeom prst="straightConnector1">
+              <a:avLst/>
+            </a:prstGeom>
+            <a:ln>
+              <a:tailEnd type="triangle"/>
+            </a:ln>
+          </p:spPr>
+          <p:style>
+            <a:lnRef idx="2">
+              <a:schemeClr val="accent1"/>
+            </a:lnRef>
+            <a:fillRef idx="0">
+              <a:schemeClr val="accent1"/>
+            </a:fillRef>
+            <a:effectRef idx="1">
+              <a:schemeClr val="accent1"/>
+            </a:effectRef>
+            <a:fontRef idx="minor">
+              <a:schemeClr val="tx1"/>
+            </a:fontRef>
+          </p:style>
+        </p:cxnSp>
+        <p:sp>
+          <p:nvSpPr>
+            <p:cNvPr id="11" name="ZoneTexte 10">
+              <a:extLst>
+                <a:ext uri="{FF2B5EF4-FFF2-40B4-BE49-F238E27FC236}">
+                  <a16:creationId xmlns:a16="http://schemas.microsoft.com/office/drawing/2014/main" id="{FD1FA1AC-0CBB-05F3-2DE3-6DE994D15BDB}"/>
+                </a:ext>
+              </a:extLst>
+            </p:cNvPr>
+            <p:cNvSpPr txBox="1"/>
+            <p:nvPr/>
+          </p:nvSpPr>
+          <p:spPr>
+            <a:xfrm>
+              <a:off x="311285" y="5603132"/>
+              <a:ext cx="1741251" cy="1200329"/>
+            </a:xfrm>
+            <a:prstGeom prst="rect">
+              <a:avLst/>
+            </a:prstGeom>
+            <a:noFill/>
+          </p:spPr>
+          <p:txBody>
+            <a:bodyPr wrap="square" rtlCol="0">
+              <a:spAutoFit/>
+            </a:bodyPr>
+            <a:lstStyle/>
+            <a:p>
+              <a:r>
+                <a:rPr lang="fr-CA" dirty="0"/>
+                <a:t>Discrétisation temporelle prend le dessus</a:t>
+              </a:r>
+            </a:p>
+          </p:txBody>
+        </p:sp>
+      </p:grpSp>
+    </p:spTree>
+    <p:extLst>
+      <p:ext uri="{BB962C8B-B14F-4D97-AF65-F5344CB8AC3E}">
+        <p14:creationId xmlns:p14="http://schemas.microsoft.com/office/powerpoint/2010/main" val="963557291"/>
+      </p:ext>
+    </p:extLst>
+  </p:cSld>
+  <p:clrMapOvr>
+    <a:masterClrMapping/>
+  </p:clrMapOvr>
+  <p:timing>
+    <p:tnLst>
+      <p:par>
+        <p:cTn id="1" dur="indefinite" restart="never" nodeType="tmRoot">
+          <p:childTnLst>
+            <p:seq concurrent="1" nextAc="seek">
+              <p:cTn id="2" dur="indefinite" nodeType="mainSeq">
+                <p:childTnLst>
+                  <p:par>
+                    <p:cTn id="3" fill="hold">
+                      <p:stCondLst>
+                        <p:cond delay="indefinite"/>
+                      </p:stCondLst>
+                      <p:childTnLst>
+                        <p:par>
+                          <p:cTn id="4" fill="hold">
+                            <p:stCondLst>
+                              <p:cond delay="0"/>
+                            </p:stCondLst>
+                            <p:childTnLst>
+                              <p:par>
+                                <p:cTn id="5" presetID="1" presetClass="entr" presetSubtype="0" fill="hold" nodeType="clickEffect">
+                                  <p:stCondLst>
+                                    <p:cond delay="0"/>
+                                  </p:stCondLst>
+                                  <p:childTnLst>
+                                    <p:set>
+                                      <p:cBhvr>
+                                        <p:cTn id="6" dur="1" fill="hold">
+                                          <p:stCondLst>
+                                            <p:cond delay="0"/>
+                                          </p:stCondLst>
+                                        </p:cTn>
+                                        <p:tgtEl>
+                                          <p:spTgt spid="8"/>
+                                        </p:tgtEl>
+                                        <p:attrNameLst>
+                                          <p:attrName>style.visibility</p:attrName>
+                                        </p:attrNameLst>
+                                      </p:cBhvr>
+                                      <p:to>
+                                        <p:strVal val="visible"/>
+                                      </p:to>
+                                    </p:set>
+                                  </p:childTnLst>
+                                </p:cTn>
+                              </p:par>
+                            </p:childTnLst>
+                          </p:cTn>
+                        </p:par>
+                      </p:childTnLst>
+                    </p:cTn>
+                  </p:par>
+                </p:childTnLst>
+              </p:cTn>
+              <p:prevCondLst>
+                <p:cond evt="onPrev" delay="0">
+                  <p:tgtEl>
+                    <p:sldTgt/>
+                  </p:tgtEl>
+                </p:cond>
+              </p:prevCondLst>
+              <p:nextCondLst>
+                <p:cond evt="onNext" delay="0">
+                  <p:tgtEl>
+                    <p:sldTgt/>
+                  </p:tgtEl>
+                </p:cond>
+              </p:nextCondLst>
+            </p:seq>
+          </p:childTnLst>
+        </p:cTn>
+      </p:par>
+    </p:tnLst>
+  </p:timing>
 </p:sld>
 </file>
 

</xml_diff>

<commit_message>
pwp: ajout de description du code et retour sur euler explicite
</commit_message>
<xml_diff>
--- a/projet_final/projet_final/MEC8211-Projet-final-Presentation.pptx
+++ b/projet_final/projet_final/MEC8211-Projet-final-Presentation.pptx
@@ -5,7 +5,7 @@
     <p:sldMasterId id="2147483648" r:id="rId1"/>
   </p:sldMasterIdLst>
   <p:notesMasterIdLst>
-    <p:notesMasterId r:id="rId15"/>
+    <p:notesMasterId r:id="rId16"/>
   </p:notesMasterIdLst>
   <p:sldIdLst>
     <p:sldId id="256" r:id="rId2"/>
@@ -14,13 +14,14 @@
     <p:sldId id="264" r:id="rId5"/>
     <p:sldId id="259" r:id="rId6"/>
     <p:sldId id="263" r:id="rId7"/>
-    <p:sldId id="260" r:id="rId8"/>
-    <p:sldId id="262" r:id="rId9"/>
-    <p:sldId id="261" r:id="rId10"/>
-    <p:sldId id="265" r:id="rId11"/>
-    <p:sldId id="266" r:id="rId12"/>
-    <p:sldId id="267" r:id="rId13"/>
-    <p:sldId id="268" r:id="rId14"/>
+    <p:sldId id="269" r:id="rId8"/>
+    <p:sldId id="260" r:id="rId9"/>
+    <p:sldId id="262" r:id="rId10"/>
+    <p:sldId id="261" r:id="rId11"/>
+    <p:sldId id="265" r:id="rId12"/>
+    <p:sldId id="266" r:id="rId13"/>
+    <p:sldId id="267" r:id="rId14"/>
+    <p:sldId id="268" r:id="rId15"/>
   </p:sldIdLst>
   <p:sldSz cx="12192000" cy="6858000"/>
   <p:notesSz cx="6858000" cy="9144000"/>
@@ -625,7 +626,7 @@
           <a:p>
             <a:fld id="{F6105186-0725-443C-BC59-E521425E81CD}" type="slidenum">
               <a:rPr lang="fr-FR" smtClean="0"/>
-              <a:t>7</a:t>
+              <a:t>8</a:t>
             </a:fld>
             <a:endParaRPr lang="fr-FR"/>
           </a:p>
@@ -733,7 +734,7 @@
           <a:p>
             <a:fld id="{F6105186-0725-443C-BC59-E521425E81CD}" type="slidenum">
               <a:rPr lang="fr-FR" smtClean="0"/>
-              <a:t>8</a:t>
+              <a:t>9</a:t>
             </a:fld>
             <a:endParaRPr lang="fr-FR"/>
           </a:p>
@@ -3987,18 +3988,28 @@
         </p:nvSpPr>
         <p:spPr>
           <a:xfrm>
-            <a:off x="1524000" y="1426463"/>
+            <a:off x="1524000" y="2003869"/>
             <a:ext cx="9144000" cy="1425131"/>
           </a:xfrm>
         </p:spPr>
         <p:txBody>
-          <a:bodyPr/>
+          <a:bodyPr>
+            <a:normAutofit fontScale="90000"/>
+          </a:bodyPr>
           <a:lstStyle/>
           <a:p>
             <a:r>
               <a:rPr lang="fr-FR" noProof="0" dirty="0"/>
               <a:t>MEC8211 – Projet final</a:t>
             </a:r>
+            <a:br>
+              <a:rPr lang="fr-FR" noProof="0" dirty="0"/>
+            </a:br>
+            <a:r>
+              <a:rPr lang="fr-FR" sz="4400" noProof="0" dirty="0"/>
+              <a:t>Vérification et Validation d’un solveur de différences finies réalisé dans le cadre du cours GCH2545 – Modélisation numérique en ingénierie</a:t>
+            </a:r>
+            <a:endParaRPr lang="fr-FR" noProof="0" dirty="0"/>
           </a:p>
         </p:txBody>
       </p:sp>
@@ -4117,6 +4128,441 @@
 </file>
 
 <file path=ppt/slides/slide10.xml><?xml version="1.0" encoding="utf-8"?>
+<p:sld xmlns:a="http://schemas.openxmlformats.org/drawingml/2006/main" xmlns:r="http://schemas.openxmlformats.org/officeDocument/2006/relationships" xmlns:p="http://schemas.openxmlformats.org/presentationml/2006/main">
+  <p:cSld>
+    <p:spTree>
+      <p:nvGrpSpPr>
+        <p:cNvPr id="1" name=""/>
+        <p:cNvGrpSpPr/>
+        <p:nvPr/>
+      </p:nvGrpSpPr>
+      <p:grpSpPr>
+        <a:xfrm>
+          <a:off x="0" y="0"/>
+          <a:ext cx="0" cy="0"/>
+          <a:chOff x="0" y="0"/>
+          <a:chExt cx="0" cy="0"/>
+        </a:xfrm>
+      </p:grpSpPr>
+      <p:sp>
+        <p:nvSpPr>
+          <p:cNvPr id="2" name="Titre 1">
+            <a:extLst>
+              <a:ext uri="{FF2B5EF4-FFF2-40B4-BE49-F238E27FC236}">
+                <a16:creationId xmlns:a16="http://schemas.microsoft.com/office/drawing/2014/main" id="{730210F2-DE1D-E808-58AF-DFA01EAAB4C6}"/>
+              </a:ext>
+            </a:extLst>
+          </p:cNvPr>
+          <p:cNvSpPr>
+            <a:spLocks noGrp="1"/>
+          </p:cNvSpPr>
+          <p:nvPr>
+            <p:ph type="title"/>
+          </p:nvPr>
+        </p:nvSpPr>
+        <p:spPr/>
+        <p:txBody>
+          <a:bodyPr/>
+          <a:lstStyle/>
+          <a:p>
+            <a:r>
+              <a:rPr lang="fr-FR" dirty="0"/>
+              <a:t>Vérification de code - Méthodologie :</a:t>
+            </a:r>
+          </a:p>
+        </p:txBody>
+      </p:sp>
+      <mc:AlternateContent xmlns:mc="http://schemas.openxmlformats.org/markup-compatibility/2006">
+        <mc:Choice xmlns:a14="http://schemas.microsoft.com/office/drawing/2010/main" Requires="a14">
+          <p:sp>
+            <p:nvSpPr>
+              <p:cNvPr id="3" name="Espace réservé du contenu 2">
+                <a:extLst>
+                  <a:ext uri="{FF2B5EF4-FFF2-40B4-BE49-F238E27FC236}">
+                    <a16:creationId xmlns:a16="http://schemas.microsoft.com/office/drawing/2014/main" id="{4013CAEC-1AC4-C17B-EAFA-EC1AB7DBA279}"/>
+                  </a:ext>
+                </a:extLst>
+              </p:cNvPr>
+              <p:cNvSpPr>
+                <a:spLocks noGrp="1"/>
+              </p:cNvSpPr>
+              <p:nvPr>
+                <p:ph idx="1"/>
+              </p:nvPr>
+            </p:nvSpPr>
+            <p:spPr>
+              <a:xfrm>
+                <a:off x="838200" y="1825625"/>
+                <a:ext cx="10628376" cy="4351338"/>
+              </a:xfrm>
+            </p:spPr>
+            <p:txBody>
+              <a:bodyPr>
+                <a:normAutofit fontScale="77500" lnSpcReduction="20000"/>
+              </a:bodyPr>
+              <a:lstStyle/>
+              <a:p>
+                <a:pPr>
+                  <a:lnSpc>
+                    <a:spcPct val="124000"/>
+                  </a:lnSpc>
+                </a:pPr>
+                <a:r>
+                  <a:rPr lang="fr-FR" dirty="0"/>
+                  <a:t>Implémentation de divers tests avec le module </a:t>
+                </a:r>
+                <a:r>
+                  <a:rPr lang="fr-FR" i="1" dirty="0" err="1"/>
+                  <a:t>unittest</a:t>
+                </a:r>
+                <a:r>
+                  <a:rPr lang="fr-FR" dirty="0"/>
+                  <a:t> de python :</a:t>
+                </a:r>
+              </a:p>
+              <a:p>
+                <a:pPr lvl="1">
+                  <a:lnSpc>
+                    <a:spcPct val="124000"/>
+                  </a:lnSpc>
+                </a:pPr>
+                <a:r>
+                  <a:rPr lang="fr-FR" b="1" dirty="0"/>
+                  <a:t>Tests unitaires </a:t>
+                </a:r>
+                <a:r>
+                  <a:rPr lang="fr-FR" dirty="0"/>
+                  <a:t>pour les différentes fonctions du code implémentés :</a:t>
+                </a:r>
+              </a:p>
+              <a:p>
+                <a:pPr lvl="2">
+                  <a:lnSpc>
+                    <a:spcPct val="124000"/>
+                  </a:lnSpc>
+                  <a:buFont typeface="Courier New" panose="02070309020205020404" pitchFamily="49" charset="0"/>
+                  <a:buChar char="o"/>
+                </a:pPr>
+                <a:r>
+                  <a:rPr lang="fr-FR" b="1" dirty="0" err="1"/>
+                  <a:t>testPosition</a:t>
+                </a:r>
+                <a:r>
+                  <a:rPr lang="fr-FR" dirty="0"/>
+                  <a:t> : </a:t>
+                </a:r>
+                <a:r>
+                  <a:rPr lang="fr-CA" dirty="0"/>
+                  <a:t>Test la fonction Position avec des valeurs connues.</a:t>
+                </a:r>
+              </a:p>
+              <a:p>
+                <a:pPr lvl="2">
+                  <a:lnSpc>
+                    <a:spcPct val="124000"/>
+                  </a:lnSpc>
+                  <a:buFont typeface="Courier New" panose="02070309020205020404" pitchFamily="49" charset="0"/>
+                  <a:buChar char="o"/>
+                </a:pPr>
+                <a:r>
+                  <a:rPr lang="fr-CA" b="1" dirty="0" err="1"/>
+                  <a:t>testMilieu</a:t>
+                </a:r>
+                <a:r>
+                  <a:rPr lang="fr-CA" dirty="0"/>
+                  <a:t> : Test la fonction Milieu avec des valeurs connues.</a:t>
+                </a:r>
+              </a:p>
+              <a:p>
+                <a:pPr lvl="2">
+                  <a:lnSpc>
+                    <a:spcPct val="124000"/>
+                  </a:lnSpc>
+                  <a:buFont typeface="Courier New" panose="02070309020205020404" pitchFamily="49" charset="0"/>
+                  <a:buChar char="o"/>
+                </a:pPr>
+                <a:r>
+                  <a:rPr lang="fr-CA" b="1" dirty="0" err="1"/>
+                  <a:t>testTemperature</a:t>
+                </a:r>
+                <a:r>
+                  <a:rPr lang="fr-CA" dirty="0"/>
+                  <a:t> : Test la fonction </a:t>
+                </a:r>
+                <a:r>
+                  <a:rPr lang="fr-CA" dirty="0" err="1"/>
+                  <a:t>Temperature</a:t>
+                </a:r>
+                <a:r>
+                  <a:rPr lang="fr-CA" dirty="0"/>
+                  <a:t> avec des valeurs connues.</a:t>
+                </a:r>
+              </a:p>
+              <a:p>
+                <a:pPr lvl="1">
+                  <a:lnSpc>
+                    <a:spcPct val="124000"/>
+                  </a:lnSpc>
+                </a:pPr>
+                <a:r>
+                  <a:rPr lang="fr-CA" b="1" dirty="0"/>
+                  <a:t>Tests de vérification de code </a:t>
+                </a:r>
+                <a:r>
+                  <a:rPr lang="fr-CA" dirty="0"/>
+                  <a:t>implémentés :</a:t>
+                </a:r>
+              </a:p>
+              <a:p>
+                <a:pPr lvl="2">
+                  <a:lnSpc>
+                    <a:spcPct val="124000"/>
+                  </a:lnSpc>
+                  <a:buFont typeface="Courier New" panose="02070309020205020404" pitchFamily="49" charset="0"/>
+                  <a:buChar char="o"/>
+                </a:pPr>
+                <a:r>
+                  <a:rPr lang="fr-CA" b="1" dirty="0" err="1"/>
+                  <a:t>testSymetrie</a:t>
+                </a:r>
+                <a:r>
+                  <a:rPr lang="fr-CA" dirty="0"/>
+                  <a:t> : Test la simplification de la condition de symétrie en comparant le résultat symétrique au résultat du domaine complet.</a:t>
+                </a:r>
+              </a:p>
+              <a:p>
+                <a:pPr lvl="2">
+                  <a:lnSpc>
+                    <a:spcPct val="124000"/>
+                  </a:lnSpc>
+                  <a:buFont typeface="Courier New" panose="02070309020205020404" pitchFamily="49" charset="0"/>
+                  <a:buChar char="o"/>
+                </a:pPr>
+                <a:r>
+                  <a:rPr lang="fr-CA" b="1" dirty="0" err="1"/>
+                  <a:t>testConservationEnergie</a:t>
+                </a:r>
+                <a:r>
+                  <a:rPr lang="fr-CA" dirty="0"/>
+                  <a:t> : Test la conservation de l'énergie du solveur en effectuant un bilan </a:t>
+                </a:r>
+                <a:r>
+                  <a:rPr lang="fr-CA" dirty="0" err="1"/>
+                  <a:t>énegérique</a:t>
+                </a:r>
+                <a:r>
+                  <a:rPr lang="fr-CA" dirty="0"/>
+                  <a:t> à l'intérieur du domaine et sur la frontière. On cherche :</a:t>
+                </a:r>
+                <a:br>
+                  <a:rPr lang="fr-CA" dirty="0"/>
+                </a:br>
+                <a14:m>
+                  <m:oMath xmlns:m="http://schemas.openxmlformats.org/officeDocument/2006/math">
+                    <m:acc>
+                      <m:accPr>
+                        <m:chr m:val="̇"/>
+                        <m:ctrlPr>
+                          <a:rPr lang="fr-CA" i="1" smtClean="0">
+                            <a:latin typeface="Cambria Math" panose="02040503050406030204" pitchFamily="18" charset="0"/>
+                          </a:rPr>
+                        </m:ctrlPr>
+                      </m:accPr>
+                      <m:e>
+                        <m:sSub>
+                          <m:sSubPr>
+                            <m:ctrlPr>
+                              <a:rPr lang="fr-CA" b="0" i="1" smtClean="0">
+                                <a:latin typeface="Cambria Math" panose="02040503050406030204" pitchFamily="18" charset="0"/>
+                              </a:rPr>
+                            </m:ctrlPr>
+                          </m:sSubPr>
+                          <m:e>
+                            <m:r>
+                              <a:rPr lang="fr-CA" b="0" i="1" smtClean="0">
+                                <a:latin typeface="Cambria Math" panose="02040503050406030204" pitchFamily="18" charset="0"/>
+                              </a:rPr>
+                              <m:t>𝑞</m:t>
+                            </m:r>
+                          </m:e>
+                          <m:sub>
+                            <m:r>
+                              <a:rPr lang="fr-CA" b="0" i="1" smtClean="0">
+                                <a:latin typeface="Cambria Math" panose="02040503050406030204" pitchFamily="18" charset="0"/>
+                              </a:rPr>
+                              <m:t>𝑖𝑛𝑡</m:t>
+                            </m:r>
+                          </m:sub>
+                        </m:sSub>
+                      </m:e>
+                    </m:acc>
+                    <m:r>
+                      <a:rPr lang="fr-CA" i="1" smtClean="0">
+                        <a:latin typeface="Cambria Math" panose="02040503050406030204" pitchFamily="18" charset="0"/>
+                        <a:ea typeface="Cambria Math" panose="02040503050406030204" pitchFamily="18" charset="0"/>
+                      </a:rPr>
+                      <m:t>≈</m:t>
+                    </m:r>
+                    <m:acc>
+                      <m:accPr>
+                        <m:chr m:val="̇"/>
+                        <m:ctrlPr>
+                          <a:rPr lang="fr-CA" i="1">
+                            <a:latin typeface="Cambria Math" panose="02040503050406030204" pitchFamily="18" charset="0"/>
+                          </a:rPr>
+                        </m:ctrlPr>
+                      </m:accPr>
+                      <m:e>
+                        <m:sSub>
+                          <m:sSubPr>
+                            <m:ctrlPr>
+                              <a:rPr lang="fr-CA" i="1">
+                                <a:latin typeface="Cambria Math" panose="02040503050406030204" pitchFamily="18" charset="0"/>
+                              </a:rPr>
+                            </m:ctrlPr>
+                          </m:sSubPr>
+                          <m:e>
+                            <m:r>
+                              <a:rPr lang="fr-CA" i="1">
+                                <a:latin typeface="Cambria Math" panose="02040503050406030204" pitchFamily="18" charset="0"/>
+                              </a:rPr>
+                              <m:t>𝑞</m:t>
+                            </m:r>
+                          </m:e>
+                          <m:sub>
+                            <m:r>
+                              <a:rPr lang="fr-CA" i="1">
+                                <a:latin typeface="Cambria Math" panose="02040503050406030204" pitchFamily="18" charset="0"/>
+                              </a:rPr>
+                              <m:t>𝑓𝑟𝑜𝑛𝑡</m:t>
+                            </m:r>
+                          </m:sub>
+                        </m:sSub>
+                      </m:e>
+                    </m:acc>
+                  </m:oMath>
+                </a14:m>
+                <a:endParaRPr lang="fr-CA" dirty="0"/>
+              </a:p>
+              <a:p>
+                <a:pPr lvl="2">
+                  <a:lnSpc>
+                    <a:spcPct val="124000"/>
+                  </a:lnSpc>
+                  <a:buFont typeface="Courier New" panose="02070309020205020404" pitchFamily="49" charset="0"/>
+                  <a:buChar char="o"/>
+                </a:pPr>
+                <a:r>
+                  <a:rPr lang="fr-CA" b="1" dirty="0" err="1"/>
+                  <a:t>testInvarianceGalileenne</a:t>
+                </a:r>
+                <a:r>
+                  <a:rPr lang="fr-CA" dirty="0"/>
+                  <a:t> : Test l’invariance galiléenne du solveur par translation des coordonnées.</a:t>
+                </a:r>
+              </a:p>
+              <a:p>
+                <a:pPr lvl="1">
+                  <a:lnSpc>
+                    <a:spcPct val="124000"/>
+                  </a:lnSpc>
+                </a:pPr>
+                <a:r>
+                  <a:rPr lang="fr-CA" dirty="0"/>
+                  <a:t>Implémentation de la </a:t>
+                </a:r>
+                <a:r>
+                  <a:rPr lang="fr-CA" b="1" dirty="0"/>
+                  <a:t>MMS</a:t>
+                </a:r>
+                <a:r>
+                  <a:rPr lang="fr-CA" dirty="0"/>
+                  <a:t> pour évaluer l’ordre de convergence du solveur.</a:t>
+                </a:r>
+              </a:p>
+              <a:p>
+                <a:pPr lvl="2">
+                  <a:buFont typeface="Courier New" panose="02070309020205020404" pitchFamily="49" charset="0"/>
+                  <a:buChar char="o"/>
+                </a:pPr>
+                <a:endParaRPr lang="fr-CA" dirty="0"/>
+              </a:p>
+              <a:p>
+                <a:pPr lvl="2">
+                  <a:buFont typeface="Courier New" panose="02070309020205020404" pitchFamily="49" charset="0"/>
+                  <a:buChar char="o"/>
+                </a:pPr>
+                <a:endParaRPr lang="fr-FR" dirty="0"/>
+              </a:p>
+              <a:p>
+                <a:pPr lvl="2"/>
+                <a:endParaRPr lang="fr-FR" dirty="0"/>
+              </a:p>
+              <a:p>
+                <a:pPr lvl="2"/>
+                <a:endParaRPr lang="fr-FR" dirty="0"/>
+              </a:p>
+            </p:txBody>
+          </p:sp>
+        </mc:Choice>
+        <mc:Fallback>
+          <p:sp>
+            <p:nvSpPr>
+              <p:cNvPr id="3" name="Espace réservé du contenu 2">
+                <a:extLst>
+                  <a:ext uri="{FF2B5EF4-FFF2-40B4-BE49-F238E27FC236}">
+                    <a16:creationId xmlns:a16="http://schemas.microsoft.com/office/drawing/2014/main" id="{4013CAEC-1AC4-C17B-EAFA-EC1AB7DBA279}"/>
+                  </a:ext>
+                </a:extLst>
+              </p:cNvPr>
+              <p:cNvSpPr>
+                <a:spLocks noGrp="1" noRot="1" noChangeAspect="1" noMove="1" noResize="1" noEditPoints="1" noAdjustHandles="1" noChangeArrowheads="1" noChangeShapeType="1" noTextEdit="1"/>
+              </p:cNvSpPr>
+              <p:nvPr>
+                <p:ph idx="1"/>
+              </p:nvPr>
+            </p:nvSpPr>
+            <p:spPr>
+              <a:xfrm>
+                <a:off x="838200" y="1825625"/>
+                <a:ext cx="10628376" cy="4351338"/>
+              </a:xfrm>
+              <a:blipFill>
+                <a:blip r:embed="rId2"/>
+                <a:stretch>
+                  <a:fillRect l="-688" t="-700" r="-574"/>
+                </a:stretch>
+              </a:blipFill>
+            </p:spPr>
+            <p:txBody>
+              <a:bodyPr/>
+              <a:lstStyle/>
+              <a:p>
+                <a:r>
+                  <a:rPr lang="fr-CA">
+                    <a:noFill/>
+                  </a:rPr>
+                  <a:t> </a:t>
+                </a:r>
+              </a:p>
+            </p:txBody>
+          </p:sp>
+        </mc:Fallback>
+      </mc:AlternateContent>
+    </p:spTree>
+    <p:extLst>
+      <p:ext uri="{BB962C8B-B14F-4D97-AF65-F5344CB8AC3E}">
+        <p14:creationId xmlns:p14="http://schemas.microsoft.com/office/powerpoint/2010/main" val="3778705103"/>
+      </p:ext>
+    </p:extLst>
+  </p:cSld>
+  <p:clrMapOvr>
+    <a:masterClrMapping/>
+  </p:clrMapOvr>
+</p:sld>
+</file>
+
+<file path=ppt/slides/slide11.xml><?xml version="1.0" encoding="utf-8"?>
 <p:sld xmlns:a="http://schemas.openxmlformats.org/drawingml/2006/main" xmlns:r="http://schemas.openxmlformats.org/officeDocument/2006/relationships" xmlns:p="http://schemas.openxmlformats.org/presentationml/2006/main">
   <p:cSld>
     <p:spTree>
@@ -4400,7 +4846,7 @@
 </p:sld>
 </file>
 
-<file path=ppt/slides/slide11.xml><?xml version="1.0" encoding="utf-8"?>
+<file path=ppt/slides/slide12.xml><?xml version="1.0" encoding="utf-8"?>
 <p:sld xmlns:a="http://schemas.openxmlformats.org/drawingml/2006/main" xmlns:r="http://schemas.openxmlformats.org/officeDocument/2006/relationships" xmlns:p="http://schemas.openxmlformats.org/presentationml/2006/main">
   <p:cSld>
     <p:spTree>
@@ -5068,7 +5514,7 @@
 </p:sld>
 </file>
 
-<file path=ppt/slides/slide12.xml><?xml version="1.0" encoding="utf-8"?>
+<file path=ppt/slides/slide13.xml><?xml version="1.0" encoding="utf-8"?>
 <p:sld xmlns:a="http://schemas.openxmlformats.org/drawingml/2006/main" xmlns:r="http://schemas.openxmlformats.org/officeDocument/2006/relationships" xmlns:p="http://schemas.openxmlformats.org/presentationml/2006/main">
   <p:cSld>
     <p:spTree>
@@ -5397,7 +5843,7 @@
 </p:sld>
 </file>
 
-<file path=ppt/slides/slide13.xml><?xml version="1.0" encoding="utf-8"?>
+<file path=ppt/slides/slide14.xml><?xml version="1.0" encoding="utf-8"?>
 <p:sld xmlns:a="http://schemas.openxmlformats.org/drawingml/2006/main" xmlns:r="http://schemas.openxmlformats.org/officeDocument/2006/relationships" xmlns:p="http://schemas.openxmlformats.org/presentationml/2006/main">
   <p:cSld>
     <p:spTree>
@@ -8508,6 +8954,192 @@
           </a:p>
         </p:txBody>
       </p:sp>
+      <mc:AlternateContent xmlns:mc="http://schemas.openxmlformats.org/markup-compatibility/2006">
+        <mc:Choice xmlns:a14="http://schemas.microsoft.com/office/drawing/2010/main" Requires="a14">
+          <p:sp>
+            <p:nvSpPr>
+              <p:cNvPr id="6" name="ZoneTexte 5">
+                <a:extLst>
+                  <a:ext uri="{FF2B5EF4-FFF2-40B4-BE49-F238E27FC236}">
+                    <a16:creationId xmlns:a16="http://schemas.microsoft.com/office/drawing/2014/main" id="{0D3DAD9B-F895-38F3-7E66-F7CE93598C25}"/>
+                  </a:ext>
+                </a:extLst>
+              </p:cNvPr>
+              <p:cNvSpPr txBox="1"/>
+              <p:nvPr/>
+            </p:nvSpPr>
+            <p:spPr>
+              <a:xfrm>
+                <a:off x="8054501" y="1155033"/>
+                <a:ext cx="3920247" cy="4524315"/>
+              </a:xfrm>
+              <a:prstGeom prst="rect">
+                <a:avLst/>
+              </a:prstGeom>
+              <a:noFill/>
+            </p:spPr>
+            <p:txBody>
+              <a:bodyPr wrap="square" rtlCol="0">
+                <a:spAutoFit/>
+              </a:bodyPr>
+              <a:lstStyle/>
+              <a:p>
+                <a:r>
+                  <a:rPr lang="fr-CA" dirty="0"/>
+                  <a:t>Schéma d’Euler Explicite :</a:t>
+                </a:r>
+              </a:p>
+              <a:p>
+                <a:endParaRPr lang="fr-CA" dirty="0"/>
+              </a:p>
+              <a:p>
+                <a:r>
+                  <a:rPr lang="fr-CA" dirty="0"/>
+                  <a:t>On vient évaluer l’état d’un système à un temps </a:t>
+                </a:r>
+                <a14:m>
+                  <m:oMath xmlns:m="http://schemas.openxmlformats.org/officeDocument/2006/math">
+                    <m:r>
+                      <a:rPr lang="fr-CA" b="0" i="1" smtClean="0">
+                        <a:latin typeface="Cambria Math" panose="02040503050406030204" pitchFamily="18" charset="0"/>
+                      </a:rPr>
+                      <m:t>𝑡</m:t>
+                    </m:r>
+                    <m:r>
+                      <a:rPr lang="fr-CA" b="0" i="1" smtClean="0">
+                        <a:latin typeface="Cambria Math" panose="02040503050406030204" pitchFamily="18" charset="0"/>
+                      </a:rPr>
+                      <m:t>+∆</m:t>
+                    </m:r>
+                    <m:r>
+                      <a:rPr lang="fr-CA" b="0" i="1" smtClean="0">
+                        <a:latin typeface="Cambria Math" panose="02040503050406030204" pitchFamily="18" charset="0"/>
+                      </a:rPr>
+                      <m:t>𝑡</m:t>
+                    </m:r>
+                  </m:oMath>
+                </a14:m>
+                <a:r>
+                  <a:rPr lang="fr-CA" dirty="0"/>
+                  <a:t> à l’aide de l’état de ce système au temps </a:t>
+                </a:r>
+                <a14:m>
+                  <m:oMath xmlns:m="http://schemas.openxmlformats.org/officeDocument/2006/math">
+                    <m:r>
+                      <a:rPr lang="fr-CA" b="0" i="1" smtClean="0">
+                        <a:latin typeface="Cambria Math" panose="02040503050406030204" pitchFamily="18" charset="0"/>
+                      </a:rPr>
+                      <m:t>𝑡</m:t>
+                    </m:r>
+                  </m:oMath>
+                </a14:m>
+                <a:r>
+                  <a:rPr lang="fr-CA" dirty="0"/>
+                  <a:t>.</a:t>
+                </a:r>
+              </a:p>
+              <a:p>
+                <a:endParaRPr lang="fr-CA" dirty="0"/>
+              </a:p>
+              <a:p>
+                <a:r>
+                  <a:rPr lang="fr-CA" dirty="0"/>
+                  <a:t>Méthode directe (pas de système à résoudre) et peu coûteuse.</a:t>
+                </a:r>
+              </a:p>
+              <a:p>
+                <a:endParaRPr lang="fr-CA" dirty="0"/>
+              </a:p>
+              <a:p>
+                <a:r>
+                  <a:rPr lang="fr-CA" dirty="0"/>
+                  <a:t>Problème de stabilité : la méthode d’Euler explicite nécessite de respecter un critère de stabilité entre la discrétisation en temps et en espace :</a:t>
+                </a:r>
+              </a:p>
+              <a:p>
+                <a:endParaRPr lang="fr-CA" dirty="0"/>
+              </a:p>
+              <a:p>
+                <a:endParaRPr lang="fr-CA" dirty="0"/>
+              </a:p>
+            </p:txBody>
+          </p:sp>
+        </mc:Choice>
+        <mc:Fallback>
+          <p:sp>
+            <p:nvSpPr>
+              <p:cNvPr id="6" name="ZoneTexte 5">
+                <a:extLst>
+                  <a:ext uri="{FF2B5EF4-FFF2-40B4-BE49-F238E27FC236}">
+                    <a16:creationId xmlns:a16="http://schemas.microsoft.com/office/drawing/2014/main" id="{0D3DAD9B-F895-38F3-7E66-F7CE93598C25}"/>
+                  </a:ext>
+                </a:extLst>
+              </p:cNvPr>
+              <p:cNvSpPr txBox="1">
+                <a:spLocks noRot="1" noChangeAspect="1" noMove="1" noResize="1" noEditPoints="1" noAdjustHandles="1" noChangeArrowheads="1" noChangeShapeType="1" noTextEdit="1"/>
+              </p:cNvSpPr>
+              <p:nvPr/>
+            </p:nvSpPr>
+            <p:spPr>
+              <a:xfrm>
+                <a:off x="8054501" y="1155033"/>
+                <a:ext cx="3920247" cy="4524315"/>
+              </a:xfrm>
+              <a:prstGeom prst="rect">
+                <a:avLst/>
+              </a:prstGeom>
+              <a:blipFill>
+                <a:blip r:embed="rId3"/>
+                <a:stretch>
+                  <a:fillRect l="-1244" t="-538" r="-467"/>
+                </a:stretch>
+              </a:blipFill>
+            </p:spPr>
+            <p:txBody>
+              <a:bodyPr/>
+              <a:lstStyle/>
+              <a:p>
+                <a:r>
+                  <a:rPr lang="fr-CA">
+                    <a:noFill/>
+                  </a:rPr>
+                  <a:t> </a:t>
+                </a:r>
+              </a:p>
+            </p:txBody>
+          </p:sp>
+        </mc:Fallback>
+      </mc:AlternateContent>
+      <p:pic>
+        <p:nvPicPr>
+          <p:cNvPr id="8" name="Image 7">
+            <a:extLst>
+              <a:ext uri="{FF2B5EF4-FFF2-40B4-BE49-F238E27FC236}">
+                <a16:creationId xmlns:a16="http://schemas.microsoft.com/office/drawing/2014/main" id="{19BD9348-480B-8C6C-AE14-0653FA999484}"/>
+              </a:ext>
+            </a:extLst>
+          </p:cNvPr>
+          <p:cNvPicPr>
+            <a:picLocks noChangeAspect="1"/>
+          </p:cNvPicPr>
+          <p:nvPr/>
+        </p:nvPicPr>
+        <p:blipFill>
+          <a:blip r:embed="rId4"/>
+          <a:stretch>
+            <a:fillRect/>
+          </a:stretch>
+        </p:blipFill>
+        <p:spPr>
+          <a:xfrm>
+            <a:off x="7846411" y="5073307"/>
+            <a:ext cx="4258607" cy="911282"/>
+          </a:xfrm>
+          <a:prstGeom prst="rect">
+            <a:avLst/>
+          </a:prstGeom>
+        </p:spPr>
+      </p:pic>
     </p:spTree>
     <p:extLst>
       <p:ext uri="{BB962C8B-B14F-4D97-AF65-F5344CB8AC3E}">
@@ -8556,8 +9188,8 @@
         </p:nvSpPr>
         <p:spPr>
           <a:xfrm>
-            <a:off x="838200" y="0"/>
-            <a:ext cx="10515600" cy="1325563"/>
+            <a:off x="419100" y="0"/>
+            <a:ext cx="11353800" cy="1325563"/>
           </a:xfrm>
         </p:spPr>
         <p:txBody>
@@ -8566,7 +9198,7 @@
           <a:p>
             <a:r>
               <a:rPr lang="fr-FR" dirty="0"/>
-              <a:t>Discrétisation : Milieu </a:t>
+              <a:t>Discrétisation : Milieu – Schéma d’Euler Explicite </a:t>
             </a:r>
           </a:p>
         </p:txBody>
@@ -11255,8 +11887,8 @@
         </p:nvSpPr>
         <p:spPr>
           <a:xfrm>
-            <a:off x="838200" y="18255"/>
-            <a:ext cx="10515600" cy="1325563"/>
+            <a:off x="150876" y="-30897"/>
+            <a:ext cx="11945112" cy="1325563"/>
           </a:xfrm>
         </p:spPr>
         <p:txBody>
@@ -11265,7 +11897,7 @@
           <a:p>
             <a:r>
               <a:rPr lang="fr-FR" dirty="0"/>
-              <a:t>Discrétisation : frontières</a:t>
+              <a:t>Discrétisation : frontières - Schéma d’Euler Explicite </a:t>
             </a:r>
           </a:p>
         </p:txBody>
@@ -14751,6 +15383,498 @@
   <p:cSld>
     <p:spTree>
       <p:nvGrpSpPr>
+        <p:cNvPr id="1" name="">
+          <a:extLst>
+            <a:ext uri="{FF2B5EF4-FFF2-40B4-BE49-F238E27FC236}">
+              <a16:creationId xmlns:a16="http://schemas.microsoft.com/office/drawing/2014/main" id="{728D2072-1734-D724-EA81-E925334F5FC2}"/>
+            </a:ext>
+          </a:extLst>
+        </p:cNvPr>
+        <p:cNvGrpSpPr/>
+        <p:nvPr/>
+      </p:nvGrpSpPr>
+      <p:grpSpPr>
+        <a:xfrm>
+          <a:off x="0" y="0"/>
+          <a:ext cx="0" cy="0"/>
+          <a:chOff x="0" y="0"/>
+          <a:chExt cx="0" cy="0"/>
+        </a:xfrm>
+      </p:grpSpPr>
+      <p:sp>
+        <p:nvSpPr>
+          <p:cNvPr id="2" name="Titre 1">
+            <a:extLst>
+              <a:ext uri="{FF2B5EF4-FFF2-40B4-BE49-F238E27FC236}">
+                <a16:creationId xmlns:a16="http://schemas.microsoft.com/office/drawing/2014/main" id="{04BB688C-D97C-481D-A291-13AA5890C45F}"/>
+              </a:ext>
+            </a:extLst>
+          </p:cNvPr>
+          <p:cNvSpPr>
+            <a:spLocks noGrp="1"/>
+          </p:cNvSpPr>
+          <p:nvPr>
+            <p:ph type="title"/>
+          </p:nvPr>
+        </p:nvSpPr>
+        <p:spPr>
+          <a:xfrm>
+            <a:off x="838200" y="0"/>
+            <a:ext cx="10515600" cy="1325563"/>
+          </a:xfrm>
+        </p:spPr>
+        <p:txBody>
+          <a:bodyPr>
+            <a:normAutofit/>
+          </a:bodyPr>
+          <a:lstStyle/>
+          <a:p>
+            <a:r>
+              <a:rPr lang="fr-FR" dirty="0"/>
+              <a:t>Description du code :</a:t>
+            </a:r>
+          </a:p>
+        </p:txBody>
+      </p:sp>
+      <mc:AlternateContent xmlns:mc="http://schemas.openxmlformats.org/markup-compatibility/2006">
+        <mc:Choice xmlns:a14="http://schemas.microsoft.com/office/drawing/2010/main" Requires="a14">
+          <p:sp>
+            <p:nvSpPr>
+              <p:cNvPr id="3" name="Espace réservé du contenu 2">
+                <a:extLst>
+                  <a:ext uri="{FF2B5EF4-FFF2-40B4-BE49-F238E27FC236}">
+                    <a16:creationId xmlns:a16="http://schemas.microsoft.com/office/drawing/2014/main" id="{B4B15E8C-4AC7-7351-4AC9-E6164AE5CE0F}"/>
+                  </a:ext>
+                </a:extLst>
+              </p:cNvPr>
+              <p:cNvSpPr>
+                <a:spLocks noGrp="1"/>
+              </p:cNvSpPr>
+              <p:nvPr>
+                <p:ph idx="1"/>
+              </p:nvPr>
+            </p:nvSpPr>
+            <p:spPr>
+              <a:xfrm>
+                <a:off x="261258" y="1331494"/>
+                <a:ext cx="11930742" cy="5526505"/>
+              </a:xfrm>
+            </p:spPr>
+            <p:txBody>
+              <a:bodyPr>
+                <a:normAutofit fontScale="92500" lnSpcReduction="10000"/>
+              </a:bodyPr>
+              <a:lstStyle/>
+              <a:p>
+                <a:r>
+                  <a:rPr lang="fr-FR" dirty="0"/>
+                  <a:t>main.py : fichier permettant d’exécuter le solveur pour une configuration prédéterminée.</a:t>
+                </a:r>
+              </a:p>
+              <a:p>
+                <a:r>
+                  <a:rPr lang="fr-FR" dirty="0"/>
+                  <a:t>fonctions.py : le cœur du code</a:t>
+                </a:r>
+              </a:p>
+              <a:p>
+                <a:pPr lvl="1"/>
+                <a:r>
+                  <a:rPr lang="fr-FR" dirty="0"/>
+                  <a:t>Classe Paramètres : classe contenant la configuration du problème.</a:t>
+                </a:r>
+              </a:p>
+              <a:p>
+                <a:pPr lvl="2"/>
+                <a14:m>
+                  <m:oMath xmlns:m="http://schemas.openxmlformats.org/officeDocument/2006/math">
+                    <m:sSub>
+                      <m:sSubPr>
+                        <m:ctrlPr>
+                          <a:rPr lang="fr-CA" b="0" i="1" smtClean="0">
+                            <a:latin typeface="Cambria Math" panose="02040503050406030204" pitchFamily="18" charset="0"/>
+                          </a:rPr>
+                        </m:ctrlPr>
+                      </m:sSubPr>
+                      <m:e>
+                        <m:r>
+                          <a:rPr lang="fr-CA" b="0" i="1" smtClean="0">
+                            <a:latin typeface="Cambria Math" panose="02040503050406030204" pitchFamily="18" charset="0"/>
+                          </a:rPr>
+                          <m:t>𝑅</m:t>
+                        </m:r>
+                      </m:e>
+                      <m:sub>
+                        <m:r>
+                          <a:rPr lang="fr-CA" b="0" i="1" smtClean="0">
+                            <a:latin typeface="Cambria Math" panose="02040503050406030204" pitchFamily="18" charset="0"/>
+                          </a:rPr>
+                          <m:t>𝑚𝑎𝑥</m:t>
+                        </m:r>
+                      </m:sub>
+                    </m:sSub>
+                    <m:r>
+                      <a:rPr lang="fr-CA" b="0" i="1" smtClean="0">
+                        <a:latin typeface="Cambria Math" panose="02040503050406030204" pitchFamily="18" charset="0"/>
+                      </a:rPr>
+                      <m:t>,</m:t>
+                    </m:r>
+                    <m:r>
+                      <a:rPr lang="fr-CA" b="0" i="1" smtClean="0">
+                        <a:latin typeface="Cambria Math" panose="02040503050406030204" pitchFamily="18" charset="0"/>
+                      </a:rPr>
+                      <m:t>𝜌</m:t>
+                    </m:r>
+                    <m:r>
+                      <a:rPr lang="fr-CA" b="0" i="1" smtClean="0">
+                        <a:latin typeface="Cambria Math" panose="02040503050406030204" pitchFamily="18" charset="0"/>
+                      </a:rPr>
+                      <m:t>,</m:t>
+                    </m:r>
+                    <m:sSub>
+                      <m:sSubPr>
+                        <m:ctrlPr>
+                          <a:rPr lang="fr-CA" b="0" i="1" smtClean="0">
+                            <a:latin typeface="Cambria Math" panose="02040503050406030204" pitchFamily="18" charset="0"/>
+                          </a:rPr>
+                        </m:ctrlPr>
+                      </m:sSubPr>
+                      <m:e>
+                        <m:r>
+                          <a:rPr lang="fr-CA" b="0" i="1" smtClean="0">
+                            <a:latin typeface="Cambria Math" panose="02040503050406030204" pitchFamily="18" charset="0"/>
+                          </a:rPr>
+                          <m:t>𝐶</m:t>
+                        </m:r>
+                      </m:e>
+                      <m:sub>
+                        <m:r>
+                          <a:rPr lang="fr-CA" b="0" i="1" smtClean="0">
+                            <a:latin typeface="Cambria Math" panose="02040503050406030204" pitchFamily="18" charset="0"/>
+                          </a:rPr>
+                          <m:t>𝑝</m:t>
+                        </m:r>
+                      </m:sub>
+                    </m:sSub>
+                    <m:r>
+                      <a:rPr lang="fr-CA" b="0" i="1" smtClean="0">
+                        <a:latin typeface="Cambria Math" panose="02040503050406030204" pitchFamily="18" charset="0"/>
+                      </a:rPr>
+                      <m:t>, </m:t>
+                    </m:r>
+                    <m:r>
+                      <a:rPr lang="fr-CA" b="0" i="1" smtClean="0">
+                        <a:latin typeface="Cambria Math" panose="02040503050406030204" pitchFamily="18" charset="0"/>
+                      </a:rPr>
+                      <m:t>𝑛𝑟</m:t>
+                    </m:r>
+                    <m:r>
+                      <a:rPr lang="fr-CA" b="0" i="1" smtClean="0">
+                        <a:latin typeface="Cambria Math" panose="02040503050406030204" pitchFamily="18" charset="0"/>
+                      </a:rPr>
+                      <m:t>,</m:t>
+                    </m:r>
+                    <m:r>
+                      <a:rPr lang="fr-CA" b="0" i="1" smtClean="0">
+                        <a:latin typeface="Cambria Math" panose="02040503050406030204" pitchFamily="18" charset="0"/>
+                      </a:rPr>
+                      <m:t>𝑛𝑧</m:t>
+                    </m:r>
+                    <m:r>
+                      <a:rPr lang="fr-CA" b="0" i="1" smtClean="0">
+                        <a:latin typeface="Cambria Math" panose="02040503050406030204" pitchFamily="18" charset="0"/>
+                      </a:rPr>
+                      <m:t>,</m:t>
+                    </m:r>
+                    <m:r>
+                      <a:rPr lang="fr-CA" b="0" i="1" smtClean="0">
+                        <a:latin typeface="Cambria Math" panose="02040503050406030204" pitchFamily="18" charset="0"/>
+                      </a:rPr>
+                      <m:t>𝑑𝑟</m:t>
+                    </m:r>
+                    <m:r>
+                      <a:rPr lang="fr-CA" b="0" i="1" smtClean="0">
+                        <a:latin typeface="Cambria Math" panose="02040503050406030204" pitchFamily="18" charset="0"/>
+                      </a:rPr>
+                      <m:t>,</m:t>
+                    </m:r>
+                    <m:r>
+                      <a:rPr lang="fr-CA" b="0" i="1" smtClean="0">
+                        <a:latin typeface="Cambria Math" panose="02040503050406030204" pitchFamily="18" charset="0"/>
+                      </a:rPr>
+                      <m:t>𝑑𝑧</m:t>
+                    </m:r>
+                    <m:r>
+                      <a:rPr lang="fr-CA" b="0" i="1" smtClean="0">
+                        <a:latin typeface="Cambria Math" panose="02040503050406030204" pitchFamily="18" charset="0"/>
+                      </a:rPr>
+                      <m:t>,</m:t>
+                    </m:r>
+                    <m:r>
+                      <a:rPr lang="fr-CA" b="0" i="1" smtClean="0">
+                        <a:latin typeface="Cambria Math" panose="02040503050406030204" pitchFamily="18" charset="0"/>
+                      </a:rPr>
+                      <m:t>𝑑𝑡</m:t>
+                    </m:r>
+                    <m:r>
+                      <a:rPr lang="fr-CA" b="0" i="1" smtClean="0">
+                        <a:latin typeface="Cambria Math" panose="02040503050406030204" pitchFamily="18" charset="0"/>
+                      </a:rPr>
+                      <m:t>,</m:t>
+                    </m:r>
+                    <m:sSub>
+                      <m:sSubPr>
+                        <m:ctrlPr>
+                          <a:rPr lang="fr-CA" b="0" i="1" smtClean="0">
+                            <a:latin typeface="Cambria Math" panose="02040503050406030204" pitchFamily="18" charset="0"/>
+                          </a:rPr>
+                        </m:ctrlPr>
+                      </m:sSubPr>
+                      <m:e>
+                        <m:r>
+                          <a:rPr lang="fr-CA" b="0" i="1" smtClean="0">
+                            <a:latin typeface="Cambria Math" panose="02040503050406030204" pitchFamily="18" charset="0"/>
+                          </a:rPr>
+                          <m:t>𝑇</m:t>
+                        </m:r>
+                      </m:e>
+                      <m:sub>
+                        <m:r>
+                          <a:rPr lang="fr-CA" i="1">
+                            <a:latin typeface="Cambria Math" panose="02040503050406030204" pitchFamily="18" charset="0"/>
+                            <a:ea typeface="Cambria Math" panose="02040503050406030204" pitchFamily="18" charset="0"/>
+                          </a:rPr>
+                          <m:t>∞</m:t>
+                        </m:r>
+                      </m:sub>
+                    </m:sSub>
+                    <m:r>
+                      <a:rPr lang="fr-CA" b="0" i="1" smtClean="0">
+                        <a:latin typeface="Cambria Math" panose="02040503050406030204" pitchFamily="18" charset="0"/>
+                      </a:rPr>
+                      <m:t>,</m:t>
+                    </m:r>
+                    <m:r>
+                      <a:rPr lang="fr-CA" b="0" i="1" smtClean="0">
+                        <a:latin typeface="Cambria Math" panose="02040503050406030204" pitchFamily="18" charset="0"/>
+                      </a:rPr>
+                      <m:t>𝑝𝑜𝑠𝑖𝑡𝑖𝑜𝑛</m:t>
+                    </m:r>
+                    <m:r>
+                      <a:rPr lang="fr-CA" b="0" i="1" smtClean="0">
+                        <a:latin typeface="Cambria Math" panose="02040503050406030204" pitchFamily="18" charset="0"/>
+                      </a:rPr>
+                      <m:t>,</m:t>
+                    </m:r>
+                    <m:r>
+                      <a:rPr lang="fr-CA" b="0" i="1" smtClean="0">
+                        <a:latin typeface="Cambria Math" panose="02040503050406030204" pitchFamily="18" charset="0"/>
+                      </a:rPr>
+                      <m:t>𝑀𝑀𝑆</m:t>
+                    </m:r>
+                    <m:r>
+                      <a:rPr lang="fr-CA" b="0" i="1" smtClean="0">
+                        <a:latin typeface="Cambria Math" panose="02040503050406030204" pitchFamily="18" charset="0"/>
+                      </a:rPr>
+                      <m:t>,</m:t>
+                    </m:r>
+                    <m:r>
+                      <a:rPr lang="fr-CA" b="0" i="1" smtClean="0">
+                        <a:latin typeface="Cambria Math" panose="02040503050406030204" pitchFamily="18" charset="0"/>
+                      </a:rPr>
+                      <m:t>𝑒𝑡𝑐</m:t>
+                    </m:r>
+                    <m:r>
+                      <a:rPr lang="fr-CA" b="0" i="1" smtClean="0">
+                        <a:latin typeface="Cambria Math" panose="02040503050406030204" pitchFamily="18" charset="0"/>
+                      </a:rPr>
+                      <m:t>.</m:t>
+                    </m:r>
+                  </m:oMath>
+                </a14:m>
+                <a:endParaRPr lang="fr-CA" b="0" i="1" dirty="0">
+                  <a:latin typeface="Cambria Math" panose="02040503050406030204" pitchFamily="18" charset="0"/>
+                </a:endParaRPr>
+              </a:p>
+              <a:p>
+                <a:pPr lvl="1"/>
+                <a:r>
+                  <a:rPr lang="fr-CA" b="0" dirty="0"/>
+                  <a:t>Fonction Position : permet de générer les matrices de position des points du domaine </a:t>
+                </a:r>
+                <a:r>
+                  <a:rPr lang="fr-CA" dirty="0"/>
+                  <a:t>(</a:t>
+                </a:r>
+                <a:r>
+                  <a:rPr lang="fr-CA" b="1" dirty="0"/>
+                  <a:t>R </a:t>
+                </a:r>
+                <a:r>
+                  <a:rPr lang="fr-CA" dirty="0"/>
+                  <a:t>et </a:t>
+                </a:r>
+                <a:r>
+                  <a:rPr lang="fr-CA" b="1" dirty="0"/>
+                  <a:t>M</a:t>
+                </a:r>
+                <a:r>
+                  <a:rPr lang="fr-CA" dirty="0"/>
+                  <a:t>).</a:t>
+                </a:r>
+                <a14:m>
+                  <m:oMath xmlns:m="http://schemas.openxmlformats.org/officeDocument/2006/math">
+                    <m:r>
+                      <a:rPr lang="fr-CA" b="0" i="1" smtClean="0">
+                        <a:latin typeface="Cambria Math" panose="02040503050406030204" pitchFamily="18" charset="0"/>
+                      </a:rPr>
+                      <m:t> </m:t>
+                    </m:r>
+                  </m:oMath>
+                </a14:m>
+                <a:endParaRPr lang="fr-CA" b="0" dirty="0"/>
+              </a:p>
+              <a:p>
+                <a:pPr lvl="1"/>
+                <a:r>
+                  <a:rPr lang="fr-CA" dirty="0"/>
+                  <a:t>Fonction Température : calcul l’état de la température au pas de temps suivant.</a:t>
+                </a:r>
+              </a:p>
+              <a:p>
+                <a:pPr lvl="2"/>
+                <a:r>
+                  <a:rPr lang="fr-CA" b="0" dirty="0"/>
+                  <a:t>Génère un état intermédiaire composé de l’état au temps </a:t>
+                </a:r>
+                <a:r>
+                  <a:rPr lang="fr-CA" b="0" i="1" dirty="0"/>
+                  <a:t>t</a:t>
+                </a:r>
+                <a:r>
+                  <a:rPr lang="fr-CA" b="0" dirty="0"/>
+                  <a:t> au milieu et l’état au temps </a:t>
+                </a:r>
+                <a14:m>
+                  <m:oMath xmlns:m="http://schemas.openxmlformats.org/officeDocument/2006/math">
+                    <m:r>
+                      <a:rPr lang="fr-CA" b="0" i="1" smtClean="0">
+                        <a:latin typeface="Cambria Math" panose="02040503050406030204" pitchFamily="18" charset="0"/>
+                      </a:rPr>
+                      <m:t>𝑡</m:t>
+                    </m:r>
+                    <m:r>
+                      <a:rPr lang="fr-CA" b="0" i="1" smtClean="0">
+                        <a:latin typeface="Cambria Math" panose="02040503050406030204" pitchFamily="18" charset="0"/>
+                      </a:rPr>
+                      <m:t>+∆</m:t>
+                    </m:r>
+                    <m:r>
+                      <a:rPr lang="fr-CA" b="0" i="1" smtClean="0">
+                        <a:latin typeface="Cambria Math" panose="02040503050406030204" pitchFamily="18" charset="0"/>
+                      </a:rPr>
+                      <m:t>𝑡</m:t>
+                    </m:r>
+                  </m:oMath>
+                </a14:m>
+                <a:r>
+                  <a:rPr lang="fr-CA" b="0" dirty="0"/>
+                  <a:t> aux frontières.</a:t>
+                </a:r>
+              </a:p>
+              <a:p>
+                <a:pPr lvl="2"/>
+                <a:r>
+                  <a:rPr lang="fr-CA" dirty="0"/>
+                  <a:t>Appelle la fonction Milieu.</a:t>
+                </a:r>
+                <a:endParaRPr lang="fr-CA" b="0" dirty="0"/>
+              </a:p>
+              <a:p>
+                <a:pPr lvl="1"/>
+                <a:r>
+                  <a:rPr lang="fr-FR" dirty="0"/>
+                  <a:t>Fonction Milieu : permet de calculer l’état de la température au pas de temps suivant à l’aide de l’état intermédiaire fourni par la fonction Température.</a:t>
+                </a:r>
+              </a:p>
+              <a:p>
+                <a:pPr lvl="1"/>
+                <a:endParaRPr lang="fr-FR" dirty="0"/>
+              </a:p>
+              <a:p>
+                <a:pPr marL="0" indent="0">
+                  <a:buNone/>
+                </a:pPr>
+                <a:r>
+                  <a:rPr lang="fr-FR" dirty="0"/>
+                  <a:t>Résolution du système : on itère sur le temps en appelant la fonction Température, jusqu’à ce qu’on ait atteint le temps final.</a:t>
+                </a:r>
+              </a:p>
+            </p:txBody>
+          </p:sp>
+        </mc:Choice>
+        <mc:Fallback>
+          <p:sp>
+            <p:nvSpPr>
+              <p:cNvPr id="3" name="Espace réservé du contenu 2">
+                <a:extLst>
+                  <a:ext uri="{FF2B5EF4-FFF2-40B4-BE49-F238E27FC236}">
+                    <a16:creationId xmlns:a16="http://schemas.microsoft.com/office/drawing/2014/main" id="{B4B15E8C-4AC7-7351-4AC9-E6164AE5CE0F}"/>
+                  </a:ext>
+                </a:extLst>
+              </p:cNvPr>
+              <p:cNvSpPr>
+                <a:spLocks noGrp="1" noRot="1" noChangeAspect="1" noMove="1" noResize="1" noEditPoints="1" noAdjustHandles="1" noChangeArrowheads="1" noChangeShapeType="1" noTextEdit="1"/>
+              </p:cNvSpPr>
+              <p:nvPr>
+                <p:ph idx="1"/>
+              </p:nvPr>
+            </p:nvSpPr>
+            <p:spPr>
+              <a:xfrm>
+                <a:off x="261258" y="1331494"/>
+                <a:ext cx="11930742" cy="5526505"/>
+              </a:xfrm>
+              <a:blipFill>
+                <a:blip r:embed="rId2"/>
+                <a:stretch>
+                  <a:fillRect l="-920" t="-2205" r="-664"/>
+                </a:stretch>
+              </a:blipFill>
+            </p:spPr>
+            <p:txBody>
+              <a:bodyPr/>
+              <a:lstStyle/>
+              <a:p>
+                <a:r>
+                  <a:rPr lang="fr-CA">
+                    <a:noFill/>
+                  </a:rPr>
+                  <a:t> </a:t>
+                </a:r>
+              </a:p>
+            </p:txBody>
+          </p:sp>
+        </mc:Fallback>
+      </mc:AlternateContent>
+    </p:spTree>
+    <p:extLst>
+      <p:ext uri="{BB962C8B-B14F-4D97-AF65-F5344CB8AC3E}">
+        <p14:creationId xmlns:p14="http://schemas.microsoft.com/office/powerpoint/2010/main" val="597455943"/>
+      </p:ext>
+    </p:extLst>
+  </p:cSld>
+  <p:clrMapOvr>
+    <a:masterClrMapping/>
+  </p:clrMapOvr>
+</p:sld>
+</file>
+
+<file path=ppt/slides/slide8.xml><?xml version="1.0" encoding="utf-8"?>
+<p:sld xmlns:a="http://schemas.openxmlformats.org/drawingml/2006/main" xmlns:r="http://schemas.openxmlformats.org/officeDocument/2006/relationships" xmlns:p="http://schemas.openxmlformats.org/presentationml/2006/main">
+  <p:cSld>
+    <p:spTree>
+      <p:nvGrpSpPr>
         <p:cNvPr id="1" name=""/>
         <p:cNvGrpSpPr/>
         <p:nvPr/>
@@ -17466,7 +18590,7 @@
 </p:sld>
 </file>
 
-<file path=ppt/slides/slide8.xml><?xml version="1.0" encoding="utf-8"?>
+<file path=ppt/slides/slide9.xml><?xml version="1.0" encoding="utf-8"?>
 <p:sld xmlns:a="http://schemas.openxmlformats.org/drawingml/2006/main" xmlns:r="http://schemas.openxmlformats.org/officeDocument/2006/relationships" xmlns:p="http://schemas.openxmlformats.org/presentationml/2006/main">
   <p:cSld>
     <p:spTree>
@@ -22281,441 +23405,6 @@
     <p:extLst>
       <p:ext uri="{BB962C8B-B14F-4D97-AF65-F5344CB8AC3E}">
         <p14:creationId xmlns:p14="http://schemas.microsoft.com/office/powerpoint/2010/main" val="2901290548"/>
-      </p:ext>
-    </p:extLst>
-  </p:cSld>
-  <p:clrMapOvr>
-    <a:masterClrMapping/>
-  </p:clrMapOvr>
-</p:sld>
-</file>
-
-<file path=ppt/slides/slide9.xml><?xml version="1.0" encoding="utf-8"?>
-<p:sld xmlns:a="http://schemas.openxmlformats.org/drawingml/2006/main" xmlns:r="http://schemas.openxmlformats.org/officeDocument/2006/relationships" xmlns:p="http://schemas.openxmlformats.org/presentationml/2006/main">
-  <p:cSld>
-    <p:spTree>
-      <p:nvGrpSpPr>
-        <p:cNvPr id="1" name=""/>
-        <p:cNvGrpSpPr/>
-        <p:nvPr/>
-      </p:nvGrpSpPr>
-      <p:grpSpPr>
-        <a:xfrm>
-          <a:off x="0" y="0"/>
-          <a:ext cx="0" cy="0"/>
-          <a:chOff x="0" y="0"/>
-          <a:chExt cx="0" cy="0"/>
-        </a:xfrm>
-      </p:grpSpPr>
-      <p:sp>
-        <p:nvSpPr>
-          <p:cNvPr id="2" name="Titre 1">
-            <a:extLst>
-              <a:ext uri="{FF2B5EF4-FFF2-40B4-BE49-F238E27FC236}">
-                <a16:creationId xmlns:a16="http://schemas.microsoft.com/office/drawing/2014/main" id="{730210F2-DE1D-E808-58AF-DFA01EAAB4C6}"/>
-              </a:ext>
-            </a:extLst>
-          </p:cNvPr>
-          <p:cNvSpPr>
-            <a:spLocks noGrp="1"/>
-          </p:cNvSpPr>
-          <p:nvPr>
-            <p:ph type="title"/>
-          </p:nvPr>
-        </p:nvSpPr>
-        <p:spPr/>
-        <p:txBody>
-          <a:bodyPr/>
-          <a:lstStyle/>
-          <a:p>
-            <a:r>
-              <a:rPr lang="fr-FR" dirty="0"/>
-              <a:t>Vérification de code - Méthodologie :</a:t>
-            </a:r>
-          </a:p>
-        </p:txBody>
-      </p:sp>
-      <mc:AlternateContent xmlns:mc="http://schemas.openxmlformats.org/markup-compatibility/2006">
-        <mc:Choice xmlns:a14="http://schemas.microsoft.com/office/drawing/2010/main" Requires="a14">
-          <p:sp>
-            <p:nvSpPr>
-              <p:cNvPr id="3" name="Espace réservé du contenu 2">
-                <a:extLst>
-                  <a:ext uri="{FF2B5EF4-FFF2-40B4-BE49-F238E27FC236}">
-                    <a16:creationId xmlns:a16="http://schemas.microsoft.com/office/drawing/2014/main" id="{4013CAEC-1AC4-C17B-EAFA-EC1AB7DBA279}"/>
-                  </a:ext>
-                </a:extLst>
-              </p:cNvPr>
-              <p:cNvSpPr>
-                <a:spLocks noGrp="1"/>
-              </p:cNvSpPr>
-              <p:nvPr>
-                <p:ph idx="1"/>
-              </p:nvPr>
-            </p:nvSpPr>
-            <p:spPr>
-              <a:xfrm>
-                <a:off x="838200" y="1825625"/>
-                <a:ext cx="10628376" cy="4351338"/>
-              </a:xfrm>
-            </p:spPr>
-            <p:txBody>
-              <a:bodyPr>
-                <a:normAutofit fontScale="77500" lnSpcReduction="20000"/>
-              </a:bodyPr>
-              <a:lstStyle/>
-              <a:p>
-                <a:pPr>
-                  <a:lnSpc>
-                    <a:spcPct val="124000"/>
-                  </a:lnSpc>
-                </a:pPr>
-                <a:r>
-                  <a:rPr lang="fr-FR" dirty="0"/>
-                  <a:t>Implémentation de divers tests avec le module </a:t>
-                </a:r>
-                <a:r>
-                  <a:rPr lang="fr-FR" i="1" dirty="0" err="1"/>
-                  <a:t>unittest</a:t>
-                </a:r>
-                <a:r>
-                  <a:rPr lang="fr-FR" dirty="0"/>
-                  <a:t> de python :</a:t>
-                </a:r>
-              </a:p>
-              <a:p>
-                <a:pPr lvl="1">
-                  <a:lnSpc>
-                    <a:spcPct val="124000"/>
-                  </a:lnSpc>
-                </a:pPr>
-                <a:r>
-                  <a:rPr lang="fr-FR" b="1" dirty="0"/>
-                  <a:t>Tests unitaires </a:t>
-                </a:r>
-                <a:r>
-                  <a:rPr lang="fr-FR" dirty="0"/>
-                  <a:t>pour les différentes fonctions du code implémentés :</a:t>
-                </a:r>
-              </a:p>
-              <a:p>
-                <a:pPr lvl="2">
-                  <a:lnSpc>
-                    <a:spcPct val="124000"/>
-                  </a:lnSpc>
-                  <a:buFont typeface="Courier New" panose="02070309020205020404" pitchFamily="49" charset="0"/>
-                  <a:buChar char="o"/>
-                </a:pPr>
-                <a:r>
-                  <a:rPr lang="fr-FR" b="1" dirty="0" err="1"/>
-                  <a:t>testPosition</a:t>
-                </a:r>
-                <a:r>
-                  <a:rPr lang="fr-FR" dirty="0"/>
-                  <a:t> : </a:t>
-                </a:r>
-                <a:r>
-                  <a:rPr lang="fr-CA" dirty="0"/>
-                  <a:t>Test la fonction Position avec des valeurs connues.</a:t>
-                </a:r>
-              </a:p>
-              <a:p>
-                <a:pPr lvl="2">
-                  <a:lnSpc>
-                    <a:spcPct val="124000"/>
-                  </a:lnSpc>
-                  <a:buFont typeface="Courier New" panose="02070309020205020404" pitchFamily="49" charset="0"/>
-                  <a:buChar char="o"/>
-                </a:pPr>
-                <a:r>
-                  <a:rPr lang="fr-CA" b="1" dirty="0" err="1"/>
-                  <a:t>testMilieu</a:t>
-                </a:r>
-                <a:r>
-                  <a:rPr lang="fr-CA" dirty="0"/>
-                  <a:t> : Test la fonction Milieu avec des valeurs connues.</a:t>
-                </a:r>
-              </a:p>
-              <a:p>
-                <a:pPr lvl="2">
-                  <a:lnSpc>
-                    <a:spcPct val="124000"/>
-                  </a:lnSpc>
-                  <a:buFont typeface="Courier New" panose="02070309020205020404" pitchFamily="49" charset="0"/>
-                  <a:buChar char="o"/>
-                </a:pPr>
-                <a:r>
-                  <a:rPr lang="fr-CA" b="1" dirty="0" err="1"/>
-                  <a:t>testTemperature</a:t>
-                </a:r>
-                <a:r>
-                  <a:rPr lang="fr-CA" dirty="0"/>
-                  <a:t> : Test la fonction </a:t>
-                </a:r>
-                <a:r>
-                  <a:rPr lang="fr-CA" dirty="0" err="1"/>
-                  <a:t>Temperature</a:t>
-                </a:r>
-                <a:r>
-                  <a:rPr lang="fr-CA" dirty="0"/>
-                  <a:t> avec des valeurs connues.</a:t>
-                </a:r>
-              </a:p>
-              <a:p>
-                <a:pPr lvl="1">
-                  <a:lnSpc>
-                    <a:spcPct val="124000"/>
-                  </a:lnSpc>
-                </a:pPr>
-                <a:r>
-                  <a:rPr lang="fr-CA" b="1" dirty="0"/>
-                  <a:t>Tests de vérification de code </a:t>
-                </a:r>
-                <a:r>
-                  <a:rPr lang="fr-CA" dirty="0"/>
-                  <a:t>implémentés :</a:t>
-                </a:r>
-              </a:p>
-              <a:p>
-                <a:pPr lvl="2">
-                  <a:lnSpc>
-                    <a:spcPct val="124000"/>
-                  </a:lnSpc>
-                  <a:buFont typeface="Courier New" panose="02070309020205020404" pitchFamily="49" charset="0"/>
-                  <a:buChar char="o"/>
-                </a:pPr>
-                <a:r>
-                  <a:rPr lang="fr-CA" b="1" dirty="0" err="1"/>
-                  <a:t>testSymetrie</a:t>
-                </a:r>
-                <a:r>
-                  <a:rPr lang="fr-CA" dirty="0"/>
-                  <a:t> : Test la simplification de la condition de symétrie en comparant le résultat symétrique au résultat du domaine complet.</a:t>
-                </a:r>
-              </a:p>
-              <a:p>
-                <a:pPr lvl="2">
-                  <a:lnSpc>
-                    <a:spcPct val="124000"/>
-                  </a:lnSpc>
-                  <a:buFont typeface="Courier New" panose="02070309020205020404" pitchFamily="49" charset="0"/>
-                  <a:buChar char="o"/>
-                </a:pPr>
-                <a:r>
-                  <a:rPr lang="fr-CA" b="1" dirty="0" err="1"/>
-                  <a:t>testConservationEnergie</a:t>
-                </a:r>
-                <a:r>
-                  <a:rPr lang="fr-CA" dirty="0"/>
-                  <a:t> : Test la conservation de l'énergie du solveur en effectuant un bilan </a:t>
-                </a:r>
-                <a:r>
-                  <a:rPr lang="fr-CA" dirty="0" err="1"/>
-                  <a:t>énegérique</a:t>
-                </a:r>
-                <a:r>
-                  <a:rPr lang="fr-CA" dirty="0"/>
-                  <a:t> à l'intérieur du domaine et sur la frontière. On cherche :</a:t>
-                </a:r>
-                <a:br>
-                  <a:rPr lang="fr-CA" dirty="0"/>
-                </a:br>
-                <a14:m>
-                  <m:oMath xmlns:m="http://schemas.openxmlformats.org/officeDocument/2006/math">
-                    <m:acc>
-                      <m:accPr>
-                        <m:chr m:val="̇"/>
-                        <m:ctrlPr>
-                          <a:rPr lang="fr-CA" i="1" smtClean="0">
-                            <a:latin typeface="Cambria Math" panose="02040503050406030204" pitchFamily="18" charset="0"/>
-                          </a:rPr>
-                        </m:ctrlPr>
-                      </m:accPr>
-                      <m:e>
-                        <m:sSub>
-                          <m:sSubPr>
-                            <m:ctrlPr>
-                              <a:rPr lang="fr-CA" b="0" i="1" smtClean="0">
-                                <a:latin typeface="Cambria Math" panose="02040503050406030204" pitchFamily="18" charset="0"/>
-                              </a:rPr>
-                            </m:ctrlPr>
-                          </m:sSubPr>
-                          <m:e>
-                            <m:r>
-                              <a:rPr lang="fr-CA" b="0" i="1" smtClean="0">
-                                <a:latin typeface="Cambria Math" panose="02040503050406030204" pitchFamily="18" charset="0"/>
-                              </a:rPr>
-                              <m:t>𝑞</m:t>
-                            </m:r>
-                          </m:e>
-                          <m:sub>
-                            <m:r>
-                              <a:rPr lang="fr-CA" b="0" i="1" smtClean="0">
-                                <a:latin typeface="Cambria Math" panose="02040503050406030204" pitchFamily="18" charset="0"/>
-                              </a:rPr>
-                              <m:t>𝑖𝑛𝑡</m:t>
-                            </m:r>
-                          </m:sub>
-                        </m:sSub>
-                      </m:e>
-                    </m:acc>
-                    <m:r>
-                      <a:rPr lang="fr-CA" i="1" smtClean="0">
-                        <a:latin typeface="Cambria Math" panose="02040503050406030204" pitchFamily="18" charset="0"/>
-                        <a:ea typeface="Cambria Math" panose="02040503050406030204" pitchFamily="18" charset="0"/>
-                      </a:rPr>
-                      <m:t>≈</m:t>
-                    </m:r>
-                    <m:acc>
-                      <m:accPr>
-                        <m:chr m:val="̇"/>
-                        <m:ctrlPr>
-                          <a:rPr lang="fr-CA" i="1">
-                            <a:latin typeface="Cambria Math" panose="02040503050406030204" pitchFamily="18" charset="0"/>
-                          </a:rPr>
-                        </m:ctrlPr>
-                      </m:accPr>
-                      <m:e>
-                        <m:sSub>
-                          <m:sSubPr>
-                            <m:ctrlPr>
-                              <a:rPr lang="fr-CA" i="1">
-                                <a:latin typeface="Cambria Math" panose="02040503050406030204" pitchFamily="18" charset="0"/>
-                              </a:rPr>
-                            </m:ctrlPr>
-                          </m:sSubPr>
-                          <m:e>
-                            <m:r>
-                              <a:rPr lang="fr-CA" i="1">
-                                <a:latin typeface="Cambria Math" panose="02040503050406030204" pitchFamily="18" charset="0"/>
-                              </a:rPr>
-                              <m:t>𝑞</m:t>
-                            </m:r>
-                          </m:e>
-                          <m:sub>
-                            <m:r>
-                              <a:rPr lang="fr-CA" i="1">
-                                <a:latin typeface="Cambria Math" panose="02040503050406030204" pitchFamily="18" charset="0"/>
-                              </a:rPr>
-                              <m:t>𝑓𝑟𝑜𝑛𝑡</m:t>
-                            </m:r>
-                          </m:sub>
-                        </m:sSub>
-                      </m:e>
-                    </m:acc>
-                  </m:oMath>
-                </a14:m>
-                <a:endParaRPr lang="fr-CA" dirty="0"/>
-              </a:p>
-              <a:p>
-                <a:pPr lvl="2">
-                  <a:lnSpc>
-                    <a:spcPct val="124000"/>
-                  </a:lnSpc>
-                  <a:buFont typeface="Courier New" panose="02070309020205020404" pitchFamily="49" charset="0"/>
-                  <a:buChar char="o"/>
-                </a:pPr>
-                <a:r>
-                  <a:rPr lang="fr-CA" b="1" dirty="0" err="1"/>
-                  <a:t>testInvarianceGalileenne</a:t>
-                </a:r>
-                <a:r>
-                  <a:rPr lang="fr-CA" dirty="0"/>
-                  <a:t> : Test l’invariance galiléenne du solveur par translation des coordonnées.</a:t>
-                </a:r>
-              </a:p>
-              <a:p>
-                <a:pPr lvl="1">
-                  <a:lnSpc>
-                    <a:spcPct val="124000"/>
-                  </a:lnSpc>
-                </a:pPr>
-                <a:r>
-                  <a:rPr lang="fr-CA" dirty="0"/>
-                  <a:t>Implémentation de la </a:t>
-                </a:r>
-                <a:r>
-                  <a:rPr lang="fr-CA" b="1" dirty="0"/>
-                  <a:t>MMS</a:t>
-                </a:r>
-                <a:r>
-                  <a:rPr lang="fr-CA" dirty="0"/>
-                  <a:t> pour évaluer l’ordre de convergence du solveur.</a:t>
-                </a:r>
-              </a:p>
-              <a:p>
-                <a:pPr lvl="2">
-                  <a:buFont typeface="Courier New" panose="02070309020205020404" pitchFamily="49" charset="0"/>
-                  <a:buChar char="o"/>
-                </a:pPr>
-                <a:endParaRPr lang="fr-CA" dirty="0"/>
-              </a:p>
-              <a:p>
-                <a:pPr lvl="2">
-                  <a:buFont typeface="Courier New" panose="02070309020205020404" pitchFamily="49" charset="0"/>
-                  <a:buChar char="o"/>
-                </a:pPr>
-                <a:endParaRPr lang="fr-FR" dirty="0"/>
-              </a:p>
-              <a:p>
-                <a:pPr lvl="2"/>
-                <a:endParaRPr lang="fr-FR" dirty="0"/>
-              </a:p>
-              <a:p>
-                <a:pPr lvl="2"/>
-                <a:endParaRPr lang="fr-FR" dirty="0"/>
-              </a:p>
-            </p:txBody>
-          </p:sp>
-        </mc:Choice>
-        <mc:Fallback>
-          <p:sp>
-            <p:nvSpPr>
-              <p:cNvPr id="3" name="Espace réservé du contenu 2">
-                <a:extLst>
-                  <a:ext uri="{FF2B5EF4-FFF2-40B4-BE49-F238E27FC236}">
-                    <a16:creationId xmlns:a16="http://schemas.microsoft.com/office/drawing/2014/main" id="{4013CAEC-1AC4-C17B-EAFA-EC1AB7DBA279}"/>
-                  </a:ext>
-                </a:extLst>
-              </p:cNvPr>
-              <p:cNvSpPr>
-                <a:spLocks noGrp="1" noRot="1" noChangeAspect="1" noMove="1" noResize="1" noEditPoints="1" noAdjustHandles="1" noChangeArrowheads="1" noChangeShapeType="1" noTextEdit="1"/>
-              </p:cNvSpPr>
-              <p:nvPr>
-                <p:ph idx="1"/>
-              </p:nvPr>
-            </p:nvSpPr>
-            <p:spPr>
-              <a:xfrm>
-                <a:off x="838200" y="1825625"/>
-                <a:ext cx="10628376" cy="4351338"/>
-              </a:xfrm>
-              <a:blipFill>
-                <a:blip r:embed="rId2"/>
-                <a:stretch>
-                  <a:fillRect l="-688" t="-700" r="-574"/>
-                </a:stretch>
-              </a:blipFill>
-            </p:spPr>
-            <p:txBody>
-              <a:bodyPr/>
-              <a:lstStyle/>
-              <a:p>
-                <a:r>
-                  <a:rPr lang="fr-CA">
-                    <a:noFill/>
-                  </a:rPr>
-                  <a:t> </a:t>
-                </a:r>
-              </a:p>
-            </p:txBody>
-          </p:sp>
-        </mc:Fallback>
-      </mc:AlternateContent>
-    </p:spTree>
-    <p:extLst>
-      <p:ext uri="{BB962C8B-B14F-4D97-AF65-F5344CB8AC3E}">
-        <p14:creationId xmlns:p14="http://schemas.microsoft.com/office/powerpoint/2010/main" val="3778705103"/>
       </p:ext>
     </p:extLst>
   </p:cSld>

</xml_diff>

<commit_message>
PWP partie validation v1
Partie validation en cours de construction
</commit_message>
<xml_diff>
--- a/projet_final/projet_final/MEC8211-Projet-final-Presentation.pptx
+++ b/projet_final/projet_final/MEC8211-Projet-final-Presentation.pptx
@@ -5,7 +5,7 @@
     <p:sldMasterId id="2147483648" r:id="rId1"/>
   </p:sldMasterIdLst>
   <p:notesMasterIdLst>
-    <p:notesMasterId r:id="rId16"/>
+    <p:notesMasterId r:id="rId22"/>
   </p:notesMasterIdLst>
   <p:sldIdLst>
     <p:sldId id="256" r:id="rId2"/>
@@ -22,6 +22,12 @@
     <p:sldId id="266" r:id="rId13"/>
     <p:sldId id="267" r:id="rId14"/>
     <p:sldId id="268" r:id="rId15"/>
+    <p:sldId id="272" r:id="rId16"/>
+    <p:sldId id="270" r:id="rId17"/>
+    <p:sldId id="271" r:id="rId18"/>
+    <p:sldId id="273" r:id="rId19"/>
+    <p:sldId id="275" r:id="rId20"/>
+    <p:sldId id="274" r:id="rId21"/>
   </p:sldIdLst>
   <p:sldSz cx="12192000" cy="6858000"/>
   <p:notesSz cx="6858000" cy="9144000"/>
@@ -210,7 +216,7 @@
           <a:p>
             <a:fld id="{BB0B2023-C595-443A-8D8C-AB9DF5A28D48}" type="datetimeFigureOut">
               <a:rPr lang="fr-FR" smtClean="0"/>
-              <a:t>10/04/2026</a:t>
+              <a:t>11/04/2026</a:t>
             </a:fld>
             <a:endParaRPr lang="fr-FR"/>
           </a:p>
@@ -368,7 +374,7 @@
           <a:p>
             <a:fld id="{F6105186-0725-443C-BC59-E521425E81CD}" type="slidenum">
               <a:rPr lang="fr-FR" smtClean="0"/>
-              <a:t>‹N°›</a:t>
+              <a:t>‹#›</a:t>
             </a:fld>
             <a:endParaRPr lang="fr-FR"/>
           </a:p>
@@ -900,7 +906,7 @@
           <a:p>
             <a:fld id="{4E51AFDA-D128-4B68-A211-269E2451E5DE}" type="datetimeFigureOut">
               <a:rPr lang="fr-FR" smtClean="0"/>
-              <a:t>10/04/2026</a:t>
+              <a:t>11/04/2026</a:t>
             </a:fld>
             <a:endParaRPr lang="fr-FR"/>
           </a:p>
@@ -954,7 +960,7 @@
           <a:p>
             <a:fld id="{FD85B578-4E75-4E1C-9BE3-D5DCC0715B13}" type="slidenum">
               <a:rPr lang="fr-FR" smtClean="0"/>
-              <a:t>‹N°›</a:t>
+              <a:t>‹#›</a:t>
             </a:fld>
             <a:endParaRPr lang="fr-FR"/>
           </a:p>
@@ -1098,7 +1104,7 @@
           <a:p>
             <a:fld id="{4E51AFDA-D128-4B68-A211-269E2451E5DE}" type="datetimeFigureOut">
               <a:rPr lang="fr-FR" smtClean="0"/>
-              <a:t>10/04/2026</a:t>
+              <a:t>11/04/2026</a:t>
             </a:fld>
             <a:endParaRPr lang="fr-FR"/>
           </a:p>
@@ -1152,7 +1158,7 @@
           <a:p>
             <a:fld id="{FD85B578-4E75-4E1C-9BE3-D5DCC0715B13}" type="slidenum">
               <a:rPr lang="fr-FR" smtClean="0"/>
-              <a:t>‹N°›</a:t>
+              <a:t>‹#›</a:t>
             </a:fld>
             <a:endParaRPr lang="fr-FR"/>
           </a:p>
@@ -1306,7 +1312,7 @@
           <a:p>
             <a:fld id="{4E51AFDA-D128-4B68-A211-269E2451E5DE}" type="datetimeFigureOut">
               <a:rPr lang="fr-FR" smtClean="0"/>
-              <a:t>10/04/2026</a:t>
+              <a:t>11/04/2026</a:t>
             </a:fld>
             <a:endParaRPr lang="fr-FR"/>
           </a:p>
@@ -1360,7 +1366,7 @@
           <a:p>
             <a:fld id="{FD85B578-4E75-4E1C-9BE3-D5DCC0715B13}" type="slidenum">
               <a:rPr lang="fr-FR" smtClean="0"/>
-              <a:t>‹N°›</a:t>
+              <a:t>‹#›</a:t>
             </a:fld>
             <a:endParaRPr lang="fr-FR"/>
           </a:p>
@@ -1504,7 +1510,7 @@
           <a:p>
             <a:fld id="{4E51AFDA-D128-4B68-A211-269E2451E5DE}" type="datetimeFigureOut">
               <a:rPr lang="fr-FR" smtClean="0"/>
-              <a:t>10/04/2026</a:t>
+              <a:t>11/04/2026</a:t>
             </a:fld>
             <a:endParaRPr lang="fr-FR"/>
           </a:p>
@@ -1558,7 +1564,7 @@
           <a:p>
             <a:fld id="{FD85B578-4E75-4E1C-9BE3-D5DCC0715B13}" type="slidenum">
               <a:rPr lang="fr-FR" smtClean="0"/>
-              <a:t>‹N°›</a:t>
+              <a:t>‹#›</a:t>
             </a:fld>
             <a:endParaRPr lang="fr-FR"/>
           </a:p>
@@ -1779,7 +1785,7 @@
           <a:p>
             <a:fld id="{4E51AFDA-D128-4B68-A211-269E2451E5DE}" type="datetimeFigureOut">
               <a:rPr lang="fr-FR" smtClean="0"/>
-              <a:t>10/04/2026</a:t>
+              <a:t>11/04/2026</a:t>
             </a:fld>
             <a:endParaRPr lang="fr-FR"/>
           </a:p>
@@ -1833,7 +1839,7 @@
           <a:p>
             <a:fld id="{FD85B578-4E75-4E1C-9BE3-D5DCC0715B13}" type="slidenum">
               <a:rPr lang="fr-FR" smtClean="0"/>
-              <a:t>‹N°›</a:t>
+              <a:t>‹#›</a:t>
             </a:fld>
             <a:endParaRPr lang="fr-FR"/>
           </a:p>
@@ -2044,7 +2050,7 @@
           <a:p>
             <a:fld id="{4E51AFDA-D128-4B68-A211-269E2451E5DE}" type="datetimeFigureOut">
               <a:rPr lang="fr-FR" smtClean="0"/>
-              <a:t>10/04/2026</a:t>
+              <a:t>11/04/2026</a:t>
             </a:fld>
             <a:endParaRPr lang="fr-FR"/>
           </a:p>
@@ -2098,7 +2104,7 @@
           <a:p>
             <a:fld id="{FD85B578-4E75-4E1C-9BE3-D5DCC0715B13}" type="slidenum">
               <a:rPr lang="fr-FR" smtClean="0"/>
-              <a:t>‹N°›</a:t>
+              <a:t>‹#›</a:t>
             </a:fld>
             <a:endParaRPr lang="fr-FR"/>
           </a:p>
@@ -2456,7 +2462,7 @@
           <a:p>
             <a:fld id="{4E51AFDA-D128-4B68-A211-269E2451E5DE}" type="datetimeFigureOut">
               <a:rPr lang="fr-FR" smtClean="0"/>
-              <a:t>10/04/2026</a:t>
+              <a:t>11/04/2026</a:t>
             </a:fld>
             <a:endParaRPr lang="fr-FR"/>
           </a:p>
@@ -2510,7 +2516,7 @@
           <a:p>
             <a:fld id="{FD85B578-4E75-4E1C-9BE3-D5DCC0715B13}" type="slidenum">
               <a:rPr lang="fr-FR" smtClean="0"/>
-              <a:t>‹N°›</a:t>
+              <a:t>‹#›</a:t>
             </a:fld>
             <a:endParaRPr lang="fr-FR"/>
           </a:p>
@@ -2597,7 +2603,7 @@
           <a:p>
             <a:fld id="{4E51AFDA-D128-4B68-A211-269E2451E5DE}" type="datetimeFigureOut">
               <a:rPr lang="fr-FR" smtClean="0"/>
-              <a:t>10/04/2026</a:t>
+              <a:t>11/04/2026</a:t>
             </a:fld>
             <a:endParaRPr lang="fr-FR"/>
           </a:p>
@@ -2651,7 +2657,7 @@
           <a:p>
             <a:fld id="{FD85B578-4E75-4E1C-9BE3-D5DCC0715B13}" type="slidenum">
               <a:rPr lang="fr-FR" smtClean="0"/>
-              <a:t>‹N°›</a:t>
+              <a:t>‹#›</a:t>
             </a:fld>
             <a:endParaRPr lang="fr-FR"/>
           </a:p>
@@ -2710,7 +2716,7 @@
           <a:p>
             <a:fld id="{4E51AFDA-D128-4B68-A211-269E2451E5DE}" type="datetimeFigureOut">
               <a:rPr lang="fr-FR" smtClean="0"/>
-              <a:t>10/04/2026</a:t>
+              <a:t>11/04/2026</a:t>
             </a:fld>
             <a:endParaRPr lang="fr-FR"/>
           </a:p>
@@ -2764,7 +2770,7 @@
           <a:p>
             <a:fld id="{FD85B578-4E75-4E1C-9BE3-D5DCC0715B13}" type="slidenum">
               <a:rPr lang="fr-FR" smtClean="0"/>
-              <a:t>‹N°›</a:t>
+              <a:t>‹#›</a:t>
             </a:fld>
             <a:endParaRPr lang="fr-FR"/>
           </a:p>
@@ -3021,7 +3027,7 @@
           <a:p>
             <a:fld id="{4E51AFDA-D128-4B68-A211-269E2451E5DE}" type="datetimeFigureOut">
               <a:rPr lang="fr-FR" smtClean="0"/>
-              <a:t>10/04/2026</a:t>
+              <a:t>11/04/2026</a:t>
             </a:fld>
             <a:endParaRPr lang="fr-FR"/>
           </a:p>
@@ -3075,7 +3081,7 @@
           <a:p>
             <a:fld id="{FD85B578-4E75-4E1C-9BE3-D5DCC0715B13}" type="slidenum">
               <a:rPr lang="fr-FR" smtClean="0"/>
-              <a:t>‹N°›</a:t>
+              <a:t>‹#›</a:t>
             </a:fld>
             <a:endParaRPr lang="fr-FR"/>
           </a:p>
@@ -3309,7 +3315,7 @@
           <a:p>
             <a:fld id="{4E51AFDA-D128-4B68-A211-269E2451E5DE}" type="datetimeFigureOut">
               <a:rPr lang="fr-FR" smtClean="0"/>
-              <a:t>10/04/2026</a:t>
+              <a:t>11/04/2026</a:t>
             </a:fld>
             <a:endParaRPr lang="fr-FR"/>
           </a:p>
@@ -3363,7 +3369,7 @@
           <a:p>
             <a:fld id="{FD85B578-4E75-4E1C-9BE3-D5DCC0715B13}" type="slidenum">
               <a:rPr lang="fr-FR" smtClean="0"/>
-              <a:t>‹N°›</a:t>
+              <a:t>‹#›</a:t>
             </a:fld>
             <a:endParaRPr lang="fr-FR"/>
           </a:p>
@@ -3553,7 +3559,7 @@
           <a:p>
             <a:fld id="{4E51AFDA-D128-4B68-A211-269E2451E5DE}" type="datetimeFigureOut">
               <a:rPr lang="fr-FR" smtClean="0"/>
-              <a:t>10/04/2026</a:t>
+              <a:t>11/04/2026</a:t>
             </a:fld>
             <a:endParaRPr lang="fr-FR"/>
           </a:p>
@@ -3643,7 +3649,7 @@
           <a:p>
             <a:fld id="{FD85B578-4E75-4E1C-9BE3-D5DCC0715B13}" type="slidenum">
               <a:rPr lang="fr-FR" smtClean="0"/>
-              <a:t>‹N°›</a:t>
+              <a:t>‹#›</a:t>
             </a:fld>
             <a:endParaRPr lang="fr-FR"/>
           </a:p>
@@ -4172,8 +4178,8 @@
           </a:p>
         </p:txBody>
       </p:sp>
-      <mc:AlternateContent xmlns:mc="http://schemas.openxmlformats.org/markup-compatibility/2006">
-        <mc:Choice xmlns:a14="http://schemas.microsoft.com/office/drawing/2010/main" Requires="a14">
+      <mc:AlternateContent xmlns:mc="http://schemas.openxmlformats.org/markup-compatibility/2006" xmlns:a14="http://schemas.microsoft.com/office/drawing/2010/main">
+        <mc:Choice Requires="a14">
           <p:sp>
             <p:nvSpPr>
               <p:cNvPr id="3" name="Espace réservé du contenu 2">
@@ -4505,7 +4511,7 @@
             </p:txBody>
           </p:sp>
         </mc:Choice>
-        <mc:Fallback>
+        <mc:Fallback xmlns="">
           <p:sp>
             <p:nvSpPr>
               <p:cNvPr id="3" name="Espace réservé du contenu 2">
@@ -4897,8 +4903,8 @@
           </a:p>
         </p:txBody>
       </p:sp>
-      <mc:AlternateContent xmlns:mc="http://schemas.openxmlformats.org/markup-compatibility/2006">
-        <mc:Choice xmlns:a14="http://schemas.microsoft.com/office/drawing/2010/main" Requires="a14">
+      <mc:AlternateContent xmlns:mc="http://schemas.openxmlformats.org/markup-compatibility/2006" xmlns:a14="http://schemas.microsoft.com/office/drawing/2010/main">
+        <mc:Choice Requires="a14">
           <p:sp>
             <p:nvSpPr>
               <p:cNvPr id="3" name="Espace réservé du contenu 2">
@@ -5457,7 +5463,7 @@
             </p:txBody>
           </p:sp>
         </mc:Choice>
-        <mc:Fallback>
+        <mc:Fallback xmlns="">
           <p:sp>
             <p:nvSpPr>
               <p:cNvPr id="3" name="Espace réservé du contenu 2">
@@ -6172,6 +6178,2569 @@
 </p:sld>
 </file>
 
+<file path=ppt/slides/slide15.xml><?xml version="1.0" encoding="utf-8"?>
+<p:sld xmlns:a="http://schemas.openxmlformats.org/drawingml/2006/main" xmlns:r="http://schemas.openxmlformats.org/officeDocument/2006/relationships" xmlns:p="http://schemas.openxmlformats.org/presentationml/2006/main">
+  <p:cSld>
+    <p:spTree>
+      <p:nvGrpSpPr>
+        <p:cNvPr id="1" name=""/>
+        <p:cNvGrpSpPr/>
+        <p:nvPr/>
+      </p:nvGrpSpPr>
+      <p:grpSpPr>
+        <a:xfrm>
+          <a:off x="0" y="0"/>
+          <a:ext cx="0" cy="0"/>
+          <a:chOff x="0" y="0"/>
+          <a:chExt cx="0" cy="0"/>
+        </a:xfrm>
+      </p:grpSpPr>
+      <p:sp>
+        <p:nvSpPr>
+          <p:cNvPr id="2" name="Title 1">
+            <a:extLst>
+              <a:ext uri="{FF2B5EF4-FFF2-40B4-BE49-F238E27FC236}">
+                <a16:creationId xmlns:a16="http://schemas.microsoft.com/office/drawing/2014/main" id="{A918AE09-663A-81B9-7889-A42F5868E2D6}"/>
+              </a:ext>
+            </a:extLst>
+          </p:cNvPr>
+          <p:cNvSpPr>
+            <a:spLocks noGrp="1"/>
+          </p:cNvSpPr>
+          <p:nvPr>
+            <p:ph type="title"/>
+          </p:nvPr>
+        </p:nvSpPr>
+        <p:spPr>
+          <a:xfrm>
+            <a:off x="838200" y="365125"/>
+            <a:ext cx="7894090" cy="808809"/>
+          </a:xfrm>
+        </p:spPr>
+        <p:txBody>
+          <a:bodyPr>
+            <a:normAutofit/>
+          </a:bodyPr>
+          <a:lstStyle/>
+          <a:p>
+            <a:r>
+              <a:rPr lang="fr-FR" dirty="0"/>
+              <a:t>Validation – erreur de simulation	:</a:t>
+            </a:r>
+            <a:endParaRPr lang="en-US" dirty="0"/>
+          </a:p>
+        </p:txBody>
+      </p:sp>
+      <mc:AlternateContent xmlns:mc="http://schemas.openxmlformats.org/markup-compatibility/2006">
+        <mc:Choice xmlns:a14="http://schemas.microsoft.com/office/drawing/2010/main" Requires="a14">
+          <p:sp>
+            <p:nvSpPr>
+              <p:cNvPr id="3" name="Content Placeholder 2">
+                <a:extLst>
+                  <a:ext uri="{FF2B5EF4-FFF2-40B4-BE49-F238E27FC236}">
+                    <a16:creationId xmlns:a16="http://schemas.microsoft.com/office/drawing/2014/main" id="{C2C32232-D971-F63A-4322-D27F6CDB07D2}"/>
+                  </a:ext>
+                </a:extLst>
+              </p:cNvPr>
+              <p:cNvSpPr>
+                <a:spLocks noGrp="1"/>
+              </p:cNvSpPr>
+              <p:nvPr>
+                <p:ph idx="1"/>
+              </p:nvPr>
+            </p:nvSpPr>
+            <p:spPr>
+              <a:xfrm>
+                <a:off x="491491" y="1173934"/>
+                <a:ext cx="7486650" cy="2347163"/>
+              </a:xfrm>
+            </p:spPr>
+            <p:txBody>
+              <a:bodyPr>
+                <a:normAutofit fontScale="92500"/>
+              </a:bodyPr>
+              <a:lstStyle/>
+              <a:p>
+                <a:pPr marL="0" indent="0">
+                  <a:buNone/>
+                </a:pPr>
+                <a14:m>
+                  <m:oMathPara xmlns:m="http://schemas.openxmlformats.org/officeDocument/2006/math">
+                    <m:oMathParaPr>
+                      <m:jc m:val="centerGroup"/>
+                    </m:oMathParaPr>
+                    <m:oMath xmlns:m="http://schemas.openxmlformats.org/officeDocument/2006/math">
+                      <m:r>
+                        <m:rPr>
+                          <m:sty m:val="p"/>
+                        </m:rPr>
+                        <a:rPr lang="fr-FR" sz="2000" b="0" i="1" smtClean="0">
+                          <a:latin typeface="Cambria Math" panose="02040503050406030204" pitchFamily="18" charset="0"/>
+                        </a:rPr>
+                        <m:t>E</m:t>
+                      </m:r>
+                      <m:r>
+                        <a:rPr lang="fr-FR" sz="2000" b="0" i="1" smtClean="0">
+                          <a:latin typeface="Cambria Math" panose="02040503050406030204" pitchFamily="18" charset="0"/>
+                        </a:rPr>
+                        <m:t>̃</m:t>
+                      </m:r>
+                      <m:r>
+                        <a:rPr lang="fr-FR" sz="2000" b="0" i="1" smtClean="0">
+                          <a:latin typeface="Cambria Math" panose="02040503050406030204" pitchFamily="18" charset="0"/>
+                        </a:rPr>
+                        <m:t> = </m:t>
+                      </m:r>
+                      <m:r>
+                        <m:rPr>
+                          <m:sty m:val="p"/>
+                        </m:rPr>
+                        <a:rPr lang="fr-FR" sz="2000" b="0" i="1" smtClean="0">
+                          <a:latin typeface="Cambria Math" panose="02040503050406030204" pitchFamily="18" charset="0"/>
+                        </a:rPr>
+                        <m:t>ye</m:t>
+                      </m:r>
+                      <m:r>
+                        <a:rPr lang="fr-FR" sz="2000" b="0" i="1" smtClean="0">
+                          <a:latin typeface="Cambria Math" panose="02040503050406030204" pitchFamily="18" charset="0"/>
+                        </a:rPr>
+                        <m:t> − </m:t>
+                      </m:r>
+                      <m:r>
+                        <m:rPr>
+                          <m:sty m:val="p"/>
+                        </m:rPr>
+                        <a:rPr lang="fr-FR" sz="2000" b="0" i="1" smtClean="0">
+                          <a:latin typeface="Cambria Math" panose="02040503050406030204" pitchFamily="18" charset="0"/>
+                        </a:rPr>
+                        <m:t>ym</m:t>
+                      </m:r>
+                      <m:r>
+                        <a:rPr lang="fr-FR" sz="2000" b="0" i="1" smtClean="0">
+                          <a:latin typeface="Cambria Math" panose="02040503050406030204" pitchFamily="18" charset="0"/>
+                        </a:rPr>
+                        <m:t> </m:t>
+                      </m:r>
+                    </m:oMath>
+                  </m:oMathPara>
+                </a14:m>
+                <a:endParaRPr lang="fr-FR" sz="2000" dirty="0"/>
+              </a:p>
+              <a:p>
+                <a:endParaRPr lang="fr-FR" sz="2000" dirty="0"/>
+              </a:p>
+              <a:p>
+                <a:r>
+                  <a:rPr lang="fr-FR" sz="2000" dirty="0"/>
+                  <a:t>Problème : pas de valeur expérimentale (manque de précision dans la littérature)</a:t>
+                </a:r>
+              </a:p>
+              <a:p>
+                <a:r>
+                  <a:rPr lang="fr-FR" sz="2000" dirty="0">
+                    <a:sym typeface="Wingdings" panose="05000000000000000000" pitchFamily="2" charset="2"/>
+                  </a:rPr>
+                  <a:t>Solution : passage par un code commercial</a:t>
+                </a:r>
+              </a:p>
+              <a:p>
+                <a:r>
+                  <a:rPr lang="fr-FR" sz="2000" dirty="0">
+                    <a:sym typeface="Wingdings" panose="05000000000000000000" pitchFamily="2" charset="2"/>
+                  </a:rPr>
+                  <a:t>Modélisation du problème sous SolidWorks pour un métal AISI 4340</a:t>
+                </a:r>
+                <a:endParaRPr lang="en-US" sz="2000" dirty="0"/>
+              </a:p>
+            </p:txBody>
+          </p:sp>
+        </mc:Choice>
+        <mc:Fallback>
+          <p:sp>
+            <p:nvSpPr>
+              <p:cNvPr id="3" name="Content Placeholder 2">
+                <a:extLst>
+                  <a:ext uri="{FF2B5EF4-FFF2-40B4-BE49-F238E27FC236}">
+                    <a16:creationId xmlns:a16="http://schemas.microsoft.com/office/drawing/2014/main" id="{C2C32232-D971-F63A-4322-D27F6CDB07D2}"/>
+                  </a:ext>
+                </a:extLst>
+              </p:cNvPr>
+              <p:cNvSpPr>
+                <a:spLocks noGrp="1" noRot="1" noChangeAspect="1" noMove="1" noResize="1" noEditPoints="1" noAdjustHandles="1" noChangeArrowheads="1" noChangeShapeType="1" noTextEdit="1"/>
+              </p:cNvSpPr>
+              <p:nvPr>
+                <p:ph idx="1"/>
+              </p:nvPr>
+            </p:nvSpPr>
+            <p:spPr>
+              <a:xfrm>
+                <a:off x="491491" y="1173934"/>
+                <a:ext cx="7486650" cy="2347163"/>
+              </a:xfrm>
+              <a:blipFill>
+                <a:blip r:embed="rId2"/>
+                <a:stretch>
+                  <a:fillRect l="-651" t="-779" r="-81"/>
+                </a:stretch>
+              </a:blipFill>
+            </p:spPr>
+            <p:txBody>
+              <a:bodyPr/>
+              <a:lstStyle/>
+              <a:p>
+                <a:r>
+                  <a:rPr lang="en-US">
+                    <a:noFill/>
+                  </a:rPr>
+                  <a:t> </a:t>
+                </a:r>
+              </a:p>
+            </p:txBody>
+          </p:sp>
+        </mc:Fallback>
+      </mc:AlternateContent>
+      <p:pic>
+        <p:nvPicPr>
+          <p:cNvPr id="7" name="Picture 6">
+            <a:extLst>
+              <a:ext uri="{FF2B5EF4-FFF2-40B4-BE49-F238E27FC236}">
+                <a16:creationId xmlns:a16="http://schemas.microsoft.com/office/drawing/2014/main" id="{32592D05-AA83-1726-AA8E-76EA7CE43027}"/>
+              </a:ext>
+            </a:extLst>
+          </p:cNvPr>
+          <p:cNvPicPr>
+            <a:picLocks noChangeAspect="1"/>
+          </p:cNvPicPr>
+          <p:nvPr/>
+        </p:nvPicPr>
+        <p:blipFill>
+          <a:blip r:embed="rId3">
+            <a:extLst>
+              <a:ext uri="{28A0092B-C50C-407E-A947-70E740481C1C}">
+                <a14:useLocalDpi xmlns:a14="http://schemas.microsoft.com/office/drawing/2010/main" val="0"/>
+              </a:ext>
+            </a:extLst>
+          </a:blip>
+          <a:stretch>
+            <a:fillRect/>
+          </a:stretch>
+        </p:blipFill>
+        <p:spPr>
+          <a:xfrm>
+            <a:off x="8625531" y="521767"/>
+            <a:ext cx="3566469" cy="2347163"/>
+          </a:xfrm>
+          <a:prstGeom prst="rect">
+            <a:avLst/>
+          </a:prstGeom>
+        </p:spPr>
+      </p:pic>
+      <p:pic>
+        <p:nvPicPr>
+          <p:cNvPr id="9" name="Picture 8">
+            <a:extLst>
+              <a:ext uri="{FF2B5EF4-FFF2-40B4-BE49-F238E27FC236}">
+                <a16:creationId xmlns:a16="http://schemas.microsoft.com/office/drawing/2014/main" id="{4100F7ED-BB1D-A4E9-64F3-B26EE6B577C0}"/>
+              </a:ext>
+            </a:extLst>
+          </p:cNvPr>
+          <p:cNvPicPr>
+            <a:picLocks noChangeAspect="1"/>
+          </p:cNvPicPr>
+          <p:nvPr/>
+        </p:nvPicPr>
+        <p:blipFill>
+          <a:blip r:embed="rId4">
+            <a:extLst>
+              <a:ext uri="{28A0092B-C50C-407E-A947-70E740481C1C}">
+                <a14:useLocalDpi xmlns:a14="http://schemas.microsoft.com/office/drawing/2010/main" val="0"/>
+              </a:ext>
+            </a:extLst>
+          </a:blip>
+          <a:stretch>
+            <a:fillRect/>
+          </a:stretch>
+        </p:blipFill>
+        <p:spPr>
+          <a:xfrm>
+            <a:off x="9077336" y="3704045"/>
+            <a:ext cx="2997683" cy="2997683"/>
+          </a:xfrm>
+          <a:prstGeom prst="rect">
+            <a:avLst/>
+          </a:prstGeom>
+        </p:spPr>
+      </p:pic>
+      <p:pic>
+        <p:nvPicPr>
+          <p:cNvPr id="11" name="Picture 10">
+            <a:extLst>
+              <a:ext uri="{FF2B5EF4-FFF2-40B4-BE49-F238E27FC236}">
+                <a16:creationId xmlns:a16="http://schemas.microsoft.com/office/drawing/2014/main" id="{F5B50BF5-90A1-6B98-D3FC-7350FE4FB618}"/>
+              </a:ext>
+            </a:extLst>
+          </p:cNvPr>
+          <p:cNvPicPr>
+            <a:picLocks noChangeAspect="1"/>
+          </p:cNvPicPr>
+          <p:nvPr/>
+        </p:nvPicPr>
+        <p:blipFill>
+          <a:blip r:embed="rId5">
+            <a:extLst>
+              <a:ext uri="{28A0092B-C50C-407E-A947-70E740481C1C}">
+                <a14:useLocalDpi xmlns:a14="http://schemas.microsoft.com/office/drawing/2010/main" val="0"/>
+              </a:ext>
+            </a:extLst>
+          </a:blip>
+          <a:stretch>
+            <a:fillRect/>
+          </a:stretch>
+        </p:blipFill>
+        <p:spPr>
+          <a:xfrm>
+            <a:off x="5602846" y="3704044"/>
+            <a:ext cx="3003714" cy="2997683"/>
+          </a:xfrm>
+          <a:prstGeom prst="rect">
+            <a:avLst/>
+          </a:prstGeom>
+        </p:spPr>
+      </p:pic>
+      <p:pic>
+        <p:nvPicPr>
+          <p:cNvPr id="13" name="Picture 12">
+            <a:extLst>
+              <a:ext uri="{FF2B5EF4-FFF2-40B4-BE49-F238E27FC236}">
+                <a16:creationId xmlns:a16="http://schemas.microsoft.com/office/drawing/2014/main" id="{A9A009A9-8BFC-1B9B-F910-FCE3DE41CCF7}"/>
+              </a:ext>
+            </a:extLst>
+          </p:cNvPr>
+          <p:cNvPicPr>
+            <a:picLocks noChangeAspect="1"/>
+          </p:cNvPicPr>
+          <p:nvPr/>
+        </p:nvPicPr>
+        <p:blipFill>
+          <a:blip r:embed="rId6">
+            <a:extLst>
+              <a:ext uri="{28A0092B-C50C-407E-A947-70E740481C1C}">
+                <a14:useLocalDpi xmlns:a14="http://schemas.microsoft.com/office/drawing/2010/main" val="0"/>
+              </a:ext>
+            </a:extLst>
+          </a:blip>
+          <a:stretch>
+            <a:fillRect/>
+          </a:stretch>
+        </p:blipFill>
+        <p:spPr>
+          <a:xfrm>
+            <a:off x="296732" y="4148806"/>
+            <a:ext cx="3848433" cy="2552921"/>
+          </a:xfrm>
+          <a:prstGeom prst="rect">
+            <a:avLst/>
+          </a:prstGeom>
+        </p:spPr>
+      </p:pic>
+      <p:sp>
+        <p:nvSpPr>
+          <p:cNvPr id="14" name="TextBox 13">
+            <a:extLst>
+              <a:ext uri="{FF2B5EF4-FFF2-40B4-BE49-F238E27FC236}">
+                <a16:creationId xmlns:a16="http://schemas.microsoft.com/office/drawing/2014/main" id="{A6A5E198-79E3-ED9B-9BBD-110FAE83354B}"/>
+              </a:ext>
+            </a:extLst>
+          </p:cNvPr>
+          <p:cNvSpPr txBox="1"/>
+          <p:nvPr/>
+        </p:nvSpPr>
+        <p:spPr>
+          <a:xfrm>
+            <a:off x="1144371" y="3874770"/>
+            <a:ext cx="2153154" cy="369332"/>
+          </a:xfrm>
+          <a:prstGeom prst="rect">
+            <a:avLst/>
+          </a:prstGeom>
+          <a:noFill/>
+        </p:spPr>
+        <p:txBody>
+          <a:bodyPr wrap="none" rtlCol="0">
+            <a:spAutoFit/>
+          </a:bodyPr>
+          <a:lstStyle/>
+          <a:p>
+            <a:r>
+              <a:rPr lang="fr-FR" dirty="0"/>
+              <a:t>Température initiale</a:t>
+            </a:r>
+            <a:endParaRPr lang="en-US" dirty="0"/>
+          </a:p>
+        </p:txBody>
+      </p:sp>
+      <p:sp>
+        <p:nvSpPr>
+          <p:cNvPr id="15" name="TextBox 14">
+            <a:extLst>
+              <a:ext uri="{FF2B5EF4-FFF2-40B4-BE49-F238E27FC236}">
+                <a16:creationId xmlns:a16="http://schemas.microsoft.com/office/drawing/2014/main" id="{54FE961D-8228-C8D9-8233-FE31E59D1AC9}"/>
+              </a:ext>
+            </a:extLst>
+          </p:cNvPr>
+          <p:cNvSpPr txBox="1"/>
+          <p:nvPr/>
+        </p:nvSpPr>
+        <p:spPr>
+          <a:xfrm>
+            <a:off x="5955189" y="3427905"/>
+            <a:ext cx="2299027" cy="369332"/>
+          </a:xfrm>
+          <a:prstGeom prst="rect">
+            <a:avLst/>
+          </a:prstGeom>
+          <a:noFill/>
+        </p:spPr>
+        <p:txBody>
+          <a:bodyPr wrap="none" rtlCol="0">
+            <a:spAutoFit/>
+          </a:bodyPr>
+          <a:lstStyle/>
+          <a:p>
+            <a:r>
+              <a:rPr lang="fr-FR" dirty="0"/>
+              <a:t>Radiation : émissivité</a:t>
+            </a:r>
+            <a:endParaRPr lang="en-US" dirty="0"/>
+          </a:p>
+        </p:txBody>
+      </p:sp>
+      <p:sp>
+        <p:nvSpPr>
+          <p:cNvPr id="16" name="TextBox 15">
+            <a:extLst>
+              <a:ext uri="{FF2B5EF4-FFF2-40B4-BE49-F238E27FC236}">
+                <a16:creationId xmlns:a16="http://schemas.microsoft.com/office/drawing/2014/main" id="{51AC3AD7-E755-29F6-BDA8-03CAC197225B}"/>
+              </a:ext>
+            </a:extLst>
+          </p:cNvPr>
+          <p:cNvSpPr txBox="1"/>
+          <p:nvPr/>
+        </p:nvSpPr>
+        <p:spPr>
+          <a:xfrm>
+            <a:off x="9912373" y="3427905"/>
+            <a:ext cx="1327608" cy="369332"/>
+          </a:xfrm>
+          <a:prstGeom prst="rect">
+            <a:avLst/>
+          </a:prstGeom>
+          <a:noFill/>
+        </p:spPr>
+        <p:txBody>
+          <a:bodyPr wrap="none" rtlCol="0">
+            <a:spAutoFit/>
+          </a:bodyPr>
+          <a:lstStyle/>
+          <a:p>
+            <a:r>
+              <a:rPr lang="fr-FR" dirty="0"/>
+              <a:t>Convection</a:t>
+            </a:r>
+            <a:endParaRPr lang="en-US" dirty="0"/>
+          </a:p>
+        </p:txBody>
+      </p:sp>
+    </p:spTree>
+    <p:extLst>
+      <p:ext uri="{BB962C8B-B14F-4D97-AF65-F5344CB8AC3E}">
+        <p14:creationId xmlns:p14="http://schemas.microsoft.com/office/powerpoint/2010/main" val="888647311"/>
+      </p:ext>
+    </p:extLst>
+  </p:cSld>
+  <p:clrMapOvr>
+    <a:masterClrMapping/>
+  </p:clrMapOvr>
+</p:sld>
+</file>
+
+<file path=ppt/slides/slide16.xml><?xml version="1.0" encoding="utf-8"?>
+<p:sld xmlns:a="http://schemas.openxmlformats.org/drawingml/2006/main" xmlns:r="http://schemas.openxmlformats.org/officeDocument/2006/relationships" xmlns:p="http://schemas.openxmlformats.org/presentationml/2006/main">
+  <p:cSld>
+    <p:spTree>
+      <p:nvGrpSpPr>
+        <p:cNvPr id="1" name=""/>
+        <p:cNvGrpSpPr/>
+        <p:nvPr/>
+      </p:nvGrpSpPr>
+      <p:grpSpPr>
+        <a:xfrm>
+          <a:off x="0" y="0"/>
+          <a:ext cx="0" cy="0"/>
+          <a:chOff x="0" y="0"/>
+          <a:chExt cx="0" cy="0"/>
+        </a:xfrm>
+      </p:grpSpPr>
+      <p:sp>
+        <p:nvSpPr>
+          <p:cNvPr id="2" name="Title 1">
+            <a:extLst>
+              <a:ext uri="{FF2B5EF4-FFF2-40B4-BE49-F238E27FC236}">
+                <a16:creationId xmlns:a16="http://schemas.microsoft.com/office/drawing/2014/main" id="{5A8D1F89-F778-6C72-5829-94790C929507}"/>
+              </a:ext>
+            </a:extLst>
+          </p:cNvPr>
+          <p:cNvSpPr>
+            <a:spLocks noGrp="1"/>
+          </p:cNvSpPr>
+          <p:nvPr>
+            <p:ph type="title"/>
+          </p:nvPr>
+        </p:nvSpPr>
+        <p:spPr/>
+        <p:txBody>
+          <a:bodyPr/>
+          <a:lstStyle/>
+          <a:p>
+            <a:r>
+              <a:rPr lang="fr-FR" dirty="0"/>
+              <a:t>Validation - erreur de simulation :</a:t>
+            </a:r>
+            <a:endParaRPr lang="en-US" dirty="0"/>
+          </a:p>
+        </p:txBody>
+      </p:sp>
+      <p:pic>
+        <p:nvPicPr>
+          <p:cNvPr id="35" name="Content Placeholder 34">
+            <a:extLst>
+              <a:ext uri="{FF2B5EF4-FFF2-40B4-BE49-F238E27FC236}">
+                <a16:creationId xmlns:a16="http://schemas.microsoft.com/office/drawing/2014/main" id="{B470CD96-A82E-E0EB-A3EC-1334F9C20B6F}"/>
+              </a:ext>
+            </a:extLst>
+          </p:cNvPr>
+          <p:cNvPicPr>
+            <a:picLocks noGrp="1" noRot="1" noChangeAspect="1" noMove="1" noResize="1" noEditPoints="1" noAdjustHandles="1" noChangeArrowheads="1" noChangeShapeType="1" noCrop="1"/>
+          </p:cNvPicPr>
+          <p:nvPr>
+            <p:ph idx="1"/>
+          </p:nvPr>
+        </p:nvPicPr>
+        <p:blipFill>
+          <a:blip r:embed="rId2">
+            <a:extLst>
+              <a:ext uri="{28A0092B-C50C-407E-A947-70E740481C1C}">
+                <a14:useLocalDpi xmlns:a14="http://schemas.microsoft.com/office/drawing/2010/main" val="0"/>
+              </a:ext>
+            </a:extLst>
+          </a:blip>
+          <a:stretch>
+            <a:fillRect/>
+          </a:stretch>
+        </p:blipFill>
+        <p:spPr>
+          <a:xfrm>
+            <a:off x="183670" y="4864715"/>
+            <a:ext cx="764723" cy="1531620"/>
+          </a:xfrm>
+          <a:prstGeom prst="rect">
+            <a:avLst/>
+          </a:prstGeom>
+        </p:spPr>
+      </p:pic>
+      <p:pic>
+        <p:nvPicPr>
+          <p:cNvPr id="37" name="Picture 36">
+            <a:extLst>
+              <a:ext uri="{FF2B5EF4-FFF2-40B4-BE49-F238E27FC236}">
+                <a16:creationId xmlns:a16="http://schemas.microsoft.com/office/drawing/2014/main" id="{BD5C8037-549E-B941-FE25-FC8B83B3AE8B}"/>
+              </a:ext>
+            </a:extLst>
+          </p:cNvPr>
+          <p:cNvPicPr>
+            <a:picLocks noGrp="1" noRot="1" noChangeAspect="1" noMove="1" noResize="1" noEditPoints="1" noAdjustHandles="1" noChangeArrowheads="1" noChangeShapeType="1" noCrop="1"/>
+          </p:cNvPicPr>
+          <p:nvPr/>
+        </p:nvPicPr>
+        <p:blipFill>
+          <a:blip r:embed="rId3">
+            <a:extLst>
+              <a:ext uri="{28A0092B-C50C-407E-A947-70E740481C1C}">
+                <a14:useLocalDpi xmlns:a14="http://schemas.microsoft.com/office/drawing/2010/main" val="0"/>
+              </a:ext>
+            </a:extLst>
+          </a:blip>
+          <a:stretch>
+            <a:fillRect/>
+          </a:stretch>
+        </p:blipFill>
+        <p:spPr>
+          <a:xfrm>
+            <a:off x="987481" y="4864715"/>
+            <a:ext cx="770186" cy="1531620"/>
+          </a:xfrm>
+          <a:prstGeom prst="rect">
+            <a:avLst/>
+          </a:prstGeom>
+        </p:spPr>
+      </p:pic>
+      <p:pic>
+        <p:nvPicPr>
+          <p:cNvPr id="39" name="Picture 38">
+            <a:extLst>
+              <a:ext uri="{FF2B5EF4-FFF2-40B4-BE49-F238E27FC236}">
+                <a16:creationId xmlns:a16="http://schemas.microsoft.com/office/drawing/2014/main" id="{D4695AF5-14C8-8B55-5D76-A5D9F788F65F}"/>
+              </a:ext>
+            </a:extLst>
+          </p:cNvPr>
+          <p:cNvPicPr>
+            <a:picLocks noGrp="1" noRot="1" noChangeAspect="1" noMove="1" noResize="1" noEditPoints="1" noAdjustHandles="1" noChangeArrowheads="1" noChangeShapeType="1" noCrop="1"/>
+          </p:cNvPicPr>
+          <p:nvPr/>
+        </p:nvPicPr>
+        <p:blipFill>
+          <a:blip r:embed="rId4">
+            <a:extLst>
+              <a:ext uri="{28A0092B-C50C-407E-A947-70E740481C1C}">
+                <a14:useLocalDpi xmlns:a14="http://schemas.microsoft.com/office/drawing/2010/main" val="0"/>
+              </a:ext>
+            </a:extLst>
+          </a:blip>
+          <a:stretch>
+            <a:fillRect/>
+          </a:stretch>
+        </p:blipFill>
+        <p:spPr>
+          <a:xfrm>
+            <a:off x="1791287" y="4864715"/>
+            <a:ext cx="775642" cy="1531620"/>
+          </a:xfrm>
+          <a:prstGeom prst="rect">
+            <a:avLst/>
+          </a:prstGeom>
+        </p:spPr>
+      </p:pic>
+      <p:pic>
+        <p:nvPicPr>
+          <p:cNvPr id="41" name="Picture 40">
+            <a:extLst>
+              <a:ext uri="{FF2B5EF4-FFF2-40B4-BE49-F238E27FC236}">
+                <a16:creationId xmlns:a16="http://schemas.microsoft.com/office/drawing/2014/main" id="{AE5FD986-C902-A6A4-CE75-3F189ADA9EED}"/>
+              </a:ext>
+            </a:extLst>
+          </p:cNvPr>
+          <p:cNvPicPr>
+            <a:picLocks noGrp="1" noRot="1" noChangeAspect="1" noMove="1" noResize="1" noEditPoints="1" noAdjustHandles="1" noChangeArrowheads="1" noChangeShapeType="1" noCrop="1"/>
+          </p:cNvPicPr>
+          <p:nvPr/>
+        </p:nvPicPr>
+        <p:blipFill>
+          <a:blip r:embed="rId5">
+            <a:extLst>
+              <a:ext uri="{28A0092B-C50C-407E-A947-70E740481C1C}">
+                <a14:useLocalDpi xmlns:a14="http://schemas.microsoft.com/office/drawing/2010/main" val="0"/>
+              </a:ext>
+            </a:extLst>
+          </a:blip>
+          <a:stretch>
+            <a:fillRect/>
+          </a:stretch>
+        </p:blipFill>
+        <p:spPr>
+          <a:xfrm>
+            <a:off x="2603321" y="4864715"/>
+            <a:ext cx="771257" cy="1531620"/>
+          </a:xfrm>
+          <a:prstGeom prst="rect">
+            <a:avLst/>
+          </a:prstGeom>
+        </p:spPr>
+      </p:pic>
+      <p:pic>
+        <p:nvPicPr>
+          <p:cNvPr id="43" name="Picture 42">
+            <a:extLst>
+              <a:ext uri="{FF2B5EF4-FFF2-40B4-BE49-F238E27FC236}">
+                <a16:creationId xmlns:a16="http://schemas.microsoft.com/office/drawing/2014/main" id="{E4EFAB5C-E687-B58A-EE9E-79B9093375AE}"/>
+              </a:ext>
+            </a:extLst>
+          </p:cNvPr>
+          <p:cNvPicPr>
+            <a:picLocks noGrp="1" noRot="1" noChangeAspect="1" noMove="1" noResize="1" noEditPoints="1" noAdjustHandles="1" noChangeArrowheads="1" noChangeShapeType="1" noCrop="1"/>
+          </p:cNvPicPr>
+          <p:nvPr/>
+        </p:nvPicPr>
+        <p:blipFill>
+          <a:blip r:embed="rId6">
+            <a:extLst>
+              <a:ext uri="{28A0092B-C50C-407E-A947-70E740481C1C}">
+                <a14:useLocalDpi xmlns:a14="http://schemas.microsoft.com/office/drawing/2010/main" val="0"/>
+              </a:ext>
+            </a:extLst>
+          </a:blip>
+          <a:stretch>
+            <a:fillRect/>
+          </a:stretch>
+        </p:blipFill>
+        <p:spPr>
+          <a:xfrm>
+            <a:off x="3401810" y="4864715"/>
+            <a:ext cx="764717" cy="1531620"/>
+          </a:xfrm>
+          <a:prstGeom prst="rect">
+            <a:avLst/>
+          </a:prstGeom>
+        </p:spPr>
+      </p:pic>
+      <p:pic>
+        <p:nvPicPr>
+          <p:cNvPr id="45" name="Picture 44">
+            <a:extLst>
+              <a:ext uri="{FF2B5EF4-FFF2-40B4-BE49-F238E27FC236}">
+                <a16:creationId xmlns:a16="http://schemas.microsoft.com/office/drawing/2014/main" id="{F72B7175-DEBB-3BDD-18D7-21B44DE17A67}"/>
+              </a:ext>
+            </a:extLst>
+          </p:cNvPr>
+          <p:cNvPicPr>
+            <a:picLocks noGrp="1" noRot="1" noChangeAspect="1" noMove="1" noResize="1" noEditPoints="1" noAdjustHandles="1" noChangeArrowheads="1" noChangeShapeType="1" noCrop="1"/>
+          </p:cNvPicPr>
+          <p:nvPr/>
+        </p:nvPicPr>
+        <p:blipFill>
+          <a:blip r:embed="rId7">
+            <a:extLst>
+              <a:ext uri="{28A0092B-C50C-407E-A947-70E740481C1C}">
+                <a14:useLocalDpi xmlns:a14="http://schemas.microsoft.com/office/drawing/2010/main" val="0"/>
+              </a:ext>
+            </a:extLst>
+          </a:blip>
+          <a:stretch>
+            <a:fillRect/>
+          </a:stretch>
+        </p:blipFill>
+        <p:spPr>
+          <a:xfrm>
+            <a:off x="4204095" y="4864715"/>
+            <a:ext cx="752530" cy="1531620"/>
+          </a:xfrm>
+          <a:prstGeom prst="rect">
+            <a:avLst/>
+          </a:prstGeom>
+        </p:spPr>
+      </p:pic>
+      <p:pic>
+        <p:nvPicPr>
+          <p:cNvPr id="47" name="Picture 46">
+            <a:extLst>
+              <a:ext uri="{FF2B5EF4-FFF2-40B4-BE49-F238E27FC236}">
+                <a16:creationId xmlns:a16="http://schemas.microsoft.com/office/drawing/2014/main" id="{CFEAD094-7ADB-7B93-230A-513191FA86AA}"/>
+              </a:ext>
+            </a:extLst>
+          </p:cNvPr>
+          <p:cNvPicPr>
+            <a:picLocks noGrp="1" noRot="1" noChangeAspect="1" noMove="1" noResize="1" noEditPoints="1" noAdjustHandles="1" noChangeArrowheads="1" noChangeShapeType="1" noCrop="1"/>
+          </p:cNvPicPr>
+          <p:nvPr/>
+        </p:nvPicPr>
+        <p:blipFill>
+          <a:blip r:embed="rId8">
+            <a:extLst>
+              <a:ext uri="{28A0092B-C50C-407E-A947-70E740481C1C}">
+                <a14:useLocalDpi xmlns:a14="http://schemas.microsoft.com/office/drawing/2010/main" val="0"/>
+              </a:ext>
+            </a:extLst>
+          </a:blip>
+          <a:stretch>
+            <a:fillRect/>
+          </a:stretch>
+        </p:blipFill>
+        <p:spPr>
+          <a:xfrm>
+            <a:off x="5009543" y="4864715"/>
+            <a:ext cx="773458" cy="1531620"/>
+          </a:xfrm>
+          <a:prstGeom prst="rect">
+            <a:avLst/>
+          </a:prstGeom>
+        </p:spPr>
+      </p:pic>
+      <p:pic>
+        <p:nvPicPr>
+          <p:cNvPr id="49" name="Picture 48">
+            <a:extLst>
+              <a:ext uri="{FF2B5EF4-FFF2-40B4-BE49-F238E27FC236}">
+                <a16:creationId xmlns:a16="http://schemas.microsoft.com/office/drawing/2014/main" id="{E0245B62-8CC7-E885-49A0-9C13DA3242F2}"/>
+              </a:ext>
+            </a:extLst>
+          </p:cNvPr>
+          <p:cNvPicPr>
+            <a:picLocks noGrp="1" noRot="1" noChangeAspect="1" noMove="1" noResize="1" noEditPoints="1" noAdjustHandles="1" noChangeArrowheads="1" noChangeShapeType="1" noCrop="1"/>
+          </p:cNvPicPr>
+          <p:nvPr/>
+        </p:nvPicPr>
+        <p:blipFill>
+          <a:blip r:embed="rId9">
+            <a:extLst>
+              <a:ext uri="{28A0092B-C50C-407E-A947-70E740481C1C}">
+                <a14:useLocalDpi xmlns:a14="http://schemas.microsoft.com/office/drawing/2010/main" val="0"/>
+              </a:ext>
+            </a:extLst>
+          </a:blip>
+          <a:stretch>
+            <a:fillRect/>
+          </a:stretch>
+        </p:blipFill>
+        <p:spPr>
+          <a:xfrm>
+            <a:off x="5833093" y="4864715"/>
+            <a:ext cx="774537" cy="1531620"/>
+          </a:xfrm>
+          <a:prstGeom prst="rect">
+            <a:avLst/>
+          </a:prstGeom>
+        </p:spPr>
+      </p:pic>
+      <p:pic>
+        <p:nvPicPr>
+          <p:cNvPr id="52" name="Picture 51">
+            <a:extLst>
+              <a:ext uri="{FF2B5EF4-FFF2-40B4-BE49-F238E27FC236}">
+                <a16:creationId xmlns:a16="http://schemas.microsoft.com/office/drawing/2014/main" id="{51A5B0D7-2859-21E8-101F-3B1B9D125349}"/>
+              </a:ext>
+            </a:extLst>
+          </p:cNvPr>
+          <p:cNvPicPr>
+            <a:picLocks noGrp="1" noRot="1" noChangeAspect="1" noMove="1" noResize="1" noEditPoints="1" noAdjustHandles="1" noChangeArrowheads="1" noChangeShapeType="1" noCrop="1"/>
+          </p:cNvPicPr>
+          <p:nvPr/>
+        </p:nvPicPr>
+        <p:blipFill>
+          <a:blip r:embed="rId10">
+            <a:extLst>
+              <a:ext uri="{28A0092B-C50C-407E-A947-70E740481C1C}">
+                <a14:useLocalDpi xmlns:a14="http://schemas.microsoft.com/office/drawing/2010/main" val="0"/>
+              </a:ext>
+            </a:extLst>
+          </a:blip>
+          <a:stretch>
+            <a:fillRect/>
+          </a:stretch>
+        </p:blipFill>
+        <p:spPr>
+          <a:xfrm>
+            <a:off x="6656258" y="4864715"/>
+            <a:ext cx="770161" cy="1531620"/>
+          </a:xfrm>
+          <a:prstGeom prst="rect">
+            <a:avLst/>
+          </a:prstGeom>
+        </p:spPr>
+      </p:pic>
+      <p:cxnSp>
+        <p:nvCxnSpPr>
+          <p:cNvPr id="54" name="Straight Arrow Connector 53">
+            <a:extLst>
+              <a:ext uri="{FF2B5EF4-FFF2-40B4-BE49-F238E27FC236}">
+                <a16:creationId xmlns:a16="http://schemas.microsoft.com/office/drawing/2014/main" id="{7DC9A4AC-38ED-A0E8-3543-95C8B64B1948}"/>
+              </a:ext>
+            </a:extLst>
+          </p:cNvPr>
+          <p:cNvCxnSpPr>
+            <a:cxnSpLocks noGrp="1" noRot="1" noMove="1" noResize="1" noEditPoints="1" noAdjustHandles="1" noChangeArrowheads="1" noChangeShapeType="1"/>
+          </p:cNvCxnSpPr>
+          <p:nvPr/>
+        </p:nvCxnSpPr>
+        <p:spPr>
+          <a:xfrm>
+            <a:off x="160020" y="6533495"/>
+            <a:ext cx="7338060" cy="0"/>
+          </a:xfrm>
+          <a:prstGeom prst="straightConnector1">
+            <a:avLst/>
+          </a:prstGeom>
+          <a:ln>
+            <a:tailEnd type="triangle"/>
+          </a:ln>
+        </p:spPr>
+        <p:style>
+          <a:lnRef idx="2">
+            <a:schemeClr val="dk1"/>
+          </a:lnRef>
+          <a:fillRef idx="0">
+            <a:schemeClr val="dk1"/>
+          </a:fillRef>
+          <a:effectRef idx="1">
+            <a:schemeClr val="dk1"/>
+          </a:effectRef>
+          <a:fontRef idx="minor">
+            <a:schemeClr val="tx1"/>
+          </a:fontRef>
+        </p:style>
+      </p:cxnSp>
+      <mc:AlternateContent xmlns:mc="http://schemas.openxmlformats.org/markup-compatibility/2006">
+        <mc:Choice xmlns:a14="http://schemas.microsoft.com/office/drawing/2010/main" Requires="a14">
+          <p:sp>
+            <p:nvSpPr>
+              <p:cNvPr id="58" name="TextBox 57">
+                <a:extLst>
+                  <a:ext uri="{FF2B5EF4-FFF2-40B4-BE49-F238E27FC236}">
+                    <a16:creationId xmlns:a16="http://schemas.microsoft.com/office/drawing/2014/main" id="{0CEAB3DF-E113-A48A-4976-5362A80A08F7}"/>
+                  </a:ext>
+                </a:extLst>
+              </p:cNvPr>
+              <p:cNvSpPr txBox="1"/>
+              <p:nvPr/>
+            </p:nvSpPr>
+            <p:spPr>
+              <a:xfrm>
+                <a:off x="560860" y="1690688"/>
+                <a:ext cx="10651970" cy="2986459"/>
+              </a:xfrm>
+              <a:prstGeom prst="rect">
+                <a:avLst/>
+              </a:prstGeom>
+              <a:noFill/>
+            </p:spPr>
+            <p:txBody>
+              <a:bodyPr wrap="square" rtlCol="0">
+                <a:spAutoFit/>
+              </a:bodyPr>
+              <a:lstStyle/>
+              <a:p>
+                <a:pPr marL="285750" indent="-285750">
+                  <a:buFont typeface="Arial" panose="020B0604020202020204" pitchFamily="34" charset="0"/>
+                  <a:buChar char="•"/>
+                </a:pPr>
+                <a:r>
+                  <a:rPr lang="fr-FR" dirty="0"/>
+                  <a:t>S’assurer de la qualité des résultats de SolidWorks </a:t>
+                </a:r>
+                <a:r>
+                  <a:rPr lang="fr-FR" dirty="0">
+                    <a:sym typeface="Wingdings" panose="05000000000000000000" pitchFamily="2" charset="2"/>
+                  </a:rPr>
+                  <a:t> analyse de convergence (temps et espace)</a:t>
+                </a:r>
+              </a:p>
+              <a:p>
+                <a:pPr marL="285750" indent="-285750">
+                  <a:buFont typeface="Arial" panose="020B0604020202020204" pitchFamily="34" charset="0"/>
+                  <a:buChar char="•"/>
+                </a:pPr>
+                <a14:m>
+                  <m:oMath xmlns:m="http://schemas.openxmlformats.org/officeDocument/2006/math">
+                    <m:r>
+                      <m:rPr>
+                        <m:sty m:val="p"/>
+                      </m:rPr>
+                      <a:rPr lang="fr-FR" b="0" i="1" smtClean="0">
+                        <a:latin typeface="Cambria Math" panose="02040503050406030204" pitchFamily="18" charset="0"/>
+                        <a:sym typeface="Wingdings" panose="05000000000000000000" pitchFamily="2" charset="2"/>
+                      </a:rPr>
+                      <m:t>h</m:t>
+                    </m:r>
+                    <m:r>
+                      <a:rPr lang="fr-FR" b="0" i="1" smtClean="0">
+                        <a:latin typeface="Cambria Math" panose="02040503050406030204" pitchFamily="18" charset="0"/>
+                        <a:sym typeface="Wingdings" panose="05000000000000000000" pitchFamily="2" charset="2"/>
+                      </a:rPr>
+                      <m:t>=</m:t>
+                    </m:r>
+                    <m:f>
+                      <m:fPr>
+                        <m:ctrlPr>
+                          <a:rPr lang="pt-BR" b="0" i="1" smtClean="0">
+                            <a:latin typeface="Cambria Math" panose="02040503050406030204" pitchFamily="18" charset="0"/>
+                            <a:sym typeface="Wingdings" panose="05000000000000000000" pitchFamily="2" charset="2"/>
+                          </a:rPr>
+                        </m:ctrlPr>
+                      </m:fPr>
+                      <m:num>
+                        <m:r>
+                          <m:rPr>
+                            <m:sty m:val="p"/>
+                          </m:rPr>
+                          <a:rPr lang="fr-FR" i="1">
+                            <a:latin typeface="Cambria Math" panose="02040503050406030204" pitchFamily="18" charset="0"/>
+                            <a:sym typeface="Wingdings" panose="05000000000000000000" pitchFamily="2" charset="2"/>
+                          </a:rPr>
+                          <m:t>Δt</m:t>
+                        </m:r>
+                      </m:num>
+                      <m:den>
+                        <m:r>
+                          <m:rPr>
+                            <m:sty m:val="p"/>
+                          </m:rPr>
+                          <a:rPr lang="fr-FR" b="0" i="1" smtClean="0">
+                            <a:latin typeface="Cambria Math" panose="02040503050406030204" pitchFamily="18" charset="0"/>
+                            <a:sym typeface="Wingdings" panose="05000000000000000000" pitchFamily="2" charset="2"/>
+                          </a:rPr>
+                          <m:t>Te</m:t>
+                        </m:r>
+                      </m:den>
+                    </m:f>
+                    <m:r>
+                      <a:rPr lang="fr-FR" b="0" i="1" smtClean="0">
+                        <a:latin typeface="Cambria Math" panose="02040503050406030204" pitchFamily="18" charset="0"/>
+                        <a:sym typeface="Wingdings" panose="05000000000000000000" pitchFamily="2" charset="2"/>
+                      </a:rPr>
+                      <m:t> </m:t>
+                    </m:r>
+                  </m:oMath>
+                </a14:m>
+                <a:r>
+                  <a:rPr lang="fr-FR" dirty="0">
+                    <a:sym typeface="Wingdings" panose="05000000000000000000" pitchFamily="2" charset="2"/>
+                  </a:rPr>
+                  <a:t> où Te désigne la taille des éléments (cm) et </a:t>
+                </a:r>
+                <a14:m>
+                  <m:oMath xmlns:m="http://schemas.openxmlformats.org/officeDocument/2006/math">
+                    <m:r>
+                      <m:rPr>
+                        <m:sty m:val="p"/>
+                      </m:rPr>
+                      <a:rPr lang="fr-FR" i="1">
+                        <a:latin typeface="Cambria Math" panose="02040503050406030204" pitchFamily="18" charset="0"/>
+                        <a:sym typeface="Wingdings" panose="05000000000000000000" pitchFamily="2" charset="2"/>
+                      </a:rPr>
+                      <m:t>Δt</m:t>
+                    </m:r>
+                  </m:oMath>
+                </a14:m>
+                <a:r>
+                  <a:rPr lang="fr-FR" dirty="0">
+                    <a:sym typeface="Wingdings" panose="05000000000000000000" pitchFamily="2" charset="2"/>
+                  </a:rPr>
+                  <a:t> le pas de temps (s)</a:t>
+                </a:r>
+              </a:p>
+              <a:p>
+                <a:pPr marL="285750" indent="-285750">
+                  <a:buFont typeface="Arial" panose="020B0604020202020204" pitchFamily="34" charset="0"/>
+                  <a:buChar char="•"/>
+                </a:pPr>
+                <a:r>
+                  <a:rPr lang="fr-FR" dirty="0">
+                    <a:sym typeface="Wingdings" panose="05000000000000000000" pitchFamily="2" charset="2"/>
+                  </a:rPr>
+                  <a:t>Analyse de convergence réalisé avec les paramètres : </a:t>
+                </a:r>
+              </a:p>
+              <a:p>
+                <a:pPr marL="742950" lvl="1" indent="-285750">
+                  <a:buFont typeface="Arial" panose="020B0604020202020204" pitchFamily="34" charset="0"/>
+                  <a:buChar char="•"/>
+                </a:pPr>
+                <a14:m>
+                  <m:oMath xmlns:m="http://schemas.openxmlformats.org/officeDocument/2006/math">
+                    <m:r>
+                      <m:rPr>
+                        <m:sty m:val="p"/>
+                      </m:rPr>
+                      <a:rPr lang="fr-FR" b="0" i="1" smtClean="0">
+                        <a:latin typeface="Cambria Math" panose="02040503050406030204" pitchFamily="18" charset="0"/>
+                        <a:sym typeface="Wingdings" panose="05000000000000000000" pitchFamily="2" charset="2"/>
+                      </a:rPr>
+                      <m:t>t</m:t>
+                    </m:r>
+                    <m:r>
+                      <m:rPr>
+                        <m:sty m:val="p"/>
+                      </m:rPr>
+                      <a:rPr lang="fr-FR" b="0" i="1" baseline="-25000" smtClean="0">
+                        <a:latin typeface="Cambria Math" panose="02040503050406030204" pitchFamily="18" charset="0"/>
+                        <a:sym typeface="Wingdings" panose="05000000000000000000" pitchFamily="2" charset="2"/>
+                      </a:rPr>
+                      <m:t>fin</m:t>
+                    </m:r>
+                    <m:r>
+                      <a:rPr lang="fr-FR" b="0" i="1" smtClean="0">
+                        <a:latin typeface="Cambria Math" panose="02040503050406030204" pitchFamily="18" charset="0"/>
+                        <a:sym typeface="Wingdings" panose="05000000000000000000" pitchFamily="2" charset="2"/>
+                      </a:rPr>
+                      <m:t> = 100</m:t>
+                    </m:r>
+                    <m:r>
+                      <m:rPr>
+                        <m:sty m:val="p"/>
+                      </m:rPr>
+                      <a:rPr lang="fr-FR" b="0" i="1" smtClean="0">
+                        <a:latin typeface="Cambria Math" panose="02040503050406030204" pitchFamily="18" charset="0"/>
+                        <a:sym typeface="Wingdings" panose="05000000000000000000" pitchFamily="2" charset="2"/>
+                      </a:rPr>
+                      <m:t>s</m:t>
+                    </m:r>
+                    <m:r>
+                      <a:rPr lang="fr-FR" b="0" i="1" smtClean="0">
+                        <a:latin typeface="Cambria Math" panose="02040503050406030204" pitchFamily="18" charset="0"/>
+                        <a:sym typeface="Wingdings" panose="05000000000000000000" pitchFamily="2" charset="2"/>
+                      </a:rPr>
+                      <m:t> , </m:t>
+                    </m:r>
+                    <m:r>
+                      <m:rPr>
+                        <m:sty m:val="p"/>
+                      </m:rPr>
+                      <a:rPr lang="fr-FR" b="0" i="1" smtClean="0">
+                        <a:latin typeface="Cambria Math" panose="02040503050406030204" pitchFamily="18" charset="0"/>
+                        <a:sym typeface="Wingdings" panose="05000000000000000000" pitchFamily="2" charset="2"/>
+                      </a:rPr>
+                      <m:t>h</m:t>
+                    </m:r>
+                    <m:r>
+                      <a:rPr lang="fr-FR" b="0" i="1" smtClean="0">
+                        <a:latin typeface="Cambria Math" panose="02040503050406030204" pitchFamily="18" charset="0"/>
+                        <a:sym typeface="Wingdings" panose="05000000000000000000" pitchFamily="2" charset="2"/>
+                      </a:rPr>
+                      <m:t>=2</m:t>
+                    </m:r>
+                  </m:oMath>
+                </a14:m>
+                <a:endParaRPr lang="fr-FR" dirty="0">
+                  <a:sym typeface="Wingdings" panose="05000000000000000000" pitchFamily="2" charset="2"/>
+                </a:endParaRPr>
+              </a:p>
+              <a:p>
+                <a:pPr marL="285750" indent="-285750">
+                  <a:buFont typeface="Arial" panose="020B0604020202020204" pitchFamily="34" charset="0"/>
+                  <a:buChar char="•"/>
+                </a:pPr>
+                <a:endParaRPr lang="fr-FR" dirty="0">
+                  <a:sym typeface="Wingdings" panose="05000000000000000000" pitchFamily="2" charset="2"/>
+                </a:endParaRPr>
+              </a:p>
+              <a:p>
+                <a:pPr marL="285750" indent="-285750">
+                  <a:buFont typeface="Arial" panose="020B0604020202020204" pitchFamily="34" charset="0"/>
+                  <a:buChar char="•"/>
+                </a:pPr>
+                <a:r>
+                  <a:rPr lang="fr-FR" dirty="0">
+                    <a:sym typeface="Wingdings" panose="05000000000000000000" pitchFamily="2" charset="2"/>
+                  </a:rPr>
+                  <a:t>Condition : obtenir convergence des valeurs finales + symétrie </a:t>
+                </a:r>
+              </a:p>
+              <a:p>
+                <a:pPr marL="285750" indent="-285750">
+                  <a:buFont typeface="Arial" panose="020B0604020202020204" pitchFamily="34" charset="0"/>
+                  <a:buChar char="•"/>
+                </a:pPr>
+                <a:endParaRPr lang="fr-FR" dirty="0">
+                  <a:sym typeface="Wingdings" panose="05000000000000000000" pitchFamily="2" charset="2"/>
+                </a:endParaRPr>
+              </a:p>
+              <a:p>
+                <a:pPr marL="285750" indent="-285750">
+                  <a:buFont typeface="Arial" panose="020B0604020202020204" pitchFamily="34" charset="0"/>
+                  <a:buChar char="•"/>
+                </a:pPr>
+                <a:r>
+                  <a:rPr lang="fr-FR" dirty="0">
+                    <a:sym typeface="Wingdings" panose="05000000000000000000" pitchFamily="2" charset="2"/>
+                  </a:rPr>
+                  <a:t>Obtention de résultat fiable pour </a:t>
+                </a:r>
+                <a14:m>
+                  <m:oMath xmlns:m="http://schemas.openxmlformats.org/officeDocument/2006/math">
+                    <m:r>
+                      <m:rPr>
+                        <m:sty m:val="p"/>
+                      </m:rPr>
+                      <a:rPr lang="fr-FR" i="1">
+                        <a:latin typeface="Cambria Math" panose="02040503050406030204" pitchFamily="18" charset="0"/>
+                        <a:sym typeface="Wingdings" panose="05000000000000000000" pitchFamily="2" charset="2"/>
+                      </a:rPr>
+                      <m:t>Δt</m:t>
+                    </m:r>
+                    <m:r>
+                      <a:rPr lang="fr-FR" b="0" i="1" smtClean="0">
+                        <a:latin typeface="Cambria Math" panose="02040503050406030204" pitchFamily="18" charset="0"/>
+                        <a:sym typeface="Wingdings" panose="05000000000000000000" pitchFamily="2" charset="2"/>
+                      </a:rPr>
+                      <m:t>= 0.6</m:t>
+                    </m:r>
+                    <m:r>
+                      <m:rPr>
+                        <m:sty m:val="p"/>
+                      </m:rPr>
+                      <a:rPr lang="fr-FR" b="0" i="1" smtClean="0">
+                        <a:latin typeface="Cambria Math" panose="02040503050406030204" pitchFamily="18" charset="0"/>
+                        <a:sym typeface="Wingdings" panose="05000000000000000000" pitchFamily="2" charset="2"/>
+                      </a:rPr>
+                      <m:t>s</m:t>
+                    </m:r>
+                  </m:oMath>
+                </a14:m>
+                <a:r>
+                  <a:rPr lang="fr-FR" dirty="0">
+                    <a:sym typeface="Wingdings" panose="05000000000000000000" pitchFamily="2" charset="2"/>
+                  </a:rPr>
+                  <a:t>  et </a:t>
+                </a:r>
+                <a14:m>
+                  <m:oMath xmlns:m="http://schemas.openxmlformats.org/officeDocument/2006/math">
+                    <m:r>
+                      <m:rPr>
+                        <m:sty m:val="p"/>
+                      </m:rPr>
+                      <a:rPr lang="fr-FR" i="1">
+                        <a:latin typeface="Cambria Math" panose="02040503050406030204" pitchFamily="18" charset="0"/>
+                        <a:sym typeface="Wingdings" panose="05000000000000000000" pitchFamily="2" charset="2"/>
+                      </a:rPr>
+                      <m:t>Te</m:t>
+                    </m:r>
+                    <m:r>
+                      <a:rPr lang="fr-FR" b="0" i="1" smtClean="0">
+                        <a:latin typeface="Cambria Math" panose="02040503050406030204" pitchFamily="18" charset="0"/>
+                        <a:sym typeface="Wingdings" panose="05000000000000000000" pitchFamily="2" charset="2"/>
+                      </a:rPr>
+                      <m:t> = 0.3</m:t>
+                    </m:r>
+                  </m:oMath>
+                </a14:m>
+                <a:endParaRPr lang="fr-FR" dirty="0">
+                  <a:sym typeface="Wingdings" panose="05000000000000000000" pitchFamily="2" charset="2"/>
+                </a:endParaRPr>
+              </a:p>
+              <a:p>
+                <a:endParaRPr lang="fr-FR" dirty="0">
+                  <a:sym typeface="Wingdings" panose="05000000000000000000" pitchFamily="2" charset="2"/>
+                </a:endParaRPr>
+              </a:p>
+              <a:p>
+                <a:endParaRPr lang="fr-FR" dirty="0">
+                  <a:sym typeface="Wingdings" panose="05000000000000000000" pitchFamily="2" charset="2"/>
+                </a:endParaRPr>
+              </a:p>
+            </p:txBody>
+          </p:sp>
+        </mc:Choice>
+        <mc:Fallback>
+          <p:sp>
+            <p:nvSpPr>
+              <p:cNvPr id="58" name="TextBox 57">
+                <a:extLst>
+                  <a:ext uri="{FF2B5EF4-FFF2-40B4-BE49-F238E27FC236}">
+                    <a16:creationId xmlns:a16="http://schemas.microsoft.com/office/drawing/2014/main" id="{0CEAB3DF-E113-A48A-4976-5362A80A08F7}"/>
+                  </a:ext>
+                </a:extLst>
+              </p:cNvPr>
+              <p:cNvSpPr txBox="1">
+                <a:spLocks noRot="1" noChangeAspect="1" noMove="1" noResize="1" noEditPoints="1" noAdjustHandles="1" noChangeArrowheads="1" noChangeShapeType="1" noTextEdit="1"/>
+              </p:cNvSpPr>
+              <p:nvPr/>
+            </p:nvSpPr>
+            <p:spPr>
+              <a:xfrm>
+                <a:off x="560860" y="1690688"/>
+                <a:ext cx="10651970" cy="2986459"/>
+              </a:xfrm>
+              <a:prstGeom prst="rect">
+                <a:avLst/>
+              </a:prstGeom>
+              <a:blipFill>
+                <a:blip r:embed="rId11"/>
+                <a:stretch>
+                  <a:fillRect l="-343" t="-1224"/>
+                </a:stretch>
+              </a:blipFill>
+            </p:spPr>
+            <p:txBody>
+              <a:bodyPr/>
+              <a:lstStyle/>
+              <a:p>
+                <a:r>
+                  <a:rPr lang="en-US">
+                    <a:noFill/>
+                  </a:rPr>
+                  <a:t> </a:t>
+                </a:r>
+              </a:p>
+            </p:txBody>
+          </p:sp>
+        </mc:Fallback>
+      </mc:AlternateContent>
+      <p:sp>
+        <p:nvSpPr>
+          <p:cNvPr id="59" name="TextBox 58">
+            <a:extLst>
+              <a:ext uri="{FF2B5EF4-FFF2-40B4-BE49-F238E27FC236}">
+                <a16:creationId xmlns:a16="http://schemas.microsoft.com/office/drawing/2014/main" id="{D1B8D06E-603C-C267-3757-24818DA12201}"/>
+              </a:ext>
+            </a:extLst>
+          </p:cNvPr>
+          <p:cNvSpPr txBox="1">
+            <a:spLocks noGrp="1" noRot="1" noMove="1" noResize="1" noEditPoints="1" noAdjustHandles="1" noChangeArrowheads="1" noChangeShapeType="1"/>
+          </p:cNvSpPr>
+          <p:nvPr/>
+        </p:nvSpPr>
+        <p:spPr>
+          <a:xfrm>
+            <a:off x="7498081" y="6396335"/>
+            <a:ext cx="771258" cy="307777"/>
+          </a:xfrm>
+          <a:prstGeom prst="rect">
+            <a:avLst/>
+          </a:prstGeom>
+          <a:noFill/>
+        </p:spPr>
+        <p:txBody>
+          <a:bodyPr wrap="square" rtlCol="0">
+            <a:spAutoFit/>
+          </a:bodyPr>
+          <a:lstStyle/>
+          <a:p>
+            <a:r>
+              <a:rPr lang="fr-FR" sz="1400" dirty="0"/>
+              <a:t>Te (cm)</a:t>
+            </a:r>
+            <a:endParaRPr lang="en-US" sz="1400" dirty="0"/>
+          </a:p>
+        </p:txBody>
+      </p:sp>
+      <p:sp>
+        <p:nvSpPr>
+          <p:cNvPr id="60" name="TextBox 59">
+            <a:extLst>
+              <a:ext uri="{FF2B5EF4-FFF2-40B4-BE49-F238E27FC236}">
+                <a16:creationId xmlns:a16="http://schemas.microsoft.com/office/drawing/2014/main" id="{377C65A6-DFDD-665B-F68B-741DFE066405}"/>
+              </a:ext>
+            </a:extLst>
+          </p:cNvPr>
+          <p:cNvSpPr txBox="1">
+            <a:spLocks noGrp="1" noRot="1" noMove="1" noResize="1" noEditPoints="1" noAdjustHandles="1" noChangeArrowheads="1" noChangeShapeType="1"/>
+          </p:cNvSpPr>
+          <p:nvPr/>
+        </p:nvSpPr>
+        <p:spPr>
+          <a:xfrm>
+            <a:off x="425608" y="6550223"/>
+            <a:ext cx="280846" cy="307777"/>
+          </a:xfrm>
+          <a:prstGeom prst="rect">
+            <a:avLst/>
+          </a:prstGeom>
+          <a:noFill/>
+        </p:spPr>
+        <p:txBody>
+          <a:bodyPr wrap="none" rtlCol="0">
+            <a:spAutoFit/>
+          </a:bodyPr>
+          <a:lstStyle/>
+          <a:p>
+            <a:r>
+              <a:rPr lang="fr-FR" sz="1400" dirty="0"/>
+              <a:t>1</a:t>
+            </a:r>
+            <a:endParaRPr lang="en-US" dirty="0"/>
+          </a:p>
+        </p:txBody>
+      </p:sp>
+      <p:sp>
+        <p:nvSpPr>
+          <p:cNvPr id="61" name="TextBox 60">
+            <a:extLst>
+              <a:ext uri="{FF2B5EF4-FFF2-40B4-BE49-F238E27FC236}">
+                <a16:creationId xmlns:a16="http://schemas.microsoft.com/office/drawing/2014/main" id="{88D5B6F5-F7F2-D061-02CE-DBF9E04F5741}"/>
+              </a:ext>
+            </a:extLst>
+          </p:cNvPr>
+          <p:cNvSpPr txBox="1">
+            <a:spLocks noGrp="1" noRot="1" noMove="1" noResize="1" noEditPoints="1" noAdjustHandles="1" noChangeArrowheads="1" noChangeShapeType="1"/>
+          </p:cNvSpPr>
+          <p:nvPr/>
+        </p:nvSpPr>
+        <p:spPr>
+          <a:xfrm>
+            <a:off x="6838695" y="6550223"/>
+            <a:ext cx="428322" cy="307777"/>
+          </a:xfrm>
+          <a:prstGeom prst="rect">
+            <a:avLst/>
+          </a:prstGeom>
+          <a:noFill/>
+        </p:spPr>
+        <p:txBody>
+          <a:bodyPr wrap="none" rtlCol="0">
+            <a:spAutoFit/>
+          </a:bodyPr>
+          <a:lstStyle/>
+          <a:p>
+            <a:r>
+              <a:rPr lang="fr-FR" sz="1400" dirty="0"/>
+              <a:t>0.2</a:t>
+            </a:r>
+            <a:endParaRPr lang="en-US" dirty="0"/>
+          </a:p>
+        </p:txBody>
+      </p:sp>
+      <p:sp>
+        <p:nvSpPr>
+          <p:cNvPr id="62" name="TextBox 61">
+            <a:extLst>
+              <a:ext uri="{FF2B5EF4-FFF2-40B4-BE49-F238E27FC236}">
+                <a16:creationId xmlns:a16="http://schemas.microsoft.com/office/drawing/2014/main" id="{7C2BD58C-6402-B763-16DB-A732584E4F56}"/>
+              </a:ext>
+            </a:extLst>
+          </p:cNvPr>
+          <p:cNvSpPr txBox="1">
+            <a:spLocks noGrp="1" noRot="1" noMove="1" noResize="1" noEditPoints="1" noAdjustHandles="1" noChangeArrowheads="1" noChangeShapeType="1"/>
+          </p:cNvSpPr>
+          <p:nvPr/>
+        </p:nvSpPr>
+        <p:spPr>
+          <a:xfrm>
+            <a:off x="3555159" y="6550223"/>
+            <a:ext cx="428322" cy="307777"/>
+          </a:xfrm>
+          <a:prstGeom prst="rect">
+            <a:avLst/>
+          </a:prstGeom>
+          <a:noFill/>
+        </p:spPr>
+        <p:txBody>
+          <a:bodyPr wrap="none" rtlCol="0">
+            <a:spAutoFit/>
+          </a:bodyPr>
+          <a:lstStyle/>
+          <a:p>
+            <a:r>
+              <a:rPr lang="fr-FR" sz="1400" dirty="0"/>
+              <a:t>0.6</a:t>
+            </a:r>
+            <a:endParaRPr lang="en-US" dirty="0"/>
+          </a:p>
+        </p:txBody>
+      </p:sp>
+      <p:pic>
+        <p:nvPicPr>
+          <p:cNvPr id="64" name="Picture 63">
+            <a:extLst>
+              <a:ext uri="{FF2B5EF4-FFF2-40B4-BE49-F238E27FC236}">
+                <a16:creationId xmlns:a16="http://schemas.microsoft.com/office/drawing/2014/main" id="{63B385C4-FDC5-27BD-D21F-1496ACB0F442}"/>
+              </a:ext>
+            </a:extLst>
+          </p:cNvPr>
+          <p:cNvPicPr>
+            <a:picLocks noChangeAspect="1"/>
+          </p:cNvPicPr>
+          <p:nvPr/>
+        </p:nvPicPr>
+        <p:blipFill>
+          <a:blip r:embed="rId12">
+            <a:extLst>
+              <a:ext uri="{28A0092B-C50C-407E-A947-70E740481C1C}">
+                <a14:useLocalDpi xmlns:a14="http://schemas.microsoft.com/office/drawing/2010/main" val="0"/>
+              </a:ext>
+            </a:extLst>
+          </a:blip>
+          <a:stretch>
+            <a:fillRect/>
+          </a:stretch>
+        </p:blipFill>
+        <p:spPr>
+          <a:xfrm>
+            <a:off x="8548852" y="4120909"/>
+            <a:ext cx="3239085" cy="2429314"/>
+          </a:xfrm>
+          <a:prstGeom prst="rect">
+            <a:avLst/>
+          </a:prstGeom>
+        </p:spPr>
+      </p:pic>
+    </p:spTree>
+    <p:extLst>
+      <p:ext uri="{BB962C8B-B14F-4D97-AF65-F5344CB8AC3E}">
+        <p14:creationId xmlns:p14="http://schemas.microsoft.com/office/powerpoint/2010/main" val="2856502644"/>
+      </p:ext>
+    </p:extLst>
+  </p:cSld>
+  <p:clrMapOvr>
+    <a:masterClrMapping/>
+  </p:clrMapOvr>
+</p:sld>
+</file>
+
+<file path=ppt/slides/slide17.xml><?xml version="1.0" encoding="utf-8"?>
+<p:sld xmlns:a="http://schemas.openxmlformats.org/drawingml/2006/main" xmlns:r="http://schemas.openxmlformats.org/officeDocument/2006/relationships" xmlns:p="http://schemas.openxmlformats.org/presentationml/2006/main">
+  <p:cSld>
+    <p:spTree>
+      <p:nvGrpSpPr>
+        <p:cNvPr id="1" name=""/>
+        <p:cNvGrpSpPr/>
+        <p:nvPr/>
+      </p:nvGrpSpPr>
+      <p:grpSpPr>
+        <a:xfrm>
+          <a:off x="0" y="0"/>
+          <a:ext cx="0" cy="0"/>
+          <a:chOff x="0" y="0"/>
+          <a:chExt cx="0" cy="0"/>
+        </a:xfrm>
+      </p:grpSpPr>
+      <p:sp>
+        <p:nvSpPr>
+          <p:cNvPr id="2" name="Title 1">
+            <a:extLst>
+              <a:ext uri="{FF2B5EF4-FFF2-40B4-BE49-F238E27FC236}">
+                <a16:creationId xmlns:a16="http://schemas.microsoft.com/office/drawing/2014/main" id="{65A98810-4DBB-A150-02D8-A72B03EB7ECC}"/>
+              </a:ext>
+            </a:extLst>
+          </p:cNvPr>
+          <p:cNvSpPr>
+            <a:spLocks noGrp="1"/>
+          </p:cNvSpPr>
+          <p:nvPr>
+            <p:ph type="title"/>
+          </p:nvPr>
+        </p:nvSpPr>
+        <p:spPr/>
+        <p:txBody>
+          <a:bodyPr/>
+          <a:lstStyle/>
+          <a:p>
+            <a:r>
+              <a:rPr lang="fr-FR" dirty="0"/>
+              <a:t>Validation - erreur expérimentale :</a:t>
+            </a:r>
+            <a:endParaRPr lang="en-US" dirty="0"/>
+          </a:p>
+        </p:txBody>
+      </p:sp>
+      <p:pic>
+        <p:nvPicPr>
+          <p:cNvPr id="5" name="Content Placeholder 4">
+            <a:extLst>
+              <a:ext uri="{FF2B5EF4-FFF2-40B4-BE49-F238E27FC236}">
+                <a16:creationId xmlns:a16="http://schemas.microsoft.com/office/drawing/2014/main" id="{EBB7CBB9-6184-B33E-4584-B7B75F691002}"/>
+              </a:ext>
+            </a:extLst>
+          </p:cNvPr>
+          <p:cNvPicPr>
+            <a:picLocks noGrp="1" noChangeAspect="1"/>
+          </p:cNvPicPr>
+          <p:nvPr>
+            <p:ph idx="1"/>
+          </p:nvPr>
+        </p:nvPicPr>
+        <p:blipFill>
+          <a:blip r:embed="rId2">
+            <a:extLst>
+              <a:ext uri="{28A0092B-C50C-407E-A947-70E740481C1C}">
+                <a14:useLocalDpi xmlns:a14="http://schemas.microsoft.com/office/drawing/2010/main" val="0"/>
+              </a:ext>
+            </a:extLst>
+          </a:blip>
+          <a:stretch>
+            <a:fillRect/>
+          </a:stretch>
+        </p:blipFill>
+        <p:spPr>
+          <a:xfrm>
+            <a:off x="8036455" y="1279180"/>
+            <a:ext cx="4060801" cy="3045601"/>
+          </a:xfrm>
+          <a:prstGeom prst="rect">
+            <a:avLst/>
+          </a:prstGeom>
+        </p:spPr>
+      </p:pic>
+      <p:pic>
+        <p:nvPicPr>
+          <p:cNvPr id="9" name="Picture 8">
+            <a:extLst>
+              <a:ext uri="{FF2B5EF4-FFF2-40B4-BE49-F238E27FC236}">
+                <a16:creationId xmlns:a16="http://schemas.microsoft.com/office/drawing/2014/main" id="{BD4F830D-AEB1-FC20-2BEA-EE909DD91100}"/>
+              </a:ext>
+            </a:extLst>
+          </p:cNvPr>
+          <p:cNvPicPr>
+            <a:picLocks noChangeAspect="1"/>
+          </p:cNvPicPr>
+          <p:nvPr/>
+        </p:nvPicPr>
+        <p:blipFill>
+          <a:blip r:embed="rId3">
+            <a:extLst>
+              <a:ext uri="{28A0092B-C50C-407E-A947-70E740481C1C}">
+                <a14:useLocalDpi xmlns:a14="http://schemas.microsoft.com/office/drawing/2010/main" val="0"/>
+              </a:ext>
+            </a:extLst>
+          </a:blip>
+          <a:stretch>
+            <a:fillRect/>
+          </a:stretch>
+        </p:blipFill>
+        <p:spPr>
+          <a:xfrm>
+            <a:off x="8399409" y="4324781"/>
+            <a:ext cx="3334892" cy="2858480"/>
+          </a:xfrm>
+          <a:prstGeom prst="rect">
+            <a:avLst/>
+          </a:prstGeom>
+        </p:spPr>
+      </p:pic>
+      <mc:AlternateContent xmlns:mc="http://schemas.openxmlformats.org/markup-compatibility/2006">
+        <mc:Choice xmlns:a14="http://schemas.microsoft.com/office/drawing/2010/main" Requires="a14">
+          <p:sp>
+            <p:nvSpPr>
+              <p:cNvPr id="10" name="TextBox 9">
+                <a:extLst>
+                  <a:ext uri="{FF2B5EF4-FFF2-40B4-BE49-F238E27FC236}">
+                    <a16:creationId xmlns:a16="http://schemas.microsoft.com/office/drawing/2014/main" id="{FB13BC59-1CF5-FBB2-63DD-9DDC99704668}"/>
+                  </a:ext>
+                </a:extLst>
+              </p:cNvPr>
+              <p:cNvSpPr txBox="1"/>
+              <p:nvPr/>
+            </p:nvSpPr>
+            <p:spPr>
+              <a:xfrm>
+                <a:off x="838200" y="1968560"/>
+                <a:ext cx="6614160" cy="5324919"/>
+              </a:xfrm>
+              <a:prstGeom prst="rect">
+                <a:avLst/>
+              </a:prstGeom>
+              <a:noFill/>
+            </p:spPr>
+            <p:txBody>
+              <a:bodyPr wrap="square" rtlCol="0">
+                <a:spAutoFit/>
+              </a:bodyPr>
+              <a:lstStyle/>
+              <a:p>
+                <a:r>
+                  <a:rPr lang="fr-FR" dirty="0"/>
+                  <a:t>Comparaison des champs de température pour </a:t>
+                </a:r>
+                <a:r>
+                  <a:rPr lang="fr-FR" dirty="0" err="1"/>
+                  <a:t>t</a:t>
+                </a:r>
+                <a:r>
+                  <a:rPr lang="fr-FR" baseline="-25000" dirty="0" err="1"/>
+                  <a:t>fin</a:t>
+                </a:r>
+                <a:r>
+                  <a:rPr lang="fr-FR" baseline="-25000" dirty="0"/>
+                  <a:t> </a:t>
+                </a:r>
+                <a:r>
+                  <a:rPr lang="fr-FR" dirty="0"/>
+                  <a:t>= 600s</a:t>
+                </a:r>
+              </a:p>
+              <a:p>
+                <a:endParaRPr lang="fr-FR" dirty="0"/>
+              </a:p>
+              <a:p>
+                <a:endParaRPr lang="fr-FR" dirty="0"/>
+              </a:p>
+              <a:p>
+                <a:endParaRPr lang="fr-FR" dirty="0"/>
+              </a:p>
+              <a:p>
+                <a:endParaRPr lang="fr-FR" dirty="0"/>
+              </a:p>
+              <a:p>
+                <a14:m>
+                  <m:oMathPara xmlns:m="http://schemas.openxmlformats.org/officeDocument/2006/math">
+                    <m:oMathParaPr>
+                      <m:jc m:val="centerGroup"/>
+                    </m:oMathParaPr>
+                    <m:oMath xmlns:m="http://schemas.openxmlformats.org/officeDocument/2006/math">
+                      <m:sSub>
+                        <m:sSubPr>
+                          <m:ctrlPr>
+                            <a:rPr lang="fr-FR" b="0" i="1" smtClean="0">
+                              <a:latin typeface="Cambria Math" panose="02040503050406030204" pitchFamily="18" charset="0"/>
+                            </a:rPr>
+                          </m:ctrlPr>
+                        </m:sSubPr>
+                        <m:e>
+                          <m:r>
+                            <a:rPr lang="fr-FR" b="0" i="1" smtClean="0">
+                              <a:latin typeface="Cambria Math" panose="02040503050406030204" pitchFamily="18" charset="0"/>
+                            </a:rPr>
+                            <m:t>𝐸</m:t>
+                          </m:r>
+                        </m:e>
+                        <m:sub>
+                          <m:sSub>
+                            <m:sSubPr>
+                              <m:ctrlPr>
+                                <a:rPr lang="fr-FR" b="0" i="1" smtClean="0">
+                                  <a:latin typeface="Cambria Math" panose="02040503050406030204" pitchFamily="18" charset="0"/>
+                                </a:rPr>
+                              </m:ctrlPr>
+                            </m:sSubPr>
+                            <m:e>
+                              <m:r>
+                                <a:rPr lang="fr-FR" b="0" i="1" smtClean="0">
+                                  <a:latin typeface="Cambria Math" panose="02040503050406030204" pitchFamily="18" charset="0"/>
+                                </a:rPr>
+                                <m:t>𝐿</m:t>
+                              </m:r>
+                            </m:e>
+                            <m:sub>
+                              <m:r>
+                                <a:rPr lang="fr-FR" b="0" i="1" smtClean="0">
+                                  <a:latin typeface="Cambria Math" panose="02040503050406030204" pitchFamily="18" charset="0"/>
+                                </a:rPr>
+                                <m:t>2</m:t>
+                              </m:r>
+                            </m:sub>
+                          </m:sSub>
+                        </m:sub>
+                      </m:sSub>
+                      <m:r>
+                        <a:rPr lang="fr-FR" b="0" i="1" smtClean="0">
+                          <a:latin typeface="Cambria Math" panose="02040503050406030204" pitchFamily="18" charset="0"/>
+                        </a:rPr>
+                        <m:t>=</m:t>
+                      </m:r>
+                      <m:rad>
+                        <m:radPr>
+                          <m:degHide m:val="on"/>
+                          <m:ctrlPr>
+                            <a:rPr lang="fr-FR" b="0" i="1" smtClean="0">
+                              <a:latin typeface="Cambria Math" panose="02040503050406030204" pitchFamily="18" charset="0"/>
+                            </a:rPr>
+                          </m:ctrlPr>
+                        </m:radPr>
+                        <m:deg/>
+                        <m:e>
+                          <m:f>
+                            <m:fPr>
+                              <m:ctrlPr>
+                                <a:rPr lang="fr-FR" i="1">
+                                  <a:latin typeface="Cambria Math" panose="02040503050406030204" pitchFamily="18" charset="0"/>
+                                </a:rPr>
+                              </m:ctrlPr>
+                            </m:fPr>
+                            <m:num>
+                              <m:r>
+                                <a:rPr lang="fr-FR" i="1">
+                                  <a:latin typeface="Cambria Math" panose="02040503050406030204" pitchFamily="18" charset="0"/>
+                                </a:rPr>
+                                <m:t>1</m:t>
+                              </m:r>
+                            </m:num>
+                            <m:den>
+                              <m:r>
+                                <m:rPr>
+                                  <m:sty m:val="p"/>
+                                </m:rPr>
+                                <a:rPr lang="fr-FR" i="1">
+                                  <a:latin typeface="Cambria Math" panose="02040503050406030204" pitchFamily="18" charset="0"/>
+                                </a:rPr>
+                                <m:t>N</m:t>
+                              </m:r>
+                            </m:den>
+                          </m:f>
+                          <m:nary>
+                            <m:naryPr>
+                              <m:chr m:val="∑"/>
+                              <m:ctrlPr>
+                                <a:rPr lang="fr-FR" i="1">
+                                  <a:latin typeface="Cambria Math" panose="02040503050406030204" pitchFamily="18" charset="0"/>
+                                </a:rPr>
+                              </m:ctrlPr>
+                            </m:naryPr>
+                            <m:sub>
+                              <m:r>
+                                <a:rPr lang="fr-FR" i="1">
+                                  <a:latin typeface="Cambria Math" panose="02040503050406030204" pitchFamily="18" charset="0"/>
+                                </a:rPr>
+                                <m:t>𝑖</m:t>
+                              </m:r>
+                              <m:r>
+                                <a:rPr lang="fr-FR" i="1">
+                                  <a:latin typeface="Cambria Math" panose="02040503050406030204" pitchFamily="18" charset="0"/>
+                                </a:rPr>
+                                <m:t>=</m:t>
+                              </m:r>
+                              <m:r>
+                                <a:rPr lang="fr-FR" i="1">
+                                  <a:latin typeface="Cambria Math" panose="02040503050406030204" pitchFamily="18" charset="0"/>
+                                </a:rPr>
+                                <m:t>1</m:t>
+                              </m:r>
+                            </m:sub>
+                            <m:sup>
+                              <m:r>
+                                <a:rPr lang="fr-FR" i="1">
+                                  <a:latin typeface="Cambria Math" panose="02040503050406030204" pitchFamily="18" charset="0"/>
+                                </a:rPr>
+                                <m:t>𝑁</m:t>
+                              </m:r>
+                            </m:sup>
+                            <m:e>
+                              <m:sSup>
+                                <m:sSupPr>
+                                  <m:ctrlPr>
+                                    <a:rPr lang="fr-FR" i="1">
+                                      <a:latin typeface="Cambria Math" panose="02040503050406030204" pitchFamily="18" charset="0"/>
+                                    </a:rPr>
+                                  </m:ctrlPr>
+                                </m:sSupPr>
+                                <m:e>
+                                  <m:d>
+                                    <m:dPr>
+                                      <m:ctrlPr>
+                                        <a:rPr lang="fr-FR" i="1">
+                                          <a:latin typeface="Cambria Math" panose="02040503050406030204" pitchFamily="18" charset="0"/>
+                                        </a:rPr>
+                                      </m:ctrlPr>
+                                    </m:dPr>
+                                    <m:e>
+                                      <m:sSub>
+                                        <m:sSubPr>
+                                          <m:ctrlPr>
+                                            <a:rPr lang="fr-FR" i="1">
+                                              <a:latin typeface="Cambria Math" panose="02040503050406030204" pitchFamily="18" charset="0"/>
+                                            </a:rPr>
+                                          </m:ctrlPr>
+                                        </m:sSubPr>
+                                        <m:e>
+                                          <m:r>
+                                            <a:rPr lang="fr-FR" i="1">
+                                              <a:latin typeface="Cambria Math" panose="02040503050406030204" pitchFamily="18" charset="0"/>
+                                            </a:rPr>
+                                            <m:t>𝑦</m:t>
+                                          </m:r>
+                                        </m:e>
+                                        <m:sub>
+                                          <m:r>
+                                            <a:rPr lang="fr-FR" i="1">
+                                              <a:latin typeface="Cambria Math" panose="02040503050406030204" pitchFamily="18" charset="0"/>
+                                            </a:rPr>
+                                            <m:t>𝑒</m:t>
+                                          </m:r>
+                                          <m:r>
+                                            <a:rPr lang="fr-FR" i="1">
+                                              <a:latin typeface="Cambria Math" panose="02040503050406030204" pitchFamily="18" charset="0"/>
+                                            </a:rPr>
+                                            <m:t>,</m:t>
+                                          </m:r>
+                                          <m:r>
+                                            <a:rPr lang="fr-FR" i="1">
+                                              <a:latin typeface="Cambria Math" panose="02040503050406030204" pitchFamily="18" charset="0"/>
+                                            </a:rPr>
+                                            <m:t>𝑖</m:t>
+                                          </m:r>
+                                        </m:sub>
+                                      </m:sSub>
+                                      <m:r>
+                                        <a:rPr lang="fr-FR" i="1">
+                                          <a:latin typeface="Cambria Math" panose="02040503050406030204" pitchFamily="18" charset="0"/>
+                                        </a:rPr>
+                                        <m:t>−</m:t>
+                                      </m:r>
+                                      <m:r>
+                                        <a:rPr lang="fr-FR" i="1">
+                                          <a:latin typeface="Cambria Math" panose="02040503050406030204" pitchFamily="18" charset="0"/>
+                                        </a:rPr>
+                                        <m:t>𝑦𝑚</m:t>
+                                      </m:r>
+                                      <m:r>
+                                        <a:rPr lang="fr-FR" i="1">
+                                          <a:latin typeface="Cambria Math" panose="02040503050406030204" pitchFamily="18" charset="0"/>
+                                        </a:rPr>
+                                        <m:t>,</m:t>
+                                      </m:r>
+                                      <m:r>
+                                        <a:rPr lang="fr-FR" i="1">
+                                          <a:latin typeface="Cambria Math" panose="02040503050406030204" pitchFamily="18" charset="0"/>
+                                        </a:rPr>
+                                        <m:t>𝑖</m:t>
+                                      </m:r>
+                                    </m:e>
+                                  </m:d>
+                                </m:e>
+                                <m:sup>
+                                  <m:r>
+                                    <a:rPr lang="fr-FR" i="1">
+                                      <a:latin typeface="Cambria Math" panose="02040503050406030204" pitchFamily="18" charset="0"/>
+                                    </a:rPr>
+                                    <m:t>2</m:t>
+                                  </m:r>
+                                </m:sup>
+                              </m:sSup>
+                            </m:e>
+                          </m:nary>
+                        </m:e>
+                      </m:rad>
+                    </m:oMath>
+                  </m:oMathPara>
+                </a14:m>
+                <a:endParaRPr lang="fr-FR" dirty="0"/>
+              </a:p>
+              <a:p>
+                <a:endParaRPr lang="fr-FR" dirty="0"/>
+              </a:p>
+              <a:p>
+                <a:endParaRPr lang="fr-FR" dirty="0"/>
+              </a:p>
+              <a:p>
+                <a:endParaRPr lang="fr-FR" dirty="0"/>
+              </a:p>
+              <a:p>
+                <a:endParaRPr lang="fr-FR" dirty="0"/>
+              </a:p>
+              <a:p>
+                <a:endParaRPr lang="fr-FR" dirty="0"/>
+              </a:p>
+              <a:p>
+                <a:endParaRPr lang="fr-FR" dirty="0"/>
+              </a:p>
+              <a:p>
+                <a:endParaRPr lang="fr-FR" dirty="0"/>
+              </a:p>
+              <a:p>
+                <a:endParaRPr lang="fr-FR" dirty="0"/>
+              </a:p>
+              <a:p>
+                <a:endParaRPr lang="fr-FR" dirty="0"/>
+              </a:p>
+              <a:p>
+                <a:endParaRPr lang="en-US" dirty="0"/>
+              </a:p>
+            </p:txBody>
+          </p:sp>
+        </mc:Choice>
+        <mc:Fallback>
+          <p:sp>
+            <p:nvSpPr>
+              <p:cNvPr id="10" name="TextBox 9">
+                <a:extLst>
+                  <a:ext uri="{FF2B5EF4-FFF2-40B4-BE49-F238E27FC236}">
+                    <a16:creationId xmlns:a16="http://schemas.microsoft.com/office/drawing/2014/main" id="{FB13BC59-1CF5-FBB2-63DD-9DDC99704668}"/>
+                  </a:ext>
+                </a:extLst>
+              </p:cNvPr>
+              <p:cNvSpPr txBox="1">
+                <a:spLocks noRot="1" noChangeAspect="1" noMove="1" noResize="1" noEditPoints="1" noAdjustHandles="1" noChangeArrowheads="1" noChangeShapeType="1" noTextEdit="1"/>
+              </p:cNvSpPr>
+              <p:nvPr/>
+            </p:nvSpPr>
+            <p:spPr>
+              <a:xfrm>
+                <a:off x="838200" y="1968560"/>
+                <a:ext cx="6614160" cy="5324919"/>
+              </a:xfrm>
+              <a:prstGeom prst="rect">
+                <a:avLst/>
+              </a:prstGeom>
+              <a:blipFill>
+                <a:blip r:embed="rId4"/>
+                <a:stretch>
+                  <a:fillRect l="-829" t="-573"/>
+                </a:stretch>
+              </a:blipFill>
+            </p:spPr>
+            <p:txBody>
+              <a:bodyPr/>
+              <a:lstStyle/>
+              <a:p>
+                <a:r>
+                  <a:rPr lang="en-US">
+                    <a:noFill/>
+                  </a:rPr>
+                  <a:t> </a:t>
+                </a:r>
+              </a:p>
+            </p:txBody>
+          </p:sp>
+        </mc:Fallback>
+      </mc:AlternateContent>
+    </p:spTree>
+    <p:extLst>
+      <p:ext uri="{BB962C8B-B14F-4D97-AF65-F5344CB8AC3E}">
+        <p14:creationId xmlns:p14="http://schemas.microsoft.com/office/powerpoint/2010/main" val="4162514676"/>
+      </p:ext>
+    </p:extLst>
+  </p:cSld>
+  <p:clrMapOvr>
+    <a:masterClrMapping/>
+  </p:clrMapOvr>
+</p:sld>
+</file>
+
+<file path=ppt/slides/slide18.xml><?xml version="1.0" encoding="utf-8"?>
+<p:sld xmlns:a="http://schemas.openxmlformats.org/drawingml/2006/main" xmlns:r="http://schemas.openxmlformats.org/officeDocument/2006/relationships" xmlns:p="http://schemas.openxmlformats.org/presentationml/2006/main">
+  <p:cSld>
+    <p:spTree>
+      <p:nvGrpSpPr>
+        <p:cNvPr id="1" name=""/>
+        <p:cNvGrpSpPr/>
+        <p:nvPr/>
+      </p:nvGrpSpPr>
+      <p:grpSpPr>
+        <a:xfrm>
+          <a:off x="0" y="0"/>
+          <a:ext cx="0" cy="0"/>
+          <a:chOff x="0" y="0"/>
+          <a:chExt cx="0" cy="0"/>
+        </a:xfrm>
+      </p:grpSpPr>
+      <p:sp>
+        <p:nvSpPr>
+          <p:cNvPr id="2" name="Title 1">
+            <a:extLst>
+              <a:ext uri="{FF2B5EF4-FFF2-40B4-BE49-F238E27FC236}">
+                <a16:creationId xmlns:a16="http://schemas.microsoft.com/office/drawing/2014/main" id="{F3C6439F-29E7-5985-9D89-DC076CF9176A}"/>
+              </a:ext>
+            </a:extLst>
+          </p:cNvPr>
+          <p:cNvSpPr>
+            <a:spLocks noGrp="1"/>
+          </p:cNvSpPr>
+          <p:nvPr>
+            <p:ph type="title"/>
+          </p:nvPr>
+        </p:nvSpPr>
+        <p:spPr/>
+        <p:txBody>
+          <a:bodyPr/>
+          <a:lstStyle/>
+          <a:p>
+            <a:r>
+              <a:rPr lang="fr-FR" dirty="0"/>
+              <a:t>Validation – erreur expérimentale</a:t>
+            </a:r>
+            <a:endParaRPr lang="en-US" dirty="0"/>
+          </a:p>
+        </p:txBody>
+      </p:sp>
+      <mc:AlternateContent xmlns:mc="http://schemas.openxmlformats.org/markup-compatibility/2006">
+        <mc:Choice xmlns:a14="http://schemas.microsoft.com/office/drawing/2010/main" Requires="a14">
+          <p:sp>
+            <p:nvSpPr>
+              <p:cNvPr id="3" name="Content Placeholder 2">
+                <a:extLst>
+                  <a:ext uri="{FF2B5EF4-FFF2-40B4-BE49-F238E27FC236}">
+                    <a16:creationId xmlns:a16="http://schemas.microsoft.com/office/drawing/2014/main" id="{D0659431-7107-A76B-E208-96EAABE1F908}"/>
+                  </a:ext>
+                </a:extLst>
+              </p:cNvPr>
+              <p:cNvSpPr>
+                <a:spLocks noGrp="1"/>
+              </p:cNvSpPr>
+              <p:nvPr>
+                <p:ph idx="1"/>
+              </p:nvPr>
+            </p:nvSpPr>
+            <p:spPr>
+              <a:xfrm>
+                <a:off x="838200" y="1825625"/>
+                <a:ext cx="10515600" cy="3134995"/>
+              </a:xfrm>
+            </p:spPr>
+            <p:txBody>
+              <a:bodyPr>
+                <a:normAutofit/>
+              </a:bodyPr>
+              <a:lstStyle/>
+              <a:p>
+                <a:r>
+                  <a:rPr lang="fr-FR" dirty="0"/>
+                  <a:t>Erreur épistémique d’un thermocouple classique : ±1.5°C*</a:t>
+                </a:r>
+              </a:p>
+              <a:p>
+                <a:pPr marL="0" indent="0" algn="ctr">
+                  <a:buNone/>
+                </a:pPr>
+                <a14:m>
+                  <m:oMath xmlns:m="http://schemas.openxmlformats.org/officeDocument/2006/math">
+                    <m:r>
+                      <m:rPr>
+                        <m:sty m:val="p"/>
+                      </m:rPr>
+                      <a:rPr lang="fr-FR" b="0" i="1" smtClean="0">
+                        <a:latin typeface="Cambria Math" panose="02040503050406030204" pitchFamily="18" charset="0"/>
+                      </a:rPr>
+                      <m:t>σ</m:t>
+                    </m:r>
+                    <m:r>
+                      <m:rPr>
+                        <m:sty m:val="p"/>
+                      </m:rPr>
+                      <a:rPr lang="fr-FR" b="0" i="1" baseline="-25000" smtClean="0">
+                        <a:latin typeface="Cambria Math" panose="02040503050406030204" pitchFamily="18" charset="0"/>
+                      </a:rPr>
+                      <m:t>tc</m:t>
+                    </m:r>
+                    <m:r>
+                      <a:rPr lang="fr-FR" b="0" i="1" smtClean="0">
+                        <a:latin typeface="Cambria Math" panose="02040503050406030204" pitchFamily="18" charset="0"/>
+                      </a:rPr>
+                      <m:t>= </m:t>
+                    </m:r>
+                    <m:f>
+                      <m:fPr>
+                        <m:ctrlPr>
+                          <a:rPr lang="fr-FR" b="0" i="1" smtClean="0">
+                            <a:latin typeface="Cambria Math" panose="02040503050406030204" pitchFamily="18" charset="0"/>
+                          </a:rPr>
+                        </m:ctrlPr>
+                      </m:fPr>
+                      <m:num>
+                        <m:r>
+                          <a:rPr lang="fr-FR" b="0" i="1" smtClean="0">
+                            <a:latin typeface="Cambria Math" panose="02040503050406030204" pitchFamily="18" charset="0"/>
+                          </a:rPr>
+                          <m:t>1</m:t>
+                        </m:r>
+                        <m:r>
+                          <a:rPr lang="fr-FR" b="0" i="1" smtClean="0">
+                            <a:latin typeface="Cambria Math" panose="02040503050406030204" pitchFamily="18" charset="0"/>
+                          </a:rPr>
+                          <m:t>.</m:t>
+                        </m:r>
+                        <m:r>
+                          <a:rPr lang="fr-FR" b="0" i="1" smtClean="0">
+                            <a:latin typeface="Cambria Math" panose="02040503050406030204" pitchFamily="18" charset="0"/>
+                          </a:rPr>
+                          <m:t>5</m:t>
+                        </m:r>
+                      </m:num>
+                      <m:den>
+                        <m:rad>
+                          <m:radPr>
+                            <m:degHide m:val="on"/>
+                            <m:ctrlPr>
+                              <a:rPr lang="fr-FR" b="0" i="1" smtClean="0">
+                                <a:latin typeface="Cambria Math" panose="02040503050406030204" pitchFamily="18" charset="0"/>
+                              </a:rPr>
+                            </m:ctrlPr>
+                          </m:radPr>
+                          <m:deg/>
+                          <m:e>
+                            <m:r>
+                              <a:rPr lang="fr-FR" b="0" i="1" smtClean="0">
+                                <a:latin typeface="Cambria Math" panose="02040503050406030204" pitchFamily="18" charset="0"/>
+                              </a:rPr>
+                              <m:t>3</m:t>
+                            </m:r>
+                          </m:e>
+                        </m:rad>
+                      </m:den>
+                    </m:f>
+                    <m:r>
+                      <a:rPr lang="fr-FR" b="0" i="1" smtClean="0">
+                        <a:latin typeface="Cambria Math" panose="02040503050406030204" pitchFamily="18" charset="0"/>
+                      </a:rPr>
+                      <m:t> = </m:t>
+                    </m:r>
+                    <m:r>
+                      <a:rPr lang="fr-FR" b="0" i="1" smtClean="0">
+                        <a:latin typeface="Cambria Math" panose="02040503050406030204" pitchFamily="18" charset="0"/>
+                      </a:rPr>
+                      <m:t>0</m:t>
+                    </m:r>
+                    <m:r>
+                      <a:rPr lang="fr-FR" b="0" i="1" smtClean="0">
+                        <a:latin typeface="Cambria Math" panose="02040503050406030204" pitchFamily="18" charset="0"/>
+                      </a:rPr>
+                      <m:t>.</m:t>
+                    </m:r>
+                    <m:r>
+                      <a:rPr lang="fr-FR" b="0" i="1" smtClean="0">
+                        <a:latin typeface="Cambria Math" panose="02040503050406030204" pitchFamily="18" charset="0"/>
+                      </a:rPr>
+                      <m:t>87</m:t>
+                    </m:r>
+                    <m:r>
+                      <a:rPr lang="fr-FR" b="0" i="1" smtClean="0">
+                        <a:latin typeface="Cambria Math" panose="02040503050406030204" pitchFamily="18" charset="0"/>
+                      </a:rPr>
+                      <m:t> °</m:t>
+                    </m:r>
+                    <m:r>
+                      <m:rPr>
+                        <m:sty m:val="p"/>
+                      </m:rPr>
+                      <a:rPr lang="fr-FR" b="0" i="1" smtClean="0">
+                        <a:latin typeface="Cambria Math" panose="02040503050406030204" pitchFamily="18" charset="0"/>
+                      </a:rPr>
+                      <m:t>C</m:t>
+                    </m:r>
+                  </m:oMath>
+                </a14:m>
+                <a:r>
+                  <a:rPr lang="fr-FR" dirty="0"/>
+                  <a:t> </a:t>
+                </a:r>
+              </a:p>
+              <a:p>
+                <a:pPr marL="0" indent="0">
+                  <a:buNone/>
+                </a:pPr>
+                <a:r>
+                  <a:rPr lang="fr-FR" dirty="0"/>
+                  <a:t> car distribution normale dans cet intervalle </a:t>
+                </a:r>
+              </a:p>
+              <a:p>
+                <a:pPr marL="0" indent="0">
+                  <a:buNone/>
+                </a:pPr>
+                <a:endParaRPr lang="fr-FR" dirty="0"/>
+              </a:p>
+              <a:p>
+                <a:pPr marL="0" indent="0">
+                  <a:buNone/>
+                </a:pPr>
+                <a14:m>
+                  <m:oMathPara xmlns:m="http://schemas.openxmlformats.org/officeDocument/2006/math">
+                    <m:oMathParaPr>
+                      <m:jc m:val="centerGroup"/>
+                    </m:oMathParaPr>
+                    <m:oMath xmlns:m="http://schemas.openxmlformats.org/officeDocument/2006/math">
+                      <m:r>
+                        <m:rPr>
+                          <m:sty m:val="p"/>
+                        </m:rPr>
+                        <a:rPr lang="fr-FR" b="0" i="1" smtClean="0">
+                          <a:latin typeface="Cambria Math" panose="02040503050406030204" pitchFamily="18" charset="0"/>
+                        </a:rPr>
+                        <m:t>u</m:t>
+                      </m:r>
+                      <m:r>
+                        <m:rPr>
+                          <m:sty m:val="p"/>
+                        </m:rPr>
+                        <a:rPr lang="fr-FR" b="0" i="1" baseline="-25000" smtClean="0">
+                          <a:latin typeface="Cambria Math" panose="02040503050406030204" pitchFamily="18" charset="0"/>
+                        </a:rPr>
+                        <m:t>D</m:t>
+                      </m:r>
+                      <m:r>
+                        <a:rPr lang="fr-FR" b="0" i="1" smtClean="0">
+                          <a:latin typeface="Cambria Math" panose="02040503050406030204" pitchFamily="18" charset="0"/>
+                        </a:rPr>
+                        <m:t> = </m:t>
+                      </m:r>
+                      <m:rad>
+                        <m:radPr>
+                          <m:degHide m:val="on"/>
+                          <m:ctrlPr>
+                            <a:rPr lang="fr-FR" b="0" i="1" smtClean="0">
+                              <a:latin typeface="Cambria Math" panose="02040503050406030204" pitchFamily="18" charset="0"/>
+                            </a:rPr>
+                          </m:ctrlPr>
+                        </m:radPr>
+                        <m:deg/>
+                        <m:e>
+                          <m:r>
+                            <m:rPr>
+                              <m:sty m:val="p"/>
+                            </m:rPr>
+                            <a:rPr lang="fr-FR" b="0" i="1" smtClean="0">
+                              <a:latin typeface="Cambria Math" panose="02040503050406030204" pitchFamily="18" charset="0"/>
+                            </a:rPr>
+                            <m:t>σ</m:t>
+                          </m:r>
+                          <m:r>
+                            <m:rPr>
+                              <m:sty m:val="p"/>
+                            </m:rPr>
+                            <a:rPr lang="fr-FR" b="0" i="1" baseline="-25000" smtClean="0">
+                              <a:latin typeface="Cambria Math" panose="02040503050406030204" pitchFamily="18" charset="0"/>
+                            </a:rPr>
+                            <m:t>tc</m:t>
+                          </m:r>
+                          <m:r>
+                            <a:rPr lang="fr-FR" b="0" i="1" baseline="30000" smtClean="0">
+                              <a:latin typeface="Cambria Math" panose="02040503050406030204" pitchFamily="18" charset="0"/>
+                            </a:rPr>
+                            <m:t>2</m:t>
+                          </m:r>
+                          <m:r>
+                            <a:rPr lang="fr-FR" b="0" i="1" smtClean="0">
+                              <a:latin typeface="Cambria Math" panose="02040503050406030204" pitchFamily="18" charset="0"/>
+                            </a:rPr>
+                            <m:t> + </m:t>
+                          </m:r>
+                          <m:r>
+                            <a:rPr lang="fr-FR" b="0" i="1" smtClean="0">
+                              <a:latin typeface="Cambria Math" panose="02040503050406030204" pitchFamily="18" charset="0"/>
+                            </a:rPr>
+                            <m:t>02</m:t>
+                          </m:r>
+                          <m:r>
+                            <a:rPr lang="fr-FR" b="0" i="1" smtClean="0">
+                              <a:latin typeface="Cambria Math" panose="02040503050406030204" pitchFamily="18" charset="0"/>
+                            </a:rPr>
+                            <m:t> </m:t>
+                          </m:r>
+                        </m:e>
+                      </m:rad>
+                      <m:r>
+                        <a:rPr lang="fr-FR" b="0" i="1" smtClean="0">
+                          <a:latin typeface="Cambria Math" panose="02040503050406030204" pitchFamily="18" charset="0"/>
+                        </a:rPr>
+                        <m:t>=</m:t>
+                      </m:r>
+                      <m:r>
+                        <m:rPr>
+                          <m:sty m:val="p"/>
+                        </m:rPr>
+                        <a:rPr lang="fr-FR" i="1">
+                          <a:latin typeface="Cambria Math" panose="02040503050406030204" pitchFamily="18" charset="0"/>
+                        </a:rPr>
+                        <m:t>σ</m:t>
+                      </m:r>
+                      <m:r>
+                        <m:rPr>
+                          <m:sty m:val="p"/>
+                        </m:rPr>
+                        <a:rPr lang="fr-FR" i="1" baseline="-25000">
+                          <a:latin typeface="Cambria Math" panose="02040503050406030204" pitchFamily="18" charset="0"/>
+                        </a:rPr>
+                        <m:t>tc</m:t>
+                      </m:r>
+                      <m:r>
+                        <a:rPr lang="fr-FR" b="0" i="1" smtClean="0">
+                          <a:latin typeface="Cambria Math" panose="02040503050406030204" pitchFamily="18" charset="0"/>
+                        </a:rPr>
+                        <m:t>=</m:t>
+                      </m:r>
+                      <m:r>
+                        <a:rPr lang="fr-FR" b="0" i="1" smtClean="0">
+                          <a:latin typeface="Cambria Math" panose="02040503050406030204" pitchFamily="18" charset="0"/>
+                        </a:rPr>
+                        <m:t>0</m:t>
+                      </m:r>
+                      <m:r>
+                        <a:rPr lang="fr-FR" b="0" i="1" smtClean="0">
+                          <a:latin typeface="Cambria Math" panose="02040503050406030204" pitchFamily="18" charset="0"/>
+                        </a:rPr>
+                        <m:t>.</m:t>
+                      </m:r>
+                      <m:r>
+                        <a:rPr lang="fr-FR" b="0" i="1" smtClean="0">
+                          <a:latin typeface="Cambria Math" panose="02040503050406030204" pitchFamily="18" charset="0"/>
+                        </a:rPr>
+                        <m:t>87</m:t>
+                      </m:r>
+                      <m:r>
+                        <a:rPr lang="fr-FR" b="0" i="1" smtClean="0">
+                          <a:latin typeface="Cambria Math" panose="02040503050406030204" pitchFamily="18" charset="0"/>
+                        </a:rPr>
+                        <m:t>°</m:t>
+                      </m:r>
+                      <m:r>
+                        <m:rPr>
+                          <m:sty m:val="p"/>
+                        </m:rPr>
+                        <a:rPr lang="fr-FR" b="0" i="1" smtClean="0">
+                          <a:latin typeface="Cambria Math" panose="02040503050406030204" pitchFamily="18" charset="0"/>
+                        </a:rPr>
+                        <m:t>C</m:t>
+                      </m:r>
+                    </m:oMath>
+                  </m:oMathPara>
+                </a14:m>
+                <a:endParaRPr lang="fr-FR" dirty="0"/>
+              </a:p>
+              <a:p>
+                <a:pPr marL="0" indent="0">
+                  <a:buNone/>
+                </a:pPr>
+                <a:endParaRPr lang="fr-FR" dirty="0"/>
+              </a:p>
+            </p:txBody>
+          </p:sp>
+        </mc:Choice>
+        <mc:Fallback>
+          <p:sp>
+            <p:nvSpPr>
+              <p:cNvPr id="3" name="Content Placeholder 2">
+                <a:extLst>
+                  <a:ext uri="{FF2B5EF4-FFF2-40B4-BE49-F238E27FC236}">
+                    <a16:creationId xmlns:a16="http://schemas.microsoft.com/office/drawing/2014/main" id="{D0659431-7107-A76B-E208-96EAABE1F908}"/>
+                  </a:ext>
+                </a:extLst>
+              </p:cNvPr>
+              <p:cNvSpPr>
+                <a:spLocks noGrp="1" noRot="1" noChangeAspect="1" noMove="1" noResize="1" noEditPoints="1" noAdjustHandles="1" noChangeArrowheads="1" noChangeShapeType="1" noTextEdit="1"/>
+              </p:cNvSpPr>
+              <p:nvPr>
+                <p:ph idx="1"/>
+              </p:nvPr>
+            </p:nvSpPr>
+            <p:spPr>
+              <a:xfrm>
+                <a:off x="838200" y="1825625"/>
+                <a:ext cx="10515600" cy="3134995"/>
+              </a:xfrm>
+              <a:blipFill>
+                <a:blip r:embed="rId2"/>
+                <a:stretch>
+                  <a:fillRect l="-1217" t="-3301"/>
+                </a:stretch>
+              </a:blipFill>
+            </p:spPr>
+            <p:txBody>
+              <a:bodyPr/>
+              <a:lstStyle/>
+              <a:p>
+                <a:r>
+                  <a:rPr lang="en-US">
+                    <a:noFill/>
+                  </a:rPr>
+                  <a:t> </a:t>
+                </a:r>
+              </a:p>
+            </p:txBody>
+          </p:sp>
+        </mc:Fallback>
+      </mc:AlternateContent>
+      <p:sp>
+        <p:nvSpPr>
+          <p:cNvPr id="4" name="TextBox 3">
+            <a:extLst>
+              <a:ext uri="{FF2B5EF4-FFF2-40B4-BE49-F238E27FC236}">
+                <a16:creationId xmlns:a16="http://schemas.microsoft.com/office/drawing/2014/main" id="{2CF3D44E-FDBD-44F9-D894-E056CB9F80B0}"/>
+              </a:ext>
+            </a:extLst>
+          </p:cNvPr>
+          <p:cNvSpPr txBox="1"/>
+          <p:nvPr/>
+        </p:nvSpPr>
+        <p:spPr>
+          <a:xfrm>
+            <a:off x="838200" y="6126480"/>
+            <a:ext cx="11231880" cy="369332"/>
+          </a:xfrm>
+          <a:prstGeom prst="rect">
+            <a:avLst/>
+          </a:prstGeom>
+          <a:noFill/>
+        </p:spPr>
+        <p:txBody>
+          <a:bodyPr wrap="square" rtlCol="0">
+            <a:spAutoFit/>
+          </a:bodyPr>
+          <a:lstStyle/>
+          <a:p>
+            <a:r>
+              <a:rPr lang="fr-FR" dirty="0"/>
+              <a:t>*Source : tcsa.fr/thermocouple/type-k-thermocouple.html</a:t>
+            </a:r>
+            <a:endParaRPr lang="en-US" dirty="0"/>
+          </a:p>
+        </p:txBody>
+      </p:sp>
+    </p:spTree>
+    <p:extLst>
+      <p:ext uri="{BB962C8B-B14F-4D97-AF65-F5344CB8AC3E}">
+        <p14:creationId xmlns:p14="http://schemas.microsoft.com/office/powerpoint/2010/main" val="153986674"/>
+      </p:ext>
+    </p:extLst>
+  </p:cSld>
+  <p:clrMapOvr>
+    <a:masterClrMapping/>
+  </p:clrMapOvr>
+</p:sld>
+</file>
+
+<file path=ppt/slides/slide19.xml><?xml version="1.0" encoding="utf-8"?>
+<p:sld xmlns:a="http://schemas.openxmlformats.org/drawingml/2006/main" xmlns:r="http://schemas.openxmlformats.org/officeDocument/2006/relationships" xmlns:p="http://schemas.openxmlformats.org/presentationml/2006/main">
+  <p:cSld>
+    <p:spTree>
+      <p:nvGrpSpPr>
+        <p:cNvPr id="1" name=""/>
+        <p:cNvGrpSpPr/>
+        <p:nvPr/>
+      </p:nvGrpSpPr>
+      <p:grpSpPr>
+        <a:xfrm>
+          <a:off x="0" y="0"/>
+          <a:ext cx="0" cy="0"/>
+          <a:chOff x="0" y="0"/>
+          <a:chExt cx="0" cy="0"/>
+        </a:xfrm>
+      </p:grpSpPr>
+      <p:sp>
+        <p:nvSpPr>
+          <p:cNvPr id="2" name="Title 1">
+            <a:extLst>
+              <a:ext uri="{FF2B5EF4-FFF2-40B4-BE49-F238E27FC236}">
+                <a16:creationId xmlns:a16="http://schemas.microsoft.com/office/drawing/2014/main" id="{54C6E061-A18D-9828-5D8A-6DB04AFF154E}"/>
+              </a:ext>
+            </a:extLst>
+          </p:cNvPr>
+          <p:cNvSpPr>
+            <a:spLocks noGrp="1"/>
+          </p:cNvSpPr>
+          <p:nvPr>
+            <p:ph type="title"/>
+          </p:nvPr>
+        </p:nvSpPr>
+        <p:spPr/>
+        <p:txBody>
+          <a:bodyPr/>
+          <a:lstStyle/>
+          <a:p>
+            <a:r>
+              <a:rPr lang="fr-FR" dirty="0"/>
+              <a:t>Validation – erreur numérique</a:t>
+            </a:r>
+            <a:endParaRPr lang="en-US" dirty="0"/>
+          </a:p>
+        </p:txBody>
+      </p:sp>
+      <p:sp>
+        <p:nvSpPr>
+          <p:cNvPr id="3" name="Content Placeholder 2">
+            <a:extLst>
+              <a:ext uri="{FF2B5EF4-FFF2-40B4-BE49-F238E27FC236}">
+                <a16:creationId xmlns:a16="http://schemas.microsoft.com/office/drawing/2014/main" id="{A130E620-26B7-5449-95D5-A34047E15DFF}"/>
+              </a:ext>
+            </a:extLst>
+          </p:cNvPr>
+          <p:cNvSpPr>
+            <a:spLocks noGrp="1"/>
+          </p:cNvSpPr>
+          <p:nvPr>
+            <p:ph idx="1"/>
+          </p:nvPr>
+        </p:nvSpPr>
+        <p:spPr/>
+        <p:txBody>
+          <a:bodyPr/>
+          <a:lstStyle/>
+          <a:p>
+            <a:r>
+              <a:rPr lang="fr-FR" dirty="0"/>
+              <a:t>En fonction de la valeur de GCI</a:t>
+            </a:r>
+            <a:endParaRPr lang="en-US" dirty="0"/>
+          </a:p>
+        </p:txBody>
+      </p:sp>
+    </p:spTree>
+    <p:extLst>
+      <p:ext uri="{BB962C8B-B14F-4D97-AF65-F5344CB8AC3E}">
+        <p14:creationId xmlns:p14="http://schemas.microsoft.com/office/powerpoint/2010/main" val="211247040"/>
+      </p:ext>
+    </p:extLst>
+  </p:cSld>
+  <p:clrMapOvr>
+    <a:masterClrMapping/>
+  </p:clrMapOvr>
+</p:sld>
+</file>
+
 <file path=ppt/slides/slide2.xml><?xml version="1.0" encoding="utf-8"?>
 <p:sld xmlns:a="http://schemas.openxmlformats.org/drawingml/2006/main" xmlns:r="http://schemas.openxmlformats.org/officeDocument/2006/relationships" xmlns:p="http://schemas.openxmlformats.org/presentationml/2006/main">
   <p:cSld>
@@ -6373,6 +8942,184 @@
 </p:sld>
 </file>
 
+<file path=ppt/slides/slide20.xml><?xml version="1.0" encoding="utf-8"?>
+<p:sld xmlns:a="http://schemas.openxmlformats.org/drawingml/2006/main" xmlns:r="http://schemas.openxmlformats.org/officeDocument/2006/relationships" xmlns:p="http://schemas.openxmlformats.org/presentationml/2006/main">
+  <p:cSld>
+    <p:spTree>
+      <p:nvGrpSpPr>
+        <p:cNvPr id="1" name=""/>
+        <p:cNvGrpSpPr/>
+        <p:nvPr/>
+      </p:nvGrpSpPr>
+      <p:grpSpPr>
+        <a:xfrm>
+          <a:off x="0" y="0"/>
+          <a:ext cx="0" cy="0"/>
+          <a:chOff x="0" y="0"/>
+          <a:chExt cx="0" cy="0"/>
+        </a:xfrm>
+      </p:grpSpPr>
+      <p:sp>
+        <p:nvSpPr>
+          <p:cNvPr id="2" name="Title 1">
+            <a:extLst>
+              <a:ext uri="{FF2B5EF4-FFF2-40B4-BE49-F238E27FC236}">
+                <a16:creationId xmlns:a16="http://schemas.microsoft.com/office/drawing/2014/main" id="{7171FAF8-D45E-B846-39C4-A2BDDFE609C9}"/>
+              </a:ext>
+            </a:extLst>
+          </p:cNvPr>
+          <p:cNvSpPr>
+            <a:spLocks noGrp="1"/>
+          </p:cNvSpPr>
+          <p:nvPr>
+            <p:ph type="title"/>
+          </p:nvPr>
+        </p:nvSpPr>
+        <p:spPr/>
+        <p:txBody>
+          <a:bodyPr/>
+          <a:lstStyle/>
+          <a:p>
+            <a:r>
+              <a:rPr lang="fr-FR" dirty="0"/>
+              <a:t>Amélioration possible</a:t>
+            </a:r>
+            <a:endParaRPr lang="en-US" dirty="0"/>
+          </a:p>
+        </p:txBody>
+      </p:sp>
+      <mc:AlternateContent xmlns:mc="http://schemas.openxmlformats.org/markup-compatibility/2006">
+        <mc:Choice xmlns:a14="http://schemas.microsoft.com/office/drawing/2010/main" Requires="a14">
+          <p:sp>
+            <p:nvSpPr>
+              <p:cNvPr id="3" name="Content Placeholder 2">
+                <a:extLst>
+                  <a:ext uri="{FF2B5EF4-FFF2-40B4-BE49-F238E27FC236}">
+                    <a16:creationId xmlns:a16="http://schemas.microsoft.com/office/drawing/2014/main" id="{DF9282C8-F6FB-A0A2-B31D-09362B254F0F}"/>
+                  </a:ext>
+                </a:extLst>
+              </p:cNvPr>
+              <p:cNvSpPr>
+                <a:spLocks noGrp="1"/>
+              </p:cNvSpPr>
+              <p:nvPr>
+                <p:ph idx="1"/>
+              </p:nvPr>
+            </p:nvSpPr>
+            <p:spPr/>
+            <p:txBody>
+              <a:bodyPr/>
+              <a:lstStyle/>
+              <a:p>
+                <a:r>
+                  <a:rPr lang="fr-FR" dirty="0"/>
+                  <a:t>Rajouter une erreur d’expérimentation à partir de la littérature d’une expérience similaire</a:t>
+                </a:r>
+                <a:r>
+                  <a:rPr lang="fr-FR" dirty="0">
+                    <a:sym typeface="Wingdings" panose="05000000000000000000" pitchFamily="2" charset="2"/>
+                  </a:rPr>
+                  <a:t> estimation plus concrète de </a:t>
+                </a:r>
+                <a14:m>
+                  <m:oMath xmlns:m="http://schemas.openxmlformats.org/officeDocument/2006/math">
+                    <m:r>
+                      <m:rPr>
+                        <m:sty m:val="p"/>
+                      </m:rPr>
+                      <a:rPr lang="fr-FR" i="1">
+                        <a:latin typeface="Cambria Math" panose="02040503050406030204" pitchFamily="18" charset="0"/>
+                      </a:rPr>
+                      <m:t>u</m:t>
+                    </m:r>
+                    <m:r>
+                      <m:rPr>
+                        <m:sty m:val="p"/>
+                      </m:rPr>
+                      <a:rPr lang="fr-FR" i="1" baseline="-25000">
+                        <a:latin typeface="Cambria Math" panose="02040503050406030204" pitchFamily="18" charset="0"/>
+                      </a:rPr>
+                      <m:t>D</m:t>
+                    </m:r>
+                    <m:r>
+                      <a:rPr lang="fr-FR" i="1">
+                        <a:latin typeface="Cambria Math" panose="02040503050406030204" pitchFamily="18" charset="0"/>
+                      </a:rPr>
+                      <m:t> </m:t>
+                    </m:r>
+                  </m:oMath>
+                </a14:m>
+                <a:endParaRPr lang="fr-FR" dirty="0"/>
+              </a:p>
+              <a:p>
+                <a:r>
+                  <a:rPr lang="fr-FR" dirty="0"/>
+                  <a:t>Affiner le pas de temps et d’espace pour la simulation SolidWorks</a:t>
+                </a:r>
+                <a:r>
+                  <a:rPr lang="fr-FR" dirty="0">
+                    <a:sym typeface="Wingdings" panose="05000000000000000000" pitchFamily="2" charset="2"/>
+                  </a:rPr>
+                  <a:t> précision accrue sur l’erreur de simulation</a:t>
+                </a:r>
+                <a:endParaRPr lang="en-US" dirty="0"/>
+              </a:p>
+            </p:txBody>
+          </p:sp>
+        </mc:Choice>
+        <mc:Fallback>
+          <p:sp>
+            <p:nvSpPr>
+              <p:cNvPr id="3" name="Content Placeholder 2">
+                <a:extLst>
+                  <a:ext uri="{FF2B5EF4-FFF2-40B4-BE49-F238E27FC236}">
+                    <a16:creationId xmlns:a16="http://schemas.microsoft.com/office/drawing/2014/main" id="{DF9282C8-F6FB-A0A2-B31D-09362B254F0F}"/>
+                  </a:ext>
+                </a:extLst>
+              </p:cNvPr>
+              <p:cNvSpPr>
+                <a:spLocks noGrp="1" noRot="1" noChangeAspect="1" noMove="1" noResize="1" noEditPoints="1" noAdjustHandles="1" noChangeArrowheads="1" noChangeShapeType="1" noTextEdit="1"/>
+              </p:cNvSpPr>
+              <p:nvPr>
+                <p:ph idx="1"/>
+              </p:nvPr>
+            </p:nvSpPr>
+            <p:spPr>
+              <a:blipFill>
+                <a:blip r:embed="rId2"/>
+                <a:stretch>
+                  <a:fillRect l="-1043" t="-2381"/>
+                </a:stretch>
+              </a:blipFill>
+            </p:spPr>
+            <p:txBody>
+              <a:bodyPr/>
+              <a:lstStyle/>
+              <a:p>
+                <a:r>
+                  <a:rPr lang="en-US">
+                    <a:noFill/>
+                  </a:rPr>
+                  <a:t> </a:t>
+                </a:r>
+              </a:p>
+            </p:txBody>
+          </p:sp>
+        </mc:Fallback>
+      </mc:AlternateContent>
+    </p:spTree>
+    <p:extLst>
+      <p:ext uri="{BB962C8B-B14F-4D97-AF65-F5344CB8AC3E}">
+        <p14:creationId xmlns:p14="http://schemas.microsoft.com/office/powerpoint/2010/main" val="3426608694"/>
+      </p:ext>
+    </p:extLst>
+  </p:cSld>
+  <p:clrMapOvr>
+    <a:masterClrMapping/>
+  </p:clrMapOvr>
+</p:sld>
+</file>
+
 <file path=ppt/slides/slide3.xml><?xml version="1.0" encoding="utf-8"?>
 <p:sld xmlns:a="http://schemas.openxmlformats.org/drawingml/2006/main" xmlns:r="http://schemas.openxmlformats.org/officeDocument/2006/relationships" xmlns:p="http://schemas.openxmlformats.org/presentationml/2006/main">
   <p:cSld>
@@ -6423,8 +9170,8 @@
           </a:p>
         </p:txBody>
       </p:sp>
-      <mc:AlternateContent xmlns:mc="http://schemas.openxmlformats.org/markup-compatibility/2006">
-        <mc:Choice xmlns:a14="http://schemas.microsoft.com/office/drawing/2010/main" Requires="a14">
+      <mc:AlternateContent xmlns:mc="http://schemas.openxmlformats.org/markup-compatibility/2006" xmlns:a14="http://schemas.microsoft.com/office/drawing/2010/main">
+        <mc:Choice Requires="a14">
           <p:sp>
             <p:nvSpPr>
               <p:cNvPr id="3" name="Espace réservé du contenu 2">
@@ -7346,7 +10093,7 @@
             </p:txBody>
           </p:sp>
         </mc:Choice>
-        <mc:Fallback>
+        <mc:Fallback xmlns="">
           <p:sp>
             <p:nvSpPr>
               <p:cNvPr id="3" name="Espace réservé du contenu 2">
@@ -7536,8 +10283,8 @@
           </a:p>
         </p:txBody>
       </p:sp>
-      <mc:AlternateContent xmlns:mc="http://schemas.openxmlformats.org/markup-compatibility/2006">
-        <mc:Choice xmlns:a14="http://schemas.microsoft.com/office/drawing/2010/main" Requires="a14">
+      <mc:AlternateContent xmlns:mc="http://schemas.openxmlformats.org/markup-compatibility/2006" xmlns:a14="http://schemas.microsoft.com/office/drawing/2010/main">
+        <mc:Choice Requires="a14">
           <p:sp>
             <p:nvSpPr>
               <p:cNvPr id="3" name="Espace réservé du contenu 2">
@@ -8131,7 +10878,13 @@
                         <a:rPr lang="fr-CA" b="0" i="1" smtClean="0">
                           <a:latin typeface="Cambria Math" panose="02040503050406030204" pitchFamily="18" charset="0"/>
                         </a:rPr>
-                        <m:t>=0</m:t>
+                        <m:t>=</m:t>
+                      </m:r>
+                      <m:r>
+                        <a:rPr lang="fr-CA" b="0" i="1" smtClean="0">
+                          <a:latin typeface="Cambria Math" panose="02040503050406030204" pitchFamily="18" charset="0"/>
+                        </a:rPr>
+                        <m:t>0</m:t>
                       </m:r>
                     </m:oMath>
                   </m:oMathPara>
@@ -8855,7 +11608,7 @@
             </p:txBody>
           </p:sp>
         </mc:Choice>
-        <mc:Fallback>
+        <mc:Fallback xmlns="">
           <p:sp>
             <p:nvSpPr>
               <p:cNvPr id="3" name="Espace réservé du contenu 2">
@@ -8954,8 +11707,8 @@
           </a:p>
         </p:txBody>
       </p:sp>
-      <mc:AlternateContent xmlns:mc="http://schemas.openxmlformats.org/markup-compatibility/2006">
-        <mc:Choice xmlns:a14="http://schemas.microsoft.com/office/drawing/2010/main" Requires="a14">
+      <mc:AlternateContent xmlns:mc="http://schemas.openxmlformats.org/markup-compatibility/2006" xmlns:a14="http://schemas.microsoft.com/office/drawing/2010/main">
+        <mc:Choice Requires="a14">
           <p:sp>
             <p:nvSpPr>
               <p:cNvPr id="6" name="ZoneTexte 5">
@@ -9065,7 +11818,7 @@
             </p:txBody>
           </p:sp>
         </mc:Choice>
-        <mc:Fallback>
+        <mc:Fallback xmlns="">
           <p:sp>
             <p:nvSpPr>
               <p:cNvPr id="6" name="ZoneTexte 5">
@@ -9203,8 +11956,8 @@
           </a:p>
         </p:txBody>
       </p:sp>
-      <mc:AlternateContent xmlns:mc="http://schemas.openxmlformats.org/markup-compatibility/2006">
-        <mc:Choice xmlns:a14="http://schemas.microsoft.com/office/drawing/2010/main" Requires="a14">
+      <mc:AlternateContent xmlns:mc="http://schemas.openxmlformats.org/markup-compatibility/2006" xmlns:a14="http://schemas.microsoft.com/office/drawing/2010/main">
+        <mc:Choice Requires="a14">
           <p:sp>
             <p:nvSpPr>
               <p:cNvPr id="3" name="Espace réservé du contenu 2">
@@ -9609,7 +12362,13 @@
                               <a:rPr lang="fr-FR" b="0" i="1" smtClean="0">
                                 <a:latin typeface="Cambria Math" panose="02040503050406030204" pitchFamily="18" charset="0"/>
                               </a:rPr>
-                              <m:t>+1</m:t>
+                              <m:t>+</m:t>
+                            </m:r>
+                            <m:r>
+                              <a:rPr lang="fr-FR" b="0" i="1" smtClean="0">
+                                <a:latin typeface="Cambria Math" panose="02040503050406030204" pitchFamily="18" charset="0"/>
+                              </a:rPr>
+                              <m:t>1</m:t>
                             </m:r>
                             <m:r>
                               <a:rPr lang="fr-FR" i="1">
@@ -9666,7 +12425,13 @@
                               <a:rPr lang="fr-FR" b="0" i="1" smtClean="0">
                                 <a:latin typeface="Cambria Math" panose="02040503050406030204" pitchFamily="18" charset="0"/>
                               </a:rPr>
-                              <m:t>−1</m:t>
+                              <m:t>−</m:t>
+                            </m:r>
+                            <m:r>
+                              <a:rPr lang="fr-FR" b="0" i="1" smtClean="0">
+                                <a:latin typeface="Cambria Math" panose="02040503050406030204" pitchFamily="18" charset="0"/>
+                              </a:rPr>
+                              <m:t>1</m:t>
                             </m:r>
                             <m:r>
                               <a:rPr lang="fr-FR" i="1">
@@ -10314,7 +13079,19 @@
                                 <a:rPr lang="fr-FR" sz="2400" i="1">
                                   <a:latin typeface="Cambria Math" panose="02040503050406030204" pitchFamily="18" charset="0"/>
                                 </a:rPr>
-                                <m:t>+1,</m:t>
+                                <m:t>+</m:t>
+                              </m:r>
+                              <m:r>
+                                <a:rPr lang="fr-FR" sz="2400" i="1">
+                                  <a:latin typeface="Cambria Math" panose="02040503050406030204" pitchFamily="18" charset="0"/>
+                                </a:rPr>
+                                <m:t>1</m:t>
+                              </m:r>
+                              <m:r>
+                                <a:rPr lang="fr-FR" sz="2400" i="1">
+                                  <a:latin typeface="Cambria Math" panose="02040503050406030204" pitchFamily="18" charset="0"/>
+                                </a:rPr>
+                                <m:t>,</m:t>
                               </m:r>
                               <m:r>
                                 <a:rPr lang="fr-FR" sz="2400" i="1">
@@ -10422,7 +13199,19 @@
                                 <a:rPr lang="fr-FR" sz="2400" i="1">
                                   <a:latin typeface="Cambria Math" panose="02040503050406030204" pitchFamily="18" charset="0"/>
                                 </a:rPr>
-                                <m:t>−1,</m:t>
+                                <m:t>−</m:t>
+                              </m:r>
+                              <m:r>
+                                <a:rPr lang="fr-FR" sz="2400" i="1">
+                                  <a:latin typeface="Cambria Math" panose="02040503050406030204" pitchFamily="18" charset="0"/>
+                                </a:rPr>
+                                <m:t>1</m:t>
+                              </m:r>
+                              <m:r>
+                                <a:rPr lang="fr-FR" sz="2400" i="1">
+                                  <a:latin typeface="Cambria Math" panose="02040503050406030204" pitchFamily="18" charset="0"/>
+                                </a:rPr>
+                                <m:t>,</m:t>
                               </m:r>
                               <m:r>
                                 <a:rPr lang="fr-FR" sz="2400" i="1">
@@ -10555,7 +13344,19 @@
                                 <a:rPr lang="fr-FR" sz="2400" i="1">
                                   <a:latin typeface="Cambria Math" panose="02040503050406030204" pitchFamily="18" charset="0"/>
                                 </a:rPr>
-                                <m:t>+1,</m:t>
+                                <m:t>+</m:t>
+                              </m:r>
+                              <m:r>
+                                <a:rPr lang="fr-FR" sz="2400" i="1">
+                                  <a:latin typeface="Cambria Math" panose="02040503050406030204" pitchFamily="18" charset="0"/>
+                                </a:rPr>
+                                <m:t>1</m:t>
+                              </m:r>
+                              <m:r>
+                                <a:rPr lang="fr-FR" sz="2400" i="1">
+                                  <a:latin typeface="Cambria Math" panose="02040503050406030204" pitchFamily="18" charset="0"/>
+                                </a:rPr>
+                                <m:t>,</m:t>
                               </m:r>
                               <m:r>
                                 <a:rPr lang="fr-FR" sz="2400" i="1">
@@ -10606,7 +13407,19 @@
                                 <a:rPr lang="fr-FR" sz="2400" i="1">
                                   <a:latin typeface="Cambria Math" panose="02040503050406030204" pitchFamily="18" charset="0"/>
                                 </a:rPr>
-                                <m:t>−1,</m:t>
+                                <m:t>−</m:t>
+                              </m:r>
+                              <m:r>
+                                <a:rPr lang="fr-FR" sz="2400" i="1">
+                                  <a:latin typeface="Cambria Math" panose="02040503050406030204" pitchFamily="18" charset="0"/>
+                                </a:rPr>
+                                <m:t>1</m:t>
+                              </m:r>
+                              <m:r>
+                                <a:rPr lang="fr-FR" sz="2400" i="1">
+                                  <a:latin typeface="Cambria Math" panose="02040503050406030204" pitchFamily="18" charset="0"/>
+                                </a:rPr>
+                                <m:t>,</m:t>
                               </m:r>
                               <m:r>
                                 <a:rPr lang="fr-FR" sz="2400" i="1">
@@ -10703,7 +13516,13 @@
                                 <a:rPr lang="fr-FR" sz="2400" i="1">
                                   <a:latin typeface="Cambria Math" panose="02040503050406030204" pitchFamily="18" charset="0"/>
                                 </a:rPr>
-                                <m:t>+1</m:t>
+                                <m:t>+</m:t>
+                              </m:r>
+                              <m:r>
+                                <a:rPr lang="fr-FR" sz="2400" i="1">
+                                  <a:latin typeface="Cambria Math" panose="02040503050406030204" pitchFamily="18" charset="0"/>
+                                </a:rPr>
+                                <m:t>1</m:t>
                               </m:r>
                             </m:sub>
                             <m:sup>
@@ -10817,7 +13636,13 @@
                                 <a:rPr lang="fr-FR" sz="2400" i="1">
                                   <a:latin typeface="Cambria Math" panose="02040503050406030204" pitchFamily="18" charset="0"/>
                                 </a:rPr>
-                                <m:t>−1</m:t>
+                                <m:t>−</m:t>
+                              </m:r>
+                              <m:r>
+                                <a:rPr lang="fr-FR" sz="2400" i="1">
+                                  <a:latin typeface="Cambria Math" panose="02040503050406030204" pitchFamily="18" charset="0"/>
+                                </a:rPr>
+                                <m:t>1</m:t>
                               </m:r>
                             </m:sub>
                             <m:sup>
@@ -10903,7 +13728,7 @@
             </p:txBody>
           </p:sp>
         </mc:Choice>
-        <mc:Fallback>
+        <mc:Fallback xmlns="">
           <p:sp>
             <p:nvSpPr>
               <p:cNvPr id="3" name="Espace réservé du contenu 2">
@@ -10947,8 +13772,8 @@
           </p:sp>
         </mc:Fallback>
       </mc:AlternateContent>
-      <mc:AlternateContent xmlns:mc="http://schemas.openxmlformats.org/markup-compatibility/2006">
-        <mc:Choice xmlns:a14="http://schemas.microsoft.com/office/drawing/2010/main" Requires="a14">
+      <mc:AlternateContent xmlns:mc="http://schemas.openxmlformats.org/markup-compatibility/2006" xmlns:a14="http://schemas.microsoft.com/office/drawing/2010/main">
+        <mc:Choice Requires="a14">
           <p:sp>
             <p:nvSpPr>
               <p:cNvPr id="5" name="ZoneTexte 4">
@@ -11163,7 +13988,21 @@
                                 <a:latin typeface="Cambria Math" panose="02040503050406030204" pitchFamily="18" charset="0"/>
                                 <a:ea typeface="Cambria Math" panose="02040503050406030204" pitchFamily="18" charset="0"/>
                               </a:rPr>
-                              <m:t>+1,</m:t>
+                              <m:t>+</m:t>
+                            </m:r>
+                            <m:r>
+                              <a:rPr lang="fr-FR" sz="2600" i="1">
+                                <a:latin typeface="Cambria Math" panose="02040503050406030204" pitchFamily="18" charset="0"/>
+                                <a:ea typeface="Cambria Math" panose="02040503050406030204" pitchFamily="18" charset="0"/>
+                              </a:rPr>
+                              <m:t>1</m:t>
+                            </m:r>
+                            <m:r>
+                              <a:rPr lang="fr-FR" sz="2600" i="1">
+                                <a:latin typeface="Cambria Math" panose="02040503050406030204" pitchFamily="18" charset="0"/>
+                                <a:ea typeface="Cambria Math" panose="02040503050406030204" pitchFamily="18" charset="0"/>
+                              </a:rPr>
+                              <m:t>,</m:t>
                             </m:r>
                             <m:r>
                               <a:rPr lang="fr-FR" sz="2600" i="1">
@@ -11286,7 +14125,21 @@
                                 <a:latin typeface="Cambria Math" panose="02040503050406030204" pitchFamily="18" charset="0"/>
                                 <a:ea typeface="Cambria Math" panose="02040503050406030204" pitchFamily="18" charset="0"/>
                               </a:rPr>
-                              <m:t>−1,</m:t>
+                              <m:t>−</m:t>
+                            </m:r>
+                            <m:r>
+                              <a:rPr lang="fr-FR" sz="2600" i="1">
+                                <a:latin typeface="Cambria Math" panose="02040503050406030204" pitchFamily="18" charset="0"/>
+                                <a:ea typeface="Cambria Math" panose="02040503050406030204" pitchFamily="18" charset="0"/>
+                              </a:rPr>
+                              <m:t>1</m:t>
+                            </m:r>
+                            <m:r>
+                              <a:rPr lang="fr-FR" sz="2600" i="1">
+                                <a:latin typeface="Cambria Math" panose="02040503050406030204" pitchFamily="18" charset="0"/>
+                                <a:ea typeface="Cambria Math" panose="02040503050406030204" pitchFamily="18" charset="0"/>
+                              </a:rPr>
+                              <m:t>,</m:t>
                             </m:r>
                             <m:r>
                               <a:rPr lang="fr-FR" sz="2600" i="1">
@@ -11555,7 +14408,13 @@
                               <a:rPr lang="fr-FR" sz="2600" i="1">
                                 <a:latin typeface="Cambria Math" panose="02040503050406030204" pitchFamily="18" charset="0"/>
                               </a:rPr>
-                              <m:t>+1</m:t>
+                              <m:t>+</m:t>
+                            </m:r>
+                            <m:r>
+                              <a:rPr lang="fr-FR" sz="2600" i="1">
+                                <a:latin typeface="Cambria Math" panose="02040503050406030204" pitchFamily="18" charset="0"/>
+                              </a:rPr>
+                              <m:t>1</m:t>
                             </m:r>
                           </m:sub>
                           <m:sup>
@@ -11669,7 +14528,13 @@
                               <a:rPr lang="fr-FR" sz="2600" i="1">
                                 <a:latin typeface="Cambria Math" panose="02040503050406030204" pitchFamily="18" charset="0"/>
                               </a:rPr>
-                              <m:t>−1</m:t>
+                              <m:t>−</m:t>
+                            </m:r>
+                            <m:r>
+                              <a:rPr lang="fr-FR" sz="2600" i="1">
+                                <a:latin typeface="Cambria Math" panose="02040503050406030204" pitchFamily="18" charset="0"/>
+                              </a:rPr>
+                              <m:t>1</m:t>
                             </m:r>
                           </m:sub>
                           <m:sup>
@@ -11746,7 +14611,7 @@
             </p:txBody>
           </p:sp>
         </mc:Choice>
-        <mc:Fallback>
+        <mc:Fallback xmlns="">
           <p:sp>
             <p:nvSpPr>
               <p:cNvPr id="5" name="ZoneTexte 4">
@@ -11934,8 +14799,8 @@
           </a:prstGeom>
         </p:spPr>
       </p:pic>
-      <mc:AlternateContent xmlns:mc="http://schemas.openxmlformats.org/markup-compatibility/2006">
-        <mc:Choice xmlns:a14="http://schemas.microsoft.com/office/drawing/2010/main" Requires="a14">
+      <mc:AlternateContent xmlns:mc="http://schemas.openxmlformats.org/markup-compatibility/2006" xmlns:a14="http://schemas.microsoft.com/office/drawing/2010/main">
+        <mc:Choice Requires="a14">
           <p:sp>
             <p:nvSpPr>
               <p:cNvPr id="6" name="ZoneTexte 5">
@@ -12026,7 +14891,16 @@
                         </a:solidFill>
                         <a:latin typeface="Cambria Math" panose="02040503050406030204" pitchFamily="18" charset="0"/>
                       </a:rPr>
-                      <m:t>=0</m:t>
+                      <m:t>=</m:t>
+                    </m:r>
+                    <m:r>
+                      <a:rPr lang="fr-CA" b="0" i="1" smtClean="0">
+                        <a:solidFill>
+                          <a:schemeClr val="accent2"/>
+                        </a:solidFill>
+                        <a:latin typeface="Cambria Math" panose="02040503050406030204" pitchFamily="18" charset="0"/>
+                      </a:rPr>
+                      <m:t>0</m:t>
                     </m:r>
                   </m:oMath>
                 </a14:m>
@@ -12139,7 +15013,7 @@
                       <m:f>
                         <m:fPr>
                           <m:ctrlPr>
-                            <a:rPr lang="fr-CA" b="0" i="0" smtClean="0">
+                            <a:rPr lang="fr-CA" b="0" i="1" smtClean="0">
                               <a:solidFill>
                                 <a:schemeClr val="accent2"/>
                               </a:solidFill>
@@ -12236,7 +15110,16 @@
                               </a:solidFill>
                               <a:latin typeface="Cambria Math" panose="02040503050406030204" pitchFamily="18" charset="0"/>
                             </a:rPr>
-                            <m:t>+2</m:t>
+                            <m:t>+</m:t>
+                          </m:r>
+                          <m:r>
+                            <a:rPr lang="fr-CA" b="0" i="1" smtClean="0">
+                              <a:solidFill>
+                                <a:schemeClr val="accent2"/>
+                              </a:solidFill>
+                              <a:latin typeface="Cambria Math" panose="02040503050406030204" pitchFamily="18" charset="0"/>
+                            </a:rPr>
+                            <m:t>2</m:t>
                           </m:r>
                         </m:sub>
                         <m:sup>
@@ -12355,7 +15238,16 @@
                               </a:solidFill>
                               <a:latin typeface="Cambria Math" panose="02040503050406030204" pitchFamily="18" charset="0"/>
                             </a:rPr>
-                            <m:t>+1</m:t>
+                            <m:t>+</m:t>
+                          </m:r>
+                          <m:r>
+                            <a:rPr lang="fr-CA" b="0" i="1" smtClean="0">
+                              <a:solidFill>
+                                <a:schemeClr val="accent2"/>
+                              </a:solidFill>
+                              <a:latin typeface="Cambria Math" panose="02040503050406030204" pitchFamily="18" charset="0"/>
+                            </a:rPr>
+                            <m:t>1</m:t>
                           </m:r>
                         </m:sub>
                         <m:sup>
@@ -12382,7 +15274,7 @@
             </p:txBody>
           </p:sp>
         </mc:Choice>
-        <mc:Fallback>
+        <mc:Fallback xmlns="">
           <p:sp>
             <p:nvSpPr>
               <p:cNvPr id="6" name="ZoneTexte 5">
@@ -12427,8 +15319,8 @@
           </p:sp>
         </mc:Fallback>
       </mc:AlternateContent>
-      <mc:AlternateContent xmlns:mc="http://schemas.openxmlformats.org/markup-compatibility/2006">
-        <mc:Choice xmlns:a14="http://schemas.microsoft.com/office/drawing/2010/main" Requires="a14">
+      <mc:AlternateContent xmlns:mc="http://schemas.openxmlformats.org/markup-compatibility/2006" xmlns:a14="http://schemas.microsoft.com/office/drawing/2010/main">
+        <mc:Choice Requires="a14">
           <p:sp>
             <p:nvSpPr>
               <p:cNvPr id="7" name="ZoneTexte 6">
@@ -12519,7 +15411,16 @@
                         </a:solidFill>
                         <a:latin typeface="Cambria Math" panose="02040503050406030204" pitchFamily="18" charset="0"/>
                       </a:rPr>
-                      <m:t>=0</m:t>
+                      <m:t>=</m:t>
+                    </m:r>
+                    <m:r>
+                      <a:rPr lang="fr-CA" b="0" i="1" smtClean="0">
+                        <a:solidFill>
+                          <a:srgbClr val="FFBF00"/>
+                        </a:solidFill>
+                        <a:latin typeface="Cambria Math" panose="02040503050406030204" pitchFamily="18" charset="0"/>
+                      </a:rPr>
+                      <m:t>0</m:t>
                     </m:r>
                   </m:oMath>
                 </a14:m>
@@ -12648,7 +15549,16 @@
                               </a:solidFill>
                               <a:latin typeface="Cambria Math" panose="02040503050406030204" pitchFamily="18" charset="0"/>
                             </a:rPr>
-                            <m:t>−1</m:t>
+                            <m:t>−</m:t>
+                          </m:r>
+                          <m:r>
+                            <a:rPr lang="fr-CA" b="0" i="0" smtClean="0">
+                              <a:solidFill>
+                                <a:srgbClr val="FFBF00"/>
+                              </a:solidFill>
+                              <a:latin typeface="Cambria Math" panose="02040503050406030204" pitchFamily="18" charset="0"/>
+                            </a:rPr>
+                            <m:t>1</m:t>
                           </m:r>
                         </m:num>
                         <m:den>
@@ -12720,7 +15630,16 @@
                               </a:solidFill>
                               <a:latin typeface="Cambria Math" panose="02040503050406030204" pitchFamily="18" charset="0"/>
                             </a:rPr>
-                            <m:t>+2</m:t>
+                            <m:t>+</m:t>
+                          </m:r>
+                          <m:r>
+                            <a:rPr lang="fr-CA" b="0" i="1" smtClean="0">
+                              <a:solidFill>
+                                <a:srgbClr val="FFBF00"/>
+                              </a:solidFill>
+                              <a:latin typeface="Cambria Math" panose="02040503050406030204" pitchFamily="18" charset="0"/>
+                            </a:rPr>
+                            <m:t>2</m:t>
                           </m:r>
                         </m:sub>
                         <m:sup>
@@ -12839,7 +15758,16 @@
                               </a:solidFill>
                               <a:latin typeface="Cambria Math" panose="02040503050406030204" pitchFamily="18" charset="0"/>
                             </a:rPr>
-                            <m:t>+1</m:t>
+                            <m:t>+</m:t>
+                          </m:r>
+                          <m:r>
+                            <a:rPr lang="fr-CA" b="0" i="1" smtClean="0">
+                              <a:solidFill>
+                                <a:srgbClr val="FFBF00"/>
+                              </a:solidFill>
+                              <a:latin typeface="Cambria Math" panose="02040503050406030204" pitchFamily="18" charset="0"/>
+                            </a:rPr>
+                            <m:t>1</m:t>
                           </m:r>
                         </m:sub>
                         <m:sup>
@@ -12866,7 +15794,7 @@
             </p:txBody>
           </p:sp>
         </mc:Choice>
-        <mc:Fallback>
+        <mc:Fallback xmlns="">
           <p:sp>
             <p:nvSpPr>
               <p:cNvPr id="7" name="ZoneTexte 6">
@@ -12911,8 +15839,8 @@
           </p:sp>
         </mc:Fallback>
       </mc:AlternateContent>
-      <mc:AlternateContent xmlns:mc="http://schemas.openxmlformats.org/markup-compatibility/2006">
-        <mc:Choice xmlns:a14="http://schemas.microsoft.com/office/drawing/2010/main" Requires="a14">
+      <mc:AlternateContent xmlns:mc="http://schemas.openxmlformats.org/markup-compatibility/2006" xmlns:a14="http://schemas.microsoft.com/office/drawing/2010/main">
+        <mc:Choice Requires="a14">
           <p:sp>
             <p:nvSpPr>
               <p:cNvPr id="8" name="ZoneTexte 7">
@@ -13361,21 +16289,12 @@
                         </a:solidFill>
                         <a:latin typeface="Cambria Math" panose="02040503050406030204" pitchFamily="18" charset="0"/>
                       </a:rPr>
-                      <m:t>=</m:t>
-                    </m:r>
-                    <m:r>
-                      <a:rPr lang="fr-CA" b="0" i="0" smtClean="0">
-                        <a:solidFill>
-                          <a:srgbClr val="5B9BD5"/>
-                        </a:solidFill>
-                        <a:latin typeface="Cambria Math" panose="02040503050406030204" pitchFamily="18" charset="0"/>
-                      </a:rPr>
-                      <m:t>[</m:t>
+                      <m:t>=[</m:t>
                     </m:r>
                     <m:d>
                       <m:dPr>
                         <m:ctrlPr>
-                          <a:rPr lang="fr-CA" b="0" i="0" smtClean="0">
+                          <a:rPr lang="fr-CA" b="0" i="1" smtClean="0">
                             <a:solidFill>
                               <a:srgbClr val="5B9BD5"/>
                             </a:solidFill>
@@ -13387,15 +16306,24 @@
                         <m:f>
                           <m:fPr>
                             <m:ctrlPr>
+                              <a:rPr lang="fr-CA" b="0" i="1" smtClean="0">
+                                <a:solidFill>
+                                  <a:srgbClr val="5B9BD5"/>
+                                </a:solidFill>
+                                <a:latin typeface="Cambria Math" panose="02040503050406030204" pitchFamily="18" charset="0"/>
+                              </a:rPr>
+                            </m:ctrlPr>
+                          </m:fPr>
+                          <m:num>
+                            <m:r>
                               <a:rPr lang="fr-CA" b="0" i="0" smtClean="0">
                                 <a:solidFill>
                                   <a:srgbClr val="5B9BD5"/>
                                 </a:solidFill>
                                 <a:latin typeface="Cambria Math" panose="02040503050406030204" pitchFamily="18" charset="0"/>
                               </a:rPr>
-                            </m:ctrlPr>
-                          </m:fPr>
-                          <m:num>
+                              <m:t>−</m:t>
+                            </m:r>
                             <m:r>
                               <a:rPr lang="fr-CA" b="0" i="0" smtClean="0">
                                 <a:solidFill>
@@ -13403,7 +16331,7 @@
                                 </a:solidFill>
                                 <a:latin typeface="Cambria Math" panose="02040503050406030204" pitchFamily="18" charset="0"/>
                               </a:rPr>
-                              <m:t>−2</m:t>
+                              <m:t>2</m:t>
                             </m:r>
                             <m:r>
                               <a:rPr lang="fr-CA" b="0" i="1" smtClean="0">
@@ -13861,7 +16789,16 @@
                             </a:solidFill>
                             <a:latin typeface="Cambria Math" panose="02040503050406030204" pitchFamily="18" charset="0"/>
                           </a:rPr>
-                          <m:t>−2</m:t>
+                          <m:t>−</m:t>
+                        </m:r>
+                        <m:r>
+                          <a:rPr lang="fr-CA" b="0" i="1" smtClean="0">
+                            <a:solidFill>
+                              <a:srgbClr val="5B9BD5"/>
+                            </a:solidFill>
+                            <a:latin typeface="Cambria Math" panose="02040503050406030204" pitchFamily="18" charset="0"/>
+                          </a:rPr>
+                          <m:t>2</m:t>
                         </m:r>
                       </m:sub>
                       <m:sup>
@@ -13884,7 +16821,17 @@
                         <a:latin typeface="Cambria Math" panose="02040503050406030204" pitchFamily="18" charset="0"/>
                         <a:ea typeface="Cambria Math" panose="02040503050406030204" pitchFamily="18" charset="0"/>
                       </a:rPr>
-                      <m:t>+4</m:t>
+                      <m:t>+</m:t>
+                    </m:r>
+                    <m:r>
+                      <a:rPr lang="fr-CA" b="0" i="1" smtClean="0">
+                        <a:solidFill>
+                          <a:srgbClr val="5B9BD5"/>
+                        </a:solidFill>
+                        <a:latin typeface="Cambria Math" panose="02040503050406030204" pitchFamily="18" charset="0"/>
+                        <a:ea typeface="Cambria Math" panose="02040503050406030204" pitchFamily="18" charset="0"/>
+                      </a:rPr>
+                      <m:t>4</m:t>
                     </m:r>
                     <m:sSubSup>
                       <m:sSubSupPr>
@@ -13943,7 +16890,16 @@
                             </a:solidFill>
                             <a:latin typeface="Cambria Math" panose="02040503050406030204" pitchFamily="18" charset="0"/>
                           </a:rPr>
-                          <m:t>−1</m:t>
+                          <m:t>−</m:t>
+                        </m:r>
+                        <m:r>
+                          <a:rPr lang="fr-CA" b="0" i="1" smtClean="0">
+                            <a:solidFill>
+                              <a:srgbClr val="5B9BD5"/>
+                            </a:solidFill>
+                            <a:latin typeface="Cambria Math" panose="02040503050406030204" pitchFamily="18" charset="0"/>
+                          </a:rPr>
+                          <m:t>1</m:t>
                         </m:r>
                       </m:sub>
                       <m:sup>
@@ -13966,7 +16922,17 @@
                         <a:latin typeface="Cambria Math" panose="02040503050406030204" pitchFamily="18" charset="0"/>
                         <a:ea typeface="Cambria Math" panose="02040503050406030204" pitchFamily="18" charset="0"/>
                       </a:rPr>
-                      <m:t>)]÷3</m:t>
+                      <m:t>)]÷</m:t>
+                    </m:r>
+                    <m:r>
+                      <a:rPr lang="fr-CA" b="0" i="1" smtClean="0">
+                        <a:solidFill>
+                          <a:srgbClr val="5B9BD5"/>
+                        </a:solidFill>
+                        <a:latin typeface="Cambria Math" panose="02040503050406030204" pitchFamily="18" charset="0"/>
+                        <a:ea typeface="Cambria Math" panose="02040503050406030204" pitchFamily="18" charset="0"/>
+                      </a:rPr>
+                      <m:t>3</m:t>
                     </m:r>
                   </m:oMath>
                 </a14:m>
@@ -14018,7 +16984,43 @@
                           </a:solidFill>
                           <a:latin typeface="Cambria Math" panose="02040503050406030204" pitchFamily="18" charset="0"/>
                         </a:rPr>
-                        <m:t>=(0,1)</m:t>
+                        <m:t>=(</m:t>
+                      </m:r>
+                      <m:r>
+                        <a:rPr lang="fr-CA" b="0" i="1" smtClean="0">
+                          <a:solidFill>
+                            <a:srgbClr val="5B9BD5"/>
+                          </a:solidFill>
+                          <a:latin typeface="Cambria Math" panose="02040503050406030204" pitchFamily="18" charset="0"/>
+                        </a:rPr>
+                        <m:t>0</m:t>
+                      </m:r>
+                      <m:r>
+                        <a:rPr lang="fr-CA" b="0" i="1" smtClean="0">
+                          <a:solidFill>
+                            <a:srgbClr val="5B9BD5"/>
+                          </a:solidFill>
+                          <a:latin typeface="Cambria Math" panose="02040503050406030204" pitchFamily="18" charset="0"/>
+                        </a:rPr>
+                        <m:t>,</m:t>
+                      </m:r>
+                      <m:r>
+                        <a:rPr lang="fr-CA" b="0" i="1" smtClean="0">
+                          <a:solidFill>
+                            <a:srgbClr val="5B9BD5"/>
+                          </a:solidFill>
+                          <a:latin typeface="Cambria Math" panose="02040503050406030204" pitchFamily="18" charset="0"/>
+                        </a:rPr>
+                        <m:t>1</m:t>
+                      </m:r>
+                      <m:r>
+                        <a:rPr lang="fr-CA" b="0" i="1" smtClean="0">
+                          <a:solidFill>
+                            <a:srgbClr val="5B9BD5"/>
+                          </a:solidFill>
+                          <a:latin typeface="Cambria Math" panose="02040503050406030204" pitchFamily="18" charset="0"/>
+                        </a:rPr>
+                        <m:t>)</m:t>
                       </m:r>
                     </m:oMath>
                   </m:oMathPara>
@@ -14032,7 +17034,7 @@
             </p:txBody>
           </p:sp>
         </mc:Choice>
-        <mc:Fallback>
+        <mc:Fallback xmlns="">
           <p:sp>
             <p:nvSpPr>
               <p:cNvPr id="8" name="ZoneTexte 7">
@@ -14077,8 +17079,8 @@
           </p:sp>
         </mc:Fallback>
       </mc:AlternateContent>
-      <mc:AlternateContent xmlns:mc="http://schemas.openxmlformats.org/markup-compatibility/2006">
-        <mc:Choice xmlns:a14="http://schemas.microsoft.com/office/drawing/2010/main" Requires="a14">
+      <mc:AlternateContent xmlns:mc="http://schemas.openxmlformats.org/markup-compatibility/2006" xmlns:a14="http://schemas.microsoft.com/office/drawing/2010/main">
+        <mc:Choice Requires="a14">
           <p:sp>
             <p:nvSpPr>
               <p:cNvPr id="9" name="ZoneTexte 8">
@@ -14560,7 +17562,16 @@
                                 </a:solidFill>
                                 <a:latin typeface="Cambria Math" panose="02040503050406030204" pitchFamily="18" charset="0"/>
                               </a:rPr>
-                              <m:t>−2</m:t>
+                              <m:t>−</m:t>
+                            </m:r>
+                            <m:r>
+                              <a:rPr lang="fr-CA" b="0" i="0" smtClean="0">
+                                <a:solidFill>
+                                  <a:srgbClr val="6FAD46"/>
+                                </a:solidFill>
+                                <a:latin typeface="Cambria Math" panose="02040503050406030204" pitchFamily="18" charset="0"/>
+                              </a:rPr>
+                              <m:t>2</m:t>
                             </m:r>
                             <m:r>
                               <a:rPr lang="fr-CA" b="0" i="1" smtClean="0">
@@ -15050,7 +18061,17 @@
                         <a:latin typeface="Cambria Math" panose="02040503050406030204" pitchFamily="18" charset="0"/>
                         <a:ea typeface="Cambria Math" panose="02040503050406030204" pitchFamily="18" charset="0"/>
                       </a:rPr>
-                      <m:t>+4</m:t>
+                      <m:t>+</m:t>
+                    </m:r>
+                    <m:r>
+                      <a:rPr lang="fr-CA" b="0" i="1" smtClean="0">
+                        <a:solidFill>
+                          <a:srgbClr val="6FAD46"/>
+                        </a:solidFill>
+                        <a:latin typeface="Cambria Math" panose="02040503050406030204" pitchFamily="18" charset="0"/>
+                        <a:ea typeface="Cambria Math" panose="02040503050406030204" pitchFamily="18" charset="0"/>
+                      </a:rPr>
+                      <m:t>4</m:t>
                     </m:r>
                     <m:sSubSup>
                       <m:sSubSupPr>
@@ -15141,7 +18162,17 @@
                         <a:latin typeface="Cambria Math" panose="02040503050406030204" pitchFamily="18" charset="0"/>
                         <a:ea typeface="Cambria Math" panose="02040503050406030204" pitchFamily="18" charset="0"/>
                       </a:rPr>
-                      <m:t>)]÷3</m:t>
+                      <m:t>)]÷</m:t>
+                    </m:r>
+                    <m:r>
+                      <a:rPr lang="fr-CA" b="0" i="1" smtClean="0">
+                        <a:solidFill>
+                          <a:srgbClr val="6FAD46"/>
+                        </a:solidFill>
+                        <a:latin typeface="Cambria Math" panose="02040503050406030204" pitchFamily="18" charset="0"/>
+                        <a:ea typeface="Cambria Math" panose="02040503050406030204" pitchFamily="18" charset="0"/>
+                      </a:rPr>
+                      <m:t>3</m:t>
                     </m:r>
                   </m:oMath>
                 </a14:m>
@@ -15243,7 +18274,7 @@
             </p:txBody>
           </p:sp>
         </mc:Choice>
-        <mc:Fallback>
+        <mc:Fallback xmlns="">
           <p:sp>
             <p:nvSpPr>
               <p:cNvPr id="9" name="ZoneTexte 8">
@@ -15436,8 +18467,8 @@
           </a:p>
         </p:txBody>
       </p:sp>
-      <mc:AlternateContent xmlns:mc="http://schemas.openxmlformats.org/markup-compatibility/2006">
-        <mc:Choice xmlns:a14="http://schemas.microsoft.com/office/drawing/2010/main" Requires="a14">
+      <mc:AlternateContent xmlns:mc="http://schemas.openxmlformats.org/markup-compatibility/2006" xmlns:a14="http://schemas.microsoft.com/office/drawing/2010/main">
+        <mc:Choice Requires="a14">
           <p:sp>
             <p:nvSpPr>
               <p:cNvPr id="3" name="Espace réservé du contenu 2">
@@ -15822,7 +18853,7 @@
             </p:txBody>
           </p:sp>
         </mc:Choice>
-        <mc:Fallback>
+        <mc:Fallback xmlns="">
           <p:sp>
             <p:nvSpPr>
               <p:cNvPr id="3" name="Espace réservé du contenu 2">
@@ -15929,8 +18960,8 @@
           </a:p>
         </p:txBody>
       </p:sp>
-      <mc:AlternateContent xmlns:mc="http://schemas.openxmlformats.org/markup-compatibility/2006">
-        <mc:Choice xmlns:a14="http://schemas.microsoft.com/office/drawing/2010/main" Requires="a14">
+      <mc:AlternateContent xmlns:mc="http://schemas.openxmlformats.org/markup-compatibility/2006" xmlns:a14="http://schemas.microsoft.com/office/drawing/2010/main">
+        <mc:Choice Requires="a14">
           <p:sp>
             <p:nvSpPr>
               <p:cNvPr id="3" name="Espace réservé du contenu 2">
@@ -16314,7 +19345,13 @@
                           <a:rPr lang="fr-FR" i="1">
                             <a:latin typeface="Cambria Math" panose="02040503050406030204" pitchFamily="18" charset="0"/>
                           </a:rPr>
-                          <m:t>2!</m:t>
+                          <m:t>2</m:t>
+                        </m:r>
+                        <m:r>
+                          <a:rPr lang="fr-FR" i="1">
+                            <a:latin typeface="Cambria Math" panose="02040503050406030204" pitchFamily="18" charset="0"/>
+                          </a:rPr>
+                          <m:t>!</m:t>
                         </m:r>
                       </m:den>
                     </m:f>
@@ -16486,7 +19523,13 @@
                           <a:rPr lang="fr-FR" i="1">
                             <a:latin typeface="Cambria Math" panose="02040503050406030204" pitchFamily="18" charset="0"/>
                           </a:rPr>
-                          <m:t>3!</m:t>
+                          <m:t>3</m:t>
+                        </m:r>
+                        <m:r>
+                          <a:rPr lang="fr-FR" i="1">
+                            <a:latin typeface="Cambria Math" panose="02040503050406030204" pitchFamily="18" charset="0"/>
+                          </a:rPr>
+                          <m:t>!</m:t>
                         </m:r>
                       </m:den>
                     </m:f>
@@ -16658,7 +19701,13 @@
                           <a:rPr lang="fr-FR" i="1">
                             <a:latin typeface="Cambria Math" panose="02040503050406030204" pitchFamily="18" charset="0"/>
                           </a:rPr>
-                          <m:t>4!</m:t>
+                          <m:t>4</m:t>
+                        </m:r>
+                        <m:r>
+                          <a:rPr lang="fr-FR" i="1">
+                            <a:latin typeface="Cambria Math" panose="02040503050406030204" pitchFamily="18" charset="0"/>
+                          </a:rPr>
+                          <m:t>!</m:t>
                         </m:r>
                       </m:den>
                     </m:f>
@@ -17076,7 +20125,13 @@
                           <a:rPr lang="fr-FR" i="1">
                             <a:latin typeface="Cambria Math" panose="02040503050406030204" pitchFamily="18" charset="0"/>
                           </a:rPr>
-                          <m:t>2!</m:t>
+                          <m:t>2</m:t>
+                        </m:r>
+                        <m:r>
+                          <a:rPr lang="fr-FR" i="1">
+                            <a:latin typeface="Cambria Math" panose="02040503050406030204" pitchFamily="18" charset="0"/>
+                          </a:rPr>
+                          <m:t>!</m:t>
                         </m:r>
                       </m:den>
                     </m:f>
@@ -17248,7 +20303,13 @@
                           <a:rPr lang="fr-FR" i="1">
                             <a:latin typeface="Cambria Math" panose="02040503050406030204" pitchFamily="18" charset="0"/>
                           </a:rPr>
-                          <m:t>3!</m:t>
+                          <m:t>3</m:t>
+                        </m:r>
+                        <m:r>
+                          <a:rPr lang="fr-FR" i="1">
+                            <a:latin typeface="Cambria Math" panose="02040503050406030204" pitchFamily="18" charset="0"/>
+                          </a:rPr>
+                          <m:t>!</m:t>
                         </m:r>
                       </m:den>
                     </m:f>
@@ -17420,7 +20481,13 @@
                           <a:rPr lang="fr-FR" i="1">
                             <a:latin typeface="Cambria Math" panose="02040503050406030204" pitchFamily="18" charset="0"/>
                           </a:rPr>
-                          <m:t>4!</m:t>
+                          <m:t>4</m:t>
+                        </m:r>
+                        <m:r>
+                          <a:rPr lang="fr-FR" i="1">
+                            <a:latin typeface="Cambria Math" panose="02040503050406030204" pitchFamily="18" charset="0"/>
+                          </a:rPr>
+                          <m:t>!</m:t>
                         </m:r>
                       </m:den>
                     </m:f>
@@ -18011,7 +21078,13 @@
                           <a:rPr lang="fr-FR" i="1">
                             <a:latin typeface="Cambria Math" panose="02040503050406030204" pitchFamily="18" charset="0"/>
                           </a:rPr>
-                          <m:t>2!</m:t>
+                          <m:t>2</m:t>
+                        </m:r>
+                        <m:r>
+                          <a:rPr lang="fr-FR" i="1">
+                            <a:latin typeface="Cambria Math" panose="02040503050406030204" pitchFamily="18" charset="0"/>
+                          </a:rPr>
+                          <m:t>!</m:t>
                         </m:r>
                       </m:den>
                     </m:f>
@@ -18472,7 +21545,13 @@
                           <a:rPr lang="fr-FR" i="1">
                             <a:latin typeface="Cambria Math" panose="02040503050406030204" pitchFamily="18" charset="0"/>
                           </a:rPr>
-                          <m:t>2!</m:t>
+                          <m:t>2</m:t>
+                        </m:r>
+                        <m:r>
+                          <a:rPr lang="fr-FR" i="1">
+                            <a:latin typeface="Cambria Math" panose="02040503050406030204" pitchFamily="18" charset="0"/>
+                          </a:rPr>
+                          <m:t>!</m:t>
                         </m:r>
                       </m:den>
                     </m:f>
@@ -18542,7 +21621,7 @@
             </p:txBody>
           </p:sp>
         </mc:Choice>
-        <mc:Fallback>
+        <mc:Fallback xmlns="">
           <p:sp>
             <p:nvSpPr>
               <p:cNvPr id="3" name="Espace réservé du contenu 2">
@@ -18655,8 +21734,8 @@
           </a:p>
         </p:txBody>
       </p:sp>
-      <mc:AlternateContent xmlns:mc="http://schemas.openxmlformats.org/markup-compatibility/2006">
-        <mc:Choice xmlns:a14="http://schemas.microsoft.com/office/drawing/2010/main" Requires="a14">
+      <mc:AlternateContent xmlns:mc="http://schemas.openxmlformats.org/markup-compatibility/2006" xmlns:a14="http://schemas.microsoft.com/office/drawing/2010/main">
+        <mc:Choice Requires="a14">
           <p:sp>
             <p:nvSpPr>
               <p:cNvPr id="3" name="Espace réservé du contenu 2">
@@ -23366,7 +26445,7 @@
             </p:txBody>
           </p:sp>
         </mc:Choice>
-        <mc:Fallback>
+        <mc:Fallback xmlns="">
           <p:sp>
             <p:nvSpPr>
               <p:cNvPr id="3" name="Espace réservé du contenu 2">

</xml_diff>

<commit_message>
pwp: correction ordre de convergence en r
</commit_message>
<xml_diff>
--- a/projet_final/projet_final/MEC8211-Projet-final-Presentation.pptx
+++ b/projet_final/projet_final/MEC8211-Projet-final-Presentation.pptx
@@ -377,7 +377,7 @@
           <a:p>
             <a:fld id="{F6105186-0725-443C-BC59-E521425E81CD}" type="slidenum">
               <a:rPr lang="fr-FR" smtClean="0"/>
-              <a:t>‹#›</a:t>
+              <a:t>‹N°›</a:t>
             </a:fld>
             <a:endParaRPr lang="fr-FR"/>
           </a:p>
@@ -963,7 +963,7 @@
           <a:p>
             <a:fld id="{FD85B578-4E75-4E1C-9BE3-D5DCC0715B13}" type="slidenum">
               <a:rPr lang="fr-FR" smtClean="0"/>
-              <a:t>‹#›</a:t>
+              <a:t>‹N°›</a:t>
             </a:fld>
             <a:endParaRPr lang="fr-FR"/>
           </a:p>
@@ -1161,7 +1161,7 @@
           <a:p>
             <a:fld id="{FD85B578-4E75-4E1C-9BE3-D5DCC0715B13}" type="slidenum">
               <a:rPr lang="fr-FR" smtClean="0"/>
-              <a:t>‹#›</a:t>
+              <a:t>‹N°›</a:t>
             </a:fld>
             <a:endParaRPr lang="fr-FR"/>
           </a:p>
@@ -1369,7 +1369,7 @@
           <a:p>
             <a:fld id="{FD85B578-4E75-4E1C-9BE3-D5DCC0715B13}" type="slidenum">
               <a:rPr lang="fr-FR" smtClean="0"/>
-              <a:t>‹#›</a:t>
+              <a:t>‹N°›</a:t>
             </a:fld>
             <a:endParaRPr lang="fr-FR"/>
           </a:p>
@@ -1567,7 +1567,7 @@
           <a:p>
             <a:fld id="{FD85B578-4E75-4E1C-9BE3-D5DCC0715B13}" type="slidenum">
               <a:rPr lang="fr-FR" smtClean="0"/>
-              <a:t>‹#›</a:t>
+              <a:t>‹N°›</a:t>
             </a:fld>
             <a:endParaRPr lang="fr-FR"/>
           </a:p>
@@ -1842,7 +1842,7 @@
           <a:p>
             <a:fld id="{FD85B578-4E75-4E1C-9BE3-D5DCC0715B13}" type="slidenum">
               <a:rPr lang="fr-FR" smtClean="0"/>
-              <a:t>‹#›</a:t>
+              <a:t>‹N°›</a:t>
             </a:fld>
             <a:endParaRPr lang="fr-FR"/>
           </a:p>
@@ -2107,7 +2107,7 @@
           <a:p>
             <a:fld id="{FD85B578-4E75-4E1C-9BE3-D5DCC0715B13}" type="slidenum">
               <a:rPr lang="fr-FR" smtClean="0"/>
-              <a:t>‹#›</a:t>
+              <a:t>‹N°›</a:t>
             </a:fld>
             <a:endParaRPr lang="fr-FR"/>
           </a:p>
@@ -2519,7 +2519,7 @@
           <a:p>
             <a:fld id="{FD85B578-4E75-4E1C-9BE3-D5DCC0715B13}" type="slidenum">
               <a:rPr lang="fr-FR" smtClean="0"/>
-              <a:t>‹#›</a:t>
+              <a:t>‹N°›</a:t>
             </a:fld>
             <a:endParaRPr lang="fr-FR"/>
           </a:p>
@@ -2660,7 +2660,7 @@
           <a:p>
             <a:fld id="{FD85B578-4E75-4E1C-9BE3-D5DCC0715B13}" type="slidenum">
               <a:rPr lang="fr-FR" smtClean="0"/>
-              <a:t>‹#›</a:t>
+              <a:t>‹N°›</a:t>
             </a:fld>
             <a:endParaRPr lang="fr-FR"/>
           </a:p>
@@ -2773,7 +2773,7 @@
           <a:p>
             <a:fld id="{FD85B578-4E75-4E1C-9BE3-D5DCC0715B13}" type="slidenum">
               <a:rPr lang="fr-FR" smtClean="0"/>
-              <a:t>‹#›</a:t>
+              <a:t>‹N°›</a:t>
             </a:fld>
             <a:endParaRPr lang="fr-FR"/>
           </a:p>
@@ -3084,7 +3084,7 @@
           <a:p>
             <a:fld id="{FD85B578-4E75-4E1C-9BE3-D5DCC0715B13}" type="slidenum">
               <a:rPr lang="fr-FR" smtClean="0"/>
-              <a:t>‹#›</a:t>
+              <a:t>‹N°›</a:t>
             </a:fld>
             <a:endParaRPr lang="fr-FR"/>
           </a:p>
@@ -3372,7 +3372,7 @@
           <a:p>
             <a:fld id="{FD85B578-4E75-4E1C-9BE3-D5DCC0715B13}" type="slidenum">
               <a:rPr lang="fr-FR" smtClean="0"/>
-              <a:t>‹#›</a:t>
+              <a:t>‹N°›</a:t>
             </a:fld>
             <a:endParaRPr lang="fr-FR"/>
           </a:p>
@@ -3652,7 +3652,7 @@
           <a:p>
             <a:fld id="{FD85B578-4E75-4E1C-9BE3-D5DCC0715B13}" type="slidenum">
               <a:rPr lang="fr-FR" smtClean="0"/>
-              <a:t>‹#›</a:t>
+              <a:t>‹N°›</a:t>
             </a:fld>
             <a:endParaRPr lang="fr-FR"/>
           </a:p>
@@ -7252,7 +7252,14 @@
                         <a:latin typeface="Cambria Math" panose="02040503050406030204" pitchFamily="18" charset="0"/>
                         <a:sym typeface="Wingdings" panose="05000000000000000000" pitchFamily="2" charset="2"/>
                       </a:rPr>
-                      <m:t> = 100</m:t>
+                      <m:t> = </m:t>
+                    </m:r>
+                    <m:r>
+                      <a:rPr lang="fr-FR" b="0" i="1" smtClean="0">
+                        <a:latin typeface="Cambria Math" panose="02040503050406030204" pitchFamily="18" charset="0"/>
+                        <a:sym typeface="Wingdings" panose="05000000000000000000" pitchFamily="2" charset="2"/>
+                      </a:rPr>
+                      <m:t>100</m:t>
                     </m:r>
                     <m:r>
                       <m:rPr>
@@ -7286,7 +7293,14 @@
                         <a:latin typeface="Cambria Math" panose="02040503050406030204" pitchFamily="18" charset="0"/>
                         <a:sym typeface="Wingdings" panose="05000000000000000000" pitchFamily="2" charset="2"/>
                       </a:rPr>
-                      <m:t>=2</m:t>
+                      <m:t>=</m:t>
+                    </m:r>
+                    <m:r>
+                      <a:rPr lang="fr-FR" b="0" i="1" smtClean="0">
+                        <a:latin typeface="Cambria Math" panose="02040503050406030204" pitchFamily="18" charset="0"/>
+                        <a:sym typeface="Wingdings" panose="05000000000000000000" pitchFamily="2" charset="2"/>
+                      </a:rPr>
+                      <m:t>2</m:t>
                     </m:r>
                   </m:oMath>
                 </a14:m>
@@ -7352,7 +7366,28 @@
                         <a:latin typeface="Cambria Math" panose="02040503050406030204" pitchFamily="18" charset="0"/>
                         <a:sym typeface="Wingdings" panose="05000000000000000000" pitchFamily="2" charset="2"/>
                       </a:rPr>
-                      <m:t>= 0.6</m:t>
+                      <m:t>= </m:t>
+                    </m:r>
+                    <m:r>
+                      <a:rPr lang="fr-FR" b="0" i="1" smtClean="0">
+                        <a:latin typeface="Cambria Math" panose="02040503050406030204" pitchFamily="18" charset="0"/>
+                        <a:sym typeface="Wingdings" panose="05000000000000000000" pitchFamily="2" charset="2"/>
+                      </a:rPr>
+                      <m:t>0</m:t>
+                    </m:r>
+                    <m:r>
+                      <a:rPr lang="fr-FR" b="0" i="1" smtClean="0">
+                        <a:latin typeface="Cambria Math" panose="02040503050406030204" pitchFamily="18" charset="0"/>
+                        <a:sym typeface="Wingdings" panose="05000000000000000000" pitchFamily="2" charset="2"/>
+                      </a:rPr>
+                      <m:t>.</m:t>
+                    </m:r>
+                    <m:r>
+                      <a:rPr lang="fr-FR" b="0" i="1" smtClean="0">
+                        <a:latin typeface="Cambria Math" panose="02040503050406030204" pitchFamily="18" charset="0"/>
+                        <a:sym typeface="Wingdings" panose="05000000000000000000" pitchFamily="2" charset="2"/>
+                      </a:rPr>
+                      <m:t>6</m:t>
                     </m:r>
                     <m:r>
                       <m:rPr>
@@ -7389,7 +7424,28 @@
                         <a:latin typeface="Cambria Math" panose="02040503050406030204" pitchFamily="18" charset="0"/>
                         <a:sym typeface="Wingdings" panose="05000000000000000000" pitchFamily="2" charset="2"/>
                       </a:rPr>
-                      <m:t> = 0.3</m:t>
+                      <m:t> = </m:t>
+                    </m:r>
+                    <m:r>
+                      <a:rPr lang="fr-FR" b="0" i="1" smtClean="0">
+                        <a:latin typeface="Cambria Math" panose="02040503050406030204" pitchFamily="18" charset="0"/>
+                        <a:sym typeface="Wingdings" panose="05000000000000000000" pitchFamily="2" charset="2"/>
+                      </a:rPr>
+                      <m:t>0</m:t>
+                    </m:r>
+                    <m:r>
+                      <a:rPr lang="fr-FR" b="0" i="1" smtClean="0">
+                        <a:latin typeface="Cambria Math" panose="02040503050406030204" pitchFamily="18" charset="0"/>
+                        <a:sym typeface="Wingdings" panose="05000000000000000000" pitchFamily="2" charset="2"/>
+                      </a:rPr>
+                      <m:t>.</m:t>
+                    </m:r>
+                    <m:r>
+                      <a:rPr lang="fr-FR" b="0" i="1" smtClean="0">
+                        <a:latin typeface="Cambria Math" panose="02040503050406030204" pitchFamily="18" charset="0"/>
+                        <a:sym typeface="Wingdings" panose="05000000000000000000" pitchFamily="2" charset="2"/>
+                      </a:rPr>
+                      <m:t>3</m:t>
                     </m:r>
                   </m:oMath>
                 </a14:m>
@@ -9455,13 +9511,7 @@
                           <a:rPr lang="fr-FR" i="1">
                             <a:latin typeface="Cambria Math" panose="02040503050406030204" pitchFamily="18" charset="0"/>
                           </a:rPr>
-                          <m:t>−</m:t>
-                        </m:r>
-                        <m:r>
-                          <a:rPr lang="fr-FR" i="1">
-                            <a:latin typeface="Cambria Math" panose="02040503050406030204" pitchFamily="18" charset="0"/>
-                          </a:rPr>
-                          <m:t>1</m:t>
+                          <m:t>−1</m:t>
                         </m:r>
                       </m:den>
                     </m:f>
@@ -9651,19 +9701,7 @@
                       <a:rPr lang="fr-FR" i="1">
                         <a:latin typeface="Cambria Math" panose="02040503050406030204" pitchFamily="18" charset="0"/>
                       </a:rPr>
-                      <m:t>0</m:t>
-                    </m:r>
-                    <m:r>
-                      <a:rPr lang="fr-FR" i="1">
-                        <a:latin typeface="Cambria Math" panose="02040503050406030204" pitchFamily="18" charset="0"/>
-                      </a:rPr>
-                      <m:t>.</m:t>
-                    </m:r>
-                    <m:r>
-                      <a:rPr lang="fr-FR" i="1">
-                        <a:latin typeface="Cambria Math" panose="02040503050406030204" pitchFamily="18" charset="0"/>
-                      </a:rPr>
-                      <m:t>1</m:t>
+                      <m:t>0.1</m:t>
                     </m:r>
                   </m:oMath>
                 </a14:m>
@@ -9708,25 +9746,7 @@
                       <a:rPr lang="fr-FR" i="1">
                         <a:latin typeface="Cambria Math" panose="02040503050406030204" pitchFamily="18" charset="0"/>
                       </a:rPr>
-                      <m:t>=</m:t>
-                    </m:r>
-                    <m:r>
-                      <a:rPr lang="fr-FR" i="1">
-                        <a:latin typeface="Cambria Math" panose="02040503050406030204" pitchFamily="18" charset="0"/>
-                      </a:rPr>
-                      <m:t>1</m:t>
-                    </m:r>
-                    <m:r>
-                      <a:rPr lang="fr-FR" i="1">
-                        <a:latin typeface="Cambria Math" panose="02040503050406030204" pitchFamily="18" charset="0"/>
-                      </a:rPr>
-                      <m:t>.</m:t>
-                    </m:r>
-                    <m:r>
-                      <a:rPr lang="fr-FR" i="1">
-                        <a:latin typeface="Cambria Math" panose="02040503050406030204" pitchFamily="18" charset="0"/>
-                      </a:rPr>
-                      <m:t>25</m:t>
+                      <m:t>=1.25</m:t>
                     </m:r>
                   </m:oMath>
                 </a14:m>
@@ -9871,14 +9891,7 @@
                             <a:latin typeface="Cambria Math" panose="02040503050406030204" pitchFamily="18" charset="0"/>
                             <a:sym typeface="Wingdings" panose="05000000000000000000" pitchFamily="2" charset="2"/>
                           </a:rPr>
-                          <m:t>×</m:t>
-                        </m:r>
-                        <m:r>
-                          <a:rPr lang="fr-FR" b="0" i="1" smtClean="0">
-                            <a:latin typeface="Cambria Math" panose="02040503050406030204" pitchFamily="18" charset="0"/>
-                            <a:sym typeface="Wingdings" panose="05000000000000000000" pitchFamily="2" charset="2"/>
-                          </a:rPr>
-                          <m:t>10</m:t>
+                          <m:t>×10</m:t>
                         </m:r>
                       </m:e>
                       <m:sup>
@@ -9887,14 +9900,7 @@
                             <a:latin typeface="Cambria Math" panose="02040503050406030204" pitchFamily="18" charset="0"/>
                             <a:sym typeface="Wingdings" panose="05000000000000000000" pitchFamily="2" charset="2"/>
                           </a:rPr>
-                          <m:t>−</m:t>
-                        </m:r>
-                        <m:r>
-                          <a:rPr lang="fr-FR" b="0" i="1" smtClean="0">
-                            <a:latin typeface="Cambria Math" panose="02040503050406030204" pitchFamily="18" charset="0"/>
-                            <a:sym typeface="Wingdings" panose="05000000000000000000" pitchFamily="2" charset="2"/>
-                          </a:rPr>
-                          <m:t>3</m:t>
+                          <m:t>−3</m:t>
                         </m:r>
                       </m:sup>
                     </m:sSup>
@@ -10159,13 +10165,7 @@
                                     <a:rPr lang="fr-FR" b="0" i="1" smtClean="0">
                                       <a:latin typeface="Cambria Math" panose="02040503050406030204" pitchFamily="18" charset="0"/>
                                     </a:rPr>
-                                    <m:t>−</m:t>
-                                  </m:r>
-                                  <m:r>
-                                    <a:rPr lang="fr-FR" b="0" i="1" smtClean="0">
-                                      <a:latin typeface="Cambria Math" panose="02040503050406030204" pitchFamily="18" charset="0"/>
-                                    </a:rPr>
-                                    <m:t>4</m:t>
+                                    <m:t>−4</m:t>
                                   </m:r>
                                 </m:sup>
                               </m:sSup>
@@ -10242,13 +10242,7 @@
                                     <a:rPr lang="fr-FR" b="0" i="1" smtClean="0">
                                       <a:latin typeface="Cambria Math" panose="02040503050406030204" pitchFamily="18" charset="0"/>
                                     </a:rPr>
-                                    <m:t>−</m:t>
-                                  </m:r>
-                                  <m:r>
-                                    <a:rPr lang="fr-FR" b="0" i="1" smtClean="0">
-                                      <a:latin typeface="Cambria Math" panose="02040503050406030204" pitchFamily="18" charset="0"/>
-                                    </a:rPr>
-                                    <m:t>4</m:t>
+                                    <m:t>−4</m:t>
                                   </m:r>
                                 </m:sup>
                               </m:sSup>
@@ -10325,13 +10319,7 @@
                                     <a:rPr lang="fr-FR" b="0" i="1" smtClean="0">
                                       <a:latin typeface="Cambria Math" panose="02040503050406030204" pitchFamily="18" charset="0"/>
                                     </a:rPr>
-                                    <m:t>−</m:t>
-                                  </m:r>
-                                  <m:r>
-                                    <a:rPr lang="fr-FR" b="0" i="1" smtClean="0">
-                                      <a:latin typeface="Cambria Math" panose="02040503050406030204" pitchFamily="18" charset="0"/>
-                                    </a:rPr>
-                                    <m:t>3</m:t>
+                                    <m:t>−3</m:t>
                                   </m:r>
                                 </m:sup>
                               </m:sSup>
@@ -11409,7 +11397,55 @@
                       <a:rPr lang="fr-FR" b="0" i="1" smtClean="0">
                         <a:latin typeface="Cambria Math" panose="02040503050406030204" pitchFamily="18" charset="0"/>
                       </a:rPr>
-                      <m:t>(42.5,3.75) </m:t>
+                      <m:t>(</m:t>
+                    </m:r>
+                    <m:r>
+                      <a:rPr lang="fr-FR" b="0" i="1" smtClean="0">
+                        <a:latin typeface="Cambria Math" panose="02040503050406030204" pitchFamily="18" charset="0"/>
+                      </a:rPr>
+                      <m:t>42</m:t>
+                    </m:r>
+                    <m:r>
+                      <a:rPr lang="fr-FR" b="0" i="1" smtClean="0">
+                        <a:latin typeface="Cambria Math" panose="02040503050406030204" pitchFamily="18" charset="0"/>
+                      </a:rPr>
+                      <m:t>.</m:t>
+                    </m:r>
+                    <m:r>
+                      <a:rPr lang="fr-FR" b="0" i="1" smtClean="0">
+                        <a:latin typeface="Cambria Math" panose="02040503050406030204" pitchFamily="18" charset="0"/>
+                      </a:rPr>
+                      <m:t>5</m:t>
+                    </m:r>
+                    <m:r>
+                      <a:rPr lang="fr-FR" b="0" i="1" smtClean="0">
+                        <a:latin typeface="Cambria Math" panose="02040503050406030204" pitchFamily="18" charset="0"/>
+                      </a:rPr>
+                      <m:t>,</m:t>
+                    </m:r>
+                    <m:r>
+                      <a:rPr lang="fr-FR" b="0" i="1" smtClean="0">
+                        <a:latin typeface="Cambria Math" panose="02040503050406030204" pitchFamily="18" charset="0"/>
+                      </a:rPr>
+                      <m:t>3</m:t>
+                    </m:r>
+                    <m:r>
+                      <a:rPr lang="fr-FR" b="0" i="1" smtClean="0">
+                        <a:latin typeface="Cambria Math" panose="02040503050406030204" pitchFamily="18" charset="0"/>
+                      </a:rPr>
+                      <m:t>.</m:t>
+                    </m:r>
+                    <m:r>
+                      <a:rPr lang="fr-FR" b="0" i="1" smtClean="0">
+                        <a:latin typeface="Cambria Math" panose="02040503050406030204" pitchFamily="18" charset="0"/>
+                      </a:rPr>
+                      <m:t>75</m:t>
+                    </m:r>
+                    <m:r>
+                      <a:rPr lang="fr-FR" b="0" i="1" smtClean="0">
+                        <a:latin typeface="Cambria Math" panose="02040503050406030204" pitchFamily="18" charset="0"/>
+                      </a:rPr>
+                      <m:t>) </m:t>
                     </m:r>
                     <m:r>
                       <a:rPr lang="fr-FR" b="0" i="1" smtClean="0">
@@ -11538,7 +11574,43 @@
                             <a:rPr lang="fr-FR" b="0" i="1" smtClean="0">
                               <a:latin typeface="Cambria Math" panose="02040503050406030204" pitchFamily="18" charset="0"/>
                             </a:rPr>
-                            <m:t>0.525,0.19</m:t>
+                            <m:t>0</m:t>
+                          </m:r>
+                          <m:r>
+                            <a:rPr lang="fr-FR" b="0" i="1" smtClean="0">
+                              <a:latin typeface="Cambria Math" panose="02040503050406030204" pitchFamily="18" charset="0"/>
+                            </a:rPr>
+                            <m:t>.</m:t>
+                          </m:r>
+                          <m:r>
+                            <a:rPr lang="fr-FR" b="0" i="1" smtClean="0">
+                              <a:latin typeface="Cambria Math" panose="02040503050406030204" pitchFamily="18" charset="0"/>
+                            </a:rPr>
+                            <m:t>525</m:t>
+                          </m:r>
+                          <m:r>
+                            <a:rPr lang="fr-FR" b="0" i="1" smtClean="0">
+                              <a:latin typeface="Cambria Math" panose="02040503050406030204" pitchFamily="18" charset="0"/>
+                            </a:rPr>
+                            <m:t>,</m:t>
+                          </m:r>
+                          <m:r>
+                            <a:rPr lang="fr-FR" b="0" i="1" smtClean="0">
+                              <a:latin typeface="Cambria Math" panose="02040503050406030204" pitchFamily="18" charset="0"/>
+                            </a:rPr>
+                            <m:t>0</m:t>
+                          </m:r>
+                          <m:r>
+                            <a:rPr lang="fr-FR" b="0" i="1" smtClean="0">
+                              <a:latin typeface="Cambria Math" panose="02040503050406030204" pitchFamily="18" charset="0"/>
+                            </a:rPr>
+                            <m:t>.</m:t>
+                          </m:r>
+                          <m:r>
+                            <a:rPr lang="fr-FR" b="0" i="1" smtClean="0">
+                              <a:latin typeface="Cambria Math" panose="02040503050406030204" pitchFamily="18" charset="0"/>
+                            </a:rPr>
+                            <m:t>19</m:t>
                           </m:r>
                         </m:e>
                       </m:d>
@@ -11708,7 +11780,31 @@
                       <a:rPr lang="fr-FR" sz="2200" b="0" i="1" smtClean="0">
                         <a:latin typeface="Cambria Math" panose="02040503050406030204" pitchFamily="18" charset="0"/>
                       </a:rPr>
-                      <m:t>=44.91 </m:t>
+                      <m:t>=</m:t>
+                    </m:r>
+                    <m:r>
+                      <a:rPr lang="fr-FR" sz="2200" b="0" i="1" smtClean="0">
+                        <a:latin typeface="Cambria Math" panose="02040503050406030204" pitchFamily="18" charset="0"/>
+                      </a:rPr>
+                      <m:t>44</m:t>
+                    </m:r>
+                    <m:r>
+                      <a:rPr lang="fr-FR" sz="2200" b="0" i="1" smtClean="0">
+                        <a:latin typeface="Cambria Math" panose="02040503050406030204" pitchFamily="18" charset="0"/>
+                      </a:rPr>
+                      <m:t>.</m:t>
+                    </m:r>
+                    <m:r>
+                      <a:rPr lang="fr-FR" sz="2200" b="0" i="1" smtClean="0">
+                        <a:latin typeface="Cambria Math" panose="02040503050406030204" pitchFamily="18" charset="0"/>
+                      </a:rPr>
+                      <m:t>91</m:t>
+                    </m:r>
+                    <m:r>
+                      <a:rPr lang="fr-FR" sz="2200" b="0" i="1" smtClean="0">
+                        <a:latin typeface="Cambria Math" panose="02040503050406030204" pitchFamily="18" charset="0"/>
+                      </a:rPr>
+                      <m:t> </m:t>
                     </m:r>
                     <m:r>
                       <m:rPr>
@@ -13041,8 +13137,8 @@
           </a:prstGeom>
         </p:spPr>
       </p:pic>
-      <mc:AlternateContent xmlns:mc="http://schemas.openxmlformats.org/markup-compatibility/2006">
-        <mc:Choice xmlns:a14="http://schemas.microsoft.com/office/drawing/2010/main" Requires="a14">
+      <mc:AlternateContent xmlns:mc="http://schemas.openxmlformats.org/markup-compatibility/2006" xmlns:a14="http://schemas.microsoft.com/office/drawing/2010/main">
+        <mc:Choice Requires="a14">
           <p:sp>
             <p:nvSpPr>
               <p:cNvPr id="6" name="TextBox 5">
@@ -13238,7 +13334,7 @@
                         <m:nor/>
                       </m:rPr>
                       <a:rPr lang="en-US" dirty="0"/>
-                      <m:t>-7.70 </m:t>
+                      <m:t>−7.70 </m:t>
                     </m:r>
                     <m:r>
                       <m:rPr>
@@ -13322,7 +13418,7 @@
             </p:txBody>
           </p:sp>
         </mc:Choice>
-        <mc:Fallback>
+        <mc:Fallback xmlns="">
           <p:sp>
             <p:nvSpPr>
               <p:cNvPr id="6" name="TextBox 5">
@@ -25590,8 +25686,8 @@
           </a:p>
         </p:txBody>
       </p:sp>
-      <mc:AlternateContent xmlns:mc="http://schemas.openxmlformats.org/markup-compatibility/2006" xmlns:a14="http://schemas.microsoft.com/office/drawing/2010/main">
-        <mc:Choice Requires="a14">
+      <mc:AlternateContent xmlns:mc="http://schemas.openxmlformats.org/markup-compatibility/2006">
+        <mc:Choice xmlns:a14="http://schemas.microsoft.com/office/drawing/2010/main" Requires="a14">
           <p:sp>
             <p:nvSpPr>
               <p:cNvPr id="3" name="Espace réservé du contenu 2">
@@ -25669,19 +25765,7 @@
                               <a:rPr lang="fr-FR" sz="2400" i="1">
                                 <a:latin typeface="Cambria Math" panose="02040503050406030204" pitchFamily="18" charset="0"/>
                               </a:rPr>
-                              <m:t>+</m:t>
-                            </m:r>
-                            <m:r>
-                              <a:rPr lang="fr-FR" sz="2400" i="1">
-                                <a:latin typeface="Cambria Math" panose="02040503050406030204" pitchFamily="18" charset="0"/>
-                              </a:rPr>
-                              <m:t>1</m:t>
-                            </m:r>
-                            <m:r>
-                              <a:rPr lang="fr-FR" sz="2400" i="1">
-                                <a:latin typeface="Cambria Math" panose="02040503050406030204" pitchFamily="18" charset="0"/>
-                              </a:rPr>
-                              <m:t>,</m:t>
+                              <m:t>+1,</m:t>
                             </m:r>
                             <m:r>
                               <a:rPr lang="fr-FR" sz="2400" i="1">
@@ -25732,19 +25816,7 @@
                               <a:rPr lang="fr-FR" sz="2400" i="1">
                                 <a:latin typeface="Cambria Math" panose="02040503050406030204" pitchFamily="18" charset="0"/>
                               </a:rPr>
-                              <m:t>−</m:t>
-                            </m:r>
-                            <m:r>
-                              <a:rPr lang="fr-FR" sz="2400" i="1">
-                                <a:latin typeface="Cambria Math" panose="02040503050406030204" pitchFamily="18" charset="0"/>
-                              </a:rPr>
-                              <m:t>1</m:t>
-                            </m:r>
-                            <m:r>
-                              <a:rPr lang="fr-FR" sz="2400" i="1">
-                                <a:latin typeface="Cambria Math" panose="02040503050406030204" pitchFamily="18" charset="0"/>
-                              </a:rPr>
-                              <m:t>,</m:t>
+                              <m:t>−1,</m:t>
                             </m:r>
                             <m:r>
                               <a:rPr lang="fr-FR" sz="2400" i="1">
@@ -25764,6 +25836,12 @@
                         </m:sSubSup>
                       </m:num>
                       <m:den>
+                        <m:r>
+                          <a:rPr lang="fr-CA" sz="2400" b="0" i="1" smtClean="0">
+                            <a:latin typeface="Cambria Math" panose="02040503050406030204" pitchFamily="18" charset="0"/>
+                          </a:rPr>
+                          <m:t>2</m:t>
+                        </m:r>
                         <m:r>
                           <m:rPr>
                             <m:sty m:val="p"/>
@@ -26254,16 +26332,7 @@
                             </a:solidFill>
                             <a:latin typeface="Cambria Math" panose="02040503050406030204" pitchFamily="18" charset="0"/>
                           </a:rPr>
-                          <m:t>2</m:t>
-                        </m:r>
-                        <m:r>
-                          <a:rPr lang="fr-FR" sz="2400" i="1">
-                            <a:solidFill>
-                              <a:srgbClr val="FF0000"/>
-                            </a:solidFill>
-                            <a:latin typeface="Cambria Math" panose="02040503050406030204" pitchFamily="18" charset="0"/>
-                          </a:rPr>
-                          <m:t>!</m:t>
+                          <m:t>2!</m:t>
                         </m:r>
                       </m:den>
                     </m:f>
@@ -26459,13 +26528,7 @@
                           <a:rPr lang="fr-FR" sz="2400" i="1">
                             <a:latin typeface="Cambria Math" panose="02040503050406030204" pitchFamily="18" charset="0"/>
                           </a:rPr>
-                          <m:t>3</m:t>
-                        </m:r>
-                        <m:r>
-                          <a:rPr lang="fr-FR" sz="2400" i="1">
-                            <a:latin typeface="Cambria Math" panose="02040503050406030204" pitchFamily="18" charset="0"/>
-                          </a:rPr>
-                          <m:t>!</m:t>
+                          <m:t>3!</m:t>
                         </m:r>
                       </m:den>
                     </m:f>
@@ -26981,16 +27044,7 @@
                             </a:solidFill>
                             <a:latin typeface="Cambria Math" panose="02040503050406030204" pitchFamily="18" charset="0"/>
                           </a:rPr>
-                          <m:t>2</m:t>
-                        </m:r>
-                        <m:r>
-                          <a:rPr lang="fr-FR" sz="2400" i="1">
-                            <a:solidFill>
-                              <a:srgbClr val="FF0000"/>
-                            </a:solidFill>
-                            <a:latin typeface="Cambria Math" panose="02040503050406030204" pitchFamily="18" charset="0"/>
-                          </a:rPr>
-                          <m:t>!</m:t>
+                          <m:t>2!</m:t>
                         </m:r>
                       </m:den>
                     </m:f>
@@ -27198,13 +27252,7 @@
                           <a:rPr lang="fr-FR" sz="2400" i="1">
                             <a:latin typeface="Cambria Math" panose="02040503050406030204" pitchFamily="18" charset="0"/>
                           </a:rPr>
-                          <m:t>3</m:t>
-                        </m:r>
-                        <m:r>
-                          <a:rPr lang="fr-FR" sz="2400" i="1">
-                            <a:latin typeface="Cambria Math" panose="02040503050406030204" pitchFamily="18" charset="0"/>
-                          </a:rPr>
-                          <m:t>!</m:t>
+                          <m:t>3!</m:t>
                         </m:r>
                       </m:den>
                     </m:f>
@@ -27722,13 +27770,7 @@
                               <a:rPr lang="fr-FR" sz="2400" i="1">
                                 <a:latin typeface="Cambria Math" panose="02040503050406030204" pitchFamily="18" charset="0"/>
                               </a:rPr>
-                              <m:t>+</m:t>
-                            </m:r>
-                            <m:r>
-                              <a:rPr lang="fr-FR" sz="2400" i="1">
-                                <a:latin typeface="Cambria Math" panose="02040503050406030204" pitchFamily="18" charset="0"/>
-                              </a:rPr>
-                              <m:t>1</m:t>
+                              <m:t>+1</m:t>
                             </m:r>
                           </m:sub>
                           <m:sup>
@@ -27842,13 +27884,7 @@
                               <a:rPr lang="fr-FR" sz="2400" i="1">
                                 <a:latin typeface="Cambria Math" panose="02040503050406030204" pitchFamily="18" charset="0"/>
                               </a:rPr>
-                              <m:t>−</m:t>
-                            </m:r>
-                            <m:r>
-                              <a:rPr lang="fr-FR" sz="2400" i="1">
-                                <a:latin typeface="Cambria Math" panose="02040503050406030204" pitchFamily="18" charset="0"/>
-                              </a:rPr>
-                              <m:t>1</m:t>
+                              <m:t>−1</m:t>
                             </m:r>
                           </m:sub>
                           <m:sup>
@@ -28442,16 +28478,7 @@
                             </a:solidFill>
                             <a:latin typeface="Cambria Math" panose="02040503050406030204" pitchFamily="18" charset="0"/>
                           </a:rPr>
-                          <m:t>2</m:t>
-                        </m:r>
-                        <m:r>
-                          <a:rPr lang="fr-FR" sz="2400" i="1">
-                            <a:solidFill>
-                              <a:schemeClr val="tx1"/>
-                            </a:solidFill>
-                            <a:latin typeface="Cambria Math" panose="02040503050406030204" pitchFamily="18" charset="0"/>
-                          </a:rPr>
-                          <m:t>!</m:t>
+                          <m:t>2!</m:t>
                         </m:r>
                       </m:den>
                     </m:f>
@@ -28719,16 +28746,7 @@
                             </a:solidFill>
                             <a:latin typeface="Cambria Math" panose="02040503050406030204" pitchFamily="18" charset="0"/>
                           </a:rPr>
-                          <m:t>3</m:t>
-                        </m:r>
-                        <m:r>
-                          <a:rPr lang="fr-FR" sz="2400" i="1">
-                            <a:solidFill>
-                              <a:srgbClr val="FF0000"/>
-                            </a:solidFill>
-                            <a:latin typeface="Cambria Math" panose="02040503050406030204" pitchFamily="18" charset="0"/>
-                          </a:rPr>
-                          <m:t>!</m:t>
+                          <m:t>3!</m:t>
                         </m:r>
                       </m:den>
                     </m:f>
@@ -28900,13 +28918,7 @@
                           <a:rPr lang="fr-FR" sz="2400" i="1">
                             <a:latin typeface="Cambria Math" panose="02040503050406030204" pitchFamily="18" charset="0"/>
                           </a:rPr>
-                          <m:t>4</m:t>
-                        </m:r>
-                        <m:r>
-                          <a:rPr lang="fr-FR" sz="2400" i="1">
-                            <a:latin typeface="Cambria Math" panose="02040503050406030204" pitchFamily="18" charset="0"/>
-                          </a:rPr>
-                          <m:t>!</m:t>
+                          <m:t>4!</m:t>
                         </m:r>
                       </m:den>
                     </m:f>
@@ -29337,13 +29349,7 @@
                           <a:rPr lang="fr-FR" sz="2400" i="1">
                             <a:latin typeface="Cambria Math" panose="02040503050406030204" pitchFamily="18" charset="0"/>
                           </a:rPr>
-                          <m:t>2</m:t>
-                        </m:r>
-                        <m:r>
-                          <a:rPr lang="fr-FR" sz="2400" i="1">
-                            <a:latin typeface="Cambria Math" panose="02040503050406030204" pitchFamily="18" charset="0"/>
-                          </a:rPr>
-                          <m:t>!</m:t>
+                          <m:t>2!</m:t>
                         </m:r>
                       </m:den>
                     </m:f>
@@ -29611,16 +29617,7 @@
                             </a:solidFill>
                             <a:latin typeface="Cambria Math" panose="02040503050406030204" pitchFamily="18" charset="0"/>
                           </a:rPr>
-                          <m:t>3</m:t>
-                        </m:r>
-                        <m:r>
-                          <a:rPr lang="fr-FR" sz="2400" i="1">
-                            <a:solidFill>
-                              <a:srgbClr val="FF0000"/>
-                            </a:solidFill>
-                            <a:latin typeface="Cambria Math" panose="02040503050406030204" pitchFamily="18" charset="0"/>
-                          </a:rPr>
-                          <m:t>!</m:t>
+                          <m:t>3!</m:t>
                         </m:r>
                       </m:den>
                     </m:f>
@@ -29792,13 +29789,7 @@
                           <a:rPr lang="fr-FR" sz="2400" i="1">
                             <a:latin typeface="Cambria Math" panose="02040503050406030204" pitchFamily="18" charset="0"/>
                           </a:rPr>
-                          <m:t>4</m:t>
-                        </m:r>
-                        <m:r>
-                          <a:rPr lang="fr-FR" sz="2400" i="1">
-                            <a:latin typeface="Cambria Math" panose="02040503050406030204" pitchFamily="18" charset="0"/>
-                          </a:rPr>
-                          <m:t>!</m:t>
+                          <m:t>4!</m:t>
                         </m:r>
                       </m:den>
                     </m:f>
@@ -30321,13 +30312,7 @@
                           <a:rPr lang="fr-FR" sz="2400" i="1">
                             <a:latin typeface="Cambria Math" panose="02040503050406030204" pitchFamily="18" charset="0"/>
                           </a:rPr>
-                          <m:t>4</m:t>
-                        </m:r>
-                        <m:r>
-                          <a:rPr lang="fr-FR" sz="2400" i="1">
-                            <a:latin typeface="Cambria Math" panose="02040503050406030204" pitchFamily="18" charset="0"/>
-                          </a:rPr>
-                          <m:t>!</m:t>
+                          <m:t>4!</m:t>
                         </m:r>
                       </m:den>
                     </m:f>
@@ -30418,7 +30403,7 @@
             </p:txBody>
           </p:sp>
         </mc:Choice>
-        <mc:Fallback xmlns="">
+        <mc:Fallback>
           <p:sp>
             <p:nvSpPr>
               <p:cNvPr id="3" name="Espace réservé du contenu 2">
@@ -30462,6 +30447,76 @@
           </p:sp>
         </mc:Fallback>
       </mc:AlternateContent>
+      <p:sp>
+        <p:nvSpPr>
+          <p:cNvPr id="4" name="ZoneTexte 3">
+            <a:extLst>
+              <a:ext uri="{FF2B5EF4-FFF2-40B4-BE49-F238E27FC236}">
+                <a16:creationId xmlns:a16="http://schemas.microsoft.com/office/drawing/2014/main" id="{E6A5FF14-066D-C8AE-EF4F-5F0D2C183AC9}"/>
+              </a:ext>
+            </a:extLst>
+          </p:cNvPr>
+          <p:cNvSpPr txBox="1"/>
+          <p:nvPr/>
+        </p:nvSpPr>
+        <p:spPr>
+          <a:xfrm>
+            <a:off x="838200" y="2634557"/>
+            <a:ext cx="1412341" cy="646331"/>
+          </a:xfrm>
+          <a:prstGeom prst="rect">
+            <a:avLst/>
+          </a:prstGeom>
+          <a:noFill/>
+        </p:spPr>
+        <p:txBody>
+          <a:bodyPr wrap="square" rtlCol="0">
+            <a:spAutoFit/>
+          </a:bodyPr>
+          <a:lstStyle/>
+          <a:p>
+            <a:r>
+              <a:rPr lang="fr-CA" dirty="0"/>
+              <a:t>Dérivée Première</a:t>
+            </a:r>
+          </a:p>
+        </p:txBody>
+      </p:sp>
+      <p:sp>
+        <p:nvSpPr>
+          <p:cNvPr id="5" name="ZoneTexte 4">
+            <a:extLst>
+              <a:ext uri="{FF2B5EF4-FFF2-40B4-BE49-F238E27FC236}">
+                <a16:creationId xmlns:a16="http://schemas.microsoft.com/office/drawing/2014/main" id="{C20C234A-069E-22E5-E6B1-F2E536A584B4}"/>
+              </a:ext>
+            </a:extLst>
+          </p:cNvPr>
+          <p:cNvSpPr txBox="1"/>
+          <p:nvPr/>
+        </p:nvSpPr>
+        <p:spPr>
+          <a:xfrm>
+            <a:off x="838199" y="4977896"/>
+            <a:ext cx="1412341" cy="646331"/>
+          </a:xfrm>
+          <a:prstGeom prst="rect">
+            <a:avLst/>
+          </a:prstGeom>
+          <a:noFill/>
+        </p:spPr>
+        <p:txBody>
+          <a:bodyPr wrap="square" rtlCol="0">
+            <a:spAutoFit/>
+          </a:bodyPr>
+          <a:lstStyle/>
+          <a:p>
+            <a:r>
+              <a:rPr lang="fr-CA" dirty="0"/>
+              <a:t>Dérivées Seconde</a:t>
+            </a:r>
+          </a:p>
+        </p:txBody>
+      </p:sp>
     </p:spTree>
     <p:extLst>
       <p:ext uri="{BB962C8B-B14F-4D97-AF65-F5344CB8AC3E}">

</xml_diff>

<commit_message>
PArtie validation presque complète
</commit_message>
<xml_diff>
--- a/projet_final/projet_final/MEC8211-Projet-final-Presentation.pptx
+++ b/projet_final/projet_final/MEC8211-Projet-final-Presentation.pptx
@@ -5,7 +5,7 @@
     <p:sldMasterId id="2147483648" r:id="rId1"/>
   </p:sldMasterIdLst>
   <p:notesMasterIdLst>
-    <p:notesMasterId r:id="rId33"/>
+    <p:notesMasterId r:id="rId34"/>
   </p:notesMasterIdLst>
   <p:sldIdLst>
     <p:sldId id="256" r:id="rId2"/>
@@ -36,9 +36,10 @@
     <p:sldId id="278" r:id="rId27"/>
     <p:sldId id="273" r:id="rId28"/>
     <p:sldId id="276" r:id="rId29"/>
-    <p:sldId id="277" r:id="rId30"/>
-    <p:sldId id="274" r:id="rId31"/>
-    <p:sldId id="279" r:id="rId32"/>
+    <p:sldId id="288" r:id="rId30"/>
+    <p:sldId id="277" r:id="rId31"/>
+    <p:sldId id="289" r:id="rId32"/>
+    <p:sldId id="274" r:id="rId33"/>
   </p:sldIdLst>
   <p:sldSz cx="12192000" cy="6858000"/>
   <p:notesSz cx="6858000" cy="9144000"/>
@@ -227,7 +228,7 @@
           <a:p>
             <a:fld id="{BB0B2023-C595-443A-8D8C-AB9DF5A28D48}" type="datetimeFigureOut">
               <a:rPr lang="fr-FR" smtClean="0"/>
-              <a:t>16/04/2026</a:t>
+              <a:t>18/04/2026</a:t>
             </a:fld>
             <a:endParaRPr lang="fr-FR"/>
           </a:p>
@@ -917,7 +918,7 @@
           <a:p>
             <a:fld id="{E29E3EF2-BB98-40F8-97FA-C4A3F82A773E}" type="datetime1">
               <a:rPr lang="fr-FR" smtClean="0"/>
-              <a:t>16/04/2026</a:t>
+              <a:t>18/04/2026</a:t>
             </a:fld>
             <a:endParaRPr lang="fr-FR"/>
           </a:p>
@@ -1115,7 +1116,7 @@
           <a:p>
             <a:fld id="{7A3D4F6E-E469-42CC-A5EB-D2CD9317FE9F}" type="datetime1">
               <a:rPr lang="fr-FR" smtClean="0"/>
-              <a:t>16/04/2026</a:t>
+              <a:t>18/04/2026</a:t>
             </a:fld>
             <a:endParaRPr lang="fr-FR"/>
           </a:p>
@@ -1323,7 +1324,7 @@
           <a:p>
             <a:fld id="{22E65B0F-6D1C-4B44-AEC8-DA6E37704C0A}" type="datetime1">
               <a:rPr lang="fr-FR" smtClean="0"/>
-              <a:t>16/04/2026</a:t>
+              <a:t>18/04/2026</a:t>
             </a:fld>
             <a:endParaRPr lang="fr-FR"/>
           </a:p>
@@ -1521,7 +1522,7 @@
           <a:p>
             <a:fld id="{A212A586-A44F-4832-86AD-F3953D03CDFD}" type="datetime1">
               <a:rPr lang="fr-FR" smtClean="0"/>
-              <a:t>16/04/2026</a:t>
+              <a:t>18/04/2026</a:t>
             </a:fld>
             <a:endParaRPr lang="fr-FR"/>
           </a:p>
@@ -1796,7 +1797,7 @@
           <a:p>
             <a:fld id="{5F8470F2-053A-49C8-975F-D66A9D98776B}" type="datetime1">
               <a:rPr lang="fr-FR" smtClean="0"/>
-              <a:t>16/04/2026</a:t>
+              <a:t>18/04/2026</a:t>
             </a:fld>
             <a:endParaRPr lang="fr-FR"/>
           </a:p>
@@ -2061,7 +2062,7 @@
           <a:p>
             <a:fld id="{E16153F4-9539-487A-AAD9-7CDB222E0065}" type="datetime1">
               <a:rPr lang="fr-FR" smtClean="0"/>
-              <a:t>16/04/2026</a:t>
+              <a:t>18/04/2026</a:t>
             </a:fld>
             <a:endParaRPr lang="fr-FR"/>
           </a:p>
@@ -2473,7 +2474,7 @@
           <a:p>
             <a:fld id="{336F1CD1-F040-4758-8097-CF709F1D3BD2}" type="datetime1">
               <a:rPr lang="fr-FR" smtClean="0"/>
-              <a:t>16/04/2026</a:t>
+              <a:t>18/04/2026</a:t>
             </a:fld>
             <a:endParaRPr lang="fr-FR"/>
           </a:p>
@@ -2614,7 +2615,7 @@
           <a:p>
             <a:fld id="{3757EA93-3E66-43EA-9968-19C091DEE6B2}" type="datetime1">
               <a:rPr lang="fr-FR" smtClean="0"/>
-              <a:t>16/04/2026</a:t>
+              <a:t>18/04/2026</a:t>
             </a:fld>
             <a:endParaRPr lang="fr-FR"/>
           </a:p>
@@ -2727,7 +2728,7 @@
           <a:p>
             <a:fld id="{780D0892-96A3-401F-9540-0D0F4005E0BA}" type="datetime1">
               <a:rPr lang="fr-FR" smtClean="0"/>
-              <a:t>16/04/2026</a:t>
+              <a:t>18/04/2026</a:t>
             </a:fld>
             <a:endParaRPr lang="fr-FR"/>
           </a:p>
@@ -3038,7 +3039,7 @@
           <a:p>
             <a:fld id="{D2E4351D-395D-4EA4-B21E-7BFE1F4E205E}" type="datetime1">
               <a:rPr lang="fr-FR" smtClean="0"/>
-              <a:t>16/04/2026</a:t>
+              <a:t>18/04/2026</a:t>
             </a:fld>
             <a:endParaRPr lang="fr-FR"/>
           </a:p>
@@ -3326,7 +3327,7 @@
           <a:p>
             <a:fld id="{EADED27B-925F-4DEA-AB38-A034A10A1BE9}" type="datetime1">
               <a:rPr lang="fr-FR" smtClean="0"/>
-              <a:t>16/04/2026</a:t>
+              <a:t>18/04/2026</a:t>
             </a:fld>
             <a:endParaRPr lang="fr-FR"/>
           </a:p>
@@ -3570,7 +3571,7 @@
           <a:p>
             <a:fld id="{FA6CD994-6CF5-4070-B12A-5121E0D5A99F}" type="datetime1">
               <a:rPr lang="fr-FR" smtClean="0"/>
-              <a:t>16/04/2026</a:t>
+              <a:t>18/04/2026</a:t>
             </a:fld>
             <a:endParaRPr lang="fr-FR"/>
           </a:p>
@@ -17561,8 +17562,8 @@
           </a:fontRef>
         </p:style>
       </p:cxnSp>
-      <mc:AlternateContent xmlns:mc="http://schemas.openxmlformats.org/markup-compatibility/2006">
-        <mc:Choice xmlns:a14="http://schemas.microsoft.com/office/drawing/2010/main" Requires="a14">
+      <mc:AlternateContent xmlns:mc="http://schemas.openxmlformats.org/markup-compatibility/2006" xmlns:a14="http://schemas.microsoft.com/office/drawing/2010/main">
+        <mc:Choice Requires="a14">
           <p:sp>
             <p:nvSpPr>
               <p:cNvPr id="58" name="TextBox 57">
@@ -17961,7 +17962,7 @@
             </p:txBody>
           </p:sp>
         </mc:Choice>
-        <mc:Fallback>
+        <mc:Fallback xmlns="">
           <p:sp>
             <p:nvSpPr>
               <p:cNvPr id="58" name="TextBox 57">
@@ -18348,7 +18349,15 @@
                 </a:r>
                 <a:r>
                   <a:rPr lang="en-US" b="1" dirty="0"/>
-                  <a:t> consistent et quasi </a:t>
+                  <a:t> </a:t>
+                </a:r>
+                <a:r>
+                  <a:rPr lang="en-US" b="1" dirty="0" err="1"/>
+                  <a:t>consistant</a:t>
+                </a:r>
+                <a:r>
+                  <a:rPr lang="en-US" b="1" dirty="0"/>
+                  <a:t> et quasi </a:t>
                 </a:r>
                 <a:r>
                   <a:rPr lang="en-US" b="1" dirty="0" err="1"/>
@@ -22443,8 +22452,8 @@
           </p:sp>
         </mc:Fallback>
       </mc:AlternateContent>
-      <mc:AlternateContent xmlns:mc="http://schemas.openxmlformats.org/markup-compatibility/2006" xmlns:a14="http://schemas.microsoft.com/office/drawing/2010/main">
-        <mc:Choice Requires="a14">
+      <mc:AlternateContent xmlns:mc="http://schemas.openxmlformats.org/markup-compatibility/2006">
+        <mc:Choice xmlns:a14="http://schemas.microsoft.com/office/drawing/2010/main" Requires="a14">
           <p:sp>
             <p:nvSpPr>
               <p:cNvPr id="3" name="Content Placeholder 2">
@@ -22463,57 +22472,35 @@
             </p:nvSpPr>
             <p:spPr>
               <a:xfrm>
-                <a:off x="838200" y="1512507"/>
+                <a:off x="838200" y="1418558"/>
                 <a:ext cx="10515600" cy="1902313"/>
               </a:xfrm>
             </p:spPr>
             <p:txBody>
               <a:bodyPr>
-                <a:normAutofit fontScale="77500" lnSpcReduction="20000"/>
+                <a:normAutofit fontScale="47500" lnSpcReduction="20000"/>
               </a:bodyPr>
               <a:lstStyle/>
               <a:p>
                 <a:r>
-                  <a:rPr lang="fr-FR" dirty="0"/>
-                  <a:t>Conductivité thermique suit une loi normale</a:t>
+                  <a:rPr lang="fr-FR" sz="3300" dirty="0"/>
+                  <a:t>Conductivité thermique du 4340 trouvé dans la littérature : </a:t>
                 </a:r>
               </a:p>
               <a:p>
-                <a:pPr marL="0" indent="0" algn="ctr">
+                <a:pPr marL="0" indent="0">
                   <a:buNone/>
                 </a:pPr>
-                <a:r>
-                  <a:rPr lang="fr-FR" dirty="0"/>
-                  <a:t> </a:t>
-                </a:r>
                 <a14:m>
                   <m:oMath xmlns:m="http://schemas.openxmlformats.org/officeDocument/2006/math">
                     <m:r>
-                      <a:rPr lang="fr-FR" b="0" i="0" smtClean="0">
+                      <a:rPr lang="fr-FR" sz="3300" b="0" i="0" smtClean="0">
                         <a:latin typeface="Cambria Math" panose="02040503050406030204" pitchFamily="18" charset="0"/>
                       </a:rPr>
-                      <m:t>𝑘</m:t>
+                      <m:t>[35,50]</m:t>
                     </m:r>
                     <m:r>
-                      <a:rPr lang="fr-FR" b="0" i="1" smtClean="0">
-                        <a:latin typeface="Cambria Math" panose="02040503050406030204" pitchFamily="18" charset="0"/>
-                      </a:rPr>
-                      <m:t> ∼</m:t>
-                    </m:r>
-                    <m:r>
-                      <a:rPr lang="fr-FR" b="0" i="1" smtClean="0">
-                        <a:latin typeface="Cambria Math" panose="02040503050406030204" pitchFamily="18" charset="0"/>
-                      </a:rPr>
-                      <m:t>𝒩</m:t>
-                    </m:r>
-                    <m:r>
-                      <a:rPr lang="fr-FR" b="0" i="1" smtClean="0">
-                        <a:latin typeface="Cambria Math" panose="02040503050406030204" pitchFamily="18" charset="0"/>
-                      </a:rPr>
-                      <m:t>(42.5,3.75) </m:t>
-                    </m:r>
-                    <m:r>
-                      <a:rPr lang="fr-FR" b="0" i="1" smtClean="0">
+                      <a:rPr lang="fr-FR" sz="3300" i="1">
                         <a:latin typeface="Cambria Math" panose="02040503050406030204" pitchFamily="18" charset="0"/>
                       </a:rPr>
                       <m:t>𝑊</m:t>
@@ -22522,25 +22509,25 @@
                       <m:rPr>
                         <m:lit/>
                       </m:rPr>
-                      <a:rPr lang="fr-FR" b="0" i="1" smtClean="0">
+                      <a:rPr lang="fr-FR" sz="3300" i="1">
                         <a:latin typeface="Cambria Math" panose="02040503050406030204" pitchFamily="18" charset="0"/>
                       </a:rPr>
                       <m:t>/</m:t>
                     </m:r>
                     <m:r>
-                      <a:rPr lang="fr-FR" b="0" i="1" smtClean="0">
+                      <a:rPr lang="fr-FR" sz="3300" i="1">
                         <a:latin typeface="Cambria Math" panose="02040503050406030204" pitchFamily="18" charset="0"/>
                       </a:rPr>
                       <m:t>(</m:t>
                     </m:r>
                     <m:r>
-                      <a:rPr lang="fr-FR" b="0" i="1" smtClean="0">
+                      <a:rPr lang="fr-FR" sz="3300" i="1">
                         <a:latin typeface="Cambria Math" panose="02040503050406030204" pitchFamily="18" charset="0"/>
                       </a:rPr>
                       <m:t>𝑚</m:t>
                     </m:r>
                     <m:r>
-                      <a:rPr lang="fr-FR" b="0" i="1" smtClean="0">
+                      <a:rPr lang="fr-FR" sz="3300" i="1">
                         <a:latin typeface="Cambria Math" panose="02040503050406030204" pitchFamily="18" charset="0"/>
                       </a:rPr>
                       <m:t>⋅</m:t>
@@ -22549,54 +22536,227 @@
                       <m:rPr>
                         <m:sty m:val="p"/>
                       </m:rPr>
-                      <a:rPr lang="fr-FR" b="0" i="1" smtClean="0">
+                      <a:rPr lang="fr-FR" sz="3300" i="1">
                         <a:latin typeface="Cambria Math" panose="02040503050406030204" pitchFamily="18" charset="0"/>
                       </a:rPr>
                       <m:t>K</m:t>
                     </m:r>
                     <m:r>
-                      <a:rPr lang="fr-FR" b="0" i="1" smtClean="0">
+                      <a:rPr lang="fr-FR" sz="3300" i="1">
                         <a:latin typeface="Cambria Math" panose="02040503050406030204" pitchFamily="18" charset="0"/>
                       </a:rPr>
                       <m:t>)</m:t>
                     </m:r>
                   </m:oMath>
                 </a14:m>
-                <a:endParaRPr lang="en-US" dirty="0"/>
+                <a:r>
+                  <a:rPr lang="fr-FR" sz="3300" dirty="0"/>
+                  <a:t> </a:t>
+                </a:r>
+                <a:r>
+                  <a:rPr lang="fr-FR" sz="3300" dirty="0">
+                    <a:sym typeface="Wingdings" panose="05000000000000000000" pitchFamily="2" charset="2"/>
+                  </a:rPr>
+                  <a:t> intervalle de confiance de 95.4% pour une loi normale </a:t>
+                </a:r>
+                <a:r>
+                  <a:rPr lang="fr-FR" sz="2900" dirty="0">
+                    <a:sym typeface="Wingdings" panose="05000000000000000000" pitchFamily="2" charset="2"/>
+                  </a:rPr>
+                  <a:t> </a:t>
+                </a:r>
+                <a:r>
+                  <a:rPr lang="fr-FR" sz="3300" dirty="0">
+                    <a:sym typeface="Wingdings" panose="05000000000000000000" pitchFamily="2" charset="2"/>
+                  </a:rPr>
+                  <a:t>déduction des paramètres de la loi :</a:t>
+                </a:r>
+                <a:endParaRPr lang="fr-FR" sz="3300" dirty="0"/>
+              </a:p>
+              <a:p>
+                <a:pPr marL="0" indent="0">
+                  <a:buNone/>
+                </a:pPr>
+                <a14:m>
+                  <m:oMathPara xmlns:m="http://schemas.openxmlformats.org/officeDocument/2006/math">
+                    <m:oMathParaPr>
+                      <m:jc m:val="centerGroup"/>
+                    </m:oMathParaPr>
+                    <m:oMath xmlns:m="http://schemas.openxmlformats.org/officeDocument/2006/math">
+                      <m:r>
+                        <a:rPr lang="fr-FR" sz="3300" b="0" i="0" smtClean="0">
+                          <a:latin typeface="Cambria Math" panose="02040503050406030204" pitchFamily="18" charset="0"/>
+                        </a:rPr>
+                        <m:t>𝑘</m:t>
+                      </m:r>
+                      <m:r>
+                        <a:rPr lang="fr-FR" sz="3300" b="0" i="1" smtClean="0">
+                          <a:latin typeface="Cambria Math" panose="02040503050406030204" pitchFamily="18" charset="0"/>
+                        </a:rPr>
+                        <m:t> ∼</m:t>
+                      </m:r>
+                      <m:r>
+                        <a:rPr lang="fr-FR" sz="3300" b="0" i="1" smtClean="0">
+                          <a:latin typeface="Cambria Math" panose="02040503050406030204" pitchFamily="18" charset="0"/>
+                        </a:rPr>
+                        <m:t>𝒩</m:t>
+                      </m:r>
+                      <m:r>
+                        <a:rPr lang="fr-FR" sz="3300" b="0" i="1" smtClean="0">
+                          <a:latin typeface="Cambria Math" panose="02040503050406030204" pitchFamily="18" charset="0"/>
+                        </a:rPr>
+                        <m:t>(42.5,3.75) </m:t>
+                      </m:r>
+                      <m:r>
+                        <a:rPr lang="fr-FR" sz="3300" b="0" i="1" smtClean="0">
+                          <a:latin typeface="Cambria Math" panose="02040503050406030204" pitchFamily="18" charset="0"/>
+                        </a:rPr>
+                        <m:t>𝑊</m:t>
+                      </m:r>
+                      <m:r>
+                        <m:rPr>
+                          <m:lit/>
+                        </m:rPr>
+                        <a:rPr lang="fr-FR" sz="3300" b="0" i="1" smtClean="0">
+                          <a:latin typeface="Cambria Math" panose="02040503050406030204" pitchFamily="18" charset="0"/>
+                        </a:rPr>
+                        <m:t>/</m:t>
+                      </m:r>
+                      <m:r>
+                        <a:rPr lang="fr-FR" sz="3300" b="0" i="1" smtClean="0">
+                          <a:latin typeface="Cambria Math" panose="02040503050406030204" pitchFamily="18" charset="0"/>
+                        </a:rPr>
+                        <m:t>(</m:t>
+                      </m:r>
+                      <m:r>
+                        <a:rPr lang="fr-FR" sz="3300" b="0" i="1" smtClean="0">
+                          <a:latin typeface="Cambria Math" panose="02040503050406030204" pitchFamily="18" charset="0"/>
+                        </a:rPr>
+                        <m:t>𝑚</m:t>
+                      </m:r>
+                      <m:r>
+                        <a:rPr lang="fr-FR" sz="3300" b="0" i="1" smtClean="0">
+                          <a:latin typeface="Cambria Math" panose="02040503050406030204" pitchFamily="18" charset="0"/>
+                        </a:rPr>
+                        <m:t>⋅</m:t>
+                      </m:r>
+                      <m:r>
+                        <m:rPr>
+                          <m:sty m:val="p"/>
+                        </m:rPr>
+                        <a:rPr lang="fr-FR" sz="3300" b="0" i="1" smtClean="0">
+                          <a:latin typeface="Cambria Math" panose="02040503050406030204" pitchFamily="18" charset="0"/>
+                        </a:rPr>
+                        <m:t>K</m:t>
+                      </m:r>
+                      <m:r>
+                        <a:rPr lang="fr-FR" sz="3300" b="0" i="1" smtClean="0">
+                          <a:latin typeface="Cambria Math" panose="02040503050406030204" pitchFamily="18" charset="0"/>
+                        </a:rPr>
+                        <m:t>)</m:t>
+                      </m:r>
+                    </m:oMath>
+                  </m:oMathPara>
+                </a14:m>
+                <a:endParaRPr lang="en-US" sz="3300" dirty="0"/>
               </a:p>
               <a:p>
                 <a:r>
-                  <a:rPr lang="en-US" dirty="0" err="1"/>
+                  <a:rPr lang="en-US" sz="3300" dirty="0" err="1"/>
                   <a:t>Emissivité</a:t>
                 </a:r>
                 <a:r>
-                  <a:rPr lang="en-US" dirty="0"/>
-                  <a:t> suit </a:t>
+                  <a:rPr lang="en-US" sz="3300" dirty="0"/>
+                  <a:t> d’un 4340 trouvé dans la </a:t>
                 </a:r>
                 <a:r>
-                  <a:rPr lang="en-US" dirty="0" err="1"/>
+                  <a:rPr lang="en-US" sz="3300" dirty="0" err="1"/>
+                  <a:t>littérature</a:t>
+                </a:r>
+                <a:r>
+                  <a:rPr lang="en-US" sz="3300" dirty="0"/>
+                  <a:t> :</a:t>
+                </a:r>
+              </a:p>
+              <a:p>
+                <a:pPr marL="0" indent="0">
+                  <a:buNone/>
+                </a:pPr>
+                <a:r>
+                  <a:rPr lang="en-US" sz="3300" dirty="0"/>
+                  <a:t>[0.15,0.9] </a:t>
+                </a:r>
+                <a:r>
+                  <a:rPr lang="en-US" sz="3300" dirty="0">
+                    <a:sym typeface="Wingdings" panose="05000000000000000000" pitchFamily="2" charset="2"/>
+                  </a:rPr>
+                  <a:t> </a:t>
+                </a:r>
+                <a:r>
+                  <a:rPr lang="en-US" sz="3300" dirty="0" err="1">
+                    <a:sym typeface="Wingdings" panose="05000000000000000000" pitchFamily="2" charset="2"/>
+                  </a:rPr>
+                  <a:t>intervalle</a:t>
+                </a:r>
+                <a:r>
+                  <a:rPr lang="en-US" sz="3300" dirty="0">
+                    <a:sym typeface="Wingdings" panose="05000000000000000000" pitchFamily="2" charset="2"/>
+                  </a:rPr>
+                  <a:t> de </a:t>
+                </a:r>
+                <a:r>
+                  <a:rPr lang="en-US" sz="3300" dirty="0" err="1">
+                    <a:sym typeface="Wingdings" panose="05000000000000000000" pitchFamily="2" charset="2"/>
+                  </a:rPr>
+                  <a:t>confiance</a:t>
+                </a:r>
+                <a:r>
+                  <a:rPr lang="en-US" sz="3300" dirty="0">
+                    <a:sym typeface="Wingdings" panose="05000000000000000000" pitchFamily="2" charset="2"/>
+                  </a:rPr>
+                  <a:t> à 95.4% pour </a:t>
+                </a:r>
+                <a:r>
+                  <a:rPr lang="en-US" sz="3300" dirty="0" err="1">
+                    <a:sym typeface="Wingdings" panose="05000000000000000000" pitchFamily="2" charset="2"/>
+                  </a:rPr>
                   <a:t>une</a:t>
                 </a:r>
                 <a:r>
-                  <a:rPr lang="en-US" dirty="0"/>
+                  <a:rPr lang="en-US" sz="3300" dirty="0">
+                    <a:sym typeface="Wingdings" panose="05000000000000000000" pitchFamily="2" charset="2"/>
+                  </a:rPr>
                   <a:t> </a:t>
                 </a:r>
                 <a:r>
-                  <a:rPr lang="en-US" dirty="0" err="1"/>
+                  <a:rPr lang="en-US" sz="3300" dirty="0" err="1"/>
                   <a:t>loi</a:t>
                 </a:r>
                 <a:r>
-                  <a:rPr lang="en-US" dirty="0"/>
+                  <a:rPr lang="en-US" sz="3300" dirty="0"/>
                   <a:t> </a:t>
                 </a:r>
                 <a:r>
-                  <a:rPr lang="en-US" dirty="0" err="1"/>
+                  <a:rPr lang="en-US" sz="3300" dirty="0" err="1"/>
                   <a:t>normale</a:t>
                 </a:r>
                 <a:r>
-                  <a:rPr lang="en-US" dirty="0"/>
+                  <a:rPr lang="en-US" sz="3300" dirty="0"/>
                   <a:t> </a:t>
                 </a:r>
+                <a:r>
+                  <a:rPr lang="fr-FR" sz="2900" dirty="0">
+                    <a:sym typeface="Wingdings" panose="05000000000000000000" pitchFamily="2" charset="2"/>
+                  </a:rPr>
+                  <a:t> </a:t>
+                </a:r>
+                <a:r>
+                  <a:rPr lang="fr-FR" sz="3300" dirty="0">
+                    <a:sym typeface="Wingdings" panose="05000000000000000000" pitchFamily="2" charset="2"/>
+                  </a:rPr>
+                  <a:t>déduction des paramètres de la loi :</a:t>
+                </a:r>
+                <a:endParaRPr lang="en-US" sz="3300" dirty="0"/>
               </a:p>
               <a:p>
                 <a:pPr marL="0" indent="0" algn="ctr">
@@ -22609,19 +22769,19 @@
                     </m:oMathParaPr>
                     <m:oMath xmlns:m="http://schemas.openxmlformats.org/officeDocument/2006/math">
                       <m:r>
-                        <a:rPr lang="fr-FR" b="0" i="1" smtClean="0">
+                        <a:rPr lang="fr-FR" sz="3300" b="0" i="1" smtClean="0">
                           <a:latin typeface="Cambria Math" panose="02040503050406030204" pitchFamily="18" charset="0"/>
                         </a:rPr>
                         <m:t>𝜀</m:t>
                       </m:r>
                       <m:r>
-                        <a:rPr lang="fr-FR" i="1">
+                        <a:rPr lang="fr-FR" sz="3300" i="1">
                           <a:latin typeface="Cambria Math" panose="02040503050406030204" pitchFamily="18" charset="0"/>
                         </a:rPr>
                         <m:t>∼</m:t>
                       </m:r>
                       <m:r>
-                        <a:rPr lang="fr-FR" i="1">
+                        <a:rPr lang="fr-FR" sz="3300" i="1">
                           <a:latin typeface="Cambria Math" panose="02040503050406030204" pitchFamily="18" charset="0"/>
                         </a:rPr>
                         <m:t>𝒩</m:t>
@@ -22629,14 +22789,14 @@
                       <m:d>
                         <m:dPr>
                           <m:ctrlPr>
-                            <a:rPr lang="fr-FR" b="0" i="1" smtClean="0">
+                            <a:rPr lang="fr-FR" sz="3300" b="0" i="1" smtClean="0">
                               <a:latin typeface="Cambria Math" panose="02040503050406030204" pitchFamily="18" charset="0"/>
                             </a:rPr>
                           </m:ctrlPr>
                         </m:dPr>
                         <m:e>
                           <m:r>
-                            <a:rPr lang="fr-FR" b="0" i="1" smtClean="0">
+                            <a:rPr lang="fr-FR" sz="3300" b="0" i="1" smtClean="0">
                               <a:latin typeface="Cambria Math" panose="02040503050406030204" pitchFamily="18" charset="0"/>
                             </a:rPr>
                             <m:t>0.525,0.19</m:t>
@@ -22646,17 +22806,17 @@
                     </m:oMath>
                   </m:oMathPara>
                 </a14:m>
-                <a:endParaRPr lang="fr-FR" b="0" dirty="0"/>
+                <a:endParaRPr lang="fr-FR" sz="3300" b="0" dirty="0"/>
               </a:p>
               <a:p>
                 <a:pPr marL="0" indent="0">
                   <a:buNone/>
                 </a:pPr>
                 <a:r>
-                  <a:rPr lang="fr-FR" dirty="0"/>
+                  <a:rPr lang="fr-FR" sz="3300" dirty="0"/>
                   <a:t>Par la méthode de Monte Carlo en travaillant sur la température moyenne de surface :</a:t>
                 </a:r>
-                <a:endParaRPr lang="fr-FR" b="0" dirty="0"/>
+                <a:endParaRPr lang="fr-FR" sz="3300" b="0" dirty="0"/>
               </a:p>
               <a:p>
                 <a:pPr marL="0" indent="0" algn="ctr">
@@ -22667,7 +22827,7 @@
             </p:txBody>
           </p:sp>
         </mc:Choice>
-        <mc:Fallback xmlns="">
+        <mc:Fallback>
           <p:sp>
             <p:nvSpPr>
               <p:cNvPr id="3" name="Content Placeholder 2">
@@ -22686,13 +22846,13 @@
             </p:nvSpPr>
             <p:spPr>
               <a:xfrm>
-                <a:off x="838200" y="1512507"/>
+                <a:off x="838200" y="1418558"/>
                 <a:ext cx="10515600" cy="1902313"/>
               </a:xfrm>
               <a:blipFill>
                 <a:blip r:embed="rId3"/>
                 <a:stretch>
-                  <a:fillRect l="-754" t="-6410"/>
+                  <a:fillRect l="-348" t="-4167" b="-4167"/>
                 </a:stretch>
               </a:blipFill>
             </p:spPr>
@@ -22733,15 +22893,15 @@
               </a:ext>
             </a:extLst>
           </a:blip>
-          <a:srcRect r="67245"/>
+          <a:srcRect t="5346" r="67245"/>
           <a:stretch>
             <a:fillRect/>
           </a:stretch>
         </p:blipFill>
         <p:spPr>
           <a:xfrm>
-            <a:off x="667378" y="3242213"/>
-            <a:ext cx="3522785" cy="3494180"/>
+            <a:off x="667378" y="3428999"/>
+            <a:ext cx="3522785" cy="3307393"/>
           </a:xfrm>
           <a:prstGeom prst="rect">
             <a:avLst/>
@@ -23002,43 +23162,115 @@
           <a:chExt cx="0" cy="0"/>
         </a:xfrm>
       </p:grpSpPr>
-      <p:sp>
-        <p:nvSpPr>
-          <p:cNvPr id="2" name="Title 1">
-            <a:extLst>
-              <a:ext uri="{FF2B5EF4-FFF2-40B4-BE49-F238E27FC236}">
-                <a16:creationId xmlns:a16="http://schemas.microsoft.com/office/drawing/2014/main" id="{B0F15578-24AA-1A1D-99B9-0FD28C04FF50}"/>
-              </a:ext>
-            </a:extLst>
-          </p:cNvPr>
-          <p:cNvSpPr>
-            <a:spLocks noGrp="1"/>
-          </p:cNvSpPr>
-          <p:nvPr>
-            <p:ph type="title"/>
-          </p:nvPr>
-        </p:nvSpPr>
-        <p:spPr/>
-        <p:txBody>
-          <a:bodyPr/>
-          <a:lstStyle/>
-          <a:p>
-            <a:r>
-              <a:rPr lang="fr-FR" dirty="0"/>
-              <a:t>Validation – erreur du modèle </a:t>
-            </a:r>
-            <a:endParaRPr lang="en-US" dirty="0"/>
-          </a:p>
-        </p:txBody>
-      </p:sp>
-      <mc:AlternateContent xmlns:mc="http://schemas.openxmlformats.org/markup-compatibility/2006" xmlns:a14="http://schemas.microsoft.com/office/drawing/2010/main">
-        <mc:Choice Requires="a14">
+      <mc:AlternateContent xmlns:mc="http://schemas.openxmlformats.org/markup-compatibility/2006">
+        <mc:Choice xmlns:a14="http://schemas.microsoft.com/office/drawing/2010/main" Requires="a14">
+          <p:sp>
+            <p:nvSpPr>
+              <p:cNvPr id="2" name="Title 1">
+                <a:extLst>
+                  <a:ext uri="{FF2B5EF4-FFF2-40B4-BE49-F238E27FC236}">
+                    <a16:creationId xmlns:a16="http://schemas.microsoft.com/office/drawing/2014/main" id="{66820A09-0F49-B31F-9AA1-11B0ABCFF4D4}"/>
+                  </a:ext>
+                </a:extLst>
+              </p:cNvPr>
+              <p:cNvSpPr>
+                <a:spLocks noGrp="1"/>
+              </p:cNvSpPr>
+              <p:nvPr>
+                <p:ph type="title"/>
+              </p:nvPr>
+            </p:nvSpPr>
+            <p:spPr/>
+            <p:txBody>
+              <a:bodyPr/>
+              <a:lstStyle/>
+              <a:p>
+                <a:r>
+                  <a:rPr lang="fr-FR" dirty="0"/>
+                  <a:t>Validation – incertitude </a:t>
+                </a:r>
+                <a14:m>
+                  <m:oMath xmlns:m="http://schemas.openxmlformats.org/officeDocument/2006/math">
+                    <m:sSub>
+                      <m:sSubPr>
+                        <m:ctrlPr>
+                          <a:rPr lang="fr-FR" i="1">
+                            <a:latin typeface="Cambria Math" panose="02040503050406030204" pitchFamily="18" charset="0"/>
+                          </a:rPr>
+                        </m:ctrlPr>
+                      </m:sSubPr>
+                      <m:e>
+                        <m:r>
+                          <a:rPr lang="fr-FR" i="1">
+                            <a:latin typeface="Cambria Math" panose="02040503050406030204" pitchFamily="18" charset="0"/>
+                          </a:rPr>
+                          <m:t>𝑢</m:t>
+                        </m:r>
+                      </m:e>
+                      <m:sub>
+                        <m:r>
+                          <a:rPr lang="fr-FR" i="1">
+                            <a:latin typeface="Cambria Math" panose="02040503050406030204" pitchFamily="18" charset="0"/>
+                          </a:rPr>
+                          <m:t>𝑖𝑛𝑝𝑢𝑡</m:t>
+                        </m:r>
+                      </m:sub>
+                    </m:sSub>
+                  </m:oMath>
+                </a14:m>
+                <a:endParaRPr lang="en-US" dirty="0"/>
+              </a:p>
+            </p:txBody>
+          </p:sp>
+        </mc:Choice>
+        <mc:Fallback>
+          <p:sp>
+            <p:nvSpPr>
+              <p:cNvPr id="2" name="Title 1">
+                <a:extLst>
+                  <a:ext uri="{FF2B5EF4-FFF2-40B4-BE49-F238E27FC236}">
+                    <a16:creationId xmlns:a16="http://schemas.microsoft.com/office/drawing/2014/main" id="{66820A09-0F49-B31F-9AA1-11B0ABCFF4D4}"/>
+                  </a:ext>
+                </a:extLst>
+              </p:cNvPr>
+              <p:cNvSpPr>
+                <a:spLocks noGrp="1" noRot="1" noChangeAspect="1" noMove="1" noResize="1" noEditPoints="1" noAdjustHandles="1" noChangeArrowheads="1" noChangeShapeType="1" noTextEdit="1"/>
+              </p:cNvSpPr>
+              <p:nvPr>
+                <p:ph type="title"/>
+              </p:nvPr>
+            </p:nvSpPr>
+            <p:spPr>
+              <a:blipFill>
+                <a:blip r:embed="rId2"/>
+                <a:stretch>
+                  <a:fillRect l="-2377"/>
+                </a:stretch>
+              </a:blipFill>
+            </p:spPr>
+            <p:txBody>
+              <a:bodyPr/>
+              <a:lstStyle/>
+              <a:p>
+                <a:r>
+                  <a:rPr lang="en-US">
+                    <a:noFill/>
+                  </a:rPr>
+                  <a:t> </a:t>
+                </a:r>
+              </a:p>
+            </p:txBody>
+          </p:sp>
+        </mc:Fallback>
+      </mc:AlternateContent>
+      <mc:AlternateContent xmlns:mc="http://schemas.openxmlformats.org/markup-compatibility/2006">
+        <mc:Choice xmlns:a14="http://schemas.microsoft.com/office/drawing/2010/main" Requires="a14">
           <p:sp>
             <p:nvSpPr>
               <p:cNvPr id="3" name="Content Placeholder 2">
                 <a:extLst>
                   <a:ext uri="{FF2B5EF4-FFF2-40B4-BE49-F238E27FC236}">
-                    <a16:creationId xmlns:a16="http://schemas.microsoft.com/office/drawing/2014/main" id="{41DABA39-902C-A6ED-B4EF-7E3705D66722}"/>
+                    <a16:creationId xmlns:a16="http://schemas.microsoft.com/office/drawing/2014/main" id="{7BB71198-7608-579F-B3DD-7C7CBD28912F}"/>
                   </a:ext>
                 </a:extLst>
               </p:cNvPr>
@@ -23051,165 +23283,33 @@
             </p:nvSpPr>
             <p:spPr>
               <a:xfrm>
-                <a:off x="838200" y="1855122"/>
-                <a:ext cx="10515600" cy="4351338"/>
+                <a:off x="838200" y="1825625"/>
+                <a:ext cx="10515600" cy="1462085"/>
               </a:xfrm>
             </p:spPr>
             <p:txBody>
-              <a:bodyPr/>
+              <a:bodyPr>
+                <a:normAutofit fontScale="92500"/>
+              </a:bodyPr>
               <a:lstStyle/>
               <a:p>
-                <a14:m>
-                  <m:oMath xmlns:m="http://schemas.openxmlformats.org/officeDocument/2006/math">
-                    <m:r>
-                      <a:rPr lang="fr-FR" i="1">
-                        <a:latin typeface="Cambria Math" panose="02040503050406030204" pitchFamily="18" charset="0"/>
-                      </a:rPr>
-                      <m:t>𝐸</m:t>
-                    </m:r>
-                    <m:r>
-                      <a:rPr lang="fr-FR" i="1">
-                        <a:latin typeface="Cambria Math" panose="02040503050406030204" pitchFamily="18" charset="0"/>
-                      </a:rPr>
-                      <m:t>−</m:t>
-                    </m:r>
-                    <m:r>
-                      <a:rPr lang="fr-FR" i="1">
-                        <a:latin typeface="Cambria Math" panose="02040503050406030204" pitchFamily="18" charset="0"/>
-                      </a:rPr>
-                      <m:t>𝑘</m:t>
-                    </m:r>
-                    <m:sSub>
-                      <m:sSubPr>
-                        <m:ctrlPr>
-                          <a:rPr lang="fr-FR" i="1">
-                            <a:latin typeface="Cambria Math" panose="02040503050406030204" pitchFamily="18" charset="0"/>
-                          </a:rPr>
-                        </m:ctrlPr>
-                      </m:sSubPr>
-                      <m:e>
-                        <m:r>
-                          <a:rPr lang="fr-FR" i="1">
-                            <a:latin typeface="Cambria Math" panose="02040503050406030204" pitchFamily="18" charset="0"/>
-                          </a:rPr>
-                          <m:t>𝑢</m:t>
-                        </m:r>
-                      </m:e>
-                      <m:sub>
-                        <m:r>
-                          <a:rPr lang="fr-FR" i="1">
-                            <a:latin typeface="Cambria Math" panose="02040503050406030204" pitchFamily="18" charset="0"/>
-                          </a:rPr>
-                          <m:t>𝑣𝑎𝑙</m:t>
-                        </m:r>
-                      </m:sub>
-                    </m:sSub>
-                    <m:r>
-                      <a:rPr lang="fr-FR" i="1">
-                        <a:latin typeface="Cambria Math" panose="02040503050406030204" pitchFamily="18" charset="0"/>
-                      </a:rPr>
-                      <m:t>≤</m:t>
-                    </m:r>
-                    <m:sSub>
-                      <m:sSubPr>
-                        <m:ctrlPr>
-                          <a:rPr lang="fr-FR" i="1">
-                            <a:latin typeface="Cambria Math" panose="02040503050406030204" pitchFamily="18" charset="0"/>
-                          </a:rPr>
-                        </m:ctrlPr>
-                      </m:sSubPr>
-                      <m:e>
-                        <m:r>
-                          <a:rPr lang="fr-FR" i="1">
-                            <a:latin typeface="Cambria Math" panose="02040503050406030204" pitchFamily="18" charset="0"/>
-                          </a:rPr>
-                          <m:t>𝛿</m:t>
-                        </m:r>
-                      </m:e>
-                      <m:sub>
-                        <m:r>
-                          <a:rPr lang="fr-FR" i="1">
-                            <a:latin typeface="Cambria Math" panose="02040503050406030204" pitchFamily="18" charset="0"/>
-                          </a:rPr>
-                          <m:t>𝑚𝑜𝑑𝑒𝑙</m:t>
-                        </m:r>
-                      </m:sub>
-                    </m:sSub>
-                    <m:r>
-                      <a:rPr lang="fr-FR" i="1">
-                        <a:latin typeface="Cambria Math" panose="02040503050406030204" pitchFamily="18" charset="0"/>
-                      </a:rPr>
-                      <m:t>≤</m:t>
-                    </m:r>
-                    <m:r>
-                      <a:rPr lang="fr-FR" i="1">
-                        <a:latin typeface="Cambria Math" panose="02040503050406030204" pitchFamily="18" charset="0"/>
-                      </a:rPr>
-                      <m:t>𝐸</m:t>
-                    </m:r>
-                    <m:r>
-                      <a:rPr lang="fr-FR" i="1">
-                        <a:latin typeface="Cambria Math" panose="02040503050406030204" pitchFamily="18" charset="0"/>
-                      </a:rPr>
-                      <m:t>+</m:t>
-                    </m:r>
-                    <m:r>
-                      <a:rPr lang="fr-FR" i="1">
-                        <a:latin typeface="Cambria Math" panose="02040503050406030204" pitchFamily="18" charset="0"/>
-                      </a:rPr>
-                      <m:t>𝑘</m:t>
-                    </m:r>
-                    <m:sSub>
-                      <m:sSubPr>
-                        <m:ctrlPr>
-                          <a:rPr lang="fr-FR" i="1">
-                            <a:latin typeface="Cambria Math" panose="02040503050406030204" pitchFamily="18" charset="0"/>
-                          </a:rPr>
-                        </m:ctrlPr>
-                      </m:sSubPr>
-                      <m:e>
-                        <m:r>
-                          <a:rPr lang="fr-FR" i="1">
-                            <a:latin typeface="Cambria Math" panose="02040503050406030204" pitchFamily="18" charset="0"/>
-                          </a:rPr>
-                          <m:t>𝑢</m:t>
-                        </m:r>
-                      </m:e>
-                      <m:sub>
-                        <m:r>
-                          <a:rPr lang="fr-FR" i="1">
-                            <a:latin typeface="Cambria Math" panose="02040503050406030204" pitchFamily="18" charset="0"/>
-                          </a:rPr>
-                          <m:t>𝑣𝑎𝑙</m:t>
-                        </m:r>
-                      </m:sub>
-                    </m:sSub>
-                  </m:oMath>
-                </a14:m>
-                <a:endParaRPr lang="fr-FR" dirty="0"/>
-              </a:p>
-              <a:p>
                 <a:r>
-                  <a:rPr lang="en-US" dirty="0" err="1"/>
-                  <a:t>Où</a:t>
-                </a:r>
-                <a:r>
-                  <a:rPr lang="en-US" dirty="0"/>
-                  <a:t> </a:t>
+                  <a:rPr lang="fr-FR" dirty="0"/>
+                  <a:t>Par une méthode moins conservatrice en considérant les intervalles des valeurs trouvé dans la littérature comme des intervalles de confiance à 99% il est possible de réduire considérablement </a:t>
                 </a:r>
                 <a14:m>
                   <m:oMath xmlns:m="http://schemas.openxmlformats.org/officeDocument/2006/math">
                     <m:sSub>
                       <m:sSubPr>
                         <m:ctrlPr>
-                          <a:rPr lang="fr-FR" b="0" i="1" smtClean="0">
+                          <a:rPr lang="fr-FR" i="1">
                             <a:latin typeface="Cambria Math" panose="02040503050406030204" pitchFamily="18" charset="0"/>
                           </a:rPr>
                         </m:ctrlPr>
                       </m:sSubPr>
                       <m:e>
                         <m:r>
-                          <a:rPr lang="fr-FR" b="0" i="1" smtClean="0">
+                          <a:rPr lang="fr-FR" i="1">
                             <a:latin typeface="Cambria Math" panose="02040503050406030204" pitchFamily="18" charset="0"/>
                           </a:rPr>
                           <m:t>𝑢</m:t>
@@ -23217,375 +23317,27 @@
                       </m:e>
                       <m:sub>
                         <m:r>
-                          <a:rPr lang="fr-FR" b="0" i="1" smtClean="0">
-                            <a:latin typeface="Cambria Math" panose="02040503050406030204" pitchFamily="18" charset="0"/>
-                          </a:rPr>
-                          <m:t>𝑣𝑎𝑙</m:t>
+                          <a:rPr lang="fr-FR" i="1">
+                            <a:latin typeface="Cambria Math" panose="02040503050406030204" pitchFamily="18" charset="0"/>
+                          </a:rPr>
+                          <m:t>𝑖𝑛𝑝𝑢𝑡</m:t>
                         </m:r>
                       </m:sub>
                     </m:sSub>
-                    <m:r>
-                      <a:rPr lang="fr-FR" b="0" i="1" smtClean="0">
-                        <a:latin typeface="Cambria Math" panose="02040503050406030204" pitchFamily="18" charset="0"/>
-                      </a:rPr>
-                      <m:t>= </m:t>
-                    </m:r>
-                    <m:rad>
-                      <m:radPr>
-                        <m:degHide m:val="on"/>
-                        <m:ctrlPr>
-                          <a:rPr lang="fr-FR" b="0" i="1" smtClean="0">
-                            <a:latin typeface="Cambria Math" panose="02040503050406030204" pitchFamily="18" charset="0"/>
-                          </a:rPr>
-                        </m:ctrlPr>
-                      </m:radPr>
-                      <m:deg/>
-                      <m:e>
-                        <m:sSup>
-                          <m:sSupPr>
-                            <m:ctrlPr>
-                              <a:rPr lang="fr-FR" b="0" i="1" smtClean="0">
-                                <a:latin typeface="Cambria Math" panose="02040503050406030204" pitchFamily="18" charset="0"/>
-                              </a:rPr>
-                            </m:ctrlPr>
-                          </m:sSupPr>
-                          <m:e>
-                            <m:r>
-                              <a:rPr lang="fr-FR" b="0" i="1" smtClean="0">
-                                <a:latin typeface="Cambria Math" panose="02040503050406030204" pitchFamily="18" charset="0"/>
-                              </a:rPr>
-                              <m:t>0.87</m:t>
-                            </m:r>
-                          </m:e>
-                          <m:sup>
-                            <m:r>
-                              <a:rPr lang="fr-FR" b="0" i="1" smtClean="0">
-                                <a:latin typeface="Cambria Math" panose="02040503050406030204" pitchFamily="18" charset="0"/>
-                              </a:rPr>
-                              <m:t>2</m:t>
-                            </m:r>
-                          </m:sup>
-                        </m:sSup>
-                        <m:r>
-                          <a:rPr lang="fr-FR" b="0" i="1" smtClean="0">
-                            <a:latin typeface="Cambria Math" panose="02040503050406030204" pitchFamily="18" charset="0"/>
-                          </a:rPr>
-                          <m:t>+</m:t>
-                        </m:r>
-                        <m:sSup>
-                          <m:sSupPr>
-                            <m:ctrlPr>
-                              <a:rPr lang="fr-FR" b="0" i="1" smtClean="0">
-                                <a:latin typeface="Cambria Math" panose="02040503050406030204" pitchFamily="18" charset="0"/>
-                              </a:rPr>
-                            </m:ctrlPr>
-                          </m:sSupPr>
-                          <m:e>
-                            <m:r>
-                              <a:rPr lang="fr-FR" b="0" i="1" smtClean="0">
-                                <a:latin typeface="Cambria Math" panose="02040503050406030204" pitchFamily="18" charset="0"/>
-                              </a:rPr>
-                              <m:t>44.91</m:t>
-                            </m:r>
-                          </m:e>
-                          <m:sup>
-                            <m:r>
-                              <a:rPr lang="fr-FR" b="0" i="1" smtClean="0">
-                                <a:latin typeface="Cambria Math" panose="02040503050406030204" pitchFamily="18" charset="0"/>
-                              </a:rPr>
-                              <m:t>2</m:t>
-                            </m:r>
-                          </m:sup>
-                        </m:sSup>
-                        <m:r>
-                          <a:rPr lang="fr-FR" b="0" i="1" smtClean="0">
-                            <a:latin typeface="Cambria Math" panose="02040503050406030204" pitchFamily="18" charset="0"/>
-                          </a:rPr>
-                          <m:t>+</m:t>
-                        </m:r>
-                        <m:sSup>
-                          <m:sSupPr>
-                            <m:ctrlPr>
-                              <a:rPr lang="fr-FR" i="1">
-                                <a:latin typeface="Cambria Math" panose="02040503050406030204" pitchFamily="18" charset="0"/>
-                                <a:sym typeface="Wingdings" panose="05000000000000000000" pitchFamily="2" charset="2"/>
-                              </a:rPr>
-                            </m:ctrlPr>
-                          </m:sSupPr>
-                          <m:e>
-                            <m:r>
-                              <a:rPr lang="fr-FR" b="0" i="1" smtClean="0">
-                                <a:latin typeface="Cambria Math" panose="02040503050406030204" pitchFamily="18" charset="0"/>
-                                <a:sym typeface="Wingdings" panose="05000000000000000000" pitchFamily="2" charset="2"/>
-                              </a:rPr>
-                              <m:t>(</m:t>
-                            </m:r>
-                            <m:r>
-                              <a:rPr lang="fr-FR" i="1">
-                                <a:latin typeface="Cambria Math" panose="02040503050406030204" pitchFamily="18" charset="0"/>
-                                <a:sym typeface="Wingdings" panose="05000000000000000000" pitchFamily="2" charset="2"/>
-                              </a:rPr>
-                              <m:t>1,1</m:t>
-                            </m:r>
-                            <m:r>
-                              <a:rPr lang="fr-FR" b="0" i="1" smtClean="0">
-                                <a:latin typeface="Cambria Math" panose="02040503050406030204" pitchFamily="18" charset="0"/>
-                                <a:sym typeface="Wingdings" panose="05000000000000000000" pitchFamily="2" charset="2"/>
-                              </a:rPr>
-                              <m:t>1</m:t>
-                            </m:r>
-                            <m:r>
-                              <a:rPr lang="fr-FR" i="1">
-                                <a:latin typeface="Cambria Math" panose="02040503050406030204" pitchFamily="18" charset="0"/>
-                                <a:sym typeface="Wingdings" panose="05000000000000000000" pitchFamily="2" charset="2"/>
-                              </a:rPr>
-                              <m:t>×10</m:t>
-                            </m:r>
-                          </m:e>
-                          <m:sup>
-                            <m:r>
-                              <a:rPr lang="fr-FR" i="1">
-                                <a:latin typeface="Cambria Math" panose="02040503050406030204" pitchFamily="18" charset="0"/>
-                                <a:sym typeface="Wingdings" panose="05000000000000000000" pitchFamily="2" charset="2"/>
-                              </a:rPr>
-                              <m:t>−3</m:t>
-                            </m:r>
-                          </m:sup>
-                        </m:sSup>
-                        <m:r>
-                          <a:rPr lang="fr-FR" b="0" i="1" smtClean="0">
-                            <a:latin typeface="Cambria Math" panose="02040503050406030204" pitchFamily="18" charset="0"/>
-                            <a:sym typeface="Wingdings" panose="05000000000000000000" pitchFamily="2" charset="2"/>
-                          </a:rPr>
-                          <m:t>)²</m:t>
-                        </m:r>
-                      </m:e>
-                    </m:rad>
-                    <m:r>
-                      <a:rPr lang="fr-FR" b="0" i="1" smtClean="0">
-                        <a:latin typeface="Cambria Math" panose="02040503050406030204" pitchFamily="18" charset="0"/>
-                      </a:rPr>
-                      <m:t>= 44.92 </m:t>
-                    </m:r>
-                    <m:r>
-                      <m:rPr>
-                        <m:sty m:val="p"/>
-                      </m:rPr>
-                      <a:rPr lang="fr-FR" b="0" i="1" smtClean="0">
-                        <a:latin typeface="Cambria Math" panose="02040503050406030204" pitchFamily="18" charset="0"/>
-                      </a:rPr>
-                      <m:t>K</m:t>
-                    </m:r>
                   </m:oMath>
                 </a14:m>
-                <a:r>
-                  <a:rPr lang="en-US" dirty="0"/>
-                  <a:t>   </a:t>
-                </a:r>
-              </a:p>
-              <a:p>
-                <a:r>
-                  <a:rPr lang="en-US" dirty="0"/>
-                  <a:t>k =2 pour 95.4% de </a:t>
-                </a:r>
-                <a:r>
-                  <a:rPr lang="en-US" dirty="0" err="1"/>
-                  <a:t>confiance</a:t>
-                </a:r>
-                <a:r>
-                  <a:rPr lang="en-US" dirty="0"/>
-                  <a:t> </a:t>
-                </a:r>
-              </a:p>
-              <a:p>
                 <a:endParaRPr lang="en-US" dirty="0"/>
-              </a:p>
-              <a:p>
-                <a:pPr marL="0" indent="0">
-                  <a:buNone/>
-                </a:pPr>
-                <a14:m>
-                  <m:oMath xmlns:m="http://schemas.openxmlformats.org/officeDocument/2006/math">
-                    <m:r>
-                      <a:rPr lang="fr-FR" b="1" i="0" smtClean="0">
-                        <a:latin typeface="Cambria Math" panose="02040503050406030204" pitchFamily="18" charset="0"/>
-                      </a:rPr>
-                      <m:t>−</m:t>
-                    </m:r>
-                    <m:r>
-                      <a:rPr lang="fr-FR" b="1" i="0" smtClean="0">
-                        <a:latin typeface="Cambria Math" panose="02040503050406030204" pitchFamily="18" charset="0"/>
-                      </a:rPr>
-                      <m:t>𝟕𝟖</m:t>
-                    </m:r>
-                    <m:r>
-                      <a:rPr lang="fr-FR" b="1" i="0" smtClean="0">
-                        <a:latin typeface="Cambria Math" panose="02040503050406030204" pitchFamily="18" charset="0"/>
-                      </a:rPr>
-                      <m:t>.</m:t>
-                    </m:r>
-                    <m:r>
-                      <a:rPr lang="fr-FR" b="1" i="0" smtClean="0">
-                        <a:latin typeface="Cambria Math" panose="02040503050406030204" pitchFamily="18" charset="0"/>
-                      </a:rPr>
-                      <m:t>𝟎𝟒</m:t>
-                    </m:r>
-                    <m:r>
-                      <a:rPr lang="fr-FR" b="1" i="0" smtClean="0">
-                        <a:latin typeface="Cambria Math" panose="02040503050406030204" pitchFamily="18" charset="0"/>
-                      </a:rPr>
-                      <m:t> </m:t>
-                    </m:r>
-                    <m:r>
-                      <a:rPr lang="fr-FR" b="1" i="0" smtClean="0">
-                        <a:latin typeface="Cambria Math" panose="02040503050406030204" pitchFamily="18" charset="0"/>
-                      </a:rPr>
-                      <m:t>𝐊</m:t>
-                    </m:r>
-                    <m:r>
-                      <a:rPr lang="fr-FR" b="1" i="0" smtClean="0">
-                        <a:latin typeface="Cambria Math" panose="02040503050406030204" pitchFamily="18" charset="0"/>
-                      </a:rPr>
-                      <m:t>&lt;</m:t>
-                    </m:r>
-                    <m:sSub>
-                      <m:sSubPr>
-                        <m:ctrlPr>
-                          <a:rPr lang="fr-FR" b="1" i="1">
-                            <a:latin typeface="Cambria Math" panose="02040503050406030204" pitchFamily="18" charset="0"/>
-                          </a:rPr>
-                        </m:ctrlPr>
-                      </m:sSubPr>
-                      <m:e>
-                        <m:r>
-                          <a:rPr lang="fr-FR" b="1" i="0">
-                            <a:latin typeface="Cambria Math" panose="02040503050406030204" pitchFamily="18" charset="0"/>
-                          </a:rPr>
-                          <m:t>𝛅</m:t>
-                        </m:r>
-                      </m:e>
-                      <m:sub>
-                        <m:r>
-                          <a:rPr lang="fr-FR" b="1" i="0">
-                            <a:latin typeface="Cambria Math" panose="02040503050406030204" pitchFamily="18" charset="0"/>
-                          </a:rPr>
-                          <m:t>𝐦𝐨𝐝𝐞𝐥</m:t>
-                        </m:r>
-                      </m:sub>
-                    </m:sSub>
-                    <m:r>
-                      <a:rPr lang="fr-FR" b="1" i="0" smtClean="0">
-                        <a:latin typeface="Cambria Math" panose="02040503050406030204" pitchFamily="18" charset="0"/>
-                      </a:rPr>
-                      <m:t> &lt;</m:t>
-                    </m:r>
-                    <m:r>
-                      <a:rPr lang="fr-FR" b="1" i="0" smtClean="0">
-                        <a:latin typeface="Cambria Math" panose="02040503050406030204" pitchFamily="18" charset="0"/>
-                      </a:rPr>
-                      <m:t>𝟏𝟎𝟏</m:t>
-                    </m:r>
-                    <m:r>
-                      <a:rPr lang="fr-FR" b="1" i="0" smtClean="0">
-                        <a:latin typeface="Cambria Math" panose="02040503050406030204" pitchFamily="18" charset="0"/>
-                      </a:rPr>
-                      <m:t>.</m:t>
-                    </m:r>
-                    <m:r>
-                      <a:rPr lang="fr-FR" b="1" i="0" smtClean="0">
-                        <a:latin typeface="Cambria Math" panose="02040503050406030204" pitchFamily="18" charset="0"/>
-                      </a:rPr>
-                      <m:t>𝟔𝟒</m:t>
-                    </m:r>
-                    <m:r>
-                      <a:rPr lang="fr-FR" b="1" i="0" smtClean="0">
-                        <a:latin typeface="Cambria Math" panose="02040503050406030204" pitchFamily="18" charset="0"/>
-                      </a:rPr>
-                      <m:t> </m:t>
-                    </m:r>
-                    <m:r>
-                      <a:rPr lang="fr-FR" b="1" i="0" smtClean="0">
-                        <a:latin typeface="Cambria Math" panose="02040503050406030204" pitchFamily="18" charset="0"/>
-                      </a:rPr>
-                      <m:t>𝐊</m:t>
-                    </m:r>
-                  </m:oMath>
-                </a14:m>
-                <a:r>
-                  <a:rPr lang="en-US" b="1" dirty="0"/>
-                  <a:t> </a:t>
-                </a:r>
-              </a:p>
-              <a:p>
-                <a:pPr marL="0" indent="0">
-                  <a:buNone/>
-                </a:pPr>
-                <a:endParaRPr lang="en-US" b="1" dirty="0"/>
-              </a:p>
-              <a:p>
-                <a:pPr marL="0" indent="0">
-                  <a:buNone/>
-                </a:pPr>
-                <a14:m>
-                  <m:oMath xmlns:m="http://schemas.openxmlformats.org/officeDocument/2006/math">
-                    <m:r>
-                      <a:rPr lang="en-US" b="1" i="1" smtClean="0">
-                        <a:latin typeface="Cambria Math" panose="02040503050406030204" pitchFamily="18" charset="0"/>
-                      </a:rPr>
-                      <m:t>⇒</m:t>
-                    </m:r>
-                    <m:r>
-                      <a:rPr lang="fr-FR" b="1" i="1" smtClean="0">
-                        <a:latin typeface="Cambria Math" panose="02040503050406030204" pitchFamily="18" charset="0"/>
-                      </a:rPr>
-                      <m:t> </m:t>
-                    </m:r>
-                  </m:oMath>
-                </a14:m>
-                <a:r>
-                  <a:rPr lang="en-US" b="1" dirty="0"/>
-                  <a:t> </a:t>
-                </a:r>
-                <a:r>
-                  <a:rPr lang="en-US" b="1" dirty="0" err="1"/>
-                  <a:t>Amélioration</a:t>
-                </a:r>
-                <a:r>
-                  <a:rPr lang="en-US" b="1" dirty="0"/>
-                  <a:t> sur </a:t>
-                </a:r>
-                <a:r>
-                  <a:rPr lang="en-US" b="1" dirty="0" err="1"/>
-                  <a:t>l’incertitude</a:t>
-                </a:r>
-                <a:r>
-                  <a:rPr lang="en-US" b="1" dirty="0"/>
-                  <a:t> de </a:t>
-                </a:r>
-                <a:r>
-                  <a:rPr lang="en-US" b="1" dirty="0" err="1"/>
-                  <a:t>l’émissivité</a:t>
-                </a:r>
-                <a:r>
-                  <a:rPr lang="en-US" b="1" dirty="0"/>
-                  <a:t> </a:t>
-                </a:r>
-                <a:r>
-                  <a:rPr lang="en-US" b="1" dirty="0" err="1"/>
-                  <a:t>nécessaire</a:t>
-                </a:r>
-                <a:endParaRPr lang="en-US" b="1" dirty="0"/>
               </a:p>
             </p:txBody>
           </p:sp>
         </mc:Choice>
-        <mc:Fallback xmlns="">
+        <mc:Fallback>
           <p:sp>
             <p:nvSpPr>
               <p:cNvPr id="3" name="Content Placeholder 2">
                 <a:extLst>
                   <a:ext uri="{FF2B5EF4-FFF2-40B4-BE49-F238E27FC236}">
-                    <a16:creationId xmlns:a16="http://schemas.microsoft.com/office/drawing/2014/main" id="{41DABA39-902C-A6ED-B4EF-7E3705D66722}"/>
+                    <a16:creationId xmlns:a16="http://schemas.microsoft.com/office/drawing/2014/main" id="{7BB71198-7608-579F-B3DD-7C7CBD28912F}"/>
                   </a:ext>
                 </a:extLst>
               </p:cNvPr>
@@ -23598,13 +23350,13 @@
             </p:nvSpPr>
             <p:spPr>
               <a:xfrm>
-                <a:off x="838200" y="1855122"/>
-                <a:ext cx="10515600" cy="4351338"/>
+                <a:off x="838200" y="1825625"/>
+                <a:ext cx="10515600" cy="1462085"/>
               </a:xfrm>
               <a:blipFill>
-                <a:blip r:embed="rId2"/>
+                <a:blip r:embed="rId3"/>
                 <a:stretch>
-                  <a:fillRect l="-1043"/>
+                  <a:fillRect l="-928" t="-6250"/>
                 </a:stretch>
               </a:blipFill>
             </p:spPr>
@@ -23625,187 +23377,10 @@
       </mc:AlternateContent>
       <p:sp>
         <p:nvSpPr>
-          <p:cNvPr id="4" name="Rectangle 3">
+          <p:cNvPr id="4" name="Slide Number Placeholder 3">
             <a:extLst>
               <a:ext uri="{FF2B5EF4-FFF2-40B4-BE49-F238E27FC236}">
-                <a16:creationId xmlns:a16="http://schemas.microsoft.com/office/drawing/2014/main" id="{806A440F-4525-4755-9716-F3DDCC775AB6}"/>
-              </a:ext>
-            </a:extLst>
-          </p:cNvPr>
-          <p:cNvSpPr/>
-          <p:nvPr/>
-        </p:nvSpPr>
-        <p:spPr>
-          <a:xfrm>
-            <a:off x="838200" y="3932141"/>
-            <a:ext cx="5312780" cy="488220"/>
-          </a:xfrm>
-          <a:prstGeom prst="rect">
-            <a:avLst/>
-          </a:prstGeom>
-          <a:noFill/>
-          <a:ln w="28575">
-            <a:solidFill>
-              <a:schemeClr val="tx1"/>
-            </a:solidFill>
-          </a:ln>
-        </p:spPr>
-        <p:style>
-          <a:lnRef idx="2">
-            <a:schemeClr val="accent1">
-              <a:shade val="15000"/>
-            </a:schemeClr>
-          </a:lnRef>
-          <a:fillRef idx="1">
-            <a:schemeClr val="accent1"/>
-          </a:fillRef>
-          <a:effectRef idx="0">
-            <a:schemeClr val="accent1"/>
-          </a:effectRef>
-          <a:fontRef idx="minor">
-            <a:schemeClr val="lt1"/>
-          </a:fontRef>
-        </p:style>
-        <p:txBody>
-          <a:bodyPr rtlCol="0" anchor="ctr"/>
-          <a:lstStyle>
-            <a:defPPr>
-              <a:defRPr lang="fr-FR"/>
-            </a:defPPr>
-            <a:lvl1pPr marL="0" algn="l" defTabSz="914400" rtl="0" eaLnBrk="1" latinLnBrk="0" hangingPunct="1">
-              <a:defRPr sz="1800" kern="1200">
-                <a:solidFill>
-                  <a:schemeClr val="lt1"/>
-                </a:solidFill>
-                <a:latin typeface="+mn-lt"/>
-                <a:ea typeface="+mn-ea"/>
-                <a:cs typeface="+mn-cs"/>
-              </a:defRPr>
-            </a:lvl1pPr>
-            <a:lvl2pPr marL="457200" algn="l" defTabSz="914400" rtl="0" eaLnBrk="1" latinLnBrk="0" hangingPunct="1">
-              <a:defRPr sz="1800" kern="1200">
-                <a:solidFill>
-                  <a:schemeClr val="lt1"/>
-                </a:solidFill>
-                <a:latin typeface="+mn-lt"/>
-                <a:ea typeface="+mn-ea"/>
-                <a:cs typeface="+mn-cs"/>
-              </a:defRPr>
-            </a:lvl2pPr>
-            <a:lvl3pPr marL="914400" algn="l" defTabSz="914400" rtl="0" eaLnBrk="1" latinLnBrk="0" hangingPunct="1">
-              <a:defRPr sz="1800" kern="1200">
-                <a:solidFill>
-                  <a:schemeClr val="lt1"/>
-                </a:solidFill>
-                <a:latin typeface="+mn-lt"/>
-                <a:ea typeface="+mn-ea"/>
-                <a:cs typeface="+mn-cs"/>
-              </a:defRPr>
-            </a:lvl3pPr>
-            <a:lvl4pPr marL="1371600" algn="l" defTabSz="914400" rtl="0" eaLnBrk="1" latinLnBrk="0" hangingPunct="1">
-              <a:defRPr sz="1800" kern="1200">
-                <a:solidFill>
-                  <a:schemeClr val="lt1"/>
-                </a:solidFill>
-                <a:latin typeface="+mn-lt"/>
-                <a:ea typeface="+mn-ea"/>
-                <a:cs typeface="+mn-cs"/>
-              </a:defRPr>
-            </a:lvl4pPr>
-            <a:lvl5pPr marL="1828800" algn="l" defTabSz="914400" rtl="0" eaLnBrk="1" latinLnBrk="0" hangingPunct="1">
-              <a:defRPr sz="1800" kern="1200">
-                <a:solidFill>
-                  <a:schemeClr val="lt1"/>
-                </a:solidFill>
-                <a:latin typeface="+mn-lt"/>
-                <a:ea typeface="+mn-ea"/>
-                <a:cs typeface="+mn-cs"/>
-              </a:defRPr>
-            </a:lvl5pPr>
-            <a:lvl6pPr marL="2286000" algn="l" defTabSz="914400" rtl="0" eaLnBrk="1" latinLnBrk="0" hangingPunct="1">
-              <a:defRPr sz="1800" kern="1200">
-                <a:solidFill>
-                  <a:schemeClr val="lt1"/>
-                </a:solidFill>
-                <a:latin typeface="+mn-lt"/>
-                <a:ea typeface="+mn-ea"/>
-                <a:cs typeface="+mn-cs"/>
-              </a:defRPr>
-            </a:lvl6pPr>
-            <a:lvl7pPr marL="2743200" algn="l" defTabSz="914400" rtl="0" eaLnBrk="1" latinLnBrk="0" hangingPunct="1">
-              <a:defRPr sz="1800" kern="1200">
-                <a:solidFill>
-                  <a:schemeClr val="lt1"/>
-                </a:solidFill>
-                <a:latin typeface="+mn-lt"/>
-                <a:ea typeface="+mn-ea"/>
-                <a:cs typeface="+mn-cs"/>
-              </a:defRPr>
-            </a:lvl7pPr>
-            <a:lvl8pPr marL="3200400" algn="l" defTabSz="914400" rtl="0" eaLnBrk="1" latinLnBrk="0" hangingPunct="1">
-              <a:defRPr sz="1800" kern="1200">
-                <a:solidFill>
-                  <a:schemeClr val="lt1"/>
-                </a:solidFill>
-                <a:latin typeface="+mn-lt"/>
-                <a:ea typeface="+mn-ea"/>
-                <a:cs typeface="+mn-cs"/>
-              </a:defRPr>
-            </a:lvl8pPr>
-            <a:lvl9pPr marL="3657600" algn="l" defTabSz="914400" rtl="0" eaLnBrk="1" latinLnBrk="0" hangingPunct="1">
-              <a:defRPr sz="1800" kern="1200">
-                <a:solidFill>
-                  <a:schemeClr val="lt1"/>
-                </a:solidFill>
-                <a:latin typeface="+mn-lt"/>
-                <a:ea typeface="+mn-ea"/>
-                <a:cs typeface="+mn-cs"/>
-              </a:defRPr>
-            </a:lvl9pPr>
-          </a:lstStyle>
-          <a:p>
-            <a:pPr algn="ctr"/>
-            <a:endParaRPr lang="fr-FR"/>
-          </a:p>
-        </p:txBody>
-      </p:sp>
-      <p:pic>
-        <p:nvPicPr>
-          <p:cNvPr id="6" name="Picture 5">
-            <a:extLst>
-              <a:ext uri="{FF2B5EF4-FFF2-40B4-BE49-F238E27FC236}">
-                <a16:creationId xmlns:a16="http://schemas.microsoft.com/office/drawing/2014/main" id="{BA00158C-C960-342C-B0C7-9E64CB5F528C}"/>
-              </a:ext>
-            </a:extLst>
-          </p:cNvPr>
-          <p:cNvPicPr>
-            <a:picLocks noChangeAspect="1"/>
-          </p:cNvPicPr>
-          <p:nvPr/>
-        </p:nvPicPr>
-        <p:blipFill>
-          <a:blip r:embed="rId3"/>
-          <a:srcRect l="10238" b="2376"/>
-          <a:stretch>
-            <a:fillRect/>
-          </a:stretch>
-        </p:blipFill>
-        <p:spPr>
-          <a:xfrm>
-            <a:off x="6351639" y="3893193"/>
-            <a:ext cx="5002161" cy="566116"/>
-          </a:xfrm>
-          <a:prstGeom prst="rect">
-            <a:avLst/>
-          </a:prstGeom>
-        </p:spPr>
-      </p:pic>
-      <p:sp>
-        <p:nvSpPr>
-          <p:cNvPr id="5" name="Slide Number Placeholder 4">
-            <a:extLst>
-              <a:ext uri="{FF2B5EF4-FFF2-40B4-BE49-F238E27FC236}">
-                <a16:creationId xmlns:a16="http://schemas.microsoft.com/office/drawing/2014/main" id="{7EAE2EA8-7F3E-29F7-BF38-BCFC5580D379}"/>
+                <a16:creationId xmlns:a16="http://schemas.microsoft.com/office/drawing/2014/main" id="{91EA1BFD-A6AF-4A14-34C0-65467A1D021C}"/>
               </a:ext>
             </a:extLst>
           </p:cNvPr>
@@ -23825,14 +23400,818 @@
               <a:rPr lang="fr-FR" smtClean="0"/>
               <a:t>29</a:t>
             </a:fld>
-            <a:endParaRPr lang="fr-FR"/>
+            <a:endParaRPr lang="fr-FR" dirty="0"/>
           </a:p>
         </p:txBody>
       </p:sp>
+      <mc:AlternateContent xmlns:mc="http://schemas.openxmlformats.org/markup-compatibility/2006">
+        <mc:Choice xmlns:a14="http://schemas.microsoft.com/office/drawing/2010/main" Requires="a14">
+          <p:sp>
+            <p:nvSpPr>
+              <p:cNvPr id="6" name="TextBox 5">
+                <a:extLst>
+                  <a:ext uri="{FF2B5EF4-FFF2-40B4-BE49-F238E27FC236}">
+                    <a16:creationId xmlns:a16="http://schemas.microsoft.com/office/drawing/2014/main" id="{D0E9DB5F-EBD0-D834-D4ED-493307BE600E}"/>
+                  </a:ext>
+                </a:extLst>
+              </p:cNvPr>
+              <p:cNvSpPr txBox="1"/>
+              <p:nvPr/>
+            </p:nvSpPr>
+            <p:spPr>
+              <a:xfrm>
+                <a:off x="501445" y="5642899"/>
+                <a:ext cx="7076768" cy="849976"/>
+              </a:xfrm>
+              <a:prstGeom prst="rect">
+                <a:avLst/>
+              </a:prstGeom>
+              <a:noFill/>
+            </p:spPr>
+            <p:txBody>
+              <a:bodyPr wrap="square" rtlCol="0">
+                <a:spAutoFit/>
+              </a:bodyPr>
+              <a:lstStyle/>
+              <a:p>
+                <a:r>
+                  <a:rPr lang="fr-FR" sz="1600" b="0" i="1" dirty="0">
+                    <a:latin typeface="Cambria Math" panose="02040503050406030204" pitchFamily="18" charset="0"/>
+                  </a:rPr>
+                  <a:t>Résultat pour intervalle de confian</a:t>
+                </a:r>
+                <a:r>
+                  <a:rPr lang="fr-FR" sz="1600" i="1" dirty="0">
+                    <a:latin typeface="Cambria Math" panose="02040503050406030204" pitchFamily="18" charset="0"/>
+                  </a:rPr>
+                  <a:t>ce à 99%</a:t>
+                </a:r>
+                <a:endParaRPr lang="fr-FR" sz="1600" b="0" i="1" dirty="0">
+                  <a:latin typeface="Cambria Math" panose="02040503050406030204" pitchFamily="18" charset="0"/>
+                </a:endParaRPr>
+              </a:p>
+              <a:p>
+                <a14:m>
+                  <m:oMath xmlns:m="http://schemas.openxmlformats.org/officeDocument/2006/math">
+                    <m:sSub>
+                      <m:sSubPr>
+                        <m:ctrlPr>
+                          <a:rPr lang="fr-FR" sz="1600" b="0" i="1" smtClean="0">
+                            <a:latin typeface="Cambria Math" panose="02040503050406030204" pitchFamily="18" charset="0"/>
+                          </a:rPr>
+                        </m:ctrlPr>
+                      </m:sSubPr>
+                      <m:e>
+                        <m:r>
+                          <a:rPr lang="fr-FR" sz="1600" b="0" i="1" smtClean="0">
+                            <a:latin typeface="Cambria Math" panose="02040503050406030204" pitchFamily="18" charset="0"/>
+                          </a:rPr>
+                          <m:t>𝑢</m:t>
+                        </m:r>
+                      </m:e>
+                      <m:sub>
+                        <m:r>
+                          <a:rPr lang="fr-FR" sz="1600" b="0" i="1" smtClean="0">
+                            <a:latin typeface="Cambria Math" panose="02040503050406030204" pitchFamily="18" charset="0"/>
+                          </a:rPr>
+                          <m:t>𝑖𝑛𝑝𝑢𝑡</m:t>
+                        </m:r>
+                      </m:sub>
+                    </m:sSub>
+                    <m:r>
+                      <a:rPr lang="fr-FR" sz="1600" b="0" i="1" smtClean="0">
+                        <a:latin typeface="Cambria Math" panose="02040503050406030204" pitchFamily="18" charset="0"/>
+                      </a:rPr>
+                      <m:t>=</m:t>
+                    </m:r>
+                    <m:r>
+                      <a:rPr lang="fr-FR" sz="1600" b="0" i="1" smtClean="0">
+                        <a:latin typeface="Cambria Math" panose="02040503050406030204" pitchFamily="18" charset="0"/>
+                      </a:rPr>
+                      <m:t>13.1</m:t>
+                    </m:r>
+                    <m:r>
+                      <a:rPr lang="fr-FR" sz="1600" b="0" i="1" smtClean="0">
+                        <a:latin typeface="Cambria Math" panose="02040503050406030204" pitchFamily="18" charset="0"/>
+                      </a:rPr>
+                      <m:t> </m:t>
+                    </m:r>
+                    <m:r>
+                      <m:rPr>
+                        <m:sty m:val="p"/>
+                      </m:rPr>
+                      <a:rPr lang="fr-FR" sz="1600" b="0" i="1" smtClean="0">
+                        <a:latin typeface="Cambria Math" panose="02040503050406030204" pitchFamily="18" charset="0"/>
+                      </a:rPr>
+                      <m:t>K</m:t>
+                    </m:r>
+                  </m:oMath>
+                </a14:m>
+                <a:r>
+                  <a:rPr lang="en-US" sz="1600" dirty="0"/>
+                  <a:t> pour </a:t>
+                </a:r>
+                <a14:m>
+                  <m:oMath xmlns:m="http://schemas.openxmlformats.org/officeDocument/2006/math">
+                    <m:sSub>
+                      <m:sSubPr>
+                        <m:ctrlPr>
+                          <a:rPr lang="fr-FR" sz="1600" b="0" i="1" smtClean="0">
+                            <a:latin typeface="Cambria Math" panose="02040503050406030204" pitchFamily="18" charset="0"/>
+                          </a:rPr>
+                        </m:ctrlPr>
+                      </m:sSubPr>
+                      <m:e>
+                        <m:r>
+                          <a:rPr lang="fr-FR" sz="1600" b="0" i="1" smtClean="0">
+                            <a:latin typeface="Cambria Math" panose="02040503050406030204" pitchFamily="18" charset="0"/>
+                          </a:rPr>
+                          <m:t>𝜎</m:t>
+                        </m:r>
+                      </m:e>
+                      <m:sub>
+                        <m:r>
+                          <a:rPr lang="fr-FR" sz="1600" b="0" i="1" smtClean="0">
+                            <a:latin typeface="Cambria Math" panose="02040503050406030204" pitchFamily="18" charset="0"/>
+                          </a:rPr>
+                          <m:t>𝜀</m:t>
+                        </m:r>
+                      </m:sub>
+                    </m:sSub>
+                    <m:r>
+                      <a:rPr lang="fr-FR" sz="1600" b="0" i="1" smtClean="0">
+                        <a:latin typeface="Cambria Math" panose="02040503050406030204" pitchFamily="18" charset="0"/>
+                      </a:rPr>
+                      <m:t>=0.0</m:t>
+                    </m:r>
+                    <m:r>
+                      <a:rPr lang="fr-FR" sz="1600" b="0" i="1" smtClean="0">
+                        <a:latin typeface="Cambria Math" panose="02040503050406030204" pitchFamily="18" charset="0"/>
+                      </a:rPr>
+                      <m:t>7</m:t>
+                    </m:r>
+                    <m:r>
+                      <a:rPr lang="fr-FR" sz="1600" b="1" i="1" smtClean="0">
+                        <a:latin typeface="Cambria Math" panose="02040503050406030204" pitchFamily="18" charset="0"/>
+                      </a:rPr>
+                      <m:t>5 </m:t>
+                    </m:r>
+                    <m:r>
+                      <m:rPr>
+                        <m:sty m:val="p"/>
+                      </m:rPr>
+                      <a:rPr lang="fr-FR" sz="1600" b="1" i="1" smtClean="0">
+                        <a:latin typeface="Cambria Math" panose="02040503050406030204" pitchFamily="18" charset="0"/>
+                      </a:rPr>
+                      <m:t>et</m:t>
+                    </m:r>
+                    <m:r>
+                      <a:rPr lang="fr-FR" sz="1600" b="1" i="1" smtClean="0">
+                        <a:latin typeface="Cambria Math" panose="02040503050406030204" pitchFamily="18" charset="0"/>
+                      </a:rPr>
+                      <m:t> </m:t>
+                    </m:r>
+                    <m:r>
+                      <m:rPr>
+                        <m:sty m:val="p"/>
+                      </m:rPr>
+                      <a:rPr lang="fr-FR" sz="1600" b="1" i="1" smtClean="0">
+                        <a:latin typeface="Cambria Math" panose="02040503050406030204" pitchFamily="18" charset="0"/>
+                      </a:rPr>
+                      <m:t>σk</m:t>
+                    </m:r>
+                    <m:r>
+                      <a:rPr lang="fr-FR" sz="1600" b="1" i="1" smtClean="0">
+                        <a:latin typeface="Cambria Math" panose="02040503050406030204" pitchFamily="18" charset="0"/>
+                      </a:rPr>
+                      <m:t> = 2.5</m:t>
+                    </m:r>
+                    <m:r>
+                      <a:rPr lang="en-US" sz="1600" b="1" i="1">
+                        <a:latin typeface="Cambria Math" panose="02040503050406030204" pitchFamily="18" charset="0"/>
+                      </a:rPr>
+                      <m:t>⇒</m:t>
+                    </m:r>
+                    <m:sSub>
+                      <m:sSubPr>
+                        <m:ctrlPr>
+                          <a:rPr lang="fr-FR" sz="1600" b="1" i="1" smtClean="0">
+                            <a:latin typeface="Cambria Math" panose="02040503050406030204" pitchFamily="18" charset="0"/>
+                          </a:rPr>
+                        </m:ctrlPr>
+                      </m:sSubPr>
+                      <m:e>
+                        <m:r>
+                          <a:rPr lang="fr-FR" sz="1600" b="1" i="1" smtClean="0">
+                            <a:latin typeface="Cambria Math" panose="02040503050406030204" pitchFamily="18" charset="0"/>
+                          </a:rPr>
+                          <m:t>𝒖</m:t>
+                        </m:r>
+                      </m:e>
+                      <m:sub>
+                        <m:r>
+                          <a:rPr lang="fr-FR" sz="1600" b="1" i="1" smtClean="0">
+                            <a:latin typeface="Cambria Math" panose="02040503050406030204" pitchFamily="18" charset="0"/>
+                          </a:rPr>
+                          <m:t>𝒗𝒂𝒍</m:t>
+                        </m:r>
+                      </m:sub>
+                    </m:sSub>
+                    <m:r>
+                      <a:rPr lang="fr-FR" sz="1600" b="1" i="1" smtClean="0">
+                        <a:latin typeface="Cambria Math" panose="02040503050406030204" pitchFamily="18" charset="0"/>
+                      </a:rPr>
+                      <m:t>=</m:t>
+                    </m:r>
+                    <m:r>
+                      <a:rPr lang="fr-FR" sz="1600" b="1" i="1" smtClean="0">
+                        <a:latin typeface="Cambria Math" panose="02040503050406030204" pitchFamily="18" charset="0"/>
+                      </a:rPr>
+                      <m:t>13.13 </m:t>
+                    </m:r>
+                    <m:r>
+                      <a:rPr lang="fr-FR" sz="1600" b="1" i="1" smtClean="0">
+                        <a:latin typeface="Cambria Math" panose="02040503050406030204" pitchFamily="18" charset="0"/>
+                      </a:rPr>
+                      <m:t>𝑲</m:t>
+                    </m:r>
+                  </m:oMath>
+                </a14:m>
+                <a:endParaRPr lang="en-US" sz="1600" dirty="0"/>
+              </a:p>
+              <a:p>
+                <a:r>
+                  <a:rPr lang="en-US" sz="1600" dirty="0"/>
+                  <a:t> </a:t>
+                </a:r>
+                <a14:m>
+                  <m:oMath xmlns:m="http://schemas.openxmlformats.org/officeDocument/2006/math">
+                    <m:r>
+                      <a:rPr lang="en-US" sz="1600" b="1" i="1">
+                        <a:latin typeface="Cambria Math" panose="02040503050406030204" pitchFamily="18" charset="0"/>
+                      </a:rPr>
+                      <m:t>⇒</m:t>
+                    </m:r>
+                    <m:r>
+                      <m:rPr>
+                        <m:nor/>
+                      </m:rPr>
+                      <a:rPr lang="en-US" sz="1600" dirty="0"/>
+                      <m:t>−</m:t>
+                    </m:r>
+                    <m:r>
+                      <m:rPr>
+                        <m:nor/>
+                      </m:rPr>
+                      <a:rPr lang="fr-FR" sz="1600" b="0" i="0" dirty="0" smtClean="0"/>
+                      <m:t>14.5</m:t>
+                    </m:r>
+                    <m:r>
+                      <m:rPr>
+                        <m:nor/>
+                      </m:rPr>
+                      <a:rPr lang="en-US" sz="1600" dirty="0"/>
+                      <m:t> </m:t>
+                    </m:r>
+                    <m:r>
+                      <m:rPr>
+                        <m:nor/>
+                      </m:rPr>
+                      <a:rPr lang="en-US" sz="1600" dirty="0"/>
+                      <m:t>K</m:t>
+                    </m:r>
+                    <m:r>
+                      <m:rPr>
+                        <m:nor/>
+                      </m:rPr>
+                      <a:rPr lang="en-US" sz="1600" dirty="0"/>
+                      <m:t> &lt;</m:t>
+                    </m:r>
+                    <m:sSub>
+                      <m:sSubPr>
+                        <m:ctrlPr>
+                          <a:rPr lang="fr-FR" sz="1600" i="1">
+                            <a:latin typeface="Cambria Math" panose="02040503050406030204" pitchFamily="18" charset="0"/>
+                          </a:rPr>
+                        </m:ctrlPr>
+                      </m:sSubPr>
+                      <m:e>
+                        <m:r>
+                          <a:rPr lang="fr-FR" sz="1600" b="0" i="1" smtClean="0">
+                            <a:latin typeface="Cambria Math" panose="02040503050406030204" pitchFamily="18" charset="0"/>
+                          </a:rPr>
+                          <m:t> </m:t>
+                        </m:r>
+                        <m:r>
+                          <m:rPr>
+                            <m:sty m:val="p"/>
+                          </m:rPr>
+                          <a:rPr lang="fr-FR" sz="1600" b="0" i="1">
+                            <a:latin typeface="Cambria Math" panose="02040503050406030204" pitchFamily="18" charset="0"/>
+                          </a:rPr>
+                          <m:t>δ</m:t>
+                        </m:r>
+                      </m:e>
+                      <m:sub>
+                        <m:r>
+                          <m:rPr>
+                            <m:sty m:val="p"/>
+                          </m:rPr>
+                          <a:rPr lang="fr-FR" sz="1600" b="0" i="1">
+                            <a:latin typeface="Cambria Math" panose="02040503050406030204" pitchFamily="18" charset="0"/>
+                          </a:rPr>
+                          <m:t>model</m:t>
+                        </m:r>
+                      </m:sub>
+                    </m:sSub>
+                    <m:r>
+                      <a:rPr lang="fr-FR" sz="1600" b="0">
+                        <a:latin typeface="Cambria Math" panose="02040503050406030204" pitchFamily="18" charset="0"/>
+                      </a:rPr>
+                      <m:t>&lt;</m:t>
+                    </m:r>
+                    <m:r>
+                      <a:rPr lang="fr-FR" sz="1600" b="0" i="1" smtClean="0">
+                        <a:latin typeface="Cambria Math" panose="02040503050406030204" pitchFamily="18" charset="0"/>
+                      </a:rPr>
+                      <m:t>38.1</m:t>
+                    </m:r>
+                    <m:r>
+                      <m:rPr>
+                        <m:sty m:val="p"/>
+                      </m:rPr>
+                      <a:rPr lang="fr-FR" sz="1600" b="0" i="1">
+                        <a:latin typeface="Cambria Math" panose="02040503050406030204" pitchFamily="18" charset="0"/>
+                      </a:rPr>
+                      <m:t>K</m:t>
+                    </m:r>
+                  </m:oMath>
+                </a14:m>
+                <a:r>
+                  <a:rPr lang="en-US" sz="1600" dirty="0"/>
+                  <a:t> </a:t>
+                </a:r>
+              </a:p>
+            </p:txBody>
+          </p:sp>
+        </mc:Choice>
+        <mc:Fallback>
+          <p:sp>
+            <p:nvSpPr>
+              <p:cNvPr id="6" name="TextBox 5">
+                <a:extLst>
+                  <a:ext uri="{FF2B5EF4-FFF2-40B4-BE49-F238E27FC236}">
+                    <a16:creationId xmlns:a16="http://schemas.microsoft.com/office/drawing/2014/main" id="{D0E9DB5F-EBD0-D834-D4ED-493307BE600E}"/>
+                  </a:ext>
+                </a:extLst>
+              </p:cNvPr>
+              <p:cNvSpPr txBox="1">
+                <a:spLocks noRot="1" noChangeAspect="1" noMove="1" noResize="1" noEditPoints="1" noAdjustHandles="1" noChangeArrowheads="1" noChangeShapeType="1" noTextEdit="1"/>
+              </p:cNvSpPr>
+              <p:nvPr/>
+            </p:nvSpPr>
+            <p:spPr>
+              <a:xfrm>
+                <a:off x="501445" y="5642899"/>
+                <a:ext cx="7076768" cy="849976"/>
+              </a:xfrm>
+              <a:prstGeom prst="rect">
+                <a:avLst/>
+              </a:prstGeom>
+              <a:blipFill>
+                <a:blip r:embed="rId4"/>
+                <a:stretch>
+                  <a:fillRect l="-431" t="-2878"/>
+                </a:stretch>
+              </a:blipFill>
+            </p:spPr>
+            <p:txBody>
+              <a:bodyPr/>
+              <a:lstStyle/>
+              <a:p>
+                <a:r>
+                  <a:rPr lang="en-US">
+                    <a:noFill/>
+                  </a:rPr>
+                  <a:t> </a:t>
+                </a:r>
+              </a:p>
+            </p:txBody>
+          </p:sp>
+        </mc:Fallback>
+      </mc:AlternateContent>
+      <mc:AlternateContent xmlns:mc="http://schemas.openxmlformats.org/markup-compatibility/2006">
+        <mc:Choice xmlns:a14="http://schemas.microsoft.com/office/drawing/2010/main" Requires="a14">
+          <p:sp>
+            <p:nvSpPr>
+              <p:cNvPr id="7" name="TextBox 6">
+                <a:extLst>
+                  <a:ext uri="{FF2B5EF4-FFF2-40B4-BE49-F238E27FC236}">
+                    <a16:creationId xmlns:a16="http://schemas.microsoft.com/office/drawing/2014/main" id="{25D42C7E-25E3-AF65-F96B-BB8C9D734754}"/>
+                  </a:ext>
+                </a:extLst>
+              </p:cNvPr>
+              <p:cNvSpPr txBox="1"/>
+              <p:nvPr/>
+            </p:nvSpPr>
+            <p:spPr>
+              <a:xfrm>
+                <a:off x="7973961" y="3429000"/>
+                <a:ext cx="3883742" cy="2464521"/>
+              </a:xfrm>
+              <a:prstGeom prst="rect">
+                <a:avLst/>
+              </a:prstGeom>
+              <a:noFill/>
+            </p:spPr>
+            <p:txBody>
+              <a:bodyPr wrap="square" rtlCol="0">
+                <a:spAutoFit/>
+              </a:bodyPr>
+              <a:lstStyle/>
+              <a:p>
+                <a:r>
+                  <a:rPr lang="fr-FR" b="0" dirty="0">
+                    <a:latin typeface="Cambria Math" panose="02040503050406030204" pitchFamily="18" charset="0"/>
+                  </a:rPr>
+                  <a:t>Dans le cas d’une loi normale : </a:t>
+                </a:r>
+              </a:p>
+              <a:p>
+                <a14:m>
+                  <m:oMathPara xmlns:m="http://schemas.openxmlformats.org/officeDocument/2006/math">
+                    <m:oMathParaPr>
+                      <m:jc m:val="centerGroup"/>
+                    </m:oMathParaPr>
+                    <m:oMath xmlns:m="http://schemas.openxmlformats.org/officeDocument/2006/math">
+                      <m:d>
+                        <m:dPr>
+                          <m:begChr m:val="["/>
+                          <m:endChr m:val="]"/>
+                          <m:ctrlPr>
+                            <a:rPr lang="fr-FR" b="0" i="1" smtClean="0">
+                              <a:latin typeface="Cambria Math" panose="02040503050406030204" pitchFamily="18" charset="0"/>
+                            </a:rPr>
+                          </m:ctrlPr>
+                        </m:dPr>
+                        <m:e>
+                          <m:r>
+                            <a:rPr lang="fr-FR" b="0" i="1" smtClean="0">
+                              <a:latin typeface="Cambria Math" panose="02040503050406030204" pitchFamily="18" charset="0"/>
+                            </a:rPr>
+                            <m:t>𝑎</m:t>
+                          </m:r>
+                          <m:r>
+                            <a:rPr lang="fr-FR" b="0" i="1" smtClean="0">
+                              <a:latin typeface="Cambria Math" panose="02040503050406030204" pitchFamily="18" charset="0"/>
+                            </a:rPr>
+                            <m:t>,</m:t>
+                          </m:r>
+                          <m:r>
+                            <a:rPr lang="fr-FR" b="0" i="1" smtClean="0">
+                              <a:latin typeface="Cambria Math" panose="02040503050406030204" pitchFamily="18" charset="0"/>
+                            </a:rPr>
+                            <m:t>𝑏</m:t>
+                          </m:r>
+                        </m:e>
+                      </m:d>
+                      <m:r>
+                        <a:rPr lang="fr-FR" b="0" i="1" smtClean="0">
+                          <a:latin typeface="Cambria Math" panose="02040503050406030204" pitchFamily="18" charset="0"/>
+                        </a:rPr>
+                        <m:t>→</m:t>
+                      </m:r>
+                      <m:r>
+                        <a:rPr lang="fr-FR" b="0" i="1" smtClean="0">
+                          <a:latin typeface="Cambria Math" panose="02040503050406030204" pitchFamily="18" charset="0"/>
+                        </a:rPr>
+                        <m:t>𝜇</m:t>
+                      </m:r>
+                      <m:r>
+                        <a:rPr lang="fr-FR" b="0" i="1" smtClean="0">
+                          <a:latin typeface="Cambria Math" panose="02040503050406030204" pitchFamily="18" charset="0"/>
+                        </a:rPr>
+                        <m:t>=</m:t>
+                      </m:r>
+                      <m:f>
+                        <m:fPr>
+                          <m:ctrlPr>
+                            <a:rPr lang="fr-FR" b="0" i="1" smtClean="0">
+                              <a:latin typeface="Cambria Math" panose="02040503050406030204" pitchFamily="18" charset="0"/>
+                            </a:rPr>
+                          </m:ctrlPr>
+                        </m:fPr>
+                        <m:num>
+                          <m:r>
+                            <m:rPr>
+                              <m:sty m:val="p"/>
+                            </m:rPr>
+                            <a:rPr lang="fr-FR" b="0" i="1" smtClean="0">
+                              <a:latin typeface="Cambria Math" panose="02040503050406030204" pitchFamily="18" charset="0"/>
+                            </a:rPr>
+                            <m:t>a</m:t>
+                          </m:r>
+                          <m:r>
+                            <a:rPr lang="fr-FR" b="0" i="1" smtClean="0">
+                              <a:latin typeface="Cambria Math" panose="02040503050406030204" pitchFamily="18" charset="0"/>
+                            </a:rPr>
+                            <m:t>+</m:t>
+                          </m:r>
+                          <m:r>
+                            <m:rPr>
+                              <m:sty m:val="p"/>
+                            </m:rPr>
+                            <a:rPr lang="fr-FR" b="0" i="1" smtClean="0">
+                              <a:latin typeface="Cambria Math" panose="02040503050406030204" pitchFamily="18" charset="0"/>
+                            </a:rPr>
+                            <m:t>b</m:t>
+                          </m:r>
+                        </m:num>
+                        <m:den>
+                          <m:r>
+                            <a:rPr lang="fr-FR" b="0" i="1" smtClean="0">
+                              <a:latin typeface="Cambria Math" panose="02040503050406030204" pitchFamily="18" charset="0"/>
+                            </a:rPr>
+                            <m:t>2</m:t>
+                          </m:r>
+                        </m:den>
+                      </m:f>
+                    </m:oMath>
+                  </m:oMathPara>
+                </a14:m>
+                <a:endParaRPr lang="fr-FR" b="0" dirty="0"/>
+              </a:p>
+              <a:p>
+                <a:r>
+                  <a:rPr lang="en-US" dirty="0"/>
+                  <a:t>Pour </a:t>
+                </a:r>
+                <a:r>
+                  <a:rPr lang="en-US" dirty="0" err="1"/>
+                  <a:t>intervalle</a:t>
+                </a:r>
+                <a:r>
+                  <a:rPr lang="en-US" dirty="0"/>
+                  <a:t> de </a:t>
+                </a:r>
+                <a:r>
+                  <a:rPr lang="en-US" dirty="0" err="1"/>
+                  <a:t>confiance</a:t>
+                </a:r>
+                <a:r>
+                  <a:rPr lang="en-US" dirty="0"/>
+                  <a:t> à 95,4% :</a:t>
+                </a:r>
+              </a:p>
+              <a:p>
+                <a14:m>
+                  <m:oMath xmlns:m="http://schemas.openxmlformats.org/officeDocument/2006/math">
+                    <m:r>
+                      <m:rPr>
+                        <m:sty m:val="p"/>
+                      </m:rPr>
+                      <a:rPr lang="fr-FR" b="0" i="1" smtClean="0">
+                        <a:latin typeface="Cambria Math" panose="02040503050406030204" pitchFamily="18" charset="0"/>
+                      </a:rPr>
+                      <m:t>σ</m:t>
+                    </m:r>
+                    <m:r>
+                      <a:rPr lang="fr-FR" b="0" i="1" smtClean="0">
+                        <a:latin typeface="Cambria Math" panose="02040503050406030204" pitchFamily="18" charset="0"/>
+                      </a:rPr>
+                      <m:t>= </m:t>
+                    </m:r>
+                    <m:f>
+                      <m:fPr>
+                        <m:ctrlPr>
+                          <a:rPr lang="fr-FR" b="0" i="1" smtClean="0">
+                            <a:latin typeface="Cambria Math" panose="02040503050406030204" pitchFamily="18" charset="0"/>
+                          </a:rPr>
+                        </m:ctrlPr>
+                      </m:fPr>
+                      <m:num>
+                        <m:r>
+                          <m:rPr>
+                            <m:sty m:val="p"/>
+                          </m:rPr>
+                          <a:rPr lang="fr-FR" b="0" i="1" smtClean="0">
+                            <a:latin typeface="Cambria Math" panose="02040503050406030204" pitchFamily="18" charset="0"/>
+                          </a:rPr>
+                          <m:t>μ</m:t>
+                        </m:r>
+                        <m:r>
+                          <a:rPr lang="fr-FR" b="0" i="1" smtClean="0">
+                            <a:latin typeface="Cambria Math" panose="02040503050406030204" pitchFamily="18" charset="0"/>
+                          </a:rPr>
+                          <m:t>-</m:t>
+                        </m:r>
+                        <m:r>
+                          <m:rPr>
+                            <m:sty m:val="p"/>
+                          </m:rPr>
+                          <a:rPr lang="fr-FR" b="0" i="1" smtClean="0">
+                            <a:latin typeface="Cambria Math" panose="02040503050406030204" pitchFamily="18" charset="0"/>
+                          </a:rPr>
+                          <m:t>a</m:t>
+                        </m:r>
+                      </m:num>
+                      <m:den>
+                        <m:r>
+                          <a:rPr lang="fr-FR" b="0" i="1" smtClean="0">
+                            <a:latin typeface="Cambria Math" panose="02040503050406030204" pitchFamily="18" charset="0"/>
+                          </a:rPr>
+                          <m:t>2</m:t>
+                        </m:r>
+                      </m:den>
+                    </m:f>
+                  </m:oMath>
+                </a14:m>
+                <a:r>
+                  <a:rPr lang="en-US" dirty="0"/>
+                  <a:t> </a:t>
+                </a:r>
+              </a:p>
+              <a:p>
+                <a:r>
+                  <a:rPr lang="en-US" dirty="0"/>
+                  <a:t>Pour </a:t>
+                </a:r>
+                <a:r>
+                  <a:rPr lang="en-US" dirty="0" err="1"/>
+                  <a:t>intervalle</a:t>
+                </a:r>
+                <a:r>
+                  <a:rPr lang="en-US" dirty="0"/>
+                  <a:t> de </a:t>
+                </a:r>
+                <a:r>
+                  <a:rPr lang="en-US" dirty="0" err="1"/>
+                  <a:t>confiance</a:t>
+                </a:r>
+                <a:r>
+                  <a:rPr lang="en-US" dirty="0"/>
+                  <a:t> à 99% :</a:t>
+                </a:r>
+              </a:p>
+              <a:p>
+                <a14:m>
+                  <m:oMath xmlns:m="http://schemas.openxmlformats.org/officeDocument/2006/math">
+                    <m:r>
+                      <m:rPr>
+                        <m:sty m:val="p"/>
+                      </m:rPr>
+                      <a:rPr lang="fr-FR" i="1">
+                        <a:latin typeface="Cambria Math" panose="02040503050406030204" pitchFamily="18" charset="0"/>
+                      </a:rPr>
+                      <m:t>σ</m:t>
+                    </m:r>
+                    <m:r>
+                      <a:rPr lang="fr-FR" i="1">
+                        <a:latin typeface="Cambria Math" panose="02040503050406030204" pitchFamily="18" charset="0"/>
+                      </a:rPr>
+                      <m:t>= </m:t>
+                    </m:r>
+                    <m:f>
+                      <m:fPr>
+                        <m:ctrlPr>
+                          <a:rPr lang="fr-FR" i="1">
+                            <a:latin typeface="Cambria Math" panose="02040503050406030204" pitchFamily="18" charset="0"/>
+                          </a:rPr>
+                        </m:ctrlPr>
+                      </m:fPr>
+                      <m:num>
+                        <m:r>
+                          <m:rPr>
+                            <m:sty m:val="p"/>
+                          </m:rPr>
+                          <a:rPr lang="fr-FR" i="1">
+                            <a:latin typeface="Cambria Math" panose="02040503050406030204" pitchFamily="18" charset="0"/>
+                          </a:rPr>
+                          <m:t>μ</m:t>
+                        </m:r>
+                        <m:r>
+                          <a:rPr lang="fr-FR" i="1">
+                            <a:latin typeface="Cambria Math" panose="02040503050406030204" pitchFamily="18" charset="0"/>
+                          </a:rPr>
+                          <m:t>−</m:t>
+                        </m:r>
+                        <m:r>
+                          <m:rPr>
+                            <m:sty m:val="p"/>
+                          </m:rPr>
+                          <a:rPr lang="fr-FR" i="1">
+                            <a:latin typeface="Cambria Math" panose="02040503050406030204" pitchFamily="18" charset="0"/>
+                          </a:rPr>
+                          <m:t>a</m:t>
+                        </m:r>
+                      </m:num>
+                      <m:den>
+                        <m:r>
+                          <a:rPr lang="fr-FR" b="0" i="1" smtClean="0">
+                            <a:latin typeface="Cambria Math" panose="02040503050406030204" pitchFamily="18" charset="0"/>
+                          </a:rPr>
+                          <m:t>5</m:t>
+                        </m:r>
+                      </m:den>
+                    </m:f>
+                  </m:oMath>
+                </a14:m>
+                <a:r>
+                  <a:rPr lang="en-US" dirty="0"/>
+                  <a:t> </a:t>
+                </a:r>
+              </a:p>
+              <a:p>
+                <a:endParaRPr lang="en-US" dirty="0"/>
+              </a:p>
+            </p:txBody>
+          </p:sp>
+        </mc:Choice>
+        <mc:Fallback>
+          <p:sp>
+            <p:nvSpPr>
+              <p:cNvPr id="7" name="TextBox 6">
+                <a:extLst>
+                  <a:ext uri="{FF2B5EF4-FFF2-40B4-BE49-F238E27FC236}">
+                    <a16:creationId xmlns:a16="http://schemas.microsoft.com/office/drawing/2014/main" id="{25D42C7E-25E3-AF65-F96B-BB8C9D734754}"/>
+                  </a:ext>
+                </a:extLst>
+              </p:cNvPr>
+              <p:cNvSpPr txBox="1">
+                <a:spLocks noRot="1" noChangeAspect="1" noMove="1" noResize="1" noEditPoints="1" noAdjustHandles="1" noChangeArrowheads="1" noChangeShapeType="1" noTextEdit="1"/>
+              </p:cNvSpPr>
+              <p:nvPr/>
+            </p:nvSpPr>
+            <p:spPr>
+              <a:xfrm>
+                <a:off x="7973961" y="3429000"/>
+                <a:ext cx="3883742" cy="2464521"/>
+              </a:xfrm>
+              <a:prstGeom prst="rect">
+                <a:avLst/>
+              </a:prstGeom>
+              <a:blipFill>
+                <a:blip r:embed="rId5"/>
+                <a:stretch>
+                  <a:fillRect l="-1256" t="-1733" r="-1099"/>
+                </a:stretch>
+              </a:blipFill>
+            </p:spPr>
+            <p:txBody>
+              <a:bodyPr/>
+              <a:lstStyle/>
+              <a:p>
+                <a:r>
+                  <a:rPr lang="en-US">
+                    <a:noFill/>
+                  </a:rPr>
+                  <a:t> </a:t>
+                </a:r>
+              </a:p>
+            </p:txBody>
+          </p:sp>
+        </mc:Fallback>
+      </mc:AlternateContent>
+      <p:pic>
+        <p:nvPicPr>
+          <p:cNvPr id="9" name="Picture 8">
+            <a:extLst>
+              <a:ext uri="{FF2B5EF4-FFF2-40B4-BE49-F238E27FC236}">
+                <a16:creationId xmlns:a16="http://schemas.microsoft.com/office/drawing/2014/main" id="{7A2BFB8D-3C80-BD69-86E4-533DD007EACD}"/>
+              </a:ext>
+            </a:extLst>
+          </p:cNvPr>
+          <p:cNvPicPr>
+            <a:picLocks noChangeAspect="1"/>
+          </p:cNvPicPr>
+          <p:nvPr/>
+        </p:nvPicPr>
+        <p:blipFill>
+          <a:blip r:embed="rId6">
+            <a:extLst>
+              <a:ext uri="{28A0092B-C50C-407E-A947-70E740481C1C}">
+                <a14:useLocalDpi xmlns:a14="http://schemas.microsoft.com/office/drawing/2010/main" val="0"/>
+              </a:ext>
+            </a:extLst>
+          </a:blip>
+          <a:stretch>
+            <a:fillRect/>
+          </a:stretch>
+        </p:blipFill>
+        <p:spPr>
+          <a:xfrm>
+            <a:off x="501445" y="3216721"/>
+            <a:ext cx="6961239" cy="2261611"/>
+          </a:xfrm>
+          <a:prstGeom prst="rect">
+            <a:avLst/>
+          </a:prstGeom>
+        </p:spPr>
+      </p:pic>
     </p:spTree>
     <p:extLst>
       <p:ext uri="{BB962C8B-B14F-4D97-AF65-F5344CB8AC3E}">
-        <p14:creationId xmlns:p14="http://schemas.microsoft.com/office/powerpoint/2010/main" val="3191033194"/>
+        <p14:creationId xmlns:p14="http://schemas.microsoft.com/office/powerpoint/2010/main" val="172672328"/>
       </p:ext>
     </p:extLst>
   </p:cSld>
@@ -24216,6 +24595,1079 @@
           <p:cNvPr id="2" name="Title 1">
             <a:extLst>
               <a:ext uri="{FF2B5EF4-FFF2-40B4-BE49-F238E27FC236}">
+                <a16:creationId xmlns:a16="http://schemas.microsoft.com/office/drawing/2014/main" id="{B0F15578-24AA-1A1D-99B9-0FD28C04FF50}"/>
+              </a:ext>
+            </a:extLst>
+          </p:cNvPr>
+          <p:cNvSpPr>
+            <a:spLocks noGrp="1"/>
+          </p:cNvSpPr>
+          <p:nvPr>
+            <p:ph type="title"/>
+          </p:nvPr>
+        </p:nvSpPr>
+        <p:spPr/>
+        <p:txBody>
+          <a:bodyPr/>
+          <a:lstStyle/>
+          <a:p>
+            <a:r>
+              <a:rPr lang="fr-FR" dirty="0"/>
+              <a:t>Validation – erreur du modèle </a:t>
+            </a:r>
+            <a:endParaRPr lang="en-US" dirty="0"/>
+          </a:p>
+        </p:txBody>
+      </p:sp>
+      <mc:AlternateContent xmlns:mc="http://schemas.openxmlformats.org/markup-compatibility/2006" xmlns:a14="http://schemas.microsoft.com/office/drawing/2010/main">
+        <mc:Choice Requires="a14">
+          <p:sp>
+            <p:nvSpPr>
+              <p:cNvPr id="3" name="Content Placeholder 2">
+                <a:extLst>
+                  <a:ext uri="{FF2B5EF4-FFF2-40B4-BE49-F238E27FC236}">
+                    <a16:creationId xmlns:a16="http://schemas.microsoft.com/office/drawing/2014/main" id="{41DABA39-902C-A6ED-B4EF-7E3705D66722}"/>
+                  </a:ext>
+                </a:extLst>
+              </p:cNvPr>
+              <p:cNvSpPr>
+                <a:spLocks noGrp="1"/>
+              </p:cNvSpPr>
+              <p:nvPr>
+                <p:ph idx="1"/>
+              </p:nvPr>
+            </p:nvSpPr>
+            <p:spPr>
+              <a:xfrm>
+                <a:off x="838200" y="1855122"/>
+                <a:ext cx="10515600" cy="4351338"/>
+              </a:xfrm>
+            </p:spPr>
+            <p:txBody>
+              <a:bodyPr/>
+              <a:lstStyle/>
+              <a:p>
+                <a14:m>
+                  <m:oMath xmlns:m="http://schemas.openxmlformats.org/officeDocument/2006/math">
+                    <m:r>
+                      <a:rPr lang="fr-FR" i="1">
+                        <a:latin typeface="Cambria Math" panose="02040503050406030204" pitchFamily="18" charset="0"/>
+                      </a:rPr>
+                      <m:t>𝐸</m:t>
+                    </m:r>
+                    <m:r>
+                      <a:rPr lang="fr-FR" i="1">
+                        <a:latin typeface="Cambria Math" panose="02040503050406030204" pitchFamily="18" charset="0"/>
+                      </a:rPr>
+                      <m:t>−</m:t>
+                    </m:r>
+                    <m:r>
+                      <a:rPr lang="fr-FR" i="1">
+                        <a:latin typeface="Cambria Math" panose="02040503050406030204" pitchFamily="18" charset="0"/>
+                      </a:rPr>
+                      <m:t>𝑘</m:t>
+                    </m:r>
+                    <m:sSub>
+                      <m:sSubPr>
+                        <m:ctrlPr>
+                          <a:rPr lang="fr-FR" i="1">
+                            <a:latin typeface="Cambria Math" panose="02040503050406030204" pitchFamily="18" charset="0"/>
+                          </a:rPr>
+                        </m:ctrlPr>
+                      </m:sSubPr>
+                      <m:e>
+                        <m:r>
+                          <a:rPr lang="fr-FR" i="1">
+                            <a:latin typeface="Cambria Math" panose="02040503050406030204" pitchFamily="18" charset="0"/>
+                          </a:rPr>
+                          <m:t>𝑢</m:t>
+                        </m:r>
+                      </m:e>
+                      <m:sub>
+                        <m:r>
+                          <a:rPr lang="fr-FR" i="1">
+                            <a:latin typeface="Cambria Math" panose="02040503050406030204" pitchFamily="18" charset="0"/>
+                          </a:rPr>
+                          <m:t>𝑣𝑎𝑙</m:t>
+                        </m:r>
+                      </m:sub>
+                    </m:sSub>
+                    <m:r>
+                      <a:rPr lang="fr-FR" i="1">
+                        <a:latin typeface="Cambria Math" panose="02040503050406030204" pitchFamily="18" charset="0"/>
+                      </a:rPr>
+                      <m:t>≤</m:t>
+                    </m:r>
+                    <m:sSub>
+                      <m:sSubPr>
+                        <m:ctrlPr>
+                          <a:rPr lang="fr-FR" i="1">
+                            <a:latin typeface="Cambria Math" panose="02040503050406030204" pitchFamily="18" charset="0"/>
+                          </a:rPr>
+                        </m:ctrlPr>
+                      </m:sSubPr>
+                      <m:e>
+                        <m:r>
+                          <a:rPr lang="fr-FR" i="1">
+                            <a:latin typeface="Cambria Math" panose="02040503050406030204" pitchFamily="18" charset="0"/>
+                          </a:rPr>
+                          <m:t>𝛿</m:t>
+                        </m:r>
+                      </m:e>
+                      <m:sub>
+                        <m:r>
+                          <a:rPr lang="fr-FR" i="1">
+                            <a:latin typeface="Cambria Math" panose="02040503050406030204" pitchFamily="18" charset="0"/>
+                          </a:rPr>
+                          <m:t>𝑚𝑜𝑑𝑒𝑙</m:t>
+                        </m:r>
+                      </m:sub>
+                    </m:sSub>
+                    <m:r>
+                      <a:rPr lang="fr-FR" i="1">
+                        <a:latin typeface="Cambria Math" panose="02040503050406030204" pitchFamily="18" charset="0"/>
+                      </a:rPr>
+                      <m:t>≤</m:t>
+                    </m:r>
+                    <m:r>
+                      <a:rPr lang="fr-FR" i="1">
+                        <a:latin typeface="Cambria Math" panose="02040503050406030204" pitchFamily="18" charset="0"/>
+                      </a:rPr>
+                      <m:t>𝐸</m:t>
+                    </m:r>
+                    <m:r>
+                      <a:rPr lang="fr-FR" i="1">
+                        <a:latin typeface="Cambria Math" panose="02040503050406030204" pitchFamily="18" charset="0"/>
+                      </a:rPr>
+                      <m:t>+</m:t>
+                    </m:r>
+                    <m:r>
+                      <a:rPr lang="fr-FR" i="1">
+                        <a:latin typeface="Cambria Math" panose="02040503050406030204" pitchFamily="18" charset="0"/>
+                      </a:rPr>
+                      <m:t>𝑘</m:t>
+                    </m:r>
+                    <m:sSub>
+                      <m:sSubPr>
+                        <m:ctrlPr>
+                          <a:rPr lang="fr-FR" i="1">
+                            <a:latin typeface="Cambria Math" panose="02040503050406030204" pitchFamily="18" charset="0"/>
+                          </a:rPr>
+                        </m:ctrlPr>
+                      </m:sSubPr>
+                      <m:e>
+                        <m:r>
+                          <a:rPr lang="fr-FR" i="1">
+                            <a:latin typeface="Cambria Math" panose="02040503050406030204" pitchFamily="18" charset="0"/>
+                          </a:rPr>
+                          <m:t>𝑢</m:t>
+                        </m:r>
+                      </m:e>
+                      <m:sub>
+                        <m:r>
+                          <a:rPr lang="fr-FR" i="1">
+                            <a:latin typeface="Cambria Math" panose="02040503050406030204" pitchFamily="18" charset="0"/>
+                          </a:rPr>
+                          <m:t>𝑣𝑎𝑙</m:t>
+                        </m:r>
+                      </m:sub>
+                    </m:sSub>
+                  </m:oMath>
+                </a14:m>
+                <a:endParaRPr lang="fr-FR" dirty="0"/>
+              </a:p>
+              <a:p>
+                <a:r>
+                  <a:rPr lang="en-US" dirty="0" err="1"/>
+                  <a:t>Où</a:t>
+                </a:r>
+                <a:r>
+                  <a:rPr lang="en-US" dirty="0"/>
+                  <a:t> </a:t>
+                </a:r>
+                <a14:m>
+                  <m:oMath xmlns:m="http://schemas.openxmlformats.org/officeDocument/2006/math">
+                    <m:sSub>
+                      <m:sSubPr>
+                        <m:ctrlPr>
+                          <a:rPr lang="fr-FR" b="0" i="1" smtClean="0">
+                            <a:latin typeface="Cambria Math" panose="02040503050406030204" pitchFamily="18" charset="0"/>
+                          </a:rPr>
+                        </m:ctrlPr>
+                      </m:sSubPr>
+                      <m:e>
+                        <m:r>
+                          <a:rPr lang="fr-FR" b="0" i="1" smtClean="0">
+                            <a:latin typeface="Cambria Math" panose="02040503050406030204" pitchFamily="18" charset="0"/>
+                          </a:rPr>
+                          <m:t>𝑢</m:t>
+                        </m:r>
+                      </m:e>
+                      <m:sub>
+                        <m:r>
+                          <a:rPr lang="fr-FR" b="0" i="1" smtClean="0">
+                            <a:latin typeface="Cambria Math" panose="02040503050406030204" pitchFamily="18" charset="0"/>
+                          </a:rPr>
+                          <m:t>𝑣𝑎𝑙</m:t>
+                        </m:r>
+                      </m:sub>
+                    </m:sSub>
+                    <m:r>
+                      <a:rPr lang="fr-FR" b="0" i="1" smtClean="0">
+                        <a:latin typeface="Cambria Math" panose="02040503050406030204" pitchFamily="18" charset="0"/>
+                      </a:rPr>
+                      <m:t>= </m:t>
+                    </m:r>
+                    <m:rad>
+                      <m:radPr>
+                        <m:degHide m:val="on"/>
+                        <m:ctrlPr>
+                          <a:rPr lang="fr-FR" b="0" i="1" smtClean="0">
+                            <a:latin typeface="Cambria Math" panose="02040503050406030204" pitchFamily="18" charset="0"/>
+                          </a:rPr>
+                        </m:ctrlPr>
+                      </m:radPr>
+                      <m:deg/>
+                      <m:e>
+                        <m:sSup>
+                          <m:sSupPr>
+                            <m:ctrlPr>
+                              <a:rPr lang="fr-FR" b="0" i="1" smtClean="0">
+                                <a:latin typeface="Cambria Math" panose="02040503050406030204" pitchFamily="18" charset="0"/>
+                              </a:rPr>
+                            </m:ctrlPr>
+                          </m:sSupPr>
+                          <m:e>
+                            <m:r>
+                              <a:rPr lang="fr-FR" b="0" i="1" smtClean="0">
+                                <a:latin typeface="Cambria Math" panose="02040503050406030204" pitchFamily="18" charset="0"/>
+                              </a:rPr>
+                              <m:t>0.87</m:t>
+                            </m:r>
+                          </m:e>
+                          <m:sup>
+                            <m:r>
+                              <a:rPr lang="fr-FR" b="0" i="1" smtClean="0">
+                                <a:latin typeface="Cambria Math" panose="02040503050406030204" pitchFamily="18" charset="0"/>
+                              </a:rPr>
+                              <m:t>2</m:t>
+                            </m:r>
+                          </m:sup>
+                        </m:sSup>
+                        <m:r>
+                          <a:rPr lang="fr-FR" b="0" i="1" smtClean="0">
+                            <a:latin typeface="Cambria Math" panose="02040503050406030204" pitchFamily="18" charset="0"/>
+                          </a:rPr>
+                          <m:t>+</m:t>
+                        </m:r>
+                        <m:sSup>
+                          <m:sSupPr>
+                            <m:ctrlPr>
+                              <a:rPr lang="fr-FR" b="0" i="1" smtClean="0">
+                                <a:latin typeface="Cambria Math" panose="02040503050406030204" pitchFamily="18" charset="0"/>
+                              </a:rPr>
+                            </m:ctrlPr>
+                          </m:sSupPr>
+                          <m:e>
+                            <m:r>
+                              <a:rPr lang="fr-FR" b="0" i="1" smtClean="0">
+                                <a:latin typeface="Cambria Math" panose="02040503050406030204" pitchFamily="18" charset="0"/>
+                              </a:rPr>
+                              <m:t>44.91</m:t>
+                            </m:r>
+                          </m:e>
+                          <m:sup>
+                            <m:r>
+                              <a:rPr lang="fr-FR" b="0" i="1" smtClean="0">
+                                <a:latin typeface="Cambria Math" panose="02040503050406030204" pitchFamily="18" charset="0"/>
+                              </a:rPr>
+                              <m:t>2</m:t>
+                            </m:r>
+                          </m:sup>
+                        </m:sSup>
+                        <m:r>
+                          <a:rPr lang="fr-FR" b="0" i="1" smtClean="0">
+                            <a:latin typeface="Cambria Math" panose="02040503050406030204" pitchFamily="18" charset="0"/>
+                          </a:rPr>
+                          <m:t>+</m:t>
+                        </m:r>
+                        <m:sSup>
+                          <m:sSupPr>
+                            <m:ctrlPr>
+                              <a:rPr lang="fr-FR" i="1">
+                                <a:latin typeface="Cambria Math" panose="02040503050406030204" pitchFamily="18" charset="0"/>
+                                <a:sym typeface="Wingdings" panose="05000000000000000000" pitchFamily="2" charset="2"/>
+                              </a:rPr>
+                            </m:ctrlPr>
+                          </m:sSupPr>
+                          <m:e>
+                            <m:r>
+                              <a:rPr lang="fr-FR" b="0" i="1" smtClean="0">
+                                <a:latin typeface="Cambria Math" panose="02040503050406030204" pitchFamily="18" charset="0"/>
+                                <a:sym typeface="Wingdings" panose="05000000000000000000" pitchFamily="2" charset="2"/>
+                              </a:rPr>
+                              <m:t>(</m:t>
+                            </m:r>
+                            <m:r>
+                              <a:rPr lang="fr-FR" i="1">
+                                <a:latin typeface="Cambria Math" panose="02040503050406030204" pitchFamily="18" charset="0"/>
+                                <a:sym typeface="Wingdings" panose="05000000000000000000" pitchFamily="2" charset="2"/>
+                              </a:rPr>
+                              <m:t>1,1</m:t>
+                            </m:r>
+                            <m:r>
+                              <a:rPr lang="fr-FR" b="0" i="1" smtClean="0">
+                                <a:latin typeface="Cambria Math" panose="02040503050406030204" pitchFamily="18" charset="0"/>
+                                <a:sym typeface="Wingdings" panose="05000000000000000000" pitchFamily="2" charset="2"/>
+                              </a:rPr>
+                              <m:t>1</m:t>
+                            </m:r>
+                            <m:r>
+                              <a:rPr lang="fr-FR" i="1">
+                                <a:latin typeface="Cambria Math" panose="02040503050406030204" pitchFamily="18" charset="0"/>
+                                <a:sym typeface="Wingdings" panose="05000000000000000000" pitchFamily="2" charset="2"/>
+                              </a:rPr>
+                              <m:t>×10</m:t>
+                            </m:r>
+                          </m:e>
+                          <m:sup>
+                            <m:r>
+                              <a:rPr lang="fr-FR" i="1">
+                                <a:latin typeface="Cambria Math" panose="02040503050406030204" pitchFamily="18" charset="0"/>
+                                <a:sym typeface="Wingdings" panose="05000000000000000000" pitchFamily="2" charset="2"/>
+                              </a:rPr>
+                              <m:t>−3</m:t>
+                            </m:r>
+                          </m:sup>
+                        </m:sSup>
+                        <m:r>
+                          <a:rPr lang="fr-FR" b="0" i="1" smtClean="0">
+                            <a:latin typeface="Cambria Math" panose="02040503050406030204" pitchFamily="18" charset="0"/>
+                            <a:sym typeface="Wingdings" panose="05000000000000000000" pitchFamily="2" charset="2"/>
+                          </a:rPr>
+                          <m:t>)²</m:t>
+                        </m:r>
+                      </m:e>
+                    </m:rad>
+                    <m:r>
+                      <a:rPr lang="fr-FR" b="0" i="1" smtClean="0">
+                        <a:latin typeface="Cambria Math" panose="02040503050406030204" pitchFamily="18" charset="0"/>
+                      </a:rPr>
+                      <m:t>= 44.92 </m:t>
+                    </m:r>
+                    <m:r>
+                      <m:rPr>
+                        <m:sty m:val="p"/>
+                      </m:rPr>
+                      <a:rPr lang="fr-FR" b="0" i="1" smtClean="0">
+                        <a:latin typeface="Cambria Math" panose="02040503050406030204" pitchFamily="18" charset="0"/>
+                      </a:rPr>
+                      <m:t>K</m:t>
+                    </m:r>
+                  </m:oMath>
+                </a14:m>
+                <a:r>
+                  <a:rPr lang="en-US" dirty="0"/>
+                  <a:t>   </a:t>
+                </a:r>
+              </a:p>
+              <a:p>
+                <a:r>
+                  <a:rPr lang="en-US" dirty="0"/>
+                  <a:t>k =2 pour 95.4% de </a:t>
+                </a:r>
+                <a:r>
+                  <a:rPr lang="en-US" dirty="0" err="1"/>
+                  <a:t>confiance</a:t>
+                </a:r>
+                <a:r>
+                  <a:rPr lang="en-US" dirty="0"/>
+                  <a:t> </a:t>
+                </a:r>
+              </a:p>
+              <a:p>
+                <a:endParaRPr lang="en-US" dirty="0"/>
+              </a:p>
+              <a:p>
+                <a:pPr marL="0" indent="0">
+                  <a:buNone/>
+                </a:pPr>
+                <a14:m>
+                  <m:oMath xmlns:m="http://schemas.openxmlformats.org/officeDocument/2006/math">
+                    <m:r>
+                      <a:rPr lang="fr-FR" b="1" i="0" smtClean="0">
+                        <a:latin typeface="Cambria Math" panose="02040503050406030204" pitchFamily="18" charset="0"/>
+                      </a:rPr>
+                      <m:t>−</m:t>
+                    </m:r>
+                    <m:r>
+                      <a:rPr lang="fr-FR" b="1" i="0" smtClean="0">
+                        <a:latin typeface="Cambria Math" panose="02040503050406030204" pitchFamily="18" charset="0"/>
+                      </a:rPr>
+                      <m:t>𝟕𝟖</m:t>
+                    </m:r>
+                    <m:r>
+                      <a:rPr lang="fr-FR" b="1" i="0" smtClean="0">
+                        <a:latin typeface="Cambria Math" panose="02040503050406030204" pitchFamily="18" charset="0"/>
+                      </a:rPr>
+                      <m:t>.</m:t>
+                    </m:r>
+                    <m:r>
+                      <a:rPr lang="fr-FR" b="1" i="0" smtClean="0">
+                        <a:latin typeface="Cambria Math" panose="02040503050406030204" pitchFamily="18" charset="0"/>
+                      </a:rPr>
+                      <m:t>𝟎𝟒</m:t>
+                    </m:r>
+                    <m:r>
+                      <a:rPr lang="fr-FR" b="1" i="0" smtClean="0">
+                        <a:latin typeface="Cambria Math" panose="02040503050406030204" pitchFamily="18" charset="0"/>
+                      </a:rPr>
+                      <m:t> </m:t>
+                    </m:r>
+                    <m:r>
+                      <a:rPr lang="fr-FR" b="1" i="0" smtClean="0">
+                        <a:latin typeface="Cambria Math" panose="02040503050406030204" pitchFamily="18" charset="0"/>
+                      </a:rPr>
+                      <m:t>𝐊</m:t>
+                    </m:r>
+                    <m:r>
+                      <a:rPr lang="fr-FR" b="1" i="0" smtClean="0">
+                        <a:latin typeface="Cambria Math" panose="02040503050406030204" pitchFamily="18" charset="0"/>
+                      </a:rPr>
+                      <m:t>&lt;</m:t>
+                    </m:r>
+                    <m:sSub>
+                      <m:sSubPr>
+                        <m:ctrlPr>
+                          <a:rPr lang="fr-FR" b="1" i="1">
+                            <a:latin typeface="Cambria Math" panose="02040503050406030204" pitchFamily="18" charset="0"/>
+                          </a:rPr>
+                        </m:ctrlPr>
+                      </m:sSubPr>
+                      <m:e>
+                        <m:r>
+                          <a:rPr lang="fr-FR" b="1" i="0">
+                            <a:latin typeface="Cambria Math" panose="02040503050406030204" pitchFamily="18" charset="0"/>
+                          </a:rPr>
+                          <m:t>𝛅</m:t>
+                        </m:r>
+                      </m:e>
+                      <m:sub>
+                        <m:r>
+                          <a:rPr lang="fr-FR" b="1" i="0">
+                            <a:latin typeface="Cambria Math" panose="02040503050406030204" pitchFamily="18" charset="0"/>
+                          </a:rPr>
+                          <m:t>𝐦𝐨𝐝𝐞𝐥</m:t>
+                        </m:r>
+                      </m:sub>
+                    </m:sSub>
+                    <m:r>
+                      <a:rPr lang="fr-FR" b="1" i="0" smtClean="0">
+                        <a:latin typeface="Cambria Math" panose="02040503050406030204" pitchFamily="18" charset="0"/>
+                      </a:rPr>
+                      <m:t> &lt;</m:t>
+                    </m:r>
+                    <m:r>
+                      <a:rPr lang="fr-FR" b="1" i="0" smtClean="0">
+                        <a:latin typeface="Cambria Math" panose="02040503050406030204" pitchFamily="18" charset="0"/>
+                      </a:rPr>
+                      <m:t>𝟏𝟎𝟏</m:t>
+                    </m:r>
+                    <m:r>
+                      <a:rPr lang="fr-FR" b="1" i="0" smtClean="0">
+                        <a:latin typeface="Cambria Math" panose="02040503050406030204" pitchFamily="18" charset="0"/>
+                      </a:rPr>
+                      <m:t>.</m:t>
+                    </m:r>
+                    <m:r>
+                      <a:rPr lang="fr-FR" b="1" i="0" smtClean="0">
+                        <a:latin typeface="Cambria Math" panose="02040503050406030204" pitchFamily="18" charset="0"/>
+                      </a:rPr>
+                      <m:t>𝟔𝟒</m:t>
+                    </m:r>
+                    <m:r>
+                      <a:rPr lang="fr-FR" b="1" i="0" smtClean="0">
+                        <a:latin typeface="Cambria Math" panose="02040503050406030204" pitchFamily="18" charset="0"/>
+                      </a:rPr>
+                      <m:t> </m:t>
+                    </m:r>
+                    <m:r>
+                      <a:rPr lang="fr-FR" b="1" i="0" smtClean="0">
+                        <a:latin typeface="Cambria Math" panose="02040503050406030204" pitchFamily="18" charset="0"/>
+                      </a:rPr>
+                      <m:t>𝐊</m:t>
+                    </m:r>
+                  </m:oMath>
+                </a14:m>
+                <a:r>
+                  <a:rPr lang="en-US" b="1" dirty="0"/>
+                  <a:t> </a:t>
+                </a:r>
+              </a:p>
+              <a:p>
+                <a:pPr marL="0" indent="0">
+                  <a:buNone/>
+                </a:pPr>
+                <a:endParaRPr lang="en-US" b="1" dirty="0"/>
+              </a:p>
+              <a:p>
+                <a:pPr marL="0" indent="0">
+                  <a:buNone/>
+                </a:pPr>
+                <a14:m>
+                  <m:oMath xmlns:m="http://schemas.openxmlformats.org/officeDocument/2006/math">
+                    <m:r>
+                      <a:rPr lang="en-US" b="1" i="1" smtClean="0">
+                        <a:latin typeface="Cambria Math" panose="02040503050406030204" pitchFamily="18" charset="0"/>
+                      </a:rPr>
+                      <m:t>⇒</m:t>
+                    </m:r>
+                    <m:r>
+                      <a:rPr lang="fr-FR" b="1" i="1" smtClean="0">
+                        <a:latin typeface="Cambria Math" panose="02040503050406030204" pitchFamily="18" charset="0"/>
+                      </a:rPr>
+                      <m:t> </m:t>
+                    </m:r>
+                  </m:oMath>
+                </a14:m>
+                <a:r>
+                  <a:rPr lang="en-US" b="1" dirty="0"/>
+                  <a:t> </a:t>
+                </a:r>
+                <a:r>
+                  <a:rPr lang="en-US" b="1" dirty="0" err="1"/>
+                  <a:t>Amélioration</a:t>
+                </a:r>
+                <a:r>
+                  <a:rPr lang="en-US" b="1" dirty="0"/>
+                  <a:t> sur </a:t>
+                </a:r>
+                <a:r>
+                  <a:rPr lang="en-US" b="1" dirty="0" err="1"/>
+                  <a:t>l’incertitude</a:t>
+                </a:r>
+                <a:r>
+                  <a:rPr lang="en-US" b="1" dirty="0"/>
+                  <a:t> de </a:t>
+                </a:r>
+                <a:r>
+                  <a:rPr lang="en-US" b="1" dirty="0" err="1"/>
+                  <a:t>l’émissivité</a:t>
+                </a:r>
+                <a:r>
+                  <a:rPr lang="en-US" b="1" dirty="0"/>
+                  <a:t> </a:t>
+                </a:r>
+                <a:r>
+                  <a:rPr lang="en-US" b="1" dirty="0" err="1"/>
+                  <a:t>nécessaire</a:t>
+                </a:r>
+                <a:endParaRPr lang="en-US" b="1" dirty="0"/>
+              </a:p>
+            </p:txBody>
+          </p:sp>
+        </mc:Choice>
+        <mc:Fallback xmlns="">
+          <p:sp>
+            <p:nvSpPr>
+              <p:cNvPr id="3" name="Content Placeholder 2">
+                <a:extLst>
+                  <a:ext uri="{FF2B5EF4-FFF2-40B4-BE49-F238E27FC236}">
+                    <a16:creationId xmlns:a16="http://schemas.microsoft.com/office/drawing/2014/main" id="{41DABA39-902C-A6ED-B4EF-7E3705D66722}"/>
+                  </a:ext>
+                </a:extLst>
+              </p:cNvPr>
+              <p:cNvSpPr>
+                <a:spLocks noGrp="1" noRot="1" noChangeAspect="1" noMove="1" noResize="1" noEditPoints="1" noAdjustHandles="1" noChangeArrowheads="1" noChangeShapeType="1" noTextEdit="1"/>
+              </p:cNvSpPr>
+              <p:nvPr>
+                <p:ph idx="1"/>
+              </p:nvPr>
+            </p:nvSpPr>
+            <p:spPr>
+              <a:xfrm>
+                <a:off x="838200" y="1855122"/>
+                <a:ext cx="10515600" cy="4351338"/>
+              </a:xfrm>
+              <a:blipFill>
+                <a:blip r:embed="rId2"/>
+                <a:stretch>
+                  <a:fillRect l="-1043"/>
+                </a:stretch>
+              </a:blipFill>
+            </p:spPr>
+            <p:txBody>
+              <a:bodyPr/>
+              <a:lstStyle/>
+              <a:p>
+                <a:r>
+                  <a:rPr lang="en-US">
+                    <a:noFill/>
+                  </a:rPr>
+                  <a:t> </a:t>
+                </a:r>
+              </a:p>
+            </p:txBody>
+          </p:sp>
+        </mc:Fallback>
+      </mc:AlternateContent>
+      <p:sp>
+        <p:nvSpPr>
+          <p:cNvPr id="4" name="Rectangle 3">
+            <a:extLst>
+              <a:ext uri="{FF2B5EF4-FFF2-40B4-BE49-F238E27FC236}">
+                <a16:creationId xmlns:a16="http://schemas.microsoft.com/office/drawing/2014/main" id="{806A440F-4525-4755-9716-F3DDCC775AB6}"/>
+              </a:ext>
+            </a:extLst>
+          </p:cNvPr>
+          <p:cNvSpPr/>
+          <p:nvPr/>
+        </p:nvSpPr>
+        <p:spPr>
+          <a:xfrm>
+            <a:off x="838200" y="3932141"/>
+            <a:ext cx="5312780" cy="488220"/>
+          </a:xfrm>
+          <a:prstGeom prst="rect">
+            <a:avLst/>
+          </a:prstGeom>
+          <a:noFill/>
+          <a:ln w="28575">
+            <a:solidFill>
+              <a:schemeClr val="tx1"/>
+            </a:solidFill>
+          </a:ln>
+        </p:spPr>
+        <p:style>
+          <a:lnRef idx="2">
+            <a:schemeClr val="accent1">
+              <a:shade val="15000"/>
+            </a:schemeClr>
+          </a:lnRef>
+          <a:fillRef idx="1">
+            <a:schemeClr val="accent1"/>
+          </a:fillRef>
+          <a:effectRef idx="0">
+            <a:schemeClr val="accent1"/>
+          </a:effectRef>
+          <a:fontRef idx="minor">
+            <a:schemeClr val="lt1"/>
+          </a:fontRef>
+        </p:style>
+        <p:txBody>
+          <a:bodyPr rtlCol="0" anchor="ctr"/>
+          <a:lstStyle>
+            <a:defPPr>
+              <a:defRPr lang="fr-FR"/>
+            </a:defPPr>
+            <a:lvl1pPr marL="0" algn="l" defTabSz="914400" rtl="0" eaLnBrk="1" latinLnBrk="0" hangingPunct="1">
+              <a:defRPr sz="1800" kern="1200">
+                <a:solidFill>
+                  <a:schemeClr val="lt1"/>
+                </a:solidFill>
+                <a:latin typeface="+mn-lt"/>
+                <a:ea typeface="+mn-ea"/>
+                <a:cs typeface="+mn-cs"/>
+              </a:defRPr>
+            </a:lvl1pPr>
+            <a:lvl2pPr marL="457200" algn="l" defTabSz="914400" rtl="0" eaLnBrk="1" latinLnBrk="0" hangingPunct="1">
+              <a:defRPr sz="1800" kern="1200">
+                <a:solidFill>
+                  <a:schemeClr val="lt1"/>
+                </a:solidFill>
+                <a:latin typeface="+mn-lt"/>
+                <a:ea typeface="+mn-ea"/>
+                <a:cs typeface="+mn-cs"/>
+              </a:defRPr>
+            </a:lvl2pPr>
+            <a:lvl3pPr marL="914400" algn="l" defTabSz="914400" rtl="0" eaLnBrk="1" latinLnBrk="0" hangingPunct="1">
+              <a:defRPr sz="1800" kern="1200">
+                <a:solidFill>
+                  <a:schemeClr val="lt1"/>
+                </a:solidFill>
+                <a:latin typeface="+mn-lt"/>
+                <a:ea typeface="+mn-ea"/>
+                <a:cs typeface="+mn-cs"/>
+              </a:defRPr>
+            </a:lvl3pPr>
+            <a:lvl4pPr marL="1371600" algn="l" defTabSz="914400" rtl="0" eaLnBrk="1" latinLnBrk="0" hangingPunct="1">
+              <a:defRPr sz="1800" kern="1200">
+                <a:solidFill>
+                  <a:schemeClr val="lt1"/>
+                </a:solidFill>
+                <a:latin typeface="+mn-lt"/>
+                <a:ea typeface="+mn-ea"/>
+                <a:cs typeface="+mn-cs"/>
+              </a:defRPr>
+            </a:lvl4pPr>
+            <a:lvl5pPr marL="1828800" algn="l" defTabSz="914400" rtl="0" eaLnBrk="1" latinLnBrk="0" hangingPunct="1">
+              <a:defRPr sz="1800" kern="1200">
+                <a:solidFill>
+                  <a:schemeClr val="lt1"/>
+                </a:solidFill>
+                <a:latin typeface="+mn-lt"/>
+                <a:ea typeface="+mn-ea"/>
+                <a:cs typeface="+mn-cs"/>
+              </a:defRPr>
+            </a:lvl5pPr>
+            <a:lvl6pPr marL="2286000" algn="l" defTabSz="914400" rtl="0" eaLnBrk="1" latinLnBrk="0" hangingPunct="1">
+              <a:defRPr sz="1800" kern="1200">
+                <a:solidFill>
+                  <a:schemeClr val="lt1"/>
+                </a:solidFill>
+                <a:latin typeface="+mn-lt"/>
+                <a:ea typeface="+mn-ea"/>
+                <a:cs typeface="+mn-cs"/>
+              </a:defRPr>
+            </a:lvl6pPr>
+            <a:lvl7pPr marL="2743200" algn="l" defTabSz="914400" rtl="0" eaLnBrk="1" latinLnBrk="0" hangingPunct="1">
+              <a:defRPr sz="1800" kern="1200">
+                <a:solidFill>
+                  <a:schemeClr val="lt1"/>
+                </a:solidFill>
+                <a:latin typeface="+mn-lt"/>
+                <a:ea typeface="+mn-ea"/>
+                <a:cs typeface="+mn-cs"/>
+              </a:defRPr>
+            </a:lvl7pPr>
+            <a:lvl8pPr marL="3200400" algn="l" defTabSz="914400" rtl="0" eaLnBrk="1" latinLnBrk="0" hangingPunct="1">
+              <a:defRPr sz="1800" kern="1200">
+                <a:solidFill>
+                  <a:schemeClr val="lt1"/>
+                </a:solidFill>
+                <a:latin typeface="+mn-lt"/>
+                <a:ea typeface="+mn-ea"/>
+                <a:cs typeface="+mn-cs"/>
+              </a:defRPr>
+            </a:lvl8pPr>
+            <a:lvl9pPr marL="3657600" algn="l" defTabSz="914400" rtl="0" eaLnBrk="1" latinLnBrk="0" hangingPunct="1">
+              <a:defRPr sz="1800" kern="1200">
+                <a:solidFill>
+                  <a:schemeClr val="lt1"/>
+                </a:solidFill>
+                <a:latin typeface="+mn-lt"/>
+                <a:ea typeface="+mn-ea"/>
+                <a:cs typeface="+mn-cs"/>
+              </a:defRPr>
+            </a:lvl9pPr>
+          </a:lstStyle>
+          <a:p>
+            <a:pPr algn="ctr"/>
+            <a:endParaRPr lang="fr-FR"/>
+          </a:p>
+        </p:txBody>
+      </p:sp>
+      <p:pic>
+        <p:nvPicPr>
+          <p:cNvPr id="6" name="Picture 5">
+            <a:extLst>
+              <a:ext uri="{FF2B5EF4-FFF2-40B4-BE49-F238E27FC236}">
+                <a16:creationId xmlns:a16="http://schemas.microsoft.com/office/drawing/2014/main" id="{BA00158C-C960-342C-B0C7-9E64CB5F528C}"/>
+              </a:ext>
+            </a:extLst>
+          </p:cNvPr>
+          <p:cNvPicPr>
+            <a:picLocks noChangeAspect="1"/>
+          </p:cNvPicPr>
+          <p:nvPr/>
+        </p:nvPicPr>
+        <p:blipFill>
+          <a:blip r:embed="rId3"/>
+          <a:srcRect l="10238" b="2376"/>
+          <a:stretch>
+            <a:fillRect/>
+          </a:stretch>
+        </p:blipFill>
+        <p:spPr>
+          <a:xfrm>
+            <a:off x="6351639" y="3893193"/>
+            <a:ext cx="5002161" cy="566116"/>
+          </a:xfrm>
+          <a:prstGeom prst="rect">
+            <a:avLst/>
+          </a:prstGeom>
+        </p:spPr>
+      </p:pic>
+      <p:sp>
+        <p:nvSpPr>
+          <p:cNvPr id="5" name="Slide Number Placeholder 4">
+            <a:extLst>
+              <a:ext uri="{FF2B5EF4-FFF2-40B4-BE49-F238E27FC236}">
+                <a16:creationId xmlns:a16="http://schemas.microsoft.com/office/drawing/2014/main" id="{7EAE2EA8-7F3E-29F7-BF38-BCFC5580D379}"/>
+              </a:ext>
+            </a:extLst>
+          </p:cNvPr>
+          <p:cNvSpPr>
+            <a:spLocks noGrp="1"/>
+          </p:cNvSpPr>
+          <p:nvPr>
+            <p:ph type="sldNum" sz="quarter" idx="12"/>
+          </p:nvPr>
+        </p:nvSpPr>
+        <p:spPr/>
+        <p:txBody>
+          <a:bodyPr/>
+          <a:lstStyle/>
+          <a:p>
+            <a:fld id="{FD85B578-4E75-4E1C-9BE3-D5DCC0715B13}" type="slidenum">
+              <a:rPr lang="fr-FR" smtClean="0"/>
+              <a:t>30</a:t>
+            </a:fld>
+            <a:endParaRPr lang="fr-FR"/>
+          </a:p>
+        </p:txBody>
+      </p:sp>
+    </p:spTree>
+    <p:extLst>
+      <p:ext uri="{BB962C8B-B14F-4D97-AF65-F5344CB8AC3E}">
+        <p14:creationId xmlns:p14="http://schemas.microsoft.com/office/powerpoint/2010/main" val="3191033194"/>
+      </p:ext>
+    </p:extLst>
+  </p:cSld>
+  <p:clrMapOvr>
+    <a:masterClrMapping/>
+  </p:clrMapOvr>
+</p:sld>
+</file>
+
+<file path=ppt/slides/slide31.xml><?xml version="1.0" encoding="utf-8"?>
+<p:sld xmlns:a="http://schemas.openxmlformats.org/drawingml/2006/main" xmlns:r="http://schemas.openxmlformats.org/officeDocument/2006/relationships" xmlns:p="http://schemas.openxmlformats.org/presentationml/2006/main">
+  <p:cSld>
+    <p:spTree>
+      <p:nvGrpSpPr>
+        <p:cNvPr id="1" name=""/>
+        <p:cNvGrpSpPr/>
+        <p:nvPr/>
+      </p:nvGrpSpPr>
+      <p:grpSpPr>
+        <a:xfrm>
+          <a:off x="0" y="0"/>
+          <a:ext cx="0" cy="0"/>
+          <a:chOff x="0" y="0"/>
+          <a:chExt cx="0" cy="0"/>
+        </a:xfrm>
+      </p:grpSpPr>
+      <p:sp>
+        <p:nvSpPr>
+          <p:cNvPr id="2" name="Title 1">
+            <a:extLst>
+              <a:ext uri="{FF2B5EF4-FFF2-40B4-BE49-F238E27FC236}">
+                <a16:creationId xmlns:a16="http://schemas.microsoft.com/office/drawing/2014/main" id="{A28AFEF6-8EC2-0957-BC55-0F8F644E0B4A}"/>
+              </a:ext>
+            </a:extLst>
+          </p:cNvPr>
+          <p:cNvSpPr>
+            <a:spLocks noGrp="1"/>
+          </p:cNvSpPr>
+          <p:nvPr>
+            <p:ph type="title"/>
+          </p:nvPr>
+        </p:nvSpPr>
+        <p:spPr/>
+        <p:txBody>
+          <a:bodyPr/>
+          <a:lstStyle/>
+          <a:p>
+            <a:r>
+              <a:rPr lang="fr-FR" dirty="0"/>
+              <a:t>Analyse</a:t>
+            </a:r>
+            <a:endParaRPr lang="en-US" dirty="0"/>
+          </a:p>
+        </p:txBody>
+      </p:sp>
+      <p:pic>
+        <p:nvPicPr>
+          <p:cNvPr id="6" name="Content Placeholder 5">
+            <a:extLst>
+              <a:ext uri="{FF2B5EF4-FFF2-40B4-BE49-F238E27FC236}">
+                <a16:creationId xmlns:a16="http://schemas.microsoft.com/office/drawing/2014/main" id="{A9B1EB5D-6BED-13E3-7B99-2FF5E8D02C0F}"/>
+              </a:ext>
+            </a:extLst>
+          </p:cNvPr>
+          <p:cNvPicPr>
+            <a:picLocks noGrp="1" noChangeAspect="1"/>
+          </p:cNvPicPr>
+          <p:nvPr>
+            <p:ph idx="1"/>
+          </p:nvPr>
+        </p:nvPicPr>
+        <p:blipFill>
+          <a:blip r:embed="rId2">
+            <a:extLst>
+              <a:ext uri="{28A0092B-C50C-407E-A947-70E740481C1C}">
+                <a14:useLocalDpi xmlns:a14="http://schemas.microsoft.com/office/drawing/2010/main" val="0"/>
+              </a:ext>
+            </a:extLst>
+          </a:blip>
+          <a:stretch>
+            <a:fillRect/>
+          </a:stretch>
+        </p:blipFill>
+        <p:spPr>
+          <a:xfrm>
+            <a:off x="696077" y="1847850"/>
+            <a:ext cx="3565031" cy="4351338"/>
+          </a:xfrm>
+          <a:prstGeom prst="rect">
+            <a:avLst/>
+          </a:prstGeom>
+        </p:spPr>
+      </p:pic>
+      <p:sp>
+        <p:nvSpPr>
+          <p:cNvPr id="4" name="Slide Number Placeholder 3">
+            <a:extLst>
+              <a:ext uri="{FF2B5EF4-FFF2-40B4-BE49-F238E27FC236}">
+                <a16:creationId xmlns:a16="http://schemas.microsoft.com/office/drawing/2014/main" id="{8D57C330-FE28-8D25-5B72-A8BB2E6BC2C7}"/>
+              </a:ext>
+            </a:extLst>
+          </p:cNvPr>
+          <p:cNvSpPr>
+            <a:spLocks noGrp="1"/>
+          </p:cNvSpPr>
+          <p:nvPr>
+            <p:ph type="sldNum" sz="quarter" idx="12"/>
+          </p:nvPr>
+        </p:nvSpPr>
+        <p:spPr/>
+        <p:txBody>
+          <a:bodyPr/>
+          <a:lstStyle/>
+          <a:p>
+            <a:fld id="{FD85B578-4E75-4E1C-9BE3-D5DCC0715B13}" type="slidenum">
+              <a:rPr lang="fr-FR" smtClean="0"/>
+              <a:t>31</a:t>
+            </a:fld>
+            <a:endParaRPr lang="fr-FR"/>
+          </a:p>
+        </p:txBody>
+      </p:sp>
+      <p:sp>
+        <p:nvSpPr>
+          <p:cNvPr id="7" name="TextBox 6">
+            <a:extLst>
+              <a:ext uri="{FF2B5EF4-FFF2-40B4-BE49-F238E27FC236}">
+                <a16:creationId xmlns:a16="http://schemas.microsoft.com/office/drawing/2014/main" id="{C1F03330-F29A-3AD5-1C0C-F14A10FA4C72}"/>
+              </a:ext>
+            </a:extLst>
+          </p:cNvPr>
+          <p:cNvSpPr txBox="1"/>
+          <p:nvPr/>
+        </p:nvSpPr>
+        <p:spPr>
+          <a:xfrm>
+            <a:off x="696078" y="6199188"/>
+            <a:ext cx="3565030" cy="461665"/>
+          </a:xfrm>
+          <a:prstGeom prst="rect">
+            <a:avLst/>
+          </a:prstGeom>
+          <a:noFill/>
+        </p:spPr>
+        <p:txBody>
+          <a:bodyPr wrap="square" rtlCol="0">
+            <a:spAutoFit/>
+          </a:bodyPr>
+          <a:lstStyle/>
+          <a:p>
+            <a:pPr algn="ctr"/>
+            <a:r>
+              <a:rPr lang="fr-FR" sz="1200" dirty="0"/>
+              <a:t>Diagramme TTT pour 4340, source : Thèse </a:t>
+            </a:r>
+            <a:r>
+              <a:rPr lang="en-US" sz="1200" dirty="0"/>
+              <a:t>Jean Christophe Hell</a:t>
+            </a:r>
+          </a:p>
+        </p:txBody>
+      </p:sp>
+      <p:sp>
+        <p:nvSpPr>
+          <p:cNvPr id="8" name="TextBox 7">
+            <a:extLst>
+              <a:ext uri="{FF2B5EF4-FFF2-40B4-BE49-F238E27FC236}">
+                <a16:creationId xmlns:a16="http://schemas.microsoft.com/office/drawing/2014/main" id="{07FFD53F-2E3A-C030-8C63-BCCF5F1B32A3}"/>
+              </a:ext>
+            </a:extLst>
+          </p:cNvPr>
+          <p:cNvSpPr txBox="1"/>
+          <p:nvPr/>
+        </p:nvSpPr>
+        <p:spPr>
+          <a:xfrm>
+            <a:off x="4621161" y="1847850"/>
+            <a:ext cx="7246374" cy="2585323"/>
+          </a:xfrm>
+          <a:prstGeom prst="rect">
+            <a:avLst/>
+          </a:prstGeom>
+          <a:noFill/>
+        </p:spPr>
+        <p:txBody>
+          <a:bodyPr wrap="square" rtlCol="0">
+            <a:spAutoFit/>
+          </a:bodyPr>
+          <a:lstStyle/>
+          <a:p>
+            <a:r>
+              <a:rPr lang="fr-FR" dirty="0"/>
+              <a:t>Afin d’évaluer la pertinence du modèle pour l’application visée, cette erreur est comparée à un critère physique issu du diagramme TTT de l’acier 4340. Dans les zones critiques, une variation de l’ordre de 15°C entraîne des transformations de phase significativement différentes.</a:t>
+            </a:r>
+          </a:p>
+          <a:p>
+            <a:r>
+              <a:rPr lang="fr-FR" dirty="0"/>
+              <a:t>Ainsi, le modèle est considéré valide pour l’application si son erreur reste inférieure à cet ordre de grandeur.</a:t>
+            </a:r>
+          </a:p>
+          <a:p>
+            <a:endParaRPr lang="fr-FR" dirty="0"/>
+          </a:p>
+          <a:p>
+            <a:r>
+              <a:rPr lang="fr-FR" dirty="0"/>
+              <a:t>Tout le travaille repose sur la caractérisation de l’écart type de l’émissivité. </a:t>
+            </a:r>
+          </a:p>
+        </p:txBody>
+      </p:sp>
+    </p:spTree>
+    <p:extLst>
+      <p:ext uri="{BB962C8B-B14F-4D97-AF65-F5344CB8AC3E}">
+        <p14:creationId xmlns:p14="http://schemas.microsoft.com/office/powerpoint/2010/main" val="3753155108"/>
+      </p:ext>
+    </p:extLst>
+  </p:cSld>
+  <p:clrMapOvr>
+    <a:masterClrMapping/>
+  </p:clrMapOvr>
+</p:sld>
+</file>
+
+<file path=ppt/slides/slide32.xml><?xml version="1.0" encoding="utf-8"?>
+<p:sld xmlns:a="http://schemas.openxmlformats.org/drawingml/2006/main" xmlns:r="http://schemas.openxmlformats.org/officeDocument/2006/relationships" xmlns:p="http://schemas.openxmlformats.org/presentationml/2006/main">
+  <p:cSld>
+    <p:spTree>
+      <p:nvGrpSpPr>
+        <p:cNvPr id="1" name=""/>
+        <p:cNvGrpSpPr/>
+        <p:nvPr/>
+      </p:nvGrpSpPr>
+      <p:grpSpPr>
+        <a:xfrm>
+          <a:off x="0" y="0"/>
+          <a:ext cx="0" cy="0"/>
+          <a:chOff x="0" y="0"/>
+          <a:chExt cx="0" cy="0"/>
+        </a:xfrm>
+      </p:grpSpPr>
+      <p:sp>
+        <p:nvSpPr>
+          <p:cNvPr id="2" name="Title 1">
+            <a:extLst>
+              <a:ext uri="{FF2B5EF4-FFF2-40B4-BE49-F238E27FC236}">
                 <a16:creationId xmlns:a16="http://schemas.microsoft.com/office/drawing/2014/main" id="{7171FAF8-D45E-B846-39C4-A2BDDFE609C9}"/>
               </a:ext>
             </a:extLst>
@@ -24478,7 +25930,7 @@
           <a:p>
             <a:fld id="{FD85B578-4E75-4E1C-9BE3-D5DCC0715B13}" type="slidenum">
               <a:rPr lang="fr-FR" smtClean="0"/>
-              <a:t>30</a:t>
+              <a:t>32</a:t>
             </a:fld>
             <a:endParaRPr lang="fr-FR"/>
           </a:p>
@@ -24488,458 +25940,6 @@
     <p:extLst>
       <p:ext uri="{BB962C8B-B14F-4D97-AF65-F5344CB8AC3E}">
         <p14:creationId xmlns:p14="http://schemas.microsoft.com/office/powerpoint/2010/main" val="3426608694"/>
-      </p:ext>
-    </p:extLst>
-  </p:cSld>
-  <p:clrMapOvr>
-    <a:masterClrMapping/>
-  </p:clrMapOvr>
-</p:sld>
-</file>
-
-<file path=ppt/slides/slide31.xml><?xml version="1.0" encoding="utf-8"?>
-<p:sld xmlns:a="http://schemas.openxmlformats.org/drawingml/2006/main" xmlns:r="http://schemas.openxmlformats.org/officeDocument/2006/relationships" xmlns:p="http://schemas.openxmlformats.org/presentationml/2006/main">
-  <p:cSld>
-    <p:spTree>
-      <p:nvGrpSpPr>
-        <p:cNvPr id="1" name=""/>
-        <p:cNvGrpSpPr/>
-        <p:nvPr/>
-      </p:nvGrpSpPr>
-      <p:grpSpPr>
-        <a:xfrm>
-          <a:off x="0" y="0"/>
-          <a:ext cx="0" cy="0"/>
-          <a:chOff x="0" y="0"/>
-          <a:chExt cx="0" cy="0"/>
-        </a:xfrm>
-      </p:grpSpPr>
-      <p:sp>
-        <p:nvSpPr>
-          <p:cNvPr id="2" name="Title 1">
-            <a:extLst>
-              <a:ext uri="{FF2B5EF4-FFF2-40B4-BE49-F238E27FC236}">
-                <a16:creationId xmlns:a16="http://schemas.microsoft.com/office/drawing/2014/main" id="{08AFCC7F-3AF3-6D33-FB0F-E15C4FAC0B2D}"/>
-              </a:ext>
-            </a:extLst>
-          </p:cNvPr>
-          <p:cNvSpPr>
-            <a:spLocks noGrp="1"/>
-          </p:cNvSpPr>
-          <p:nvPr>
-            <p:ph type="title"/>
-          </p:nvPr>
-        </p:nvSpPr>
-        <p:spPr/>
-        <p:txBody>
-          <a:bodyPr/>
-          <a:lstStyle/>
-          <a:p>
-            <a:r>
-              <a:rPr lang="fr-FR" dirty="0"/>
-              <a:t>Annexe</a:t>
-            </a:r>
-            <a:endParaRPr lang="en-US" dirty="0"/>
-          </a:p>
-        </p:txBody>
-      </p:sp>
-      <p:pic>
-        <p:nvPicPr>
-          <p:cNvPr id="5" name="Content Placeholder 4">
-            <a:extLst>
-              <a:ext uri="{FF2B5EF4-FFF2-40B4-BE49-F238E27FC236}">
-                <a16:creationId xmlns:a16="http://schemas.microsoft.com/office/drawing/2014/main" id="{AFD8984B-B992-0FD9-B126-55C7737C1E84}"/>
-              </a:ext>
-            </a:extLst>
-          </p:cNvPr>
-          <p:cNvPicPr>
-            <a:picLocks noGrp="1" noChangeAspect="1"/>
-          </p:cNvPicPr>
-          <p:nvPr>
-            <p:ph idx="1"/>
-          </p:nvPr>
-        </p:nvPicPr>
-        <p:blipFill>
-          <a:blip r:embed="rId2">
-            <a:extLst>
-              <a:ext uri="{28A0092B-C50C-407E-A947-70E740481C1C}">
-                <a14:useLocalDpi xmlns:a14="http://schemas.microsoft.com/office/drawing/2010/main" val="0"/>
-              </a:ext>
-            </a:extLst>
-          </a:blip>
-          <a:stretch>
-            <a:fillRect/>
-          </a:stretch>
-        </p:blipFill>
-        <p:spPr>
-          <a:xfrm>
-            <a:off x="838200" y="1690688"/>
-            <a:ext cx="10515600" cy="3416374"/>
-          </a:xfrm>
-          <a:prstGeom prst="rect">
-            <a:avLst/>
-          </a:prstGeom>
-        </p:spPr>
-      </p:pic>
-      <mc:AlternateContent xmlns:mc="http://schemas.openxmlformats.org/markup-compatibility/2006" xmlns:a14="http://schemas.microsoft.com/office/drawing/2010/main">
-        <mc:Choice Requires="a14">
-          <p:sp>
-            <p:nvSpPr>
-              <p:cNvPr id="6" name="TextBox 5">
-                <a:extLst>
-                  <a:ext uri="{FF2B5EF4-FFF2-40B4-BE49-F238E27FC236}">
-                    <a16:creationId xmlns:a16="http://schemas.microsoft.com/office/drawing/2014/main" id="{D0E9DB5F-EBD0-D834-D4ED-493307BE600E}"/>
-                  </a:ext>
-                </a:extLst>
-              </p:cNvPr>
-              <p:cNvSpPr txBox="1"/>
-              <p:nvPr/>
-            </p:nvSpPr>
-            <p:spPr>
-              <a:xfrm>
-                <a:off x="954593" y="5456255"/>
-                <a:ext cx="10279464" cy="390748"/>
-              </a:xfrm>
-              <a:prstGeom prst="rect">
-                <a:avLst/>
-              </a:prstGeom>
-              <a:noFill/>
-            </p:spPr>
-            <p:txBody>
-              <a:bodyPr wrap="square" rtlCol="0">
-                <a:spAutoFit/>
-              </a:bodyPr>
-              <a:lstStyle/>
-              <a:p>
-                <a14:m>
-                  <m:oMath xmlns:m="http://schemas.openxmlformats.org/officeDocument/2006/math">
-                    <m:sSub>
-                      <m:sSubPr>
-                        <m:ctrlPr>
-                          <a:rPr lang="fr-FR" b="0" i="1" smtClean="0">
-                            <a:latin typeface="Cambria Math" panose="02040503050406030204" pitchFamily="18" charset="0"/>
-                          </a:rPr>
-                        </m:ctrlPr>
-                      </m:sSubPr>
-                      <m:e>
-                        <m:r>
-                          <a:rPr lang="fr-FR" b="0" i="1" smtClean="0">
-                            <a:latin typeface="Cambria Math" panose="02040503050406030204" pitchFamily="18" charset="0"/>
-                          </a:rPr>
-                          <m:t>𝑢</m:t>
-                        </m:r>
-                      </m:e>
-                      <m:sub>
-                        <m:r>
-                          <a:rPr lang="fr-FR" b="0" i="1" smtClean="0">
-                            <a:latin typeface="Cambria Math" panose="02040503050406030204" pitchFamily="18" charset="0"/>
-                          </a:rPr>
-                          <m:t>𝑖𝑛𝑝𝑢𝑡</m:t>
-                        </m:r>
-                      </m:sub>
-                    </m:sSub>
-                    <m:r>
-                      <a:rPr lang="fr-FR" b="0" i="1" smtClean="0">
-                        <a:latin typeface="Cambria Math" panose="02040503050406030204" pitchFamily="18" charset="0"/>
-                      </a:rPr>
-                      <m:t>=9.71 </m:t>
-                    </m:r>
-                    <m:r>
-                      <m:rPr>
-                        <m:sty m:val="p"/>
-                      </m:rPr>
-                      <a:rPr lang="fr-FR" b="0" i="1" smtClean="0">
-                        <a:latin typeface="Cambria Math" panose="02040503050406030204" pitchFamily="18" charset="0"/>
-                      </a:rPr>
-                      <m:t>K</m:t>
-                    </m:r>
-                  </m:oMath>
-                </a14:m>
-                <a:r>
-                  <a:rPr lang="en-US" dirty="0"/>
-                  <a:t> pour </a:t>
-                </a:r>
-                <a14:m>
-                  <m:oMath xmlns:m="http://schemas.openxmlformats.org/officeDocument/2006/math">
-                    <m:sSub>
-                      <m:sSubPr>
-                        <m:ctrlPr>
-                          <a:rPr lang="fr-FR" b="0" i="1" smtClean="0">
-                            <a:latin typeface="Cambria Math" panose="02040503050406030204" pitchFamily="18" charset="0"/>
-                          </a:rPr>
-                        </m:ctrlPr>
-                      </m:sSubPr>
-                      <m:e>
-                        <m:r>
-                          <a:rPr lang="fr-FR" b="0" i="1" smtClean="0">
-                            <a:latin typeface="Cambria Math" panose="02040503050406030204" pitchFamily="18" charset="0"/>
-                          </a:rPr>
-                          <m:t>𝜎</m:t>
-                        </m:r>
-                      </m:e>
-                      <m:sub>
-                        <m:r>
-                          <a:rPr lang="fr-FR" b="0" i="1" smtClean="0">
-                            <a:latin typeface="Cambria Math" panose="02040503050406030204" pitchFamily="18" charset="0"/>
-                          </a:rPr>
-                          <m:t>𝜀</m:t>
-                        </m:r>
-                      </m:sub>
-                    </m:sSub>
-                    <m:r>
-                      <a:rPr lang="fr-FR" b="0" i="1" smtClean="0">
-                        <a:latin typeface="Cambria Math" panose="02040503050406030204" pitchFamily="18" charset="0"/>
-                      </a:rPr>
-                      <m:t>=0.05</m:t>
-                    </m:r>
-                    <m:r>
-                      <a:rPr lang="en-US" b="1" i="1">
-                        <a:latin typeface="Cambria Math" panose="02040503050406030204" pitchFamily="18" charset="0"/>
-                      </a:rPr>
-                      <m:t>⇒</m:t>
-                    </m:r>
-                    <m:sSub>
-                      <m:sSubPr>
-                        <m:ctrlPr>
-                          <a:rPr lang="fr-FR" b="1" i="1" smtClean="0">
-                            <a:latin typeface="Cambria Math" panose="02040503050406030204" pitchFamily="18" charset="0"/>
-                          </a:rPr>
-                        </m:ctrlPr>
-                      </m:sSubPr>
-                      <m:e>
-                        <m:r>
-                          <a:rPr lang="fr-FR" b="1" i="1" smtClean="0">
-                            <a:latin typeface="Cambria Math" panose="02040503050406030204" pitchFamily="18" charset="0"/>
-                          </a:rPr>
-                          <m:t>𝒖</m:t>
-                        </m:r>
-                      </m:e>
-                      <m:sub>
-                        <m:r>
-                          <a:rPr lang="fr-FR" b="1" i="1" smtClean="0">
-                            <a:latin typeface="Cambria Math" panose="02040503050406030204" pitchFamily="18" charset="0"/>
-                          </a:rPr>
-                          <m:t>𝒗𝒂𝒍</m:t>
-                        </m:r>
-                      </m:sub>
-                    </m:sSub>
-                    <m:r>
-                      <a:rPr lang="fr-FR" b="1" i="1" smtClean="0">
-                        <a:latin typeface="Cambria Math" panose="02040503050406030204" pitchFamily="18" charset="0"/>
-                      </a:rPr>
-                      <m:t>=</m:t>
-                    </m:r>
-                    <m:r>
-                      <a:rPr lang="fr-FR" b="1" i="1" smtClean="0">
-                        <a:latin typeface="Cambria Math" panose="02040503050406030204" pitchFamily="18" charset="0"/>
-                      </a:rPr>
-                      <m:t>𝟗</m:t>
-                    </m:r>
-                    <m:r>
-                      <a:rPr lang="fr-FR" b="1" i="1" smtClean="0">
-                        <a:latin typeface="Cambria Math" panose="02040503050406030204" pitchFamily="18" charset="0"/>
-                      </a:rPr>
-                      <m:t>.</m:t>
-                    </m:r>
-                    <m:r>
-                      <a:rPr lang="fr-FR" b="1" i="1" smtClean="0">
-                        <a:latin typeface="Cambria Math" panose="02040503050406030204" pitchFamily="18" charset="0"/>
-                      </a:rPr>
-                      <m:t>𝟕𝟓</m:t>
-                    </m:r>
-                    <m:r>
-                      <a:rPr lang="fr-FR" b="1" i="1" smtClean="0">
-                        <a:latin typeface="Cambria Math" panose="02040503050406030204" pitchFamily="18" charset="0"/>
-                      </a:rPr>
-                      <m:t> </m:t>
-                    </m:r>
-                    <m:r>
-                      <a:rPr lang="fr-FR" b="1" i="1" smtClean="0">
-                        <a:latin typeface="Cambria Math" panose="02040503050406030204" pitchFamily="18" charset="0"/>
-                      </a:rPr>
-                      <m:t>𝑲</m:t>
-                    </m:r>
-                  </m:oMath>
-                </a14:m>
-                <a:r>
-                  <a:rPr lang="en-US" dirty="0"/>
-                  <a:t> </a:t>
-                </a:r>
-                <a14:m>
-                  <m:oMath xmlns:m="http://schemas.openxmlformats.org/officeDocument/2006/math">
-                    <m:r>
-                      <a:rPr lang="en-US" b="1" i="1">
-                        <a:latin typeface="Cambria Math" panose="02040503050406030204" pitchFamily="18" charset="0"/>
-                      </a:rPr>
-                      <m:t>⇒</m:t>
-                    </m:r>
-                    <m:r>
-                      <m:rPr>
-                        <m:nor/>
-                      </m:rPr>
-                      <a:rPr lang="en-US" dirty="0"/>
-                      <m:t>−7.70 </m:t>
-                    </m:r>
-                    <m:r>
-                      <m:rPr>
-                        <m:nor/>
-                      </m:rPr>
-                      <a:rPr lang="en-US" dirty="0"/>
-                      <m:t>K</m:t>
-                    </m:r>
-                    <m:r>
-                      <m:rPr>
-                        <m:nor/>
-                      </m:rPr>
-                      <a:rPr lang="en-US" dirty="0"/>
-                      <m:t> &lt;</m:t>
-                    </m:r>
-                    <m:sSub>
-                      <m:sSubPr>
-                        <m:ctrlPr>
-                          <a:rPr lang="fr-FR" i="1">
-                            <a:latin typeface="Cambria Math" panose="02040503050406030204" pitchFamily="18" charset="0"/>
-                          </a:rPr>
-                        </m:ctrlPr>
-                      </m:sSubPr>
-                      <m:e>
-                        <m:r>
-                          <a:rPr lang="fr-FR" b="0" i="1" smtClean="0">
-                            <a:latin typeface="Cambria Math" panose="02040503050406030204" pitchFamily="18" charset="0"/>
-                          </a:rPr>
-                          <m:t> </m:t>
-                        </m:r>
-                        <m:r>
-                          <m:rPr>
-                            <m:sty m:val="p"/>
-                          </m:rPr>
-                          <a:rPr lang="fr-FR" b="0" i="1">
-                            <a:latin typeface="Cambria Math" panose="02040503050406030204" pitchFamily="18" charset="0"/>
-                          </a:rPr>
-                          <m:t>δ</m:t>
-                        </m:r>
-                      </m:e>
-                      <m:sub>
-                        <m:r>
-                          <m:rPr>
-                            <m:sty m:val="p"/>
-                          </m:rPr>
-                          <a:rPr lang="fr-FR" b="0" i="1">
-                            <a:latin typeface="Cambria Math" panose="02040503050406030204" pitchFamily="18" charset="0"/>
-                          </a:rPr>
-                          <m:t>model</m:t>
-                        </m:r>
-                      </m:sub>
-                    </m:sSub>
-                    <m:r>
-                      <a:rPr lang="fr-FR" b="0">
-                        <a:latin typeface="Cambria Math" panose="02040503050406030204" pitchFamily="18" charset="0"/>
-                      </a:rPr>
-                      <m:t>&lt;</m:t>
-                    </m:r>
-                    <m:r>
-                      <a:rPr lang="fr-FR" b="0" i="0" smtClean="0">
-                        <a:latin typeface="Cambria Math" panose="02040503050406030204" pitchFamily="18" charset="0"/>
-                      </a:rPr>
-                      <m:t>31.30</m:t>
-                    </m:r>
-                    <m:r>
-                      <m:rPr>
-                        <m:sty m:val="p"/>
-                      </m:rPr>
-                      <a:rPr lang="fr-FR" b="0" i="1">
-                        <a:latin typeface="Cambria Math" panose="02040503050406030204" pitchFamily="18" charset="0"/>
-                      </a:rPr>
-                      <m:t>K</m:t>
-                    </m:r>
-                  </m:oMath>
-                </a14:m>
-                <a:r>
-                  <a:rPr lang="en-US" dirty="0"/>
-                  <a:t> </a:t>
-                </a:r>
-              </a:p>
-            </p:txBody>
-          </p:sp>
-        </mc:Choice>
-        <mc:Fallback xmlns="">
-          <p:sp>
-            <p:nvSpPr>
-              <p:cNvPr id="6" name="TextBox 5">
-                <a:extLst>
-                  <a:ext uri="{FF2B5EF4-FFF2-40B4-BE49-F238E27FC236}">
-                    <a16:creationId xmlns:a16="http://schemas.microsoft.com/office/drawing/2014/main" id="{D0E9DB5F-EBD0-D834-D4ED-493307BE600E}"/>
-                  </a:ext>
-                </a:extLst>
-              </p:cNvPr>
-              <p:cNvSpPr txBox="1">
-                <a:spLocks noRot="1" noChangeAspect="1" noMove="1" noResize="1" noEditPoints="1" noAdjustHandles="1" noChangeArrowheads="1" noChangeShapeType="1" noTextEdit="1"/>
-              </p:cNvSpPr>
-              <p:nvPr/>
-            </p:nvSpPr>
-            <p:spPr>
-              <a:xfrm>
-                <a:off x="954593" y="5456255"/>
-                <a:ext cx="10279464" cy="390748"/>
-              </a:xfrm>
-              <a:prstGeom prst="rect">
-                <a:avLst/>
-              </a:prstGeom>
-              <a:blipFill>
-                <a:blip r:embed="rId3"/>
-                <a:stretch>
-                  <a:fillRect t="-4688" b="-21875"/>
-                </a:stretch>
-              </a:blipFill>
-            </p:spPr>
-            <p:txBody>
-              <a:bodyPr/>
-              <a:lstStyle/>
-              <a:p>
-                <a:r>
-                  <a:rPr lang="en-US">
-                    <a:noFill/>
-                  </a:rPr>
-                  <a:t> </a:t>
-                </a:r>
-              </a:p>
-            </p:txBody>
-          </p:sp>
-        </mc:Fallback>
-      </mc:AlternateContent>
-      <p:sp>
-        <p:nvSpPr>
-          <p:cNvPr id="3" name="Slide Number Placeholder 2">
-            <a:extLst>
-              <a:ext uri="{FF2B5EF4-FFF2-40B4-BE49-F238E27FC236}">
-                <a16:creationId xmlns:a16="http://schemas.microsoft.com/office/drawing/2014/main" id="{4FE09455-7A8D-7C98-051B-E028203490D8}"/>
-              </a:ext>
-            </a:extLst>
-          </p:cNvPr>
-          <p:cNvSpPr>
-            <a:spLocks noGrp="1"/>
-          </p:cNvSpPr>
-          <p:nvPr>
-            <p:ph type="sldNum" sz="quarter" idx="12"/>
-          </p:nvPr>
-        </p:nvSpPr>
-        <p:spPr/>
-        <p:txBody>
-          <a:bodyPr/>
-          <a:lstStyle/>
-          <a:p>
-            <a:fld id="{FD85B578-4E75-4E1C-9BE3-D5DCC0715B13}" type="slidenum">
-              <a:rPr lang="fr-FR" smtClean="0"/>
-              <a:t>31</a:t>
-            </a:fld>
-            <a:endParaRPr lang="fr-FR"/>
-          </a:p>
-        </p:txBody>
-      </p:sp>
-    </p:spTree>
-    <p:extLst>
-      <p:ext uri="{BB962C8B-B14F-4D97-AF65-F5344CB8AC3E}">
-        <p14:creationId xmlns:p14="http://schemas.microsoft.com/office/powerpoint/2010/main" val="2932396356"/>
       </p:ext>
     </p:extLst>
   </p:cSld>

</xml_diff>

<commit_message>
pwp: ajout de détails sur la description du code
</commit_message>
<xml_diff>
--- a/projet_final/projet_final/MEC8211-Projet-final-Presentation.pptx
+++ b/projet_final/projet_final/MEC8211-Projet-final-Presentation.pptx
@@ -5,7 +5,7 @@
     <p:sldMasterId id="2147483648" r:id="rId1"/>
   </p:sldMasterIdLst>
   <p:notesMasterIdLst>
-    <p:notesMasterId r:id="rId34"/>
+    <p:notesMasterId r:id="rId35"/>
   </p:notesMasterIdLst>
   <p:sldIdLst>
     <p:sldId id="256" r:id="rId2"/>
@@ -21,25 +21,26 @@
     <p:sldId id="262" r:id="rId12"/>
     <p:sldId id="283" r:id="rId13"/>
     <p:sldId id="269" r:id="rId14"/>
-    <p:sldId id="286" r:id="rId15"/>
-    <p:sldId id="284" r:id="rId16"/>
-    <p:sldId id="261" r:id="rId17"/>
-    <p:sldId id="265" r:id="rId18"/>
-    <p:sldId id="266" r:id="rId19"/>
-    <p:sldId id="267" r:id="rId20"/>
-    <p:sldId id="268" r:id="rId21"/>
-    <p:sldId id="285" r:id="rId22"/>
-    <p:sldId id="272" r:id="rId23"/>
-    <p:sldId id="270" r:id="rId24"/>
-    <p:sldId id="287" r:id="rId25"/>
-    <p:sldId id="271" r:id="rId26"/>
-    <p:sldId id="278" r:id="rId27"/>
-    <p:sldId id="273" r:id="rId28"/>
-    <p:sldId id="276" r:id="rId29"/>
-    <p:sldId id="288" r:id="rId30"/>
-    <p:sldId id="277" r:id="rId31"/>
-    <p:sldId id="289" r:id="rId32"/>
-    <p:sldId id="274" r:id="rId33"/>
+    <p:sldId id="290" r:id="rId15"/>
+    <p:sldId id="286" r:id="rId16"/>
+    <p:sldId id="284" r:id="rId17"/>
+    <p:sldId id="261" r:id="rId18"/>
+    <p:sldId id="265" r:id="rId19"/>
+    <p:sldId id="266" r:id="rId20"/>
+    <p:sldId id="267" r:id="rId21"/>
+    <p:sldId id="268" r:id="rId22"/>
+    <p:sldId id="285" r:id="rId23"/>
+    <p:sldId id="272" r:id="rId24"/>
+    <p:sldId id="270" r:id="rId25"/>
+    <p:sldId id="287" r:id="rId26"/>
+    <p:sldId id="271" r:id="rId27"/>
+    <p:sldId id="278" r:id="rId28"/>
+    <p:sldId id="273" r:id="rId29"/>
+    <p:sldId id="276" r:id="rId30"/>
+    <p:sldId id="288" r:id="rId31"/>
+    <p:sldId id="277" r:id="rId32"/>
+    <p:sldId id="289" r:id="rId33"/>
+    <p:sldId id="274" r:id="rId34"/>
   </p:sldIdLst>
   <p:sldSz cx="12192000" cy="6858000"/>
   <p:notesSz cx="6858000" cy="9144000"/>
@@ -386,7 +387,7 @@
           <a:p>
             <a:fld id="{F6105186-0725-443C-BC59-E521425E81CD}" type="slidenum">
               <a:rPr lang="fr-FR" smtClean="0"/>
-              <a:t>‹#›</a:t>
+              <a:t>‹N°›</a:t>
             </a:fld>
             <a:endParaRPr lang="fr-FR"/>
           </a:p>
@@ -836,7 +837,7 @@
           <a:p>
             <a:fld id="{F6105186-0725-443C-BC59-E521425E81CD}" type="slidenum">
               <a:rPr lang="fr-FR" smtClean="0"/>
-              <a:t>27</a:t>
+              <a:t>28</a:t>
             </a:fld>
             <a:endParaRPr lang="fr-FR"/>
           </a:p>
@@ -1056,7 +1057,7 @@
           <a:p>
             <a:fld id="{FD85B578-4E75-4E1C-9BE3-D5DCC0715B13}" type="slidenum">
               <a:rPr lang="fr-FR" smtClean="0"/>
-              <a:t>‹#›</a:t>
+              <a:t>‹N°›</a:t>
             </a:fld>
             <a:endParaRPr lang="fr-FR"/>
           </a:p>
@@ -1254,7 +1255,7 @@
           <a:p>
             <a:fld id="{FD85B578-4E75-4E1C-9BE3-D5DCC0715B13}" type="slidenum">
               <a:rPr lang="fr-FR" smtClean="0"/>
-              <a:t>‹#›</a:t>
+              <a:t>‹N°›</a:t>
             </a:fld>
             <a:endParaRPr lang="fr-FR"/>
           </a:p>
@@ -1462,7 +1463,7 @@
           <a:p>
             <a:fld id="{FD85B578-4E75-4E1C-9BE3-D5DCC0715B13}" type="slidenum">
               <a:rPr lang="fr-FR" smtClean="0"/>
-              <a:t>‹#›</a:t>
+              <a:t>‹N°›</a:t>
             </a:fld>
             <a:endParaRPr lang="fr-FR"/>
           </a:p>
@@ -1660,7 +1661,7 @@
           <a:p>
             <a:fld id="{FD85B578-4E75-4E1C-9BE3-D5DCC0715B13}" type="slidenum">
               <a:rPr lang="fr-FR" smtClean="0"/>
-              <a:t>‹#›</a:t>
+              <a:t>‹N°›</a:t>
             </a:fld>
             <a:endParaRPr lang="fr-FR"/>
           </a:p>
@@ -1935,7 +1936,7 @@
           <a:p>
             <a:fld id="{FD85B578-4E75-4E1C-9BE3-D5DCC0715B13}" type="slidenum">
               <a:rPr lang="fr-FR" smtClean="0"/>
-              <a:t>‹#›</a:t>
+              <a:t>‹N°›</a:t>
             </a:fld>
             <a:endParaRPr lang="fr-FR"/>
           </a:p>
@@ -2200,7 +2201,7 @@
           <a:p>
             <a:fld id="{FD85B578-4E75-4E1C-9BE3-D5DCC0715B13}" type="slidenum">
               <a:rPr lang="fr-FR" smtClean="0"/>
-              <a:t>‹#›</a:t>
+              <a:t>‹N°›</a:t>
             </a:fld>
             <a:endParaRPr lang="fr-FR"/>
           </a:p>
@@ -2612,7 +2613,7 @@
           <a:p>
             <a:fld id="{FD85B578-4E75-4E1C-9BE3-D5DCC0715B13}" type="slidenum">
               <a:rPr lang="fr-FR" smtClean="0"/>
-              <a:t>‹#›</a:t>
+              <a:t>‹N°›</a:t>
             </a:fld>
             <a:endParaRPr lang="fr-FR"/>
           </a:p>
@@ -2753,7 +2754,7 @@
           <a:p>
             <a:fld id="{FD85B578-4E75-4E1C-9BE3-D5DCC0715B13}" type="slidenum">
               <a:rPr lang="fr-FR" smtClean="0"/>
-              <a:t>‹#›</a:t>
+              <a:t>‹N°›</a:t>
             </a:fld>
             <a:endParaRPr lang="fr-FR"/>
           </a:p>
@@ -2866,7 +2867,7 @@
           <a:p>
             <a:fld id="{FD85B578-4E75-4E1C-9BE3-D5DCC0715B13}" type="slidenum">
               <a:rPr lang="fr-FR" smtClean="0"/>
-              <a:t>‹#›</a:t>
+              <a:t>‹N°›</a:t>
             </a:fld>
             <a:endParaRPr lang="fr-FR"/>
           </a:p>
@@ -3177,7 +3178,7 @@
           <a:p>
             <a:fld id="{FD85B578-4E75-4E1C-9BE3-D5DCC0715B13}" type="slidenum">
               <a:rPr lang="fr-FR" smtClean="0"/>
-              <a:t>‹#›</a:t>
+              <a:t>‹N°›</a:t>
             </a:fld>
             <a:endParaRPr lang="fr-FR"/>
           </a:p>
@@ -3465,7 +3466,7 @@
           <a:p>
             <a:fld id="{FD85B578-4E75-4E1C-9BE3-D5DCC0715B13}" type="slidenum">
               <a:rPr lang="fr-FR" smtClean="0"/>
-              <a:t>‹#›</a:t>
+              <a:t>‹N°›</a:t>
             </a:fld>
             <a:endParaRPr lang="fr-FR"/>
           </a:p>
@@ -3745,7 +3746,7 @@
           <a:p>
             <a:fld id="{FD85B578-4E75-4E1C-9BE3-D5DCC0715B13}" type="slidenum">
               <a:rPr lang="fr-FR" smtClean="0"/>
-              <a:t>‹#›</a:t>
+              <a:t>‹N°›</a:t>
             </a:fld>
             <a:endParaRPr lang="fr-FR"/>
           </a:p>
@@ -12330,18 +12331,18 @@
         </p:nvSpPr>
         <p:spPr>
           <a:xfrm>
-            <a:off x="838200" y="0"/>
-            <a:ext cx="10515600" cy="1325563"/>
+            <a:off x="761800" y="762001"/>
+            <a:ext cx="5334197" cy="1708242"/>
           </a:xfrm>
         </p:spPr>
         <p:txBody>
-          <a:bodyPr>
+          <a:bodyPr anchor="ctr">
             <a:normAutofit/>
           </a:bodyPr>
           <a:lstStyle/>
           <a:p>
             <a:r>
-              <a:rPr lang="fr-FR" dirty="0"/>
+              <a:rPr lang="fr-FR" sz="4000"/>
               <a:t>Description du code :</a:t>
             </a:r>
           </a:p>
@@ -12367,31 +12368,45 @@
             </p:nvSpPr>
             <p:spPr>
               <a:xfrm>
-                <a:off x="261258" y="1331494"/>
-                <a:ext cx="11930742" cy="5526505"/>
+                <a:off x="761800" y="2228850"/>
+                <a:ext cx="6505775" cy="4011229"/>
               </a:xfrm>
             </p:spPr>
             <p:txBody>
-              <a:bodyPr>
+              <a:bodyPr anchor="ctr">
                 <a:normAutofit/>
               </a:bodyPr>
               <a:lstStyle/>
               <a:p>
                 <a:r>
-                  <a:rPr lang="fr-FR" dirty="0"/>
-                  <a:t>main.py : fichier permettant d’exécuter le solveur pour une configuration prédéterminée.</a:t>
+                  <a:rPr lang="fr-FR" sz="1300" dirty="0"/>
+                  <a:t>main.py :</a:t>
+                </a:r>
+              </a:p>
+              <a:p>
+                <a:pPr lvl="1"/>
+                <a:r>
+                  <a:rPr lang="fr-FR" sz="1200" dirty="0"/>
+                  <a:t>Usage typique du solveur pour une configuration prédéterminée (énoncé du problème).</a:t>
+                </a:r>
+              </a:p>
+              <a:p>
+                <a:pPr lvl="1"/>
+                <a:r>
+                  <a:rPr lang="fr-FR" sz="1200" dirty="0"/>
+                  <a:t>Usage typique du solveur pour une configuration avec MMS.</a:t>
                 </a:r>
               </a:p>
               <a:p>
                 <a:r>
-                  <a:rPr lang="fr-FR" dirty="0"/>
+                  <a:rPr lang="fr-FR" sz="1300" dirty="0"/>
                   <a:t>fonctions.py : le cœur du code</a:t>
                 </a:r>
               </a:p>
               <a:p>
                 <a:pPr lvl="1"/>
                 <a:r>
-                  <a:rPr lang="fr-FR" dirty="0"/>
+                  <a:rPr lang="fr-FR" sz="1300" dirty="0"/>
                   <a:t>Classe Paramètres : classe contenant la configuration du problème.</a:t>
                 </a:r>
               </a:p>
@@ -12405,14 +12420,14 @@
                     <m:sSub>
                       <m:sSubPr>
                         <m:ctrlPr>
-                          <a:rPr lang="fr-CA" b="0" i="1" smtClean="0">
+                          <a:rPr lang="fr-CA" sz="1300" b="0" i="1">
                             <a:latin typeface="Cambria Math" panose="02040503050406030204" pitchFamily="18" charset="0"/>
                           </a:rPr>
                         </m:ctrlPr>
                       </m:sSubPr>
                       <m:e>
                         <m:r>
-                          <a:rPr lang="fr-CA" b="0" i="1" smtClean="0">
+                          <a:rPr lang="fr-CA" sz="1300" b="0" i="1">
                             <a:latin typeface="Cambria Math" panose="02040503050406030204" pitchFamily="18" charset="0"/>
                           </a:rPr>
                           <m:t>𝑅</m:t>
@@ -12420,7 +12435,7 @@
                       </m:e>
                       <m:sub>
                         <m:r>
-                          <a:rPr lang="fr-CA" b="0" i="1" smtClean="0">
+                          <a:rPr lang="fr-CA" sz="1300" b="0" i="1">
                             <a:latin typeface="Cambria Math" panose="02040503050406030204" pitchFamily="18" charset="0"/>
                           </a:rPr>
                           <m:t>𝑚𝑎𝑥</m:t>
@@ -12428,19 +12443,19 @@
                       </m:sub>
                     </m:sSub>
                     <m:r>
-                      <a:rPr lang="fr-CA" b="0" i="1" smtClean="0">
+                      <a:rPr lang="fr-CA" sz="1300" b="0" i="1">
                         <a:latin typeface="Cambria Math" panose="02040503050406030204" pitchFamily="18" charset="0"/>
                       </a:rPr>
                       <m:t>,</m:t>
                     </m:r>
                     <m:r>
-                      <a:rPr lang="fr-CA" b="0" i="1" smtClean="0">
+                      <a:rPr lang="fr-CA" sz="1300" b="0" i="1">
                         <a:latin typeface="Cambria Math" panose="02040503050406030204" pitchFamily="18" charset="0"/>
                       </a:rPr>
                       <m:t>𝜌</m:t>
                     </m:r>
                     <m:r>
-                      <a:rPr lang="fr-CA" b="0" i="1" smtClean="0">
+                      <a:rPr lang="fr-CA" sz="1300" b="0" i="1">
                         <a:latin typeface="Cambria Math" panose="02040503050406030204" pitchFamily="18" charset="0"/>
                       </a:rPr>
                       <m:t>,</m:t>
@@ -12448,14 +12463,14 @@
                     <m:sSub>
                       <m:sSubPr>
                         <m:ctrlPr>
-                          <a:rPr lang="fr-CA" b="0" i="1" smtClean="0">
+                          <a:rPr lang="fr-CA" sz="1300" b="0" i="1">
                             <a:latin typeface="Cambria Math" panose="02040503050406030204" pitchFamily="18" charset="0"/>
                           </a:rPr>
                         </m:ctrlPr>
                       </m:sSubPr>
                       <m:e>
                         <m:r>
-                          <a:rPr lang="fr-CA" b="0" i="1" smtClean="0">
+                          <a:rPr lang="fr-CA" sz="1300" b="0" i="1">
                             <a:latin typeface="Cambria Math" panose="02040503050406030204" pitchFamily="18" charset="0"/>
                           </a:rPr>
                           <m:t>𝐶</m:t>
@@ -12463,7 +12478,7 @@
                       </m:e>
                       <m:sub>
                         <m:r>
-                          <a:rPr lang="fr-CA" b="0" i="1" smtClean="0">
+                          <a:rPr lang="fr-CA" sz="1300" b="0" i="1">
                             <a:latin typeface="Cambria Math" panose="02040503050406030204" pitchFamily="18" charset="0"/>
                           </a:rPr>
                           <m:t>𝑝</m:t>
@@ -12471,67 +12486,67 @@
                       </m:sub>
                     </m:sSub>
                     <m:r>
-                      <a:rPr lang="fr-CA" b="0" i="1" smtClean="0">
+                      <a:rPr lang="fr-CA" sz="1300" b="0" i="1">
                         <a:latin typeface="Cambria Math" panose="02040503050406030204" pitchFamily="18" charset="0"/>
                       </a:rPr>
                       <m:t>, </m:t>
                     </m:r>
                     <m:r>
-                      <a:rPr lang="fr-CA" b="0" i="1" smtClean="0">
+                      <a:rPr lang="fr-CA" sz="1300" b="0" i="1">
                         <a:latin typeface="Cambria Math" panose="02040503050406030204" pitchFamily="18" charset="0"/>
                       </a:rPr>
                       <m:t>𝑛𝑟</m:t>
                     </m:r>
                     <m:r>
-                      <a:rPr lang="fr-CA" b="0" i="1" smtClean="0">
+                      <a:rPr lang="fr-CA" sz="1300" b="0" i="1">
                         <a:latin typeface="Cambria Math" panose="02040503050406030204" pitchFamily="18" charset="0"/>
                       </a:rPr>
                       <m:t>,</m:t>
                     </m:r>
                     <m:r>
-                      <a:rPr lang="fr-CA" b="0" i="1" smtClean="0">
+                      <a:rPr lang="fr-CA" sz="1300" b="0" i="1">
                         <a:latin typeface="Cambria Math" panose="02040503050406030204" pitchFamily="18" charset="0"/>
                       </a:rPr>
                       <m:t>𝑛𝑧</m:t>
                     </m:r>
                     <m:r>
-                      <a:rPr lang="fr-CA" b="0" i="1" smtClean="0">
+                      <a:rPr lang="fr-CA" sz="1300" b="0" i="1">
                         <a:latin typeface="Cambria Math" panose="02040503050406030204" pitchFamily="18" charset="0"/>
                       </a:rPr>
                       <m:t>,</m:t>
                     </m:r>
                     <m:r>
-                      <a:rPr lang="fr-CA" b="0" i="1" smtClean="0">
+                      <a:rPr lang="fr-CA" sz="1300" b="0" i="1">
                         <a:latin typeface="Cambria Math" panose="02040503050406030204" pitchFamily="18" charset="0"/>
                       </a:rPr>
                       <m:t>𝑑𝑟</m:t>
                     </m:r>
                     <m:r>
-                      <a:rPr lang="fr-CA" b="0" i="1" smtClean="0">
+                      <a:rPr lang="fr-CA" sz="1300" b="0" i="1">
                         <a:latin typeface="Cambria Math" panose="02040503050406030204" pitchFamily="18" charset="0"/>
                       </a:rPr>
                       <m:t>,</m:t>
                     </m:r>
                     <m:r>
-                      <a:rPr lang="fr-CA" b="0" i="1" smtClean="0">
+                      <a:rPr lang="fr-CA" sz="1300" b="0" i="1">
                         <a:latin typeface="Cambria Math" panose="02040503050406030204" pitchFamily="18" charset="0"/>
                       </a:rPr>
                       <m:t>𝑑𝑧</m:t>
                     </m:r>
                     <m:r>
-                      <a:rPr lang="fr-CA" b="0" i="1" smtClean="0">
+                      <a:rPr lang="fr-CA" sz="1300" b="0" i="1">
                         <a:latin typeface="Cambria Math" panose="02040503050406030204" pitchFamily="18" charset="0"/>
                       </a:rPr>
                       <m:t>,</m:t>
                     </m:r>
                     <m:r>
-                      <a:rPr lang="fr-CA" b="0" i="1" smtClean="0">
+                      <a:rPr lang="fr-CA" sz="1300" b="0" i="1">
                         <a:latin typeface="Cambria Math" panose="02040503050406030204" pitchFamily="18" charset="0"/>
                       </a:rPr>
                       <m:t>𝑑𝑡</m:t>
                     </m:r>
                     <m:r>
-                      <a:rPr lang="fr-CA" b="0" i="1" smtClean="0">
+                      <a:rPr lang="fr-CA" sz="1300" b="0" i="1">
                         <a:latin typeface="Cambria Math" panose="02040503050406030204" pitchFamily="18" charset="0"/>
                       </a:rPr>
                       <m:t>,</m:t>
@@ -12539,14 +12554,14 @@
                     <m:sSub>
                       <m:sSubPr>
                         <m:ctrlPr>
-                          <a:rPr lang="fr-CA" b="0" i="1" smtClean="0">
+                          <a:rPr lang="fr-CA" sz="1300" b="0" i="1">
                             <a:latin typeface="Cambria Math" panose="02040503050406030204" pitchFamily="18" charset="0"/>
                           </a:rPr>
                         </m:ctrlPr>
                       </m:sSubPr>
                       <m:e>
                         <m:r>
-                          <a:rPr lang="fr-CA" b="0" i="1" smtClean="0">
+                          <a:rPr lang="fr-CA" sz="1300" b="0" i="1">
                             <a:latin typeface="Cambria Math" panose="02040503050406030204" pitchFamily="18" charset="0"/>
                           </a:rPr>
                           <m:t>𝑇</m:t>
@@ -12554,7 +12569,7 @@
                       </m:e>
                       <m:sub>
                         <m:r>
-                          <a:rPr lang="fr-CA" i="1">
+                          <a:rPr lang="fr-CA" sz="1300" i="1">
                             <a:latin typeface="Cambria Math" panose="02040503050406030204" pitchFamily="18" charset="0"/>
                             <a:ea typeface="Cambria Math" panose="02040503050406030204" pitchFamily="18" charset="0"/>
                           </a:rPr>
@@ -12563,95 +12578,95 @@
                       </m:sub>
                     </m:sSub>
                     <m:r>
-                      <a:rPr lang="fr-CA" b="0" i="1" smtClean="0">
+                      <a:rPr lang="fr-CA" sz="1300" b="0" i="1">
                         <a:latin typeface="Cambria Math" panose="02040503050406030204" pitchFamily="18" charset="0"/>
                       </a:rPr>
                       <m:t>,</m:t>
                     </m:r>
                     <m:r>
-                      <a:rPr lang="fr-CA" b="0" i="1" smtClean="0">
+                      <a:rPr lang="fr-CA" sz="1300" b="0" i="1">
                         <a:latin typeface="Cambria Math" panose="02040503050406030204" pitchFamily="18" charset="0"/>
                       </a:rPr>
                       <m:t>𝑝𝑜𝑠𝑖𝑡𝑖𝑜𝑛</m:t>
                     </m:r>
                     <m:r>
-                      <a:rPr lang="fr-CA" b="0" i="1" smtClean="0">
+                      <a:rPr lang="fr-CA" sz="1300" b="0" i="1">
                         <a:latin typeface="Cambria Math" panose="02040503050406030204" pitchFamily="18" charset="0"/>
                       </a:rPr>
                       <m:t>,</m:t>
                     </m:r>
                     <m:r>
-                      <a:rPr lang="fr-CA" b="0" i="1" smtClean="0">
+                      <a:rPr lang="fr-CA" sz="1300" b="0" i="1">
                         <a:latin typeface="Cambria Math" panose="02040503050406030204" pitchFamily="18" charset="0"/>
                       </a:rPr>
                       <m:t>𝑀𝑀𝑆</m:t>
                     </m:r>
                     <m:r>
-                      <a:rPr lang="fr-CA" b="0" i="1" smtClean="0">
+                      <a:rPr lang="fr-CA" sz="1300" b="0" i="1">
                         <a:latin typeface="Cambria Math" panose="02040503050406030204" pitchFamily="18" charset="0"/>
                       </a:rPr>
                       <m:t>,</m:t>
                     </m:r>
                     <m:r>
-                      <a:rPr lang="fr-CA" b="0" i="1" smtClean="0">
+                      <a:rPr lang="fr-CA" sz="1300" b="0" i="1">
                         <a:latin typeface="Cambria Math" panose="02040503050406030204" pitchFamily="18" charset="0"/>
                       </a:rPr>
                       <m:t>𝑒𝑡𝑐</m:t>
                     </m:r>
                     <m:r>
-                      <a:rPr lang="fr-CA" b="0" i="1" smtClean="0">
+                      <a:rPr lang="fr-CA" sz="1300" b="0" i="1">
                         <a:latin typeface="Cambria Math" panose="02040503050406030204" pitchFamily="18" charset="0"/>
                       </a:rPr>
                       <m:t>.</m:t>
                     </m:r>
                   </m:oMath>
                 </a14:m>
-                <a:endParaRPr lang="fr-CA" b="0" i="1" dirty="0">
+                <a:endParaRPr lang="fr-CA" sz="1300" b="0" i="1" dirty="0">
                   <a:latin typeface="Cambria Math" panose="02040503050406030204" pitchFamily="18" charset="0"/>
                 </a:endParaRPr>
               </a:p>
               <a:p>
                 <a:pPr lvl="1"/>
                 <a:r>
-                  <a:rPr lang="fr-CA" b="0" dirty="0"/>
+                  <a:rPr lang="fr-CA" sz="1300" b="0" dirty="0"/>
                   <a:t>Fonction Position : permet de générer les matrices de position des points du domaine </a:t>
                 </a:r>
                 <a:r>
-                  <a:rPr lang="fr-CA" dirty="0"/>
+                  <a:rPr lang="fr-CA" sz="1300" dirty="0"/>
                   <a:t>(</a:t>
                 </a:r>
                 <a:r>
-                  <a:rPr lang="fr-CA" b="1" dirty="0"/>
+                  <a:rPr lang="fr-CA" sz="1300" b="1" dirty="0"/>
                   <a:t>R </a:t>
                 </a:r>
                 <a:r>
-                  <a:rPr lang="fr-CA" dirty="0"/>
+                  <a:rPr lang="fr-CA" sz="1300" dirty="0"/>
                   <a:t>et </a:t>
                 </a:r>
                 <a:r>
-                  <a:rPr lang="fr-CA" b="1" dirty="0"/>
+                  <a:rPr lang="fr-CA" sz="1300" b="1" dirty="0"/>
                   <a:t>M</a:t>
                 </a:r>
                 <a:r>
-                  <a:rPr lang="fr-CA" dirty="0"/>
+                  <a:rPr lang="fr-CA" sz="1300" dirty="0"/>
                   <a:t>).</a:t>
                 </a:r>
                 <a14:m>
                   <m:oMath xmlns:m="http://schemas.openxmlformats.org/officeDocument/2006/math">
                     <m:r>
-                      <a:rPr lang="fr-CA" b="0" i="1" smtClean="0">
+                      <a:rPr lang="fr-CA" sz="1300" b="0" i="1">
                         <a:latin typeface="Cambria Math" panose="02040503050406030204" pitchFamily="18" charset="0"/>
                       </a:rPr>
                       <m:t> </m:t>
                     </m:r>
                   </m:oMath>
                 </a14:m>
-                <a:endParaRPr lang="fr-CA" b="0" dirty="0"/>
+                <a:endParaRPr lang="fr-CA" sz="1300" b="0" dirty="0"/>
               </a:p>
               <a:p>
                 <a:pPr lvl="1"/>
                 <a:r>
-                  <a:rPr lang="fr-CA" dirty="0"/>
+                  <a:rPr lang="fr-CA" sz="1300" dirty="0"/>
                   <a:t>Fonction Température : calcul l’état de la température au pas de temps suivant.</a:t>
                 </a:r>
               </a:p>
@@ -12661,33 +12676,33 @@
                   <a:buChar char="o"/>
                 </a:pPr>
                 <a:r>
-                  <a:rPr lang="fr-CA" b="0" dirty="0"/>
+                  <a:rPr lang="fr-CA" sz="1300" b="0" dirty="0"/>
                   <a:t>Génère un état intermédiaire composé de l’état au temps </a:t>
                 </a:r>
                 <a:r>
-                  <a:rPr lang="fr-CA" b="0" i="1" dirty="0"/>
+                  <a:rPr lang="fr-CA" sz="1300" b="0" i="1" dirty="0"/>
                   <a:t>t</a:t>
                 </a:r>
                 <a:r>
-                  <a:rPr lang="fr-CA" b="0" dirty="0"/>
+                  <a:rPr lang="fr-CA" sz="1300" b="0" dirty="0"/>
                   <a:t> au milieu et l’état au temps </a:t>
                 </a:r>
                 <a14:m>
                   <m:oMath xmlns:m="http://schemas.openxmlformats.org/officeDocument/2006/math">
                     <m:r>
-                      <a:rPr lang="fr-CA" b="0" i="1" smtClean="0">
+                      <a:rPr lang="fr-CA" sz="1300" b="0" i="1">
                         <a:latin typeface="Cambria Math" panose="02040503050406030204" pitchFamily="18" charset="0"/>
                       </a:rPr>
                       <m:t>𝑡</m:t>
                     </m:r>
                     <m:r>
-                      <a:rPr lang="fr-CA" b="0" i="1" smtClean="0">
+                      <a:rPr lang="fr-CA" sz="1300" b="0" i="1">
                         <a:latin typeface="Cambria Math" panose="02040503050406030204" pitchFamily="18" charset="0"/>
                       </a:rPr>
                       <m:t>+∆</m:t>
                     </m:r>
                     <m:r>
-                      <a:rPr lang="fr-CA" b="0" i="1" smtClean="0">
+                      <a:rPr lang="fr-CA" sz="1300" b="0" i="1">
                         <a:latin typeface="Cambria Math" panose="02040503050406030204" pitchFamily="18" charset="0"/>
                       </a:rPr>
                       <m:t>𝑡</m:t>
@@ -12695,7 +12710,7 @@
                   </m:oMath>
                 </a14:m>
                 <a:r>
-                  <a:rPr lang="fr-CA" b="0" dirty="0"/>
+                  <a:rPr lang="fr-CA" sz="1300" b="0" dirty="0"/>
                   <a:t> aux frontières.</a:t>
                 </a:r>
               </a:p>
@@ -12705,15 +12720,15 @@
                   <a:buChar char="o"/>
                 </a:pPr>
                 <a:r>
-                  <a:rPr lang="fr-CA" dirty="0"/>
+                  <a:rPr lang="fr-CA" sz="1300" dirty="0"/>
                   <a:t>Appelle la fonction Milieu.</a:t>
                 </a:r>
-                <a:endParaRPr lang="fr-CA" b="0" dirty="0"/>
+                <a:endParaRPr lang="fr-CA" sz="1300" b="0" dirty="0"/>
               </a:p>
               <a:p>
                 <a:pPr lvl="1"/>
                 <a:r>
-                  <a:rPr lang="fr-FR" dirty="0"/>
+                  <a:rPr lang="fr-FR" sz="1300" dirty="0"/>
                   <a:t>Fonction Milieu : permet de calculer l’état de la température au pas de temps suivant à l’aide de l’état intermédiaire fourni par la fonction Température</a:t>
                 </a:r>
               </a:p>
@@ -12739,13 +12754,13 @@
             </p:nvSpPr>
             <p:spPr>
               <a:xfrm>
-                <a:off x="261258" y="1331494"/>
-                <a:ext cx="11930742" cy="5526505"/>
+                <a:off x="761800" y="2228850"/>
+                <a:ext cx="6505775" cy="4011229"/>
               </a:xfrm>
               <a:blipFill>
                 <a:blip r:embed="rId2"/>
                 <a:stretch>
-                  <a:fillRect l="-920" t="-1874" r="-255"/>
+                  <a:fillRect l="-94"/>
                 </a:stretch>
               </a:blipFill>
             </p:spPr>
@@ -12764,6 +12779,44 @@
           </p:sp>
         </mc:Fallback>
       </mc:AlternateContent>
+      <p:pic>
+        <p:nvPicPr>
+          <p:cNvPr id="6" name="Picture 5" descr="101010 lignes de données vers l’infini">
+            <a:extLst>
+              <a:ext uri="{FF2B5EF4-FFF2-40B4-BE49-F238E27FC236}">
+                <a16:creationId xmlns:a16="http://schemas.microsoft.com/office/drawing/2014/main" id="{85BD774B-D107-D5A0-F14C-393E37A0CED5}"/>
+              </a:ext>
+            </a:extLst>
+          </p:cNvPr>
+          <p:cNvPicPr>
+            <a:picLocks noChangeAspect="1"/>
+          </p:cNvPicPr>
+          <p:nvPr/>
+        </p:nvPicPr>
+        <p:blipFill>
+          <a:blip r:embed="rId3"/>
+          <a:srcRect l="26611" r="23107" b="1"/>
+          <a:stretch>
+            <a:fillRect/>
+          </a:stretch>
+        </p:blipFill>
+        <p:spPr>
+          <a:xfrm>
+            <a:off x="7800975" y="-10886"/>
+            <a:ext cx="4391026" cy="6868886"/>
+          </a:xfrm>
+          <a:prstGeom prst="rect">
+            <a:avLst/>
+          </a:prstGeom>
+          <a:effectLst>
+            <a:outerShdw blurRad="127000" dist="50800" dir="10800000" sx="99000" sy="99000" algn="r" rotWithShape="0">
+              <a:prstClr val="black">
+                <a:alpha val="40000"/>
+              </a:prstClr>
+            </a:outerShdw>
+          </a:effectLst>
+        </p:spPr>
+      </p:pic>
       <p:sp>
         <p:nvSpPr>
           <p:cNvPr id="4" name="Slide Number Placeholder 3">
@@ -12780,16 +12833,41 @@
             <p:ph type="sldNum" sz="quarter" idx="12"/>
           </p:nvPr>
         </p:nvSpPr>
-        <p:spPr/>
+        <p:spPr>
+          <a:xfrm>
+            <a:off x="10167869" y="6356350"/>
+            <a:ext cx="1768425" cy="365125"/>
+          </a:xfrm>
+        </p:spPr>
         <p:txBody>
-          <a:bodyPr/>
+          <a:bodyPr>
+            <a:normAutofit/>
+          </a:bodyPr>
           <a:lstStyle/>
           <a:p>
+            <a:pPr>
+              <a:spcAft>
+                <a:spcPts val="600"/>
+              </a:spcAft>
+            </a:pPr>
             <a:fld id="{FD85B578-4E75-4E1C-9BE3-D5DCC0715B13}" type="slidenum">
-              <a:rPr lang="fr-FR" smtClean="0"/>
+              <a:rPr lang="fr-FR">
+                <a:solidFill>
+                  <a:srgbClr val="FFFFFF"/>
+                </a:solidFill>
+              </a:rPr>
+              <a:pPr>
+                <a:spcAft>
+                  <a:spcPts val="600"/>
+                </a:spcAft>
+              </a:pPr>
               <a:t>13</a:t>
             </a:fld>
-            <a:endParaRPr lang="fr-FR"/>
+            <a:endParaRPr lang="fr-FR">
+              <a:solidFill>
+                <a:srgbClr val="FFFFFF"/>
+              </a:solidFill>
+            </a:endParaRPr>
           </a:p>
         </p:txBody>
       </p:sp>
@@ -12807,6 +12885,304 @@
 </file>
 
 <file path=ppt/slides/slide14.xml><?xml version="1.0" encoding="utf-8"?>
+<p:sld xmlns:a="http://schemas.openxmlformats.org/drawingml/2006/main" xmlns:r="http://schemas.openxmlformats.org/officeDocument/2006/relationships" xmlns:p="http://schemas.openxmlformats.org/presentationml/2006/main">
+  <p:cSld>
+    <p:spTree>
+      <p:nvGrpSpPr>
+        <p:cNvPr id="1" name="">
+          <a:extLst>
+            <a:ext uri="{FF2B5EF4-FFF2-40B4-BE49-F238E27FC236}">
+              <a16:creationId xmlns:a16="http://schemas.microsoft.com/office/drawing/2014/main" id="{C0F815C8-A273-7030-2A3F-6BDE9587055D}"/>
+            </a:ext>
+          </a:extLst>
+        </p:cNvPr>
+        <p:cNvGrpSpPr/>
+        <p:nvPr/>
+      </p:nvGrpSpPr>
+      <p:grpSpPr>
+        <a:xfrm>
+          <a:off x="0" y="0"/>
+          <a:ext cx="0" cy="0"/>
+          <a:chOff x="0" y="0"/>
+          <a:chExt cx="0" cy="0"/>
+        </a:xfrm>
+      </p:grpSpPr>
+      <p:sp>
+        <p:nvSpPr>
+          <p:cNvPr id="2" name="Titre 1">
+            <a:extLst>
+              <a:ext uri="{FF2B5EF4-FFF2-40B4-BE49-F238E27FC236}">
+                <a16:creationId xmlns:a16="http://schemas.microsoft.com/office/drawing/2014/main" id="{133D28FB-7916-00FF-A0BA-554D31B7A321}"/>
+              </a:ext>
+            </a:extLst>
+          </p:cNvPr>
+          <p:cNvSpPr>
+            <a:spLocks noGrp="1"/>
+          </p:cNvSpPr>
+          <p:nvPr>
+            <p:ph type="title"/>
+          </p:nvPr>
+        </p:nvSpPr>
+        <p:spPr>
+          <a:xfrm>
+            <a:off x="761800" y="762001"/>
+            <a:ext cx="5334197" cy="1708242"/>
+          </a:xfrm>
+        </p:spPr>
+        <p:txBody>
+          <a:bodyPr anchor="ctr">
+            <a:normAutofit/>
+          </a:bodyPr>
+          <a:lstStyle/>
+          <a:p>
+            <a:r>
+              <a:rPr lang="fr-FR" sz="4000"/>
+              <a:t>Description du code :</a:t>
+            </a:r>
+          </a:p>
+        </p:txBody>
+      </p:sp>
+      <p:sp>
+        <p:nvSpPr>
+          <p:cNvPr id="3" name="Espace réservé du contenu 2">
+            <a:extLst>
+              <a:ext uri="{FF2B5EF4-FFF2-40B4-BE49-F238E27FC236}">
+                <a16:creationId xmlns:a16="http://schemas.microsoft.com/office/drawing/2014/main" id="{C313977C-A105-AC6E-44AE-ED95C34708DC}"/>
+              </a:ext>
+            </a:extLst>
+          </p:cNvPr>
+          <p:cNvSpPr>
+            <a:spLocks noGrp="1"/>
+          </p:cNvSpPr>
+          <p:nvPr>
+            <p:ph idx="1"/>
+          </p:nvPr>
+        </p:nvSpPr>
+        <p:spPr>
+          <a:xfrm>
+            <a:off x="761800" y="2228850"/>
+            <a:ext cx="6505775" cy="4011229"/>
+          </a:xfrm>
+        </p:spPr>
+        <p:txBody>
+          <a:bodyPr anchor="ctr">
+            <a:normAutofit/>
+          </a:bodyPr>
+          <a:lstStyle/>
+          <a:p>
+            <a:r>
+              <a:rPr lang="fr-FR" sz="1300" dirty="0"/>
+              <a:t>convergence_generate_data.py : </a:t>
+            </a:r>
+          </a:p>
+          <a:p>
+            <a:pPr lvl="1"/>
+            <a:r>
+              <a:rPr lang="fr-FR" sz="1200" dirty="0"/>
+              <a:t>Génère les solutions pour les configurations de discrétisation prescrites dans le fichier.</a:t>
+            </a:r>
+          </a:p>
+          <a:p>
+            <a:pPr lvl="1"/>
+            <a:r>
+              <a:rPr lang="fr-FR" sz="1200" dirty="0" err="1"/>
+              <a:t>Dépendament</a:t>
+            </a:r>
+            <a:r>
+              <a:rPr lang="fr-FR" sz="1200" dirty="0"/>
+              <a:t> de la machine, peut prendre beaucoup de temps à s’exécuter.</a:t>
+            </a:r>
+          </a:p>
+          <a:p>
+            <a:pPr lvl="1"/>
+            <a:r>
+              <a:rPr lang="fr-FR" sz="1200" dirty="0"/>
+              <a:t>Données des configurations enregistrées de manière Spatio-Temporelle en format .</a:t>
+            </a:r>
+            <a:r>
+              <a:rPr lang="fr-FR" sz="1200" dirty="0" err="1"/>
+              <a:t>npz</a:t>
+            </a:r>
+            <a:r>
+              <a:rPr lang="fr-FR" sz="1200" dirty="0"/>
+              <a:t> (</a:t>
+            </a:r>
+            <a:r>
+              <a:rPr lang="fr-FR" sz="1200" dirty="0" err="1"/>
+              <a:t>NumPy</a:t>
+            </a:r>
+            <a:r>
+              <a:rPr lang="fr-FR" sz="1200" dirty="0"/>
+              <a:t> zip) dans le dossier .</a:t>
+            </a:r>
+            <a:r>
+              <a:rPr lang="fr-FR" sz="1200" dirty="0" err="1"/>
+              <a:t>resultats</a:t>
+            </a:r>
+            <a:r>
+              <a:rPr lang="fr-FR" sz="1200" dirty="0"/>
+              <a:t>/ .</a:t>
+            </a:r>
+          </a:p>
+          <a:p>
+            <a:r>
+              <a:rPr lang="fr-FR" sz="1300" dirty="0"/>
+              <a:t>ordre_convergence_MMS.py : </a:t>
+            </a:r>
+          </a:p>
+          <a:p>
+            <a:pPr lvl="1"/>
+            <a:r>
+              <a:rPr lang="fr-CA" sz="1300" b="0" dirty="0"/>
+              <a:t>Génère les graphiques et calcul l’ordre de convergence asymptotique de la discrétisation en temps (</a:t>
+            </a:r>
+            <a:r>
+              <a:rPr lang="fr-CA" sz="1300" b="0" dirty="0" err="1"/>
+              <a:t>dt</a:t>
+            </a:r>
+            <a:r>
+              <a:rPr lang="fr-CA" sz="1300" dirty="0"/>
+              <a:t>) ou en espace (</a:t>
+            </a:r>
+            <a:r>
+              <a:rPr lang="fr-CA" sz="1300" dirty="0" err="1"/>
+              <a:t>dr,dz</a:t>
+            </a:r>
+            <a:r>
+              <a:rPr lang="fr-CA" sz="1300" dirty="0"/>
+              <a:t>).</a:t>
+            </a:r>
+          </a:p>
+          <a:p>
+            <a:pPr lvl="1"/>
+            <a:r>
+              <a:rPr lang="fr-CA" sz="1300" b="0" dirty="0"/>
+              <a:t>Ordre de convergence obtenus : final (dernier pas de temps) et spatio-temporel (tous les pas de temps)</a:t>
+            </a:r>
+          </a:p>
+          <a:p>
+            <a:pPr lvl="1"/>
+            <a:r>
+              <a:rPr lang="fr-CA" sz="1300" dirty="0"/>
+              <a:t>L’utilisateur peut avoir à modifier certains paramètres dans ce fichier pour s’assurer de saisir l’ordre de convergence </a:t>
+            </a:r>
+            <a:r>
+              <a:rPr lang="fr-CA" sz="1300" b="1" dirty="0"/>
+              <a:t>asymptotique</a:t>
+            </a:r>
+            <a:r>
+              <a:rPr lang="fr-CA" sz="1300" dirty="0"/>
+              <a:t>.</a:t>
+            </a:r>
+          </a:p>
+        </p:txBody>
+      </p:sp>
+      <p:pic>
+        <p:nvPicPr>
+          <p:cNvPr id="6" name="Picture 5" descr="101010 lignes de données vers l’infini">
+            <a:extLst>
+              <a:ext uri="{FF2B5EF4-FFF2-40B4-BE49-F238E27FC236}">
+                <a16:creationId xmlns:a16="http://schemas.microsoft.com/office/drawing/2014/main" id="{E3EE24B8-9B25-AE46-02FD-B58AD315982A}"/>
+              </a:ext>
+            </a:extLst>
+          </p:cNvPr>
+          <p:cNvPicPr>
+            <a:picLocks noChangeAspect="1"/>
+          </p:cNvPicPr>
+          <p:nvPr/>
+        </p:nvPicPr>
+        <p:blipFill>
+          <a:blip r:embed="rId2"/>
+          <a:srcRect l="26611" r="23107" b="1"/>
+          <a:stretch>
+            <a:fillRect/>
+          </a:stretch>
+        </p:blipFill>
+        <p:spPr>
+          <a:xfrm>
+            <a:off x="7800975" y="-10886"/>
+            <a:ext cx="4391026" cy="6868886"/>
+          </a:xfrm>
+          <a:prstGeom prst="rect">
+            <a:avLst/>
+          </a:prstGeom>
+          <a:effectLst>
+            <a:outerShdw blurRad="127000" dist="50800" dir="10800000" sx="99000" sy="99000" algn="r" rotWithShape="0">
+              <a:prstClr val="black">
+                <a:alpha val="40000"/>
+              </a:prstClr>
+            </a:outerShdw>
+          </a:effectLst>
+        </p:spPr>
+      </p:pic>
+      <p:sp>
+        <p:nvSpPr>
+          <p:cNvPr id="4" name="Slide Number Placeholder 3">
+            <a:extLst>
+              <a:ext uri="{FF2B5EF4-FFF2-40B4-BE49-F238E27FC236}">
+                <a16:creationId xmlns:a16="http://schemas.microsoft.com/office/drawing/2014/main" id="{2FF45D1D-53C5-7CBA-D775-3D774B54AB9A}"/>
+              </a:ext>
+            </a:extLst>
+          </p:cNvPr>
+          <p:cNvSpPr>
+            <a:spLocks noGrp="1"/>
+          </p:cNvSpPr>
+          <p:nvPr>
+            <p:ph type="sldNum" sz="quarter" idx="12"/>
+          </p:nvPr>
+        </p:nvSpPr>
+        <p:spPr>
+          <a:xfrm>
+            <a:off x="10167869" y="6356350"/>
+            <a:ext cx="1768425" cy="365125"/>
+          </a:xfrm>
+        </p:spPr>
+        <p:txBody>
+          <a:bodyPr>
+            <a:normAutofit/>
+          </a:bodyPr>
+          <a:lstStyle/>
+          <a:p>
+            <a:pPr>
+              <a:spcAft>
+                <a:spcPts val="600"/>
+              </a:spcAft>
+            </a:pPr>
+            <a:fld id="{FD85B578-4E75-4E1C-9BE3-D5DCC0715B13}" type="slidenum">
+              <a:rPr lang="fr-FR">
+                <a:solidFill>
+                  <a:srgbClr val="FFFFFF"/>
+                </a:solidFill>
+              </a:rPr>
+              <a:pPr>
+                <a:spcAft>
+                  <a:spcPts val="600"/>
+                </a:spcAft>
+              </a:pPr>
+              <a:t>14</a:t>
+            </a:fld>
+            <a:endParaRPr lang="fr-FR">
+              <a:solidFill>
+                <a:srgbClr val="FFFFFF"/>
+              </a:solidFill>
+            </a:endParaRPr>
+          </a:p>
+        </p:txBody>
+      </p:sp>
+    </p:spTree>
+    <p:extLst>
+      <p:ext uri="{BB962C8B-B14F-4D97-AF65-F5344CB8AC3E}">
+        <p14:creationId xmlns:p14="http://schemas.microsoft.com/office/powerpoint/2010/main" val="1436084241"/>
+      </p:ext>
+    </p:extLst>
+  </p:cSld>
+  <p:clrMapOvr>
+    <a:masterClrMapping/>
+  </p:clrMapOvr>
+</p:sld>
+</file>
+
+<file path=ppt/slides/slide15.xml><?xml version="1.0" encoding="utf-8"?>
 <p:sld xmlns:a="http://schemas.openxmlformats.org/drawingml/2006/main" xmlns:r="http://schemas.openxmlformats.org/officeDocument/2006/relationships" xmlns:p="http://schemas.openxmlformats.org/presentationml/2006/main">
   <p:cSld>
     <p:spTree>
@@ -13235,7 +13611,7 @@
           <a:p>
             <a:fld id="{FD85B578-4E75-4E1C-9BE3-D5DCC0715B13}" type="slidenum">
               <a:rPr lang="fr-FR" smtClean="0"/>
-              <a:t>14</a:t>
+              <a:t>15</a:t>
             </a:fld>
             <a:endParaRPr lang="fr-FR"/>
           </a:p>
@@ -13254,7 +13630,7 @@
 </p:sld>
 </file>
 
-<file path=ppt/slides/slide15.xml><?xml version="1.0" encoding="utf-8"?>
+<file path=ppt/slides/slide16.xml><?xml version="1.0" encoding="utf-8"?>
 <p:sld xmlns:a="http://schemas.openxmlformats.org/drawingml/2006/main" xmlns:r="http://schemas.openxmlformats.org/officeDocument/2006/relationships" xmlns:p="http://schemas.openxmlformats.org/presentationml/2006/main">
   <p:cSld>
     <p:spTree>
@@ -13587,7 +13963,7 @@
           <a:p>
             <a:fld id="{FD85B578-4E75-4E1C-9BE3-D5DCC0715B13}" type="slidenum">
               <a:rPr lang="fr-FR" smtClean="0"/>
-              <a:t>15</a:t>
+              <a:t>16</a:t>
             </a:fld>
             <a:endParaRPr lang="fr-FR"/>
           </a:p>
@@ -13606,7 +13982,7 @@
 </p:sld>
 </file>
 
-<file path=ppt/slides/slide16.xml><?xml version="1.0" encoding="utf-8"?>
+<file path=ppt/slides/slide17.xml><?xml version="1.0" encoding="utf-8"?>
 <p:sld xmlns:a="http://schemas.openxmlformats.org/drawingml/2006/main" xmlns:r="http://schemas.openxmlformats.org/officeDocument/2006/relationships" xmlns:p="http://schemas.openxmlformats.org/presentationml/2006/main">
   <p:cSld>
     <p:spTree>
@@ -14051,7 +14427,7 @@
           <a:p>
             <a:fld id="{FD85B578-4E75-4E1C-9BE3-D5DCC0715B13}" type="slidenum">
               <a:rPr lang="fr-FR" smtClean="0"/>
-              <a:t>16</a:t>
+              <a:t>17</a:t>
             </a:fld>
             <a:endParaRPr lang="fr-FR"/>
           </a:p>
@@ -14070,7 +14446,7 @@
 </p:sld>
 </file>
 
-<file path=ppt/slides/slide17.xml><?xml version="1.0" encoding="utf-8"?>
+<file path=ppt/slides/slide18.xml><?xml version="1.0" encoding="utf-8"?>
 <p:sld xmlns:a="http://schemas.openxmlformats.org/drawingml/2006/main" xmlns:r="http://schemas.openxmlformats.org/officeDocument/2006/relationships" xmlns:p="http://schemas.openxmlformats.org/presentationml/2006/main">
   <p:cSld>
     <p:spTree>
@@ -14364,7 +14740,7 @@
           <a:p>
             <a:fld id="{FD85B578-4E75-4E1C-9BE3-D5DCC0715B13}" type="slidenum">
               <a:rPr lang="fr-FR" smtClean="0"/>
-              <a:t>17</a:t>
+              <a:t>18</a:t>
             </a:fld>
             <a:endParaRPr lang="fr-FR"/>
           </a:p>
@@ -14383,7 +14759,7 @@
 </p:sld>
 </file>
 
-<file path=ppt/slides/slide18.xml><?xml version="1.0" encoding="utf-8"?>
+<file path=ppt/slides/slide19.xml><?xml version="1.0" encoding="utf-8"?>
 <p:sld xmlns:a="http://schemas.openxmlformats.org/drawingml/2006/main" xmlns:r="http://schemas.openxmlformats.org/officeDocument/2006/relationships" xmlns:p="http://schemas.openxmlformats.org/presentationml/2006/main">
   <p:cSld>
     <p:spTree>
@@ -15061,7 +15437,7 @@
           <a:p>
             <a:fld id="{FD85B578-4E75-4E1C-9BE3-D5DCC0715B13}" type="slidenum">
               <a:rPr lang="fr-FR" smtClean="0"/>
-              <a:t>18</a:t>
+              <a:t>19</a:t>
             </a:fld>
             <a:endParaRPr lang="fr-FR"/>
           </a:p>
@@ -15077,364 +15453,6 @@
   <p:clrMapOvr>
     <a:masterClrMapping/>
   </p:clrMapOvr>
-</p:sld>
-</file>
-
-<file path=ppt/slides/slide19.xml><?xml version="1.0" encoding="utf-8"?>
-<p:sld xmlns:a="http://schemas.openxmlformats.org/drawingml/2006/main" xmlns:r="http://schemas.openxmlformats.org/officeDocument/2006/relationships" xmlns:p="http://schemas.openxmlformats.org/presentationml/2006/main">
-  <p:cSld>
-    <p:spTree>
-      <p:nvGrpSpPr>
-        <p:cNvPr id="1" name="">
-          <a:extLst>
-            <a:ext uri="{FF2B5EF4-FFF2-40B4-BE49-F238E27FC236}">
-              <a16:creationId xmlns:a16="http://schemas.microsoft.com/office/drawing/2014/main" id="{4810F47C-EA86-426C-9E31-441BF44D6DBA}"/>
-            </a:ext>
-          </a:extLst>
-        </p:cNvPr>
-        <p:cNvGrpSpPr/>
-        <p:nvPr/>
-      </p:nvGrpSpPr>
-      <p:grpSpPr>
-        <a:xfrm>
-          <a:off x="0" y="0"/>
-          <a:ext cx="0" cy="0"/>
-          <a:chOff x="0" y="0"/>
-          <a:chExt cx="0" cy="0"/>
-        </a:xfrm>
-      </p:grpSpPr>
-      <p:sp>
-        <p:nvSpPr>
-          <p:cNvPr id="2" name="Titre 1">
-            <a:extLst>
-              <a:ext uri="{FF2B5EF4-FFF2-40B4-BE49-F238E27FC236}">
-                <a16:creationId xmlns:a16="http://schemas.microsoft.com/office/drawing/2014/main" id="{15732BA4-6A05-72B7-DA5A-7F788E2CAD71}"/>
-              </a:ext>
-            </a:extLst>
-          </p:cNvPr>
-          <p:cNvSpPr>
-            <a:spLocks noGrp="1"/>
-          </p:cNvSpPr>
-          <p:nvPr>
-            <p:ph type="title"/>
-          </p:nvPr>
-        </p:nvSpPr>
-        <p:spPr/>
-        <p:txBody>
-          <a:bodyPr/>
-          <a:lstStyle/>
-          <a:p>
-            <a:r>
-              <a:rPr lang="fr-FR" dirty="0"/>
-              <a:t>Vérification de code – MMS – Résultats :</a:t>
-            </a:r>
-          </a:p>
-        </p:txBody>
-      </p:sp>
-      <p:pic>
-        <p:nvPicPr>
-          <p:cNvPr id="5" name="Espace réservé du contenu 4">
-            <a:extLst>
-              <a:ext uri="{FF2B5EF4-FFF2-40B4-BE49-F238E27FC236}">
-                <a16:creationId xmlns:a16="http://schemas.microsoft.com/office/drawing/2014/main" id="{C16CC2A3-774C-4A0E-8885-22E49233D892}"/>
-              </a:ext>
-            </a:extLst>
-          </p:cNvPr>
-          <p:cNvPicPr>
-            <a:picLocks noGrp="1" noChangeAspect="1"/>
-          </p:cNvPicPr>
-          <p:nvPr>
-            <p:ph idx="1"/>
-          </p:nvPr>
-        </p:nvPicPr>
-        <p:blipFill>
-          <a:blip r:embed="rId2">
-            <a:extLst>
-              <a:ext uri="{28A0092B-C50C-407E-A947-70E740481C1C}">
-                <a14:useLocalDpi xmlns:a14="http://schemas.microsoft.com/office/drawing/2010/main" val="0"/>
-              </a:ext>
-            </a:extLst>
-          </a:blip>
-          <a:stretch>
-            <a:fillRect/>
-          </a:stretch>
-        </p:blipFill>
-        <p:spPr>
-          <a:xfrm>
-            <a:off x="1902354" y="1690688"/>
-            <a:ext cx="8387292" cy="5032375"/>
-          </a:xfrm>
-          <a:prstGeom prst="rect">
-            <a:avLst/>
-          </a:prstGeom>
-        </p:spPr>
-      </p:pic>
-      <p:grpSp>
-        <p:nvGrpSpPr>
-          <p:cNvPr id="10" name="Groupe 9">
-            <a:extLst>
-              <a:ext uri="{FF2B5EF4-FFF2-40B4-BE49-F238E27FC236}">
-                <a16:creationId xmlns:a16="http://schemas.microsoft.com/office/drawing/2014/main" id="{0733C7CD-F52D-5C54-C2B4-44406B95C157}"/>
-              </a:ext>
-            </a:extLst>
-          </p:cNvPr>
-          <p:cNvGrpSpPr/>
-          <p:nvPr/>
-        </p:nvGrpSpPr>
-        <p:grpSpPr>
-          <a:xfrm>
-            <a:off x="311285" y="5077838"/>
-            <a:ext cx="3385226" cy="1448624"/>
-            <a:chOff x="311285" y="5077838"/>
-            <a:chExt cx="3385226" cy="1448624"/>
-          </a:xfrm>
-        </p:grpSpPr>
-        <p:sp>
-          <p:nvSpPr>
-            <p:cNvPr id="6" name="Rectangle 5">
-              <a:extLst>
-                <a:ext uri="{FF2B5EF4-FFF2-40B4-BE49-F238E27FC236}">
-                  <a16:creationId xmlns:a16="http://schemas.microsoft.com/office/drawing/2014/main" id="{D6CB769F-2C76-74CB-5981-7343AE429DE5}"/>
-                </a:ext>
-              </a:extLst>
-            </p:cNvPr>
-            <p:cNvSpPr/>
-            <p:nvPr/>
-          </p:nvSpPr>
-          <p:spPr>
-            <a:xfrm>
-              <a:off x="2373549" y="5077838"/>
-              <a:ext cx="1322962" cy="398834"/>
-            </a:xfrm>
-            <a:prstGeom prst="rect">
-              <a:avLst/>
-            </a:prstGeom>
-            <a:noFill/>
-            <a:ln w="57150">
-              <a:solidFill>
-                <a:schemeClr val="accent6">
-                  <a:lumMod val="60000"/>
-                  <a:lumOff val="40000"/>
-                </a:schemeClr>
-              </a:solidFill>
-            </a:ln>
-          </p:spPr>
-          <p:style>
-            <a:lnRef idx="2">
-              <a:schemeClr val="accent6">
-                <a:shade val="15000"/>
-              </a:schemeClr>
-            </a:lnRef>
-            <a:fillRef idx="1">
-              <a:schemeClr val="accent6"/>
-            </a:fillRef>
-            <a:effectRef idx="0">
-              <a:schemeClr val="accent6"/>
-            </a:effectRef>
-            <a:fontRef idx="minor">
-              <a:schemeClr val="lt1"/>
-            </a:fontRef>
-          </p:style>
-          <p:txBody>
-            <a:bodyPr rtlCol="0" anchor="ctr"/>
-            <a:lstStyle/>
-            <a:p>
-              <a:pPr algn="ctr"/>
-              <a:endParaRPr lang="fr-CA"/>
-            </a:p>
-          </p:txBody>
-        </p:sp>
-        <p:cxnSp>
-          <p:nvCxnSpPr>
-            <p:cNvPr id="8" name="Connecteur droit avec flèche 7">
-              <a:extLst>
-                <a:ext uri="{FF2B5EF4-FFF2-40B4-BE49-F238E27FC236}">
-                  <a16:creationId xmlns:a16="http://schemas.microsoft.com/office/drawing/2014/main" id="{CEEDC86A-29FF-1B82-1333-62836274B581}"/>
-                </a:ext>
-              </a:extLst>
-            </p:cNvPr>
-            <p:cNvCxnSpPr>
-              <a:stCxn id="6" idx="1"/>
-            </p:cNvCxnSpPr>
-            <p:nvPr/>
-          </p:nvCxnSpPr>
-          <p:spPr>
-            <a:xfrm flipH="1">
-              <a:off x="1322962" y="5277255"/>
-              <a:ext cx="1050587" cy="325877"/>
-            </a:xfrm>
-            <a:prstGeom prst="straightConnector1">
-              <a:avLst/>
-            </a:prstGeom>
-            <a:ln>
-              <a:tailEnd type="triangle"/>
-            </a:ln>
-          </p:spPr>
-          <p:style>
-            <a:lnRef idx="2">
-              <a:schemeClr val="accent1"/>
-            </a:lnRef>
-            <a:fillRef idx="0">
-              <a:schemeClr val="accent1"/>
-            </a:fillRef>
-            <a:effectRef idx="1">
-              <a:schemeClr val="accent1"/>
-            </a:effectRef>
-            <a:fontRef idx="minor">
-              <a:schemeClr val="tx1"/>
-            </a:fontRef>
-          </p:style>
-        </p:cxnSp>
-        <p:sp>
-          <p:nvSpPr>
-            <p:cNvPr id="9" name="ZoneTexte 8">
-              <a:extLst>
-                <a:ext uri="{FF2B5EF4-FFF2-40B4-BE49-F238E27FC236}">
-                  <a16:creationId xmlns:a16="http://schemas.microsoft.com/office/drawing/2014/main" id="{3AD781C3-D9E5-9A25-B650-D4D2A98A52FC}"/>
-                </a:ext>
-              </a:extLst>
-            </p:cNvPr>
-            <p:cNvSpPr txBox="1"/>
-            <p:nvPr/>
-          </p:nvSpPr>
-          <p:spPr>
-            <a:xfrm>
-              <a:off x="311285" y="5603132"/>
-              <a:ext cx="1741251" cy="923330"/>
-            </a:xfrm>
-            <a:prstGeom prst="rect">
-              <a:avLst/>
-            </a:prstGeom>
-            <a:noFill/>
-          </p:spPr>
-          <p:txBody>
-            <a:bodyPr wrap="square" rtlCol="0">
-              <a:spAutoFit/>
-            </a:bodyPr>
-            <a:lstStyle/>
-            <a:p>
-              <a:r>
-                <a:rPr lang="fr-CA" dirty="0"/>
-                <a:t>Discrétisation spatiale prend le dessus</a:t>
-              </a:r>
-            </a:p>
-          </p:txBody>
-        </p:sp>
-      </p:grpSp>
-      <p:sp>
-        <p:nvSpPr>
-          <p:cNvPr id="3" name="Slide Number Placeholder 2">
-            <a:extLst>
-              <a:ext uri="{FF2B5EF4-FFF2-40B4-BE49-F238E27FC236}">
-                <a16:creationId xmlns:a16="http://schemas.microsoft.com/office/drawing/2014/main" id="{75EABFEE-657A-9A09-E8EF-DD345398C246}"/>
-              </a:ext>
-            </a:extLst>
-          </p:cNvPr>
-          <p:cNvSpPr>
-            <a:spLocks noGrp="1"/>
-          </p:cNvSpPr>
-          <p:nvPr>
-            <p:ph type="sldNum" sz="quarter" idx="12"/>
-          </p:nvPr>
-        </p:nvSpPr>
-        <p:spPr/>
-        <p:txBody>
-          <a:bodyPr/>
-          <a:lstStyle/>
-          <a:p>
-            <a:fld id="{FD85B578-4E75-4E1C-9BE3-D5DCC0715B13}" type="slidenum">
-              <a:rPr lang="fr-FR" smtClean="0"/>
-              <a:t>19</a:t>
-            </a:fld>
-            <a:endParaRPr lang="fr-FR"/>
-          </a:p>
-        </p:txBody>
-      </p:sp>
-    </p:spTree>
-    <p:extLst>
-      <p:ext uri="{BB962C8B-B14F-4D97-AF65-F5344CB8AC3E}">
-        <p14:creationId xmlns:p14="http://schemas.microsoft.com/office/powerpoint/2010/main" val="969147623"/>
-      </p:ext>
-    </p:extLst>
-  </p:cSld>
-  <p:clrMapOvr>
-    <a:masterClrMapping/>
-  </p:clrMapOvr>
-  <p:timing>
-    <p:tnLst>
-      <p:par>
-        <p:cTn id="1" dur="indefinite" restart="never" nodeType="tmRoot">
-          <p:childTnLst>
-            <p:seq concurrent="1" nextAc="seek">
-              <p:cTn id="2" dur="indefinite" nodeType="mainSeq">
-                <p:childTnLst>
-                  <p:par>
-                    <p:cTn id="3" fill="hold">
-                      <p:stCondLst>
-                        <p:cond delay="indefinite"/>
-                      </p:stCondLst>
-                      <p:childTnLst>
-                        <p:par>
-                          <p:cTn id="4" fill="hold">
-                            <p:stCondLst>
-                              <p:cond delay="0"/>
-                            </p:stCondLst>
-                            <p:childTnLst>
-                              <p:par>
-                                <p:cTn id="5" presetID="1" presetClass="entr" presetSubtype="0" fill="hold" nodeType="clickEffect">
-                                  <p:stCondLst>
-                                    <p:cond delay="0"/>
-                                  </p:stCondLst>
-                                  <p:childTnLst>
-                                    <p:set>
-                                      <p:cBhvr>
-                                        <p:cTn id="6" dur="1" fill="hold">
-                                          <p:stCondLst>
-                                            <p:cond delay="0"/>
-                                          </p:stCondLst>
-                                        </p:cTn>
-                                        <p:tgtEl>
-                                          <p:spTgt spid="10"/>
-                                        </p:tgtEl>
-                                        <p:attrNameLst>
-                                          <p:attrName>style.visibility</p:attrName>
-                                        </p:attrNameLst>
-                                      </p:cBhvr>
-                                      <p:to>
-                                        <p:strVal val="visible"/>
-                                      </p:to>
-                                    </p:set>
-                                  </p:childTnLst>
-                                </p:cTn>
-                              </p:par>
-                            </p:childTnLst>
-                          </p:cTn>
-                        </p:par>
-                      </p:childTnLst>
-                    </p:cTn>
-                  </p:par>
-                </p:childTnLst>
-              </p:cTn>
-              <p:prevCondLst>
-                <p:cond evt="onPrev" delay="0">
-                  <p:tgtEl>
-                    <p:sldTgt/>
-                  </p:tgtEl>
-                </p:cond>
-              </p:prevCondLst>
-              <p:nextCondLst>
-                <p:cond evt="onNext" delay="0">
-                  <p:tgtEl>
-                    <p:sldTgt/>
-                  </p:tgtEl>
-                </p:cond>
-              </p:nextCondLst>
-            </p:seq>
-          </p:childTnLst>
-        </p:cTn>
-      </p:par>
-    </p:tnLst>
-  </p:timing>
 </p:sld>
 </file>
 
@@ -16027,6 +16045,364 @@
         <p:cNvPr id="1" name="">
           <a:extLst>
             <a:ext uri="{FF2B5EF4-FFF2-40B4-BE49-F238E27FC236}">
+              <a16:creationId xmlns:a16="http://schemas.microsoft.com/office/drawing/2014/main" id="{4810F47C-EA86-426C-9E31-441BF44D6DBA}"/>
+            </a:ext>
+          </a:extLst>
+        </p:cNvPr>
+        <p:cNvGrpSpPr/>
+        <p:nvPr/>
+      </p:nvGrpSpPr>
+      <p:grpSpPr>
+        <a:xfrm>
+          <a:off x="0" y="0"/>
+          <a:ext cx="0" cy="0"/>
+          <a:chOff x="0" y="0"/>
+          <a:chExt cx="0" cy="0"/>
+        </a:xfrm>
+      </p:grpSpPr>
+      <p:sp>
+        <p:nvSpPr>
+          <p:cNvPr id="2" name="Titre 1">
+            <a:extLst>
+              <a:ext uri="{FF2B5EF4-FFF2-40B4-BE49-F238E27FC236}">
+                <a16:creationId xmlns:a16="http://schemas.microsoft.com/office/drawing/2014/main" id="{15732BA4-6A05-72B7-DA5A-7F788E2CAD71}"/>
+              </a:ext>
+            </a:extLst>
+          </p:cNvPr>
+          <p:cNvSpPr>
+            <a:spLocks noGrp="1"/>
+          </p:cNvSpPr>
+          <p:nvPr>
+            <p:ph type="title"/>
+          </p:nvPr>
+        </p:nvSpPr>
+        <p:spPr/>
+        <p:txBody>
+          <a:bodyPr/>
+          <a:lstStyle/>
+          <a:p>
+            <a:r>
+              <a:rPr lang="fr-FR" dirty="0"/>
+              <a:t>Vérification de code – MMS – Résultats :</a:t>
+            </a:r>
+          </a:p>
+        </p:txBody>
+      </p:sp>
+      <p:pic>
+        <p:nvPicPr>
+          <p:cNvPr id="5" name="Espace réservé du contenu 4">
+            <a:extLst>
+              <a:ext uri="{FF2B5EF4-FFF2-40B4-BE49-F238E27FC236}">
+                <a16:creationId xmlns:a16="http://schemas.microsoft.com/office/drawing/2014/main" id="{C16CC2A3-774C-4A0E-8885-22E49233D892}"/>
+              </a:ext>
+            </a:extLst>
+          </p:cNvPr>
+          <p:cNvPicPr>
+            <a:picLocks noGrp="1" noChangeAspect="1"/>
+          </p:cNvPicPr>
+          <p:nvPr>
+            <p:ph idx="1"/>
+          </p:nvPr>
+        </p:nvPicPr>
+        <p:blipFill>
+          <a:blip r:embed="rId2">
+            <a:extLst>
+              <a:ext uri="{28A0092B-C50C-407E-A947-70E740481C1C}">
+                <a14:useLocalDpi xmlns:a14="http://schemas.microsoft.com/office/drawing/2010/main" val="0"/>
+              </a:ext>
+            </a:extLst>
+          </a:blip>
+          <a:stretch>
+            <a:fillRect/>
+          </a:stretch>
+        </p:blipFill>
+        <p:spPr>
+          <a:xfrm>
+            <a:off x="1902354" y="1690688"/>
+            <a:ext cx="8387292" cy="5032375"/>
+          </a:xfrm>
+          <a:prstGeom prst="rect">
+            <a:avLst/>
+          </a:prstGeom>
+        </p:spPr>
+      </p:pic>
+      <p:grpSp>
+        <p:nvGrpSpPr>
+          <p:cNvPr id="10" name="Groupe 9">
+            <a:extLst>
+              <a:ext uri="{FF2B5EF4-FFF2-40B4-BE49-F238E27FC236}">
+                <a16:creationId xmlns:a16="http://schemas.microsoft.com/office/drawing/2014/main" id="{0733C7CD-F52D-5C54-C2B4-44406B95C157}"/>
+              </a:ext>
+            </a:extLst>
+          </p:cNvPr>
+          <p:cNvGrpSpPr/>
+          <p:nvPr/>
+        </p:nvGrpSpPr>
+        <p:grpSpPr>
+          <a:xfrm>
+            <a:off x="311285" y="5077838"/>
+            <a:ext cx="3385226" cy="1448624"/>
+            <a:chOff x="311285" y="5077838"/>
+            <a:chExt cx="3385226" cy="1448624"/>
+          </a:xfrm>
+        </p:grpSpPr>
+        <p:sp>
+          <p:nvSpPr>
+            <p:cNvPr id="6" name="Rectangle 5">
+              <a:extLst>
+                <a:ext uri="{FF2B5EF4-FFF2-40B4-BE49-F238E27FC236}">
+                  <a16:creationId xmlns:a16="http://schemas.microsoft.com/office/drawing/2014/main" id="{D6CB769F-2C76-74CB-5981-7343AE429DE5}"/>
+                </a:ext>
+              </a:extLst>
+            </p:cNvPr>
+            <p:cNvSpPr/>
+            <p:nvPr/>
+          </p:nvSpPr>
+          <p:spPr>
+            <a:xfrm>
+              <a:off x="2373549" y="5077838"/>
+              <a:ext cx="1322962" cy="398834"/>
+            </a:xfrm>
+            <a:prstGeom prst="rect">
+              <a:avLst/>
+            </a:prstGeom>
+            <a:noFill/>
+            <a:ln w="57150">
+              <a:solidFill>
+                <a:schemeClr val="accent6">
+                  <a:lumMod val="60000"/>
+                  <a:lumOff val="40000"/>
+                </a:schemeClr>
+              </a:solidFill>
+            </a:ln>
+          </p:spPr>
+          <p:style>
+            <a:lnRef idx="2">
+              <a:schemeClr val="accent6">
+                <a:shade val="15000"/>
+              </a:schemeClr>
+            </a:lnRef>
+            <a:fillRef idx="1">
+              <a:schemeClr val="accent6"/>
+            </a:fillRef>
+            <a:effectRef idx="0">
+              <a:schemeClr val="accent6"/>
+            </a:effectRef>
+            <a:fontRef idx="minor">
+              <a:schemeClr val="lt1"/>
+            </a:fontRef>
+          </p:style>
+          <p:txBody>
+            <a:bodyPr rtlCol="0" anchor="ctr"/>
+            <a:lstStyle/>
+            <a:p>
+              <a:pPr algn="ctr"/>
+              <a:endParaRPr lang="fr-CA"/>
+            </a:p>
+          </p:txBody>
+        </p:sp>
+        <p:cxnSp>
+          <p:nvCxnSpPr>
+            <p:cNvPr id="8" name="Connecteur droit avec flèche 7">
+              <a:extLst>
+                <a:ext uri="{FF2B5EF4-FFF2-40B4-BE49-F238E27FC236}">
+                  <a16:creationId xmlns:a16="http://schemas.microsoft.com/office/drawing/2014/main" id="{CEEDC86A-29FF-1B82-1333-62836274B581}"/>
+                </a:ext>
+              </a:extLst>
+            </p:cNvPr>
+            <p:cNvCxnSpPr>
+              <a:stCxn id="6" idx="1"/>
+            </p:cNvCxnSpPr>
+            <p:nvPr/>
+          </p:nvCxnSpPr>
+          <p:spPr>
+            <a:xfrm flipH="1">
+              <a:off x="1322962" y="5277255"/>
+              <a:ext cx="1050587" cy="325877"/>
+            </a:xfrm>
+            <a:prstGeom prst="straightConnector1">
+              <a:avLst/>
+            </a:prstGeom>
+            <a:ln>
+              <a:tailEnd type="triangle"/>
+            </a:ln>
+          </p:spPr>
+          <p:style>
+            <a:lnRef idx="2">
+              <a:schemeClr val="accent1"/>
+            </a:lnRef>
+            <a:fillRef idx="0">
+              <a:schemeClr val="accent1"/>
+            </a:fillRef>
+            <a:effectRef idx="1">
+              <a:schemeClr val="accent1"/>
+            </a:effectRef>
+            <a:fontRef idx="minor">
+              <a:schemeClr val="tx1"/>
+            </a:fontRef>
+          </p:style>
+        </p:cxnSp>
+        <p:sp>
+          <p:nvSpPr>
+            <p:cNvPr id="9" name="ZoneTexte 8">
+              <a:extLst>
+                <a:ext uri="{FF2B5EF4-FFF2-40B4-BE49-F238E27FC236}">
+                  <a16:creationId xmlns:a16="http://schemas.microsoft.com/office/drawing/2014/main" id="{3AD781C3-D9E5-9A25-B650-D4D2A98A52FC}"/>
+                </a:ext>
+              </a:extLst>
+            </p:cNvPr>
+            <p:cNvSpPr txBox="1"/>
+            <p:nvPr/>
+          </p:nvSpPr>
+          <p:spPr>
+            <a:xfrm>
+              <a:off x="311285" y="5603132"/>
+              <a:ext cx="1741251" cy="923330"/>
+            </a:xfrm>
+            <a:prstGeom prst="rect">
+              <a:avLst/>
+            </a:prstGeom>
+            <a:noFill/>
+          </p:spPr>
+          <p:txBody>
+            <a:bodyPr wrap="square" rtlCol="0">
+              <a:spAutoFit/>
+            </a:bodyPr>
+            <a:lstStyle/>
+            <a:p>
+              <a:r>
+                <a:rPr lang="fr-CA" dirty="0"/>
+                <a:t>Discrétisation spatiale prend le dessus</a:t>
+              </a:r>
+            </a:p>
+          </p:txBody>
+        </p:sp>
+      </p:grpSp>
+      <p:sp>
+        <p:nvSpPr>
+          <p:cNvPr id="3" name="Slide Number Placeholder 2">
+            <a:extLst>
+              <a:ext uri="{FF2B5EF4-FFF2-40B4-BE49-F238E27FC236}">
+                <a16:creationId xmlns:a16="http://schemas.microsoft.com/office/drawing/2014/main" id="{75EABFEE-657A-9A09-E8EF-DD345398C246}"/>
+              </a:ext>
+            </a:extLst>
+          </p:cNvPr>
+          <p:cNvSpPr>
+            <a:spLocks noGrp="1"/>
+          </p:cNvSpPr>
+          <p:nvPr>
+            <p:ph type="sldNum" sz="quarter" idx="12"/>
+          </p:nvPr>
+        </p:nvSpPr>
+        <p:spPr/>
+        <p:txBody>
+          <a:bodyPr/>
+          <a:lstStyle/>
+          <a:p>
+            <a:fld id="{FD85B578-4E75-4E1C-9BE3-D5DCC0715B13}" type="slidenum">
+              <a:rPr lang="fr-FR" smtClean="0"/>
+              <a:t>20</a:t>
+            </a:fld>
+            <a:endParaRPr lang="fr-FR"/>
+          </a:p>
+        </p:txBody>
+      </p:sp>
+    </p:spTree>
+    <p:extLst>
+      <p:ext uri="{BB962C8B-B14F-4D97-AF65-F5344CB8AC3E}">
+        <p14:creationId xmlns:p14="http://schemas.microsoft.com/office/powerpoint/2010/main" val="969147623"/>
+      </p:ext>
+    </p:extLst>
+  </p:cSld>
+  <p:clrMapOvr>
+    <a:masterClrMapping/>
+  </p:clrMapOvr>
+  <p:timing>
+    <p:tnLst>
+      <p:par>
+        <p:cTn id="1" dur="indefinite" restart="never" nodeType="tmRoot">
+          <p:childTnLst>
+            <p:seq concurrent="1" nextAc="seek">
+              <p:cTn id="2" dur="indefinite" nodeType="mainSeq">
+                <p:childTnLst>
+                  <p:par>
+                    <p:cTn id="3" fill="hold">
+                      <p:stCondLst>
+                        <p:cond delay="indefinite"/>
+                      </p:stCondLst>
+                      <p:childTnLst>
+                        <p:par>
+                          <p:cTn id="4" fill="hold">
+                            <p:stCondLst>
+                              <p:cond delay="0"/>
+                            </p:stCondLst>
+                            <p:childTnLst>
+                              <p:par>
+                                <p:cTn id="5" presetID="1" presetClass="entr" presetSubtype="0" fill="hold" nodeType="clickEffect">
+                                  <p:stCondLst>
+                                    <p:cond delay="0"/>
+                                  </p:stCondLst>
+                                  <p:childTnLst>
+                                    <p:set>
+                                      <p:cBhvr>
+                                        <p:cTn id="6" dur="1" fill="hold">
+                                          <p:stCondLst>
+                                            <p:cond delay="0"/>
+                                          </p:stCondLst>
+                                        </p:cTn>
+                                        <p:tgtEl>
+                                          <p:spTgt spid="10"/>
+                                        </p:tgtEl>
+                                        <p:attrNameLst>
+                                          <p:attrName>style.visibility</p:attrName>
+                                        </p:attrNameLst>
+                                      </p:cBhvr>
+                                      <p:to>
+                                        <p:strVal val="visible"/>
+                                      </p:to>
+                                    </p:set>
+                                  </p:childTnLst>
+                                </p:cTn>
+                              </p:par>
+                            </p:childTnLst>
+                          </p:cTn>
+                        </p:par>
+                      </p:childTnLst>
+                    </p:cTn>
+                  </p:par>
+                </p:childTnLst>
+              </p:cTn>
+              <p:prevCondLst>
+                <p:cond evt="onPrev" delay="0">
+                  <p:tgtEl>
+                    <p:sldTgt/>
+                  </p:tgtEl>
+                </p:cond>
+              </p:prevCondLst>
+              <p:nextCondLst>
+                <p:cond evt="onNext" delay="0">
+                  <p:tgtEl>
+                    <p:sldTgt/>
+                  </p:tgtEl>
+                </p:cond>
+              </p:nextCondLst>
+            </p:seq>
+          </p:childTnLst>
+        </p:cTn>
+      </p:par>
+    </p:tnLst>
+  </p:timing>
+</p:sld>
+</file>
+
+<file path=ppt/slides/slide21.xml><?xml version="1.0" encoding="utf-8"?>
+<p:sld xmlns:a="http://schemas.openxmlformats.org/drawingml/2006/main" xmlns:r="http://schemas.openxmlformats.org/officeDocument/2006/relationships" xmlns:p="http://schemas.openxmlformats.org/presentationml/2006/main">
+  <p:cSld>
+    <p:spTree>
+      <p:nvGrpSpPr>
+        <p:cNvPr id="1" name="">
+          <a:extLst>
+            <a:ext uri="{FF2B5EF4-FFF2-40B4-BE49-F238E27FC236}">
               <a16:creationId xmlns:a16="http://schemas.microsoft.com/office/drawing/2014/main" id="{0714F719-4F8B-B0BF-A652-91D4A8E1C2E6}"/>
             </a:ext>
           </a:extLst>
@@ -16283,7 +16659,7 @@
           <a:p>
             <a:fld id="{FD85B578-4E75-4E1C-9BE3-D5DCC0715B13}" type="slidenum">
               <a:rPr lang="fr-FR" smtClean="0"/>
-              <a:t>20</a:t>
+              <a:t>21</a:t>
             </a:fld>
             <a:endParaRPr lang="fr-FR"/>
           </a:p>
@@ -16377,7 +16753,7 @@
 </p:sld>
 </file>
 
-<file path=ppt/slides/slide21.xml><?xml version="1.0" encoding="utf-8"?>
+<file path=ppt/slides/slide22.xml><?xml version="1.0" encoding="utf-8"?>
 <p:sld xmlns:a="http://schemas.openxmlformats.org/drawingml/2006/main" xmlns:r="http://schemas.openxmlformats.org/officeDocument/2006/relationships" xmlns:p="http://schemas.openxmlformats.org/presentationml/2006/main">
   <p:cSld>
     <p:spTree>
@@ -16710,7 +17086,7 @@
           <a:p>
             <a:fld id="{FD85B578-4E75-4E1C-9BE3-D5DCC0715B13}" type="slidenum">
               <a:rPr lang="fr-FR" smtClean="0"/>
-              <a:t>21</a:t>
+              <a:t>22</a:t>
             </a:fld>
             <a:endParaRPr lang="fr-FR"/>
           </a:p>
@@ -16729,7 +17105,7 @@
 </p:sld>
 </file>
 
-<file path=ppt/slides/slide22.xml><?xml version="1.0" encoding="utf-8"?>
+<file path=ppt/slides/slide23.xml><?xml version="1.0" encoding="utf-8"?>
 <p:sld xmlns:a="http://schemas.openxmlformats.org/drawingml/2006/main" xmlns:r="http://schemas.openxmlformats.org/officeDocument/2006/relationships" xmlns:p="http://schemas.openxmlformats.org/presentationml/2006/main">
   <p:cSld>
     <p:spTree>
@@ -17214,7 +17590,7 @@
           <a:p>
             <a:fld id="{FD85B578-4E75-4E1C-9BE3-D5DCC0715B13}" type="slidenum">
               <a:rPr lang="fr-FR" smtClean="0"/>
-              <a:t>22</a:t>
+              <a:t>23</a:t>
             </a:fld>
             <a:endParaRPr lang="fr-FR"/>
           </a:p>
@@ -17233,7 +17609,7 @@
 </p:sld>
 </file>
 
-<file path=ppt/slides/slide23.xml><?xml version="1.0" encoding="utf-8"?>
+<file path=ppt/slides/slide24.xml><?xml version="1.0" encoding="utf-8"?>
 <p:sld xmlns:a="http://schemas.openxmlformats.org/drawingml/2006/main" xmlns:r="http://schemas.openxmlformats.org/officeDocument/2006/relationships" xmlns:p="http://schemas.openxmlformats.org/presentationml/2006/main">
   <p:cSld>
     <p:spTree>
@@ -18246,7 +18622,7 @@
           <a:p>
             <a:fld id="{FD85B578-4E75-4E1C-9BE3-D5DCC0715B13}" type="slidenum">
               <a:rPr lang="fr-FR" smtClean="0"/>
-              <a:t>23</a:t>
+              <a:t>24</a:t>
             </a:fld>
             <a:endParaRPr lang="fr-FR"/>
           </a:p>
@@ -18265,7 +18641,7 @@
 </p:sld>
 </file>
 
-<file path=ppt/slides/slide24.xml><?xml version="1.0" encoding="utf-8"?>
+<file path=ppt/slides/slide25.xml><?xml version="1.0" encoding="utf-8"?>
 <p:sld xmlns:a="http://schemas.openxmlformats.org/drawingml/2006/main" xmlns:r="http://schemas.openxmlformats.org/officeDocument/2006/relationships" xmlns:p="http://schemas.openxmlformats.org/presentationml/2006/main">
   <p:cSld>
     <p:spTree>
@@ -18463,7 +18839,7 @@
           <a:p>
             <a:fld id="{FD85B578-4E75-4E1C-9BE3-D5DCC0715B13}" type="slidenum">
               <a:rPr lang="fr-FR" smtClean="0"/>
-              <a:t>24</a:t>
+              <a:t>25</a:t>
             </a:fld>
             <a:endParaRPr lang="fr-FR"/>
           </a:p>
@@ -18976,7 +19352,7 @@
 </p:sld>
 </file>
 
-<file path=ppt/slides/slide25.xml><?xml version="1.0" encoding="utf-8"?>
+<file path=ppt/slides/slide26.xml><?xml version="1.0" encoding="utf-8"?>
 <p:sld xmlns:a="http://schemas.openxmlformats.org/drawingml/2006/main" xmlns:r="http://schemas.openxmlformats.org/officeDocument/2006/relationships" xmlns:p="http://schemas.openxmlformats.org/presentationml/2006/main">
   <p:cSld>
     <p:spTree>
@@ -20297,7 +20673,7 @@
           <a:p>
             <a:fld id="{FD85B578-4E75-4E1C-9BE3-D5DCC0715B13}" type="slidenum">
               <a:rPr lang="fr-FR" smtClean="0"/>
-              <a:t>25</a:t>
+              <a:t>26</a:t>
             </a:fld>
             <a:endParaRPr lang="fr-FR"/>
           </a:p>
@@ -20316,7 +20692,7 @@
 </p:sld>
 </file>
 
-<file path=ppt/slides/slide26.xml><?xml version="1.0" encoding="utf-8"?>
+<file path=ppt/slides/slide27.xml><?xml version="1.0" encoding="utf-8"?>
 <p:sld xmlns:a="http://schemas.openxmlformats.org/drawingml/2006/main" xmlns:r="http://schemas.openxmlformats.org/officeDocument/2006/relationships" xmlns:p="http://schemas.openxmlformats.org/presentationml/2006/main">
   <p:cSld>
     <p:spTree>
@@ -21865,7 +22241,7 @@
           <a:p>
             <a:fld id="{FD85B578-4E75-4E1C-9BE3-D5DCC0715B13}" type="slidenum">
               <a:rPr lang="fr-FR" smtClean="0"/>
-              <a:t>26</a:t>
+              <a:t>27</a:t>
             </a:fld>
             <a:endParaRPr lang="fr-FR"/>
           </a:p>
@@ -21884,7 +22260,7 @@
 </p:sld>
 </file>
 
-<file path=ppt/slides/slide27.xml><?xml version="1.0" encoding="utf-8"?>
+<file path=ppt/slides/slide28.xml><?xml version="1.0" encoding="utf-8"?>
 <p:sld xmlns:a="http://schemas.openxmlformats.org/drawingml/2006/main" xmlns:r="http://schemas.openxmlformats.org/officeDocument/2006/relationships" xmlns:p="http://schemas.openxmlformats.org/presentationml/2006/main">
   <p:cSld>
     <p:spTree>
@@ -21930,8 +22306,8 @@
           </a:p>
         </p:txBody>
       </p:sp>
-      <mc:AlternateContent xmlns:mc="http://schemas.openxmlformats.org/markup-compatibility/2006">
-        <mc:Choice xmlns:a14="http://schemas.microsoft.com/office/drawing/2010/main" Requires="a14">
+      <mc:AlternateContent xmlns:mc="http://schemas.openxmlformats.org/markup-compatibility/2006" xmlns:a14="http://schemas.microsoft.com/office/drawing/2010/main">
+        <mc:Choice Requires="a14">
           <p:sp>
             <p:nvSpPr>
               <p:cNvPr id="3" name="Content Placeholder 2">
@@ -22218,16 +22594,7 @@
                             <a:rPr lang="fr-FR" b="0" i="1" smtClean="0">
                               <a:latin typeface="Cambria Math" panose="02040503050406030204" pitchFamily="18" charset="0"/>
                             </a:rPr>
-                            <m:t>σ</m:t>
-                          </m:r>
-                          <m:r>
-                            <m:rPr>
-                              <m:sty m:val="p"/>
-                            </m:rPr>
-                            <a:rPr lang="fr-FR" b="0" i="1" baseline="-25000" smtClean="0">
-                              <a:latin typeface="Cambria Math" panose="02040503050406030204" pitchFamily="18" charset="0"/>
-                            </a:rPr>
-                            <m:t>al</m:t>
+                            <m:t>σal</m:t>
                           </m:r>
                           <m:r>
                             <a:rPr lang="fr-FR" b="0" i="1" smtClean="0">
@@ -22250,13 +22617,7 @@
                         <a:rPr lang="fr-FR" b="0" i="1" smtClean="0">
                           <a:latin typeface="Cambria Math" panose="02040503050406030204" pitchFamily="18" charset="0"/>
                         </a:rPr>
-                        <m:t>=</m:t>
-                      </m:r>
-                      <m:r>
-                        <a:rPr lang="fr-FR" b="0" i="1" smtClean="0">
-                          <a:latin typeface="Cambria Math" panose="02040503050406030204" pitchFamily="18" charset="0"/>
-                        </a:rPr>
-                        <m:t>1.25 </m:t>
+                        <m:t>=1.25 </m:t>
                       </m:r>
                       <m:r>
                         <m:rPr>
@@ -22281,7 +22642,7 @@
             </p:txBody>
           </p:sp>
         </mc:Choice>
-        <mc:Fallback>
+        <mc:Fallback xmlns="">
           <p:sp>
             <p:nvSpPr>
               <p:cNvPr id="3" name="Content Placeholder 2">
@@ -22404,7 +22765,7 @@
           <a:p>
             <a:fld id="{FD85B578-4E75-4E1C-9BE3-D5DCC0715B13}" type="slidenum">
               <a:rPr lang="fr-FR" smtClean="0"/>
-              <a:t>27</a:t>
+              <a:t>28</a:t>
             </a:fld>
             <a:endParaRPr lang="fr-FR"/>
           </a:p>
@@ -22423,7 +22784,7 @@
 </p:sld>
 </file>
 
-<file path=ppt/slides/slide28.xml><?xml version="1.0" encoding="utf-8"?>
+<file path=ppt/slides/slide29.xml><?xml version="1.0" encoding="utf-8"?>
 <p:sld xmlns:a="http://schemas.openxmlformats.org/drawingml/2006/main" xmlns:r="http://schemas.openxmlformats.org/officeDocument/2006/relationships" xmlns:p="http://schemas.openxmlformats.org/presentationml/2006/main">
   <p:cSld>
     <p:spTree>
@@ -23215,7 +23576,7 @@
           <a:p>
             <a:fld id="{FD85B578-4E75-4E1C-9BE3-D5DCC0715B13}" type="slidenum">
               <a:rPr lang="fr-FR" smtClean="0"/>
-              <a:t>28</a:t>
+              <a:t>29</a:t>
             </a:fld>
             <a:endParaRPr lang="fr-FR"/>
           </a:p>
@@ -23225,1065 +23586,6 @@
     <p:extLst>
       <p:ext uri="{BB962C8B-B14F-4D97-AF65-F5344CB8AC3E}">
         <p14:creationId xmlns:p14="http://schemas.microsoft.com/office/powerpoint/2010/main" val="2810957893"/>
-      </p:ext>
-    </p:extLst>
-  </p:cSld>
-  <p:clrMapOvr>
-    <a:masterClrMapping/>
-  </p:clrMapOvr>
-</p:sld>
-</file>
-
-<file path=ppt/slides/slide29.xml><?xml version="1.0" encoding="utf-8"?>
-<p:sld xmlns:a="http://schemas.openxmlformats.org/drawingml/2006/main" xmlns:r="http://schemas.openxmlformats.org/officeDocument/2006/relationships" xmlns:p="http://schemas.openxmlformats.org/presentationml/2006/main">
-  <p:cSld>
-    <p:spTree>
-      <p:nvGrpSpPr>
-        <p:cNvPr id="1" name=""/>
-        <p:cNvGrpSpPr/>
-        <p:nvPr/>
-      </p:nvGrpSpPr>
-      <p:grpSpPr>
-        <a:xfrm>
-          <a:off x="0" y="0"/>
-          <a:ext cx="0" cy="0"/>
-          <a:chOff x="0" y="0"/>
-          <a:chExt cx="0" cy="0"/>
-        </a:xfrm>
-      </p:grpSpPr>
-      <mc:AlternateContent xmlns:mc="http://schemas.openxmlformats.org/markup-compatibility/2006" xmlns:a14="http://schemas.microsoft.com/office/drawing/2010/main">
-        <mc:Choice Requires="a14">
-          <p:sp>
-            <p:nvSpPr>
-              <p:cNvPr id="2" name="Title 1">
-                <a:extLst>
-                  <a:ext uri="{FF2B5EF4-FFF2-40B4-BE49-F238E27FC236}">
-                    <a16:creationId xmlns:a16="http://schemas.microsoft.com/office/drawing/2014/main" id="{66820A09-0F49-B31F-9AA1-11B0ABCFF4D4}"/>
-                  </a:ext>
-                </a:extLst>
-              </p:cNvPr>
-              <p:cNvSpPr>
-                <a:spLocks noGrp="1"/>
-              </p:cNvSpPr>
-              <p:nvPr>
-                <p:ph type="title"/>
-              </p:nvPr>
-            </p:nvSpPr>
-            <p:spPr/>
-            <p:txBody>
-              <a:bodyPr/>
-              <a:lstStyle/>
-              <a:p>
-                <a:r>
-                  <a:rPr lang="fr-FR" dirty="0"/>
-                  <a:t>Validation – incertitude </a:t>
-                </a:r>
-                <a14:m>
-                  <m:oMath xmlns:m="http://schemas.openxmlformats.org/officeDocument/2006/math">
-                    <m:sSub>
-                      <m:sSubPr>
-                        <m:ctrlPr>
-                          <a:rPr lang="fr-FR" i="1">
-                            <a:latin typeface="Cambria Math" panose="02040503050406030204" pitchFamily="18" charset="0"/>
-                          </a:rPr>
-                        </m:ctrlPr>
-                      </m:sSubPr>
-                      <m:e>
-                        <m:r>
-                          <a:rPr lang="fr-FR" i="1">
-                            <a:latin typeface="Cambria Math" panose="02040503050406030204" pitchFamily="18" charset="0"/>
-                          </a:rPr>
-                          <m:t>𝑢</m:t>
-                        </m:r>
-                      </m:e>
-                      <m:sub>
-                        <m:r>
-                          <a:rPr lang="fr-FR" i="1">
-                            <a:latin typeface="Cambria Math" panose="02040503050406030204" pitchFamily="18" charset="0"/>
-                          </a:rPr>
-                          <m:t>𝑖𝑛𝑝𝑢𝑡</m:t>
-                        </m:r>
-                      </m:sub>
-                    </m:sSub>
-                  </m:oMath>
-                </a14:m>
-                <a:endParaRPr lang="en-US" dirty="0"/>
-              </a:p>
-            </p:txBody>
-          </p:sp>
-        </mc:Choice>
-        <mc:Fallback xmlns="">
-          <p:sp>
-            <p:nvSpPr>
-              <p:cNvPr id="2" name="Title 1">
-                <a:extLst>
-                  <a:ext uri="{FF2B5EF4-FFF2-40B4-BE49-F238E27FC236}">
-                    <a16:creationId xmlns:a16="http://schemas.microsoft.com/office/drawing/2014/main" id="{66820A09-0F49-B31F-9AA1-11B0ABCFF4D4}"/>
-                  </a:ext>
-                </a:extLst>
-              </p:cNvPr>
-              <p:cNvSpPr>
-                <a:spLocks noGrp="1" noRot="1" noChangeAspect="1" noMove="1" noResize="1" noEditPoints="1" noAdjustHandles="1" noChangeArrowheads="1" noChangeShapeType="1" noTextEdit="1"/>
-              </p:cNvSpPr>
-              <p:nvPr>
-                <p:ph type="title"/>
-              </p:nvPr>
-            </p:nvSpPr>
-            <p:spPr>
-              <a:blipFill>
-                <a:blip r:embed="rId2"/>
-                <a:stretch>
-                  <a:fillRect l="-2377"/>
-                </a:stretch>
-              </a:blipFill>
-            </p:spPr>
-            <p:txBody>
-              <a:bodyPr/>
-              <a:lstStyle/>
-              <a:p>
-                <a:r>
-                  <a:rPr lang="en-US">
-                    <a:noFill/>
-                  </a:rPr>
-                  <a:t> </a:t>
-                </a:r>
-              </a:p>
-            </p:txBody>
-          </p:sp>
-        </mc:Fallback>
-      </mc:AlternateContent>
-      <mc:AlternateContent xmlns:mc="http://schemas.openxmlformats.org/markup-compatibility/2006" xmlns:a14="http://schemas.microsoft.com/office/drawing/2010/main">
-        <mc:Choice Requires="a14">
-          <p:sp>
-            <p:nvSpPr>
-              <p:cNvPr id="3" name="Content Placeholder 2">
-                <a:extLst>
-                  <a:ext uri="{FF2B5EF4-FFF2-40B4-BE49-F238E27FC236}">
-                    <a16:creationId xmlns:a16="http://schemas.microsoft.com/office/drawing/2014/main" id="{7BB71198-7608-579F-B3DD-7C7CBD28912F}"/>
-                  </a:ext>
-                </a:extLst>
-              </p:cNvPr>
-              <p:cNvSpPr>
-                <a:spLocks noGrp="1"/>
-              </p:cNvSpPr>
-              <p:nvPr>
-                <p:ph idx="1"/>
-              </p:nvPr>
-            </p:nvSpPr>
-            <p:spPr>
-              <a:xfrm>
-                <a:off x="838200" y="1825625"/>
-                <a:ext cx="10515600" cy="1462085"/>
-              </a:xfrm>
-            </p:spPr>
-            <p:txBody>
-              <a:bodyPr>
-                <a:normAutofit fontScale="92500"/>
-              </a:bodyPr>
-              <a:lstStyle/>
-              <a:p>
-                <a:r>
-                  <a:rPr lang="fr-FR" dirty="0"/>
-                  <a:t>Par une méthode moins conservatrice en considérant les intervalles des valeurs trouvé dans la littérature comme des intervalles de confiance à 99% il est possible de réduire considérablement </a:t>
-                </a:r>
-                <a14:m>
-                  <m:oMath xmlns:m="http://schemas.openxmlformats.org/officeDocument/2006/math">
-                    <m:sSub>
-                      <m:sSubPr>
-                        <m:ctrlPr>
-                          <a:rPr lang="fr-FR" i="1">
-                            <a:latin typeface="Cambria Math" panose="02040503050406030204" pitchFamily="18" charset="0"/>
-                          </a:rPr>
-                        </m:ctrlPr>
-                      </m:sSubPr>
-                      <m:e>
-                        <m:r>
-                          <a:rPr lang="fr-FR" i="1">
-                            <a:latin typeface="Cambria Math" panose="02040503050406030204" pitchFamily="18" charset="0"/>
-                          </a:rPr>
-                          <m:t>𝑢</m:t>
-                        </m:r>
-                      </m:e>
-                      <m:sub>
-                        <m:r>
-                          <a:rPr lang="fr-FR" i="1">
-                            <a:latin typeface="Cambria Math" panose="02040503050406030204" pitchFamily="18" charset="0"/>
-                          </a:rPr>
-                          <m:t>𝑖𝑛𝑝𝑢𝑡</m:t>
-                        </m:r>
-                      </m:sub>
-                    </m:sSub>
-                  </m:oMath>
-                </a14:m>
-                <a:endParaRPr lang="en-US" dirty="0"/>
-              </a:p>
-            </p:txBody>
-          </p:sp>
-        </mc:Choice>
-        <mc:Fallback xmlns="">
-          <p:sp>
-            <p:nvSpPr>
-              <p:cNvPr id="3" name="Content Placeholder 2">
-                <a:extLst>
-                  <a:ext uri="{FF2B5EF4-FFF2-40B4-BE49-F238E27FC236}">
-                    <a16:creationId xmlns:a16="http://schemas.microsoft.com/office/drawing/2014/main" id="{7BB71198-7608-579F-B3DD-7C7CBD28912F}"/>
-                  </a:ext>
-                </a:extLst>
-              </p:cNvPr>
-              <p:cNvSpPr>
-                <a:spLocks noGrp="1" noRot="1" noChangeAspect="1" noMove="1" noResize="1" noEditPoints="1" noAdjustHandles="1" noChangeArrowheads="1" noChangeShapeType="1" noTextEdit="1"/>
-              </p:cNvSpPr>
-              <p:nvPr>
-                <p:ph idx="1"/>
-              </p:nvPr>
-            </p:nvSpPr>
-            <p:spPr>
-              <a:xfrm>
-                <a:off x="838200" y="1825625"/>
-                <a:ext cx="10515600" cy="1462085"/>
-              </a:xfrm>
-              <a:blipFill>
-                <a:blip r:embed="rId3"/>
-                <a:stretch>
-                  <a:fillRect l="-928" t="-6250"/>
-                </a:stretch>
-              </a:blipFill>
-            </p:spPr>
-            <p:txBody>
-              <a:bodyPr/>
-              <a:lstStyle/>
-              <a:p>
-                <a:r>
-                  <a:rPr lang="en-US">
-                    <a:noFill/>
-                  </a:rPr>
-                  <a:t> </a:t>
-                </a:r>
-              </a:p>
-            </p:txBody>
-          </p:sp>
-        </mc:Fallback>
-      </mc:AlternateContent>
-      <p:sp>
-        <p:nvSpPr>
-          <p:cNvPr id="4" name="Slide Number Placeholder 3">
-            <a:extLst>
-              <a:ext uri="{FF2B5EF4-FFF2-40B4-BE49-F238E27FC236}">
-                <a16:creationId xmlns:a16="http://schemas.microsoft.com/office/drawing/2014/main" id="{91EA1BFD-A6AF-4A14-34C0-65467A1D021C}"/>
-              </a:ext>
-            </a:extLst>
-          </p:cNvPr>
-          <p:cNvSpPr>
-            <a:spLocks noGrp="1"/>
-          </p:cNvSpPr>
-          <p:nvPr>
-            <p:ph type="sldNum" sz="quarter" idx="12"/>
-          </p:nvPr>
-        </p:nvSpPr>
-        <p:spPr/>
-        <p:txBody>
-          <a:bodyPr/>
-          <a:lstStyle/>
-          <a:p>
-            <a:fld id="{FD85B578-4E75-4E1C-9BE3-D5DCC0715B13}" type="slidenum">
-              <a:rPr lang="fr-FR" smtClean="0"/>
-              <a:t>29</a:t>
-            </a:fld>
-            <a:endParaRPr lang="fr-FR" dirty="0"/>
-          </a:p>
-        </p:txBody>
-      </p:sp>
-      <mc:AlternateContent xmlns:mc="http://schemas.openxmlformats.org/markup-compatibility/2006">
-        <mc:Choice xmlns:a14="http://schemas.microsoft.com/office/drawing/2010/main" Requires="a14">
-          <p:sp>
-            <p:nvSpPr>
-              <p:cNvPr id="6" name="TextBox 5">
-                <a:extLst>
-                  <a:ext uri="{FF2B5EF4-FFF2-40B4-BE49-F238E27FC236}">
-                    <a16:creationId xmlns:a16="http://schemas.microsoft.com/office/drawing/2014/main" id="{D0E9DB5F-EBD0-D834-D4ED-493307BE600E}"/>
-                  </a:ext>
-                </a:extLst>
-              </p:cNvPr>
-              <p:cNvSpPr txBox="1"/>
-              <p:nvPr/>
-            </p:nvSpPr>
-            <p:spPr>
-              <a:xfrm>
-                <a:off x="501445" y="5642899"/>
-                <a:ext cx="7076768" cy="849976"/>
-              </a:xfrm>
-              <a:prstGeom prst="rect">
-                <a:avLst/>
-              </a:prstGeom>
-              <a:noFill/>
-            </p:spPr>
-            <p:txBody>
-              <a:bodyPr wrap="square" rtlCol="0">
-                <a:spAutoFit/>
-              </a:bodyPr>
-              <a:lstStyle/>
-              <a:p>
-                <a:r>
-                  <a:rPr lang="fr-FR" sz="1600" b="0" i="1" dirty="0">
-                    <a:latin typeface="Cambria Math" panose="02040503050406030204" pitchFamily="18" charset="0"/>
-                  </a:rPr>
-                  <a:t>Résultat pour intervalle de confian</a:t>
-                </a:r>
-                <a:r>
-                  <a:rPr lang="fr-FR" sz="1600" i="1" dirty="0">
-                    <a:latin typeface="Cambria Math" panose="02040503050406030204" pitchFamily="18" charset="0"/>
-                  </a:rPr>
-                  <a:t>ce à 99%</a:t>
-                </a:r>
-                <a:endParaRPr lang="fr-FR" sz="1600" b="0" i="1" dirty="0">
-                  <a:latin typeface="Cambria Math" panose="02040503050406030204" pitchFamily="18" charset="0"/>
-                </a:endParaRPr>
-              </a:p>
-              <a:p>
-                <a14:m>
-                  <m:oMath xmlns:m="http://schemas.openxmlformats.org/officeDocument/2006/math">
-                    <m:sSub>
-                      <m:sSubPr>
-                        <m:ctrlPr>
-                          <a:rPr lang="fr-FR" sz="1600" b="0" i="1" smtClean="0">
-                            <a:latin typeface="Cambria Math" panose="02040503050406030204" pitchFamily="18" charset="0"/>
-                          </a:rPr>
-                        </m:ctrlPr>
-                      </m:sSubPr>
-                      <m:e>
-                        <m:r>
-                          <a:rPr lang="fr-FR" sz="1600" b="0" i="1" smtClean="0">
-                            <a:latin typeface="Cambria Math" panose="02040503050406030204" pitchFamily="18" charset="0"/>
-                          </a:rPr>
-                          <m:t>𝑢</m:t>
-                        </m:r>
-                      </m:e>
-                      <m:sub>
-                        <m:r>
-                          <a:rPr lang="fr-FR" sz="1600" b="0" i="1" smtClean="0">
-                            <a:latin typeface="Cambria Math" panose="02040503050406030204" pitchFamily="18" charset="0"/>
-                          </a:rPr>
-                          <m:t>𝑖𝑛𝑝𝑢𝑡</m:t>
-                        </m:r>
-                      </m:sub>
-                    </m:sSub>
-                    <m:r>
-                      <a:rPr lang="fr-FR" sz="1600" b="0" i="1" smtClean="0">
-                        <a:latin typeface="Cambria Math" panose="02040503050406030204" pitchFamily="18" charset="0"/>
-                      </a:rPr>
-                      <m:t>=13.1 </m:t>
-                    </m:r>
-                    <m:r>
-                      <m:rPr>
-                        <m:sty m:val="p"/>
-                      </m:rPr>
-                      <a:rPr lang="fr-FR" sz="1600" b="0" i="1" smtClean="0">
-                        <a:latin typeface="Cambria Math" panose="02040503050406030204" pitchFamily="18" charset="0"/>
-                      </a:rPr>
-                      <m:t>K</m:t>
-                    </m:r>
-                  </m:oMath>
-                </a14:m>
-                <a:r>
-                  <a:rPr lang="en-US" sz="1600" dirty="0"/>
-                  <a:t> pour </a:t>
-                </a:r>
-                <a14:m>
-                  <m:oMath xmlns:m="http://schemas.openxmlformats.org/officeDocument/2006/math">
-                    <m:sSub>
-                      <m:sSubPr>
-                        <m:ctrlPr>
-                          <a:rPr lang="fr-FR" sz="1600" b="0" i="1" smtClean="0">
-                            <a:latin typeface="Cambria Math" panose="02040503050406030204" pitchFamily="18" charset="0"/>
-                          </a:rPr>
-                        </m:ctrlPr>
-                      </m:sSubPr>
-                      <m:e>
-                        <m:r>
-                          <a:rPr lang="fr-FR" sz="1600" b="0" i="1" smtClean="0">
-                            <a:latin typeface="Cambria Math" panose="02040503050406030204" pitchFamily="18" charset="0"/>
-                          </a:rPr>
-                          <m:t>𝜎</m:t>
-                        </m:r>
-                      </m:e>
-                      <m:sub>
-                        <m:r>
-                          <a:rPr lang="fr-FR" sz="1600" b="0" i="1" smtClean="0">
-                            <a:latin typeface="Cambria Math" panose="02040503050406030204" pitchFamily="18" charset="0"/>
-                          </a:rPr>
-                          <m:t>𝜀</m:t>
-                        </m:r>
-                      </m:sub>
-                    </m:sSub>
-                    <m:r>
-                      <a:rPr lang="fr-FR" sz="1600" b="0" i="1" smtClean="0">
-                        <a:latin typeface="Cambria Math" panose="02040503050406030204" pitchFamily="18" charset="0"/>
-                      </a:rPr>
-                      <m:t>=0.07</m:t>
-                    </m:r>
-                    <m:r>
-                      <a:rPr lang="fr-FR" sz="1600" b="1" i="1" smtClean="0">
-                        <a:latin typeface="Cambria Math" panose="02040503050406030204" pitchFamily="18" charset="0"/>
-                      </a:rPr>
-                      <m:t>5 </m:t>
-                    </m:r>
-                    <m:r>
-                      <m:rPr>
-                        <m:sty m:val="p"/>
-                      </m:rPr>
-                      <a:rPr lang="fr-FR" sz="1600" b="1" i="1" smtClean="0">
-                        <a:latin typeface="Cambria Math" panose="02040503050406030204" pitchFamily="18" charset="0"/>
-                      </a:rPr>
-                      <m:t>et</m:t>
-                    </m:r>
-                    <m:r>
-                      <a:rPr lang="fr-FR" sz="1600" b="1" i="1" smtClean="0">
-                        <a:latin typeface="Cambria Math" panose="02040503050406030204" pitchFamily="18" charset="0"/>
-                      </a:rPr>
-                      <m:t> </m:t>
-                    </m:r>
-                    <m:r>
-                      <m:rPr>
-                        <m:sty m:val="p"/>
-                      </m:rPr>
-                      <a:rPr lang="fr-FR" sz="1600" b="1" i="1" smtClean="0">
-                        <a:latin typeface="Cambria Math" panose="02040503050406030204" pitchFamily="18" charset="0"/>
-                      </a:rPr>
-                      <m:t>σk</m:t>
-                    </m:r>
-                    <m:r>
-                      <a:rPr lang="fr-FR" sz="1600" b="1" i="1" smtClean="0">
-                        <a:latin typeface="Cambria Math" panose="02040503050406030204" pitchFamily="18" charset="0"/>
-                      </a:rPr>
-                      <m:t> = 2.5⇒</m:t>
-                    </m:r>
-                    <m:sSub>
-                      <m:sSubPr>
-                        <m:ctrlPr>
-                          <a:rPr lang="fr-FR" sz="1600" b="1" i="1" smtClean="0">
-                            <a:latin typeface="Cambria Math" panose="02040503050406030204" pitchFamily="18" charset="0"/>
-                          </a:rPr>
-                        </m:ctrlPr>
-                      </m:sSubPr>
-                      <m:e>
-                        <m:r>
-                          <a:rPr lang="fr-FR" sz="1600" b="1" i="1" smtClean="0">
-                            <a:latin typeface="Cambria Math" panose="02040503050406030204" pitchFamily="18" charset="0"/>
-                          </a:rPr>
-                          <m:t>𝒖</m:t>
-                        </m:r>
-                      </m:e>
-                      <m:sub>
-                        <m:r>
-                          <a:rPr lang="fr-FR" sz="1600" b="1" i="1" smtClean="0">
-                            <a:latin typeface="Cambria Math" panose="02040503050406030204" pitchFamily="18" charset="0"/>
-                          </a:rPr>
-                          <m:t>𝒗𝒂𝒍</m:t>
-                        </m:r>
-                      </m:sub>
-                    </m:sSub>
-                    <m:r>
-                      <a:rPr lang="fr-FR" sz="1600" b="1" i="1" smtClean="0">
-                        <a:latin typeface="Cambria Math" panose="02040503050406030204" pitchFamily="18" charset="0"/>
-                      </a:rPr>
-                      <m:t>=13.1</m:t>
-                    </m:r>
-                    <m:r>
-                      <a:rPr lang="fr-FR" sz="1600" b="1" i="1" smtClean="0">
-                        <a:latin typeface="Cambria Math" panose="02040503050406030204" pitchFamily="18" charset="0"/>
-                      </a:rPr>
-                      <m:t>6</m:t>
-                    </m:r>
-                    <m:r>
-                      <a:rPr lang="fr-FR" sz="1600" b="1" i="1" smtClean="0">
-                        <a:latin typeface="Cambria Math" panose="02040503050406030204" pitchFamily="18" charset="0"/>
-                      </a:rPr>
-                      <m:t> </m:t>
-                    </m:r>
-                    <m:r>
-                      <a:rPr lang="fr-FR" sz="1600" b="1" i="1" smtClean="0">
-                        <a:latin typeface="Cambria Math" panose="02040503050406030204" pitchFamily="18" charset="0"/>
-                      </a:rPr>
-                      <m:t>𝑲</m:t>
-                    </m:r>
-                  </m:oMath>
-                </a14:m>
-                <a:endParaRPr lang="en-US" sz="1600" dirty="0"/>
-              </a:p>
-              <a:p>
-                <a:r>
-                  <a:rPr lang="en-US" sz="1600" dirty="0"/>
-                  <a:t> </a:t>
-                </a:r>
-                <a14:m>
-                  <m:oMath xmlns:m="http://schemas.openxmlformats.org/officeDocument/2006/math">
-                    <m:r>
-                      <a:rPr lang="en-US" sz="1600" b="1" i="1">
-                        <a:latin typeface="Cambria Math" panose="02040503050406030204" pitchFamily="18" charset="0"/>
-                      </a:rPr>
-                      <m:t>⇒</m:t>
-                    </m:r>
-                    <m:r>
-                      <m:rPr>
-                        <m:nor/>
-                      </m:rPr>
-                      <a:rPr lang="en-US" sz="1600" dirty="0"/>
-                      <m:t>−</m:t>
-                    </m:r>
-                    <m:r>
-                      <m:rPr>
-                        <m:nor/>
-                      </m:rPr>
-                      <a:rPr lang="fr-FR" sz="1600" b="0" i="0" dirty="0" smtClean="0"/>
-                      <m:t>14.5</m:t>
-                    </m:r>
-                    <m:r>
-                      <m:rPr>
-                        <m:nor/>
-                      </m:rPr>
-                      <a:rPr lang="en-US" sz="1600" dirty="0"/>
-                      <m:t> </m:t>
-                    </m:r>
-                    <m:r>
-                      <m:rPr>
-                        <m:nor/>
-                      </m:rPr>
-                      <a:rPr lang="en-US" sz="1600" dirty="0"/>
-                      <m:t>K</m:t>
-                    </m:r>
-                    <m:r>
-                      <m:rPr>
-                        <m:nor/>
-                      </m:rPr>
-                      <a:rPr lang="en-US" sz="1600" dirty="0"/>
-                      <m:t> &lt;</m:t>
-                    </m:r>
-                    <m:sSub>
-                      <m:sSubPr>
-                        <m:ctrlPr>
-                          <a:rPr lang="fr-FR" sz="1600" i="1">
-                            <a:latin typeface="Cambria Math" panose="02040503050406030204" pitchFamily="18" charset="0"/>
-                          </a:rPr>
-                        </m:ctrlPr>
-                      </m:sSubPr>
-                      <m:e>
-                        <m:r>
-                          <a:rPr lang="fr-FR" sz="1600" b="0" i="1" smtClean="0">
-                            <a:latin typeface="Cambria Math" panose="02040503050406030204" pitchFamily="18" charset="0"/>
-                          </a:rPr>
-                          <m:t> </m:t>
-                        </m:r>
-                        <m:r>
-                          <m:rPr>
-                            <m:sty m:val="p"/>
-                          </m:rPr>
-                          <a:rPr lang="fr-FR" sz="1600" b="0" i="1">
-                            <a:latin typeface="Cambria Math" panose="02040503050406030204" pitchFamily="18" charset="0"/>
-                          </a:rPr>
-                          <m:t>δ</m:t>
-                        </m:r>
-                      </m:e>
-                      <m:sub>
-                        <m:r>
-                          <m:rPr>
-                            <m:sty m:val="p"/>
-                          </m:rPr>
-                          <a:rPr lang="fr-FR" sz="1600" b="0" i="1">
-                            <a:latin typeface="Cambria Math" panose="02040503050406030204" pitchFamily="18" charset="0"/>
-                          </a:rPr>
-                          <m:t>model</m:t>
-                        </m:r>
-                      </m:sub>
-                    </m:sSub>
-                    <m:r>
-                      <a:rPr lang="fr-FR" sz="1600" b="0">
-                        <a:latin typeface="Cambria Math" panose="02040503050406030204" pitchFamily="18" charset="0"/>
-                      </a:rPr>
-                      <m:t>&lt;</m:t>
-                    </m:r>
-                    <m:r>
-                      <a:rPr lang="fr-FR" sz="1600" b="0" i="1" smtClean="0">
-                        <a:latin typeface="Cambria Math" panose="02040503050406030204" pitchFamily="18" charset="0"/>
-                      </a:rPr>
-                      <m:t>38.1</m:t>
-                    </m:r>
-                    <m:r>
-                      <m:rPr>
-                        <m:sty m:val="p"/>
-                      </m:rPr>
-                      <a:rPr lang="fr-FR" sz="1600" b="0" i="1">
-                        <a:latin typeface="Cambria Math" panose="02040503050406030204" pitchFamily="18" charset="0"/>
-                      </a:rPr>
-                      <m:t>K</m:t>
-                    </m:r>
-                  </m:oMath>
-                </a14:m>
-                <a:r>
-                  <a:rPr lang="en-US" sz="1600" dirty="0"/>
-                  <a:t> </a:t>
-                </a:r>
-              </a:p>
-            </p:txBody>
-          </p:sp>
-        </mc:Choice>
-        <mc:Fallback>
-          <p:sp>
-            <p:nvSpPr>
-              <p:cNvPr id="6" name="TextBox 5">
-                <a:extLst>
-                  <a:ext uri="{FF2B5EF4-FFF2-40B4-BE49-F238E27FC236}">
-                    <a16:creationId xmlns:a16="http://schemas.microsoft.com/office/drawing/2014/main" id="{D0E9DB5F-EBD0-D834-D4ED-493307BE600E}"/>
-                  </a:ext>
-                </a:extLst>
-              </p:cNvPr>
-              <p:cNvSpPr txBox="1">
-                <a:spLocks noRot="1" noChangeAspect="1" noMove="1" noResize="1" noEditPoints="1" noAdjustHandles="1" noChangeArrowheads="1" noChangeShapeType="1" noTextEdit="1"/>
-              </p:cNvSpPr>
-              <p:nvPr/>
-            </p:nvSpPr>
-            <p:spPr>
-              <a:xfrm>
-                <a:off x="501445" y="5642899"/>
-                <a:ext cx="7076768" cy="849976"/>
-              </a:xfrm>
-              <a:prstGeom prst="rect">
-                <a:avLst/>
-              </a:prstGeom>
-              <a:blipFill>
-                <a:blip r:embed="rId4"/>
-                <a:stretch>
-                  <a:fillRect l="-431" t="-2878" b="-8633"/>
-                </a:stretch>
-              </a:blipFill>
-            </p:spPr>
-            <p:txBody>
-              <a:bodyPr/>
-              <a:lstStyle/>
-              <a:p>
-                <a:r>
-                  <a:rPr lang="en-US">
-                    <a:noFill/>
-                  </a:rPr>
-                  <a:t> </a:t>
-                </a:r>
-              </a:p>
-            </p:txBody>
-          </p:sp>
-        </mc:Fallback>
-      </mc:AlternateContent>
-      <mc:AlternateContent xmlns:mc="http://schemas.openxmlformats.org/markup-compatibility/2006" xmlns:a14="http://schemas.microsoft.com/office/drawing/2010/main">
-        <mc:Choice Requires="a14">
-          <p:sp>
-            <p:nvSpPr>
-              <p:cNvPr id="7" name="TextBox 6">
-                <a:extLst>
-                  <a:ext uri="{FF2B5EF4-FFF2-40B4-BE49-F238E27FC236}">
-                    <a16:creationId xmlns:a16="http://schemas.microsoft.com/office/drawing/2014/main" id="{25D42C7E-25E3-AF65-F96B-BB8C9D734754}"/>
-                  </a:ext>
-                </a:extLst>
-              </p:cNvPr>
-              <p:cNvSpPr txBox="1"/>
-              <p:nvPr/>
-            </p:nvSpPr>
-            <p:spPr>
-              <a:xfrm>
-                <a:off x="7973961" y="3429000"/>
-                <a:ext cx="3883742" cy="2464521"/>
-              </a:xfrm>
-              <a:prstGeom prst="rect">
-                <a:avLst/>
-              </a:prstGeom>
-              <a:noFill/>
-            </p:spPr>
-            <p:txBody>
-              <a:bodyPr wrap="square" rtlCol="0">
-                <a:spAutoFit/>
-              </a:bodyPr>
-              <a:lstStyle/>
-              <a:p>
-                <a:r>
-                  <a:rPr lang="fr-FR" b="0" dirty="0">
-                    <a:latin typeface="Cambria Math" panose="02040503050406030204" pitchFamily="18" charset="0"/>
-                  </a:rPr>
-                  <a:t>Dans le cas d’une loi normale : </a:t>
-                </a:r>
-              </a:p>
-              <a:p>
-                <a:pPr/>
-                <a14:m>
-                  <m:oMathPara xmlns:m="http://schemas.openxmlformats.org/officeDocument/2006/math">
-                    <m:oMathParaPr>
-                      <m:jc m:val="centerGroup"/>
-                    </m:oMathParaPr>
-                    <m:oMath xmlns:m="http://schemas.openxmlformats.org/officeDocument/2006/math">
-                      <m:d>
-                        <m:dPr>
-                          <m:begChr m:val="["/>
-                          <m:endChr m:val="]"/>
-                          <m:ctrlPr>
-                            <a:rPr lang="fr-FR" b="0" i="1" smtClean="0">
-                              <a:latin typeface="Cambria Math" panose="02040503050406030204" pitchFamily="18" charset="0"/>
-                            </a:rPr>
-                          </m:ctrlPr>
-                        </m:dPr>
-                        <m:e>
-                          <m:r>
-                            <a:rPr lang="fr-FR" b="0" i="1" smtClean="0">
-                              <a:latin typeface="Cambria Math" panose="02040503050406030204" pitchFamily="18" charset="0"/>
-                            </a:rPr>
-                            <m:t>𝑎</m:t>
-                          </m:r>
-                          <m:r>
-                            <a:rPr lang="fr-FR" b="0" i="1" smtClean="0">
-                              <a:latin typeface="Cambria Math" panose="02040503050406030204" pitchFamily="18" charset="0"/>
-                            </a:rPr>
-                            <m:t>,</m:t>
-                          </m:r>
-                          <m:r>
-                            <a:rPr lang="fr-FR" b="0" i="1" smtClean="0">
-                              <a:latin typeface="Cambria Math" panose="02040503050406030204" pitchFamily="18" charset="0"/>
-                            </a:rPr>
-                            <m:t>𝑏</m:t>
-                          </m:r>
-                        </m:e>
-                      </m:d>
-                      <m:r>
-                        <a:rPr lang="fr-FR" b="0" i="1" smtClean="0">
-                          <a:latin typeface="Cambria Math" panose="02040503050406030204" pitchFamily="18" charset="0"/>
-                        </a:rPr>
-                        <m:t>→</m:t>
-                      </m:r>
-                      <m:r>
-                        <a:rPr lang="fr-FR" b="0" i="1" smtClean="0">
-                          <a:latin typeface="Cambria Math" panose="02040503050406030204" pitchFamily="18" charset="0"/>
-                        </a:rPr>
-                        <m:t>𝜇</m:t>
-                      </m:r>
-                      <m:r>
-                        <a:rPr lang="fr-FR" b="0" i="1" smtClean="0">
-                          <a:latin typeface="Cambria Math" panose="02040503050406030204" pitchFamily="18" charset="0"/>
-                        </a:rPr>
-                        <m:t>=</m:t>
-                      </m:r>
-                      <m:f>
-                        <m:fPr>
-                          <m:ctrlPr>
-                            <a:rPr lang="fr-FR" b="0" i="1" smtClean="0">
-                              <a:latin typeface="Cambria Math" panose="02040503050406030204" pitchFamily="18" charset="0"/>
-                            </a:rPr>
-                          </m:ctrlPr>
-                        </m:fPr>
-                        <m:num>
-                          <m:r>
-                            <m:rPr>
-                              <m:sty m:val="p"/>
-                            </m:rPr>
-                            <a:rPr lang="fr-FR" b="0" i="1" smtClean="0">
-                              <a:latin typeface="Cambria Math" panose="02040503050406030204" pitchFamily="18" charset="0"/>
-                            </a:rPr>
-                            <m:t>a</m:t>
-                          </m:r>
-                          <m:r>
-                            <a:rPr lang="fr-FR" b="0" i="1" smtClean="0">
-                              <a:latin typeface="Cambria Math" panose="02040503050406030204" pitchFamily="18" charset="0"/>
-                            </a:rPr>
-                            <m:t>+</m:t>
-                          </m:r>
-                          <m:r>
-                            <m:rPr>
-                              <m:sty m:val="p"/>
-                            </m:rPr>
-                            <a:rPr lang="fr-FR" b="0" i="1" smtClean="0">
-                              <a:latin typeface="Cambria Math" panose="02040503050406030204" pitchFamily="18" charset="0"/>
-                            </a:rPr>
-                            <m:t>b</m:t>
-                          </m:r>
-                        </m:num>
-                        <m:den>
-                          <m:r>
-                            <a:rPr lang="fr-FR" b="0" i="1" smtClean="0">
-                              <a:latin typeface="Cambria Math" panose="02040503050406030204" pitchFamily="18" charset="0"/>
-                            </a:rPr>
-                            <m:t>2</m:t>
-                          </m:r>
-                        </m:den>
-                      </m:f>
-                    </m:oMath>
-                  </m:oMathPara>
-                </a14:m>
-                <a:endParaRPr lang="fr-FR" b="0" dirty="0"/>
-              </a:p>
-              <a:p>
-                <a:r>
-                  <a:rPr lang="en-US" dirty="0"/>
-                  <a:t>Pour </a:t>
-                </a:r>
-                <a:r>
-                  <a:rPr lang="en-US" dirty="0" err="1"/>
-                  <a:t>intervalle</a:t>
-                </a:r>
-                <a:r>
-                  <a:rPr lang="en-US" dirty="0"/>
-                  <a:t> de </a:t>
-                </a:r>
-                <a:r>
-                  <a:rPr lang="en-US" dirty="0" err="1"/>
-                  <a:t>confiance</a:t>
-                </a:r>
-                <a:r>
-                  <a:rPr lang="en-US" dirty="0"/>
-                  <a:t> à 95,4% :</a:t>
-                </a:r>
-              </a:p>
-              <a:p>
-                <a14:m>
-                  <m:oMath xmlns:m="http://schemas.openxmlformats.org/officeDocument/2006/math">
-                    <m:r>
-                      <m:rPr>
-                        <m:sty m:val="p"/>
-                      </m:rPr>
-                      <a:rPr lang="fr-FR" b="0" i="1" smtClean="0">
-                        <a:latin typeface="Cambria Math" panose="02040503050406030204" pitchFamily="18" charset="0"/>
-                      </a:rPr>
-                      <m:t>σ</m:t>
-                    </m:r>
-                    <m:r>
-                      <a:rPr lang="fr-FR" b="0" i="1" smtClean="0">
-                        <a:latin typeface="Cambria Math" panose="02040503050406030204" pitchFamily="18" charset="0"/>
-                      </a:rPr>
-                      <m:t>= </m:t>
-                    </m:r>
-                    <m:f>
-                      <m:fPr>
-                        <m:ctrlPr>
-                          <a:rPr lang="fr-FR" b="0" i="1" smtClean="0">
-                            <a:latin typeface="Cambria Math" panose="02040503050406030204" pitchFamily="18" charset="0"/>
-                          </a:rPr>
-                        </m:ctrlPr>
-                      </m:fPr>
-                      <m:num>
-                        <m:r>
-                          <m:rPr>
-                            <m:sty m:val="p"/>
-                          </m:rPr>
-                          <a:rPr lang="fr-FR" b="0" i="1" smtClean="0">
-                            <a:latin typeface="Cambria Math" panose="02040503050406030204" pitchFamily="18" charset="0"/>
-                          </a:rPr>
-                          <m:t>μ</m:t>
-                        </m:r>
-                        <m:r>
-                          <a:rPr lang="fr-FR" b="0" i="1" smtClean="0">
-                            <a:latin typeface="Cambria Math" panose="02040503050406030204" pitchFamily="18" charset="0"/>
-                          </a:rPr>
-                          <m:t>−</m:t>
-                        </m:r>
-                        <m:r>
-                          <m:rPr>
-                            <m:sty m:val="p"/>
-                          </m:rPr>
-                          <a:rPr lang="fr-FR" b="0" i="1" smtClean="0">
-                            <a:latin typeface="Cambria Math" panose="02040503050406030204" pitchFamily="18" charset="0"/>
-                          </a:rPr>
-                          <m:t>a</m:t>
-                        </m:r>
-                      </m:num>
-                      <m:den>
-                        <m:r>
-                          <a:rPr lang="fr-FR" b="0" i="1" smtClean="0">
-                            <a:latin typeface="Cambria Math" panose="02040503050406030204" pitchFamily="18" charset="0"/>
-                          </a:rPr>
-                          <m:t>2</m:t>
-                        </m:r>
-                      </m:den>
-                    </m:f>
-                  </m:oMath>
-                </a14:m>
-                <a:r>
-                  <a:rPr lang="en-US" dirty="0"/>
-                  <a:t> </a:t>
-                </a:r>
-              </a:p>
-              <a:p>
-                <a:r>
-                  <a:rPr lang="en-US" dirty="0"/>
-                  <a:t>Pour </a:t>
-                </a:r>
-                <a:r>
-                  <a:rPr lang="en-US" dirty="0" err="1"/>
-                  <a:t>intervalle</a:t>
-                </a:r>
-                <a:r>
-                  <a:rPr lang="en-US" dirty="0"/>
-                  <a:t> de </a:t>
-                </a:r>
-                <a:r>
-                  <a:rPr lang="en-US" dirty="0" err="1"/>
-                  <a:t>confiance</a:t>
-                </a:r>
-                <a:r>
-                  <a:rPr lang="en-US" dirty="0"/>
-                  <a:t> à 99% :</a:t>
-                </a:r>
-              </a:p>
-              <a:p>
-                <a14:m>
-                  <m:oMath xmlns:m="http://schemas.openxmlformats.org/officeDocument/2006/math">
-                    <m:r>
-                      <m:rPr>
-                        <m:sty m:val="p"/>
-                      </m:rPr>
-                      <a:rPr lang="fr-FR" i="1">
-                        <a:latin typeface="Cambria Math" panose="02040503050406030204" pitchFamily="18" charset="0"/>
-                      </a:rPr>
-                      <m:t>σ</m:t>
-                    </m:r>
-                    <m:r>
-                      <a:rPr lang="fr-FR" i="1">
-                        <a:latin typeface="Cambria Math" panose="02040503050406030204" pitchFamily="18" charset="0"/>
-                      </a:rPr>
-                      <m:t>= </m:t>
-                    </m:r>
-                    <m:f>
-                      <m:fPr>
-                        <m:ctrlPr>
-                          <a:rPr lang="fr-FR" i="1">
-                            <a:latin typeface="Cambria Math" panose="02040503050406030204" pitchFamily="18" charset="0"/>
-                          </a:rPr>
-                        </m:ctrlPr>
-                      </m:fPr>
-                      <m:num>
-                        <m:r>
-                          <m:rPr>
-                            <m:sty m:val="p"/>
-                          </m:rPr>
-                          <a:rPr lang="fr-FR" i="1">
-                            <a:latin typeface="Cambria Math" panose="02040503050406030204" pitchFamily="18" charset="0"/>
-                          </a:rPr>
-                          <m:t>μ</m:t>
-                        </m:r>
-                        <m:r>
-                          <a:rPr lang="fr-FR" i="1">
-                            <a:latin typeface="Cambria Math" panose="02040503050406030204" pitchFamily="18" charset="0"/>
-                          </a:rPr>
-                          <m:t>−</m:t>
-                        </m:r>
-                        <m:r>
-                          <m:rPr>
-                            <m:sty m:val="p"/>
-                          </m:rPr>
-                          <a:rPr lang="fr-FR" i="1">
-                            <a:latin typeface="Cambria Math" panose="02040503050406030204" pitchFamily="18" charset="0"/>
-                          </a:rPr>
-                          <m:t>a</m:t>
-                        </m:r>
-                      </m:num>
-                      <m:den>
-                        <m:r>
-                          <a:rPr lang="fr-FR" b="0" i="1" smtClean="0">
-                            <a:latin typeface="Cambria Math" panose="02040503050406030204" pitchFamily="18" charset="0"/>
-                          </a:rPr>
-                          <m:t>5</m:t>
-                        </m:r>
-                      </m:den>
-                    </m:f>
-                  </m:oMath>
-                </a14:m>
-                <a:r>
-                  <a:rPr lang="en-US" dirty="0"/>
-                  <a:t> </a:t>
-                </a:r>
-              </a:p>
-              <a:p>
-                <a:endParaRPr lang="en-US" dirty="0"/>
-              </a:p>
-            </p:txBody>
-          </p:sp>
-        </mc:Choice>
-        <mc:Fallback xmlns="">
-          <p:sp>
-            <p:nvSpPr>
-              <p:cNvPr id="7" name="TextBox 6">
-                <a:extLst>
-                  <a:ext uri="{FF2B5EF4-FFF2-40B4-BE49-F238E27FC236}">
-                    <a16:creationId xmlns:a16="http://schemas.microsoft.com/office/drawing/2014/main" id="{25D42C7E-25E3-AF65-F96B-BB8C9D734754}"/>
-                  </a:ext>
-                </a:extLst>
-              </p:cNvPr>
-              <p:cNvSpPr txBox="1">
-                <a:spLocks noRot="1" noChangeAspect="1" noMove="1" noResize="1" noEditPoints="1" noAdjustHandles="1" noChangeArrowheads="1" noChangeShapeType="1" noTextEdit="1"/>
-              </p:cNvSpPr>
-              <p:nvPr/>
-            </p:nvSpPr>
-            <p:spPr>
-              <a:xfrm>
-                <a:off x="7973961" y="3429000"/>
-                <a:ext cx="3883742" cy="2464521"/>
-              </a:xfrm>
-              <a:prstGeom prst="rect">
-                <a:avLst/>
-              </a:prstGeom>
-              <a:blipFill>
-                <a:blip r:embed="rId5"/>
-                <a:stretch>
-                  <a:fillRect l="-1256" t="-1733" r="-1099"/>
-                </a:stretch>
-              </a:blipFill>
-            </p:spPr>
-            <p:txBody>
-              <a:bodyPr/>
-              <a:lstStyle/>
-              <a:p>
-                <a:r>
-                  <a:rPr lang="en-US">
-                    <a:noFill/>
-                  </a:rPr>
-                  <a:t> </a:t>
-                </a:r>
-              </a:p>
-            </p:txBody>
-          </p:sp>
-        </mc:Fallback>
-      </mc:AlternateContent>
-      <p:pic>
-        <p:nvPicPr>
-          <p:cNvPr id="9" name="Picture 8">
-            <a:extLst>
-              <a:ext uri="{FF2B5EF4-FFF2-40B4-BE49-F238E27FC236}">
-                <a16:creationId xmlns:a16="http://schemas.microsoft.com/office/drawing/2014/main" id="{7A2BFB8D-3C80-BD69-86E4-533DD007EACD}"/>
-              </a:ext>
-            </a:extLst>
-          </p:cNvPr>
-          <p:cNvPicPr>
-            <a:picLocks noChangeAspect="1"/>
-          </p:cNvPicPr>
-          <p:nvPr/>
-        </p:nvPicPr>
-        <p:blipFill>
-          <a:blip r:embed="rId6">
-            <a:extLst>
-              <a:ext uri="{28A0092B-C50C-407E-A947-70E740481C1C}">
-                <a14:useLocalDpi xmlns:a14="http://schemas.microsoft.com/office/drawing/2010/main" val="0"/>
-              </a:ext>
-            </a:extLst>
-          </a:blip>
-          <a:stretch>
-            <a:fillRect/>
-          </a:stretch>
-        </p:blipFill>
-        <p:spPr>
-          <a:xfrm>
-            <a:off x="501445" y="3216721"/>
-            <a:ext cx="6961239" cy="2261611"/>
-          </a:xfrm>
-          <a:prstGeom prst="rect">
-            <a:avLst/>
-          </a:prstGeom>
-        </p:spPr>
-      </p:pic>
-    </p:spTree>
-    <p:extLst>
-      <p:ext uri="{BB962C8B-B14F-4D97-AF65-F5344CB8AC3E}">
-        <p14:creationId xmlns:p14="http://schemas.microsoft.com/office/powerpoint/2010/main" val="172672328"/>
       </p:ext>
     </p:extLst>
   </p:cSld>
@@ -24662,6 +23964,1053 @@
           <a:chExt cx="0" cy="0"/>
         </a:xfrm>
       </p:grpSpPr>
+      <mc:AlternateContent xmlns:mc="http://schemas.openxmlformats.org/markup-compatibility/2006" xmlns:a14="http://schemas.microsoft.com/office/drawing/2010/main">
+        <mc:Choice Requires="a14">
+          <p:sp>
+            <p:nvSpPr>
+              <p:cNvPr id="2" name="Title 1">
+                <a:extLst>
+                  <a:ext uri="{FF2B5EF4-FFF2-40B4-BE49-F238E27FC236}">
+                    <a16:creationId xmlns:a16="http://schemas.microsoft.com/office/drawing/2014/main" id="{66820A09-0F49-B31F-9AA1-11B0ABCFF4D4}"/>
+                  </a:ext>
+                </a:extLst>
+              </p:cNvPr>
+              <p:cNvSpPr>
+                <a:spLocks noGrp="1"/>
+              </p:cNvSpPr>
+              <p:nvPr>
+                <p:ph type="title"/>
+              </p:nvPr>
+            </p:nvSpPr>
+            <p:spPr/>
+            <p:txBody>
+              <a:bodyPr/>
+              <a:lstStyle/>
+              <a:p>
+                <a:r>
+                  <a:rPr lang="fr-FR" dirty="0"/>
+                  <a:t>Validation – incertitude </a:t>
+                </a:r>
+                <a14:m>
+                  <m:oMath xmlns:m="http://schemas.openxmlformats.org/officeDocument/2006/math">
+                    <m:sSub>
+                      <m:sSubPr>
+                        <m:ctrlPr>
+                          <a:rPr lang="fr-FR" i="1">
+                            <a:latin typeface="Cambria Math" panose="02040503050406030204" pitchFamily="18" charset="0"/>
+                          </a:rPr>
+                        </m:ctrlPr>
+                      </m:sSubPr>
+                      <m:e>
+                        <m:r>
+                          <a:rPr lang="fr-FR" i="1">
+                            <a:latin typeface="Cambria Math" panose="02040503050406030204" pitchFamily="18" charset="0"/>
+                          </a:rPr>
+                          <m:t>𝑢</m:t>
+                        </m:r>
+                      </m:e>
+                      <m:sub>
+                        <m:r>
+                          <a:rPr lang="fr-FR" i="1">
+                            <a:latin typeface="Cambria Math" panose="02040503050406030204" pitchFamily="18" charset="0"/>
+                          </a:rPr>
+                          <m:t>𝑖𝑛𝑝𝑢𝑡</m:t>
+                        </m:r>
+                      </m:sub>
+                    </m:sSub>
+                  </m:oMath>
+                </a14:m>
+                <a:endParaRPr lang="en-US" dirty="0"/>
+              </a:p>
+            </p:txBody>
+          </p:sp>
+        </mc:Choice>
+        <mc:Fallback xmlns="">
+          <p:sp>
+            <p:nvSpPr>
+              <p:cNvPr id="2" name="Title 1">
+                <a:extLst>
+                  <a:ext uri="{FF2B5EF4-FFF2-40B4-BE49-F238E27FC236}">
+                    <a16:creationId xmlns:a16="http://schemas.microsoft.com/office/drawing/2014/main" id="{66820A09-0F49-B31F-9AA1-11B0ABCFF4D4}"/>
+                  </a:ext>
+                </a:extLst>
+              </p:cNvPr>
+              <p:cNvSpPr>
+                <a:spLocks noGrp="1" noRot="1" noChangeAspect="1" noMove="1" noResize="1" noEditPoints="1" noAdjustHandles="1" noChangeArrowheads="1" noChangeShapeType="1" noTextEdit="1"/>
+              </p:cNvSpPr>
+              <p:nvPr>
+                <p:ph type="title"/>
+              </p:nvPr>
+            </p:nvSpPr>
+            <p:spPr>
+              <a:blipFill>
+                <a:blip r:embed="rId2"/>
+                <a:stretch>
+                  <a:fillRect l="-2377"/>
+                </a:stretch>
+              </a:blipFill>
+            </p:spPr>
+            <p:txBody>
+              <a:bodyPr/>
+              <a:lstStyle/>
+              <a:p>
+                <a:r>
+                  <a:rPr lang="en-US">
+                    <a:noFill/>
+                  </a:rPr>
+                  <a:t> </a:t>
+                </a:r>
+              </a:p>
+            </p:txBody>
+          </p:sp>
+        </mc:Fallback>
+      </mc:AlternateContent>
+      <mc:AlternateContent xmlns:mc="http://schemas.openxmlformats.org/markup-compatibility/2006" xmlns:a14="http://schemas.microsoft.com/office/drawing/2010/main">
+        <mc:Choice Requires="a14">
+          <p:sp>
+            <p:nvSpPr>
+              <p:cNvPr id="3" name="Content Placeholder 2">
+                <a:extLst>
+                  <a:ext uri="{FF2B5EF4-FFF2-40B4-BE49-F238E27FC236}">
+                    <a16:creationId xmlns:a16="http://schemas.microsoft.com/office/drawing/2014/main" id="{7BB71198-7608-579F-B3DD-7C7CBD28912F}"/>
+                  </a:ext>
+                </a:extLst>
+              </p:cNvPr>
+              <p:cNvSpPr>
+                <a:spLocks noGrp="1"/>
+              </p:cNvSpPr>
+              <p:nvPr>
+                <p:ph idx="1"/>
+              </p:nvPr>
+            </p:nvSpPr>
+            <p:spPr>
+              <a:xfrm>
+                <a:off x="838200" y="1825625"/>
+                <a:ext cx="10515600" cy="1462085"/>
+              </a:xfrm>
+            </p:spPr>
+            <p:txBody>
+              <a:bodyPr>
+                <a:normAutofit fontScale="92500"/>
+              </a:bodyPr>
+              <a:lstStyle/>
+              <a:p>
+                <a:r>
+                  <a:rPr lang="fr-FR" dirty="0"/>
+                  <a:t>Par une méthode moins conservatrice en considérant les intervalles des valeurs trouvé dans la littérature comme des intervalles de confiance à 99% il est possible de réduire considérablement </a:t>
+                </a:r>
+                <a14:m>
+                  <m:oMath xmlns:m="http://schemas.openxmlformats.org/officeDocument/2006/math">
+                    <m:sSub>
+                      <m:sSubPr>
+                        <m:ctrlPr>
+                          <a:rPr lang="fr-FR" i="1">
+                            <a:latin typeface="Cambria Math" panose="02040503050406030204" pitchFamily="18" charset="0"/>
+                          </a:rPr>
+                        </m:ctrlPr>
+                      </m:sSubPr>
+                      <m:e>
+                        <m:r>
+                          <a:rPr lang="fr-FR" i="1">
+                            <a:latin typeface="Cambria Math" panose="02040503050406030204" pitchFamily="18" charset="0"/>
+                          </a:rPr>
+                          <m:t>𝑢</m:t>
+                        </m:r>
+                      </m:e>
+                      <m:sub>
+                        <m:r>
+                          <a:rPr lang="fr-FR" i="1">
+                            <a:latin typeface="Cambria Math" panose="02040503050406030204" pitchFamily="18" charset="0"/>
+                          </a:rPr>
+                          <m:t>𝑖𝑛𝑝𝑢𝑡</m:t>
+                        </m:r>
+                      </m:sub>
+                    </m:sSub>
+                  </m:oMath>
+                </a14:m>
+                <a:endParaRPr lang="en-US" dirty="0"/>
+              </a:p>
+            </p:txBody>
+          </p:sp>
+        </mc:Choice>
+        <mc:Fallback xmlns="">
+          <p:sp>
+            <p:nvSpPr>
+              <p:cNvPr id="3" name="Content Placeholder 2">
+                <a:extLst>
+                  <a:ext uri="{FF2B5EF4-FFF2-40B4-BE49-F238E27FC236}">
+                    <a16:creationId xmlns:a16="http://schemas.microsoft.com/office/drawing/2014/main" id="{7BB71198-7608-579F-B3DD-7C7CBD28912F}"/>
+                  </a:ext>
+                </a:extLst>
+              </p:cNvPr>
+              <p:cNvSpPr>
+                <a:spLocks noGrp="1" noRot="1" noChangeAspect="1" noMove="1" noResize="1" noEditPoints="1" noAdjustHandles="1" noChangeArrowheads="1" noChangeShapeType="1" noTextEdit="1"/>
+              </p:cNvSpPr>
+              <p:nvPr>
+                <p:ph idx="1"/>
+              </p:nvPr>
+            </p:nvSpPr>
+            <p:spPr>
+              <a:xfrm>
+                <a:off x="838200" y="1825625"/>
+                <a:ext cx="10515600" cy="1462085"/>
+              </a:xfrm>
+              <a:blipFill>
+                <a:blip r:embed="rId3"/>
+                <a:stretch>
+                  <a:fillRect l="-928" t="-6250"/>
+                </a:stretch>
+              </a:blipFill>
+            </p:spPr>
+            <p:txBody>
+              <a:bodyPr/>
+              <a:lstStyle/>
+              <a:p>
+                <a:r>
+                  <a:rPr lang="en-US">
+                    <a:noFill/>
+                  </a:rPr>
+                  <a:t> </a:t>
+                </a:r>
+              </a:p>
+            </p:txBody>
+          </p:sp>
+        </mc:Fallback>
+      </mc:AlternateContent>
+      <p:sp>
+        <p:nvSpPr>
+          <p:cNvPr id="4" name="Slide Number Placeholder 3">
+            <a:extLst>
+              <a:ext uri="{FF2B5EF4-FFF2-40B4-BE49-F238E27FC236}">
+                <a16:creationId xmlns:a16="http://schemas.microsoft.com/office/drawing/2014/main" id="{91EA1BFD-A6AF-4A14-34C0-65467A1D021C}"/>
+              </a:ext>
+            </a:extLst>
+          </p:cNvPr>
+          <p:cNvSpPr>
+            <a:spLocks noGrp="1"/>
+          </p:cNvSpPr>
+          <p:nvPr>
+            <p:ph type="sldNum" sz="quarter" idx="12"/>
+          </p:nvPr>
+        </p:nvSpPr>
+        <p:spPr/>
+        <p:txBody>
+          <a:bodyPr/>
+          <a:lstStyle/>
+          <a:p>
+            <a:fld id="{FD85B578-4E75-4E1C-9BE3-D5DCC0715B13}" type="slidenum">
+              <a:rPr lang="fr-FR" smtClean="0"/>
+              <a:t>30</a:t>
+            </a:fld>
+            <a:endParaRPr lang="fr-FR" dirty="0"/>
+          </a:p>
+        </p:txBody>
+      </p:sp>
+      <mc:AlternateContent xmlns:mc="http://schemas.openxmlformats.org/markup-compatibility/2006" xmlns:a14="http://schemas.microsoft.com/office/drawing/2010/main">
+        <mc:Choice Requires="a14">
+          <p:sp>
+            <p:nvSpPr>
+              <p:cNvPr id="6" name="TextBox 5">
+                <a:extLst>
+                  <a:ext uri="{FF2B5EF4-FFF2-40B4-BE49-F238E27FC236}">
+                    <a16:creationId xmlns:a16="http://schemas.microsoft.com/office/drawing/2014/main" id="{D0E9DB5F-EBD0-D834-D4ED-493307BE600E}"/>
+                  </a:ext>
+                </a:extLst>
+              </p:cNvPr>
+              <p:cNvSpPr txBox="1"/>
+              <p:nvPr/>
+            </p:nvSpPr>
+            <p:spPr>
+              <a:xfrm>
+                <a:off x="501445" y="5642899"/>
+                <a:ext cx="7076768" cy="849976"/>
+              </a:xfrm>
+              <a:prstGeom prst="rect">
+                <a:avLst/>
+              </a:prstGeom>
+              <a:noFill/>
+            </p:spPr>
+            <p:txBody>
+              <a:bodyPr wrap="square" rtlCol="0">
+                <a:spAutoFit/>
+              </a:bodyPr>
+              <a:lstStyle/>
+              <a:p>
+                <a:r>
+                  <a:rPr lang="fr-FR" sz="1600" b="0" i="1" dirty="0">
+                    <a:latin typeface="Cambria Math" panose="02040503050406030204" pitchFamily="18" charset="0"/>
+                  </a:rPr>
+                  <a:t>Résultat pour intervalle de confian</a:t>
+                </a:r>
+                <a:r>
+                  <a:rPr lang="fr-FR" sz="1600" i="1" dirty="0">
+                    <a:latin typeface="Cambria Math" panose="02040503050406030204" pitchFamily="18" charset="0"/>
+                  </a:rPr>
+                  <a:t>ce à 99%</a:t>
+                </a:r>
+                <a:endParaRPr lang="fr-FR" sz="1600" b="0" i="1" dirty="0">
+                  <a:latin typeface="Cambria Math" panose="02040503050406030204" pitchFamily="18" charset="0"/>
+                </a:endParaRPr>
+              </a:p>
+              <a:p>
+                <a14:m>
+                  <m:oMath xmlns:m="http://schemas.openxmlformats.org/officeDocument/2006/math">
+                    <m:sSub>
+                      <m:sSubPr>
+                        <m:ctrlPr>
+                          <a:rPr lang="fr-FR" sz="1600" b="0" i="1" smtClean="0">
+                            <a:latin typeface="Cambria Math" panose="02040503050406030204" pitchFamily="18" charset="0"/>
+                          </a:rPr>
+                        </m:ctrlPr>
+                      </m:sSubPr>
+                      <m:e>
+                        <m:r>
+                          <a:rPr lang="fr-FR" sz="1600" b="0" i="1" smtClean="0">
+                            <a:latin typeface="Cambria Math" panose="02040503050406030204" pitchFamily="18" charset="0"/>
+                          </a:rPr>
+                          <m:t>𝑢</m:t>
+                        </m:r>
+                      </m:e>
+                      <m:sub>
+                        <m:r>
+                          <a:rPr lang="fr-FR" sz="1600" b="0" i="1" smtClean="0">
+                            <a:latin typeface="Cambria Math" panose="02040503050406030204" pitchFamily="18" charset="0"/>
+                          </a:rPr>
+                          <m:t>𝑖𝑛𝑝𝑢𝑡</m:t>
+                        </m:r>
+                      </m:sub>
+                    </m:sSub>
+                    <m:r>
+                      <a:rPr lang="fr-FR" sz="1600" b="0" i="1" smtClean="0">
+                        <a:latin typeface="Cambria Math" panose="02040503050406030204" pitchFamily="18" charset="0"/>
+                      </a:rPr>
+                      <m:t>=13.1 </m:t>
+                    </m:r>
+                    <m:r>
+                      <m:rPr>
+                        <m:sty m:val="p"/>
+                      </m:rPr>
+                      <a:rPr lang="fr-FR" sz="1600" b="0" i="1" smtClean="0">
+                        <a:latin typeface="Cambria Math" panose="02040503050406030204" pitchFamily="18" charset="0"/>
+                      </a:rPr>
+                      <m:t>K</m:t>
+                    </m:r>
+                  </m:oMath>
+                </a14:m>
+                <a:r>
+                  <a:rPr lang="en-US" sz="1600" dirty="0"/>
+                  <a:t> pour </a:t>
+                </a:r>
+                <a14:m>
+                  <m:oMath xmlns:m="http://schemas.openxmlformats.org/officeDocument/2006/math">
+                    <m:sSub>
+                      <m:sSubPr>
+                        <m:ctrlPr>
+                          <a:rPr lang="fr-FR" sz="1600" b="0" i="1" smtClean="0">
+                            <a:latin typeface="Cambria Math" panose="02040503050406030204" pitchFamily="18" charset="0"/>
+                          </a:rPr>
+                        </m:ctrlPr>
+                      </m:sSubPr>
+                      <m:e>
+                        <m:r>
+                          <a:rPr lang="fr-FR" sz="1600" b="0" i="1" smtClean="0">
+                            <a:latin typeface="Cambria Math" panose="02040503050406030204" pitchFamily="18" charset="0"/>
+                          </a:rPr>
+                          <m:t>𝜎</m:t>
+                        </m:r>
+                      </m:e>
+                      <m:sub>
+                        <m:r>
+                          <a:rPr lang="fr-FR" sz="1600" b="0" i="1" smtClean="0">
+                            <a:latin typeface="Cambria Math" panose="02040503050406030204" pitchFamily="18" charset="0"/>
+                          </a:rPr>
+                          <m:t>𝜀</m:t>
+                        </m:r>
+                      </m:sub>
+                    </m:sSub>
+                    <m:r>
+                      <a:rPr lang="fr-FR" sz="1600" b="0" i="1" smtClean="0">
+                        <a:latin typeface="Cambria Math" panose="02040503050406030204" pitchFamily="18" charset="0"/>
+                      </a:rPr>
+                      <m:t>=0.07</m:t>
+                    </m:r>
+                    <m:r>
+                      <a:rPr lang="fr-FR" sz="1600" b="1" i="1" smtClean="0">
+                        <a:latin typeface="Cambria Math" panose="02040503050406030204" pitchFamily="18" charset="0"/>
+                      </a:rPr>
+                      <m:t>5 </m:t>
+                    </m:r>
+                    <m:r>
+                      <m:rPr>
+                        <m:sty m:val="p"/>
+                      </m:rPr>
+                      <a:rPr lang="fr-FR" sz="1600" b="1" i="1" smtClean="0">
+                        <a:latin typeface="Cambria Math" panose="02040503050406030204" pitchFamily="18" charset="0"/>
+                      </a:rPr>
+                      <m:t>et</m:t>
+                    </m:r>
+                    <m:r>
+                      <a:rPr lang="fr-FR" sz="1600" b="1" i="1" smtClean="0">
+                        <a:latin typeface="Cambria Math" panose="02040503050406030204" pitchFamily="18" charset="0"/>
+                      </a:rPr>
+                      <m:t> </m:t>
+                    </m:r>
+                    <m:r>
+                      <m:rPr>
+                        <m:sty m:val="p"/>
+                      </m:rPr>
+                      <a:rPr lang="fr-FR" sz="1600" b="1" i="1" smtClean="0">
+                        <a:latin typeface="Cambria Math" panose="02040503050406030204" pitchFamily="18" charset="0"/>
+                      </a:rPr>
+                      <m:t>σk</m:t>
+                    </m:r>
+                    <m:r>
+                      <a:rPr lang="fr-FR" sz="1600" b="1" i="1" smtClean="0">
+                        <a:latin typeface="Cambria Math" panose="02040503050406030204" pitchFamily="18" charset="0"/>
+                      </a:rPr>
+                      <m:t> = 2.5⇒</m:t>
+                    </m:r>
+                    <m:sSub>
+                      <m:sSubPr>
+                        <m:ctrlPr>
+                          <a:rPr lang="fr-FR" sz="1600" b="1" i="1" smtClean="0">
+                            <a:latin typeface="Cambria Math" panose="02040503050406030204" pitchFamily="18" charset="0"/>
+                          </a:rPr>
+                        </m:ctrlPr>
+                      </m:sSubPr>
+                      <m:e>
+                        <m:r>
+                          <a:rPr lang="fr-FR" sz="1600" b="1" i="1" smtClean="0">
+                            <a:latin typeface="Cambria Math" panose="02040503050406030204" pitchFamily="18" charset="0"/>
+                          </a:rPr>
+                          <m:t>𝒖</m:t>
+                        </m:r>
+                      </m:e>
+                      <m:sub>
+                        <m:r>
+                          <a:rPr lang="fr-FR" sz="1600" b="1" i="1" smtClean="0">
+                            <a:latin typeface="Cambria Math" panose="02040503050406030204" pitchFamily="18" charset="0"/>
+                          </a:rPr>
+                          <m:t>𝒗𝒂𝒍</m:t>
+                        </m:r>
+                      </m:sub>
+                    </m:sSub>
+                    <m:r>
+                      <a:rPr lang="fr-FR" sz="1600" b="1" i="1" smtClean="0">
+                        <a:latin typeface="Cambria Math" panose="02040503050406030204" pitchFamily="18" charset="0"/>
+                      </a:rPr>
+                      <m:t>=13.16 </m:t>
+                    </m:r>
+                    <m:r>
+                      <a:rPr lang="fr-FR" sz="1600" b="1" i="1" smtClean="0">
+                        <a:latin typeface="Cambria Math" panose="02040503050406030204" pitchFamily="18" charset="0"/>
+                      </a:rPr>
+                      <m:t>𝑲</m:t>
+                    </m:r>
+                  </m:oMath>
+                </a14:m>
+                <a:endParaRPr lang="en-US" sz="1600" dirty="0"/>
+              </a:p>
+              <a:p>
+                <a:r>
+                  <a:rPr lang="en-US" sz="1600" dirty="0"/>
+                  <a:t> </a:t>
+                </a:r>
+                <a14:m>
+                  <m:oMath xmlns:m="http://schemas.openxmlformats.org/officeDocument/2006/math">
+                    <m:r>
+                      <a:rPr lang="en-US" sz="1600" b="1" i="1">
+                        <a:latin typeface="Cambria Math" panose="02040503050406030204" pitchFamily="18" charset="0"/>
+                      </a:rPr>
+                      <m:t>⇒</m:t>
+                    </m:r>
+                    <m:r>
+                      <m:rPr>
+                        <m:nor/>
+                      </m:rPr>
+                      <a:rPr lang="en-US" sz="1600" dirty="0"/>
+                      <m:t>−</m:t>
+                    </m:r>
+                    <m:r>
+                      <m:rPr>
+                        <m:nor/>
+                      </m:rPr>
+                      <a:rPr lang="fr-FR" sz="1600" b="0" i="0" dirty="0" smtClean="0"/>
+                      <m:t>14.5</m:t>
+                    </m:r>
+                    <m:r>
+                      <m:rPr>
+                        <m:nor/>
+                      </m:rPr>
+                      <a:rPr lang="en-US" sz="1600" dirty="0"/>
+                      <m:t> </m:t>
+                    </m:r>
+                    <m:r>
+                      <m:rPr>
+                        <m:nor/>
+                      </m:rPr>
+                      <a:rPr lang="en-US" sz="1600" dirty="0"/>
+                      <m:t>K</m:t>
+                    </m:r>
+                    <m:r>
+                      <m:rPr>
+                        <m:nor/>
+                      </m:rPr>
+                      <a:rPr lang="en-US" sz="1600" dirty="0"/>
+                      <m:t> &lt;</m:t>
+                    </m:r>
+                    <m:sSub>
+                      <m:sSubPr>
+                        <m:ctrlPr>
+                          <a:rPr lang="fr-FR" sz="1600" i="1">
+                            <a:latin typeface="Cambria Math" panose="02040503050406030204" pitchFamily="18" charset="0"/>
+                          </a:rPr>
+                        </m:ctrlPr>
+                      </m:sSubPr>
+                      <m:e>
+                        <m:r>
+                          <a:rPr lang="fr-FR" sz="1600" b="0" i="1" smtClean="0">
+                            <a:latin typeface="Cambria Math" panose="02040503050406030204" pitchFamily="18" charset="0"/>
+                          </a:rPr>
+                          <m:t> </m:t>
+                        </m:r>
+                        <m:r>
+                          <m:rPr>
+                            <m:sty m:val="p"/>
+                          </m:rPr>
+                          <a:rPr lang="fr-FR" sz="1600" b="0" i="1">
+                            <a:latin typeface="Cambria Math" panose="02040503050406030204" pitchFamily="18" charset="0"/>
+                          </a:rPr>
+                          <m:t>δ</m:t>
+                        </m:r>
+                      </m:e>
+                      <m:sub>
+                        <m:r>
+                          <m:rPr>
+                            <m:sty m:val="p"/>
+                          </m:rPr>
+                          <a:rPr lang="fr-FR" sz="1600" b="0" i="1">
+                            <a:latin typeface="Cambria Math" panose="02040503050406030204" pitchFamily="18" charset="0"/>
+                          </a:rPr>
+                          <m:t>model</m:t>
+                        </m:r>
+                      </m:sub>
+                    </m:sSub>
+                    <m:r>
+                      <a:rPr lang="fr-FR" sz="1600" b="0">
+                        <a:latin typeface="Cambria Math" panose="02040503050406030204" pitchFamily="18" charset="0"/>
+                      </a:rPr>
+                      <m:t>&lt;</m:t>
+                    </m:r>
+                    <m:r>
+                      <a:rPr lang="fr-FR" sz="1600" b="0" i="1" smtClean="0">
+                        <a:latin typeface="Cambria Math" panose="02040503050406030204" pitchFamily="18" charset="0"/>
+                      </a:rPr>
+                      <m:t>38.1</m:t>
+                    </m:r>
+                    <m:r>
+                      <m:rPr>
+                        <m:sty m:val="p"/>
+                      </m:rPr>
+                      <a:rPr lang="fr-FR" sz="1600" b="0" i="1">
+                        <a:latin typeface="Cambria Math" panose="02040503050406030204" pitchFamily="18" charset="0"/>
+                      </a:rPr>
+                      <m:t>K</m:t>
+                    </m:r>
+                  </m:oMath>
+                </a14:m>
+                <a:r>
+                  <a:rPr lang="en-US" sz="1600" dirty="0"/>
+                  <a:t> </a:t>
+                </a:r>
+              </a:p>
+            </p:txBody>
+          </p:sp>
+        </mc:Choice>
+        <mc:Fallback xmlns="">
+          <p:sp>
+            <p:nvSpPr>
+              <p:cNvPr id="6" name="TextBox 5">
+                <a:extLst>
+                  <a:ext uri="{FF2B5EF4-FFF2-40B4-BE49-F238E27FC236}">
+                    <a16:creationId xmlns:a16="http://schemas.microsoft.com/office/drawing/2014/main" id="{D0E9DB5F-EBD0-D834-D4ED-493307BE600E}"/>
+                  </a:ext>
+                </a:extLst>
+              </p:cNvPr>
+              <p:cNvSpPr txBox="1">
+                <a:spLocks noRot="1" noChangeAspect="1" noMove="1" noResize="1" noEditPoints="1" noAdjustHandles="1" noChangeArrowheads="1" noChangeShapeType="1" noTextEdit="1"/>
+              </p:cNvSpPr>
+              <p:nvPr/>
+            </p:nvSpPr>
+            <p:spPr>
+              <a:xfrm>
+                <a:off x="501445" y="5642899"/>
+                <a:ext cx="7076768" cy="849976"/>
+              </a:xfrm>
+              <a:prstGeom prst="rect">
+                <a:avLst/>
+              </a:prstGeom>
+              <a:blipFill>
+                <a:blip r:embed="rId4"/>
+                <a:stretch>
+                  <a:fillRect l="-431" t="-2878" b="-8633"/>
+                </a:stretch>
+              </a:blipFill>
+            </p:spPr>
+            <p:txBody>
+              <a:bodyPr/>
+              <a:lstStyle/>
+              <a:p>
+                <a:r>
+                  <a:rPr lang="en-US">
+                    <a:noFill/>
+                  </a:rPr>
+                  <a:t> </a:t>
+                </a:r>
+              </a:p>
+            </p:txBody>
+          </p:sp>
+        </mc:Fallback>
+      </mc:AlternateContent>
+      <mc:AlternateContent xmlns:mc="http://schemas.openxmlformats.org/markup-compatibility/2006" xmlns:a14="http://schemas.microsoft.com/office/drawing/2010/main">
+        <mc:Choice Requires="a14">
+          <p:sp>
+            <p:nvSpPr>
+              <p:cNvPr id="7" name="TextBox 6">
+                <a:extLst>
+                  <a:ext uri="{FF2B5EF4-FFF2-40B4-BE49-F238E27FC236}">
+                    <a16:creationId xmlns:a16="http://schemas.microsoft.com/office/drawing/2014/main" id="{25D42C7E-25E3-AF65-F96B-BB8C9D734754}"/>
+                  </a:ext>
+                </a:extLst>
+              </p:cNvPr>
+              <p:cNvSpPr txBox="1"/>
+              <p:nvPr/>
+            </p:nvSpPr>
+            <p:spPr>
+              <a:xfrm>
+                <a:off x="7973961" y="3429000"/>
+                <a:ext cx="3883742" cy="2464521"/>
+              </a:xfrm>
+              <a:prstGeom prst="rect">
+                <a:avLst/>
+              </a:prstGeom>
+              <a:noFill/>
+            </p:spPr>
+            <p:txBody>
+              <a:bodyPr wrap="square" rtlCol="0">
+                <a:spAutoFit/>
+              </a:bodyPr>
+              <a:lstStyle/>
+              <a:p>
+                <a:r>
+                  <a:rPr lang="fr-FR" b="0" dirty="0">
+                    <a:latin typeface="Cambria Math" panose="02040503050406030204" pitchFamily="18" charset="0"/>
+                  </a:rPr>
+                  <a:t>Dans le cas d’une loi normale : </a:t>
+                </a:r>
+              </a:p>
+              <a:p>
+                <a:pPr/>
+                <a14:m>
+                  <m:oMathPara xmlns:m="http://schemas.openxmlformats.org/officeDocument/2006/math">
+                    <m:oMathParaPr>
+                      <m:jc m:val="centerGroup"/>
+                    </m:oMathParaPr>
+                    <m:oMath xmlns:m="http://schemas.openxmlformats.org/officeDocument/2006/math">
+                      <m:d>
+                        <m:dPr>
+                          <m:begChr m:val="["/>
+                          <m:endChr m:val="]"/>
+                          <m:ctrlPr>
+                            <a:rPr lang="fr-FR" b="0" i="1" smtClean="0">
+                              <a:latin typeface="Cambria Math" panose="02040503050406030204" pitchFamily="18" charset="0"/>
+                            </a:rPr>
+                          </m:ctrlPr>
+                        </m:dPr>
+                        <m:e>
+                          <m:r>
+                            <a:rPr lang="fr-FR" b="0" i="1" smtClean="0">
+                              <a:latin typeface="Cambria Math" panose="02040503050406030204" pitchFamily="18" charset="0"/>
+                            </a:rPr>
+                            <m:t>𝑎</m:t>
+                          </m:r>
+                          <m:r>
+                            <a:rPr lang="fr-FR" b="0" i="1" smtClean="0">
+                              <a:latin typeface="Cambria Math" panose="02040503050406030204" pitchFamily="18" charset="0"/>
+                            </a:rPr>
+                            <m:t>,</m:t>
+                          </m:r>
+                          <m:r>
+                            <a:rPr lang="fr-FR" b="0" i="1" smtClean="0">
+                              <a:latin typeface="Cambria Math" panose="02040503050406030204" pitchFamily="18" charset="0"/>
+                            </a:rPr>
+                            <m:t>𝑏</m:t>
+                          </m:r>
+                        </m:e>
+                      </m:d>
+                      <m:r>
+                        <a:rPr lang="fr-FR" b="0" i="1" smtClean="0">
+                          <a:latin typeface="Cambria Math" panose="02040503050406030204" pitchFamily="18" charset="0"/>
+                        </a:rPr>
+                        <m:t>→</m:t>
+                      </m:r>
+                      <m:r>
+                        <a:rPr lang="fr-FR" b="0" i="1" smtClean="0">
+                          <a:latin typeface="Cambria Math" panose="02040503050406030204" pitchFamily="18" charset="0"/>
+                        </a:rPr>
+                        <m:t>𝜇</m:t>
+                      </m:r>
+                      <m:r>
+                        <a:rPr lang="fr-FR" b="0" i="1" smtClean="0">
+                          <a:latin typeface="Cambria Math" panose="02040503050406030204" pitchFamily="18" charset="0"/>
+                        </a:rPr>
+                        <m:t>=</m:t>
+                      </m:r>
+                      <m:f>
+                        <m:fPr>
+                          <m:ctrlPr>
+                            <a:rPr lang="fr-FR" b="0" i="1" smtClean="0">
+                              <a:latin typeface="Cambria Math" panose="02040503050406030204" pitchFamily="18" charset="0"/>
+                            </a:rPr>
+                          </m:ctrlPr>
+                        </m:fPr>
+                        <m:num>
+                          <m:r>
+                            <m:rPr>
+                              <m:sty m:val="p"/>
+                            </m:rPr>
+                            <a:rPr lang="fr-FR" b="0" i="1" smtClean="0">
+                              <a:latin typeface="Cambria Math" panose="02040503050406030204" pitchFamily="18" charset="0"/>
+                            </a:rPr>
+                            <m:t>a</m:t>
+                          </m:r>
+                          <m:r>
+                            <a:rPr lang="fr-FR" b="0" i="1" smtClean="0">
+                              <a:latin typeface="Cambria Math" panose="02040503050406030204" pitchFamily="18" charset="0"/>
+                            </a:rPr>
+                            <m:t>+</m:t>
+                          </m:r>
+                          <m:r>
+                            <m:rPr>
+                              <m:sty m:val="p"/>
+                            </m:rPr>
+                            <a:rPr lang="fr-FR" b="0" i="1" smtClean="0">
+                              <a:latin typeface="Cambria Math" panose="02040503050406030204" pitchFamily="18" charset="0"/>
+                            </a:rPr>
+                            <m:t>b</m:t>
+                          </m:r>
+                        </m:num>
+                        <m:den>
+                          <m:r>
+                            <a:rPr lang="fr-FR" b="0" i="1" smtClean="0">
+                              <a:latin typeface="Cambria Math" panose="02040503050406030204" pitchFamily="18" charset="0"/>
+                            </a:rPr>
+                            <m:t>2</m:t>
+                          </m:r>
+                        </m:den>
+                      </m:f>
+                    </m:oMath>
+                  </m:oMathPara>
+                </a14:m>
+                <a:endParaRPr lang="fr-FR" b="0" dirty="0"/>
+              </a:p>
+              <a:p>
+                <a:r>
+                  <a:rPr lang="en-US" dirty="0"/>
+                  <a:t>Pour </a:t>
+                </a:r>
+                <a:r>
+                  <a:rPr lang="en-US" dirty="0" err="1"/>
+                  <a:t>intervalle</a:t>
+                </a:r>
+                <a:r>
+                  <a:rPr lang="en-US" dirty="0"/>
+                  <a:t> de </a:t>
+                </a:r>
+                <a:r>
+                  <a:rPr lang="en-US" dirty="0" err="1"/>
+                  <a:t>confiance</a:t>
+                </a:r>
+                <a:r>
+                  <a:rPr lang="en-US" dirty="0"/>
+                  <a:t> à 95,4% :</a:t>
+                </a:r>
+              </a:p>
+              <a:p>
+                <a14:m>
+                  <m:oMath xmlns:m="http://schemas.openxmlformats.org/officeDocument/2006/math">
+                    <m:r>
+                      <m:rPr>
+                        <m:sty m:val="p"/>
+                      </m:rPr>
+                      <a:rPr lang="fr-FR" b="0" i="1" smtClean="0">
+                        <a:latin typeface="Cambria Math" panose="02040503050406030204" pitchFamily="18" charset="0"/>
+                      </a:rPr>
+                      <m:t>σ</m:t>
+                    </m:r>
+                    <m:r>
+                      <a:rPr lang="fr-FR" b="0" i="1" smtClean="0">
+                        <a:latin typeface="Cambria Math" panose="02040503050406030204" pitchFamily="18" charset="0"/>
+                      </a:rPr>
+                      <m:t>= </m:t>
+                    </m:r>
+                    <m:f>
+                      <m:fPr>
+                        <m:ctrlPr>
+                          <a:rPr lang="fr-FR" b="0" i="1" smtClean="0">
+                            <a:latin typeface="Cambria Math" panose="02040503050406030204" pitchFamily="18" charset="0"/>
+                          </a:rPr>
+                        </m:ctrlPr>
+                      </m:fPr>
+                      <m:num>
+                        <m:r>
+                          <m:rPr>
+                            <m:sty m:val="p"/>
+                          </m:rPr>
+                          <a:rPr lang="fr-FR" b="0" i="1" smtClean="0">
+                            <a:latin typeface="Cambria Math" panose="02040503050406030204" pitchFamily="18" charset="0"/>
+                          </a:rPr>
+                          <m:t>μ</m:t>
+                        </m:r>
+                        <m:r>
+                          <a:rPr lang="fr-FR" b="0" i="1" smtClean="0">
+                            <a:latin typeface="Cambria Math" panose="02040503050406030204" pitchFamily="18" charset="0"/>
+                          </a:rPr>
+                          <m:t>−</m:t>
+                        </m:r>
+                        <m:r>
+                          <m:rPr>
+                            <m:sty m:val="p"/>
+                          </m:rPr>
+                          <a:rPr lang="fr-FR" b="0" i="1" smtClean="0">
+                            <a:latin typeface="Cambria Math" panose="02040503050406030204" pitchFamily="18" charset="0"/>
+                          </a:rPr>
+                          <m:t>a</m:t>
+                        </m:r>
+                      </m:num>
+                      <m:den>
+                        <m:r>
+                          <a:rPr lang="fr-FR" b="0" i="1" smtClean="0">
+                            <a:latin typeface="Cambria Math" panose="02040503050406030204" pitchFamily="18" charset="0"/>
+                          </a:rPr>
+                          <m:t>2</m:t>
+                        </m:r>
+                      </m:den>
+                    </m:f>
+                  </m:oMath>
+                </a14:m>
+                <a:r>
+                  <a:rPr lang="en-US" dirty="0"/>
+                  <a:t> </a:t>
+                </a:r>
+              </a:p>
+              <a:p>
+                <a:r>
+                  <a:rPr lang="en-US" dirty="0"/>
+                  <a:t>Pour </a:t>
+                </a:r>
+                <a:r>
+                  <a:rPr lang="en-US" dirty="0" err="1"/>
+                  <a:t>intervalle</a:t>
+                </a:r>
+                <a:r>
+                  <a:rPr lang="en-US" dirty="0"/>
+                  <a:t> de </a:t>
+                </a:r>
+                <a:r>
+                  <a:rPr lang="en-US" dirty="0" err="1"/>
+                  <a:t>confiance</a:t>
+                </a:r>
+                <a:r>
+                  <a:rPr lang="en-US" dirty="0"/>
+                  <a:t> à 99% :</a:t>
+                </a:r>
+              </a:p>
+              <a:p>
+                <a14:m>
+                  <m:oMath xmlns:m="http://schemas.openxmlformats.org/officeDocument/2006/math">
+                    <m:r>
+                      <m:rPr>
+                        <m:sty m:val="p"/>
+                      </m:rPr>
+                      <a:rPr lang="fr-FR" i="1">
+                        <a:latin typeface="Cambria Math" panose="02040503050406030204" pitchFamily="18" charset="0"/>
+                      </a:rPr>
+                      <m:t>σ</m:t>
+                    </m:r>
+                    <m:r>
+                      <a:rPr lang="fr-FR" i="1">
+                        <a:latin typeface="Cambria Math" panose="02040503050406030204" pitchFamily="18" charset="0"/>
+                      </a:rPr>
+                      <m:t>= </m:t>
+                    </m:r>
+                    <m:f>
+                      <m:fPr>
+                        <m:ctrlPr>
+                          <a:rPr lang="fr-FR" i="1">
+                            <a:latin typeface="Cambria Math" panose="02040503050406030204" pitchFamily="18" charset="0"/>
+                          </a:rPr>
+                        </m:ctrlPr>
+                      </m:fPr>
+                      <m:num>
+                        <m:r>
+                          <m:rPr>
+                            <m:sty m:val="p"/>
+                          </m:rPr>
+                          <a:rPr lang="fr-FR" i="1">
+                            <a:latin typeface="Cambria Math" panose="02040503050406030204" pitchFamily="18" charset="0"/>
+                          </a:rPr>
+                          <m:t>μ</m:t>
+                        </m:r>
+                        <m:r>
+                          <a:rPr lang="fr-FR" i="1">
+                            <a:latin typeface="Cambria Math" panose="02040503050406030204" pitchFamily="18" charset="0"/>
+                          </a:rPr>
+                          <m:t>−</m:t>
+                        </m:r>
+                        <m:r>
+                          <m:rPr>
+                            <m:sty m:val="p"/>
+                          </m:rPr>
+                          <a:rPr lang="fr-FR" i="1">
+                            <a:latin typeface="Cambria Math" panose="02040503050406030204" pitchFamily="18" charset="0"/>
+                          </a:rPr>
+                          <m:t>a</m:t>
+                        </m:r>
+                      </m:num>
+                      <m:den>
+                        <m:r>
+                          <a:rPr lang="fr-FR" b="0" i="1" smtClean="0">
+                            <a:latin typeface="Cambria Math" panose="02040503050406030204" pitchFamily="18" charset="0"/>
+                          </a:rPr>
+                          <m:t>5</m:t>
+                        </m:r>
+                      </m:den>
+                    </m:f>
+                  </m:oMath>
+                </a14:m>
+                <a:r>
+                  <a:rPr lang="en-US" dirty="0"/>
+                  <a:t> </a:t>
+                </a:r>
+              </a:p>
+              <a:p>
+                <a:endParaRPr lang="en-US" dirty="0"/>
+              </a:p>
+            </p:txBody>
+          </p:sp>
+        </mc:Choice>
+        <mc:Fallback xmlns="">
+          <p:sp>
+            <p:nvSpPr>
+              <p:cNvPr id="7" name="TextBox 6">
+                <a:extLst>
+                  <a:ext uri="{FF2B5EF4-FFF2-40B4-BE49-F238E27FC236}">
+                    <a16:creationId xmlns:a16="http://schemas.microsoft.com/office/drawing/2014/main" id="{25D42C7E-25E3-AF65-F96B-BB8C9D734754}"/>
+                  </a:ext>
+                </a:extLst>
+              </p:cNvPr>
+              <p:cNvSpPr txBox="1">
+                <a:spLocks noRot="1" noChangeAspect="1" noMove="1" noResize="1" noEditPoints="1" noAdjustHandles="1" noChangeArrowheads="1" noChangeShapeType="1" noTextEdit="1"/>
+              </p:cNvSpPr>
+              <p:nvPr/>
+            </p:nvSpPr>
+            <p:spPr>
+              <a:xfrm>
+                <a:off x="7973961" y="3429000"/>
+                <a:ext cx="3883742" cy="2464521"/>
+              </a:xfrm>
+              <a:prstGeom prst="rect">
+                <a:avLst/>
+              </a:prstGeom>
+              <a:blipFill>
+                <a:blip r:embed="rId5"/>
+                <a:stretch>
+                  <a:fillRect l="-1256" t="-1733" r="-1099"/>
+                </a:stretch>
+              </a:blipFill>
+            </p:spPr>
+            <p:txBody>
+              <a:bodyPr/>
+              <a:lstStyle/>
+              <a:p>
+                <a:r>
+                  <a:rPr lang="en-US">
+                    <a:noFill/>
+                  </a:rPr>
+                  <a:t> </a:t>
+                </a:r>
+              </a:p>
+            </p:txBody>
+          </p:sp>
+        </mc:Fallback>
+      </mc:AlternateContent>
+      <p:pic>
+        <p:nvPicPr>
+          <p:cNvPr id="9" name="Picture 8">
+            <a:extLst>
+              <a:ext uri="{FF2B5EF4-FFF2-40B4-BE49-F238E27FC236}">
+                <a16:creationId xmlns:a16="http://schemas.microsoft.com/office/drawing/2014/main" id="{7A2BFB8D-3C80-BD69-86E4-533DD007EACD}"/>
+              </a:ext>
+            </a:extLst>
+          </p:cNvPr>
+          <p:cNvPicPr>
+            <a:picLocks noChangeAspect="1"/>
+          </p:cNvPicPr>
+          <p:nvPr/>
+        </p:nvPicPr>
+        <p:blipFill>
+          <a:blip r:embed="rId6">
+            <a:extLst>
+              <a:ext uri="{28A0092B-C50C-407E-A947-70E740481C1C}">
+                <a14:useLocalDpi xmlns:a14="http://schemas.microsoft.com/office/drawing/2010/main" val="0"/>
+              </a:ext>
+            </a:extLst>
+          </a:blip>
+          <a:stretch>
+            <a:fillRect/>
+          </a:stretch>
+        </p:blipFill>
+        <p:spPr>
+          <a:xfrm>
+            <a:off x="501445" y="3216721"/>
+            <a:ext cx="6961239" cy="2261611"/>
+          </a:xfrm>
+          <a:prstGeom prst="rect">
+            <a:avLst/>
+          </a:prstGeom>
+        </p:spPr>
+      </p:pic>
+    </p:spTree>
+    <p:extLst>
+      <p:ext uri="{BB962C8B-B14F-4D97-AF65-F5344CB8AC3E}">
+        <p14:creationId xmlns:p14="http://schemas.microsoft.com/office/powerpoint/2010/main" val="172672328"/>
+      </p:ext>
+    </p:extLst>
+  </p:cSld>
+  <p:clrMapOvr>
+    <a:masterClrMapping/>
+  </p:clrMapOvr>
+</p:sld>
+</file>
+
+<file path=ppt/slides/slide31.xml><?xml version="1.0" encoding="utf-8"?>
+<p:sld xmlns:a="http://schemas.openxmlformats.org/drawingml/2006/main" xmlns:r="http://schemas.openxmlformats.org/officeDocument/2006/relationships" xmlns:p="http://schemas.openxmlformats.org/presentationml/2006/main">
+  <p:cSld>
+    <p:spTree>
+      <p:nvGrpSpPr>
+        <p:cNvPr id="1" name=""/>
+        <p:cNvGrpSpPr/>
+        <p:nvPr/>
+      </p:nvGrpSpPr>
+      <p:grpSpPr>
+        <a:xfrm>
+          <a:off x="0" y="0"/>
+          <a:ext cx="0" cy="0"/>
+          <a:chOff x="0" y="0"/>
+          <a:chExt cx="0" cy="0"/>
+        </a:xfrm>
+      </p:grpSpPr>
       <p:sp>
         <p:nvSpPr>
           <p:cNvPr id="2" name="Title 1">
@@ -24691,8 +25040,8 @@
           </a:p>
         </p:txBody>
       </p:sp>
-      <mc:AlternateContent xmlns:mc="http://schemas.openxmlformats.org/markup-compatibility/2006">
-        <mc:Choice xmlns:a14="http://schemas.microsoft.com/office/drawing/2010/main" Requires="a14">
+      <mc:AlternateContent xmlns:mc="http://schemas.openxmlformats.org/markup-compatibility/2006" xmlns:a14="http://schemas.microsoft.com/office/drawing/2010/main">
+        <mc:Choice Requires="a14">
           <p:sp>
             <p:nvSpPr>
               <p:cNvPr id="3" name="Content Placeholder 2">
@@ -25025,19 +25374,7 @@
                       <a:rPr lang="fr-FR" b="0" i="1" smtClean="0">
                         <a:latin typeface="Cambria Math" panose="02040503050406030204" pitchFamily="18" charset="0"/>
                       </a:rPr>
-                      <m:t>= 44.9</m:t>
-                    </m:r>
-                    <m:r>
-                      <a:rPr lang="fr-FR" b="0" i="1" smtClean="0">
-                        <a:latin typeface="Cambria Math" panose="02040503050406030204" pitchFamily="18" charset="0"/>
-                      </a:rPr>
-                      <m:t>3</m:t>
-                    </m:r>
-                    <m:r>
-                      <a:rPr lang="fr-FR" b="0" i="1" smtClean="0">
-                        <a:latin typeface="Cambria Math" panose="02040503050406030204" pitchFamily="18" charset="0"/>
-                      </a:rPr>
-                      <m:t> </m:t>
+                      <m:t>= 44.93 </m:t>
                     </m:r>
                     <m:r>
                       <m:rPr>
@@ -25251,7 +25588,7 @@
             </p:txBody>
           </p:sp>
         </mc:Choice>
-        <mc:Fallback>
+        <mc:Fallback xmlns="">
           <p:sp>
             <p:nvSpPr>
               <p:cNvPr id="3" name="Content Placeholder 2">
@@ -25495,7 +25832,7 @@
           <a:p>
             <a:fld id="{FD85B578-4E75-4E1C-9BE3-D5DCC0715B13}" type="slidenum">
               <a:rPr lang="fr-FR" smtClean="0"/>
-              <a:t>30</a:t>
+              <a:t>31</a:t>
             </a:fld>
             <a:endParaRPr lang="fr-FR"/>
           </a:p>
@@ -25514,7 +25851,7 @@
 </p:sld>
 </file>
 
-<file path=ppt/slides/slide31.xml><?xml version="1.0" encoding="utf-8"?>
+<file path=ppt/slides/slide32.xml><?xml version="1.0" encoding="utf-8"?>
 <p:sld xmlns:a="http://schemas.openxmlformats.org/drawingml/2006/main" xmlns:r="http://schemas.openxmlformats.org/officeDocument/2006/relationships" xmlns:p="http://schemas.openxmlformats.org/presentationml/2006/main">
   <p:cSld>
     <p:spTree>
@@ -25621,7 +25958,7 @@
           <a:p>
             <a:fld id="{FD85B578-4E75-4E1C-9BE3-D5DCC0715B13}" type="slidenum">
               <a:rPr lang="fr-FR" smtClean="0"/>
-              <a:t>31</a:t>
+              <a:t>32</a:t>
             </a:fld>
             <a:endParaRPr lang="fr-FR"/>
           </a:p>
@@ -25743,7 +26080,7 @@
 </p:sld>
 </file>
 
-<file path=ppt/slides/slide32.xml><?xml version="1.0" encoding="utf-8"?>
+<file path=ppt/slides/slide33.xml><?xml version="1.0" encoding="utf-8"?>
 <p:sld xmlns:a="http://schemas.openxmlformats.org/drawingml/2006/main" xmlns:r="http://schemas.openxmlformats.org/officeDocument/2006/relationships" xmlns:p="http://schemas.openxmlformats.org/presentationml/2006/main">
   <p:cSld>
     <p:spTree>
@@ -25789,8 +26126,8 @@
           </a:p>
         </p:txBody>
       </p:sp>
-      <mc:AlternateContent xmlns:mc="http://schemas.openxmlformats.org/markup-compatibility/2006">
-        <mc:Choice xmlns:a14="http://schemas.microsoft.com/office/drawing/2010/main" Requires="a14">
+      <mc:AlternateContent xmlns:mc="http://schemas.openxmlformats.org/markup-compatibility/2006" xmlns:a14="http://schemas.microsoft.com/office/drawing/2010/main">
+        <mc:Choice Requires="a14">
           <p:sp>
             <p:nvSpPr>
               <p:cNvPr id="3" name="Content Placeholder 2">
@@ -25891,7 +26228,7 @@
             </p:txBody>
           </p:sp>
         </mc:Choice>
-        <mc:Fallback>
+        <mc:Fallback xmlns="">
           <p:sp>
             <p:nvSpPr>
               <p:cNvPr id="3" name="Content Placeholder 2">
@@ -25954,7 +26291,7 @@
           <a:p>
             <a:fld id="{FD85B578-4E75-4E1C-9BE3-D5DCC0715B13}" type="slidenum">
               <a:rPr lang="fr-FR" smtClean="0"/>
-              <a:t>32</a:t>
+              <a:t>33</a:t>
             </a:fld>
             <a:endParaRPr lang="fr-FR"/>
           </a:p>

</xml_diff>

<commit_message>
pwp: bonification de la description de l'algorithme de resolution
</commit_message>
<xml_diff>
--- a/projet_final/projet_final/MEC8211-Projet-final-Presentation.pptx
+++ b/projet_final/projet_final/MEC8211-Projet-final-Presentation.pptx
@@ -13075,6 +13075,26 @@
               <a:t>.</a:t>
             </a:r>
           </a:p>
+          <a:p>
+            <a:r>
+              <a:rPr lang="fr-CA" sz="1700" dirty="0"/>
+              <a:t>tests.py : </a:t>
+            </a:r>
+          </a:p>
+          <a:p>
+            <a:pPr lvl="1"/>
+            <a:r>
+              <a:rPr lang="fr-CA" sz="1300" dirty="0"/>
+              <a:t>Contient un ensemble de tests unitaires (décrits plus loin dans ce rapport)</a:t>
+            </a:r>
+          </a:p>
+          <a:p>
+            <a:pPr lvl="1"/>
+            <a:r>
+              <a:rPr lang="fr-CA" sz="1300" dirty="0"/>
+              <a:t>Permet de s’assurer que le code ne brise pas avec les changements (pérennité).</a:t>
+            </a:r>
+          </a:p>
         </p:txBody>
       </p:sp>
       <p:pic>
@@ -13240,8 +13260,8 @@
           </a:p>
         </p:txBody>
       </p:sp>
-      <mc:AlternateContent xmlns:mc="http://schemas.openxmlformats.org/markup-compatibility/2006" xmlns:a14="http://schemas.microsoft.com/office/drawing/2010/main">
-        <mc:Choice Requires="a14">
+      <mc:AlternateContent xmlns:mc="http://schemas.openxmlformats.org/markup-compatibility/2006">
+        <mc:Choice xmlns:a14="http://schemas.microsoft.com/office/drawing/2010/main" Requires="a14">
           <p:sp>
             <p:nvSpPr>
               <p:cNvPr id="3" name="Espace réservé du contenu 2">
@@ -13284,7 +13304,7 @@
                 </a:pPr>
                 <a:r>
                   <a:rPr lang="fr-FR" dirty="0"/>
-                  <a:t>Condition initiale dans le domaine.</a:t>
+                  <a:t>Initialisation de la solution dans le domaine. Pour MMS, on initialise la solution avec l’équation de la MMS.</a:t>
                 </a:r>
               </a:p>
               <a:p>
@@ -13368,16 +13388,67 @@
                 </a:pPr>
                 <a:r>
                   <a:rPr lang="fr-FR" dirty="0"/>
-                  <a:t>Calcul des nœuds suivants aux frontières du domaine à l’aide de la solution courante.</a:t>
+                  <a:t>Calcul des nœuds au milieu du domaine au temps </a:t>
+                </a:r>
+                <a14:m>
+                  <m:oMath xmlns:m="http://schemas.openxmlformats.org/officeDocument/2006/math">
+                    <m:r>
+                      <a:rPr lang="fr-CA" b="0" i="1" smtClean="0">
+                        <a:latin typeface="Cambria Math" panose="02040503050406030204" pitchFamily="18" charset="0"/>
+                      </a:rPr>
+                      <m:t>𝑡</m:t>
+                    </m:r>
+                    <m:r>
+                      <a:rPr lang="fr-CA" b="0" i="1" smtClean="0">
+                        <a:latin typeface="Cambria Math" panose="02040503050406030204" pitchFamily="18" charset="0"/>
+                      </a:rPr>
+                      <m:t>+∆</m:t>
+                    </m:r>
+                    <m:r>
+                      <a:rPr lang="fr-CA" b="0" i="1" smtClean="0">
+                        <a:latin typeface="Cambria Math" panose="02040503050406030204" pitchFamily="18" charset="0"/>
+                      </a:rPr>
+                      <m:t>𝑡</m:t>
+                    </m:r>
+                  </m:oMath>
+                </a14:m>
+                <a:r>
+                  <a:rPr lang="fr-FR" dirty="0"/>
+                  <a:t> à l’aide de la solution au temps </a:t>
+                </a:r>
+                <a14:m>
+                  <m:oMath xmlns:m="http://schemas.openxmlformats.org/officeDocument/2006/math">
+                    <m:r>
+                      <a:rPr lang="fr-CA" b="0" i="1" smtClean="0">
+                        <a:latin typeface="Cambria Math" panose="02040503050406030204" pitchFamily="18" charset="0"/>
+                      </a:rPr>
+                      <m:t>𝑡</m:t>
+                    </m:r>
+                  </m:oMath>
+                </a14:m>
+                <a:r>
+                  <a:rPr lang="fr-FR" dirty="0"/>
+                  <a:t>.</a:t>
                 </a:r>
               </a:p>
               <a:p>
                 <a:pPr marL="971550" lvl="1" indent="-514350">
+                  <a:buFont typeface="Arial" panose="020B0604020202020204" pitchFamily="34" charset="0"/>
                   <a:buAutoNum type="arabicPeriod"/>
                 </a:pPr>
                 <a:r>
                   <a:rPr lang="fr-FR" dirty="0"/>
-                  <a:t>Calcul des nœuds suivants au milieu du domaine à l’aide de la solution courante.</a:t>
+                  <a:t>Calcul des nœuds suivants aux frontières du domaine à l’aide de la solution des nœuds milieux calculés en 1.</a:t>
+                </a:r>
+              </a:p>
+              <a:p>
+                <a:pPr marL="971550" lvl="1" indent="-514350">
+                  <a:buFont typeface="Arial" panose="020B0604020202020204" pitchFamily="34" charset="0"/>
+                  <a:buAutoNum type="arabicPeriod"/>
+                </a:pPr>
+                <a:r>
+                  <a:rPr lang="fr-FR" dirty="0"/>
+                  <a:t>Calcul des coins à l’aides des nœuds aux frontières calculés en 2.</a:t>
                 </a:r>
               </a:p>
               <a:p>
@@ -13544,7 +13615,7 @@
             </p:txBody>
           </p:sp>
         </mc:Choice>
-        <mc:Fallback xmlns="">
+        <mc:Fallback>
           <p:sp>
             <p:nvSpPr>
               <p:cNvPr id="3" name="Espace réservé du contenu 2">
@@ -13569,7 +13640,7 @@
               <a:blipFill>
                 <a:blip r:embed="rId2"/>
                 <a:stretch>
-                  <a:fillRect l="-1073" t="-1874"/>
+                  <a:fillRect l="-1073" t="-1874" r="-358"/>
                 </a:stretch>
               </a:blipFill>
             </p:spPr>

</xml_diff>

<commit_message>
pwp: correction des équations de discrétisation frontières
</commit_message>
<xml_diff>
--- a/projet_final/projet_final/MEC8211-Projet-final-Presentation.pptx
+++ b/projet_final/projet_final/MEC8211-Projet-final-Presentation.pptx
@@ -229,7 +229,7 @@
           <a:p>
             <a:fld id="{BB0B2023-C595-443A-8D8C-AB9DF5A28D48}" type="datetimeFigureOut">
               <a:rPr lang="fr-FR" smtClean="0"/>
-              <a:t>18/04/2026</a:t>
+              <a:t>19/04/2026</a:t>
             </a:fld>
             <a:endParaRPr lang="fr-FR"/>
           </a:p>
@@ -1003,7 +1003,7 @@
           <a:p>
             <a:fld id="{E29E3EF2-BB98-40F8-97FA-C4A3F82A773E}" type="datetime1">
               <a:rPr lang="fr-FR" smtClean="0"/>
-              <a:t>18/04/2026</a:t>
+              <a:t>19/04/2026</a:t>
             </a:fld>
             <a:endParaRPr lang="fr-FR"/>
           </a:p>
@@ -1201,7 +1201,7 @@
           <a:p>
             <a:fld id="{7A3D4F6E-E469-42CC-A5EB-D2CD9317FE9F}" type="datetime1">
               <a:rPr lang="fr-FR" smtClean="0"/>
-              <a:t>18/04/2026</a:t>
+              <a:t>19/04/2026</a:t>
             </a:fld>
             <a:endParaRPr lang="fr-FR"/>
           </a:p>
@@ -1409,7 +1409,7 @@
           <a:p>
             <a:fld id="{22E65B0F-6D1C-4B44-AEC8-DA6E37704C0A}" type="datetime1">
               <a:rPr lang="fr-FR" smtClean="0"/>
-              <a:t>18/04/2026</a:t>
+              <a:t>19/04/2026</a:t>
             </a:fld>
             <a:endParaRPr lang="fr-FR"/>
           </a:p>
@@ -1607,7 +1607,7 @@
           <a:p>
             <a:fld id="{A212A586-A44F-4832-86AD-F3953D03CDFD}" type="datetime1">
               <a:rPr lang="fr-FR" smtClean="0"/>
-              <a:t>18/04/2026</a:t>
+              <a:t>19/04/2026</a:t>
             </a:fld>
             <a:endParaRPr lang="fr-FR"/>
           </a:p>
@@ -1882,7 +1882,7 @@
           <a:p>
             <a:fld id="{5F8470F2-053A-49C8-975F-D66A9D98776B}" type="datetime1">
               <a:rPr lang="fr-FR" smtClean="0"/>
-              <a:t>18/04/2026</a:t>
+              <a:t>19/04/2026</a:t>
             </a:fld>
             <a:endParaRPr lang="fr-FR"/>
           </a:p>
@@ -2147,7 +2147,7 @@
           <a:p>
             <a:fld id="{E16153F4-9539-487A-AAD9-7CDB222E0065}" type="datetime1">
               <a:rPr lang="fr-FR" smtClean="0"/>
-              <a:t>18/04/2026</a:t>
+              <a:t>19/04/2026</a:t>
             </a:fld>
             <a:endParaRPr lang="fr-FR"/>
           </a:p>
@@ -2559,7 +2559,7 @@
           <a:p>
             <a:fld id="{336F1CD1-F040-4758-8097-CF709F1D3BD2}" type="datetime1">
               <a:rPr lang="fr-FR" smtClean="0"/>
-              <a:t>18/04/2026</a:t>
+              <a:t>19/04/2026</a:t>
             </a:fld>
             <a:endParaRPr lang="fr-FR"/>
           </a:p>
@@ -2700,7 +2700,7 @@
           <a:p>
             <a:fld id="{3757EA93-3E66-43EA-9968-19C091DEE6B2}" type="datetime1">
               <a:rPr lang="fr-FR" smtClean="0"/>
-              <a:t>18/04/2026</a:t>
+              <a:t>19/04/2026</a:t>
             </a:fld>
             <a:endParaRPr lang="fr-FR"/>
           </a:p>
@@ -2813,7 +2813,7 @@
           <a:p>
             <a:fld id="{780D0892-96A3-401F-9540-0D0F4005E0BA}" type="datetime1">
               <a:rPr lang="fr-FR" smtClean="0"/>
-              <a:t>18/04/2026</a:t>
+              <a:t>19/04/2026</a:t>
             </a:fld>
             <a:endParaRPr lang="fr-FR"/>
           </a:p>
@@ -3124,7 +3124,7 @@
           <a:p>
             <a:fld id="{D2E4351D-395D-4EA4-B21E-7BFE1F4E205E}" type="datetime1">
               <a:rPr lang="fr-FR" smtClean="0"/>
-              <a:t>18/04/2026</a:t>
+              <a:t>19/04/2026</a:t>
             </a:fld>
             <a:endParaRPr lang="fr-FR"/>
           </a:p>
@@ -3412,7 +3412,7 @@
           <a:p>
             <a:fld id="{EADED27B-925F-4DEA-AB38-A034A10A1BE9}" type="datetime1">
               <a:rPr lang="fr-FR" smtClean="0"/>
-              <a:t>18/04/2026</a:t>
+              <a:t>19/04/2026</a:t>
             </a:fld>
             <a:endParaRPr lang="fr-FR"/>
           </a:p>
@@ -3656,7 +3656,7 @@
           <a:p>
             <a:fld id="{FA6CD994-6CF5-4070-B12A-5121E0D5A99F}" type="datetime1">
               <a:rPr lang="fr-FR" smtClean="0"/>
-              <a:t>18/04/2026</a:t>
+              <a:t>19/04/2026</a:t>
             </a:fld>
             <a:endParaRPr lang="fr-FR"/>
           </a:p>
@@ -4695,7 +4695,13 @@
                           <a:rPr lang="fr-FR" i="1">
                             <a:latin typeface="Cambria Math" panose="02040503050406030204" pitchFamily="18" charset="0"/>
                           </a:rPr>
-                          <m:t>2!</m:t>
+                          <m:t>2</m:t>
+                        </m:r>
+                        <m:r>
+                          <a:rPr lang="fr-FR" i="1">
+                            <a:latin typeface="Cambria Math" panose="02040503050406030204" pitchFamily="18" charset="0"/>
+                          </a:rPr>
+                          <m:t>!</m:t>
                         </m:r>
                       </m:den>
                     </m:f>
@@ -4867,7 +4873,13 @@
                           <a:rPr lang="fr-FR" i="1">
                             <a:latin typeface="Cambria Math" panose="02040503050406030204" pitchFamily="18" charset="0"/>
                           </a:rPr>
-                          <m:t>3!</m:t>
+                          <m:t>3</m:t>
+                        </m:r>
+                        <m:r>
+                          <a:rPr lang="fr-FR" i="1">
+                            <a:latin typeface="Cambria Math" panose="02040503050406030204" pitchFamily="18" charset="0"/>
+                          </a:rPr>
+                          <m:t>!</m:t>
                         </m:r>
                       </m:den>
                     </m:f>
@@ -5039,7 +5051,13 @@
                           <a:rPr lang="fr-FR" i="1">
                             <a:latin typeface="Cambria Math" panose="02040503050406030204" pitchFamily="18" charset="0"/>
                           </a:rPr>
-                          <m:t>4!</m:t>
+                          <m:t>4</m:t>
+                        </m:r>
+                        <m:r>
+                          <a:rPr lang="fr-FR" i="1">
+                            <a:latin typeface="Cambria Math" panose="02040503050406030204" pitchFamily="18" charset="0"/>
+                          </a:rPr>
+                          <m:t>!</m:t>
                         </m:r>
                       </m:den>
                     </m:f>
@@ -5457,7 +5475,13 @@
                           <a:rPr lang="fr-FR" i="1">
                             <a:latin typeface="Cambria Math" panose="02040503050406030204" pitchFamily="18" charset="0"/>
                           </a:rPr>
-                          <m:t>2!</m:t>
+                          <m:t>2</m:t>
+                        </m:r>
+                        <m:r>
+                          <a:rPr lang="fr-FR" i="1">
+                            <a:latin typeface="Cambria Math" panose="02040503050406030204" pitchFamily="18" charset="0"/>
+                          </a:rPr>
+                          <m:t>!</m:t>
                         </m:r>
                       </m:den>
                     </m:f>
@@ -5629,7 +5653,13 @@
                           <a:rPr lang="fr-FR" i="1">
                             <a:latin typeface="Cambria Math" panose="02040503050406030204" pitchFamily="18" charset="0"/>
                           </a:rPr>
-                          <m:t>3!</m:t>
+                          <m:t>3</m:t>
+                        </m:r>
+                        <m:r>
+                          <a:rPr lang="fr-FR" i="1">
+                            <a:latin typeface="Cambria Math" panose="02040503050406030204" pitchFamily="18" charset="0"/>
+                          </a:rPr>
+                          <m:t>!</m:t>
                         </m:r>
                       </m:den>
                     </m:f>
@@ -5801,7 +5831,13 @@
                           <a:rPr lang="fr-FR" i="1">
                             <a:latin typeface="Cambria Math" panose="02040503050406030204" pitchFamily="18" charset="0"/>
                           </a:rPr>
-                          <m:t>4!</m:t>
+                          <m:t>4</m:t>
+                        </m:r>
+                        <m:r>
+                          <a:rPr lang="fr-FR" i="1">
+                            <a:latin typeface="Cambria Math" panose="02040503050406030204" pitchFamily="18" charset="0"/>
+                          </a:rPr>
+                          <m:t>!</m:t>
                         </m:r>
                       </m:den>
                     </m:f>
@@ -6392,7 +6428,13 @@
                           <a:rPr lang="fr-FR" i="1">
                             <a:latin typeface="Cambria Math" panose="02040503050406030204" pitchFamily="18" charset="0"/>
                           </a:rPr>
-                          <m:t>2!</m:t>
+                          <m:t>2</m:t>
+                        </m:r>
+                        <m:r>
+                          <a:rPr lang="fr-FR" i="1">
+                            <a:latin typeface="Cambria Math" panose="02040503050406030204" pitchFamily="18" charset="0"/>
+                          </a:rPr>
+                          <m:t>!</m:t>
                         </m:r>
                       </m:den>
                     </m:f>
@@ -6853,7 +6895,13 @@
                           <a:rPr lang="fr-FR" i="1">
                             <a:latin typeface="Cambria Math" panose="02040503050406030204" pitchFamily="18" charset="0"/>
                           </a:rPr>
-                          <m:t>2!</m:t>
+                          <m:t>2</m:t>
+                        </m:r>
+                        <m:r>
+                          <a:rPr lang="fr-FR" i="1">
+                            <a:latin typeface="Cambria Math" panose="02040503050406030204" pitchFamily="18" charset="0"/>
+                          </a:rPr>
+                          <m:t>!</m:t>
                         </m:r>
                       </m:den>
                     </m:f>
@@ -12348,8 +12396,8 @@
           </a:p>
         </p:txBody>
       </p:sp>
-      <mc:AlternateContent xmlns:mc="http://schemas.openxmlformats.org/markup-compatibility/2006" xmlns:a14="http://schemas.microsoft.com/office/drawing/2010/main">
-        <mc:Choice Requires="a14">
+      <mc:AlternateContent xmlns:mc="http://schemas.openxmlformats.org/markup-compatibility/2006">
+        <mc:Choice xmlns:a14="http://schemas.microsoft.com/office/drawing/2010/main" Requires="a14">
           <p:sp>
             <p:nvSpPr>
               <p:cNvPr id="3" name="Espace réservé du contenu 2">
@@ -12379,7 +12427,7 @@
               <a:lstStyle/>
               <a:p>
                 <a:r>
-                  <a:rPr lang="fr-FR" sz="1300" dirty="0"/>
+                  <a:rPr lang="fr-FR" sz="1600" dirty="0"/>
                   <a:t>main.py :</a:t>
                 </a:r>
               </a:p>
@@ -12399,8 +12447,15 @@
               </a:p>
               <a:p>
                 <a:r>
+                  <a:rPr lang="fr-FR" sz="1600" dirty="0"/>
+                  <a:t>fonctions.py :</a:t>
+                </a:r>
+              </a:p>
+              <a:p>
+                <a:pPr lvl="1"/>
+                <a:r>
                   <a:rPr lang="fr-FR" sz="1300" dirty="0"/>
-                  <a:t>fonctions.py : le cœur du code</a:t>
+                  <a:t>Cœur du code</a:t>
                 </a:r>
               </a:p>
               <a:p>
@@ -12735,7 +12790,7 @@
             </p:txBody>
           </p:sp>
         </mc:Choice>
-        <mc:Fallback xmlns="">
+        <mc:Fallback>
           <p:sp>
             <p:nvSpPr>
               <p:cNvPr id="3" name="Espace réservé du contenu 2">
@@ -12760,7 +12815,7 @@
               <a:blipFill>
                 <a:blip r:embed="rId2"/>
                 <a:stretch>
-                  <a:fillRect l="-94"/>
+                  <a:fillRect l="-375"/>
                 </a:stretch>
               </a:blipFill>
             </p:spPr>
@@ -12971,7 +13026,7 @@
           <a:lstStyle/>
           <a:p>
             <a:r>
-              <a:rPr lang="fr-FR" sz="1300" dirty="0"/>
+              <a:rPr lang="fr-FR" sz="1600" dirty="0"/>
               <a:t>convergence_generate_data.py : </a:t>
             </a:r>
           </a:p>
@@ -13026,7 +13081,7 @@
           </a:p>
           <a:p>
             <a:r>
-              <a:rPr lang="fr-FR" sz="1300" dirty="0"/>
+              <a:rPr lang="fr-FR" sz="1600" dirty="0"/>
               <a:t>ordre_convergence_MMS.py : </a:t>
             </a:r>
           </a:p>
@@ -13077,7 +13132,7 @@
           </a:p>
           <a:p>
             <a:r>
-              <a:rPr lang="fr-CA" sz="1700" dirty="0"/>
+              <a:rPr lang="fr-CA" sz="1600" dirty="0"/>
               <a:t>tests.py : </a:t>
             </a:r>
           </a:p>
@@ -13260,8 +13315,8 @@
           </a:p>
         </p:txBody>
       </p:sp>
-      <mc:AlternateContent xmlns:mc="http://schemas.openxmlformats.org/markup-compatibility/2006">
-        <mc:Choice xmlns:a14="http://schemas.microsoft.com/office/drawing/2010/main" Requires="a14">
+      <mc:AlternateContent xmlns:mc="http://schemas.openxmlformats.org/markup-compatibility/2006" xmlns:a14="http://schemas.microsoft.com/office/drawing/2010/main">
+        <mc:Choice Requires="a14">
           <p:sp>
             <p:nvSpPr>
               <p:cNvPr id="3" name="Espace réservé du contenu 2">
@@ -13615,7 +13670,7 @@
             </p:txBody>
           </p:sp>
         </mc:Choice>
-        <mc:Fallback>
+        <mc:Fallback xmlns="">
           <p:sp>
             <p:nvSpPr>
               <p:cNvPr id="3" name="Espace réservé du contenu 2">
@@ -21251,7 +21306,13 @@
                           <a:rPr lang="fr-FR" i="1">
                             <a:latin typeface="Cambria Math" panose="02040503050406030204" pitchFamily="18" charset="0"/>
                           </a:rPr>
-                          <m:t>−1</m:t>
+                          <m:t>−</m:t>
+                        </m:r>
+                        <m:r>
+                          <a:rPr lang="fr-FR" i="1">
+                            <a:latin typeface="Cambria Math" panose="02040503050406030204" pitchFamily="18" charset="0"/>
+                          </a:rPr>
+                          <m:t>1</m:t>
                         </m:r>
                       </m:den>
                     </m:f>
@@ -21441,7 +21502,19 @@
                       <a:rPr lang="fr-FR" i="1">
                         <a:latin typeface="Cambria Math" panose="02040503050406030204" pitchFamily="18" charset="0"/>
                       </a:rPr>
-                      <m:t>0.1</m:t>
+                      <m:t>0</m:t>
+                    </m:r>
+                    <m:r>
+                      <a:rPr lang="fr-FR" i="1">
+                        <a:latin typeface="Cambria Math" panose="02040503050406030204" pitchFamily="18" charset="0"/>
+                      </a:rPr>
+                      <m:t>.</m:t>
+                    </m:r>
+                    <m:r>
+                      <a:rPr lang="fr-FR" i="1">
+                        <a:latin typeface="Cambria Math" panose="02040503050406030204" pitchFamily="18" charset="0"/>
+                      </a:rPr>
+                      <m:t>1</m:t>
                     </m:r>
                   </m:oMath>
                 </a14:m>
@@ -21486,7 +21559,25 @@
                       <a:rPr lang="fr-FR" i="1">
                         <a:latin typeface="Cambria Math" panose="02040503050406030204" pitchFamily="18" charset="0"/>
                       </a:rPr>
-                      <m:t>=1.25</m:t>
+                      <m:t>=</m:t>
+                    </m:r>
+                    <m:r>
+                      <a:rPr lang="fr-FR" i="1">
+                        <a:latin typeface="Cambria Math" panose="02040503050406030204" pitchFamily="18" charset="0"/>
+                      </a:rPr>
+                      <m:t>1</m:t>
+                    </m:r>
+                    <m:r>
+                      <a:rPr lang="fr-FR" i="1">
+                        <a:latin typeface="Cambria Math" panose="02040503050406030204" pitchFamily="18" charset="0"/>
+                      </a:rPr>
+                      <m:t>.</m:t>
+                    </m:r>
+                    <m:r>
+                      <a:rPr lang="fr-FR" i="1">
+                        <a:latin typeface="Cambria Math" panose="02040503050406030204" pitchFamily="18" charset="0"/>
+                      </a:rPr>
+                      <m:t>25</m:t>
                     </m:r>
                   </m:oMath>
                 </a14:m>
@@ -21631,7 +21722,14 @@
                             <a:latin typeface="Cambria Math" panose="02040503050406030204" pitchFamily="18" charset="0"/>
                             <a:sym typeface="Wingdings" panose="05000000000000000000" pitchFamily="2" charset="2"/>
                           </a:rPr>
-                          <m:t>×10</m:t>
+                          <m:t>×</m:t>
+                        </m:r>
+                        <m:r>
+                          <a:rPr lang="fr-FR" b="0" i="1" smtClean="0">
+                            <a:latin typeface="Cambria Math" panose="02040503050406030204" pitchFamily="18" charset="0"/>
+                            <a:sym typeface="Wingdings" panose="05000000000000000000" pitchFamily="2" charset="2"/>
+                          </a:rPr>
+                          <m:t>10</m:t>
                         </m:r>
                       </m:e>
                       <m:sup>
@@ -21640,7 +21738,14 @@
                             <a:latin typeface="Cambria Math" panose="02040503050406030204" pitchFamily="18" charset="0"/>
                             <a:sym typeface="Wingdings" panose="05000000000000000000" pitchFamily="2" charset="2"/>
                           </a:rPr>
-                          <m:t>−3</m:t>
+                          <m:t>−</m:t>
+                        </m:r>
+                        <m:r>
+                          <a:rPr lang="fr-FR" b="0" i="1" smtClean="0">
+                            <a:latin typeface="Cambria Math" panose="02040503050406030204" pitchFamily="18" charset="0"/>
+                            <a:sym typeface="Wingdings" panose="05000000000000000000" pitchFamily="2" charset="2"/>
+                          </a:rPr>
+                          <m:t>3</m:t>
                         </m:r>
                       </m:sup>
                     </m:sSup>
@@ -21905,7 +22010,13 @@
                                     <a:rPr lang="fr-FR" b="0" i="1" smtClean="0">
                                       <a:latin typeface="Cambria Math" panose="02040503050406030204" pitchFamily="18" charset="0"/>
                                     </a:rPr>
-                                    <m:t>−4</m:t>
+                                    <m:t>−</m:t>
+                                  </m:r>
+                                  <m:r>
+                                    <a:rPr lang="fr-FR" b="0" i="1" smtClean="0">
+                                      <a:latin typeface="Cambria Math" panose="02040503050406030204" pitchFamily="18" charset="0"/>
+                                    </a:rPr>
+                                    <m:t>4</m:t>
                                   </m:r>
                                 </m:sup>
                               </m:sSup>
@@ -21982,7 +22093,13 @@
                                     <a:rPr lang="fr-FR" b="0" i="1" smtClean="0">
                                       <a:latin typeface="Cambria Math" panose="02040503050406030204" pitchFamily="18" charset="0"/>
                                     </a:rPr>
-                                    <m:t>−4</m:t>
+                                    <m:t>−</m:t>
+                                  </m:r>
+                                  <m:r>
+                                    <a:rPr lang="fr-FR" b="0" i="1" smtClean="0">
+                                      <a:latin typeface="Cambria Math" panose="02040503050406030204" pitchFamily="18" charset="0"/>
+                                    </a:rPr>
+                                    <m:t>4</m:t>
                                   </m:r>
                                 </m:sup>
                               </m:sSup>
@@ -22059,7 +22176,13 @@
                                     <a:rPr lang="fr-FR" b="0" i="1" smtClean="0">
                                       <a:latin typeface="Cambria Math" panose="02040503050406030204" pitchFamily="18" charset="0"/>
                                     </a:rPr>
-                                    <m:t>−3</m:t>
+                                    <m:t>−</m:t>
+                                  </m:r>
+                                  <m:r>
+                                    <a:rPr lang="fr-FR" b="0" i="1" smtClean="0">
+                                      <a:latin typeface="Cambria Math" panose="02040503050406030204" pitchFamily="18" charset="0"/>
+                                    </a:rPr>
+                                    <m:t>3</m:t>
                                   </m:r>
                                 </m:sup>
                               </m:sSup>
@@ -22671,16 +22794,7 @@
                             <a:rPr lang="fr-FR" b="0" i="1" smtClean="0">
                               <a:latin typeface="Cambria Math" panose="02040503050406030204" pitchFamily="18" charset="0"/>
                             </a:rPr>
-                            <m:t>²</m:t>
-                          </m:r>
-                          <m:r>
-                            <a:rPr lang="fr-FR" b="0" i="1" smtClean="0">
-                              <a:highlight>
-                                <a:srgbClr val="5B9BD5"/>
-                              </a:highlight>
-                              <a:latin typeface="Cambria Math" panose="02040503050406030204" pitchFamily="18" charset="0"/>
-                            </a:rPr>
-                            <m:t> </m:t>
+                            <m:t>² </m:t>
                           </m:r>
                         </m:e>
                       </m:rad>
@@ -24355,7 +24469,31 @@
                       <a:rPr lang="fr-FR" sz="1600" b="0" i="1" smtClean="0">
                         <a:latin typeface="Cambria Math" panose="02040503050406030204" pitchFamily="18" charset="0"/>
                       </a:rPr>
-                      <m:t>=13.1 </m:t>
+                      <m:t>=</m:t>
+                    </m:r>
+                    <m:r>
+                      <a:rPr lang="fr-FR" sz="1600" b="0" i="1" smtClean="0">
+                        <a:latin typeface="Cambria Math" panose="02040503050406030204" pitchFamily="18" charset="0"/>
+                      </a:rPr>
+                      <m:t>13</m:t>
+                    </m:r>
+                    <m:r>
+                      <a:rPr lang="fr-FR" sz="1600" b="0" i="1" smtClean="0">
+                        <a:latin typeface="Cambria Math" panose="02040503050406030204" pitchFamily="18" charset="0"/>
+                      </a:rPr>
+                      <m:t>.</m:t>
+                    </m:r>
+                    <m:r>
+                      <a:rPr lang="fr-FR" sz="1600" b="0" i="1" smtClean="0">
+                        <a:latin typeface="Cambria Math" panose="02040503050406030204" pitchFamily="18" charset="0"/>
+                      </a:rPr>
+                      <m:t>1</m:t>
+                    </m:r>
+                    <m:r>
+                      <a:rPr lang="fr-FR" sz="1600" b="0" i="1" smtClean="0">
+                        <a:latin typeface="Cambria Math" panose="02040503050406030204" pitchFamily="18" charset="0"/>
+                      </a:rPr>
+                      <m:t> </m:t>
                     </m:r>
                     <m:r>
                       <m:rPr>
@@ -24403,13 +24541,37 @@
                       <a:rPr lang="fr-FR" sz="1600" b="0" i="1" smtClean="0">
                         <a:latin typeface="Cambria Math" panose="02040503050406030204" pitchFamily="18" charset="0"/>
                       </a:rPr>
-                      <m:t>=0.07</m:t>
+                      <m:t>=</m:t>
+                    </m:r>
+                    <m:r>
+                      <a:rPr lang="fr-FR" sz="1600" b="0" i="1" smtClean="0">
+                        <a:latin typeface="Cambria Math" panose="02040503050406030204" pitchFamily="18" charset="0"/>
+                      </a:rPr>
+                      <m:t>0</m:t>
+                    </m:r>
+                    <m:r>
+                      <a:rPr lang="fr-FR" sz="1600" b="0" i="1" smtClean="0">
+                        <a:latin typeface="Cambria Math" panose="02040503050406030204" pitchFamily="18" charset="0"/>
+                      </a:rPr>
+                      <m:t>.</m:t>
+                    </m:r>
+                    <m:r>
+                      <a:rPr lang="fr-FR" sz="1600" b="0" i="1" smtClean="0">
+                        <a:latin typeface="Cambria Math" panose="02040503050406030204" pitchFamily="18" charset="0"/>
+                      </a:rPr>
+                      <m:t>07</m:t>
                     </m:r>
                     <m:r>
                       <a:rPr lang="fr-FR" sz="1600" b="1" i="1" smtClean="0">
                         <a:latin typeface="Cambria Math" panose="02040503050406030204" pitchFamily="18" charset="0"/>
                       </a:rPr>
-                      <m:t>5 </m:t>
+                      <m:t>5</m:t>
+                    </m:r>
+                    <m:r>
+                      <a:rPr lang="fr-FR" sz="1600" b="1" i="1" smtClean="0">
+                        <a:latin typeface="Cambria Math" panose="02040503050406030204" pitchFamily="18" charset="0"/>
+                      </a:rPr>
+                      <m:t> </m:t>
                     </m:r>
                     <m:r>
                       <m:rPr>
@@ -24439,7 +24601,31 @@
                       <a:rPr lang="fr-FR" sz="1600" b="1" i="1" smtClean="0">
                         <a:latin typeface="Cambria Math" panose="02040503050406030204" pitchFamily="18" charset="0"/>
                       </a:rPr>
-                      <m:t> = 2.5⇒</m:t>
+                      <m:t> = </m:t>
+                    </m:r>
+                    <m:r>
+                      <a:rPr lang="fr-FR" sz="1600" b="1" i="1" smtClean="0">
+                        <a:latin typeface="Cambria Math" panose="02040503050406030204" pitchFamily="18" charset="0"/>
+                      </a:rPr>
+                      <m:t>2</m:t>
+                    </m:r>
+                    <m:r>
+                      <a:rPr lang="fr-FR" sz="1600" b="1" i="1" smtClean="0">
+                        <a:latin typeface="Cambria Math" panose="02040503050406030204" pitchFamily="18" charset="0"/>
+                      </a:rPr>
+                      <m:t>.</m:t>
+                    </m:r>
+                    <m:r>
+                      <a:rPr lang="fr-FR" sz="1600" b="1" i="1" smtClean="0">
+                        <a:latin typeface="Cambria Math" panose="02040503050406030204" pitchFamily="18" charset="0"/>
+                      </a:rPr>
+                      <m:t>5</m:t>
+                    </m:r>
+                    <m:r>
+                      <a:rPr lang="fr-FR" sz="1600" b="1" i="1" smtClean="0">
+                        <a:latin typeface="Cambria Math" panose="02040503050406030204" pitchFamily="18" charset="0"/>
+                      </a:rPr>
+                      <m:t>⇒</m:t>
                     </m:r>
                     <m:sSub>
                       <m:sSubPr>
@@ -24470,7 +24656,31 @@
                       <a:rPr lang="fr-FR" sz="1600" b="1" i="1" smtClean="0">
                         <a:latin typeface="Cambria Math" panose="02040503050406030204" pitchFamily="18" charset="0"/>
                       </a:rPr>
-                      <m:t>=13.16 </m:t>
+                      <m:t>=</m:t>
+                    </m:r>
+                    <m:r>
+                      <a:rPr lang="fr-FR" sz="1600" b="1" i="1" smtClean="0">
+                        <a:latin typeface="Cambria Math" panose="02040503050406030204" pitchFamily="18" charset="0"/>
+                      </a:rPr>
+                      <m:t>13</m:t>
+                    </m:r>
+                    <m:r>
+                      <a:rPr lang="fr-FR" sz="1600" b="1" i="1" smtClean="0">
+                        <a:latin typeface="Cambria Math" panose="02040503050406030204" pitchFamily="18" charset="0"/>
+                      </a:rPr>
+                      <m:t>.</m:t>
+                    </m:r>
+                    <m:r>
+                      <a:rPr lang="fr-FR" sz="1600" b="1" i="1" smtClean="0">
+                        <a:latin typeface="Cambria Math" panose="02040503050406030204" pitchFamily="18" charset="0"/>
+                      </a:rPr>
+                      <m:t>16</m:t>
+                    </m:r>
+                    <m:r>
+                      <a:rPr lang="fr-FR" sz="1600" b="1" i="1" smtClean="0">
+                        <a:latin typeface="Cambria Math" panose="02040503050406030204" pitchFamily="18" charset="0"/>
+                      </a:rPr>
+                      <m:t> </m:t>
                     </m:r>
                     <m:r>
                       <a:rPr lang="fr-FR" sz="1600" b="1" i="1" smtClean="0">
@@ -24528,7 +24738,14 @@
                         <m:nor/>
                       </m:rPr>
                       <a:rPr lang="en-US" sz="1600" dirty="0"/>
-                      <m:t> &lt;</m:t>
+                      <m:t> </m:t>
+                    </m:r>
+                    <m:r>
+                      <m:rPr>
+                        <m:nor/>
+                      </m:rPr>
+                      <a:rPr lang="en-US" sz="1600" dirty="0"/>
+                      <m:t>&lt;</m:t>
                     </m:r>
                     <m:sSub>
                       <m:sSubPr>
@@ -24577,7 +24794,19 @@
                       <a:rPr lang="fr-FR" sz="1600" b="0" i="1" smtClean="0">
                         <a:latin typeface="Cambria Math" panose="02040503050406030204" pitchFamily="18" charset="0"/>
                       </a:rPr>
-                      <m:t>38.1</m:t>
+                      <m:t>38</m:t>
+                    </m:r>
+                    <m:r>
+                      <a:rPr lang="fr-FR" sz="1600" b="0" i="1" smtClean="0">
+                        <a:latin typeface="Cambria Math" panose="02040503050406030204" pitchFamily="18" charset="0"/>
+                      </a:rPr>
+                      <m:t>.</m:t>
+                    </m:r>
+                    <m:r>
+                      <a:rPr lang="fr-FR" sz="1600" b="0" i="1" smtClean="0">
+                        <a:latin typeface="Cambria Math" panose="02040503050406030204" pitchFamily="18" charset="0"/>
+                      </a:rPr>
+                      <m:t>1</m:t>
                     </m:r>
                     <m:r>
                       <m:rPr>
@@ -29851,8 +30080,8 @@
           </a:p>
         </p:txBody>
       </p:sp>
-      <mc:AlternateContent xmlns:mc="http://schemas.openxmlformats.org/markup-compatibility/2006" xmlns:a14="http://schemas.microsoft.com/office/drawing/2010/main">
-        <mc:Choice Requires="a14">
+      <mc:AlternateContent xmlns:mc="http://schemas.openxmlformats.org/markup-compatibility/2006">
+        <mc:Choice xmlns:a14="http://schemas.microsoft.com/office/drawing/2010/main" Requires="a14">
           <p:sp>
             <p:nvSpPr>
               <p:cNvPr id="3" name="Espace réservé du contenu 2">
@@ -30257,7 +30486,13 @@
                               <a:rPr lang="fr-FR" b="0" i="1" smtClean="0">
                                 <a:latin typeface="Cambria Math" panose="02040503050406030204" pitchFamily="18" charset="0"/>
                               </a:rPr>
-                              <m:t>+1</m:t>
+                              <m:t>+</m:t>
+                            </m:r>
+                            <m:r>
+                              <a:rPr lang="fr-FR" b="0" i="1" smtClean="0">
+                                <a:latin typeface="Cambria Math" panose="02040503050406030204" pitchFamily="18" charset="0"/>
+                              </a:rPr>
+                              <m:t>1</m:t>
                             </m:r>
                             <m:r>
                               <a:rPr lang="fr-FR" i="1">
@@ -30314,7 +30549,13 @@
                               <a:rPr lang="fr-FR" b="0" i="1" smtClean="0">
                                 <a:latin typeface="Cambria Math" panose="02040503050406030204" pitchFamily="18" charset="0"/>
                               </a:rPr>
-                              <m:t>−1</m:t>
+                              <m:t>−</m:t>
+                            </m:r>
+                            <m:r>
+                              <a:rPr lang="fr-FR" b="0" i="1" smtClean="0">
+                                <a:latin typeface="Cambria Math" panose="02040503050406030204" pitchFamily="18" charset="0"/>
+                              </a:rPr>
+                              <m:t>1</m:t>
                             </m:r>
                             <m:r>
                               <a:rPr lang="fr-FR" i="1">
@@ -30882,6 +31123,18 @@
                             </a:rPr>
                             <m:t>𝑘</m:t>
                           </m:r>
+                          <m:r>
+                            <a:rPr lang="fr-CA" sz="2400" b="0" i="1" smtClean="0">
+                              <a:latin typeface="Cambria Math" panose="02040503050406030204" pitchFamily="18" charset="0"/>
+                            </a:rPr>
+                            <m:t>∆</m:t>
+                          </m:r>
+                          <m:r>
+                            <a:rPr lang="fr-CA" sz="2400" b="0" i="1" smtClean="0">
+                              <a:latin typeface="Cambria Math" panose="02040503050406030204" pitchFamily="18" charset="0"/>
+                            </a:rPr>
+                            <m:t>𝑡</m:t>
+                          </m:r>
                         </m:num>
                         <m:den>
                           <m:r>
@@ -30962,7 +31215,19 @@
                                 <a:rPr lang="fr-FR" sz="2400" i="1">
                                   <a:latin typeface="Cambria Math" panose="02040503050406030204" pitchFamily="18" charset="0"/>
                                 </a:rPr>
-                                <m:t>+1,</m:t>
+                                <m:t>+</m:t>
+                              </m:r>
+                              <m:r>
+                                <a:rPr lang="fr-FR" sz="2400" i="1">
+                                  <a:latin typeface="Cambria Math" panose="02040503050406030204" pitchFamily="18" charset="0"/>
+                                </a:rPr>
+                                <m:t>1</m:t>
+                              </m:r>
+                              <m:r>
+                                <a:rPr lang="fr-FR" sz="2400" i="1">
+                                  <a:latin typeface="Cambria Math" panose="02040503050406030204" pitchFamily="18" charset="0"/>
+                                </a:rPr>
+                                <m:t>,</m:t>
                               </m:r>
                               <m:r>
                                 <a:rPr lang="fr-FR" sz="2400" i="1">
@@ -31070,7 +31335,19 @@
                                 <a:rPr lang="fr-FR" sz="2400" i="1">
                                   <a:latin typeface="Cambria Math" panose="02040503050406030204" pitchFamily="18" charset="0"/>
                                 </a:rPr>
-                                <m:t>−1,</m:t>
+                                <m:t>−</m:t>
+                              </m:r>
+                              <m:r>
+                                <a:rPr lang="fr-FR" sz="2400" i="1">
+                                  <a:latin typeface="Cambria Math" panose="02040503050406030204" pitchFamily="18" charset="0"/>
+                                </a:rPr>
+                                <m:t>1</m:t>
+                              </m:r>
+                              <m:r>
+                                <a:rPr lang="fr-FR" sz="2400" i="1">
+                                  <a:latin typeface="Cambria Math" panose="02040503050406030204" pitchFamily="18" charset="0"/>
+                                </a:rPr>
+                                <m:t>,</m:t>
                               </m:r>
                               <m:r>
                                 <a:rPr lang="fr-FR" sz="2400" i="1">
@@ -31203,7 +31480,19 @@
                                 <a:rPr lang="fr-FR" sz="2400" i="1">
                                   <a:latin typeface="Cambria Math" panose="02040503050406030204" pitchFamily="18" charset="0"/>
                                 </a:rPr>
-                                <m:t>+1,</m:t>
+                                <m:t>+</m:t>
+                              </m:r>
+                              <m:r>
+                                <a:rPr lang="fr-FR" sz="2400" i="1">
+                                  <a:latin typeface="Cambria Math" panose="02040503050406030204" pitchFamily="18" charset="0"/>
+                                </a:rPr>
+                                <m:t>1</m:t>
+                              </m:r>
+                              <m:r>
+                                <a:rPr lang="fr-FR" sz="2400" i="1">
+                                  <a:latin typeface="Cambria Math" panose="02040503050406030204" pitchFamily="18" charset="0"/>
+                                </a:rPr>
+                                <m:t>,</m:t>
                               </m:r>
                               <m:r>
                                 <a:rPr lang="fr-FR" sz="2400" i="1">
@@ -31254,7 +31543,19 @@
                                 <a:rPr lang="fr-FR" sz="2400" i="1">
                                   <a:latin typeface="Cambria Math" panose="02040503050406030204" pitchFamily="18" charset="0"/>
                                 </a:rPr>
-                                <m:t>−1,</m:t>
+                                <m:t>−</m:t>
+                              </m:r>
+                              <m:r>
+                                <a:rPr lang="fr-FR" sz="2400" i="1">
+                                  <a:latin typeface="Cambria Math" panose="02040503050406030204" pitchFamily="18" charset="0"/>
+                                </a:rPr>
+                                <m:t>1</m:t>
+                              </m:r>
+                              <m:r>
+                                <a:rPr lang="fr-FR" sz="2400" i="1">
+                                  <a:latin typeface="Cambria Math" panose="02040503050406030204" pitchFamily="18" charset="0"/>
+                                </a:rPr>
+                                <m:t>,</m:t>
                               </m:r>
                               <m:r>
                                 <a:rPr lang="fr-FR" sz="2400" i="1">
@@ -31351,7 +31652,13 @@
                                 <a:rPr lang="fr-FR" sz="2400" i="1">
                                   <a:latin typeface="Cambria Math" panose="02040503050406030204" pitchFamily="18" charset="0"/>
                                 </a:rPr>
-                                <m:t>+1</m:t>
+                                <m:t>+</m:t>
+                              </m:r>
+                              <m:r>
+                                <a:rPr lang="fr-FR" sz="2400" i="1">
+                                  <a:latin typeface="Cambria Math" panose="02040503050406030204" pitchFamily="18" charset="0"/>
+                                </a:rPr>
+                                <m:t>1</m:t>
                               </m:r>
                             </m:sub>
                             <m:sup>
@@ -31465,7 +31772,13 @@
                                 <a:rPr lang="fr-FR" sz="2400" i="1">
                                   <a:latin typeface="Cambria Math" panose="02040503050406030204" pitchFamily="18" charset="0"/>
                                 </a:rPr>
-                                <m:t>−1</m:t>
+                                <m:t>−</m:t>
+                              </m:r>
+                              <m:r>
+                                <a:rPr lang="fr-FR" sz="2400" i="1">
+                                  <a:latin typeface="Cambria Math" panose="02040503050406030204" pitchFamily="18" charset="0"/>
+                                </a:rPr>
+                                <m:t>1</m:t>
                               </m:r>
                             </m:sub>
                             <m:sup>
@@ -31551,7 +31864,7 @@
             </p:txBody>
           </p:sp>
         </mc:Choice>
-        <mc:Fallback xmlns="">
+        <mc:Fallback>
           <p:sp>
             <p:nvSpPr>
               <p:cNvPr id="3" name="Espace réservé du contenu 2">
@@ -31811,7 +32124,21 @@
                                 <a:latin typeface="Cambria Math" panose="02040503050406030204" pitchFamily="18" charset="0"/>
                                 <a:ea typeface="Cambria Math" panose="02040503050406030204" pitchFamily="18" charset="0"/>
                               </a:rPr>
-                              <m:t>+1,</m:t>
+                              <m:t>+</m:t>
+                            </m:r>
+                            <m:r>
+                              <a:rPr lang="fr-FR" sz="2600" i="1">
+                                <a:latin typeface="Cambria Math" panose="02040503050406030204" pitchFamily="18" charset="0"/>
+                                <a:ea typeface="Cambria Math" panose="02040503050406030204" pitchFamily="18" charset="0"/>
+                              </a:rPr>
+                              <m:t>1</m:t>
+                            </m:r>
+                            <m:r>
+                              <a:rPr lang="fr-FR" sz="2600" i="1">
+                                <a:latin typeface="Cambria Math" panose="02040503050406030204" pitchFamily="18" charset="0"/>
+                                <a:ea typeface="Cambria Math" panose="02040503050406030204" pitchFamily="18" charset="0"/>
+                              </a:rPr>
+                              <m:t>,</m:t>
                             </m:r>
                             <m:r>
                               <a:rPr lang="fr-FR" sz="2600" i="1">
@@ -31934,7 +32261,21 @@
                                 <a:latin typeface="Cambria Math" panose="02040503050406030204" pitchFamily="18" charset="0"/>
                                 <a:ea typeface="Cambria Math" panose="02040503050406030204" pitchFamily="18" charset="0"/>
                               </a:rPr>
-                              <m:t>−1,</m:t>
+                              <m:t>−</m:t>
+                            </m:r>
+                            <m:r>
+                              <a:rPr lang="fr-FR" sz="2600" i="1">
+                                <a:latin typeface="Cambria Math" panose="02040503050406030204" pitchFamily="18" charset="0"/>
+                                <a:ea typeface="Cambria Math" panose="02040503050406030204" pitchFamily="18" charset="0"/>
+                              </a:rPr>
+                              <m:t>1</m:t>
+                            </m:r>
+                            <m:r>
+                              <a:rPr lang="fr-FR" sz="2600" i="1">
+                                <a:latin typeface="Cambria Math" panose="02040503050406030204" pitchFamily="18" charset="0"/>
+                                <a:ea typeface="Cambria Math" panose="02040503050406030204" pitchFamily="18" charset="0"/>
+                              </a:rPr>
+                              <m:t>,</m:t>
                             </m:r>
                             <m:r>
                               <a:rPr lang="fr-FR" sz="2600" i="1">
@@ -32203,7 +32544,13 @@
                               <a:rPr lang="fr-FR" sz="2600" i="1">
                                 <a:latin typeface="Cambria Math" panose="02040503050406030204" pitchFamily="18" charset="0"/>
                               </a:rPr>
-                              <m:t>+1</m:t>
+                              <m:t>+</m:t>
+                            </m:r>
+                            <m:r>
+                              <a:rPr lang="fr-FR" sz="2600" i="1">
+                                <a:latin typeface="Cambria Math" panose="02040503050406030204" pitchFamily="18" charset="0"/>
+                              </a:rPr>
+                              <m:t>1</m:t>
                             </m:r>
                           </m:sub>
                           <m:sup>
@@ -32317,7 +32664,13 @@
                               <a:rPr lang="fr-FR" sz="2600" i="1">
                                 <a:latin typeface="Cambria Math" panose="02040503050406030204" pitchFamily="18" charset="0"/>
                               </a:rPr>
-                              <m:t>−1</m:t>
+                              <m:t>−</m:t>
+                            </m:r>
+                            <m:r>
+                              <a:rPr lang="fr-FR" sz="2600" i="1">
+                                <a:latin typeface="Cambria Math" panose="02040503050406030204" pitchFamily="18" charset="0"/>
+                              </a:rPr>
+                              <m:t>1</m:t>
                             </m:r>
                           </m:sub>
                           <m:sup>
@@ -32611,8 +32964,8 @@
           </a:prstGeom>
         </p:spPr>
       </p:pic>
-      <mc:AlternateContent xmlns:mc="http://schemas.openxmlformats.org/markup-compatibility/2006" xmlns:a14="http://schemas.microsoft.com/office/drawing/2010/main">
-        <mc:Choice Requires="a14">
+      <mc:AlternateContent xmlns:mc="http://schemas.openxmlformats.org/markup-compatibility/2006">
+        <mc:Choice xmlns:a14="http://schemas.microsoft.com/office/drawing/2010/main" Requires="a14">
           <p:sp>
             <p:nvSpPr>
               <p:cNvPr id="6" name="ZoneTexte 5">
@@ -32917,6 +33270,24 @@
                             </a:rPr>
                             <m:t>𝑡</m:t>
                           </m:r>
+                          <m:r>
+                            <a:rPr lang="fr-CA" b="0" i="1" smtClean="0">
+                              <a:solidFill>
+                                <a:schemeClr val="accent2"/>
+                              </a:solidFill>
+                              <a:latin typeface="Cambria Math" panose="02040503050406030204" pitchFamily="18" charset="0"/>
+                            </a:rPr>
+                            <m:t>+∆</m:t>
+                          </m:r>
+                          <m:r>
+                            <a:rPr lang="fr-CA" b="0" i="1" smtClean="0">
+                              <a:solidFill>
+                                <a:schemeClr val="accent2"/>
+                              </a:solidFill>
+                              <a:latin typeface="Cambria Math" panose="02040503050406030204" pitchFamily="18" charset="0"/>
+                            </a:rPr>
+                            <m:t>𝑡</m:t>
+                          </m:r>
                         </m:sup>
                       </m:sSubSup>
                       <m:r>
@@ -33036,6 +33407,24 @@
                             </a:rPr>
                             <m:t>𝑡</m:t>
                           </m:r>
+                          <m:r>
+                            <a:rPr lang="fr-CA" b="0" i="1" smtClean="0">
+                              <a:solidFill>
+                                <a:schemeClr val="accent2"/>
+                              </a:solidFill>
+                              <a:latin typeface="Cambria Math" panose="02040503050406030204" pitchFamily="18" charset="0"/>
+                            </a:rPr>
+                            <m:t>+∆</m:t>
+                          </m:r>
+                          <m:r>
+                            <a:rPr lang="fr-CA" b="0" i="1" smtClean="0">
+                              <a:solidFill>
+                                <a:schemeClr val="accent2"/>
+                              </a:solidFill>
+                              <a:latin typeface="Cambria Math" panose="02040503050406030204" pitchFamily="18" charset="0"/>
+                            </a:rPr>
+                            <m:t>𝑡</m:t>
+                          </m:r>
                         </m:sup>
                       </m:sSubSup>
                     </m:oMath>
@@ -33050,7 +33439,7 @@
             </p:txBody>
           </p:sp>
         </mc:Choice>
-        <mc:Fallback xmlns="">
+        <mc:Fallback>
           <p:sp>
             <p:nvSpPr>
               <p:cNvPr id="6" name="ZoneTexte 5">
@@ -33095,8 +33484,8 @@
           </p:sp>
         </mc:Fallback>
       </mc:AlternateContent>
-      <mc:AlternateContent xmlns:mc="http://schemas.openxmlformats.org/markup-compatibility/2006" xmlns:a14="http://schemas.microsoft.com/office/drawing/2010/main">
-        <mc:Choice Requires="a14">
+      <mc:AlternateContent xmlns:mc="http://schemas.openxmlformats.org/markup-compatibility/2006">
+        <mc:Choice xmlns:a14="http://schemas.microsoft.com/office/drawing/2010/main" Requires="a14">
           <p:sp>
             <p:nvSpPr>
               <p:cNvPr id="7" name="ZoneTexte 6">
@@ -33401,6 +33790,24 @@
                             </a:rPr>
                             <m:t>𝑡</m:t>
                           </m:r>
+                          <m:r>
+                            <a:rPr lang="fr-CA" b="0" i="1" smtClean="0">
+                              <a:solidFill>
+                                <a:srgbClr val="FFBF00"/>
+                              </a:solidFill>
+                              <a:latin typeface="Cambria Math" panose="02040503050406030204" pitchFamily="18" charset="0"/>
+                            </a:rPr>
+                            <m:t>+∆</m:t>
+                          </m:r>
+                          <m:r>
+                            <a:rPr lang="fr-CA" b="0" i="1" smtClean="0">
+                              <a:solidFill>
+                                <a:srgbClr val="FFBF00"/>
+                              </a:solidFill>
+                              <a:latin typeface="Cambria Math" panose="02040503050406030204" pitchFamily="18" charset="0"/>
+                            </a:rPr>
+                            <m:t>𝑡</m:t>
+                          </m:r>
                         </m:sup>
                       </m:sSubSup>
                       <m:r>
@@ -33520,6 +33927,24 @@
                             </a:rPr>
                             <m:t>𝑡</m:t>
                           </m:r>
+                          <m:r>
+                            <a:rPr lang="fr-CA" b="0" i="1" smtClean="0">
+                              <a:solidFill>
+                                <a:srgbClr val="FFBF00"/>
+                              </a:solidFill>
+                              <a:latin typeface="Cambria Math" panose="02040503050406030204" pitchFamily="18" charset="0"/>
+                            </a:rPr>
+                            <m:t>+∆</m:t>
+                          </m:r>
+                          <m:r>
+                            <a:rPr lang="fr-CA" b="0" i="1" smtClean="0">
+                              <a:solidFill>
+                                <a:srgbClr val="FFBF00"/>
+                              </a:solidFill>
+                              <a:latin typeface="Cambria Math" panose="02040503050406030204" pitchFamily="18" charset="0"/>
+                            </a:rPr>
+                            <m:t>𝑡</m:t>
+                          </m:r>
                         </m:sup>
                       </m:sSubSup>
                     </m:oMath>
@@ -33534,7 +33959,7 @@
             </p:txBody>
           </p:sp>
         </mc:Choice>
-        <mc:Fallback xmlns="">
+        <mc:Fallback>
           <p:sp>
             <p:nvSpPr>
               <p:cNvPr id="7" name="ZoneTexte 6">
@@ -33579,8 +34004,8 @@
           </p:sp>
         </mc:Fallback>
       </mc:AlternateContent>
-      <mc:AlternateContent xmlns:mc="http://schemas.openxmlformats.org/markup-compatibility/2006" xmlns:a14="http://schemas.microsoft.com/office/drawing/2010/main">
-        <mc:Choice Requires="a14">
+      <mc:AlternateContent xmlns:mc="http://schemas.openxmlformats.org/markup-compatibility/2006">
+        <mc:Choice xmlns:a14="http://schemas.microsoft.com/office/drawing/2010/main" Requires="a14">
           <p:sp>
             <p:nvSpPr>
               <p:cNvPr id="8" name="ZoneTexte 7">
@@ -33596,7 +34021,7 @@
             <p:spPr>
               <a:xfrm>
                 <a:off x="5803392" y="1268922"/>
-                <a:ext cx="6141720" cy="1869614"/>
+                <a:ext cx="6141720" cy="1933478"/>
               </a:xfrm>
               <a:prstGeom prst="rect">
                 <a:avLst/>
@@ -34533,6 +34958,24 @@
                           </a:rPr>
                           <m:t>𝑡</m:t>
                         </m:r>
+                        <m:r>
+                          <a:rPr lang="fr-CA" b="0" i="1" smtClean="0">
+                            <a:solidFill>
+                              <a:srgbClr val="5B9BD5"/>
+                            </a:solidFill>
+                            <a:latin typeface="Cambria Math" panose="02040503050406030204" pitchFamily="18" charset="0"/>
+                          </a:rPr>
+                          <m:t>+∆</m:t>
+                        </m:r>
+                        <m:r>
+                          <a:rPr lang="fr-CA" b="0" i="1" smtClean="0">
+                            <a:solidFill>
+                              <a:srgbClr val="5B9BD5"/>
+                            </a:solidFill>
+                            <a:latin typeface="Cambria Math" panose="02040503050406030204" pitchFamily="18" charset="0"/>
+                          </a:rPr>
+                          <m:t>𝑡</m:t>
+                        </m:r>
                       </m:sup>
                     </m:sSubSup>
                     <m:r>
@@ -34608,6 +35051,24 @@
                       <m:sup>
                         <m:r>
                           <a:rPr lang="fr-CA" i="1">
+                            <a:solidFill>
+                              <a:srgbClr val="5B9BD5"/>
+                            </a:solidFill>
+                            <a:latin typeface="Cambria Math" panose="02040503050406030204" pitchFamily="18" charset="0"/>
+                          </a:rPr>
+                          <m:t>𝑡</m:t>
+                        </m:r>
+                        <m:r>
+                          <a:rPr lang="fr-CA" b="0" i="1" smtClean="0">
+                            <a:solidFill>
+                              <a:srgbClr val="5B9BD5"/>
+                            </a:solidFill>
+                            <a:latin typeface="Cambria Math" panose="02040503050406030204" pitchFamily="18" charset="0"/>
+                          </a:rPr>
+                          <m:t>+∆</m:t>
+                        </m:r>
+                        <m:r>
+                          <a:rPr lang="fr-CA" b="0" i="1" smtClean="0">
                             <a:solidFill>
                               <a:srgbClr val="5B9BD5"/>
                             </a:solidFill>
@@ -34691,7 +35152,7 @@
             </p:txBody>
           </p:sp>
         </mc:Choice>
-        <mc:Fallback xmlns="">
+        <mc:Fallback>
           <p:sp>
             <p:nvSpPr>
               <p:cNvPr id="8" name="ZoneTexte 7">
@@ -34709,7 +35170,7 @@
             <p:spPr>
               <a:xfrm>
                 <a:off x="5803392" y="1268922"/>
-                <a:ext cx="6141720" cy="1869614"/>
+                <a:ext cx="6141720" cy="1933478"/>
               </a:xfrm>
               <a:prstGeom prst="rect">
                 <a:avLst/>
@@ -34717,7 +35178,7 @@
               <a:blipFill>
                 <a:blip r:embed="rId5"/>
                 <a:stretch>
-                  <a:fillRect l="-794" t="-1303" b="-1954"/>
+                  <a:fillRect l="-794" t="-1262"/>
                 </a:stretch>
               </a:blipFill>
             </p:spPr>
@@ -34736,8 +35197,8 @@
           </p:sp>
         </mc:Fallback>
       </mc:AlternateContent>
-      <mc:AlternateContent xmlns:mc="http://schemas.openxmlformats.org/markup-compatibility/2006" xmlns:a14="http://schemas.microsoft.com/office/drawing/2010/main">
-        <mc:Choice Requires="a14">
+      <mc:AlternateContent xmlns:mc="http://schemas.openxmlformats.org/markup-compatibility/2006">
+        <mc:Choice xmlns:a14="http://schemas.microsoft.com/office/drawing/2010/main" Requires="a14">
           <p:sp>
             <p:nvSpPr>
               <p:cNvPr id="9" name="ZoneTexte 8">
@@ -34753,7 +35214,7 @@
             <p:spPr>
               <a:xfrm>
                 <a:off x="5903976" y="3023260"/>
-                <a:ext cx="6288024" cy="1869614"/>
+                <a:ext cx="6288024" cy="1933478"/>
               </a:xfrm>
               <a:prstGeom prst="rect">
                 <a:avLst/>
@@ -35690,6 +36151,24 @@
                           </a:rPr>
                           <m:t>𝑡</m:t>
                         </m:r>
+                        <m:r>
+                          <a:rPr lang="fr-CA" b="0" i="1" smtClean="0">
+                            <a:solidFill>
+                              <a:srgbClr val="6FAD46"/>
+                            </a:solidFill>
+                            <a:latin typeface="Cambria Math" panose="02040503050406030204" pitchFamily="18" charset="0"/>
+                          </a:rPr>
+                          <m:t>+∆</m:t>
+                        </m:r>
+                        <m:r>
+                          <a:rPr lang="fr-CA" b="0" i="1" smtClean="0">
+                            <a:solidFill>
+                              <a:srgbClr val="6FAD46"/>
+                            </a:solidFill>
+                            <a:latin typeface="Cambria Math" panose="02040503050406030204" pitchFamily="18" charset="0"/>
+                          </a:rPr>
+                          <m:t>𝑡</m:t>
+                        </m:r>
                       </m:sup>
                     </m:sSubSup>
                     <m:r>
@@ -35765,6 +36244,24 @@
                       <m:sup>
                         <m:r>
                           <a:rPr lang="fr-CA" i="1">
+                            <a:solidFill>
+                              <a:srgbClr val="6FAD46"/>
+                            </a:solidFill>
+                            <a:latin typeface="Cambria Math" panose="02040503050406030204" pitchFamily="18" charset="0"/>
+                          </a:rPr>
+                          <m:t>𝑡</m:t>
+                        </m:r>
+                        <m:r>
+                          <a:rPr lang="fr-CA" b="0" i="1" smtClean="0">
+                            <a:solidFill>
+                              <a:srgbClr val="6FAD46"/>
+                            </a:solidFill>
+                            <a:latin typeface="Cambria Math" panose="02040503050406030204" pitchFamily="18" charset="0"/>
+                          </a:rPr>
+                          <m:t>+∆</m:t>
+                        </m:r>
+                        <m:r>
+                          <a:rPr lang="fr-CA" b="0" i="1" smtClean="0">
                             <a:solidFill>
                               <a:srgbClr val="6FAD46"/>
                             </a:solidFill>
@@ -35848,7 +36345,7 @@
             </p:txBody>
           </p:sp>
         </mc:Choice>
-        <mc:Fallback xmlns="">
+        <mc:Fallback>
           <p:sp>
             <p:nvSpPr>
               <p:cNvPr id="9" name="ZoneTexte 8">
@@ -35866,7 +36363,7 @@
             <p:spPr>
               <a:xfrm>
                 <a:off x="5903976" y="3023260"/>
-                <a:ext cx="6288024" cy="1869614"/>
+                <a:ext cx="6288024" cy="1933478"/>
               </a:xfrm>
               <a:prstGeom prst="rect">
                 <a:avLst/>
@@ -35874,7 +36371,7 @@
               <a:blipFill>
                 <a:blip r:embed="rId6"/>
                 <a:stretch>
-                  <a:fillRect l="-873" t="-1629" b="-1629"/>
+                  <a:fillRect l="-873" t="-1577"/>
                 </a:stretch>
               </a:blipFill>
             </p:spPr>

</xml_diff>